<commit_message>
Fix 4:3 layout issues: stretched hero, overlapping titles, empty TOC gap
Export JPGs at 1600x1200 (was 1600x900) so PowerPoint doesn't squash 4:3
slides into a 16:9 canvas. Shrink headline font from 27pt to 24pt and
widen the headline box so long titles (slides 4, 6) fit on one line
instead of wrapping into the subhead. Rebuild the cover: shrink the
"AI Markets" wordmark to 60pt to fit one line, make the hero image
square rather than narrow-and-tall. Close the empty gap on the TOC by
pulling the dark card block up and growing it into the reclaimed space.

Co-Authored-By: Claude Opus 4.7 <noreply@anthropic.com>
</commit_message>
<xml_diff>
--- a/ai-markets-deck.pptx
+++ b/ai-markets-deck.pptx
@@ -5282,8 +5282,8 @@
         </p:nvSpPr>
         <p:spPr>
           <a:xfrm>
-            <a:off x="5852160" y="822960"/>
-            <a:ext cx="2926080" cy="4389120"/>
+            <a:off x="5760720" y="1463040"/>
+            <a:ext cx="3017520" cy="3017520"/>
           </a:xfrm>
           <a:prstGeom prst="rect">
             <a:avLst/>
@@ -5307,8 +5307,8 @@
         </p:nvSpPr>
         <p:spPr>
           <a:xfrm>
-            <a:off x="5943600" y="822960"/>
-            <a:ext cx="2743200" cy="4389120"/>
+            <a:off x="5852160" y="1463040"/>
+            <a:ext cx="2834640" cy="3017520"/>
           </a:xfrm>
           <a:prstGeom prst="rect">
             <a:avLst/>
@@ -5346,7 +5346,7 @@
         </p:nvSpPr>
         <p:spPr>
           <a:xfrm>
-            <a:off x="7223760" y="320040"/>
+            <a:off x="7223760" y="548640"/>
             <a:ext cx="1554480" cy="320040"/>
           </a:xfrm>
           <a:prstGeom prst="rect">
@@ -5385,7 +5385,7 @@
         </p:nvSpPr>
         <p:spPr>
           <a:xfrm>
-            <a:off x="7223760" y="685800"/>
+            <a:off x="7223760" y="914400"/>
             <a:ext cx="1554480" cy="0"/>
           </a:xfrm>
           <a:prstGeom prst="line">
@@ -5434,7 +5434,7 @@
         <p:spPr>
           <a:xfrm>
             <a:off x="457200" y="2194560"/>
-            <a:ext cx="5303520" cy="1463040"/>
+            <a:ext cx="5303520" cy="1097280"/>
           </a:xfrm>
           <a:prstGeom prst="rect">
             <a:avLst/>
@@ -5450,7 +5450,7 @@
               <a:buNone/>
             </a:pPr>
             <a:r>
-              <a:rPr lang="en-US" sz="7200" b="1" dirty="0">
+              <a:rPr lang="en-US" sz="6000" b="1" dirty="0">
                 <a:solidFill>
                   <a:srgbClr val="000000"/>
                 </a:solidFill>
@@ -5460,7 +5460,7 @@
               </a:rPr>
               <a:t>AI Markets</a:t>
             </a:r>
-            <a:endParaRPr lang="en-US" sz="7200" dirty="0"/>
+            <a:endParaRPr lang="en-US" sz="6000" dirty="0"/>
           </a:p>
         </p:txBody>
       </p:sp>
@@ -5472,7 +5472,7 @@
         </p:nvSpPr>
         <p:spPr>
           <a:xfrm>
-            <a:off x="457200" y="3931920"/>
+            <a:off x="457200" y="3429000"/>
             <a:ext cx="5303520" cy="548640"/>
           </a:xfrm>
           <a:prstGeom prst="rect">
@@ -5706,7 +5706,7 @@
         <p:spPr>
           <a:xfrm>
             <a:off x="457200" y="182880"/>
-            <a:ext cx="6583680" cy="640080"/>
+            <a:ext cx="6583680" cy="685800"/>
           </a:xfrm>
           <a:prstGeom prst="rect">
             <a:avLst/>
@@ -5722,7 +5722,7 @@
               <a:buNone/>
             </a:pPr>
             <a:r>
-              <a:rPr lang="en-US" sz="2700" b="1" dirty="0">
+              <a:rPr lang="en-US" sz="2400" b="1" dirty="0">
                 <a:solidFill>
                   <a:srgbClr val="000000"/>
                 </a:solidFill>
@@ -5732,7 +5732,7 @@
               </a:rPr>
               <a:t>What is agentic AI?</a:t>
             </a:r>
-            <a:endParaRPr lang="en-US" sz="2700" dirty="0"/>
+            <a:endParaRPr lang="en-US" sz="2400" dirty="0"/>
           </a:p>
         </p:txBody>
       </p:sp>
@@ -5744,7 +5744,7 @@
         </p:nvSpPr>
         <p:spPr>
           <a:xfrm>
-            <a:off x="457200" y="868680"/>
+            <a:off x="457200" y="914400"/>
             <a:ext cx="8229600" cy="457200"/>
           </a:xfrm>
           <a:prstGeom prst="rect">
@@ -7211,7 +7211,7 @@
         <p:spPr>
           <a:xfrm>
             <a:off x="457200" y="182880"/>
-            <a:ext cx="6583680" cy="640080"/>
+            <a:ext cx="6583680" cy="685800"/>
           </a:xfrm>
           <a:prstGeom prst="rect">
             <a:avLst/>
@@ -7227,7 +7227,7 @@
               <a:buNone/>
             </a:pPr>
             <a:r>
-              <a:rPr lang="en-US" sz="2700" b="1" dirty="0">
+              <a:rPr lang="en-US" sz="2400" b="1" dirty="0">
                 <a:solidFill>
                   <a:srgbClr val="000000"/>
                 </a:solidFill>
@@ -7237,7 +7237,7 @@
               </a:rPr>
               <a:t>The divergence.</a:t>
             </a:r>
-            <a:endParaRPr lang="en-US" sz="2700" dirty="0"/>
+            <a:endParaRPr lang="en-US" sz="2400" dirty="0"/>
           </a:p>
         </p:txBody>
       </p:sp>
@@ -7249,7 +7249,7 @@
         </p:nvSpPr>
         <p:spPr>
           <a:xfrm>
-            <a:off x="457200" y="868680"/>
+            <a:off x="457200" y="914400"/>
             <a:ext cx="8229600" cy="457200"/>
           </a:xfrm>
           <a:prstGeom prst="rect">
@@ -8453,7 +8453,7 @@
         <p:spPr>
           <a:xfrm>
             <a:off x="457200" y="182880"/>
-            <a:ext cx="6583680" cy="640080"/>
+            <a:ext cx="6583680" cy="685800"/>
           </a:xfrm>
           <a:prstGeom prst="rect">
             <a:avLst/>
@@ -8469,7 +8469,7 @@
               <a:buNone/>
             </a:pPr>
             <a:r>
-              <a:rPr lang="en-US" sz="2700" b="1" dirty="0">
+              <a:rPr lang="en-US" sz="2400" b="1" dirty="0">
                 <a:solidFill>
                   <a:srgbClr val="000000"/>
                 </a:solidFill>
@@ -8479,7 +8479,7 @@
               </a:rPr>
               <a:t>The bubble question.</a:t>
             </a:r>
-            <a:endParaRPr lang="en-US" sz="2700" dirty="0"/>
+            <a:endParaRPr lang="en-US" sz="2400" dirty="0"/>
           </a:p>
         </p:txBody>
       </p:sp>
@@ -8491,7 +8491,7 @@
         </p:nvSpPr>
         <p:spPr>
           <a:xfrm>
-            <a:off x="457200" y="868680"/>
+            <a:off x="457200" y="914400"/>
             <a:ext cx="8229600" cy="457200"/>
           </a:xfrm>
           <a:prstGeom prst="rect">
@@ -9687,7 +9687,7 @@
         <p:spPr>
           <a:xfrm>
             <a:off x="457200" y="182880"/>
-            <a:ext cx="6583680" cy="640080"/>
+            <a:ext cx="6583680" cy="685800"/>
           </a:xfrm>
           <a:prstGeom prst="rect">
             <a:avLst/>
@@ -9703,7 +9703,7 @@
               <a:buNone/>
             </a:pPr>
             <a:r>
-              <a:rPr lang="en-US" sz="2700" b="1" dirty="0">
+              <a:rPr lang="en-US" sz="2400" b="1" dirty="0">
                 <a:solidFill>
                   <a:srgbClr val="000000"/>
                 </a:solidFill>
@@ -9713,7 +9713,7 @@
               </a:rPr>
               <a:t>Supply chain fragility.</a:t>
             </a:r>
-            <a:endParaRPr lang="en-US" sz="2700" dirty="0"/>
+            <a:endParaRPr lang="en-US" sz="2400" dirty="0"/>
           </a:p>
         </p:txBody>
       </p:sp>
@@ -9725,7 +9725,7 @@
         </p:nvSpPr>
         <p:spPr>
           <a:xfrm>
-            <a:off x="457200" y="868680"/>
+            <a:off x="457200" y="914400"/>
             <a:ext cx="8229600" cy="457200"/>
           </a:xfrm>
           <a:prstGeom prst="rect">
@@ -10873,7 +10873,7 @@
         <p:spPr>
           <a:xfrm>
             <a:off x="457200" y="182880"/>
-            <a:ext cx="6583680" cy="640080"/>
+            <a:ext cx="6583680" cy="685800"/>
           </a:xfrm>
           <a:prstGeom prst="rect">
             <a:avLst/>
@@ -10889,7 +10889,7 @@
               <a:buNone/>
             </a:pPr>
             <a:r>
-              <a:rPr lang="en-US" sz="2700" b="1" dirty="0">
+              <a:rPr lang="en-US" sz="2400" b="1" dirty="0">
                 <a:solidFill>
                   <a:srgbClr val="000000"/>
                 </a:solidFill>
@@ -10899,7 +10899,7 @@
               </a:rPr>
               <a:t>Policy &amp; regulation.</a:t>
             </a:r>
-            <a:endParaRPr lang="en-US" sz="2700" dirty="0"/>
+            <a:endParaRPr lang="en-US" sz="2400" dirty="0"/>
           </a:p>
         </p:txBody>
       </p:sp>
@@ -10911,7 +10911,7 @@
         </p:nvSpPr>
         <p:spPr>
           <a:xfrm>
-            <a:off x="457200" y="868680"/>
+            <a:off x="457200" y="914400"/>
             <a:ext cx="8229600" cy="457200"/>
           </a:xfrm>
           <a:prstGeom prst="rect">
@@ -12032,7 +12032,7 @@
         <p:spPr>
           <a:xfrm>
             <a:off x="457200" y="182880"/>
-            <a:ext cx="6583680" cy="640080"/>
+            <a:ext cx="6583680" cy="685800"/>
           </a:xfrm>
           <a:prstGeom prst="rect">
             <a:avLst/>
@@ -12048,7 +12048,7 @@
               <a:buNone/>
             </a:pPr>
             <a:r>
-              <a:rPr lang="en-US" sz="2700" b="1" dirty="0">
+              <a:rPr lang="en-US" sz="2400" b="1" dirty="0">
                 <a:solidFill>
                   <a:srgbClr val="000000"/>
                 </a:solidFill>
@@ -12058,7 +12058,7 @@
               </a:rPr>
               <a:t>AI backlash.</a:t>
             </a:r>
-            <a:endParaRPr lang="en-US" sz="2700" dirty="0"/>
+            <a:endParaRPr lang="en-US" sz="2400" dirty="0"/>
           </a:p>
         </p:txBody>
       </p:sp>
@@ -12070,7 +12070,7 @@
         </p:nvSpPr>
         <p:spPr>
           <a:xfrm>
-            <a:off x="457200" y="868680"/>
+            <a:off x="457200" y="914400"/>
             <a:ext cx="8229600" cy="457200"/>
           </a:xfrm>
           <a:prstGeom prst="rect">
@@ -12909,7 +12909,7 @@
         <p:spPr>
           <a:xfrm>
             <a:off x="457200" y="182880"/>
-            <a:ext cx="6583680" cy="640080"/>
+            <a:ext cx="6583680" cy="685800"/>
           </a:xfrm>
           <a:prstGeom prst="rect">
             <a:avLst/>
@@ -12925,7 +12925,7 @@
               <a:buNone/>
             </a:pPr>
             <a:r>
-              <a:rPr lang="en-US" sz="2700" b="1" dirty="0">
+              <a:rPr lang="en-US" sz="2400" b="1" dirty="0">
                 <a:solidFill>
                   <a:srgbClr val="000000"/>
                 </a:solidFill>
@@ -12935,7 +12935,7 @@
               </a:rPr>
               <a:t>Beyond the grid.</a:t>
             </a:r>
-            <a:endParaRPr lang="en-US" sz="2700" dirty="0"/>
+            <a:endParaRPr lang="en-US" sz="2400" dirty="0"/>
           </a:p>
         </p:txBody>
       </p:sp>
@@ -12947,7 +12947,7 @@
         </p:nvSpPr>
         <p:spPr>
           <a:xfrm>
-            <a:off x="457200" y="868680"/>
+            <a:off x="457200" y="914400"/>
             <a:ext cx="8229600" cy="457200"/>
           </a:xfrm>
           <a:prstGeom prst="rect">
@@ -13769,7 +13769,7 @@
         <p:spPr>
           <a:xfrm>
             <a:off x="457200" y="182880"/>
-            <a:ext cx="6583680" cy="640080"/>
+            <a:ext cx="6583680" cy="685800"/>
           </a:xfrm>
           <a:prstGeom prst="rect">
             <a:avLst/>
@@ -13785,7 +13785,7 @@
               <a:buNone/>
             </a:pPr>
             <a:r>
-              <a:rPr lang="en-US" sz="2700" b="1" dirty="0">
+              <a:rPr lang="en-US" sz="2400" b="1" dirty="0">
                 <a:solidFill>
                   <a:srgbClr val="000000"/>
                 </a:solidFill>
@@ -13795,7 +13795,7 @@
               </a:rPr>
               <a:t>Physical AI.</a:t>
             </a:r>
-            <a:endParaRPr lang="en-US" sz="2700" dirty="0"/>
+            <a:endParaRPr lang="en-US" sz="2400" dirty="0"/>
           </a:p>
         </p:txBody>
       </p:sp>
@@ -13807,7 +13807,7 @@
         </p:nvSpPr>
         <p:spPr>
           <a:xfrm>
-            <a:off x="457200" y="868680"/>
+            <a:off x="457200" y="914400"/>
             <a:ext cx="8229600" cy="457200"/>
           </a:xfrm>
           <a:prstGeom prst="rect">
@@ -14629,7 +14629,7 @@
         <p:spPr>
           <a:xfrm>
             <a:off x="457200" y="182880"/>
-            <a:ext cx="6583680" cy="640080"/>
+            <a:ext cx="6583680" cy="685800"/>
           </a:xfrm>
           <a:prstGeom prst="rect">
             <a:avLst/>
@@ -14645,7 +14645,7 @@
               <a:buNone/>
             </a:pPr>
             <a:r>
-              <a:rPr lang="en-US" sz="2700" b="1" dirty="0">
+              <a:rPr lang="en-US" sz="2400" b="1" dirty="0">
                 <a:solidFill>
                   <a:srgbClr val="000000"/>
                 </a:solidFill>
@@ -14655,7 +14655,7 @@
               </a:rPr>
               <a:t>Autonomous mobility.</a:t>
             </a:r>
-            <a:endParaRPr lang="en-US" sz="2700" dirty="0"/>
+            <a:endParaRPr lang="en-US" sz="2400" dirty="0"/>
           </a:p>
         </p:txBody>
       </p:sp>
@@ -14667,7 +14667,7 @@
         </p:nvSpPr>
         <p:spPr>
           <a:xfrm>
-            <a:off x="457200" y="868680"/>
+            <a:off x="457200" y="914400"/>
             <a:ext cx="8229600" cy="457200"/>
           </a:xfrm>
           <a:prstGeom prst="rect">
@@ -15489,7 +15489,7 @@
         <p:spPr>
           <a:xfrm>
             <a:off x="457200" y="182880"/>
-            <a:ext cx="6583680" cy="640080"/>
+            <a:ext cx="6583680" cy="685800"/>
           </a:xfrm>
           <a:prstGeom prst="rect">
             <a:avLst/>
@@ -15505,7 +15505,7 @@
               <a:buNone/>
             </a:pPr>
             <a:r>
-              <a:rPr lang="en-US" sz="2700" b="1" dirty="0">
+              <a:rPr lang="en-US" sz="2400" b="1" dirty="0">
                 <a:solidFill>
                   <a:srgbClr val="000000"/>
                 </a:solidFill>
@@ -15515,7 +15515,7 @@
               </a:rPr>
               <a:t>AI is rewriting drug discovery.</a:t>
             </a:r>
-            <a:endParaRPr lang="en-US" sz="2700" dirty="0"/>
+            <a:endParaRPr lang="en-US" sz="2400" dirty="0"/>
           </a:p>
         </p:txBody>
       </p:sp>
@@ -15527,7 +15527,7 @@
         </p:nvSpPr>
         <p:spPr>
           <a:xfrm>
-            <a:off x="457200" y="868680"/>
+            <a:off x="457200" y="914400"/>
             <a:ext cx="8229600" cy="457200"/>
           </a:xfrm>
           <a:prstGeom prst="rect">
@@ -16517,7 +16517,7 @@
         <p:spPr>
           <a:xfrm>
             <a:off x="457200" y="182880"/>
-            <a:ext cx="6583680" cy="640080"/>
+            <a:ext cx="6583680" cy="685800"/>
           </a:xfrm>
           <a:prstGeom prst="rect">
             <a:avLst/>
@@ -16533,7 +16533,7 @@
               <a:buNone/>
             </a:pPr>
             <a:r>
-              <a:rPr lang="en-US" sz="2700" b="1" dirty="0">
+              <a:rPr lang="en-US" sz="2400" b="1" dirty="0">
                 <a:solidFill>
                   <a:srgbClr val="000000"/>
                 </a:solidFill>
@@ -16543,7 +16543,7 @@
               </a:rPr>
               <a:t>The argument, in five parts.</a:t>
             </a:r>
-            <a:endParaRPr lang="en-US" sz="2700" dirty="0"/>
+            <a:endParaRPr lang="en-US" sz="2400" dirty="0"/>
           </a:p>
         </p:txBody>
       </p:sp>
@@ -16555,7 +16555,7 @@
         </p:nvSpPr>
         <p:spPr>
           <a:xfrm>
-            <a:off x="457200" y="868680"/>
+            <a:off x="457200" y="914400"/>
             <a:ext cx="8229600" cy="457200"/>
           </a:xfrm>
           <a:prstGeom prst="rect">
@@ -16617,8 +16617,8 @@
         </p:nvSpPr>
         <p:spPr>
           <a:xfrm>
-            <a:off x="0" y="2103120"/>
-            <a:ext cx="9144000" cy="3291840"/>
+            <a:off x="0" y="1691640"/>
+            <a:ext cx="9144000" cy="3749040"/>
           </a:xfrm>
           <a:prstGeom prst="rect">
             <a:avLst/>
@@ -16642,7 +16642,7 @@
         </p:nvSpPr>
         <p:spPr>
           <a:xfrm>
-            <a:off x="457200" y="2240280"/>
+            <a:off x="457200" y="1828800"/>
             <a:ext cx="8229600" cy="256032"/>
           </a:xfrm>
           <a:prstGeom prst="rect">
@@ -16681,8 +16681,8 @@
         </p:nvSpPr>
         <p:spPr>
           <a:xfrm>
-            <a:off x="356616" y="2651760"/>
-            <a:ext cx="1554480" cy="2423160"/>
+            <a:off x="356616" y="2240280"/>
+            <a:ext cx="1554480" cy="2926080"/>
           </a:xfrm>
           <a:prstGeom prst="rect">
             <a:avLst/>
@@ -16706,7 +16706,7 @@
         </p:nvSpPr>
         <p:spPr>
           <a:xfrm>
-            <a:off x="356616" y="2651760"/>
+            <a:off x="356616" y="2240280"/>
             <a:ext cx="1554480" cy="54864"/>
           </a:xfrm>
           <a:prstGeom prst="rect">
@@ -16731,7 +16731,7 @@
         </p:nvSpPr>
         <p:spPr>
           <a:xfrm>
-            <a:off x="356616" y="2926080"/>
+            <a:off x="356616" y="2514600"/>
             <a:ext cx="1554480" cy="640080"/>
           </a:xfrm>
           <a:prstGeom prst="rect">
@@ -16770,7 +16770,7 @@
         </p:nvSpPr>
         <p:spPr>
           <a:xfrm>
-            <a:off x="356616" y="3657600"/>
+            <a:off x="356616" y="3246120"/>
             <a:ext cx="1554480" cy="274320"/>
           </a:xfrm>
           <a:prstGeom prst="rect">
@@ -16809,7 +16809,7 @@
         </p:nvSpPr>
         <p:spPr>
           <a:xfrm>
-            <a:off x="466344" y="4069080"/>
+            <a:off x="466344" y="3657600"/>
             <a:ext cx="1335024" cy="731520"/>
           </a:xfrm>
           <a:prstGeom prst="rect">
@@ -16887,8 +16887,8 @@
         </p:nvSpPr>
         <p:spPr>
           <a:xfrm>
-            <a:off x="2075688" y="2651760"/>
-            <a:ext cx="1554480" cy="2423160"/>
+            <a:off x="2075688" y="2240280"/>
+            <a:ext cx="1554480" cy="2926080"/>
           </a:xfrm>
           <a:prstGeom prst="rect">
             <a:avLst/>
@@ -16912,7 +16912,7 @@
         </p:nvSpPr>
         <p:spPr>
           <a:xfrm>
-            <a:off x="2075688" y="2651760"/>
+            <a:off x="2075688" y="2240280"/>
             <a:ext cx="1554480" cy="54864"/>
           </a:xfrm>
           <a:prstGeom prst="rect">
@@ -16937,7 +16937,7 @@
         </p:nvSpPr>
         <p:spPr>
           <a:xfrm>
-            <a:off x="2075688" y="2926080"/>
+            <a:off x="2075688" y="2514600"/>
             <a:ext cx="1554480" cy="640080"/>
           </a:xfrm>
           <a:prstGeom prst="rect">
@@ -16976,7 +16976,7 @@
         </p:nvSpPr>
         <p:spPr>
           <a:xfrm>
-            <a:off x="2075688" y="3657600"/>
+            <a:off x="2075688" y="3246120"/>
             <a:ext cx="1554480" cy="274320"/>
           </a:xfrm>
           <a:prstGeom prst="rect">
@@ -17015,7 +17015,7 @@
         </p:nvSpPr>
         <p:spPr>
           <a:xfrm>
-            <a:off x="2185416" y="4069080"/>
+            <a:off x="2185416" y="3657600"/>
             <a:ext cx="1335024" cy="731520"/>
           </a:xfrm>
           <a:prstGeom prst="rect">
@@ -17093,8 +17093,8 @@
         </p:nvSpPr>
         <p:spPr>
           <a:xfrm>
-            <a:off x="3794760" y="2651760"/>
-            <a:ext cx="1554480" cy="2423160"/>
+            <a:off x="3794760" y="2240280"/>
+            <a:ext cx="1554480" cy="2926080"/>
           </a:xfrm>
           <a:prstGeom prst="rect">
             <a:avLst/>
@@ -17118,7 +17118,7 @@
         </p:nvSpPr>
         <p:spPr>
           <a:xfrm>
-            <a:off x="3794760" y="2651760"/>
+            <a:off x="3794760" y="2240280"/>
             <a:ext cx="1554480" cy="54864"/>
           </a:xfrm>
           <a:prstGeom prst="rect">
@@ -17143,7 +17143,7 @@
         </p:nvSpPr>
         <p:spPr>
           <a:xfrm>
-            <a:off x="3794760" y="2926080"/>
+            <a:off x="3794760" y="2514600"/>
             <a:ext cx="1554480" cy="640080"/>
           </a:xfrm>
           <a:prstGeom prst="rect">
@@ -17182,7 +17182,7 @@
         </p:nvSpPr>
         <p:spPr>
           <a:xfrm>
-            <a:off x="3794760" y="3657600"/>
+            <a:off x="3794760" y="3246120"/>
             <a:ext cx="1554480" cy="274320"/>
           </a:xfrm>
           <a:prstGeom prst="rect">
@@ -17221,7 +17221,7 @@
         </p:nvSpPr>
         <p:spPr>
           <a:xfrm>
-            <a:off x="3904488" y="4069080"/>
+            <a:off x="3904488" y="3657600"/>
             <a:ext cx="1335024" cy="731520"/>
           </a:xfrm>
           <a:prstGeom prst="rect">
@@ -17299,8 +17299,8 @@
         </p:nvSpPr>
         <p:spPr>
           <a:xfrm>
-            <a:off x="5513832" y="2651760"/>
-            <a:ext cx="1554480" cy="2423160"/>
+            <a:off x="5513832" y="2240280"/>
+            <a:ext cx="1554480" cy="2926080"/>
           </a:xfrm>
           <a:prstGeom prst="rect">
             <a:avLst/>
@@ -17324,7 +17324,7 @@
         </p:nvSpPr>
         <p:spPr>
           <a:xfrm>
-            <a:off x="5513832" y="2651760"/>
+            <a:off x="5513832" y="2240280"/>
             <a:ext cx="1554480" cy="54864"/>
           </a:xfrm>
           <a:prstGeom prst="rect">
@@ -17349,7 +17349,7 @@
         </p:nvSpPr>
         <p:spPr>
           <a:xfrm>
-            <a:off x="5513832" y="2926080"/>
+            <a:off x="5513832" y="2514600"/>
             <a:ext cx="1554480" cy="640080"/>
           </a:xfrm>
           <a:prstGeom prst="rect">
@@ -17388,7 +17388,7 @@
         </p:nvSpPr>
         <p:spPr>
           <a:xfrm>
-            <a:off x="5513832" y="3657600"/>
+            <a:off x="5513832" y="3246120"/>
             <a:ext cx="1554480" cy="274320"/>
           </a:xfrm>
           <a:prstGeom prst="rect">
@@ -17427,7 +17427,7 @@
         </p:nvSpPr>
         <p:spPr>
           <a:xfrm>
-            <a:off x="5623560" y="4069080"/>
+            <a:off x="5623560" y="3657600"/>
             <a:ext cx="1335024" cy="731520"/>
           </a:xfrm>
           <a:prstGeom prst="rect">
@@ -17505,8 +17505,8 @@
         </p:nvSpPr>
         <p:spPr>
           <a:xfrm>
-            <a:off x="7232904" y="2651760"/>
-            <a:ext cx="1554480" cy="2423160"/>
+            <a:off x="7232904" y="2240280"/>
+            <a:ext cx="1554480" cy="2926080"/>
           </a:xfrm>
           <a:prstGeom prst="rect">
             <a:avLst/>
@@ -17530,7 +17530,7 @@
         </p:nvSpPr>
         <p:spPr>
           <a:xfrm>
-            <a:off x="7232904" y="2651760"/>
+            <a:off x="7232904" y="2240280"/>
             <a:ext cx="1554480" cy="54864"/>
           </a:xfrm>
           <a:prstGeom prst="rect">
@@ -17555,7 +17555,7 @@
         </p:nvSpPr>
         <p:spPr>
           <a:xfrm>
-            <a:off x="7232904" y="2926080"/>
+            <a:off x="7232904" y="2514600"/>
             <a:ext cx="1554480" cy="640080"/>
           </a:xfrm>
           <a:prstGeom prst="rect">
@@ -17594,7 +17594,7 @@
         </p:nvSpPr>
         <p:spPr>
           <a:xfrm>
-            <a:off x="7232904" y="3657600"/>
+            <a:off x="7232904" y="3246120"/>
             <a:ext cx="1554480" cy="274320"/>
           </a:xfrm>
           <a:prstGeom prst="rect">
@@ -17633,7 +17633,7 @@
         </p:nvSpPr>
         <p:spPr>
           <a:xfrm>
-            <a:off x="7342632" y="4069080"/>
+            <a:off x="7342632" y="3657600"/>
             <a:ext cx="1335024" cy="731520"/>
           </a:xfrm>
           <a:prstGeom prst="rect">
@@ -17879,7 +17879,7 @@
         <p:spPr>
           <a:xfrm>
             <a:off x="457200" y="182880"/>
-            <a:ext cx="6583680" cy="640080"/>
+            <a:ext cx="6583680" cy="685800"/>
           </a:xfrm>
           <a:prstGeom prst="rect">
             <a:avLst/>
@@ -17895,7 +17895,7 @@
               <a:buNone/>
             </a:pPr>
             <a:r>
-              <a:rPr lang="en-US" sz="2700" b="1" dirty="0">
+              <a:rPr lang="en-US" sz="2400" b="1" dirty="0">
                 <a:solidFill>
                   <a:srgbClr val="000000"/>
                 </a:solidFill>
@@ -17905,7 +17905,7 @@
               </a:rPr>
               <a:t>Key takeaways.</a:t>
             </a:r>
-            <a:endParaRPr lang="en-US" sz="2700" dirty="0"/>
+            <a:endParaRPr lang="en-US" sz="2400" dirty="0"/>
           </a:p>
         </p:txBody>
       </p:sp>
@@ -17917,7 +17917,7 @@
         </p:nvSpPr>
         <p:spPr>
           <a:xfrm>
-            <a:off x="457200" y="868680"/>
+            <a:off x="457200" y="914400"/>
             <a:ext cx="8229600" cy="457200"/>
           </a:xfrm>
           <a:prstGeom prst="rect">
@@ -18781,7 +18781,7 @@
         <p:spPr>
           <a:xfrm>
             <a:off x="457200" y="182880"/>
-            <a:ext cx="6583680" cy="640080"/>
+            <a:ext cx="6583680" cy="685800"/>
           </a:xfrm>
           <a:prstGeom prst="rect">
             <a:avLst/>
@@ -18797,7 +18797,7 @@
               <a:buNone/>
             </a:pPr>
             <a:r>
-              <a:rPr lang="en-US" sz="2700" b="1" dirty="0">
+              <a:rPr lang="en-US" sz="2400" b="1" dirty="0">
                 <a:solidFill>
                   <a:srgbClr val="000000"/>
                 </a:solidFill>
@@ -18807,7 +18807,7 @@
               </a:rPr>
               <a:t>Why AI matters to markets.</a:t>
             </a:r>
-            <a:endParaRPr lang="en-US" sz="2700" dirty="0"/>
+            <a:endParaRPr lang="en-US" sz="2400" dirty="0"/>
           </a:p>
         </p:txBody>
       </p:sp>
@@ -18819,7 +18819,7 @@
         </p:nvSpPr>
         <p:spPr>
           <a:xfrm>
-            <a:off x="457200" y="868680"/>
+            <a:off x="457200" y="914400"/>
             <a:ext cx="8229600" cy="457200"/>
           </a:xfrm>
           <a:prstGeom prst="rect">
@@ -19491,7 +19491,7 @@
         <p:spPr>
           <a:xfrm>
             <a:off x="457200" y="182880"/>
-            <a:ext cx="6583680" cy="640080"/>
+            <a:ext cx="6583680" cy="685800"/>
           </a:xfrm>
           <a:prstGeom prst="rect">
             <a:avLst/>
@@ -19507,7 +19507,7 @@
               <a:buNone/>
             </a:pPr>
             <a:r>
-              <a:rPr lang="en-US" sz="2700" b="1" dirty="0">
+              <a:rPr lang="en-US" sz="2400" b="1" dirty="0">
                 <a:solidFill>
                   <a:srgbClr val="000000"/>
                 </a:solidFill>
@@ -19517,7 +19517,7 @@
               </a:rPr>
               <a:t>AI evolution from chatbots to agents.</a:t>
             </a:r>
-            <a:endParaRPr lang="en-US" sz="2700" dirty="0"/>
+            <a:endParaRPr lang="en-US" sz="2400" dirty="0"/>
           </a:p>
         </p:txBody>
       </p:sp>
@@ -19529,7 +19529,7 @@
         </p:nvSpPr>
         <p:spPr>
           <a:xfrm>
-            <a:off x="457200" y="868680"/>
+            <a:off x="457200" y="914400"/>
             <a:ext cx="8229600" cy="457200"/>
           </a:xfrm>
           <a:prstGeom prst="rect">
@@ -21000,7 +21000,7 @@
         <p:spPr>
           <a:xfrm>
             <a:off x="457200" y="182880"/>
-            <a:ext cx="6583680" cy="640080"/>
+            <a:ext cx="6583680" cy="685800"/>
           </a:xfrm>
           <a:prstGeom prst="rect">
             <a:avLst/>
@@ -21016,7 +21016,7 @@
               <a:buNone/>
             </a:pPr>
             <a:r>
-              <a:rPr lang="en-US" sz="2700" b="1" dirty="0">
+              <a:rPr lang="en-US" sz="2400" b="1" dirty="0">
                 <a:solidFill>
                   <a:srgbClr val="000000"/>
                 </a:solidFill>
@@ -21026,7 +21026,7 @@
               </a:rPr>
               <a:t>The AI stack.</a:t>
             </a:r>
-            <a:endParaRPr lang="en-US" sz="2700" dirty="0"/>
+            <a:endParaRPr lang="en-US" sz="2400" dirty="0"/>
           </a:p>
         </p:txBody>
       </p:sp>
@@ -21038,7 +21038,7 @@
         </p:nvSpPr>
         <p:spPr>
           <a:xfrm>
-            <a:off x="457200" y="868680"/>
+            <a:off x="457200" y="914400"/>
             <a:ext cx="8229600" cy="457200"/>
           </a:xfrm>
           <a:prstGeom prst="rect">
@@ -22599,7 +22599,7 @@
         <p:spPr>
           <a:xfrm>
             <a:off x="457200" y="182880"/>
-            <a:ext cx="6583680" cy="640080"/>
+            <a:ext cx="6583680" cy="685800"/>
           </a:xfrm>
           <a:prstGeom prst="rect">
             <a:avLst/>
@@ -22615,7 +22615,7 @@
               <a:buNone/>
             </a:pPr>
             <a:r>
-              <a:rPr lang="en-US" sz="2700" b="1" dirty="0">
+              <a:rPr lang="en-US" sz="2400" b="1" dirty="0">
                 <a:solidFill>
                   <a:srgbClr val="000000"/>
                 </a:solidFill>
@@ -22625,7 +22625,7 @@
               </a:rPr>
               <a:t>AI growth rates are unprecedented.</a:t>
             </a:r>
-            <a:endParaRPr lang="en-US" sz="2700" dirty="0"/>
+            <a:endParaRPr lang="en-US" sz="2400" dirty="0"/>
           </a:p>
         </p:txBody>
       </p:sp>
@@ -22637,7 +22637,7 @@
         </p:nvSpPr>
         <p:spPr>
           <a:xfrm>
-            <a:off x="457200" y="868680"/>
+            <a:off x="457200" y="914400"/>
             <a:ext cx="8229600" cy="457200"/>
           </a:xfrm>
           <a:prstGeom prst="rect">
@@ -23365,7 +23365,7 @@
         <p:spPr>
           <a:xfrm>
             <a:off x="457200" y="182880"/>
-            <a:ext cx="6583680" cy="640080"/>
+            <a:ext cx="6583680" cy="685800"/>
           </a:xfrm>
           <a:prstGeom prst="rect">
             <a:avLst/>
@@ -23381,7 +23381,7 @@
               <a:buNone/>
             </a:pPr>
             <a:r>
-              <a:rPr lang="en-US" sz="2700" b="1" dirty="0">
+              <a:rPr lang="en-US" sz="2400" b="1" dirty="0">
                 <a:solidFill>
                   <a:srgbClr val="000000"/>
                 </a:solidFill>
@@ -23391,7 +23391,7 @@
               </a:rPr>
               <a:t>The semiconductor market.</a:t>
             </a:r>
-            <a:endParaRPr lang="en-US" sz="2700" dirty="0"/>
+            <a:endParaRPr lang="en-US" sz="2400" dirty="0"/>
           </a:p>
         </p:txBody>
       </p:sp>
@@ -23403,7 +23403,7 @@
         </p:nvSpPr>
         <p:spPr>
           <a:xfrm>
-            <a:off x="457200" y="868680"/>
+            <a:off x="457200" y="914400"/>
             <a:ext cx="8229600" cy="457200"/>
           </a:xfrm>
           <a:prstGeom prst="rect">
@@ -24064,7 +24064,7 @@
         <p:spPr>
           <a:xfrm>
             <a:off x="457200" y="182880"/>
-            <a:ext cx="6583680" cy="640080"/>
+            <a:ext cx="6583680" cy="685800"/>
           </a:xfrm>
           <a:prstGeom prst="rect">
             <a:avLst/>
@@ -24080,7 +24080,7 @@
               <a:buNone/>
             </a:pPr>
             <a:r>
-              <a:rPr lang="en-US" sz="2700" b="1" dirty="0">
+              <a:rPr lang="en-US" sz="2400" b="1" dirty="0">
                 <a:solidFill>
                   <a:srgbClr val="000000"/>
                 </a:solidFill>
@@ -24090,7 +24090,7 @@
               </a:rPr>
               <a:t>The labs.</a:t>
             </a:r>
-            <a:endParaRPr lang="en-US" sz="2700" dirty="0"/>
+            <a:endParaRPr lang="en-US" sz="2400" dirty="0"/>
           </a:p>
         </p:txBody>
       </p:sp>
@@ -24102,7 +24102,7 @@
         </p:nvSpPr>
         <p:spPr>
           <a:xfrm>
-            <a:off x="457200" y="868680"/>
+            <a:off x="457200" y="914400"/>
             <a:ext cx="8229600" cy="457200"/>
           </a:xfrm>
           <a:prstGeom prst="rect">
@@ -25864,7 +25864,7 @@
         <p:spPr>
           <a:xfrm>
             <a:off x="457200" y="182880"/>
-            <a:ext cx="6583680" cy="640080"/>
+            <a:ext cx="6583680" cy="685800"/>
           </a:xfrm>
           <a:prstGeom prst="rect">
             <a:avLst/>
@@ -25880,7 +25880,7 @@
               <a:buNone/>
             </a:pPr>
             <a:r>
-              <a:rPr lang="en-US" sz="2700" b="1" dirty="0">
+              <a:rPr lang="en-US" sz="2400" b="1" dirty="0">
                 <a:solidFill>
                   <a:srgbClr val="000000"/>
                 </a:solidFill>
@@ -25890,7 +25890,7 @@
               </a:rPr>
               <a:t>Earnings &amp; valuations.</a:t>
             </a:r>
-            <a:endParaRPr lang="en-US" sz="2700" dirty="0"/>
+            <a:endParaRPr lang="en-US" sz="2400" dirty="0"/>
           </a:p>
         </p:txBody>
       </p:sp>
@@ -25902,7 +25902,7 @@
         </p:nvSpPr>
         <p:spPr>
           <a:xfrm>
-            <a:off x="457200" y="868680"/>
+            <a:off x="457200" y="914400"/>
             <a:ext cx="8229600" cy="457200"/>
           </a:xfrm>
           <a:prstGeom prst="rect">

</xml_diff>

<commit_message>
Swap Mistral for Google on slide 8 and add lab logos
Mistral drops off the frontier-labs table — its $14B valuation is an
order of magnitude below the others and no longer belongs on this
slide. Google joins at $2.3T Alphabet market cap, reframing the slide
as three private labs plus one public hyperscaler. Add a leftmost logo
column with the four company marks so the table is scannable at a
glance.

Co-Authored-By: Claude Opus 4.7 <noreply@anthropic.com>
</commit_message>
<xml_diff>
--- a/ai-markets-deck.pptx
+++ b/ai-markets-deck.pptx
@@ -24127,7 +24127,7 @@
                 <a:ea typeface="Arial" pitchFamily="34" charset="-122"/>
                 <a:cs typeface="Arial" pitchFamily="34" charset="-120"/>
               </a:rPr>
-              <a:t>Four frontier labs now worth ~$1.5T in aggregate private value. Q1 2026 doubled all of 2025's foundational-AI VC funding — and VCs are still chasing.</a:t>
+              <a:t>Three private labs worth ~$1.5T combined, plus Google inside Alphabet's $2.3T public market cap. Q1 2026 doubled all of 2025's foundational-AI VC funding.</a:t>
             </a:r>
             <a:endParaRPr lang="en-US" sz="1350" dirty="0"/>
           </a:p>
@@ -24179,12 +24179,70 @@
             <a:tbl>
               <a:tblPr/>
               <a:tblGrid>
+                <a:gridCol w="640080"/>
+                <a:gridCol w="1097280"/>
                 <a:gridCol w="1188720"/>
                 <a:gridCol w="1280160"/>
-                <a:gridCol w="1371600"/>
-                <a:gridCol w="4389120"/>
+                <a:gridCol w="4023360"/>
               </a:tblGrid>
               <a:tr h="502920">
+                <a:tc>
+                  <a:txBody>
+                    <a:bodyPr/>
+                    <a:lstStyle/>
+                    <a:p>
+                      <a:pPr algn="ctr" indent="0" marL="0">
+                        <a:buNone/>
+                      </a:pPr>
+                      <a:endParaRPr lang="en-US" sz="1100" dirty="0">
+                        <a:latin typeface="Arial" charset="0"/>
+                        <a:ea typeface="Arial" charset="0"/>
+                        <a:cs typeface="Arial" charset="0"/>
+                      </a:endParaRPr>
+                    </a:p>
+                  </a:txBody>
+                  <a:tcPr marL="91440" marR="91440" marT="45720" marB="45720" anchor="ctr">
+                    <a:lnL w="6350" cap="flat" cmpd="sng" algn="ctr">
+                      <a:solidFill>
+                        <a:srgbClr val="E5E5E5"/>
+                      </a:solidFill>
+                      <a:prstDash val="solid"/>
+                      <a:round/>
+                      <a:headEnd type="none" w="med" len="med"/>
+                      <a:tailEnd type="none" w="med" len="med"/>
+                    </a:lnL>
+                    <a:lnR w="6350" cap="flat" cmpd="sng" algn="ctr">
+                      <a:solidFill>
+                        <a:srgbClr val="E5E5E5"/>
+                      </a:solidFill>
+                      <a:prstDash val="solid"/>
+                      <a:round/>
+                      <a:headEnd type="none" w="med" len="med"/>
+                      <a:tailEnd type="none" w="med" len="med"/>
+                    </a:lnR>
+                    <a:lnT w="6350" cap="flat" cmpd="sng" algn="ctr">
+                      <a:solidFill>
+                        <a:srgbClr val="E5E5E5"/>
+                      </a:solidFill>
+                      <a:prstDash val="solid"/>
+                      <a:round/>
+                      <a:headEnd type="none" w="med" len="med"/>
+                      <a:tailEnd type="none" w="med" len="med"/>
+                    </a:lnT>
+                    <a:lnB w="6350" cap="flat" cmpd="sng" algn="ctr">
+                      <a:solidFill>
+                        <a:srgbClr val="E5E5E5"/>
+                      </a:solidFill>
+                      <a:prstDash val="solid"/>
+                      <a:round/>
+                      <a:headEnd type="none" w="med" len="med"/>
+                      <a:tailEnd type="none" w="med" len="med"/>
+                    </a:lnB>
+                    <a:solidFill>
+                      <a:srgbClr val="000000"/>
+                    </a:solidFill>
+                  </a:tcPr>
+                </a:tc>
                 <a:tc>
                   <a:txBody>
                     <a:bodyPr/>
@@ -24464,6 +24522,63 @@
                     <a:bodyPr/>
                     <a:lstStyle/>
                     <a:p>
+                      <a:pPr algn="ctr" indent="0" marL="0">
+                        <a:buNone/>
+                      </a:pPr>
+                      <a:endParaRPr lang="en-US" sz="1150" dirty="0">
+                        <a:latin typeface="Arial" charset="0"/>
+                        <a:ea typeface="Arial" charset="0"/>
+                        <a:cs typeface="Arial" charset="0"/>
+                      </a:endParaRPr>
+                    </a:p>
+                  </a:txBody>
+                  <a:tcPr marL="91440" marR="91440" marT="45720" marB="45720" anchor="ctr">
+                    <a:lnL w="6350" cap="flat" cmpd="sng" algn="ctr">
+                      <a:solidFill>
+                        <a:srgbClr val="E5E5E5"/>
+                      </a:solidFill>
+                      <a:prstDash val="solid"/>
+                      <a:round/>
+                      <a:headEnd type="none" w="med" len="med"/>
+                      <a:tailEnd type="none" w="med" len="med"/>
+                    </a:lnL>
+                    <a:lnR w="6350" cap="flat" cmpd="sng" algn="ctr">
+                      <a:solidFill>
+                        <a:srgbClr val="E5E5E5"/>
+                      </a:solidFill>
+                      <a:prstDash val="solid"/>
+                      <a:round/>
+                      <a:headEnd type="none" w="med" len="med"/>
+                      <a:tailEnd type="none" w="med" len="med"/>
+                    </a:lnR>
+                    <a:lnT w="6350" cap="flat" cmpd="sng" algn="ctr">
+                      <a:solidFill>
+                        <a:srgbClr val="E5E5E5"/>
+                      </a:solidFill>
+                      <a:prstDash val="solid"/>
+                      <a:round/>
+                      <a:headEnd type="none" w="med" len="med"/>
+                      <a:tailEnd type="none" w="med" len="med"/>
+                    </a:lnT>
+                    <a:lnB w="6350" cap="flat" cmpd="sng" algn="ctr">
+                      <a:solidFill>
+                        <a:srgbClr val="E5E5E5"/>
+                      </a:solidFill>
+                      <a:prstDash val="solid"/>
+                      <a:round/>
+                      <a:headEnd type="none" w="med" len="med"/>
+                      <a:tailEnd type="none" w="med" len="med"/>
+                    </a:lnB>
+                    <a:solidFill>
+                      <a:srgbClr val="FFFFFF"/>
+                    </a:solidFill>
+                  </a:tcPr>
+                </a:tc>
+                <a:tc>
+                  <a:txBody>
+                    <a:bodyPr/>
+                    <a:lstStyle/>
+                    <a:p>
                       <a:pPr algn="l" indent="0" marL="0">
                         <a:buNone/>
                       </a:pPr>
@@ -24733,6 +24848,63 @@
                 </a:tc>
               </a:tr>
               <a:tr h="502920">
+                <a:tc>
+                  <a:txBody>
+                    <a:bodyPr/>
+                    <a:lstStyle/>
+                    <a:p>
+                      <a:pPr algn="ctr" indent="0" marL="0">
+                        <a:buNone/>
+                      </a:pPr>
+                      <a:endParaRPr lang="en-US" sz="1150" dirty="0">
+                        <a:latin typeface="Arial" charset="0"/>
+                        <a:ea typeface="Arial" charset="0"/>
+                        <a:cs typeface="Arial" charset="0"/>
+                      </a:endParaRPr>
+                    </a:p>
+                  </a:txBody>
+                  <a:tcPr marL="91440" marR="91440" marT="45720" marB="45720" anchor="ctr">
+                    <a:lnL w="6350" cap="flat" cmpd="sng" algn="ctr">
+                      <a:solidFill>
+                        <a:srgbClr val="E5E5E5"/>
+                      </a:solidFill>
+                      <a:prstDash val="solid"/>
+                      <a:round/>
+                      <a:headEnd type="none" w="med" len="med"/>
+                      <a:tailEnd type="none" w="med" len="med"/>
+                    </a:lnL>
+                    <a:lnR w="6350" cap="flat" cmpd="sng" algn="ctr">
+                      <a:solidFill>
+                        <a:srgbClr val="E5E5E5"/>
+                      </a:solidFill>
+                      <a:prstDash val="solid"/>
+                      <a:round/>
+                      <a:headEnd type="none" w="med" len="med"/>
+                      <a:tailEnd type="none" w="med" len="med"/>
+                    </a:lnR>
+                    <a:lnT w="6350" cap="flat" cmpd="sng" algn="ctr">
+                      <a:solidFill>
+                        <a:srgbClr val="E5E5E5"/>
+                      </a:solidFill>
+                      <a:prstDash val="solid"/>
+                      <a:round/>
+                      <a:headEnd type="none" w="med" len="med"/>
+                      <a:tailEnd type="none" w="med" len="med"/>
+                    </a:lnT>
+                    <a:lnB w="6350" cap="flat" cmpd="sng" algn="ctr">
+                      <a:solidFill>
+                        <a:srgbClr val="E5E5E5"/>
+                      </a:solidFill>
+                      <a:prstDash val="solid"/>
+                      <a:round/>
+                      <a:headEnd type="none" w="med" len="med"/>
+                      <a:tailEnd type="none" w="med" len="med"/>
+                    </a:lnB>
+                    <a:solidFill>
+                      <a:srgbClr val="F9F9F9"/>
+                    </a:solidFill>
+                  </a:tcPr>
+                </a:tc>
                 <a:tc>
                   <a:txBody>
                     <a:bodyPr/>
@@ -25012,6 +25184,63 @@
                     <a:bodyPr/>
                     <a:lstStyle/>
                     <a:p>
+                      <a:pPr algn="ctr" indent="0" marL="0">
+                        <a:buNone/>
+                      </a:pPr>
+                      <a:endParaRPr lang="en-US" sz="1150" dirty="0">
+                        <a:latin typeface="Arial" charset="0"/>
+                        <a:ea typeface="Arial" charset="0"/>
+                        <a:cs typeface="Arial" charset="0"/>
+                      </a:endParaRPr>
+                    </a:p>
+                  </a:txBody>
+                  <a:tcPr marL="91440" marR="91440" marT="45720" marB="45720" anchor="ctr">
+                    <a:lnL w="6350" cap="flat" cmpd="sng" algn="ctr">
+                      <a:solidFill>
+                        <a:srgbClr val="E5E5E5"/>
+                      </a:solidFill>
+                      <a:prstDash val="solid"/>
+                      <a:round/>
+                      <a:headEnd type="none" w="med" len="med"/>
+                      <a:tailEnd type="none" w="med" len="med"/>
+                    </a:lnL>
+                    <a:lnR w="6350" cap="flat" cmpd="sng" algn="ctr">
+                      <a:solidFill>
+                        <a:srgbClr val="E5E5E5"/>
+                      </a:solidFill>
+                      <a:prstDash val="solid"/>
+                      <a:round/>
+                      <a:headEnd type="none" w="med" len="med"/>
+                      <a:tailEnd type="none" w="med" len="med"/>
+                    </a:lnR>
+                    <a:lnT w="6350" cap="flat" cmpd="sng" algn="ctr">
+                      <a:solidFill>
+                        <a:srgbClr val="E5E5E5"/>
+                      </a:solidFill>
+                      <a:prstDash val="solid"/>
+                      <a:round/>
+                      <a:headEnd type="none" w="med" len="med"/>
+                      <a:tailEnd type="none" w="med" len="med"/>
+                    </a:lnT>
+                    <a:lnB w="6350" cap="flat" cmpd="sng" algn="ctr">
+                      <a:solidFill>
+                        <a:srgbClr val="E5E5E5"/>
+                      </a:solidFill>
+                      <a:prstDash val="solid"/>
+                      <a:round/>
+                      <a:headEnd type="none" w="med" len="med"/>
+                      <a:tailEnd type="none" w="med" len="med"/>
+                    </a:lnB>
+                    <a:solidFill>
+                      <a:srgbClr val="FFFFFF"/>
+                    </a:solidFill>
+                  </a:tcPr>
+                </a:tc>
+                <a:tc>
+                  <a:txBody>
+                    <a:bodyPr/>
+                    <a:lstStyle/>
+                    <a:p>
                       <a:pPr algn="l" indent="0" marL="0">
                         <a:buNone/>
                       </a:pPr>
@@ -25024,7 +25253,7 @@
                           <a:ea typeface="Arial" pitchFamily="34" charset="-122"/>
                           <a:cs typeface="Arial" pitchFamily="34" charset="-120"/>
                         </a:rPr>
-                        <a:t>xAI</a:t>
+                        <a:t>Google</a:t>
                       </a:r>
                       <a:endParaRPr lang="en-US" sz="1150" dirty="0">
                         <a:latin typeface="Arial" charset="0"/>
@@ -25092,7 +25321,7 @@
                           <a:ea typeface="Arial" pitchFamily="34" charset="-122"/>
                           <a:cs typeface="Arial" pitchFamily="34" charset="-120"/>
                         </a:rPr>
-                        <a:t>$230B</a:t>
+                        <a:t>$2.3T</a:t>
                       </a:r>
                       <a:endParaRPr lang="en-US" sz="1150" dirty="0">
                         <a:latin typeface="Arial" charset="0"/>
@@ -25160,7 +25389,7 @@
                           <a:ea typeface="Arial" pitchFamily="34" charset="-122"/>
                           <a:cs typeface="Arial" pitchFamily="34" charset="-120"/>
                         </a:rPr>
-                        <a:t>~77× ARR*</a:t>
+                        <a:t>~20× P/E</a:t>
                       </a:r>
                       <a:endParaRPr lang="en-US" sz="1150" dirty="0">
                         <a:latin typeface="Arial" charset="0"/>
@@ -25228,7 +25457,7 @@
                           <a:ea typeface="Arial" pitchFamily="34" charset="-122"/>
                           <a:cs typeface="Arial" pitchFamily="34" charset="-120"/>
                         </a:rPr>
-                        <a:t>$20B Nvidia-led Series E · Q1 2026</a:t>
+                        <a:t>Alphabet (public) · Gemini 3 / DeepMind · ~$85B 2026 capex</a:t>
                       </a:r>
                       <a:endParaRPr lang="en-US" sz="1050" dirty="0">
                         <a:latin typeface="Arial" charset="0"/>
@@ -25286,6 +25515,63 @@
                     <a:bodyPr/>
                     <a:lstStyle/>
                     <a:p>
+                      <a:pPr algn="ctr" indent="0" marL="0">
+                        <a:buNone/>
+                      </a:pPr>
+                      <a:endParaRPr lang="en-US" sz="1150" dirty="0">
+                        <a:latin typeface="Arial" charset="0"/>
+                        <a:ea typeface="Arial" charset="0"/>
+                        <a:cs typeface="Arial" charset="0"/>
+                      </a:endParaRPr>
+                    </a:p>
+                  </a:txBody>
+                  <a:tcPr marL="91440" marR="91440" marT="45720" marB="45720" anchor="ctr">
+                    <a:lnL w="6350" cap="flat" cmpd="sng" algn="ctr">
+                      <a:solidFill>
+                        <a:srgbClr val="E5E5E5"/>
+                      </a:solidFill>
+                      <a:prstDash val="solid"/>
+                      <a:round/>
+                      <a:headEnd type="none" w="med" len="med"/>
+                      <a:tailEnd type="none" w="med" len="med"/>
+                    </a:lnL>
+                    <a:lnR w="6350" cap="flat" cmpd="sng" algn="ctr">
+                      <a:solidFill>
+                        <a:srgbClr val="E5E5E5"/>
+                      </a:solidFill>
+                      <a:prstDash val="solid"/>
+                      <a:round/>
+                      <a:headEnd type="none" w="med" len="med"/>
+                      <a:tailEnd type="none" w="med" len="med"/>
+                    </a:lnR>
+                    <a:lnT w="6350" cap="flat" cmpd="sng" algn="ctr">
+                      <a:solidFill>
+                        <a:srgbClr val="E5E5E5"/>
+                      </a:solidFill>
+                      <a:prstDash val="solid"/>
+                      <a:round/>
+                      <a:headEnd type="none" w="med" len="med"/>
+                      <a:tailEnd type="none" w="med" len="med"/>
+                    </a:lnT>
+                    <a:lnB w="6350" cap="flat" cmpd="sng" algn="ctr">
+                      <a:solidFill>
+                        <a:srgbClr val="E5E5E5"/>
+                      </a:solidFill>
+                      <a:prstDash val="solid"/>
+                      <a:round/>
+                      <a:headEnd type="none" w="med" len="med"/>
+                      <a:tailEnd type="none" w="med" len="med"/>
+                    </a:lnB>
+                    <a:solidFill>
+                      <a:srgbClr val="F9F9F9"/>
+                    </a:solidFill>
+                  </a:tcPr>
+                </a:tc>
+                <a:tc>
+                  <a:txBody>
+                    <a:bodyPr/>
+                    <a:lstStyle/>
+                    <a:p>
                       <a:pPr algn="l" indent="0" marL="0">
                         <a:buNone/>
                       </a:pPr>
@@ -25298,7 +25584,7 @@
                           <a:ea typeface="Arial" pitchFamily="34" charset="-122"/>
                           <a:cs typeface="Arial" pitchFamily="34" charset="-120"/>
                         </a:rPr>
-                        <a:t>Mistral</a:t>
+                        <a:t>xAI</a:t>
                       </a:r>
                       <a:endParaRPr lang="en-US" sz="1150" dirty="0">
                         <a:latin typeface="Arial" charset="0"/>
@@ -25366,7 +25652,7 @@
                           <a:ea typeface="Arial" pitchFamily="34" charset="-122"/>
                           <a:cs typeface="Arial" pitchFamily="34" charset="-120"/>
                         </a:rPr>
-                        <a:t>$14B</a:t>
+                        <a:t>$230B</a:t>
                       </a:r>
                       <a:endParaRPr lang="en-US" sz="1150" dirty="0">
                         <a:latin typeface="Arial" charset="0"/>
@@ -25434,7 +25720,7 @@
                           <a:ea typeface="Arial" pitchFamily="34" charset="-122"/>
                           <a:cs typeface="Arial" pitchFamily="34" charset="-120"/>
                         </a:rPr>
-                        <a:t>~14× ARR</a:t>
+                        <a:t>~77× ARR*</a:t>
                       </a:r>
                       <a:endParaRPr lang="en-US" sz="1150" dirty="0">
                         <a:latin typeface="Arial" charset="0"/>
@@ -25502,7 +25788,7 @@
                           <a:ea typeface="Arial" pitchFamily="34" charset="-122"/>
                           <a:cs typeface="Arial" pitchFamily="34" charset="-120"/>
                         </a:rPr>
-                        <a:t>€1.7B Series C · Jun 2024</a:t>
+                        <a:t>$20B Nvidia-led Series E · Q1 2026</a:t>
                       </a:r>
                       <a:endParaRPr lang="en-US" sz="1050" dirty="0">
                         <a:latin typeface="Arial" charset="0"/>
@@ -25558,9 +25844,101 @@
           </a:graphicData>
         </a:graphic>
       </p:graphicFrame>
-      <p:sp>
-        <p:nvSpPr>
-          <p:cNvPr id="8" name="Shape 5"/>
+      <p:pic>
+        <p:nvPicPr>
+          <p:cNvPr id="8" name="Image 0" descr="logos/openai.png">    </p:cNvPr>
+          <p:cNvPicPr>
+            <a:picLocks noChangeAspect="1"/>
+          </p:cNvPicPr>
+          <p:nvPr/>
+        </p:nvPicPr>
+        <p:blipFill>
+          <a:blip r:embed="rId1"/>
+          <a:srcRect l="0" r="0" t="0" b="0"/>
+          <a:stretch/>
+        </p:blipFill>
+        <p:spPr>
+          <a:xfrm>
+            <a:off x="594360" y="2308860"/>
+            <a:ext cx="365760" cy="365760"/>
+          </a:xfrm>
+          <a:prstGeom prst="rect">
+            <a:avLst/>
+          </a:prstGeom>
+        </p:spPr>
+      </p:pic>
+      <p:pic>
+        <p:nvPicPr>
+          <p:cNvPr id="9" name="Image 1" descr="logos/anthropic.png">    </p:cNvPr>
+          <p:cNvPicPr>
+            <a:picLocks noChangeAspect="1"/>
+          </p:cNvPicPr>
+          <p:nvPr/>
+        </p:nvPicPr>
+        <p:blipFill>
+          <a:blip r:embed="rId2"/>
+          <a:srcRect l="0" r="0" t="0" b="0"/>
+          <a:stretch/>
+        </p:blipFill>
+        <p:spPr>
+          <a:xfrm>
+            <a:off x="594360" y="2811780"/>
+            <a:ext cx="365760" cy="365760"/>
+          </a:xfrm>
+          <a:prstGeom prst="rect">
+            <a:avLst/>
+          </a:prstGeom>
+        </p:spPr>
+      </p:pic>
+      <p:pic>
+        <p:nvPicPr>
+          <p:cNvPr id="10" name="Image 2" descr="logos/google.png">    </p:cNvPr>
+          <p:cNvPicPr>
+            <a:picLocks noChangeAspect="1"/>
+          </p:cNvPicPr>
+          <p:nvPr/>
+        </p:nvPicPr>
+        <p:blipFill>
+          <a:blip r:embed="rId3"/>
+          <a:srcRect l="0" r="0" t="0" b="0"/>
+          <a:stretch/>
+        </p:blipFill>
+        <p:spPr>
+          <a:xfrm>
+            <a:off x="594360" y="3314700"/>
+            <a:ext cx="365760" cy="365760"/>
+          </a:xfrm>
+          <a:prstGeom prst="rect">
+            <a:avLst/>
+          </a:prstGeom>
+        </p:spPr>
+      </p:pic>
+      <p:pic>
+        <p:nvPicPr>
+          <p:cNvPr id="11" name="Image 3" descr="logos/xai.png">    </p:cNvPr>
+          <p:cNvPicPr>
+            <a:picLocks noChangeAspect="1"/>
+          </p:cNvPicPr>
+          <p:nvPr/>
+        </p:nvPicPr>
+        <p:blipFill>
+          <a:blip r:embed="rId4"/>
+          <a:srcRect l="0" r="0" t="0" b="0"/>
+          <a:stretch/>
+        </p:blipFill>
+        <p:spPr>
+          <a:xfrm>
+            <a:off x="594360" y="3817620"/>
+            <a:ext cx="365760" cy="365760"/>
+          </a:xfrm>
+          <a:prstGeom prst="rect">
+            <a:avLst/>
+          </a:prstGeom>
+        </p:spPr>
+      </p:pic>
+      <p:sp>
+        <p:nvSpPr>
+          <p:cNvPr id="12" name="Shape 5"/>
           <p:cNvSpPr/>
           <p:nvPr/>
         </p:nvSpPr>
@@ -25585,7 +25963,7 @@
       </p:sp>
       <p:sp>
         <p:nvSpPr>
-          <p:cNvPr id="9" name="Text 6"/>
+          <p:cNvPr id="13" name="Text 6"/>
           <p:cNvSpPr/>
           <p:nvPr/>
         </p:nvSpPr>
@@ -25624,7 +26002,7 @@
       </p:sp>
       <p:sp>
         <p:nvSpPr>
-          <p:cNvPr id="10" name="Text 7"/>
+          <p:cNvPr id="14" name="Text 7"/>
           <p:cNvSpPr/>
           <p:nvPr/>
         </p:nvSpPr>
@@ -25655,7 +26033,7 @@
                 <a:ea typeface="Arial" pitchFamily="34" charset="-122"/>
                 <a:cs typeface="Arial" pitchFamily="34" charset="-120"/>
               </a:rPr>
-              <a:t>Sources: TechCrunch, CNBC, Tech-Insider (Apr 2026); Crunchbase Q1 2026 VC data; Sacra ARR run-rates; Bloomberg. *xAI ARR estimated.</a:t>
+              <a:t>Sources: TechCrunch, CNBC, Tech-Insider (Apr 2026); Crunchbase Q1 2026 VC data; Sacra ARR run-rates; Bloomberg; Alphabet 10-K &amp; 2026 capex guide. *xAI ARR estimated.</a:t>
             </a:r>
             <a:endParaRPr lang="en-US" sz="700" dirty="0"/>
           </a:p>
@@ -25663,7 +26041,7 @@
       </p:sp>
       <p:sp>
         <p:nvSpPr>
-          <p:cNvPr id="11" name="Shape 8"/>
+          <p:cNvPr id="15" name="Shape 8"/>
           <p:cNvSpPr/>
           <p:nvPr/>
         </p:nvSpPr>
@@ -25688,7 +26066,7 @@
       </p:sp>
       <p:sp>
         <p:nvSpPr>
-          <p:cNvPr id="12" name="Text 9"/>
+          <p:cNvPr id="16" name="Text 9"/>
           <p:cNvSpPr/>
           <p:nvPr/>
         </p:nvSpPr>
@@ -25727,7 +26105,7 @@
       </p:sp>
       <p:sp>
         <p:nvSpPr>
-          <p:cNvPr id="13" name="Text 10"/>
+          <p:cNvPr id="17" name="Text 10"/>
           <p:cNvSpPr/>
           <p:nvPr/>
         </p:nvSpPr>

</xml_diff>

<commit_message>
Redesign slide 7 with value-chain stages; expand image prompts
Slide 7 now teaches both axes — a top strip shows the four-stage
value chain (DESIGN → EQUIPMENT → FOUNDRY → PACKAGING) with chevron
flow arrows and key players at each stage, so semicap equipment,
foundry, and advanced packaging all land as first-class topics. The
2x3 product-category card grid stays intact below. The yellow payoff
banner is refreshed to tie both axes together.

Also rewrites IMAGE_PROMPTS.md to match the current seven placeholders
with slide-by-slide ChatGPT-ready prompts that include aspect ratio,
theme-color accent, mood, and style guardrails. On-slide placeholder
descriptions are expanded modestly so each one reads as a useful
concise reference without overflowing the placeholder box.

Co-Authored-By: Claude Opus 4.7 <noreply@anthropic.com>
</commit_message>
<xml_diff>
--- a/ai-markets-deck.pptx
+++ b/ai-markets-deck.pptx
@@ -9302,7 +9302,7 @@
                 <a:ea typeface="Arial" pitchFamily="34" charset="-122"/>
                 <a:cs typeface="Arial" pitchFamily="34" charset="-120"/>
               </a:rPr>
-              <a:t>IMAGE: Screenshot — dark-themed IDE with AI coworker editing code, orange accents</a:t>
+              <a:t>IMAGE: Screenshot — dark-mode IDE, AI agent editing Python code live, glowing orange cursor, 'Claude is editing' pill, streaming test output in a terminal pane, square framing</a:t>
             </a:r>
             <a:endParaRPr lang="en-US" sz="1000" dirty="0"/>
           </a:p>
@@ -14091,7 +14091,7 @@
                 <a:ea typeface="Arial" pitchFamily="34" charset="-122"/>
                 <a:cs typeface="Arial" pitchFamily="34" charset="-120"/>
               </a:rPr>
-              <a:t>IMAGE: Cinematic — bunny-suited techs on fab floor, orange photolith glow, tall aspect</a:t>
+              <a:t>IMAGE: Cinematic — two bunny-suited technicians in front of an EUV lithography tool, warm amber photolith glow, shallow DOF on a gloved hand at a control, stainless-steel cleanroom, near-square</a:t>
             </a:r>
             <a:endParaRPr lang="en-US" sz="1000" dirty="0"/>
           </a:p>
@@ -16265,7 +16265,7 @@
                 <a:ea typeface="Arial" pitchFamily="34" charset="-122"/>
                 <a:cs typeface="Arial" pitchFamily="34" charset="-120"/>
               </a:rPr>
-              <a:t>IMAGE: Photojournalism — 'STOP THE AI RACE' hand-lettered signs at a dusk rally, tall aspect</a:t>
+              <a:t>IMAGE: Photojournalism — 'STOP THE AI RACE' hand-lettered protest signs at a dusk rally, shoulder-height crowd POV, warm golden-hour sky, faces in shadow, signs in sharp focus, square</a:t>
             </a:r>
             <a:endParaRPr lang="en-US" sz="1000" dirty="0"/>
           </a:p>
@@ -17150,7 +17150,7 @@
                 <a:ea typeface="Arial" pitchFamily="34" charset="-122"/>
                 <a:cs typeface="Arial" pitchFamily="34" charset="-120"/>
               </a:rPr>
-              <a:t>IMAGE: Render — orbital data-center satellite with solar wings above Earth's limb at dawn</a:t>
+              <a:t>IMAGE: Render — modular orbital data-center satellite with 50-meter solar wings catching a violet tint, above Earth's dawn limb with atmospheric glow, deep indigo space, hyperrealistic Octane quality, slightly portrait</a:t>
             </a:r>
             <a:endParaRPr lang="en-US" sz="1000" dirty="0"/>
           </a:p>
@@ -18010,7 +18010,7 @@
                 <a:ea typeface="Arial" pitchFamily="34" charset="-122"/>
                 <a:cs typeface="Arial" pitchFamily="34" charset="-120"/>
               </a:rPr>
-              <a:t>IMAGE: Photo — humanoid robot mid-stride on a factory floor, warm work-light, motion blur</a:t>
+              <a:t>IMAGE: Panoramic photo — humanoid robot mid-stride on a factory floor, matte-white body with violet joint accents, motion blur on limbs, amber work-lights, a blurred human worker in a safety vest in the background</a:t>
             </a:r>
             <a:endParaRPr lang="en-US" sz="1000" dirty="0"/>
           </a:p>
@@ -20066,7 +20066,7 @@
                 <a:ea typeface="Arial" pitchFamily="34" charset="-122"/>
                 <a:cs typeface="Arial" pitchFamily="34" charset="-120"/>
               </a:rPr>
-              <a:t>IMAGE: Photo — Waymo robotaxi on a rainy city street at dusk, sensor pod lit, long exposure</a:t>
+              <a:t>IMAGE: Long-exposure photo — white minivan robotaxi with a violet-glowing roof lidar on a rainy dusk city street, red and white traffic light trails, wet asphalt reflecting neon storefronts, tall portrait</a:t>
             </a:r>
             <a:endParaRPr lang="en-US" sz="1000" dirty="0"/>
           </a:p>
@@ -20926,7 +20926,7 @@
                 <a:ea typeface="Arial" pitchFamily="34" charset="-122"/>
                 <a:cs typeface="Arial" pitchFamily="34" charset="-120"/>
               </a:rPr>
-              <a:t>IMAGE: Render — ribbon-diagram protein structure against graphite black, shallow DOF</a:t>
+              <a:t>IMAGE: Render — protein ribbon diagram in a violet-to-magenta-to-gold gradient on graphite black, razor-sharp front with softly-blurred back, faint electron-density mesh around the structure, no labels or annotations</a:t>
             </a:r>
             <a:endParaRPr lang="en-US" sz="1000" dirty="0"/>
           </a:p>
@@ -33171,7 +33171,7 @@
                 <a:ea typeface="Arial" pitchFamily="34" charset="-122"/>
                 <a:cs typeface="Arial" pitchFamily="34" charset="-120"/>
               </a:rPr>
-              <a:t>Silicon wafers etched with billions of microscopic switches. A handful of categories do very different jobs — and AI demand concentrates in just two.</a:t>
+              <a:t>Chips pass through four making stages before reaching six product markets. AI capex piles into just two categories — but flows through bottlenecks at every stage.</a:t>
             </a:r>
             <a:endParaRPr lang="en-US" sz="1350" dirty="0"/>
           </a:p>
@@ -33209,7 +33209,7 @@
         <p:spPr>
           <a:xfrm>
             <a:off x="457200" y="1691640"/>
-            <a:ext cx="8229600" cy="457200"/>
+            <a:ext cx="8229600" cy="777240"/>
           </a:xfrm>
           <a:prstGeom prst="rect">
             <a:avLst/>
@@ -33233,10 +33233,812 @@
         </p:nvSpPr>
         <p:spPr>
           <a:xfrm>
-            <a:off x="658368" y="1847088"/>
-            <a:ext cx="146304" cy="146304"/>
+            <a:off x="640080" y="1792224"/>
+            <a:ext cx="128016" cy="128016"/>
           </a:xfrm>
           <a:prstGeom prst="ellipse">
+            <a:avLst/>
+          </a:prstGeom>
+          <a:solidFill>
+            <a:srgbClr val="6B46C1"/>
+          </a:solidFill>
+          <a:ln w="12700">
+            <a:solidFill>
+              <a:srgbClr val="6B46C1"/>
+            </a:solidFill>
+            <a:prstDash val="solid"/>
+          </a:ln>
+        </p:spPr>
+      </p:sp>
+      <p:sp>
+        <p:nvSpPr>
+          <p:cNvPr id="9" name="Text 7"/>
+          <p:cNvSpPr/>
+          <p:nvPr/>
+        </p:nvSpPr>
+        <p:spPr>
+          <a:xfrm>
+            <a:off x="822960" y="1709928"/>
+            <a:ext cx="1600200" cy="237744"/>
+          </a:xfrm>
+          <a:prstGeom prst="rect">
+            <a:avLst/>
+          </a:prstGeom>
+          <a:noFill/>
+          <a:ln/>
+        </p:spPr>
+        <p:txBody>
+          <a:bodyPr wrap="square" lIns="0" tIns="0" rIns="0" bIns="0" rtlCol="0" anchor="ctr"/>
+          <a:lstStyle/>
+          <a:p>
+            <a:pPr indent="0" marL="0">
+              <a:buNone/>
+            </a:pPr>
+            <a:r>
+              <a:rPr lang="en-US" sz="1100" b="1" spc="200" kern="0" dirty="0">
+                <a:solidFill>
+                  <a:srgbClr val="000000"/>
+                </a:solidFill>
+                <a:latin typeface="Arial" pitchFamily="34" charset="0"/>
+                <a:ea typeface="Arial" pitchFamily="34" charset="-122"/>
+                <a:cs typeface="Arial" pitchFamily="34" charset="-120"/>
+              </a:rPr>
+              <a:t>DESIGN</a:t>
+            </a:r>
+            <a:endParaRPr lang="en-US" sz="1100" dirty="0"/>
+          </a:p>
+        </p:txBody>
+      </p:sp>
+      <p:sp>
+        <p:nvSpPr>
+          <p:cNvPr id="10" name="Text 8"/>
+          <p:cNvSpPr/>
+          <p:nvPr/>
+        </p:nvSpPr>
+        <p:spPr>
+          <a:xfrm>
+            <a:off x="640080" y="1947672"/>
+            <a:ext cx="1783080" cy="182880"/>
+          </a:xfrm>
+          <a:prstGeom prst="rect">
+            <a:avLst/>
+          </a:prstGeom>
+          <a:noFill/>
+          <a:ln/>
+        </p:spPr>
+        <p:txBody>
+          <a:bodyPr wrap="square" lIns="0" tIns="0" rIns="0" bIns="0" rtlCol="0" anchor="ctr"/>
+          <a:lstStyle/>
+          <a:p>
+            <a:pPr indent="0" marL="0">
+              <a:buNone/>
+            </a:pPr>
+            <a:r>
+              <a:rPr lang="en-US" sz="950" i="1" dirty="0">
+                <a:solidFill>
+                  <a:srgbClr val="666666"/>
+                </a:solidFill>
+                <a:latin typeface="Arial" pitchFamily="34" charset="0"/>
+                <a:ea typeface="Arial" pitchFamily="34" charset="-122"/>
+                <a:cs typeface="Arial" pitchFamily="34" charset="-120"/>
+              </a:rPr>
+              <a:t>architects the chip</a:t>
+            </a:r>
+            <a:endParaRPr lang="en-US" sz="950" dirty="0"/>
+          </a:p>
+        </p:txBody>
+      </p:sp>
+      <p:sp>
+        <p:nvSpPr>
+          <p:cNvPr id="11" name="Shape 9"/>
+          <p:cNvSpPr/>
+          <p:nvPr/>
+        </p:nvSpPr>
+        <p:spPr>
+          <a:xfrm>
+            <a:off x="658368" y="2148840"/>
+            <a:ext cx="1600200" cy="0"/>
+          </a:xfrm>
+          <a:prstGeom prst="line">
+            <a:avLst/>
+          </a:prstGeom>
+          <a:noFill/>
+          <a:ln w="6350">
+            <a:solidFill>
+              <a:srgbClr val="E5E5E5"/>
+            </a:solidFill>
+            <a:prstDash val="solid"/>
+          </a:ln>
+        </p:spPr>
+      </p:sp>
+      <p:sp>
+        <p:nvSpPr>
+          <p:cNvPr id="12" name="Text 10"/>
+          <p:cNvSpPr/>
+          <p:nvPr/>
+        </p:nvSpPr>
+        <p:spPr>
+          <a:xfrm>
+            <a:off x="640080" y="2167128"/>
+            <a:ext cx="1783080" cy="292608"/>
+          </a:xfrm>
+          <a:prstGeom prst="rect">
+            <a:avLst/>
+          </a:prstGeom>
+          <a:noFill/>
+          <a:ln/>
+        </p:spPr>
+        <p:txBody>
+          <a:bodyPr wrap="square" lIns="0" tIns="0" rIns="0" bIns="0" rtlCol="0" anchor="t"/>
+          <a:lstStyle/>
+          <a:p>
+            <a:pPr indent="0" marL="0">
+              <a:buNone/>
+            </a:pPr>
+            <a:r>
+              <a:rPr lang="en-US" sz="850" dirty="0">
+                <a:solidFill>
+                  <a:srgbClr val="333333"/>
+                </a:solidFill>
+                <a:latin typeface="Arial" pitchFamily="34" charset="0"/>
+                <a:ea typeface="Arial" pitchFamily="34" charset="-122"/>
+                <a:cs typeface="Arial" pitchFamily="34" charset="-120"/>
+              </a:rPr>
+              <a:t>NVIDIA · Apple · AMD · Broadcom</a:t>
+            </a:r>
+            <a:endParaRPr lang="en-US" sz="850" dirty="0"/>
+          </a:p>
+        </p:txBody>
+      </p:sp>
+      <p:sp>
+        <p:nvSpPr>
+          <p:cNvPr id="13" name="Text 11"/>
+          <p:cNvSpPr/>
+          <p:nvPr/>
+        </p:nvSpPr>
+        <p:spPr>
+          <a:xfrm>
+            <a:off x="2359152" y="1897380"/>
+            <a:ext cx="219456" cy="365760"/>
+          </a:xfrm>
+          <a:prstGeom prst="rect">
+            <a:avLst/>
+          </a:prstGeom>
+          <a:noFill/>
+          <a:ln/>
+        </p:spPr>
+        <p:txBody>
+          <a:bodyPr wrap="square" lIns="0" tIns="0" rIns="0" bIns="0" rtlCol="0" anchor="ctr"/>
+          <a:lstStyle/>
+          <a:p>
+            <a:pPr algn="ctr" indent="0" marL="0">
+              <a:buNone/>
+            </a:pPr>
+            <a:r>
+              <a:rPr lang="en-US" sz="2400" b="1" dirty="0">
+                <a:solidFill>
+                  <a:srgbClr val="666666"/>
+                </a:solidFill>
+                <a:latin typeface="Arial" pitchFamily="34" charset="0"/>
+                <a:ea typeface="Arial" pitchFamily="34" charset="-122"/>
+                <a:cs typeface="Arial" pitchFamily="34" charset="-120"/>
+              </a:rPr>
+              <a:t>›</a:t>
+            </a:r>
+            <a:endParaRPr lang="en-US" sz="2400" dirty="0"/>
+          </a:p>
+        </p:txBody>
+      </p:sp>
+      <p:sp>
+        <p:nvSpPr>
+          <p:cNvPr id="14" name="Shape 12"/>
+          <p:cNvSpPr/>
+          <p:nvPr/>
+        </p:nvSpPr>
+        <p:spPr>
+          <a:xfrm>
+            <a:off x="2697480" y="1792224"/>
+            <a:ext cx="128016" cy="128016"/>
+          </a:xfrm>
+          <a:prstGeom prst="ellipse">
+            <a:avLst/>
+          </a:prstGeom>
+          <a:solidFill>
+            <a:srgbClr val="E8478D"/>
+          </a:solidFill>
+          <a:ln w="12700">
+            <a:solidFill>
+              <a:srgbClr val="E8478D"/>
+            </a:solidFill>
+            <a:prstDash val="solid"/>
+          </a:ln>
+        </p:spPr>
+      </p:sp>
+      <p:sp>
+        <p:nvSpPr>
+          <p:cNvPr id="15" name="Text 13"/>
+          <p:cNvSpPr/>
+          <p:nvPr/>
+        </p:nvSpPr>
+        <p:spPr>
+          <a:xfrm>
+            <a:off x="2880360" y="1709928"/>
+            <a:ext cx="1600200" cy="237744"/>
+          </a:xfrm>
+          <a:prstGeom prst="rect">
+            <a:avLst/>
+          </a:prstGeom>
+          <a:noFill/>
+          <a:ln/>
+        </p:spPr>
+        <p:txBody>
+          <a:bodyPr wrap="square" lIns="0" tIns="0" rIns="0" bIns="0" rtlCol="0" anchor="ctr"/>
+          <a:lstStyle/>
+          <a:p>
+            <a:pPr indent="0" marL="0">
+              <a:buNone/>
+            </a:pPr>
+            <a:r>
+              <a:rPr lang="en-US" sz="1100" b="1" spc="200" kern="0" dirty="0">
+                <a:solidFill>
+                  <a:srgbClr val="000000"/>
+                </a:solidFill>
+                <a:latin typeface="Arial" pitchFamily="34" charset="0"/>
+                <a:ea typeface="Arial" pitchFamily="34" charset="-122"/>
+                <a:cs typeface="Arial" pitchFamily="34" charset="-120"/>
+              </a:rPr>
+              <a:t>EQUIPMENT</a:t>
+            </a:r>
+            <a:endParaRPr lang="en-US" sz="1100" dirty="0"/>
+          </a:p>
+        </p:txBody>
+      </p:sp>
+      <p:sp>
+        <p:nvSpPr>
+          <p:cNvPr id="16" name="Text 14"/>
+          <p:cNvSpPr/>
+          <p:nvPr/>
+        </p:nvSpPr>
+        <p:spPr>
+          <a:xfrm>
+            <a:off x="2697480" y="1947672"/>
+            <a:ext cx="1783080" cy="182880"/>
+          </a:xfrm>
+          <a:prstGeom prst="rect">
+            <a:avLst/>
+          </a:prstGeom>
+          <a:noFill/>
+          <a:ln/>
+        </p:spPr>
+        <p:txBody>
+          <a:bodyPr wrap="square" lIns="0" tIns="0" rIns="0" bIns="0" rtlCol="0" anchor="ctr"/>
+          <a:lstStyle/>
+          <a:p>
+            <a:pPr indent="0" marL="0">
+              <a:buNone/>
+            </a:pPr>
+            <a:r>
+              <a:rPr lang="en-US" sz="950" i="1" dirty="0">
+                <a:solidFill>
+                  <a:srgbClr val="666666"/>
+                </a:solidFill>
+                <a:latin typeface="Arial" pitchFamily="34" charset="0"/>
+                <a:ea typeface="Arial" pitchFamily="34" charset="-122"/>
+                <a:cs typeface="Arial" pitchFamily="34" charset="-120"/>
+              </a:rPr>
+              <a:t>builds the tools</a:t>
+            </a:r>
+            <a:endParaRPr lang="en-US" sz="950" dirty="0"/>
+          </a:p>
+        </p:txBody>
+      </p:sp>
+      <p:sp>
+        <p:nvSpPr>
+          <p:cNvPr id="17" name="Shape 15"/>
+          <p:cNvSpPr/>
+          <p:nvPr/>
+        </p:nvSpPr>
+        <p:spPr>
+          <a:xfrm>
+            <a:off x="2715768" y="2148840"/>
+            <a:ext cx="1600200" cy="0"/>
+          </a:xfrm>
+          <a:prstGeom prst="line">
+            <a:avLst/>
+          </a:prstGeom>
+          <a:noFill/>
+          <a:ln w="6350">
+            <a:solidFill>
+              <a:srgbClr val="E5E5E5"/>
+            </a:solidFill>
+            <a:prstDash val="solid"/>
+          </a:ln>
+        </p:spPr>
+      </p:sp>
+      <p:sp>
+        <p:nvSpPr>
+          <p:cNvPr id="18" name="Text 16"/>
+          <p:cNvSpPr/>
+          <p:nvPr/>
+        </p:nvSpPr>
+        <p:spPr>
+          <a:xfrm>
+            <a:off x="2697480" y="2167128"/>
+            <a:ext cx="1783080" cy="292608"/>
+          </a:xfrm>
+          <a:prstGeom prst="rect">
+            <a:avLst/>
+          </a:prstGeom>
+          <a:noFill/>
+          <a:ln/>
+        </p:spPr>
+        <p:txBody>
+          <a:bodyPr wrap="square" lIns="0" tIns="0" rIns="0" bIns="0" rtlCol="0" anchor="t"/>
+          <a:lstStyle/>
+          <a:p>
+            <a:pPr indent="0" marL="0">
+              <a:buNone/>
+            </a:pPr>
+            <a:r>
+              <a:rPr lang="en-US" sz="850" dirty="0">
+                <a:solidFill>
+                  <a:srgbClr val="333333"/>
+                </a:solidFill>
+                <a:latin typeface="Arial" pitchFamily="34" charset="0"/>
+                <a:ea typeface="Arial" pitchFamily="34" charset="-122"/>
+                <a:cs typeface="Arial" pitchFamily="34" charset="-120"/>
+              </a:rPr>
+              <a:t>ASML · Applied Materials · Lam · KLA</a:t>
+            </a:r>
+            <a:endParaRPr lang="en-US" sz="850" dirty="0"/>
+          </a:p>
+        </p:txBody>
+      </p:sp>
+      <p:sp>
+        <p:nvSpPr>
+          <p:cNvPr id="19" name="Text 17"/>
+          <p:cNvSpPr/>
+          <p:nvPr/>
+        </p:nvSpPr>
+        <p:spPr>
+          <a:xfrm>
+            <a:off x="4416552" y="1897380"/>
+            <a:ext cx="219456" cy="365760"/>
+          </a:xfrm>
+          <a:prstGeom prst="rect">
+            <a:avLst/>
+          </a:prstGeom>
+          <a:noFill/>
+          <a:ln/>
+        </p:spPr>
+        <p:txBody>
+          <a:bodyPr wrap="square" lIns="0" tIns="0" rIns="0" bIns="0" rtlCol="0" anchor="ctr"/>
+          <a:lstStyle/>
+          <a:p>
+            <a:pPr algn="ctr" indent="0" marL="0">
+              <a:buNone/>
+            </a:pPr>
+            <a:r>
+              <a:rPr lang="en-US" sz="2400" b="1" dirty="0">
+                <a:solidFill>
+                  <a:srgbClr val="666666"/>
+                </a:solidFill>
+                <a:latin typeface="Arial" pitchFamily="34" charset="0"/>
+                <a:ea typeface="Arial" pitchFamily="34" charset="-122"/>
+                <a:cs typeface="Arial" pitchFamily="34" charset="-120"/>
+              </a:rPr>
+              <a:t>›</a:t>
+            </a:r>
+            <a:endParaRPr lang="en-US" sz="2400" dirty="0"/>
+          </a:p>
+        </p:txBody>
+      </p:sp>
+      <p:sp>
+        <p:nvSpPr>
+          <p:cNvPr id="20" name="Shape 18"/>
+          <p:cNvSpPr/>
+          <p:nvPr/>
+        </p:nvSpPr>
+        <p:spPr>
+          <a:xfrm>
+            <a:off x="4754880" y="1792224"/>
+            <a:ext cx="128016" cy="128016"/>
+          </a:xfrm>
+          <a:prstGeom prst="ellipse">
+            <a:avLst/>
+          </a:prstGeom>
+          <a:solidFill>
+            <a:srgbClr val="333333"/>
+          </a:solidFill>
+          <a:ln w="12700">
+            <a:solidFill>
+              <a:srgbClr val="333333"/>
+            </a:solidFill>
+            <a:prstDash val="solid"/>
+          </a:ln>
+        </p:spPr>
+      </p:sp>
+      <p:sp>
+        <p:nvSpPr>
+          <p:cNvPr id="21" name="Text 19"/>
+          <p:cNvSpPr/>
+          <p:nvPr/>
+        </p:nvSpPr>
+        <p:spPr>
+          <a:xfrm>
+            <a:off x="4937760" y="1709928"/>
+            <a:ext cx="1600200" cy="237744"/>
+          </a:xfrm>
+          <a:prstGeom prst="rect">
+            <a:avLst/>
+          </a:prstGeom>
+          <a:noFill/>
+          <a:ln/>
+        </p:spPr>
+        <p:txBody>
+          <a:bodyPr wrap="square" lIns="0" tIns="0" rIns="0" bIns="0" rtlCol="0" anchor="ctr"/>
+          <a:lstStyle/>
+          <a:p>
+            <a:pPr indent="0" marL="0">
+              <a:buNone/>
+            </a:pPr>
+            <a:r>
+              <a:rPr lang="en-US" sz="1100" b="1" spc="200" kern="0" dirty="0">
+                <a:solidFill>
+                  <a:srgbClr val="000000"/>
+                </a:solidFill>
+                <a:latin typeface="Arial" pitchFamily="34" charset="0"/>
+                <a:ea typeface="Arial" pitchFamily="34" charset="-122"/>
+                <a:cs typeface="Arial" pitchFamily="34" charset="-120"/>
+              </a:rPr>
+              <a:t>FOUNDRY</a:t>
+            </a:r>
+            <a:endParaRPr lang="en-US" sz="1100" dirty="0"/>
+          </a:p>
+        </p:txBody>
+      </p:sp>
+      <p:sp>
+        <p:nvSpPr>
+          <p:cNvPr id="22" name="Text 20"/>
+          <p:cNvSpPr/>
+          <p:nvPr/>
+        </p:nvSpPr>
+        <p:spPr>
+          <a:xfrm>
+            <a:off x="4754880" y="1947672"/>
+            <a:ext cx="1783080" cy="182880"/>
+          </a:xfrm>
+          <a:prstGeom prst="rect">
+            <a:avLst/>
+          </a:prstGeom>
+          <a:noFill/>
+          <a:ln/>
+        </p:spPr>
+        <p:txBody>
+          <a:bodyPr wrap="square" lIns="0" tIns="0" rIns="0" bIns="0" rtlCol="0" anchor="ctr"/>
+          <a:lstStyle/>
+          <a:p>
+            <a:pPr indent="0" marL="0">
+              <a:buNone/>
+            </a:pPr>
+            <a:r>
+              <a:rPr lang="en-US" sz="950" i="1" dirty="0">
+                <a:solidFill>
+                  <a:srgbClr val="666666"/>
+                </a:solidFill>
+                <a:latin typeface="Arial" pitchFamily="34" charset="0"/>
+                <a:ea typeface="Arial" pitchFamily="34" charset="-122"/>
+                <a:cs typeface="Arial" pitchFamily="34" charset="-120"/>
+              </a:rPr>
+              <a:t>prints the wafer</a:t>
+            </a:r>
+            <a:endParaRPr lang="en-US" sz="950" dirty="0"/>
+          </a:p>
+        </p:txBody>
+      </p:sp>
+      <p:sp>
+        <p:nvSpPr>
+          <p:cNvPr id="23" name="Shape 21"/>
+          <p:cNvSpPr/>
+          <p:nvPr/>
+        </p:nvSpPr>
+        <p:spPr>
+          <a:xfrm>
+            <a:off x="4773168" y="2148840"/>
+            <a:ext cx="1600200" cy="0"/>
+          </a:xfrm>
+          <a:prstGeom prst="line">
+            <a:avLst/>
+          </a:prstGeom>
+          <a:noFill/>
+          <a:ln w="6350">
+            <a:solidFill>
+              <a:srgbClr val="E5E5E5"/>
+            </a:solidFill>
+            <a:prstDash val="solid"/>
+          </a:ln>
+        </p:spPr>
+      </p:sp>
+      <p:sp>
+        <p:nvSpPr>
+          <p:cNvPr id="24" name="Text 22"/>
+          <p:cNvSpPr/>
+          <p:nvPr/>
+        </p:nvSpPr>
+        <p:spPr>
+          <a:xfrm>
+            <a:off x="4754880" y="2167128"/>
+            <a:ext cx="1783080" cy="292608"/>
+          </a:xfrm>
+          <a:prstGeom prst="rect">
+            <a:avLst/>
+          </a:prstGeom>
+          <a:noFill/>
+          <a:ln/>
+        </p:spPr>
+        <p:txBody>
+          <a:bodyPr wrap="square" lIns="0" tIns="0" rIns="0" bIns="0" rtlCol="0" anchor="t"/>
+          <a:lstStyle/>
+          <a:p>
+            <a:pPr indent="0" marL="0">
+              <a:buNone/>
+            </a:pPr>
+            <a:r>
+              <a:rPr lang="en-US" sz="850" dirty="0">
+                <a:solidFill>
+                  <a:srgbClr val="333333"/>
+                </a:solidFill>
+                <a:latin typeface="Arial" pitchFamily="34" charset="0"/>
+                <a:ea typeface="Arial" pitchFamily="34" charset="-122"/>
+                <a:cs typeface="Arial" pitchFamily="34" charset="-120"/>
+              </a:rPr>
+              <a:t>TSMC · Samsung · Intel Foundry</a:t>
+            </a:r>
+            <a:endParaRPr lang="en-US" sz="850" dirty="0"/>
+          </a:p>
+        </p:txBody>
+      </p:sp>
+      <p:sp>
+        <p:nvSpPr>
+          <p:cNvPr id="25" name="Text 23"/>
+          <p:cNvSpPr/>
+          <p:nvPr/>
+        </p:nvSpPr>
+        <p:spPr>
+          <a:xfrm>
+            <a:off x="6473952" y="1897380"/>
+            <a:ext cx="219456" cy="365760"/>
+          </a:xfrm>
+          <a:prstGeom prst="rect">
+            <a:avLst/>
+          </a:prstGeom>
+          <a:noFill/>
+          <a:ln/>
+        </p:spPr>
+        <p:txBody>
+          <a:bodyPr wrap="square" lIns="0" tIns="0" rIns="0" bIns="0" rtlCol="0" anchor="ctr"/>
+          <a:lstStyle/>
+          <a:p>
+            <a:pPr algn="ctr" indent="0" marL="0">
+              <a:buNone/>
+            </a:pPr>
+            <a:r>
+              <a:rPr lang="en-US" sz="2400" b="1" dirty="0">
+                <a:solidFill>
+                  <a:srgbClr val="666666"/>
+                </a:solidFill>
+                <a:latin typeface="Arial" pitchFamily="34" charset="0"/>
+                <a:ea typeface="Arial" pitchFamily="34" charset="-122"/>
+                <a:cs typeface="Arial" pitchFamily="34" charset="-120"/>
+              </a:rPr>
+              <a:t>›</a:t>
+            </a:r>
+            <a:endParaRPr lang="en-US" sz="2400" dirty="0"/>
+          </a:p>
+        </p:txBody>
+      </p:sp>
+      <p:sp>
+        <p:nvSpPr>
+          <p:cNvPr id="26" name="Shape 24"/>
+          <p:cNvSpPr/>
+          <p:nvPr/>
+        </p:nvSpPr>
+        <p:spPr>
+          <a:xfrm>
+            <a:off x="6812280" y="1792224"/>
+            <a:ext cx="128016" cy="128016"/>
+          </a:xfrm>
+          <a:prstGeom prst="ellipse">
+            <a:avLst/>
+          </a:prstGeom>
+          <a:solidFill>
+            <a:srgbClr val="000000"/>
+          </a:solidFill>
+          <a:ln w="12700">
+            <a:solidFill>
+              <a:srgbClr val="000000"/>
+            </a:solidFill>
+            <a:prstDash val="solid"/>
+          </a:ln>
+        </p:spPr>
+      </p:sp>
+      <p:sp>
+        <p:nvSpPr>
+          <p:cNvPr id="27" name="Text 25"/>
+          <p:cNvSpPr/>
+          <p:nvPr/>
+        </p:nvSpPr>
+        <p:spPr>
+          <a:xfrm>
+            <a:off x="6995160" y="1709928"/>
+            <a:ext cx="1600200" cy="237744"/>
+          </a:xfrm>
+          <a:prstGeom prst="rect">
+            <a:avLst/>
+          </a:prstGeom>
+          <a:noFill/>
+          <a:ln/>
+        </p:spPr>
+        <p:txBody>
+          <a:bodyPr wrap="square" lIns="0" tIns="0" rIns="0" bIns="0" rtlCol="0" anchor="ctr"/>
+          <a:lstStyle/>
+          <a:p>
+            <a:pPr indent="0" marL="0">
+              <a:buNone/>
+            </a:pPr>
+            <a:r>
+              <a:rPr lang="en-US" sz="1100" b="1" spc="200" kern="0" dirty="0">
+                <a:solidFill>
+                  <a:srgbClr val="000000"/>
+                </a:solidFill>
+                <a:latin typeface="Arial" pitchFamily="34" charset="0"/>
+                <a:ea typeface="Arial" pitchFamily="34" charset="-122"/>
+                <a:cs typeface="Arial" pitchFamily="34" charset="-120"/>
+              </a:rPr>
+              <a:t>PACKAGING</a:t>
+            </a:r>
+            <a:endParaRPr lang="en-US" sz="1100" dirty="0"/>
+          </a:p>
+        </p:txBody>
+      </p:sp>
+      <p:sp>
+        <p:nvSpPr>
+          <p:cNvPr id="28" name="Text 26"/>
+          <p:cNvSpPr/>
+          <p:nvPr/>
+        </p:nvSpPr>
+        <p:spPr>
+          <a:xfrm>
+            <a:off x="6812280" y="1947672"/>
+            <a:ext cx="1783080" cy="182880"/>
+          </a:xfrm>
+          <a:prstGeom prst="rect">
+            <a:avLst/>
+          </a:prstGeom>
+          <a:noFill/>
+          <a:ln/>
+        </p:spPr>
+        <p:txBody>
+          <a:bodyPr wrap="square" lIns="0" tIns="0" rIns="0" bIns="0" rtlCol="0" anchor="ctr"/>
+          <a:lstStyle/>
+          <a:p>
+            <a:pPr indent="0" marL="0">
+              <a:buNone/>
+            </a:pPr>
+            <a:r>
+              <a:rPr lang="en-US" sz="950" i="1" dirty="0">
+                <a:solidFill>
+                  <a:srgbClr val="666666"/>
+                </a:solidFill>
+                <a:latin typeface="Arial" pitchFamily="34" charset="0"/>
+                <a:ea typeface="Arial" pitchFamily="34" charset="-122"/>
+                <a:cs typeface="Arial" pitchFamily="34" charset="-120"/>
+              </a:rPr>
+              <a:t>stacks the dies</a:t>
+            </a:r>
+            <a:endParaRPr lang="en-US" sz="950" dirty="0"/>
+          </a:p>
+        </p:txBody>
+      </p:sp>
+      <p:sp>
+        <p:nvSpPr>
+          <p:cNvPr id="29" name="Shape 27"/>
+          <p:cNvSpPr/>
+          <p:nvPr/>
+        </p:nvSpPr>
+        <p:spPr>
+          <a:xfrm>
+            <a:off x="6830568" y="2148840"/>
+            <a:ext cx="1600200" cy="0"/>
+          </a:xfrm>
+          <a:prstGeom prst="line">
+            <a:avLst/>
+          </a:prstGeom>
+          <a:noFill/>
+          <a:ln w="6350">
+            <a:solidFill>
+              <a:srgbClr val="E5E5E5"/>
+            </a:solidFill>
+            <a:prstDash val="solid"/>
+          </a:ln>
+        </p:spPr>
+      </p:sp>
+      <p:sp>
+        <p:nvSpPr>
+          <p:cNvPr id="30" name="Text 28"/>
+          <p:cNvSpPr/>
+          <p:nvPr/>
+        </p:nvSpPr>
+        <p:spPr>
+          <a:xfrm>
+            <a:off x="6812280" y="2167128"/>
+            <a:ext cx="1783080" cy="292608"/>
+          </a:xfrm>
+          <a:prstGeom prst="rect">
+            <a:avLst/>
+          </a:prstGeom>
+          <a:noFill/>
+          <a:ln/>
+        </p:spPr>
+        <p:txBody>
+          <a:bodyPr wrap="square" lIns="0" tIns="0" rIns="0" bIns="0" rtlCol="0" anchor="t"/>
+          <a:lstStyle/>
+          <a:p>
+            <a:pPr indent="0" marL="0">
+              <a:buNone/>
+            </a:pPr>
+            <a:r>
+              <a:rPr lang="en-US" sz="850" dirty="0">
+                <a:solidFill>
+                  <a:srgbClr val="333333"/>
+                </a:solidFill>
+                <a:latin typeface="Arial" pitchFamily="34" charset="0"/>
+                <a:ea typeface="Arial" pitchFamily="34" charset="-122"/>
+                <a:cs typeface="Arial" pitchFamily="34" charset="-120"/>
+              </a:rPr>
+              <a:t>TSMC CoWoS · ASE · Amkor</a:t>
+            </a:r>
+            <a:endParaRPr lang="en-US" sz="850" dirty="0"/>
+          </a:p>
+        </p:txBody>
+      </p:sp>
+      <p:sp>
+        <p:nvSpPr>
+          <p:cNvPr id="31" name="Shape 29"/>
+          <p:cNvSpPr/>
+          <p:nvPr/>
+        </p:nvSpPr>
+        <p:spPr>
+          <a:xfrm>
+            <a:off x="457200" y="2606040"/>
+            <a:ext cx="2651760" cy="1280160"/>
+          </a:xfrm>
+          <a:prstGeom prst="rect">
+            <a:avLst/>
+          </a:prstGeom>
+          <a:solidFill>
+            <a:srgbClr val="F9F9F9"/>
+          </a:solidFill>
+          <a:ln w="6350">
+            <a:solidFill>
+              <a:srgbClr val="E5E5E5"/>
+            </a:solidFill>
+            <a:prstDash val="solid"/>
+          </a:ln>
+        </p:spPr>
+      </p:sp>
+      <p:sp>
+        <p:nvSpPr>
+          <p:cNvPr id="32" name="Shape 30"/>
+          <p:cNvSpPr/>
+          <p:nvPr/>
+        </p:nvSpPr>
+        <p:spPr>
+          <a:xfrm>
+            <a:off x="457200" y="2606040"/>
+            <a:ext cx="2651760" cy="256032"/>
+          </a:xfrm>
+          <a:prstGeom prst="rect">
             <a:avLst/>
           </a:prstGeom>
           <a:solidFill>
@@ -33252,14 +34054,14 @@
       </p:sp>
       <p:sp>
         <p:nvSpPr>
-          <p:cNvPr id="9" name="Text 7"/>
-          <p:cNvSpPr/>
-          <p:nvPr/>
-        </p:nvSpPr>
-        <p:spPr>
-          <a:xfrm>
-            <a:off x="859536" y="1691640"/>
-            <a:ext cx="1600200" cy="457200"/>
+          <p:cNvPr id="33" name="Text 31"/>
+          <p:cNvSpPr/>
+          <p:nvPr/>
+        </p:nvSpPr>
+        <p:spPr>
+          <a:xfrm>
+            <a:off x="457200" y="2606040"/>
+            <a:ext cx="2651760" cy="256032"/>
           </a:xfrm>
           <a:prstGeom prst="rect">
             <a:avLst/>
@@ -33271,25 +34073,89 @@
           <a:bodyPr wrap="square" lIns="0" tIns="0" rIns="0" bIns="0" rtlCol="0" anchor="ctr"/>
           <a:lstStyle/>
           <a:p>
-            <a:pPr indent="0" marL="0">
-              <a:buNone/>
-            </a:pPr>
-            <a:r>
-              <a:rPr lang="en-US" sz="1050" b="1" spc="200" kern="0" dirty="0">
-                <a:solidFill>
-                  <a:srgbClr val="000000"/>
-                </a:solidFill>
-                <a:latin typeface="Arial" pitchFamily="34" charset="0"/>
-                <a:ea typeface="Arial" pitchFamily="34" charset="-122"/>
-                <a:cs typeface="Arial" pitchFamily="34" charset="-120"/>
-              </a:rPr>
-              <a:t>LOGIC  </a:t>
-            </a:r>
-            <a:pPr indent="0" marL="0">
-              <a:buNone/>
-            </a:pPr>
-            <a:r>
-              <a:rPr lang="en-US" sz="1050" i="1" dirty="0">
+            <a:pPr algn="ctr" indent="0" marL="0">
+              <a:buNone/>
+            </a:pPr>
+            <a:r>
+              <a:rPr lang="en-US" sz="1000" b="1" spc="200" kern="0" dirty="0">
+                <a:solidFill>
+                  <a:srgbClr val="FFFFFF"/>
+                </a:solidFill>
+                <a:latin typeface="Arial" pitchFamily="34" charset="0"/>
+                <a:ea typeface="Arial" pitchFamily="34" charset="-122"/>
+                <a:cs typeface="Arial" pitchFamily="34" charset="-120"/>
+              </a:rPr>
+              <a:t>LOGIC</a:t>
+            </a:r>
+            <a:endParaRPr lang="en-US" sz="1000" dirty="0"/>
+          </a:p>
+        </p:txBody>
+      </p:sp>
+      <p:sp>
+        <p:nvSpPr>
+          <p:cNvPr id="34" name="Text 32"/>
+          <p:cNvSpPr/>
+          <p:nvPr/>
+        </p:nvSpPr>
+        <p:spPr>
+          <a:xfrm>
+            <a:off x="594360" y="2916936"/>
+            <a:ext cx="2377440" cy="457200"/>
+          </a:xfrm>
+          <a:prstGeom prst="rect">
+            <a:avLst/>
+          </a:prstGeom>
+          <a:noFill/>
+          <a:ln/>
+        </p:spPr>
+        <p:txBody>
+          <a:bodyPr wrap="square" lIns="0" tIns="0" rIns="0" bIns="0" rtlCol="0" anchor="t"/>
+          <a:lstStyle/>
+          <a:p>
+            <a:pPr indent="0" marL="0">
+              <a:buNone/>
+            </a:pPr>
+            <a:r>
+              <a:rPr lang="en-US" sz="950" dirty="0">
+                <a:solidFill>
+                  <a:srgbClr val="333333"/>
+                </a:solidFill>
+                <a:latin typeface="Arial" pitchFamily="34" charset="0"/>
+                <a:ea typeface="Arial" pitchFamily="34" charset="-122"/>
+                <a:cs typeface="Arial" pitchFamily="34" charset="-120"/>
+              </a:rPr>
+              <a:t>Where computation happens — the chips that run code and move data.</a:t>
+            </a:r>
+            <a:endParaRPr lang="en-US" sz="950" dirty="0"/>
+          </a:p>
+        </p:txBody>
+      </p:sp>
+      <p:sp>
+        <p:nvSpPr>
+          <p:cNvPr id="35" name="Text 33"/>
+          <p:cNvSpPr/>
+          <p:nvPr/>
+        </p:nvSpPr>
+        <p:spPr>
+          <a:xfrm>
+            <a:off x="594360" y="3392424"/>
+            <a:ext cx="2377440" cy="237744"/>
+          </a:xfrm>
+          <a:prstGeom prst="rect">
+            <a:avLst/>
+          </a:prstGeom>
+          <a:noFill/>
+          <a:ln/>
+        </p:spPr>
+        <p:txBody>
+          <a:bodyPr wrap="square" lIns="0" tIns="0" rIns="0" bIns="0" rtlCol="0" anchor="t"/>
+          <a:lstStyle/>
+          <a:p>
+            <a:pPr indent="0" marL="0">
+              <a:buNone/>
+            </a:pPr>
+            <a:r>
+              <a:rPr lang="en-US" sz="850" i="1" dirty="0">
                 <a:solidFill>
                   <a:srgbClr val="666666"/>
                 </a:solidFill>
@@ -33297,22 +34163,22 @@
                 <a:ea typeface="Arial" pitchFamily="34" charset="-122"/>
                 <a:cs typeface="Arial" pitchFamily="34" charset="-120"/>
               </a:rPr>
-              <a:t>computes</a:t>
-            </a:r>
-            <a:endParaRPr lang="en-US" sz="1050" dirty="0"/>
-          </a:p>
-        </p:txBody>
-      </p:sp>
-      <p:sp>
-        <p:nvSpPr>
-          <p:cNvPr id="10" name="Shape 8"/>
-          <p:cNvSpPr/>
-          <p:nvPr/>
-        </p:nvSpPr>
-        <p:spPr>
-          <a:xfrm>
-            <a:off x="2514600" y="1764792"/>
-            <a:ext cx="0" cy="310896"/>
+              <a:t>GPUs, AI accelerators, ASICs, FPGAs</a:t>
+            </a:r>
+            <a:endParaRPr lang="en-US" sz="850" dirty="0"/>
+          </a:p>
+        </p:txBody>
+      </p:sp>
+      <p:sp>
+        <p:nvSpPr>
+          <p:cNvPr id="36" name="Shape 34"/>
+          <p:cNvSpPr/>
+          <p:nvPr/>
+        </p:nvSpPr>
+        <p:spPr>
+          <a:xfrm>
+            <a:off x="640080" y="3648456"/>
+            <a:ext cx="2286000" cy="0"/>
           </a:xfrm>
           <a:prstGeom prst="line">
             <a:avLst/>
@@ -33328,16 +34194,80 @@
       </p:sp>
       <p:sp>
         <p:nvSpPr>
-          <p:cNvPr id="11" name="Shape 9"/>
-          <p:cNvSpPr/>
-          <p:nvPr/>
-        </p:nvSpPr>
-        <p:spPr>
-          <a:xfrm>
-            <a:off x="2715768" y="1847088"/>
-            <a:ext cx="146304" cy="146304"/>
-          </a:xfrm>
-          <a:prstGeom prst="ellipse">
+          <p:cNvPr id="37" name="Text 35"/>
+          <p:cNvSpPr/>
+          <p:nvPr/>
+        </p:nvSpPr>
+        <p:spPr>
+          <a:xfrm>
+            <a:off x="457200" y="3666744"/>
+            <a:ext cx="2651760" cy="201168"/>
+          </a:xfrm>
+          <a:prstGeom prst="rect">
+            <a:avLst/>
+          </a:prstGeom>
+          <a:noFill/>
+          <a:ln/>
+        </p:spPr>
+        <p:txBody>
+          <a:bodyPr wrap="square" lIns="0" tIns="0" rIns="0" bIns="0" rtlCol="0" anchor="ctr"/>
+          <a:lstStyle/>
+          <a:p>
+            <a:pPr algn="ctr" indent="0" marL="0">
+              <a:buNone/>
+            </a:pPr>
+            <a:r>
+              <a:rPr lang="en-US" sz="750" i="1" dirty="0">
+                <a:solidFill>
+                  <a:srgbClr val="666666"/>
+                </a:solidFill>
+                <a:latin typeface="Arial" pitchFamily="34" charset="0"/>
+                <a:ea typeface="Arial" pitchFamily="34" charset="-122"/>
+                <a:cs typeface="Arial" pitchFamily="34" charset="-120"/>
+              </a:rPr>
+              <a:t>NVIDIA · AMD · Broadcom · TSMC</a:t>
+            </a:r>
+            <a:endParaRPr lang="en-US" sz="750" dirty="0"/>
+          </a:p>
+        </p:txBody>
+      </p:sp>
+      <p:sp>
+        <p:nvSpPr>
+          <p:cNvPr id="38" name="Shape 36"/>
+          <p:cNvSpPr/>
+          <p:nvPr/>
+        </p:nvSpPr>
+        <p:spPr>
+          <a:xfrm>
+            <a:off x="3246120" y="2606040"/>
+            <a:ext cx="2651760" cy="1280160"/>
+          </a:xfrm>
+          <a:prstGeom prst="rect">
+            <a:avLst/>
+          </a:prstGeom>
+          <a:solidFill>
+            <a:srgbClr val="F9F9F9"/>
+          </a:solidFill>
+          <a:ln w="6350">
+            <a:solidFill>
+              <a:srgbClr val="E5E5E5"/>
+            </a:solidFill>
+            <a:prstDash val="solid"/>
+          </a:ln>
+        </p:spPr>
+      </p:sp>
+      <p:sp>
+        <p:nvSpPr>
+          <p:cNvPr id="39" name="Shape 37"/>
+          <p:cNvSpPr/>
+          <p:nvPr/>
+        </p:nvSpPr>
+        <p:spPr>
+          <a:xfrm>
+            <a:off x="3246120" y="2606040"/>
+            <a:ext cx="2651760" cy="256032"/>
+          </a:xfrm>
+          <a:prstGeom prst="rect">
             <a:avLst/>
           </a:prstGeom>
           <a:solidFill>
@@ -33353,14 +34283,14 @@
       </p:sp>
       <p:sp>
         <p:nvSpPr>
-          <p:cNvPr id="12" name="Text 10"/>
-          <p:cNvSpPr/>
-          <p:nvPr/>
-        </p:nvSpPr>
-        <p:spPr>
-          <a:xfrm>
-            <a:off x="2916936" y="1691640"/>
-            <a:ext cx="1600200" cy="457200"/>
+          <p:cNvPr id="40" name="Text 38"/>
+          <p:cNvSpPr/>
+          <p:nvPr/>
+        </p:nvSpPr>
+        <p:spPr>
+          <a:xfrm>
+            <a:off x="3246120" y="2606040"/>
+            <a:ext cx="2651760" cy="256032"/>
           </a:xfrm>
           <a:prstGeom prst="rect">
             <a:avLst/>
@@ -33372,11 +34302,11 @@
           <a:bodyPr wrap="square" lIns="0" tIns="0" rIns="0" bIns="0" rtlCol="0" anchor="ctr"/>
           <a:lstStyle/>
           <a:p>
-            <a:pPr indent="0" marL="0">
-              <a:buNone/>
-            </a:pPr>
-            <a:r>
-              <a:rPr lang="en-US" sz="1050" b="1" spc="200" kern="0" dirty="0">
+            <a:pPr algn="ctr" indent="0" marL="0">
+              <a:buNone/>
+            </a:pPr>
+            <a:r>
+              <a:rPr lang="en-US" sz="1000" b="1" spc="200" kern="0" dirty="0">
                 <a:solidFill>
                   <a:srgbClr val="000000"/>
                 </a:solidFill>
@@ -33384,13 +34314,77 @@
                 <a:ea typeface="Arial" pitchFamily="34" charset="-122"/>
                 <a:cs typeface="Arial" pitchFamily="34" charset="-120"/>
               </a:rPr>
-              <a:t>MEMORY  </a:t>
-            </a:r>
-            <a:pPr indent="0" marL="0">
-              <a:buNone/>
-            </a:pPr>
-            <a:r>
-              <a:rPr lang="en-US" sz="1050" i="1" dirty="0">
+              <a:t>MEMORY</a:t>
+            </a:r>
+            <a:endParaRPr lang="en-US" sz="1000" dirty="0"/>
+          </a:p>
+        </p:txBody>
+      </p:sp>
+      <p:sp>
+        <p:nvSpPr>
+          <p:cNvPr id="41" name="Text 39"/>
+          <p:cNvSpPr/>
+          <p:nvPr/>
+        </p:nvSpPr>
+        <p:spPr>
+          <a:xfrm>
+            <a:off x="3383280" y="2916936"/>
+            <a:ext cx="2377440" cy="457200"/>
+          </a:xfrm>
+          <a:prstGeom prst="rect">
+            <a:avLst/>
+          </a:prstGeom>
+          <a:noFill/>
+          <a:ln/>
+        </p:spPr>
+        <p:txBody>
+          <a:bodyPr wrap="square" lIns="0" tIns="0" rIns="0" bIns="0" rtlCol="0" anchor="t"/>
+          <a:lstStyle/>
+          <a:p>
+            <a:pPr indent="0" marL="0">
+              <a:buNone/>
+            </a:pPr>
+            <a:r>
+              <a:rPr lang="en-US" sz="950" dirty="0">
+                <a:solidFill>
+                  <a:srgbClr val="333333"/>
+                </a:solidFill>
+                <a:latin typeface="Arial" pitchFamily="34" charset="0"/>
+                <a:ea typeface="Arial" pitchFamily="34" charset="-122"/>
+                <a:cs typeface="Arial" pitchFamily="34" charset="-120"/>
+              </a:rPr>
+              <a:t>Stores data so logic can read it at terabit speeds.</a:t>
+            </a:r>
+            <a:endParaRPr lang="en-US" sz="950" dirty="0"/>
+          </a:p>
+        </p:txBody>
+      </p:sp>
+      <p:sp>
+        <p:nvSpPr>
+          <p:cNvPr id="42" name="Text 40"/>
+          <p:cNvSpPr/>
+          <p:nvPr/>
+        </p:nvSpPr>
+        <p:spPr>
+          <a:xfrm>
+            <a:off x="3383280" y="3392424"/>
+            <a:ext cx="2377440" cy="237744"/>
+          </a:xfrm>
+          <a:prstGeom prst="rect">
+            <a:avLst/>
+          </a:prstGeom>
+          <a:noFill/>
+          <a:ln/>
+        </p:spPr>
+        <p:txBody>
+          <a:bodyPr wrap="square" lIns="0" tIns="0" rIns="0" bIns="0" rtlCol="0" anchor="t"/>
+          <a:lstStyle/>
+          <a:p>
+            <a:pPr indent="0" marL="0">
+              <a:buNone/>
+            </a:pPr>
+            <a:r>
+              <a:rPr lang="en-US" sz="850" i="1" dirty="0">
                 <a:solidFill>
                   <a:srgbClr val="666666"/>
                 </a:solidFill>
@@ -33398,22 +34392,22 @@
                 <a:ea typeface="Arial" pitchFamily="34" charset="-122"/>
                 <a:cs typeface="Arial" pitchFamily="34" charset="-120"/>
               </a:rPr>
-              <a:t>stores</a:t>
-            </a:r>
-            <a:endParaRPr lang="en-US" sz="1050" dirty="0"/>
-          </a:p>
-        </p:txBody>
-      </p:sp>
-      <p:sp>
-        <p:nvSpPr>
-          <p:cNvPr id="13" name="Shape 11"/>
-          <p:cNvSpPr/>
-          <p:nvPr/>
-        </p:nvSpPr>
-        <p:spPr>
-          <a:xfrm>
-            <a:off x="4572000" y="1764792"/>
-            <a:ext cx="0" cy="310896"/>
+              <a:t>DRAM, HBM, NAND — every AI server</a:t>
+            </a:r>
+            <a:endParaRPr lang="en-US" sz="850" dirty="0"/>
+          </a:p>
+        </p:txBody>
+      </p:sp>
+      <p:sp>
+        <p:nvSpPr>
+          <p:cNvPr id="43" name="Shape 41"/>
+          <p:cNvSpPr/>
+          <p:nvPr/>
+        </p:nvSpPr>
+        <p:spPr>
+          <a:xfrm>
+            <a:off x="3429000" y="3648456"/>
+            <a:ext cx="2286000" cy="0"/>
           </a:xfrm>
           <a:prstGeom prst="line">
             <a:avLst/>
@@ -33429,16 +34423,309 @@
       </p:sp>
       <p:sp>
         <p:nvSpPr>
-          <p:cNvPr id="14" name="Shape 12"/>
-          <p:cNvSpPr/>
-          <p:nvPr/>
-        </p:nvSpPr>
-        <p:spPr>
-          <a:xfrm>
-            <a:off x="4773168" y="1847088"/>
-            <a:ext cx="146304" cy="146304"/>
-          </a:xfrm>
-          <a:prstGeom prst="ellipse">
+          <p:cNvPr id="44" name="Text 42"/>
+          <p:cNvSpPr/>
+          <p:nvPr/>
+        </p:nvSpPr>
+        <p:spPr>
+          <a:xfrm>
+            <a:off x="3246120" y="3666744"/>
+            <a:ext cx="2651760" cy="201168"/>
+          </a:xfrm>
+          <a:prstGeom prst="rect">
+            <a:avLst/>
+          </a:prstGeom>
+          <a:noFill/>
+          <a:ln/>
+        </p:spPr>
+        <p:txBody>
+          <a:bodyPr wrap="square" lIns="0" tIns="0" rIns="0" bIns="0" rtlCol="0" anchor="ctr"/>
+          <a:lstStyle/>
+          <a:p>
+            <a:pPr algn="ctr" indent="0" marL="0">
+              <a:buNone/>
+            </a:pPr>
+            <a:r>
+              <a:rPr lang="en-US" sz="750" i="1" dirty="0">
+                <a:solidFill>
+                  <a:srgbClr val="666666"/>
+                </a:solidFill>
+                <a:latin typeface="Arial" pitchFamily="34" charset="0"/>
+                <a:ea typeface="Arial" pitchFamily="34" charset="-122"/>
+                <a:cs typeface="Arial" pitchFamily="34" charset="-120"/>
+              </a:rPr>
+              <a:t>SK Hynix · Samsung · Micron</a:t>
+            </a:r>
+            <a:endParaRPr lang="en-US" sz="750" dirty="0"/>
+          </a:p>
+        </p:txBody>
+      </p:sp>
+      <p:sp>
+        <p:nvSpPr>
+          <p:cNvPr id="45" name="Shape 43"/>
+          <p:cNvSpPr/>
+          <p:nvPr/>
+        </p:nvSpPr>
+        <p:spPr>
+          <a:xfrm>
+            <a:off x="6035040" y="2606040"/>
+            <a:ext cx="2651760" cy="1280160"/>
+          </a:xfrm>
+          <a:prstGeom prst="rect">
+            <a:avLst/>
+          </a:prstGeom>
+          <a:solidFill>
+            <a:srgbClr val="F9F9F9"/>
+          </a:solidFill>
+          <a:ln w="6350">
+            <a:solidFill>
+              <a:srgbClr val="E5E5E5"/>
+            </a:solidFill>
+            <a:prstDash val="solid"/>
+          </a:ln>
+        </p:spPr>
+      </p:sp>
+      <p:sp>
+        <p:nvSpPr>
+          <p:cNvPr id="46" name="Shape 44"/>
+          <p:cNvSpPr/>
+          <p:nvPr/>
+        </p:nvSpPr>
+        <p:spPr>
+          <a:xfrm>
+            <a:off x="6035040" y="2606040"/>
+            <a:ext cx="2651760" cy="256032"/>
+          </a:xfrm>
+          <a:prstGeom prst="rect">
+            <a:avLst/>
+          </a:prstGeom>
+          <a:solidFill>
+            <a:srgbClr val="008B8B"/>
+          </a:solidFill>
+          <a:ln w="12700">
+            <a:solidFill>
+              <a:srgbClr val="008B8B"/>
+            </a:solidFill>
+            <a:prstDash val="solid"/>
+          </a:ln>
+        </p:spPr>
+      </p:sp>
+      <p:sp>
+        <p:nvSpPr>
+          <p:cNvPr id="47" name="Text 45"/>
+          <p:cNvSpPr/>
+          <p:nvPr/>
+        </p:nvSpPr>
+        <p:spPr>
+          <a:xfrm>
+            <a:off x="6035040" y="2606040"/>
+            <a:ext cx="2651760" cy="256032"/>
+          </a:xfrm>
+          <a:prstGeom prst="rect">
+            <a:avLst/>
+          </a:prstGeom>
+          <a:noFill/>
+          <a:ln/>
+        </p:spPr>
+        <p:txBody>
+          <a:bodyPr wrap="square" lIns="0" tIns="0" rIns="0" bIns="0" rtlCol="0" anchor="ctr"/>
+          <a:lstStyle/>
+          <a:p>
+            <a:pPr algn="ctr" indent="0" marL="0">
+              <a:buNone/>
+            </a:pPr>
+            <a:r>
+              <a:rPr lang="en-US" sz="1000" b="1" spc="200" kern="0" dirty="0">
+                <a:solidFill>
+                  <a:srgbClr val="FFFFFF"/>
+                </a:solidFill>
+                <a:latin typeface="Arial" pitchFamily="34" charset="0"/>
+                <a:ea typeface="Arial" pitchFamily="34" charset="-122"/>
+                <a:cs typeface="Arial" pitchFamily="34" charset="-120"/>
+              </a:rPr>
+              <a:t>PROCESSORS</a:t>
+            </a:r>
+            <a:endParaRPr lang="en-US" sz="1000" dirty="0"/>
+          </a:p>
+        </p:txBody>
+      </p:sp>
+      <p:sp>
+        <p:nvSpPr>
+          <p:cNvPr id="48" name="Text 46"/>
+          <p:cNvSpPr/>
+          <p:nvPr/>
+        </p:nvSpPr>
+        <p:spPr>
+          <a:xfrm>
+            <a:off x="6172200" y="2916936"/>
+            <a:ext cx="2377440" cy="457200"/>
+          </a:xfrm>
+          <a:prstGeom prst="rect">
+            <a:avLst/>
+          </a:prstGeom>
+          <a:noFill/>
+          <a:ln/>
+        </p:spPr>
+        <p:txBody>
+          <a:bodyPr wrap="square" lIns="0" tIns="0" rIns="0" bIns="0" rtlCol="0" anchor="t"/>
+          <a:lstStyle/>
+          <a:p>
+            <a:pPr indent="0" marL="0">
+              <a:buNone/>
+            </a:pPr>
+            <a:r>
+              <a:rPr lang="en-US" sz="950" dirty="0">
+                <a:solidFill>
+                  <a:srgbClr val="333333"/>
+                </a:solidFill>
+                <a:latin typeface="Arial" pitchFamily="34" charset="0"/>
+                <a:ea typeface="Arial" pitchFamily="34" charset="-122"/>
+                <a:cs typeface="Arial" pitchFamily="34" charset="-120"/>
+              </a:rPr>
+              <a:t>General-purpose silicon that runs your operating system.</a:t>
+            </a:r>
+            <a:endParaRPr lang="en-US" sz="950" dirty="0"/>
+          </a:p>
+        </p:txBody>
+      </p:sp>
+      <p:sp>
+        <p:nvSpPr>
+          <p:cNvPr id="49" name="Text 47"/>
+          <p:cNvSpPr/>
+          <p:nvPr/>
+        </p:nvSpPr>
+        <p:spPr>
+          <a:xfrm>
+            <a:off x="6172200" y="3392424"/>
+            <a:ext cx="2377440" cy="237744"/>
+          </a:xfrm>
+          <a:prstGeom prst="rect">
+            <a:avLst/>
+          </a:prstGeom>
+          <a:noFill/>
+          <a:ln/>
+        </p:spPr>
+        <p:txBody>
+          <a:bodyPr wrap="square" lIns="0" tIns="0" rIns="0" bIns="0" rtlCol="0" anchor="t"/>
+          <a:lstStyle/>
+          <a:p>
+            <a:pPr indent="0" marL="0">
+              <a:buNone/>
+            </a:pPr>
+            <a:r>
+              <a:rPr lang="en-US" sz="850" i="1" dirty="0">
+                <a:solidFill>
+                  <a:srgbClr val="666666"/>
+                </a:solidFill>
+                <a:latin typeface="Arial" pitchFamily="34" charset="0"/>
+                <a:ea typeface="Arial" pitchFamily="34" charset="-122"/>
+                <a:cs typeface="Arial" pitchFamily="34" charset="-120"/>
+              </a:rPr>
+              <a:t>CPUs in every phone and PC</a:t>
+            </a:r>
+            <a:endParaRPr lang="en-US" sz="850" dirty="0"/>
+          </a:p>
+        </p:txBody>
+      </p:sp>
+      <p:sp>
+        <p:nvSpPr>
+          <p:cNvPr id="50" name="Shape 48"/>
+          <p:cNvSpPr/>
+          <p:nvPr/>
+        </p:nvSpPr>
+        <p:spPr>
+          <a:xfrm>
+            <a:off x="6217920" y="3648456"/>
+            <a:ext cx="2286000" cy="0"/>
+          </a:xfrm>
+          <a:prstGeom prst="line">
+            <a:avLst/>
+          </a:prstGeom>
+          <a:noFill/>
+          <a:ln w="6350">
+            <a:solidFill>
+              <a:srgbClr val="E5E5E5"/>
+            </a:solidFill>
+            <a:prstDash val="solid"/>
+          </a:ln>
+        </p:spPr>
+      </p:sp>
+      <p:sp>
+        <p:nvSpPr>
+          <p:cNvPr id="51" name="Text 49"/>
+          <p:cNvSpPr/>
+          <p:nvPr/>
+        </p:nvSpPr>
+        <p:spPr>
+          <a:xfrm>
+            <a:off x="6035040" y="3666744"/>
+            <a:ext cx="2651760" cy="201168"/>
+          </a:xfrm>
+          <a:prstGeom prst="rect">
+            <a:avLst/>
+          </a:prstGeom>
+          <a:noFill/>
+          <a:ln/>
+        </p:spPr>
+        <p:txBody>
+          <a:bodyPr wrap="square" lIns="0" tIns="0" rIns="0" bIns="0" rtlCol="0" anchor="ctr"/>
+          <a:lstStyle/>
+          <a:p>
+            <a:pPr algn="ctr" indent="0" marL="0">
+              <a:buNone/>
+            </a:pPr>
+            <a:r>
+              <a:rPr lang="en-US" sz="750" i="1" dirty="0">
+                <a:solidFill>
+                  <a:srgbClr val="666666"/>
+                </a:solidFill>
+                <a:latin typeface="Arial" pitchFamily="34" charset="0"/>
+                <a:ea typeface="Arial" pitchFamily="34" charset="-122"/>
+                <a:cs typeface="Arial" pitchFamily="34" charset="-120"/>
+              </a:rPr>
+              <a:t>Intel · AMD · Apple · Qualcomm</a:t>
+            </a:r>
+            <a:endParaRPr lang="en-US" sz="750" dirty="0"/>
+          </a:p>
+        </p:txBody>
+      </p:sp>
+      <p:sp>
+        <p:nvSpPr>
+          <p:cNvPr id="52" name="Shape 50"/>
+          <p:cNvSpPr/>
+          <p:nvPr/>
+        </p:nvSpPr>
+        <p:spPr>
+          <a:xfrm>
+            <a:off x="457200" y="3977640"/>
+            <a:ext cx="2651760" cy="1280160"/>
+          </a:xfrm>
+          <a:prstGeom prst="rect">
+            <a:avLst/>
+          </a:prstGeom>
+          <a:solidFill>
+            <a:srgbClr val="F9F9F9"/>
+          </a:solidFill>
+          <a:ln w="6350">
+            <a:solidFill>
+              <a:srgbClr val="E5E5E5"/>
+            </a:solidFill>
+            <a:prstDash val="solid"/>
+          </a:ln>
+        </p:spPr>
+      </p:sp>
+      <p:sp>
+        <p:nvSpPr>
+          <p:cNvPr id="53" name="Shape 51"/>
+          <p:cNvSpPr/>
+          <p:nvPr/>
+        </p:nvSpPr>
+        <p:spPr>
+          <a:xfrm>
+            <a:off x="457200" y="3977640"/>
+            <a:ext cx="2651760" cy="256032"/>
+          </a:xfrm>
+          <a:prstGeom prst="rect">
             <a:avLst/>
           </a:prstGeom>
           <a:solidFill>
@@ -33454,14 +34741,14 @@
       </p:sp>
       <p:sp>
         <p:nvSpPr>
-          <p:cNvPr id="15" name="Text 13"/>
-          <p:cNvSpPr/>
-          <p:nvPr/>
-        </p:nvSpPr>
-        <p:spPr>
-          <a:xfrm>
-            <a:off x="4974336" y="1691640"/>
-            <a:ext cx="1600200" cy="457200"/>
+          <p:cNvPr id="54" name="Text 52"/>
+          <p:cNvSpPr/>
+          <p:nvPr/>
+        </p:nvSpPr>
+        <p:spPr>
+          <a:xfrm>
+            <a:off x="457200" y="3977640"/>
+            <a:ext cx="2651760" cy="256032"/>
           </a:xfrm>
           <a:prstGeom prst="rect">
             <a:avLst/>
@@ -33473,25 +34760,89 @@
           <a:bodyPr wrap="square" lIns="0" tIns="0" rIns="0" bIns="0" rtlCol="0" anchor="ctr"/>
           <a:lstStyle/>
           <a:p>
-            <a:pPr indent="0" marL="0">
-              <a:buNone/>
-            </a:pPr>
-            <a:r>
-              <a:rPr lang="en-US" sz="1050" b="1" spc="200" kern="0" dirty="0">
-                <a:solidFill>
-                  <a:srgbClr val="000000"/>
-                </a:solidFill>
-                <a:latin typeface="Arial" pitchFamily="34" charset="0"/>
-                <a:ea typeface="Arial" pitchFamily="34" charset="-122"/>
-                <a:cs typeface="Arial" pitchFamily="34" charset="-120"/>
-              </a:rPr>
-              <a:t>ANALOG  </a:t>
-            </a:r>
-            <a:pPr indent="0" marL="0">
-              <a:buNone/>
-            </a:pPr>
-            <a:r>
-              <a:rPr lang="en-US" sz="1050" i="1" dirty="0">
+            <a:pPr algn="ctr" indent="0" marL="0">
+              <a:buNone/>
+            </a:pPr>
+            <a:r>
+              <a:rPr lang="en-US" sz="1000" b="1" spc="200" kern="0" dirty="0">
+                <a:solidFill>
+                  <a:srgbClr val="FFFFFF"/>
+                </a:solidFill>
+                <a:latin typeface="Arial" pitchFamily="34" charset="0"/>
+                <a:ea typeface="Arial" pitchFamily="34" charset="-122"/>
+                <a:cs typeface="Arial" pitchFamily="34" charset="-120"/>
+              </a:rPr>
+              <a:t>ANALOG</a:t>
+            </a:r>
+            <a:endParaRPr lang="en-US" sz="1000" dirty="0"/>
+          </a:p>
+        </p:txBody>
+      </p:sp>
+      <p:sp>
+        <p:nvSpPr>
+          <p:cNvPr id="55" name="Text 53"/>
+          <p:cNvSpPr/>
+          <p:nvPr/>
+        </p:nvSpPr>
+        <p:spPr>
+          <a:xfrm>
+            <a:off x="594360" y="4288536"/>
+            <a:ext cx="2377440" cy="457200"/>
+          </a:xfrm>
+          <a:prstGeom prst="rect">
+            <a:avLst/>
+          </a:prstGeom>
+          <a:noFill/>
+          <a:ln/>
+        </p:spPr>
+        <p:txBody>
+          <a:bodyPr wrap="square" lIns="0" tIns="0" rIns="0" bIns="0" rtlCol="0" anchor="t"/>
+          <a:lstStyle/>
+          <a:p>
+            <a:pPr indent="0" marL="0">
+              <a:buNone/>
+            </a:pPr>
+            <a:r>
+              <a:rPr lang="en-US" sz="950" dirty="0">
+                <a:solidFill>
+                  <a:srgbClr val="333333"/>
+                </a:solidFill>
+                <a:latin typeface="Arial" pitchFamily="34" charset="0"/>
+                <a:ea typeface="Arial" pitchFamily="34" charset="-122"/>
+                <a:cs typeface="Arial" pitchFamily="34" charset="-120"/>
+              </a:rPr>
+              <a:t>The bridge between silicon and the real world — voltages, signals, RF.</a:t>
+            </a:r>
+            <a:endParaRPr lang="en-US" sz="950" dirty="0"/>
+          </a:p>
+        </p:txBody>
+      </p:sp>
+      <p:sp>
+        <p:nvSpPr>
+          <p:cNvPr id="56" name="Text 54"/>
+          <p:cNvSpPr/>
+          <p:nvPr/>
+        </p:nvSpPr>
+        <p:spPr>
+          <a:xfrm>
+            <a:off x="594360" y="4764024"/>
+            <a:ext cx="2377440" cy="237744"/>
+          </a:xfrm>
+          <a:prstGeom prst="rect">
+            <a:avLst/>
+          </a:prstGeom>
+          <a:noFill/>
+          <a:ln/>
+        </p:spPr>
+        <p:txBody>
+          <a:bodyPr wrap="square" lIns="0" tIns="0" rIns="0" bIns="0" rtlCol="0" anchor="t"/>
+          <a:lstStyle/>
+          <a:p>
+            <a:pPr indent="0" marL="0">
+              <a:buNone/>
+            </a:pPr>
+            <a:r>
+              <a:rPr lang="en-US" sz="850" i="1" dirty="0">
                 <a:solidFill>
                   <a:srgbClr val="666666"/>
                 </a:solidFill>
@@ -33499,22 +34850,22 @@
                 <a:ea typeface="Arial" pitchFamily="34" charset="-122"/>
                 <a:cs typeface="Arial" pitchFamily="34" charset="-120"/>
               </a:rPr>
-              <a:t>senses</a:t>
-            </a:r>
-            <a:endParaRPr lang="en-US" sz="1050" dirty="0"/>
-          </a:p>
-        </p:txBody>
-      </p:sp>
-      <p:sp>
-        <p:nvSpPr>
-          <p:cNvPr id="16" name="Shape 14"/>
-          <p:cNvSpPr/>
-          <p:nvPr/>
-        </p:nvSpPr>
-        <p:spPr>
-          <a:xfrm>
-            <a:off x="6629400" y="1764792"/>
-            <a:ext cx="0" cy="310896"/>
+              <a:t>Power management, radio, audio</a:t>
+            </a:r>
+            <a:endParaRPr lang="en-US" sz="850" dirty="0"/>
+          </a:p>
+        </p:txBody>
+      </p:sp>
+      <p:sp>
+        <p:nvSpPr>
+          <p:cNvPr id="57" name="Shape 55"/>
+          <p:cNvSpPr/>
+          <p:nvPr/>
+        </p:nvSpPr>
+        <p:spPr>
+          <a:xfrm>
+            <a:off x="640080" y="5020056"/>
+            <a:ext cx="2286000" cy="0"/>
           </a:xfrm>
           <a:prstGeom prst="line">
             <a:avLst/>
@@ -33530,16 +34881,309 @@
       </p:sp>
       <p:sp>
         <p:nvSpPr>
-          <p:cNvPr id="17" name="Shape 15"/>
-          <p:cNvSpPr/>
-          <p:nvPr/>
-        </p:nvSpPr>
-        <p:spPr>
-          <a:xfrm>
-            <a:off x="6830568" y="1847088"/>
-            <a:ext cx="146304" cy="146304"/>
-          </a:xfrm>
-          <a:prstGeom prst="ellipse">
+          <p:cNvPr id="58" name="Text 56"/>
+          <p:cNvSpPr/>
+          <p:nvPr/>
+        </p:nvSpPr>
+        <p:spPr>
+          <a:xfrm>
+            <a:off x="457200" y="5038344"/>
+            <a:ext cx="2651760" cy="201168"/>
+          </a:xfrm>
+          <a:prstGeom prst="rect">
+            <a:avLst/>
+          </a:prstGeom>
+          <a:noFill/>
+          <a:ln/>
+        </p:spPr>
+        <p:txBody>
+          <a:bodyPr wrap="square" lIns="0" tIns="0" rIns="0" bIns="0" rtlCol="0" anchor="ctr"/>
+          <a:lstStyle/>
+          <a:p>
+            <a:pPr algn="ctr" indent="0" marL="0">
+              <a:buNone/>
+            </a:pPr>
+            <a:r>
+              <a:rPr lang="en-US" sz="750" i="1" dirty="0">
+                <a:solidFill>
+                  <a:srgbClr val="666666"/>
+                </a:solidFill>
+                <a:latin typeface="Arial" pitchFamily="34" charset="0"/>
+                <a:ea typeface="Arial" pitchFamily="34" charset="-122"/>
+                <a:cs typeface="Arial" pitchFamily="34" charset="-120"/>
+              </a:rPr>
+              <a:t>TI · Analog Devices · Infineon</a:t>
+            </a:r>
+            <a:endParaRPr lang="en-US" sz="750" dirty="0"/>
+          </a:p>
+        </p:txBody>
+      </p:sp>
+      <p:sp>
+        <p:nvSpPr>
+          <p:cNvPr id="59" name="Shape 57"/>
+          <p:cNvSpPr/>
+          <p:nvPr/>
+        </p:nvSpPr>
+        <p:spPr>
+          <a:xfrm>
+            <a:off x="3246120" y="3977640"/>
+            <a:ext cx="2651760" cy="1280160"/>
+          </a:xfrm>
+          <a:prstGeom prst="rect">
+            <a:avLst/>
+          </a:prstGeom>
+          <a:solidFill>
+            <a:srgbClr val="F9F9F9"/>
+          </a:solidFill>
+          <a:ln w="6350">
+            <a:solidFill>
+              <a:srgbClr val="E5E5E5"/>
+            </a:solidFill>
+            <a:prstDash val="solid"/>
+          </a:ln>
+        </p:spPr>
+      </p:sp>
+      <p:sp>
+        <p:nvSpPr>
+          <p:cNvPr id="60" name="Shape 58"/>
+          <p:cNvSpPr/>
+          <p:nvPr/>
+        </p:nvSpPr>
+        <p:spPr>
+          <a:xfrm>
+            <a:off x="3246120" y="3977640"/>
+            <a:ext cx="2651760" cy="256032"/>
+          </a:xfrm>
+          <a:prstGeom prst="rect">
+            <a:avLst/>
+          </a:prstGeom>
+          <a:solidFill>
+            <a:srgbClr val="00A854"/>
+          </a:solidFill>
+          <a:ln w="12700">
+            <a:solidFill>
+              <a:srgbClr val="00A854"/>
+            </a:solidFill>
+            <a:prstDash val="solid"/>
+          </a:ln>
+        </p:spPr>
+      </p:sp>
+      <p:sp>
+        <p:nvSpPr>
+          <p:cNvPr id="61" name="Text 59"/>
+          <p:cNvSpPr/>
+          <p:nvPr/>
+        </p:nvSpPr>
+        <p:spPr>
+          <a:xfrm>
+            <a:off x="3246120" y="3977640"/>
+            <a:ext cx="2651760" cy="256032"/>
+          </a:xfrm>
+          <a:prstGeom prst="rect">
+            <a:avLst/>
+          </a:prstGeom>
+          <a:noFill/>
+          <a:ln/>
+        </p:spPr>
+        <p:txBody>
+          <a:bodyPr wrap="square" lIns="0" tIns="0" rIns="0" bIns="0" rtlCol="0" anchor="ctr"/>
+          <a:lstStyle/>
+          <a:p>
+            <a:pPr algn="ctr" indent="0" marL="0">
+              <a:buNone/>
+            </a:pPr>
+            <a:r>
+              <a:rPr lang="en-US" sz="1000" b="1" spc="200" kern="0" dirty="0">
+                <a:solidFill>
+                  <a:srgbClr val="FFFFFF"/>
+                </a:solidFill>
+                <a:latin typeface="Arial" pitchFamily="34" charset="0"/>
+                <a:ea typeface="Arial" pitchFamily="34" charset="-122"/>
+                <a:cs typeface="Arial" pitchFamily="34" charset="-120"/>
+              </a:rPr>
+              <a:t>SENSORS + OPTO</a:t>
+            </a:r>
+            <a:endParaRPr lang="en-US" sz="1000" dirty="0"/>
+          </a:p>
+        </p:txBody>
+      </p:sp>
+      <p:sp>
+        <p:nvSpPr>
+          <p:cNvPr id="62" name="Text 60"/>
+          <p:cNvSpPr/>
+          <p:nvPr/>
+        </p:nvSpPr>
+        <p:spPr>
+          <a:xfrm>
+            <a:off x="3383280" y="4288536"/>
+            <a:ext cx="2377440" cy="457200"/>
+          </a:xfrm>
+          <a:prstGeom prst="rect">
+            <a:avLst/>
+          </a:prstGeom>
+          <a:noFill/>
+          <a:ln/>
+        </p:spPr>
+        <p:txBody>
+          <a:bodyPr wrap="square" lIns="0" tIns="0" rIns="0" bIns="0" rtlCol="0" anchor="t"/>
+          <a:lstStyle/>
+          <a:p>
+            <a:pPr indent="0" marL="0">
+              <a:buNone/>
+            </a:pPr>
+            <a:r>
+              <a:rPr lang="en-US" sz="950" dirty="0">
+                <a:solidFill>
+                  <a:srgbClr val="333333"/>
+                </a:solidFill>
+                <a:latin typeface="Arial" pitchFamily="34" charset="0"/>
+                <a:ea typeface="Arial" pitchFamily="34" charset="-122"/>
+                <a:cs typeface="Arial" pitchFamily="34" charset="-120"/>
+              </a:rPr>
+              <a:t>How chips see, hear, and communicate with photons.</a:t>
+            </a:r>
+            <a:endParaRPr lang="en-US" sz="950" dirty="0"/>
+          </a:p>
+        </p:txBody>
+      </p:sp>
+      <p:sp>
+        <p:nvSpPr>
+          <p:cNvPr id="63" name="Text 61"/>
+          <p:cNvSpPr/>
+          <p:nvPr/>
+        </p:nvSpPr>
+        <p:spPr>
+          <a:xfrm>
+            <a:off x="3383280" y="4764024"/>
+            <a:ext cx="2377440" cy="237744"/>
+          </a:xfrm>
+          <a:prstGeom prst="rect">
+            <a:avLst/>
+          </a:prstGeom>
+          <a:noFill/>
+          <a:ln/>
+        </p:spPr>
+        <p:txBody>
+          <a:bodyPr wrap="square" lIns="0" tIns="0" rIns="0" bIns="0" rtlCol="0" anchor="t"/>
+          <a:lstStyle/>
+          <a:p>
+            <a:pPr indent="0" marL="0">
+              <a:buNone/>
+            </a:pPr>
+            <a:r>
+              <a:rPr lang="en-US" sz="850" i="1" dirty="0">
+                <a:solidFill>
+                  <a:srgbClr val="666666"/>
+                </a:solidFill>
+                <a:latin typeface="Arial" pitchFamily="34" charset="0"/>
+                <a:ea typeface="Arial" pitchFamily="34" charset="-122"/>
+                <a:cs typeface="Arial" pitchFamily="34" charset="-120"/>
+              </a:rPr>
+              <a:t>Phone cameras, lidar, fiber optics</a:t>
+            </a:r>
+            <a:endParaRPr lang="en-US" sz="850" dirty="0"/>
+          </a:p>
+        </p:txBody>
+      </p:sp>
+      <p:sp>
+        <p:nvSpPr>
+          <p:cNvPr id="64" name="Shape 62"/>
+          <p:cNvSpPr/>
+          <p:nvPr/>
+        </p:nvSpPr>
+        <p:spPr>
+          <a:xfrm>
+            <a:off x="3429000" y="5020056"/>
+            <a:ext cx="2286000" cy="0"/>
+          </a:xfrm>
+          <a:prstGeom prst="line">
+            <a:avLst/>
+          </a:prstGeom>
+          <a:noFill/>
+          <a:ln w="6350">
+            <a:solidFill>
+              <a:srgbClr val="E5E5E5"/>
+            </a:solidFill>
+            <a:prstDash val="solid"/>
+          </a:ln>
+        </p:spPr>
+      </p:sp>
+      <p:sp>
+        <p:nvSpPr>
+          <p:cNvPr id="65" name="Text 63"/>
+          <p:cNvSpPr/>
+          <p:nvPr/>
+        </p:nvSpPr>
+        <p:spPr>
+          <a:xfrm>
+            <a:off x="3246120" y="5038344"/>
+            <a:ext cx="2651760" cy="201168"/>
+          </a:xfrm>
+          <a:prstGeom prst="rect">
+            <a:avLst/>
+          </a:prstGeom>
+          <a:noFill/>
+          <a:ln/>
+        </p:spPr>
+        <p:txBody>
+          <a:bodyPr wrap="square" lIns="0" tIns="0" rIns="0" bIns="0" rtlCol="0" anchor="ctr"/>
+          <a:lstStyle/>
+          <a:p>
+            <a:pPr algn="ctr" indent="0" marL="0">
+              <a:buNone/>
+            </a:pPr>
+            <a:r>
+              <a:rPr lang="en-US" sz="750" i="1" dirty="0">
+                <a:solidFill>
+                  <a:srgbClr val="666666"/>
+                </a:solidFill>
+                <a:latin typeface="Arial" pitchFamily="34" charset="0"/>
+                <a:ea typeface="Arial" pitchFamily="34" charset="-122"/>
+                <a:cs typeface="Arial" pitchFamily="34" charset="-120"/>
+              </a:rPr>
+              <a:t>Sony · Samsung · STMicro</a:t>
+            </a:r>
+            <a:endParaRPr lang="en-US" sz="750" dirty="0"/>
+          </a:p>
+        </p:txBody>
+      </p:sp>
+      <p:sp>
+        <p:nvSpPr>
+          <p:cNvPr id="66" name="Shape 64"/>
+          <p:cNvSpPr/>
+          <p:nvPr/>
+        </p:nvSpPr>
+        <p:spPr>
+          <a:xfrm>
+            <a:off x="6035040" y="3977640"/>
+            <a:ext cx="2651760" cy="1280160"/>
+          </a:xfrm>
+          <a:prstGeom prst="rect">
+            <a:avLst/>
+          </a:prstGeom>
+          <a:solidFill>
+            <a:srgbClr val="F9F9F9"/>
+          </a:solidFill>
+          <a:ln w="6350">
+            <a:solidFill>
+              <a:srgbClr val="E5E5E5"/>
+            </a:solidFill>
+            <a:prstDash val="solid"/>
+          </a:ln>
+        </p:spPr>
+      </p:sp>
+      <p:sp>
+        <p:nvSpPr>
+          <p:cNvPr id="67" name="Shape 65"/>
+          <p:cNvSpPr/>
+          <p:nvPr/>
+        </p:nvSpPr>
+        <p:spPr>
+          <a:xfrm>
+            <a:off x="6035040" y="3977640"/>
+            <a:ext cx="2651760" cy="256032"/>
+          </a:xfrm>
+          <a:prstGeom prst="rect">
             <a:avLst/>
           </a:prstGeom>
           <a:solidFill>
@@ -33555,14 +35199,14 @@
       </p:sp>
       <p:sp>
         <p:nvSpPr>
-          <p:cNvPr id="18" name="Text 16"/>
-          <p:cNvSpPr/>
-          <p:nvPr/>
-        </p:nvSpPr>
-        <p:spPr>
-          <a:xfrm>
-            <a:off x="7031736" y="1691640"/>
-            <a:ext cx="1600200" cy="457200"/>
+          <p:cNvPr id="68" name="Text 66"/>
+          <p:cNvSpPr/>
+          <p:nvPr/>
+        </p:nvSpPr>
+        <p:spPr>
+          <a:xfrm>
+            <a:off x="6035040" y="3977640"/>
+            <a:ext cx="2651760" cy="256032"/>
           </a:xfrm>
           <a:prstGeom prst="rect">
             <a:avLst/>
@@ -33574,25 +35218,89 @@
           <a:bodyPr wrap="square" lIns="0" tIns="0" rIns="0" bIns="0" rtlCol="0" anchor="ctr"/>
           <a:lstStyle/>
           <a:p>
-            <a:pPr indent="0" marL="0">
-              <a:buNone/>
-            </a:pPr>
-            <a:r>
-              <a:rPr lang="en-US" sz="1050" b="1" spc="200" kern="0" dirty="0">
-                <a:solidFill>
-                  <a:srgbClr val="000000"/>
-                </a:solidFill>
-                <a:latin typeface="Arial" pitchFamily="34" charset="0"/>
-                <a:ea typeface="Arial" pitchFamily="34" charset="-122"/>
-                <a:cs typeface="Arial" pitchFamily="34" charset="-120"/>
-              </a:rPr>
-              <a:t>POWER  </a:t>
-            </a:r>
-            <a:pPr indent="0" marL="0">
-              <a:buNone/>
-            </a:pPr>
-            <a:r>
-              <a:rPr lang="en-US" sz="1050" i="1" dirty="0">
+            <a:pPr algn="ctr" indent="0" marL="0">
+              <a:buNone/>
+            </a:pPr>
+            <a:r>
+              <a:rPr lang="en-US" sz="1000" b="1" spc="200" kern="0" dirty="0">
+                <a:solidFill>
+                  <a:srgbClr val="FFFFFF"/>
+                </a:solidFill>
+                <a:latin typeface="Arial" pitchFamily="34" charset="0"/>
+                <a:ea typeface="Arial" pitchFamily="34" charset="-122"/>
+                <a:cs typeface="Arial" pitchFamily="34" charset="-120"/>
+              </a:rPr>
+              <a:t>DISCRETE + POWER</a:t>
+            </a:r>
+            <a:endParaRPr lang="en-US" sz="1000" dirty="0"/>
+          </a:p>
+        </p:txBody>
+      </p:sp>
+      <p:sp>
+        <p:nvSpPr>
+          <p:cNvPr id="69" name="Text 67"/>
+          <p:cNvSpPr/>
+          <p:nvPr/>
+        </p:nvSpPr>
+        <p:spPr>
+          <a:xfrm>
+            <a:off x="6172200" y="4288536"/>
+            <a:ext cx="2377440" cy="457200"/>
+          </a:xfrm>
+          <a:prstGeom prst="rect">
+            <a:avLst/>
+          </a:prstGeom>
+          <a:noFill/>
+          <a:ln/>
+        </p:spPr>
+        <p:txBody>
+          <a:bodyPr wrap="square" lIns="0" tIns="0" rIns="0" bIns="0" rtlCol="0" anchor="t"/>
+          <a:lstStyle/>
+          <a:p>
+            <a:pPr indent="0" marL="0">
+              <a:buNone/>
+            </a:pPr>
+            <a:r>
+              <a:rPr lang="en-US" sz="950" dirty="0">
+                <a:solidFill>
+                  <a:srgbClr val="333333"/>
+                </a:solidFill>
+                <a:latin typeface="Arial" pitchFamily="34" charset="0"/>
+                <a:ea typeface="Arial" pitchFamily="34" charset="-122"/>
+                <a:cs typeface="Arial" pitchFamily="34" charset="-120"/>
+              </a:rPr>
+              <a:t>Heavy-current switching for machines, grids, and vehicles.</a:t>
+            </a:r>
+            <a:endParaRPr lang="en-US" sz="950" dirty="0"/>
+          </a:p>
+        </p:txBody>
+      </p:sp>
+      <p:sp>
+        <p:nvSpPr>
+          <p:cNvPr id="70" name="Text 68"/>
+          <p:cNvSpPr/>
+          <p:nvPr/>
+        </p:nvSpPr>
+        <p:spPr>
+          <a:xfrm>
+            <a:off x="6172200" y="4764024"/>
+            <a:ext cx="2377440" cy="237744"/>
+          </a:xfrm>
+          <a:prstGeom prst="rect">
+            <a:avLst/>
+          </a:prstGeom>
+          <a:noFill/>
+          <a:ln/>
+        </p:spPr>
+        <p:txBody>
+          <a:bodyPr wrap="square" lIns="0" tIns="0" rIns="0" bIns="0" rtlCol="0" anchor="t"/>
+          <a:lstStyle/>
+          <a:p>
+            <a:pPr indent="0" marL="0">
+              <a:buNone/>
+            </a:pPr>
+            <a:r>
+              <a:rPr lang="en-US" sz="850" i="1" dirty="0">
                 <a:solidFill>
                   <a:srgbClr val="666666"/>
                 </a:solidFill>
@@ -33600,29 +35308,27 @@
                 <a:ea typeface="Arial" pitchFamily="34" charset="-122"/>
                 <a:cs typeface="Arial" pitchFamily="34" charset="-120"/>
               </a:rPr>
-              <a:t>switches</a:t>
-            </a:r>
-            <a:endParaRPr lang="en-US" sz="1050" dirty="0"/>
-          </a:p>
-        </p:txBody>
-      </p:sp>
-      <p:sp>
-        <p:nvSpPr>
-          <p:cNvPr id="19" name="Shape 17"/>
-          <p:cNvSpPr/>
-          <p:nvPr/>
-        </p:nvSpPr>
-        <p:spPr>
-          <a:xfrm>
-            <a:off x="457200" y="2331720"/>
-            <a:ext cx="2651760" cy="1371600"/>
-          </a:xfrm>
-          <a:prstGeom prst="rect">
-            <a:avLst/>
-          </a:prstGeom>
-          <a:solidFill>
-            <a:srgbClr val="F9F9F9"/>
-          </a:solidFill>
+              <a:t>EVs, industrial motors, chargers</a:t>
+            </a:r>
+            <a:endParaRPr lang="en-US" sz="850" dirty="0"/>
+          </a:p>
+        </p:txBody>
+      </p:sp>
+      <p:sp>
+        <p:nvSpPr>
+          <p:cNvPr id="71" name="Shape 69"/>
+          <p:cNvSpPr/>
+          <p:nvPr/>
+        </p:nvSpPr>
+        <p:spPr>
+          <a:xfrm>
+            <a:off x="6217920" y="5020056"/>
+            <a:ext cx="2286000" cy="0"/>
+          </a:xfrm>
+          <a:prstGeom prst="line">
+            <a:avLst/>
+          </a:prstGeom>
+          <a:noFill/>
           <a:ln w="6350">
             <a:solidFill>
               <a:srgbClr val="E5E5E5"/>
@@ -33633,39 +35339,14 @@
       </p:sp>
       <p:sp>
         <p:nvSpPr>
-          <p:cNvPr id="20" name="Shape 18"/>
-          <p:cNvSpPr/>
-          <p:nvPr/>
-        </p:nvSpPr>
-        <p:spPr>
-          <a:xfrm>
-            <a:off x="457200" y="2331720"/>
-            <a:ext cx="2651760" cy="274320"/>
-          </a:xfrm>
-          <a:prstGeom prst="rect">
-            <a:avLst/>
-          </a:prstGeom>
-          <a:solidFill>
-            <a:srgbClr val="F6693D"/>
-          </a:solidFill>
-          <a:ln w="12700">
-            <a:solidFill>
-              <a:srgbClr val="F6693D"/>
-            </a:solidFill>
-            <a:prstDash val="solid"/>
-          </a:ln>
-        </p:spPr>
-      </p:sp>
-      <p:sp>
-        <p:nvSpPr>
-          <p:cNvPr id="21" name="Text 19"/>
-          <p:cNvSpPr/>
-          <p:nvPr/>
-        </p:nvSpPr>
-        <p:spPr>
-          <a:xfrm>
-            <a:off x="457200" y="2331720"/>
-            <a:ext cx="2651760" cy="274320"/>
+          <p:cNvPr id="72" name="Text 70"/>
+          <p:cNvSpPr/>
+          <p:nvPr/>
+        </p:nvSpPr>
+        <p:spPr>
+          <a:xfrm>
+            <a:off x="6035040" y="5038344"/>
+            <a:ext cx="2651760" cy="201168"/>
           </a:xfrm>
           <a:prstGeom prst="rect">
             <a:avLst/>
@@ -33681,85 +35362,7 @@
               <a:buNone/>
             </a:pPr>
             <a:r>
-              <a:rPr lang="en-US" sz="1000" b="1" spc="200" kern="0" dirty="0">
-                <a:solidFill>
-                  <a:srgbClr val="FFFFFF"/>
-                </a:solidFill>
-                <a:latin typeface="Arial" pitchFamily="34" charset="0"/>
-                <a:ea typeface="Arial" pitchFamily="34" charset="-122"/>
-                <a:cs typeface="Arial" pitchFamily="34" charset="-120"/>
-              </a:rPr>
-              <a:t>LOGIC</a:t>
-            </a:r>
-            <a:endParaRPr lang="en-US" sz="1000" dirty="0"/>
-          </a:p>
-        </p:txBody>
-      </p:sp>
-      <p:sp>
-        <p:nvSpPr>
-          <p:cNvPr id="22" name="Text 20"/>
-          <p:cNvSpPr/>
-          <p:nvPr/>
-        </p:nvSpPr>
-        <p:spPr>
-          <a:xfrm>
-            <a:off x="594360" y="2679192"/>
-            <a:ext cx="2377440" cy="475488"/>
-          </a:xfrm>
-          <a:prstGeom prst="rect">
-            <a:avLst/>
-          </a:prstGeom>
-          <a:noFill/>
-          <a:ln/>
-        </p:spPr>
-        <p:txBody>
-          <a:bodyPr wrap="square" lIns="0" tIns="0" rIns="0" bIns="0" rtlCol="0" anchor="t"/>
-          <a:lstStyle/>
-          <a:p>
-            <a:pPr indent="0" marL="0">
-              <a:buNone/>
-            </a:pPr>
-            <a:r>
-              <a:rPr lang="en-US" sz="1000" dirty="0">
-                <a:solidFill>
-                  <a:srgbClr val="333333"/>
-                </a:solidFill>
-                <a:latin typeface="Arial" pitchFamily="34" charset="0"/>
-                <a:ea typeface="Arial" pitchFamily="34" charset="-122"/>
-                <a:cs typeface="Arial" pitchFamily="34" charset="-120"/>
-              </a:rPr>
-              <a:t>Where computation happens — the chips that run code and move data.</a:t>
-            </a:r>
-            <a:endParaRPr lang="en-US" sz="1000" dirty="0"/>
-          </a:p>
-        </p:txBody>
-      </p:sp>
-      <p:sp>
-        <p:nvSpPr>
-          <p:cNvPr id="23" name="Text 21"/>
-          <p:cNvSpPr/>
-          <p:nvPr/>
-        </p:nvSpPr>
-        <p:spPr>
-          <a:xfrm>
-            <a:off x="594360" y="3172968"/>
-            <a:ext cx="2377440" cy="256032"/>
-          </a:xfrm>
-          <a:prstGeom prst="rect">
-            <a:avLst/>
-          </a:prstGeom>
-          <a:noFill/>
-          <a:ln/>
-        </p:spPr>
-        <p:txBody>
-          <a:bodyPr wrap="square" lIns="0" tIns="0" rIns="0" bIns="0" rtlCol="0" anchor="t"/>
-          <a:lstStyle/>
-          <a:p>
-            <a:pPr indent="0" marL="0">
-              <a:buNone/>
-            </a:pPr>
-            <a:r>
-              <a:rPr lang="en-US" sz="900" i="1" dirty="0">
+              <a:rPr lang="en-US" sz="750" i="1" dirty="0">
                 <a:solidFill>
                   <a:srgbClr val="666666"/>
                 </a:solidFill>
@@ -33767,69 +35370,7 @@
                 <a:ea typeface="Arial" pitchFamily="34" charset="-122"/>
                 <a:cs typeface="Arial" pitchFamily="34" charset="-120"/>
               </a:rPr>
-              <a:t>GPUs, AI accelerators, ASICs, FPGAs</a:t>
-            </a:r>
-            <a:endParaRPr lang="en-US" sz="900" dirty="0"/>
-          </a:p>
-        </p:txBody>
-      </p:sp>
-      <p:sp>
-        <p:nvSpPr>
-          <p:cNvPr id="24" name="Shape 22"/>
-          <p:cNvSpPr/>
-          <p:nvPr/>
-        </p:nvSpPr>
-        <p:spPr>
-          <a:xfrm>
-            <a:off x="640080" y="3447288"/>
-            <a:ext cx="2286000" cy="0"/>
-          </a:xfrm>
-          <a:prstGeom prst="line">
-            <a:avLst/>
-          </a:prstGeom>
-          <a:noFill/>
-          <a:ln w="6350">
-            <a:solidFill>
-              <a:srgbClr val="E5E5E5"/>
-            </a:solidFill>
-            <a:prstDash val="solid"/>
-          </a:ln>
-        </p:spPr>
-      </p:sp>
-      <p:sp>
-        <p:nvSpPr>
-          <p:cNvPr id="25" name="Text 23"/>
-          <p:cNvSpPr/>
-          <p:nvPr/>
-        </p:nvSpPr>
-        <p:spPr>
-          <a:xfrm>
-            <a:off x="457200" y="3465576"/>
-            <a:ext cx="2651760" cy="201168"/>
-          </a:xfrm>
-          <a:prstGeom prst="rect">
-            <a:avLst/>
-          </a:prstGeom>
-          <a:noFill/>
-          <a:ln/>
-        </p:spPr>
-        <p:txBody>
-          <a:bodyPr wrap="square" lIns="0" tIns="0" rIns="0" bIns="0" rtlCol="0" anchor="ctr"/>
-          <a:lstStyle/>
-          <a:p>
-            <a:pPr algn="ctr" indent="0" marL="0">
-              <a:buNone/>
-            </a:pPr>
-            <a:r>
-              <a:rPr lang="en-US" sz="750" i="1" dirty="0">
-                <a:solidFill>
-                  <a:srgbClr val="666666"/>
-                </a:solidFill>
-                <a:latin typeface="Arial" pitchFamily="34" charset="0"/>
-                <a:ea typeface="Arial" pitchFamily="34" charset="-122"/>
-                <a:cs typeface="Arial" pitchFamily="34" charset="-120"/>
-              </a:rPr>
-              <a:t>NVIDIA · AMD · Broadcom · TSMC</a:t>
+              <a:t>Infineon · ON Semi · Wolfspeed</a:t>
             </a:r>
             <a:endParaRPr lang="en-US" sz="750" dirty="0"/>
           </a:p>
@@ -33837,1159 +35378,14 @@
       </p:sp>
       <p:sp>
         <p:nvSpPr>
-          <p:cNvPr id="26" name="Shape 24"/>
-          <p:cNvSpPr/>
-          <p:nvPr/>
-        </p:nvSpPr>
-        <p:spPr>
-          <a:xfrm>
-            <a:off x="3246120" y="2331720"/>
-            <a:ext cx="2651760" cy="1371600"/>
-          </a:xfrm>
-          <a:prstGeom prst="rect">
-            <a:avLst/>
-          </a:prstGeom>
-          <a:solidFill>
-            <a:srgbClr val="F9F9F9"/>
-          </a:solidFill>
-          <a:ln w="6350">
-            <a:solidFill>
-              <a:srgbClr val="E5E5E5"/>
-            </a:solidFill>
-            <a:prstDash val="solid"/>
-          </a:ln>
-        </p:spPr>
-      </p:sp>
-      <p:sp>
-        <p:nvSpPr>
-          <p:cNvPr id="27" name="Shape 25"/>
-          <p:cNvSpPr/>
-          <p:nvPr/>
-        </p:nvSpPr>
-        <p:spPr>
-          <a:xfrm>
-            <a:off x="3246120" y="2331720"/>
-            <a:ext cx="2651760" cy="274320"/>
-          </a:xfrm>
-          <a:prstGeom prst="rect">
-            <a:avLst/>
-          </a:prstGeom>
-          <a:solidFill>
-            <a:srgbClr val="FFB800"/>
-          </a:solidFill>
-          <a:ln w="12700">
-            <a:solidFill>
-              <a:srgbClr val="FFB800"/>
-            </a:solidFill>
-            <a:prstDash val="solid"/>
-          </a:ln>
-        </p:spPr>
-      </p:sp>
-      <p:sp>
-        <p:nvSpPr>
-          <p:cNvPr id="28" name="Text 26"/>
-          <p:cNvSpPr/>
-          <p:nvPr/>
-        </p:nvSpPr>
-        <p:spPr>
-          <a:xfrm>
-            <a:off x="3246120" y="2331720"/>
-            <a:ext cx="2651760" cy="274320"/>
-          </a:xfrm>
-          <a:prstGeom prst="rect">
-            <a:avLst/>
-          </a:prstGeom>
-          <a:noFill/>
-          <a:ln/>
-        </p:spPr>
-        <p:txBody>
-          <a:bodyPr wrap="square" lIns="0" tIns="0" rIns="0" bIns="0" rtlCol="0" anchor="ctr"/>
-          <a:lstStyle/>
-          <a:p>
-            <a:pPr algn="ctr" indent="0" marL="0">
-              <a:buNone/>
-            </a:pPr>
-            <a:r>
-              <a:rPr lang="en-US" sz="1000" b="1" spc="200" kern="0" dirty="0">
-                <a:solidFill>
-                  <a:srgbClr val="000000"/>
-                </a:solidFill>
-                <a:latin typeface="Arial" pitchFamily="34" charset="0"/>
-                <a:ea typeface="Arial" pitchFamily="34" charset="-122"/>
-                <a:cs typeface="Arial" pitchFamily="34" charset="-120"/>
-              </a:rPr>
-              <a:t>MEMORY</a:t>
-            </a:r>
-            <a:endParaRPr lang="en-US" sz="1000" dirty="0"/>
-          </a:p>
-        </p:txBody>
-      </p:sp>
-      <p:sp>
-        <p:nvSpPr>
-          <p:cNvPr id="29" name="Text 27"/>
-          <p:cNvSpPr/>
-          <p:nvPr/>
-        </p:nvSpPr>
-        <p:spPr>
-          <a:xfrm>
-            <a:off x="3383280" y="2679192"/>
-            <a:ext cx="2377440" cy="475488"/>
-          </a:xfrm>
-          <a:prstGeom prst="rect">
-            <a:avLst/>
-          </a:prstGeom>
-          <a:noFill/>
-          <a:ln/>
-        </p:spPr>
-        <p:txBody>
-          <a:bodyPr wrap="square" lIns="0" tIns="0" rIns="0" bIns="0" rtlCol="0" anchor="t"/>
-          <a:lstStyle/>
-          <a:p>
-            <a:pPr indent="0" marL="0">
-              <a:buNone/>
-            </a:pPr>
-            <a:r>
-              <a:rPr lang="en-US" sz="1000" dirty="0">
-                <a:solidFill>
-                  <a:srgbClr val="333333"/>
-                </a:solidFill>
-                <a:latin typeface="Arial" pitchFamily="34" charset="0"/>
-                <a:ea typeface="Arial" pitchFamily="34" charset="-122"/>
-                <a:cs typeface="Arial" pitchFamily="34" charset="-120"/>
-              </a:rPr>
-              <a:t>Stores data so logic can read it at terabit speeds.</a:t>
-            </a:r>
-            <a:endParaRPr lang="en-US" sz="1000" dirty="0"/>
-          </a:p>
-        </p:txBody>
-      </p:sp>
-      <p:sp>
-        <p:nvSpPr>
-          <p:cNvPr id="30" name="Text 28"/>
-          <p:cNvSpPr/>
-          <p:nvPr/>
-        </p:nvSpPr>
-        <p:spPr>
-          <a:xfrm>
-            <a:off x="3383280" y="3172968"/>
-            <a:ext cx="2377440" cy="256032"/>
-          </a:xfrm>
-          <a:prstGeom prst="rect">
-            <a:avLst/>
-          </a:prstGeom>
-          <a:noFill/>
-          <a:ln/>
-        </p:spPr>
-        <p:txBody>
-          <a:bodyPr wrap="square" lIns="0" tIns="0" rIns="0" bIns="0" rtlCol="0" anchor="t"/>
-          <a:lstStyle/>
-          <a:p>
-            <a:pPr indent="0" marL="0">
-              <a:buNone/>
-            </a:pPr>
-            <a:r>
-              <a:rPr lang="en-US" sz="900" i="1" dirty="0">
-                <a:solidFill>
-                  <a:srgbClr val="666666"/>
-                </a:solidFill>
-                <a:latin typeface="Arial" pitchFamily="34" charset="0"/>
-                <a:ea typeface="Arial" pitchFamily="34" charset="-122"/>
-                <a:cs typeface="Arial" pitchFamily="34" charset="-120"/>
-              </a:rPr>
-              <a:t>DRAM, HBM, NAND — every AI server</a:t>
-            </a:r>
-            <a:endParaRPr lang="en-US" sz="900" dirty="0"/>
-          </a:p>
-        </p:txBody>
-      </p:sp>
-      <p:sp>
-        <p:nvSpPr>
-          <p:cNvPr id="31" name="Shape 29"/>
-          <p:cNvSpPr/>
-          <p:nvPr/>
-        </p:nvSpPr>
-        <p:spPr>
-          <a:xfrm>
-            <a:off x="3429000" y="3447288"/>
-            <a:ext cx="2286000" cy="0"/>
-          </a:xfrm>
-          <a:prstGeom prst="line">
-            <a:avLst/>
-          </a:prstGeom>
-          <a:noFill/>
-          <a:ln w="6350">
-            <a:solidFill>
-              <a:srgbClr val="E5E5E5"/>
-            </a:solidFill>
-            <a:prstDash val="solid"/>
-          </a:ln>
-        </p:spPr>
-      </p:sp>
-      <p:sp>
-        <p:nvSpPr>
-          <p:cNvPr id="32" name="Text 30"/>
-          <p:cNvSpPr/>
-          <p:nvPr/>
-        </p:nvSpPr>
-        <p:spPr>
-          <a:xfrm>
-            <a:off x="3246120" y="3465576"/>
-            <a:ext cx="2651760" cy="201168"/>
-          </a:xfrm>
-          <a:prstGeom prst="rect">
-            <a:avLst/>
-          </a:prstGeom>
-          <a:noFill/>
-          <a:ln/>
-        </p:spPr>
-        <p:txBody>
-          <a:bodyPr wrap="square" lIns="0" tIns="0" rIns="0" bIns="0" rtlCol="0" anchor="ctr"/>
-          <a:lstStyle/>
-          <a:p>
-            <a:pPr algn="ctr" indent="0" marL="0">
-              <a:buNone/>
-            </a:pPr>
-            <a:r>
-              <a:rPr lang="en-US" sz="750" i="1" dirty="0">
-                <a:solidFill>
-                  <a:srgbClr val="666666"/>
-                </a:solidFill>
-                <a:latin typeface="Arial" pitchFamily="34" charset="0"/>
-                <a:ea typeface="Arial" pitchFamily="34" charset="-122"/>
-                <a:cs typeface="Arial" pitchFamily="34" charset="-120"/>
-              </a:rPr>
-              <a:t>SK Hynix · Samsung · Micron</a:t>
-            </a:r>
-            <a:endParaRPr lang="en-US" sz="750" dirty="0"/>
-          </a:p>
-        </p:txBody>
-      </p:sp>
-      <p:sp>
-        <p:nvSpPr>
-          <p:cNvPr id="33" name="Shape 31"/>
-          <p:cNvSpPr/>
-          <p:nvPr/>
-        </p:nvSpPr>
-        <p:spPr>
-          <a:xfrm>
-            <a:off x="6035040" y="2331720"/>
-            <a:ext cx="2651760" cy="1371600"/>
-          </a:xfrm>
-          <a:prstGeom prst="rect">
-            <a:avLst/>
-          </a:prstGeom>
-          <a:solidFill>
-            <a:srgbClr val="F9F9F9"/>
-          </a:solidFill>
-          <a:ln w="6350">
-            <a:solidFill>
-              <a:srgbClr val="E5E5E5"/>
-            </a:solidFill>
-            <a:prstDash val="solid"/>
-          </a:ln>
-        </p:spPr>
-      </p:sp>
-      <p:sp>
-        <p:nvSpPr>
-          <p:cNvPr id="34" name="Shape 32"/>
-          <p:cNvSpPr/>
-          <p:nvPr/>
-        </p:nvSpPr>
-        <p:spPr>
-          <a:xfrm>
-            <a:off x="6035040" y="2331720"/>
-            <a:ext cx="2651760" cy="274320"/>
-          </a:xfrm>
-          <a:prstGeom prst="rect">
-            <a:avLst/>
-          </a:prstGeom>
-          <a:solidFill>
-            <a:srgbClr val="008B8B"/>
-          </a:solidFill>
-          <a:ln w="12700">
-            <a:solidFill>
-              <a:srgbClr val="008B8B"/>
-            </a:solidFill>
-            <a:prstDash val="solid"/>
-          </a:ln>
-        </p:spPr>
-      </p:sp>
-      <p:sp>
-        <p:nvSpPr>
-          <p:cNvPr id="35" name="Text 33"/>
-          <p:cNvSpPr/>
-          <p:nvPr/>
-        </p:nvSpPr>
-        <p:spPr>
-          <a:xfrm>
-            <a:off x="6035040" y="2331720"/>
-            <a:ext cx="2651760" cy="274320"/>
-          </a:xfrm>
-          <a:prstGeom prst="rect">
-            <a:avLst/>
-          </a:prstGeom>
-          <a:noFill/>
-          <a:ln/>
-        </p:spPr>
-        <p:txBody>
-          <a:bodyPr wrap="square" lIns="0" tIns="0" rIns="0" bIns="0" rtlCol="0" anchor="ctr"/>
-          <a:lstStyle/>
-          <a:p>
-            <a:pPr algn="ctr" indent="0" marL="0">
-              <a:buNone/>
-            </a:pPr>
-            <a:r>
-              <a:rPr lang="en-US" sz="1000" b="1" spc="200" kern="0" dirty="0">
-                <a:solidFill>
-                  <a:srgbClr val="FFFFFF"/>
-                </a:solidFill>
-                <a:latin typeface="Arial" pitchFamily="34" charset="0"/>
-                <a:ea typeface="Arial" pitchFamily="34" charset="-122"/>
-                <a:cs typeface="Arial" pitchFamily="34" charset="-120"/>
-              </a:rPr>
-              <a:t>PROCESSORS</a:t>
-            </a:r>
-            <a:endParaRPr lang="en-US" sz="1000" dirty="0"/>
-          </a:p>
-        </p:txBody>
-      </p:sp>
-      <p:sp>
-        <p:nvSpPr>
-          <p:cNvPr id="36" name="Text 34"/>
-          <p:cNvSpPr/>
-          <p:nvPr/>
-        </p:nvSpPr>
-        <p:spPr>
-          <a:xfrm>
-            <a:off x="6172200" y="2679192"/>
-            <a:ext cx="2377440" cy="475488"/>
-          </a:xfrm>
-          <a:prstGeom prst="rect">
-            <a:avLst/>
-          </a:prstGeom>
-          <a:noFill/>
-          <a:ln/>
-        </p:spPr>
-        <p:txBody>
-          <a:bodyPr wrap="square" lIns="0" tIns="0" rIns="0" bIns="0" rtlCol="0" anchor="t"/>
-          <a:lstStyle/>
-          <a:p>
-            <a:pPr indent="0" marL="0">
-              <a:buNone/>
-            </a:pPr>
-            <a:r>
-              <a:rPr lang="en-US" sz="1000" dirty="0">
-                <a:solidFill>
-                  <a:srgbClr val="333333"/>
-                </a:solidFill>
-                <a:latin typeface="Arial" pitchFamily="34" charset="0"/>
-                <a:ea typeface="Arial" pitchFamily="34" charset="-122"/>
-                <a:cs typeface="Arial" pitchFamily="34" charset="-120"/>
-              </a:rPr>
-              <a:t>General-purpose silicon that runs your operating system.</a:t>
-            </a:r>
-            <a:endParaRPr lang="en-US" sz="1000" dirty="0"/>
-          </a:p>
-        </p:txBody>
-      </p:sp>
-      <p:sp>
-        <p:nvSpPr>
-          <p:cNvPr id="37" name="Text 35"/>
-          <p:cNvSpPr/>
-          <p:nvPr/>
-        </p:nvSpPr>
-        <p:spPr>
-          <a:xfrm>
-            <a:off x="6172200" y="3172968"/>
-            <a:ext cx="2377440" cy="256032"/>
-          </a:xfrm>
-          <a:prstGeom prst="rect">
-            <a:avLst/>
-          </a:prstGeom>
-          <a:noFill/>
-          <a:ln/>
-        </p:spPr>
-        <p:txBody>
-          <a:bodyPr wrap="square" lIns="0" tIns="0" rIns="0" bIns="0" rtlCol="0" anchor="t"/>
-          <a:lstStyle/>
-          <a:p>
-            <a:pPr indent="0" marL="0">
-              <a:buNone/>
-            </a:pPr>
-            <a:r>
-              <a:rPr lang="en-US" sz="900" i="1" dirty="0">
-                <a:solidFill>
-                  <a:srgbClr val="666666"/>
-                </a:solidFill>
-                <a:latin typeface="Arial" pitchFamily="34" charset="0"/>
-                <a:ea typeface="Arial" pitchFamily="34" charset="-122"/>
-                <a:cs typeface="Arial" pitchFamily="34" charset="-120"/>
-              </a:rPr>
-              <a:t>CPUs in every phone and PC</a:t>
-            </a:r>
-            <a:endParaRPr lang="en-US" sz="900" dirty="0"/>
-          </a:p>
-        </p:txBody>
-      </p:sp>
-      <p:sp>
-        <p:nvSpPr>
-          <p:cNvPr id="38" name="Shape 36"/>
-          <p:cNvSpPr/>
-          <p:nvPr/>
-        </p:nvSpPr>
-        <p:spPr>
-          <a:xfrm>
-            <a:off x="6217920" y="3447288"/>
-            <a:ext cx="2286000" cy="0"/>
-          </a:xfrm>
-          <a:prstGeom prst="line">
-            <a:avLst/>
-          </a:prstGeom>
-          <a:noFill/>
-          <a:ln w="6350">
-            <a:solidFill>
-              <a:srgbClr val="E5E5E5"/>
-            </a:solidFill>
-            <a:prstDash val="solid"/>
-          </a:ln>
-        </p:spPr>
-      </p:sp>
-      <p:sp>
-        <p:nvSpPr>
-          <p:cNvPr id="39" name="Text 37"/>
-          <p:cNvSpPr/>
-          <p:nvPr/>
-        </p:nvSpPr>
-        <p:spPr>
-          <a:xfrm>
-            <a:off x="6035040" y="3465576"/>
-            <a:ext cx="2651760" cy="201168"/>
-          </a:xfrm>
-          <a:prstGeom prst="rect">
-            <a:avLst/>
-          </a:prstGeom>
-          <a:noFill/>
-          <a:ln/>
-        </p:spPr>
-        <p:txBody>
-          <a:bodyPr wrap="square" lIns="0" tIns="0" rIns="0" bIns="0" rtlCol="0" anchor="ctr"/>
-          <a:lstStyle/>
-          <a:p>
-            <a:pPr algn="ctr" indent="0" marL="0">
-              <a:buNone/>
-            </a:pPr>
-            <a:r>
-              <a:rPr lang="en-US" sz="750" i="1" dirty="0">
-                <a:solidFill>
-                  <a:srgbClr val="666666"/>
-                </a:solidFill>
-                <a:latin typeface="Arial" pitchFamily="34" charset="0"/>
-                <a:ea typeface="Arial" pitchFamily="34" charset="-122"/>
-                <a:cs typeface="Arial" pitchFamily="34" charset="-120"/>
-              </a:rPr>
-              <a:t>Intel · AMD · Apple · Qualcomm</a:t>
-            </a:r>
-            <a:endParaRPr lang="en-US" sz="750" dirty="0"/>
-          </a:p>
-        </p:txBody>
-      </p:sp>
-      <p:sp>
-        <p:nvSpPr>
-          <p:cNvPr id="40" name="Shape 38"/>
-          <p:cNvSpPr/>
-          <p:nvPr/>
-        </p:nvSpPr>
-        <p:spPr>
-          <a:xfrm>
-            <a:off x="457200" y="3813048"/>
-            <a:ext cx="2651760" cy="1371600"/>
-          </a:xfrm>
-          <a:prstGeom prst="rect">
-            <a:avLst/>
-          </a:prstGeom>
-          <a:solidFill>
-            <a:srgbClr val="F9F9F9"/>
-          </a:solidFill>
-          <a:ln w="6350">
-            <a:solidFill>
-              <a:srgbClr val="E5E5E5"/>
-            </a:solidFill>
-            <a:prstDash val="solid"/>
-          </a:ln>
-        </p:spPr>
-      </p:sp>
-      <p:sp>
-        <p:nvSpPr>
-          <p:cNvPr id="41" name="Shape 39"/>
-          <p:cNvSpPr/>
-          <p:nvPr/>
-        </p:nvSpPr>
-        <p:spPr>
-          <a:xfrm>
-            <a:off x="457200" y="3813048"/>
-            <a:ext cx="2651760" cy="274320"/>
-          </a:xfrm>
-          <a:prstGeom prst="rect">
-            <a:avLst/>
-          </a:prstGeom>
-          <a:solidFill>
-            <a:srgbClr val="051A3D"/>
-          </a:solidFill>
-          <a:ln w="12700">
-            <a:solidFill>
-              <a:srgbClr val="051A3D"/>
-            </a:solidFill>
-            <a:prstDash val="solid"/>
-          </a:ln>
-        </p:spPr>
-      </p:sp>
-      <p:sp>
-        <p:nvSpPr>
-          <p:cNvPr id="42" name="Text 40"/>
-          <p:cNvSpPr/>
-          <p:nvPr/>
-        </p:nvSpPr>
-        <p:spPr>
-          <a:xfrm>
-            <a:off x="457200" y="3813048"/>
-            <a:ext cx="2651760" cy="274320"/>
-          </a:xfrm>
-          <a:prstGeom prst="rect">
-            <a:avLst/>
-          </a:prstGeom>
-          <a:noFill/>
-          <a:ln/>
-        </p:spPr>
-        <p:txBody>
-          <a:bodyPr wrap="square" lIns="0" tIns="0" rIns="0" bIns="0" rtlCol="0" anchor="ctr"/>
-          <a:lstStyle/>
-          <a:p>
-            <a:pPr algn="ctr" indent="0" marL="0">
-              <a:buNone/>
-            </a:pPr>
-            <a:r>
-              <a:rPr lang="en-US" sz="1000" b="1" spc="200" kern="0" dirty="0">
-                <a:solidFill>
-                  <a:srgbClr val="FFFFFF"/>
-                </a:solidFill>
-                <a:latin typeface="Arial" pitchFamily="34" charset="0"/>
-                <a:ea typeface="Arial" pitchFamily="34" charset="-122"/>
-                <a:cs typeface="Arial" pitchFamily="34" charset="-120"/>
-              </a:rPr>
-              <a:t>ANALOG</a:t>
-            </a:r>
-            <a:endParaRPr lang="en-US" sz="1000" dirty="0"/>
-          </a:p>
-        </p:txBody>
-      </p:sp>
-      <p:sp>
-        <p:nvSpPr>
-          <p:cNvPr id="43" name="Text 41"/>
-          <p:cNvSpPr/>
-          <p:nvPr/>
-        </p:nvSpPr>
-        <p:spPr>
-          <a:xfrm>
-            <a:off x="594360" y="4160520"/>
-            <a:ext cx="2377440" cy="475488"/>
-          </a:xfrm>
-          <a:prstGeom prst="rect">
-            <a:avLst/>
-          </a:prstGeom>
-          <a:noFill/>
-          <a:ln/>
-        </p:spPr>
-        <p:txBody>
-          <a:bodyPr wrap="square" lIns="0" tIns="0" rIns="0" bIns="0" rtlCol="0" anchor="t"/>
-          <a:lstStyle/>
-          <a:p>
-            <a:pPr indent="0" marL="0">
-              <a:buNone/>
-            </a:pPr>
-            <a:r>
-              <a:rPr lang="en-US" sz="1000" dirty="0">
-                <a:solidFill>
-                  <a:srgbClr val="333333"/>
-                </a:solidFill>
-                <a:latin typeface="Arial" pitchFamily="34" charset="0"/>
-                <a:ea typeface="Arial" pitchFamily="34" charset="-122"/>
-                <a:cs typeface="Arial" pitchFamily="34" charset="-120"/>
-              </a:rPr>
-              <a:t>The bridge between silicon and the real world — voltages, signals, RF.</a:t>
-            </a:r>
-            <a:endParaRPr lang="en-US" sz="1000" dirty="0"/>
-          </a:p>
-        </p:txBody>
-      </p:sp>
-      <p:sp>
-        <p:nvSpPr>
-          <p:cNvPr id="44" name="Text 42"/>
-          <p:cNvSpPr/>
-          <p:nvPr/>
-        </p:nvSpPr>
-        <p:spPr>
-          <a:xfrm>
-            <a:off x="594360" y="4654296"/>
-            <a:ext cx="2377440" cy="256032"/>
-          </a:xfrm>
-          <a:prstGeom prst="rect">
-            <a:avLst/>
-          </a:prstGeom>
-          <a:noFill/>
-          <a:ln/>
-        </p:spPr>
-        <p:txBody>
-          <a:bodyPr wrap="square" lIns="0" tIns="0" rIns="0" bIns="0" rtlCol="0" anchor="t"/>
-          <a:lstStyle/>
-          <a:p>
-            <a:pPr indent="0" marL="0">
-              <a:buNone/>
-            </a:pPr>
-            <a:r>
-              <a:rPr lang="en-US" sz="900" i="1" dirty="0">
-                <a:solidFill>
-                  <a:srgbClr val="666666"/>
-                </a:solidFill>
-                <a:latin typeface="Arial" pitchFamily="34" charset="0"/>
-                <a:ea typeface="Arial" pitchFamily="34" charset="-122"/>
-                <a:cs typeface="Arial" pitchFamily="34" charset="-120"/>
-              </a:rPr>
-              <a:t>Power management, radio, audio</a:t>
-            </a:r>
-            <a:endParaRPr lang="en-US" sz="900" dirty="0"/>
-          </a:p>
-        </p:txBody>
-      </p:sp>
-      <p:sp>
-        <p:nvSpPr>
-          <p:cNvPr id="45" name="Shape 43"/>
-          <p:cNvSpPr/>
-          <p:nvPr/>
-        </p:nvSpPr>
-        <p:spPr>
-          <a:xfrm>
-            <a:off x="640080" y="4928616"/>
-            <a:ext cx="2286000" cy="0"/>
-          </a:xfrm>
-          <a:prstGeom prst="line">
-            <a:avLst/>
-          </a:prstGeom>
-          <a:noFill/>
-          <a:ln w="6350">
-            <a:solidFill>
-              <a:srgbClr val="E5E5E5"/>
-            </a:solidFill>
-            <a:prstDash val="solid"/>
-          </a:ln>
-        </p:spPr>
-      </p:sp>
-      <p:sp>
-        <p:nvSpPr>
-          <p:cNvPr id="46" name="Text 44"/>
-          <p:cNvSpPr/>
-          <p:nvPr/>
-        </p:nvSpPr>
-        <p:spPr>
-          <a:xfrm>
-            <a:off x="457200" y="4946904"/>
-            <a:ext cx="2651760" cy="201168"/>
-          </a:xfrm>
-          <a:prstGeom prst="rect">
-            <a:avLst/>
-          </a:prstGeom>
-          <a:noFill/>
-          <a:ln/>
-        </p:spPr>
-        <p:txBody>
-          <a:bodyPr wrap="square" lIns="0" tIns="0" rIns="0" bIns="0" rtlCol="0" anchor="ctr"/>
-          <a:lstStyle/>
-          <a:p>
-            <a:pPr algn="ctr" indent="0" marL="0">
-              <a:buNone/>
-            </a:pPr>
-            <a:r>
-              <a:rPr lang="en-US" sz="750" i="1" dirty="0">
-                <a:solidFill>
-                  <a:srgbClr val="666666"/>
-                </a:solidFill>
-                <a:latin typeface="Arial" pitchFamily="34" charset="0"/>
-                <a:ea typeface="Arial" pitchFamily="34" charset="-122"/>
-                <a:cs typeface="Arial" pitchFamily="34" charset="-120"/>
-              </a:rPr>
-              <a:t>TI · Analog Devices · Infineon</a:t>
-            </a:r>
-            <a:endParaRPr lang="en-US" sz="750" dirty="0"/>
-          </a:p>
-        </p:txBody>
-      </p:sp>
-      <p:sp>
-        <p:nvSpPr>
-          <p:cNvPr id="47" name="Shape 45"/>
-          <p:cNvSpPr/>
-          <p:nvPr/>
-        </p:nvSpPr>
-        <p:spPr>
-          <a:xfrm>
-            <a:off x="3246120" y="3813048"/>
-            <a:ext cx="2651760" cy="1371600"/>
-          </a:xfrm>
-          <a:prstGeom prst="rect">
-            <a:avLst/>
-          </a:prstGeom>
-          <a:solidFill>
-            <a:srgbClr val="F9F9F9"/>
-          </a:solidFill>
-          <a:ln w="6350">
-            <a:solidFill>
-              <a:srgbClr val="E5E5E5"/>
-            </a:solidFill>
-            <a:prstDash val="solid"/>
-          </a:ln>
-        </p:spPr>
-      </p:sp>
-      <p:sp>
-        <p:nvSpPr>
-          <p:cNvPr id="48" name="Shape 46"/>
-          <p:cNvSpPr/>
-          <p:nvPr/>
-        </p:nvSpPr>
-        <p:spPr>
-          <a:xfrm>
-            <a:off x="3246120" y="3813048"/>
-            <a:ext cx="2651760" cy="274320"/>
-          </a:xfrm>
-          <a:prstGeom prst="rect">
-            <a:avLst/>
-          </a:prstGeom>
-          <a:solidFill>
-            <a:srgbClr val="00A854"/>
-          </a:solidFill>
-          <a:ln w="12700">
-            <a:solidFill>
-              <a:srgbClr val="00A854"/>
-            </a:solidFill>
-            <a:prstDash val="solid"/>
-          </a:ln>
-        </p:spPr>
-      </p:sp>
-      <p:sp>
-        <p:nvSpPr>
-          <p:cNvPr id="49" name="Text 47"/>
-          <p:cNvSpPr/>
-          <p:nvPr/>
-        </p:nvSpPr>
-        <p:spPr>
-          <a:xfrm>
-            <a:off x="3246120" y="3813048"/>
-            <a:ext cx="2651760" cy="274320"/>
-          </a:xfrm>
-          <a:prstGeom prst="rect">
-            <a:avLst/>
-          </a:prstGeom>
-          <a:noFill/>
-          <a:ln/>
-        </p:spPr>
-        <p:txBody>
-          <a:bodyPr wrap="square" lIns="0" tIns="0" rIns="0" bIns="0" rtlCol="0" anchor="ctr"/>
-          <a:lstStyle/>
-          <a:p>
-            <a:pPr algn="ctr" indent="0" marL="0">
-              <a:buNone/>
-            </a:pPr>
-            <a:r>
-              <a:rPr lang="en-US" sz="1000" b="1" spc="200" kern="0" dirty="0">
-                <a:solidFill>
-                  <a:srgbClr val="FFFFFF"/>
-                </a:solidFill>
-                <a:latin typeface="Arial" pitchFamily="34" charset="0"/>
-                <a:ea typeface="Arial" pitchFamily="34" charset="-122"/>
-                <a:cs typeface="Arial" pitchFamily="34" charset="-120"/>
-              </a:rPr>
-              <a:t>SENSORS + OPTO</a:t>
-            </a:r>
-            <a:endParaRPr lang="en-US" sz="1000" dirty="0"/>
-          </a:p>
-        </p:txBody>
-      </p:sp>
-      <p:sp>
-        <p:nvSpPr>
-          <p:cNvPr id="50" name="Text 48"/>
-          <p:cNvSpPr/>
-          <p:nvPr/>
-        </p:nvSpPr>
-        <p:spPr>
-          <a:xfrm>
-            <a:off x="3383280" y="4160520"/>
-            <a:ext cx="2377440" cy="475488"/>
-          </a:xfrm>
-          <a:prstGeom prst="rect">
-            <a:avLst/>
-          </a:prstGeom>
-          <a:noFill/>
-          <a:ln/>
-        </p:spPr>
-        <p:txBody>
-          <a:bodyPr wrap="square" lIns="0" tIns="0" rIns="0" bIns="0" rtlCol="0" anchor="t"/>
-          <a:lstStyle/>
-          <a:p>
-            <a:pPr indent="0" marL="0">
-              <a:buNone/>
-            </a:pPr>
-            <a:r>
-              <a:rPr lang="en-US" sz="1000" dirty="0">
-                <a:solidFill>
-                  <a:srgbClr val="333333"/>
-                </a:solidFill>
-                <a:latin typeface="Arial" pitchFamily="34" charset="0"/>
-                <a:ea typeface="Arial" pitchFamily="34" charset="-122"/>
-                <a:cs typeface="Arial" pitchFamily="34" charset="-120"/>
-              </a:rPr>
-              <a:t>How chips see, hear, and communicate with photons.</a:t>
-            </a:r>
-            <a:endParaRPr lang="en-US" sz="1000" dirty="0"/>
-          </a:p>
-        </p:txBody>
-      </p:sp>
-      <p:sp>
-        <p:nvSpPr>
-          <p:cNvPr id="51" name="Text 49"/>
-          <p:cNvSpPr/>
-          <p:nvPr/>
-        </p:nvSpPr>
-        <p:spPr>
-          <a:xfrm>
-            <a:off x="3383280" y="4654296"/>
-            <a:ext cx="2377440" cy="256032"/>
-          </a:xfrm>
-          <a:prstGeom prst="rect">
-            <a:avLst/>
-          </a:prstGeom>
-          <a:noFill/>
-          <a:ln/>
-        </p:spPr>
-        <p:txBody>
-          <a:bodyPr wrap="square" lIns="0" tIns="0" rIns="0" bIns="0" rtlCol="0" anchor="t"/>
-          <a:lstStyle/>
-          <a:p>
-            <a:pPr indent="0" marL="0">
-              <a:buNone/>
-            </a:pPr>
-            <a:r>
-              <a:rPr lang="en-US" sz="900" i="1" dirty="0">
-                <a:solidFill>
-                  <a:srgbClr val="666666"/>
-                </a:solidFill>
-                <a:latin typeface="Arial" pitchFamily="34" charset="0"/>
-                <a:ea typeface="Arial" pitchFamily="34" charset="-122"/>
-                <a:cs typeface="Arial" pitchFamily="34" charset="-120"/>
-              </a:rPr>
-              <a:t>Phone cameras, lidar, fiber optics</a:t>
-            </a:r>
-            <a:endParaRPr lang="en-US" sz="900" dirty="0"/>
-          </a:p>
-        </p:txBody>
-      </p:sp>
-      <p:sp>
-        <p:nvSpPr>
-          <p:cNvPr id="52" name="Shape 50"/>
-          <p:cNvSpPr/>
-          <p:nvPr/>
-        </p:nvSpPr>
-        <p:spPr>
-          <a:xfrm>
-            <a:off x="3429000" y="4928616"/>
-            <a:ext cx="2286000" cy="0"/>
-          </a:xfrm>
-          <a:prstGeom prst="line">
-            <a:avLst/>
-          </a:prstGeom>
-          <a:noFill/>
-          <a:ln w="6350">
-            <a:solidFill>
-              <a:srgbClr val="E5E5E5"/>
-            </a:solidFill>
-            <a:prstDash val="solid"/>
-          </a:ln>
-        </p:spPr>
-      </p:sp>
-      <p:sp>
-        <p:nvSpPr>
-          <p:cNvPr id="53" name="Text 51"/>
-          <p:cNvSpPr/>
-          <p:nvPr/>
-        </p:nvSpPr>
-        <p:spPr>
-          <a:xfrm>
-            <a:off x="3246120" y="4946904"/>
-            <a:ext cx="2651760" cy="201168"/>
-          </a:xfrm>
-          <a:prstGeom prst="rect">
-            <a:avLst/>
-          </a:prstGeom>
-          <a:noFill/>
-          <a:ln/>
-        </p:spPr>
-        <p:txBody>
-          <a:bodyPr wrap="square" lIns="0" tIns="0" rIns="0" bIns="0" rtlCol="0" anchor="ctr"/>
-          <a:lstStyle/>
-          <a:p>
-            <a:pPr algn="ctr" indent="0" marL="0">
-              <a:buNone/>
-            </a:pPr>
-            <a:r>
-              <a:rPr lang="en-US" sz="750" i="1" dirty="0">
-                <a:solidFill>
-                  <a:srgbClr val="666666"/>
-                </a:solidFill>
-                <a:latin typeface="Arial" pitchFamily="34" charset="0"/>
-                <a:ea typeface="Arial" pitchFamily="34" charset="-122"/>
-                <a:cs typeface="Arial" pitchFamily="34" charset="-120"/>
-              </a:rPr>
-              <a:t>Sony · Samsung · STMicro</a:t>
-            </a:r>
-            <a:endParaRPr lang="en-US" sz="750" dirty="0"/>
-          </a:p>
-        </p:txBody>
-      </p:sp>
-      <p:sp>
-        <p:nvSpPr>
-          <p:cNvPr id="54" name="Shape 52"/>
-          <p:cNvSpPr/>
-          <p:nvPr/>
-        </p:nvSpPr>
-        <p:spPr>
-          <a:xfrm>
-            <a:off x="6035040" y="3813048"/>
-            <a:ext cx="2651760" cy="1371600"/>
-          </a:xfrm>
-          <a:prstGeom prst="rect">
-            <a:avLst/>
-          </a:prstGeom>
-          <a:solidFill>
-            <a:srgbClr val="F9F9F9"/>
-          </a:solidFill>
-          <a:ln w="6350">
-            <a:solidFill>
-              <a:srgbClr val="E5E5E5"/>
-            </a:solidFill>
-            <a:prstDash val="solid"/>
-          </a:ln>
-        </p:spPr>
-      </p:sp>
-      <p:sp>
-        <p:nvSpPr>
-          <p:cNvPr id="55" name="Shape 53"/>
-          <p:cNvSpPr/>
-          <p:nvPr/>
-        </p:nvSpPr>
-        <p:spPr>
-          <a:xfrm>
-            <a:off x="6035040" y="3813048"/>
-            <a:ext cx="2651760" cy="274320"/>
-          </a:xfrm>
-          <a:prstGeom prst="rect">
-            <a:avLst/>
-          </a:prstGeom>
-          <a:solidFill>
-            <a:srgbClr val="666666"/>
-          </a:solidFill>
-          <a:ln w="12700">
-            <a:solidFill>
-              <a:srgbClr val="666666"/>
-            </a:solidFill>
-            <a:prstDash val="solid"/>
-          </a:ln>
-        </p:spPr>
-      </p:sp>
-      <p:sp>
-        <p:nvSpPr>
-          <p:cNvPr id="56" name="Text 54"/>
-          <p:cNvSpPr/>
-          <p:nvPr/>
-        </p:nvSpPr>
-        <p:spPr>
-          <a:xfrm>
-            <a:off x="6035040" y="3813048"/>
-            <a:ext cx="2651760" cy="274320"/>
-          </a:xfrm>
-          <a:prstGeom prst="rect">
-            <a:avLst/>
-          </a:prstGeom>
-          <a:noFill/>
-          <a:ln/>
-        </p:spPr>
-        <p:txBody>
-          <a:bodyPr wrap="square" lIns="0" tIns="0" rIns="0" bIns="0" rtlCol="0" anchor="ctr"/>
-          <a:lstStyle/>
-          <a:p>
-            <a:pPr algn="ctr" indent="0" marL="0">
-              <a:buNone/>
-            </a:pPr>
-            <a:r>
-              <a:rPr lang="en-US" sz="1000" b="1" spc="200" kern="0" dirty="0">
-                <a:solidFill>
-                  <a:srgbClr val="FFFFFF"/>
-                </a:solidFill>
-                <a:latin typeface="Arial" pitchFamily="34" charset="0"/>
-                <a:ea typeface="Arial" pitchFamily="34" charset="-122"/>
-                <a:cs typeface="Arial" pitchFamily="34" charset="-120"/>
-              </a:rPr>
-              <a:t>DISCRETE + POWER</a:t>
-            </a:r>
-            <a:endParaRPr lang="en-US" sz="1000" dirty="0"/>
-          </a:p>
-        </p:txBody>
-      </p:sp>
-      <p:sp>
-        <p:nvSpPr>
-          <p:cNvPr id="57" name="Text 55"/>
-          <p:cNvSpPr/>
-          <p:nvPr/>
-        </p:nvSpPr>
-        <p:spPr>
-          <a:xfrm>
-            <a:off x="6172200" y="4160520"/>
-            <a:ext cx="2377440" cy="475488"/>
-          </a:xfrm>
-          <a:prstGeom prst="rect">
-            <a:avLst/>
-          </a:prstGeom>
-          <a:noFill/>
-          <a:ln/>
-        </p:spPr>
-        <p:txBody>
-          <a:bodyPr wrap="square" lIns="0" tIns="0" rIns="0" bIns="0" rtlCol="0" anchor="t"/>
-          <a:lstStyle/>
-          <a:p>
-            <a:pPr indent="0" marL="0">
-              <a:buNone/>
-            </a:pPr>
-            <a:r>
-              <a:rPr lang="en-US" sz="1000" dirty="0">
-                <a:solidFill>
-                  <a:srgbClr val="333333"/>
-                </a:solidFill>
-                <a:latin typeface="Arial" pitchFamily="34" charset="0"/>
-                <a:ea typeface="Arial" pitchFamily="34" charset="-122"/>
-                <a:cs typeface="Arial" pitchFamily="34" charset="-120"/>
-              </a:rPr>
-              <a:t>Heavy-current switching for machines, grids, and vehicles.</a:t>
-            </a:r>
-            <a:endParaRPr lang="en-US" sz="1000" dirty="0"/>
-          </a:p>
-        </p:txBody>
-      </p:sp>
-      <p:sp>
-        <p:nvSpPr>
-          <p:cNvPr id="58" name="Text 56"/>
-          <p:cNvSpPr/>
-          <p:nvPr/>
-        </p:nvSpPr>
-        <p:spPr>
-          <a:xfrm>
-            <a:off x="6172200" y="4654296"/>
-            <a:ext cx="2377440" cy="256032"/>
-          </a:xfrm>
-          <a:prstGeom prst="rect">
-            <a:avLst/>
-          </a:prstGeom>
-          <a:noFill/>
-          <a:ln/>
-        </p:spPr>
-        <p:txBody>
-          <a:bodyPr wrap="square" lIns="0" tIns="0" rIns="0" bIns="0" rtlCol="0" anchor="t"/>
-          <a:lstStyle/>
-          <a:p>
-            <a:pPr indent="0" marL="0">
-              <a:buNone/>
-            </a:pPr>
-            <a:r>
-              <a:rPr lang="en-US" sz="900" i="1" dirty="0">
-                <a:solidFill>
-                  <a:srgbClr val="666666"/>
-                </a:solidFill>
-                <a:latin typeface="Arial" pitchFamily="34" charset="0"/>
-                <a:ea typeface="Arial" pitchFamily="34" charset="-122"/>
-                <a:cs typeface="Arial" pitchFamily="34" charset="-120"/>
-              </a:rPr>
-              <a:t>EVs, industrial motors, chargers</a:t>
-            </a:r>
-            <a:endParaRPr lang="en-US" sz="900" dirty="0"/>
-          </a:p>
-        </p:txBody>
-      </p:sp>
-      <p:sp>
-        <p:nvSpPr>
-          <p:cNvPr id="59" name="Shape 57"/>
-          <p:cNvSpPr/>
-          <p:nvPr/>
-        </p:nvSpPr>
-        <p:spPr>
-          <a:xfrm>
-            <a:off x="6217920" y="4928616"/>
-            <a:ext cx="2286000" cy="0"/>
-          </a:xfrm>
-          <a:prstGeom prst="line">
-            <a:avLst/>
-          </a:prstGeom>
-          <a:noFill/>
-          <a:ln w="6350">
-            <a:solidFill>
-              <a:srgbClr val="E5E5E5"/>
-            </a:solidFill>
-            <a:prstDash val="solid"/>
-          </a:ln>
-        </p:spPr>
-      </p:sp>
-      <p:sp>
-        <p:nvSpPr>
-          <p:cNvPr id="60" name="Text 58"/>
-          <p:cNvSpPr/>
-          <p:nvPr/>
-        </p:nvSpPr>
-        <p:spPr>
-          <a:xfrm>
-            <a:off x="6035040" y="4946904"/>
-            <a:ext cx="2651760" cy="201168"/>
-          </a:xfrm>
-          <a:prstGeom prst="rect">
-            <a:avLst/>
-          </a:prstGeom>
-          <a:noFill/>
-          <a:ln/>
-        </p:spPr>
-        <p:txBody>
-          <a:bodyPr wrap="square" lIns="0" tIns="0" rIns="0" bIns="0" rtlCol="0" anchor="ctr"/>
-          <a:lstStyle/>
-          <a:p>
-            <a:pPr algn="ctr" indent="0" marL="0">
-              <a:buNone/>
-            </a:pPr>
-            <a:r>
-              <a:rPr lang="en-US" sz="750" i="1" dirty="0">
-                <a:solidFill>
-                  <a:srgbClr val="666666"/>
-                </a:solidFill>
-                <a:latin typeface="Arial" pitchFamily="34" charset="0"/>
-                <a:ea typeface="Arial" pitchFamily="34" charset="-122"/>
-                <a:cs typeface="Arial" pitchFamily="34" charset="-120"/>
-              </a:rPr>
-              <a:t>Infineon · ON Semi · Wolfspeed</a:t>
-            </a:r>
-            <a:endParaRPr lang="en-US" sz="750" dirty="0"/>
-          </a:p>
-        </p:txBody>
-      </p:sp>
-      <p:sp>
-        <p:nvSpPr>
-          <p:cNvPr id="61" name="Shape 59"/>
-          <p:cNvSpPr/>
-          <p:nvPr/>
-        </p:nvSpPr>
-        <p:spPr>
-          <a:xfrm>
-            <a:off x="457200" y="5257800"/>
-            <a:ext cx="8229600" cy="411480"/>
+          <p:cNvPr id="73" name="Shape 71"/>
+          <p:cNvSpPr/>
+          <p:nvPr/>
+        </p:nvSpPr>
+        <p:spPr>
+          <a:xfrm>
+            <a:off x="457200" y="5285232"/>
+            <a:ext cx="8229600" cy="402336"/>
           </a:xfrm>
           <a:prstGeom prst="rect">
             <a:avLst/>
@@ -35007,14 +35403,14 @@
       </p:sp>
       <p:sp>
         <p:nvSpPr>
-          <p:cNvPr id="62" name="Text 60"/>
-          <p:cNvSpPr/>
-          <p:nvPr/>
-        </p:nvSpPr>
-        <p:spPr>
-          <a:xfrm>
-            <a:off x="640080" y="5257800"/>
-            <a:ext cx="7863840" cy="411480"/>
+          <p:cNvPr id="74" name="Text 72"/>
+          <p:cNvSpPr/>
+          <p:nvPr/>
+        </p:nvSpPr>
+        <p:spPr>
+          <a:xfrm>
+            <a:off x="640080" y="5285232"/>
+            <a:ext cx="7863840" cy="402336"/>
           </a:xfrm>
           <a:prstGeom prst="rect">
             <a:avLst/>
@@ -35030,7 +35426,7 @@
               <a:buNone/>
             </a:pPr>
             <a:r>
-              <a:rPr lang="en-US" sz="1200" b="1" dirty="0">
+              <a:rPr lang="en-US" sz="1150" b="1" dirty="0">
                 <a:solidFill>
                   <a:srgbClr val="000000"/>
                 </a:solidFill>
@@ -35038,15 +35434,15 @@
                 <a:ea typeface="Arial" pitchFamily="34" charset="-122"/>
                 <a:cs typeface="Arial" pitchFamily="34" charset="-120"/>
               </a:rPr>
-              <a:t>Logic and memory are the only two categories where AI capex concentrates — the rest of silicon serves the rest of the economy.</a:t>
-            </a:r>
-            <a:endParaRPr lang="en-US" sz="1200" dirty="0"/>
-          </a:p>
-        </p:txBody>
-      </p:sp>
-      <p:sp>
-        <p:nvSpPr>
-          <p:cNvPr id="63" name="Text 61"/>
+              <a:t>Logic and memory absorb the AI capex — but every chip flows through ASML tools, TSMC fabs, and advanced packaging, where bottlenecks decide who ships.</a:t>
+            </a:r>
+            <a:endParaRPr lang="en-US" sz="1150" dirty="0"/>
+          </a:p>
+        </p:txBody>
+      </p:sp>
+      <p:sp>
+        <p:nvSpPr>
+          <p:cNvPr id="75" name="Text 73"/>
           <p:cNvSpPr/>
           <p:nvPr/>
         </p:nvSpPr>
@@ -35077,7 +35473,7 @@
                 <a:ea typeface="Arial" pitchFamily="34" charset="-122"/>
                 <a:cs typeface="Arial" pitchFamily="34" charset="-120"/>
               </a:rPr>
-              <a:t>Sources: SIA category taxonomy; WSTS Fall 2025 forecast for market-size context. Category descriptions are plain-English simplifications.</a:t>
+              <a:t>Sources: SIA category taxonomy; WSTS Fall 2025; SEMI World Fab Forecast; TrendForce; company disclosures. Category descriptions are plain-English simplifications.</a:t>
             </a:r>
             <a:endParaRPr lang="en-US" sz="700" dirty="0"/>
           </a:p>
@@ -35085,7 +35481,7 @@
       </p:sp>
       <p:sp>
         <p:nvSpPr>
-          <p:cNvPr id="64" name="Shape 62"/>
+          <p:cNvPr id="76" name="Shape 74"/>
           <p:cNvSpPr/>
           <p:nvPr/>
         </p:nvSpPr>
@@ -35110,7 +35506,7 @@
       </p:sp>
       <p:sp>
         <p:nvSpPr>
-          <p:cNvPr id="65" name="Text 63"/>
+          <p:cNvPr id="77" name="Text 75"/>
           <p:cNvSpPr/>
           <p:nvPr/>
         </p:nvSpPr>
@@ -35149,7 +35545,7 @@
       </p:sp>
       <p:sp>
         <p:nvSpPr>
-          <p:cNvPr id="66" name="Text 64"/>
+          <p:cNvPr id="78" name="Text 76"/>
           <p:cNvSpPr/>
           <p:nvPr/>
         </p:nvSpPr>

</xml_diff>

<commit_message>
Fix slide 13 chart title clip; loosen slide 18 card title spacing
Slide 13: the YTD-chart title was at y=1.7 so its underline landed at
y=2.0, clipping into the chart top at y=1.9. Moved the title back to
y=1.55 and nudged the chart down to y=1.95 so the underline sits
cleanly above the plot area.

Slide 18: the three card titles on the left column hugged the dark
header bar's left edge. Doubled left padding (margin 0.15 to 0.30)
and bumped charSpacing from 2 to 3 for breathing room, then shifted
the card body text x from 0.65 to 0.75 to stay visually aligned
with the more-indented title.

Co-Authored-By: Claude Opus 4.7 <noreply@anthropic.com>
</commit_message>
<xml_diff>
--- a/ai-markets-deck.pptx
+++ b/ai-markets-deck.pptx
@@ -10757,7 +10757,7 @@
         </p:nvSpPr>
         <p:spPr>
           <a:xfrm>
-            <a:off x="457200" y="1554480"/>
+            <a:off x="457200" y="1417320"/>
             <a:ext cx="3931920" cy="274320"/>
           </a:xfrm>
           <a:prstGeom prst="rect">
@@ -10796,7 +10796,7 @@
         </p:nvSpPr>
         <p:spPr>
           <a:xfrm>
-            <a:off x="457200" y="1828800"/>
+            <a:off x="457200" y="1691640"/>
             <a:ext cx="3931920" cy="0"/>
           </a:xfrm>
           <a:prstGeom prst="line">
@@ -10818,7 +10818,7 @@
           <p:nvPr/>
         </p:nvGraphicFramePr>
         <p:xfrm>
-          <a:off x="457200" y="1737360"/>
+          <a:off x="457200" y="1783080"/>
           <a:ext cx="3931920" cy="3429000"/>
         </p:xfrm>
         <a:graphic xmlns:a="http://schemas.openxmlformats.org/drawingml/2006/main">
@@ -17199,14 +17199,14 @@
           <a:ln/>
         </p:spPr>
         <p:txBody>
-          <a:bodyPr wrap="square" lIns="1905" tIns="1905" rIns="1905" bIns="1905" rtlCol="0" anchor="ctr"/>
+          <a:bodyPr wrap="square" lIns="3810" tIns="3810" rIns="3810" bIns="3810" rtlCol="0" anchor="ctr"/>
           <a:lstStyle/>
           <a:p>
             <a:pPr algn="l" indent="0" marL="0">
               <a:buNone/>
             </a:pPr>
             <a:r>
-              <a:rPr lang="en-US" sz="1100" b="1" spc="200" kern="0" dirty="0">
+              <a:rPr lang="en-US" sz="1100" b="1" spc="300" kern="0" dirty="0">
                 <a:solidFill>
                   <a:srgbClr val="FFFFFF"/>
                 </a:solidFill>
@@ -17253,8 +17253,8 @@
         </p:nvSpPr>
         <p:spPr>
           <a:xfrm>
-            <a:off x="594360" y="1828800"/>
-            <a:ext cx="4434840" cy="658368"/>
+            <a:off x="685800" y="1828800"/>
+            <a:ext cx="4343400" cy="658368"/>
           </a:xfrm>
           <a:prstGeom prst="rect">
             <a:avLst/>
@@ -17327,14 +17327,14 @@
           <a:ln/>
         </p:spPr>
         <p:txBody>
-          <a:bodyPr wrap="square" lIns="1905" tIns="1905" rIns="1905" bIns="1905" rtlCol="0" anchor="ctr"/>
+          <a:bodyPr wrap="square" lIns="3810" tIns="3810" rIns="3810" bIns="3810" rtlCol="0" anchor="ctr"/>
           <a:lstStyle/>
           <a:p>
             <a:pPr algn="l" indent="0" marL="0">
               <a:buNone/>
             </a:pPr>
             <a:r>
-              <a:rPr lang="en-US" sz="1100" b="1" spc="200" kern="0" dirty="0">
+              <a:rPr lang="en-US" sz="1100" b="1" spc="300" kern="0" dirty="0">
                 <a:solidFill>
                   <a:srgbClr val="FFFFFF"/>
                 </a:solidFill>
@@ -17381,8 +17381,8 @@
         </p:nvSpPr>
         <p:spPr>
           <a:xfrm>
-            <a:off x="594360" y="3017520"/>
-            <a:ext cx="4434840" cy="658368"/>
+            <a:off x="685800" y="3017520"/>
+            <a:ext cx="4343400" cy="658368"/>
           </a:xfrm>
           <a:prstGeom prst="rect">
             <a:avLst/>
@@ -17455,14 +17455,14 @@
           <a:ln/>
         </p:spPr>
         <p:txBody>
-          <a:bodyPr wrap="square" lIns="1905" tIns="1905" rIns="1905" bIns="1905" rtlCol="0" anchor="ctr"/>
+          <a:bodyPr wrap="square" lIns="3810" tIns="3810" rIns="3810" bIns="3810" rtlCol="0" anchor="ctr"/>
           <a:lstStyle/>
           <a:p>
             <a:pPr algn="l" indent="0" marL="0">
               <a:buNone/>
             </a:pPr>
             <a:r>
-              <a:rPr lang="en-US" sz="1100" b="1" spc="200" kern="0" dirty="0">
+              <a:rPr lang="en-US" sz="1100" b="1" spc="300" kern="0" dirty="0">
                 <a:solidFill>
                   <a:srgbClr val="FFFFFF"/>
                 </a:solidFill>
@@ -17509,8 +17509,8 @@
         </p:nvSpPr>
         <p:spPr>
           <a:xfrm>
-            <a:off x="594360" y="4206240"/>
-            <a:ext cx="4434840" cy="658368"/>
+            <a:off x="685800" y="4206240"/>
+            <a:ext cx="4343400" cy="658368"/>
           </a:xfrm>
           <a:prstGeom prst="rect">
             <a:avLst/>

</xml_diff>

<commit_message>
Slide 14: trim citation block — drop orange numerals, drop restated stats
- Citation numbers now gray bold (same 999999 as body) instead of orange
- Each citation keeps only the source attribution; the stat being cited is already
  visible next to its superscript marker above, so restating it was redundant
  e.g. "1  Cisco fwd P/E 131× (Mar 2000) — Harding Loevner retrospective."
       → "1  Harding Loevner retrospective."

Co-Authored-By: Claude Opus 4.7 <noreply@anthropic.com>
</commit_message>
<xml_diff>
--- a/ai-markets-deck.pptx
+++ b/ai-markets-deck.pptx
@@ -13052,7 +13052,7 @@
             <a:r>
               <a:rPr lang="en-US" sz="700" b="1" dirty="0">
                 <a:solidFill>
-                  <a:srgbClr val="F6693D"/>
+                  <a:srgbClr val="999999"/>
                 </a:solidFill>
                 <a:latin typeface="Arial" pitchFamily="34" charset="0"/>
                 <a:ea typeface="Arial" pitchFamily="34" charset="-122"/>
@@ -13075,7 +13075,7 @@
                 <a:ea typeface="Arial" pitchFamily="34" charset="-122"/>
                 <a:cs typeface="Arial" pitchFamily="34" charset="-120"/>
               </a:rPr>
-              <a:t>Cisco fwd P/E 131× (Mar 2000) — Harding Loevner retrospective.</a:t>
+              <a:t>Harding Loevner retrospective.</a:t>
             </a:r>
             <a:endParaRPr lang="en-US" sz="700" dirty="0"/>
           </a:p>
@@ -13089,7 +13089,7 @@
             <a:r>
               <a:rPr lang="en-US" sz="700" b="1" dirty="0">
                 <a:solidFill>
-                  <a:srgbClr val="F6693D"/>
+                  <a:srgbClr val="999999"/>
                 </a:solidFill>
                 <a:latin typeface="Arial" pitchFamily="34" charset="0"/>
                 <a:ea typeface="Arial" pitchFamily="34" charset="-122"/>
@@ -13112,7 +13112,7 @@
                 <a:ea typeface="Arial" pitchFamily="34" charset="-122"/>
                 <a:cs typeface="Arial" pitchFamily="34" charset="-120"/>
               </a:rPr>
-              <a:t>NVDA fwd P/E ~24× (Apr 17, 2026) — GuruFocus.</a:t>
+              <a:t>GuruFocus (Apr 17, 2026).</a:t>
             </a:r>
             <a:endParaRPr lang="en-US" sz="700" dirty="0"/>
           </a:p>
@@ -13126,7 +13126,7 @@
             <a:r>
               <a:rPr lang="en-US" sz="700" b="1" dirty="0">
                 <a:solidFill>
-                  <a:srgbClr val="F6693D"/>
+                  <a:srgbClr val="999999"/>
                 </a:solidFill>
                 <a:latin typeface="Arial" pitchFamily="34" charset="0"/>
                 <a:ea typeface="Arial" pitchFamily="34" charset="-122"/>
@@ -13149,7 +13149,7 @@
                 <a:ea typeface="Arial" pitchFamily="34" charset="-122"/>
                 <a:cs typeface="Arial" pitchFamily="34" charset="-120"/>
               </a:rPr>
-              <a:t>14% of tech IPOs profitable (2000) — Jay Ritter, Univ. of Florida IPO data.</a:t>
+              <a:t>Jay Ritter, Univ. of Florida IPO data.</a:t>
             </a:r>
             <a:endParaRPr lang="en-US" sz="700" dirty="0"/>
           </a:p>
@@ -13163,7 +13163,7 @@
             <a:r>
               <a:rPr lang="en-US" sz="700" b="1" dirty="0">
                 <a:solidFill>
-                  <a:srgbClr val="F6693D"/>
+                  <a:srgbClr val="999999"/>
                 </a:solidFill>
                 <a:latin typeface="Arial" pitchFamily="34" charset="0"/>
                 <a:ea typeface="Arial" pitchFamily="34" charset="-122"/>
@@ -13186,7 +13186,7 @@
                 <a:ea typeface="Arial" pitchFamily="34" charset="-122"/>
                 <a:cs typeface="Arial" pitchFamily="34" charset="-120"/>
               </a:rPr>
-              <a:t>Mag 7 avg net margin 26% (2× S&amp;P) — Bloomberg / company filings, 2025 TTM.</a:t>
+              <a:t>Bloomberg / company filings, 2025 TTM.</a:t>
             </a:r>
             <a:endParaRPr lang="en-US" sz="700" dirty="0"/>
           </a:p>
@@ -13222,7 +13222,7 @@
             <a:r>
               <a:rPr lang="en-US" sz="700" b="1" dirty="0">
                 <a:solidFill>
-                  <a:srgbClr val="F6693D"/>
+                  <a:srgbClr val="999999"/>
                 </a:solidFill>
                 <a:latin typeface="Arial" pitchFamily="34" charset="0"/>
                 <a:ea typeface="Arial" pitchFamily="34" charset="-122"/>
@@ -13245,7 +13245,7 @@
                 <a:ea typeface="Arial" pitchFamily="34" charset="-122"/>
                 <a:cs typeface="Arial" pitchFamily="34" charset="-120"/>
               </a:rPr>
-              <a:t>$500B dark fiber unused (2000 era) — FCC / industry retrospectives.</a:t>
+              <a:t>FCC / industry retrospectives.</a:t>
             </a:r>
             <a:endParaRPr lang="en-US" sz="700" dirty="0"/>
           </a:p>
@@ -13259,7 +13259,7 @@
             <a:r>
               <a:rPr lang="en-US" sz="700" b="1" dirty="0">
                 <a:solidFill>
-                  <a:srgbClr val="F6693D"/>
+                  <a:srgbClr val="999999"/>
                 </a:solidFill>
                 <a:latin typeface="Arial" pitchFamily="34" charset="0"/>
                 <a:ea typeface="Arial" pitchFamily="34" charset="-122"/>
@@ -13282,7 +13282,7 @@
                 <a:ea typeface="Arial" pitchFamily="34" charset="-122"/>
                 <a:cs typeface="Arial" pitchFamily="34" charset="-120"/>
               </a:rPr>
-              <a:t>GPU 2nd-market 90–95% of list — CoreWeave / 2nd-market trackers, 2026.</a:t>
+              <a:t>CoreWeave / 2nd-market trackers, 2026.</a:t>
             </a:r>
             <a:endParaRPr lang="en-US" sz="700" dirty="0"/>
           </a:p>
@@ -13296,7 +13296,7 @@
             <a:r>
               <a:rPr lang="en-US" sz="700" b="1" dirty="0">
                 <a:solidFill>
-                  <a:srgbClr val="F6693D"/>
+                  <a:srgbClr val="999999"/>
                 </a:solidFill>
                 <a:latin typeface="Arial" pitchFamily="34" charset="0"/>
                 <a:ea typeface="Arial" pitchFamily="34" charset="-122"/>
@@ -13319,7 +13319,7 @@
                 <a:ea typeface="Arial" pitchFamily="34" charset="-122"/>
                 <a:cs typeface="Arial" pitchFamily="34" charset="-120"/>
               </a:rPr>
-              <a:t>20+ major telcos bankrupt (2001–02) — public filings / press retrospectives.</a:t>
+              <a:t>Public filings / press retrospectives, 2001–02.</a:t>
             </a:r>
             <a:endParaRPr lang="en-US" sz="700" dirty="0"/>
           </a:p>
@@ -13333,7 +13333,7 @@
             <a:r>
               <a:rPr lang="en-US" sz="700" b="1" dirty="0">
                 <a:solidFill>
-                  <a:srgbClr val="F6693D"/>
+                  <a:srgbClr val="999999"/>
                 </a:solidFill>
                 <a:latin typeface="Arial" pitchFamily="34" charset="0"/>
                 <a:ea typeface="Arial" pitchFamily="34" charset="-122"/>
@@ -13356,7 +13356,7 @@
                 <a:ea typeface="Arial" pitchFamily="34" charset="-122"/>
                 <a:cs typeface="Arial" pitchFamily="34" charset="-120"/>
               </a:rPr>
-              <a:t>Hyperscaler net debt/EBITDA ~48% vs ~80% S&amp;P — Bloomberg, 2025 YE.</a:t>
+              <a:t>Bloomberg, 2025 YE.</a:t>
             </a:r>
             <a:endParaRPr lang="en-US" sz="700" dirty="0"/>
           </a:p>

</xml_diff>

<commit_message>
Slides 13/14/15/16: add numbered citations and inline `(N) Source` format
- Add superscript markers on every cited stat across slides 13, 14, 15, 16
  (4 / 8 / 4 / 12 markers respectively).
- Shared `addCitations` helper renders a single wrapped 7pt gray paragraph
  with bold `(N)` markers, comma-separated, ending with a period — replaces
  the earlier multi-column citation grids.
- Slide 13 redesigned: YTD chart + `+58 pts` hero stat, `+47%` / `-21%`
  driver tiles, PE/private-credit bleed demoted to italic footnote.
- Slide 14 banner retightened to y=5.55 to clear the inline citation row.
- Slide 15 stat + narrative markers; fab-status strip unchanged.
- Slide 16 body cards restored to h=3.8 now that inline citations only
  need ~0.5 of footer height.

Co-Authored-By: Claude Opus 4.7 <noreply@anthropic.com>
</commit_message>
<xml_diff>
--- a/ai-markets-deck.pptx
+++ b/ai-markets-deck.pptx
@@ -10926,6 +10926,20 @@
               </a:rPr>
               <a:t>+58 pts</a:t>
             </a:r>
+            <a:pPr algn="ctr" indent="0" marL="0">
+              <a:buNone/>
+            </a:pPr>
+            <a:r>
+              <a:rPr lang="en-US" sz="1800" baseline="30000" dirty="0">
+                <a:solidFill>
+                  <a:srgbClr val="F6693D"/>
+                </a:solidFill>
+                <a:latin typeface="Arial Black" pitchFamily="34" charset="0"/>
+                <a:ea typeface="Arial Black" pitchFamily="34" charset="-122"/>
+                <a:cs typeface="Arial Black" pitchFamily="34" charset="-120"/>
+              </a:rPr>
+              <a:t> 1</a:t>
+            </a:r>
             <a:endParaRPr lang="en-US" sz="5200" dirty="0"/>
           </a:p>
         </p:txBody>
@@ -11093,6 +11107,20 @@
               </a:rPr>
               <a:t>+47%</a:t>
             </a:r>
+            <a:pPr algn="ctr" indent="0" marL="0">
+              <a:buNone/>
+            </a:pPr>
+            <a:r>
+              <a:rPr lang="en-US" sz="1000" baseline="30000" dirty="0">
+                <a:solidFill>
+                  <a:srgbClr val="F6693D"/>
+                </a:solidFill>
+                <a:latin typeface="Arial Black" pitchFamily="34" charset="0"/>
+                <a:ea typeface="Arial Black" pitchFamily="34" charset="-122"/>
+                <a:cs typeface="Arial Black" pitchFamily="34" charset="-120"/>
+              </a:rPr>
+              <a:t> 2</a:t>
+            </a:r>
             <a:endParaRPr lang="en-US" sz="2800" dirty="0"/>
           </a:p>
         </p:txBody>
@@ -11299,6 +11327,20 @@
               </a:rPr>
               <a:t>−21%</a:t>
             </a:r>
+            <a:pPr algn="ctr" indent="0" marL="0">
+              <a:buNone/>
+            </a:pPr>
+            <a:r>
+              <a:rPr lang="en-US" sz="1000" baseline="30000" dirty="0">
+                <a:solidFill>
+                  <a:srgbClr val="CC0000"/>
+                </a:solidFill>
+                <a:latin typeface="Arial Black" pitchFamily="34" charset="0"/>
+                <a:ea typeface="Arial Black" pitchFamily="34" charset="-122"/>
+                <a:cs typeface="Arial Black" pitchFamily="34" charset="-120"/>
+              </a:rPr>
+              <a:t> 3</a:t>
+            </a:r>
             <a:endParaRPr lang="en-US" sz="2800" dirty="0"/>
           </a:p>
         </p:txBody>
@@ -11390,7 +11432,7 @@
         <p:spPr>
           <a:xfrm>
             <a:off x="457200" y="5349240"/>
-            <a:ext cx="8229600" cy="320040"/>
+            <a:ext cx="8229600" cy="274320"/>
           </a:xfrm>
           <a:prstGeom prst="rect">
             <a:avLst/>
@@ -11414,7 +11456,35 @@
                 <a:ea typeface="Arial" pitchFamily="34" charset="-122"/>
                 <a:cs typeface="Arial" pitchFamily="34" charset="-120"/>
               </a:rPr>
-              <a:t>BDC credit indices down ~5% YTD — early signs the sell-off is bleeding into private credit and PE-held SaaS.</a:t>
+              <a:t>BDC credit indices down ~5%</a:t>
+            </a:r>
+            <a:pPr algn="ctr" indent="0" marL="0">
+              <a:buNone/>
+            </a:pPr>
+            <a:r>
+              <a:rPr lang="en-US" sz="700" i="1" baseline="30000" dirty="0">
+                <a:solidFill>
+                  <a:srgbClr val="666666"/>
+                </a:solidFill>
+                <a:latin typeface="Arial" pitchFamily="34" charset="0"/>
+                <a:ea typeface="Arial" pitchFamily="34" charset="-122"/>
+                <a:cs typeface="Arial" pitchFamily="34" charset="-120"/>
+              </a:rPr>
+              <a:t> 4</a:t>
+            </a:r>
+            <a:pPr algn="ctr" indent="0" marL="0">
+              <a:buNone/>
+            </a:pPr>
+            <a:r>
+              <a:rPr lang="en-US" sz="950" i="1" dirty="0">
+                <a:solidFill>
+                  <a:srgbClr val="666666"/>
+                </a:solidFill>
+                <a:latin typeface="Arial" pitchFamily="34" charset="0"/>
+                <a:ea typeface="Arial" pitchFamily="34" charset="-122"/>
+                <a:cs typeface="Arial" pitchFamily="34" charset="-120"/>
+              </a:rPr>
+              <a:t> YTD — early signs the sell-off is bleeding into private credit and PE-held SaaS.</a:t>
             </a:r>
             <a:endParaRPr lang="en-US" sz="950" dirty="0"/>
           </a:p>
@@ -11429,7 +11499,7 @@
         <p:spPr>
           <a:xfrm>
             <a:off x="457200" y="5875020"/>
-            <a:ext cx="8229600" cy="320040"/>
+            <a:ext cx="8229600" cy="457200"/>
           </a:xfrm>
           <a:prstGeom prst="rect">
             <a:avLst/>
@@ -11445,6 +11515,20 @@
               <a:buNone/>
             </a:pPr>
             <a:r>
+              <a:rPr lang="en-US" sz="700" b="1" dirty="0">
+                <a:solidFill>
+                  <a:srgbClr val="999999"/>
+                </a:solidFill>
+                <a:latin typeface="Arial" pitchFamily="34" charset="0"/>
+                <a:ea typeface="Arial" pitchFamily="34" charset="-122"/>
+                <a:cs typeface="Arial" pitchFamily="34" charset="-120"/>
+              </a:rPr>
+              <a:t>(1) </a:t>
+            </a:r>
+            <a:pPr indent="0" marL="0">
+              <a:buNone/>
+            </a:pPr>
+            <a:r>
               <a:rPr lang="en-US" sz="700" dirty="0">
                 <a:solidFill>
                   <a:srgbClr val="999999"/>
@@ -11453,7 +11537,91 @@
                 <a:ea typeface="Arial" pitchFamily="34" charset="-122"/>
                 <a:cs typeface="Arial" pitchFamily="34" charset="-120"/>
               </a:rPr>
-              <a:t>Sources: Yahoo Finance YTD returns (Apr 17, 2026); TrendForce / DCD on HBM capacity; multiples.vc public software multiples (Apr 2026); VanEck BIZD; Morgan Stanley CIO Survey; PitchBook PE marks.</a:t>
+              <a:t>Yahoo Finance, Apr 17, 2026 (SOX, IGV), </a:t>
+            </a:r>
+            <a:pPr indent="0" marL="0">
+              <a:buNone/>
+            </a:pPr>
+            <a:r>
+              <a:rPr lang="en-US" sz="700" b="1" dirty="0">
+                <a:solidFill>
+                  <a:srgbClr val="999999"/>
+                </a:solidFill>
+                <a:latin typeface="Arial" pitchFamily="34" charset="0"/>
+                <a:ea typeface="Arial" pitchFamily="34" charset="-122"/>
+                <a:cs typeface="Arial" pitchFamily="34" charset="-120"/>
+              </a:rPr>
+              <a:t>(2) </a:t>
+            </a:r>
+            <a:pPr indent="0" marL="0">
+              <a:buNone/>
+            </a:pPr>
+            <a:r>
+              <a:rPr lang="en-US" sz="700" dirty="0">
+                <a:solidFill>
+                  <a:srgbClr val="999999"/>
+                </a:solidFill>
+                <a:latin typeface="Arial" pitchFamily="34" charset="0"/>
+                <a:ea typeface="Arial" pitchFamily="34" charset="-122"/>
+                <a:cs typeface="Arial" pitchFamily="34" charset="-120"/>
+              </a:rPr>
+              <a:t>TrendForce via Data Center Dynamics, 2026, </a:t>
+            </a:r>
+            <a:pPr indent="0" marL="0">
+              <a:buNone/>
+            </a:pPr>
+            <a:r>
+              <a:rPr lang="en-US" sz="700" b="1" dirty="0">
+                <a:solidFill>
+                  <a:srgbClr val="999999"/>
+                </a:solidFill>
+                <a:latin typeface="Arial" pitchFamily="34" charset="0"/>
+                <a:ea typeface="Arial" pitchFamily="34" charset="-122"/>
+                <a:cs typeface="Arial" pitchFamily="34" charset="-120"/>
+              </a:rPr>
+              <a:t>(3) </a:t>
+            </a:r>
+            <a:pPr indent="0" marL="0">
+              <a:buNone/>
+            </a:pPr>
+            <a:r>
+              <a:rPr lang="en-US" sz="700" dirty="0">
+                <a:solidFill>
+                  <a:srgbClr val="999999"/>
+                </a:solidFill>
+                <a:latin typeface="Arial" pitchFamily="34" charset="0"/>
+                <a:ea typeface="Arial" pitchFamily="34" charset="-122"/>
+                <a:cs typeface="Arial" pitchFamily="34" charset="-120"/>
+              </a:rPr>
+              <a:t>multiples.vc public software multiples, Apr 2026, </a:t>
+            </a:r>
+            <a:pPr indent="0" marL="0">
+              <a:buNone/>
+            </a:pPr>
+            <a:r>
+              <a:rPr lang="en-US" sz="700" b="1" dirty="0">
+                <a:solidFill>
+                  <a:srgbClr val="999999"/>
+                </a:solidFill>
+                <a:latin typeface="Arial" pitchFamily="34" charset="0"/>
+                <a:ea typeface="Arial" pitchFamily="34" charset="-122"/>
+                <a:cs typeface="Arial" pitchFamily="34" charset="-120"/>
+              </a:rPr>
+              <a:t>(4) </a:t>
+            </a:r>
+            <a:pPr indent="0" marL="0">
+              <a:buNone/>
+            </a:pPr>
+            <a:r>
+              <a:rPr lang="en-US" sz="700" dirty="0">
+                <a:solidFill>
+                  <a:srgbClr val="999999"/>
+                </a:solidFill>
+                <a:latin typeface="Arial" pitchFamily="34" charset="0"/>
+                <a:ea typeface="Arial" pitchFamily="34" charset="-122"/>
+                <a:cs typeface="Arial" pitchFamily="34" charset="-120"/>
+              </a:rPr>
+              <a:t>VanEck BIZD / Yahoo Finance.</a:t>
             </a:r>
             <a:endParaRPr lang="en-US" sz="700" dirty="0"/>
           </a:p>
@@ -13030,8 +13198,8 @@
         </p:nvSpPr>
         <p:spPr>
           <a:xfrm>
-            <a:off x="457200" y="5532120"/>
-            <a:ext cx="4023360" cy="731520"/>
+            <a:off x="457200" y="5875020"/>
+            <a:ext cx="8229600" cy="457200"/>
           </a:xfrm>
           <a:prstGeom prst="rect">
             <a:avLst/>
@@ -13044,9 +13212,6 @@
           <a:lstStyle/>
           <a:p>
             <a:pPr indent="0" marL="0">
-              <a:spcAft>
-                <a:spcPts val="100"/>
-              </a:spcAft>
               <a:buNone/>
             </a:pPr>
             <a:r>
@@ -13058,12 +13223,9 @@
                 <a:ea typeface="Arial" pitchFamily="34" charset="-122"/>
                 <a:cs typeface="Arial" pitchFamily="34" charset="-120"/>
               </a:rPr>
-              <a:t>1  </a:t>
-            </a:r>
-            <a:pPr indent="0" marL="0">
-              <a:spcAft>
-                <a:spcPts val="100"/>
-              </a:spcAft>
+              <a:t>(1) </a:t>
+            </a:r>
+            <a:pPr indent="0" marL="0">
               <a:buNone/>
             </a:pPr>
             <a:r>
@@ -13075,296 +13237,211 @@
                 <a:ea typeface="Arial" pitchFamily="34" charset="-122"/>
                 <a:cs typeface="Arial" pitchFamily="34" charset="-120"/>
               </a:rPr>
-              <a:t>Harding Loevner retrospective.</a:t>
+              <a:t>Harding Loevner retrospective, </a:t>
+            </a:r>
+            <a:pPr indent="0" marL="0">
+              <a:buNone/>
+            </a:pPr>
+            <a:r>
+              <a:rPr lang="en-US" sz="700" b="1" dirty="0">
+                <a:solidFill>
+                  <a:srgbClr val="999999"/>
+                </a:solidFill>
+                <a:latin typeface="Arial" pitchFamily="34" charset="0"/>
+                <a:ea typeface="Arial" pitchFamily="34" charset="-122"/>
+                <a:cs typeface="Arial" pitchFamily="34" charset="-120"/>
+              </a:rPr>
+              <a:t>(2) </a:t>
+            </a:r>
+            <a:pPr indent="0" marL="0">
+              <a:buNone/>
+            </a:pPr>
+            <a:r>
+              <a:rPr lang="en-US" sz="700" dirty="0">
+                <a:solidFill>
+                  <a:srgbClr val="999999"/>
+                </a:solidFill>
+                <a:latin typeface="Arial" pitchFamily="34" charset="0"/>
+                <a:ea typeface="Arial" pitchFamily="34" charset="-122"/>
+                <a:cs typeface="Arial" pitchFamily="34" charset="-120"/>
+              </a:rPr>
+              <a:t>GuruFocus (Apr 17, 2026), </a:t>
+            </a:r>
+            <a:pPr indent="0" marL="0">
+              <a:buNone/>
+            </a:pPr>
+            <a:r>
+              <a:rPr lang="en-US" sz="700" b="1" dirty="0">
+                <a:solidFill>
+                  <a:srgbClr val="999999"/>
+                </a:solidFill>
+                <a:latin typeface="Arial" pitchFamily="34" charset="0"/>
+                <a:ea typeface="Arial" pitchFamily="34" charset="-122"/>
+                <a:cs typeface="Arial" pitchFamily="34" charset="-120"/>
+              </a:rPr>
+              <a:t>(3) </a:t>
+            </a:r>
+            <a:pPr indent="0" marL="0">
+              <a:buNone/>
+            </a:pPr>
+            <a:r>
+              <a:rPr lang="en-US" sz="700" dirty="0">
+                <a:solidFill>
+                  <a:srgbClr val="999999"/>
+                </a:solidFill>
+                <a:latin typeface="Arial" pitchFamily="34" charset="0"/>
+                <a:ea typeface="Arial" pitchFamily="34" charset="-122"/>
+                <a:cs typeface="Arial" pitchFamily="34" charset="-120"/>
+              </a:rPr>
+              <a:t>Jay Ritter, Univ. of Florida IPO data, </a:t>
+            </a:r>
+            <a:pPr indent="0" marL="0">
+              <a:buNone/>
+            </a:pPr>
+            <a:r>
+              <a:rPr lang="en-US" sz="700" b="1" dirty="0">
+                <a:solidFill>
+                  <a:srgbClr val="999999"/>
+                </a:solidFill>
+                <a:latin typeface="Arial" pitchFamily="34" charset="0"/>
+                <a:ea typeface="Arial" pitchFamily="34" charset="-122"/>
+                <a:cs typeface="Arial" pitchFamily="34" charset="-120"/>
+              </a:rPr>
+              <a:t>(4) </a:t>
+            </a:r>
+            <a:pPr indent="0" marL="0">
+              <a:buNone/>
+            </a:pPr>
+            <a:r>
+              <a:rPr lang="en-US" sz="700" dirty="0">
+                <a:solidFill>
+                  <a:srgbClr val="999999"/>
+                </a:solidFill>
+                <a:latin typeface="Arial" pitchFamily="34" charset="0"/>
+                <a:ea typeface="Arial" pitchFamily="34" charset="-122"/>
+                <a:cs typeface="Arial" pitchFamily="34" charset="-120"/>
+              </a:rPr>
+              <a:t>Bloomberg / company filings, 2025 TTM, </a:t>
+            </a:r>
+            <a:pPr indent="0" marL="0">
+              <a:buNone/>
+            </a:pPr>
+            <a:r>
+              <a:rPr lang="en-US" sz="700" b="1" dirty="0">
+                <a:solidFill>
+                  <a:srgbClr val="999999"/>
+                </a:solidFill>
+                <a:latin typeface="Arial" pitchFamily="34" charset="0"/>
+                <a:ea typeface="Arial" pitchFamily="34" charset="-122"/>
+                <a:cs typeface="Arial" pitchFamily="34" charset="-120"/>
+              </a:rPr>
+              <a:t>(5) </a:t>
+            </a:r>
+            <a:pPr indent="0" marL="0">
+              <a:buNone/>
+            </a:pPr>
+            <a:r>
+              <a:rPr lang="en-US" sz="700" dirty="0">
+                <a:solidFill>
+                  <a:srgbClr val="999999"/>
+                </a:solidFill>
+                <a:latin typeface="Arial" pitchFamily="34" charset="0"/>
+                <a:ea typeface="Arial" pitchFamily="34" charset="-122"/>
+                <a:cs typeface="Arial" pitchFamily="34" charset="-120"/>
+              </a:rPr>
+              <a:t>FCC / industry retrospectives, </a:t>
+            </a:r>
+            <a:pPr indent="0" marL="0">
+              <a:buNone/>
+            </a:pPr>
+            <a:r>
+              <a:rPr lang="en-US" sz="700" b="1" dirty="0">
+                <a:solidFill>
+                  <a:srgbClr val="999999"/>
+                </a:solidFill>
+                <a:latin typeface="Arial" pitchFamily="34" charset="0"/>
+                <a:ea typeface="Arial" pitchFamily="34" charset="-122"/>
+                <a:cs typeface="Arial" pitchFamily="34" charset="-120"/>
+              </a:rPr>
+              <a:t>(6) </a:t>
+            </a:r>
+            <a:pPr indent="0" marL="0">
+              <a:buNone/>
+            </a:pPr>
+            <a:r>
+              <a:rPr lang="en-US" sz="700" dirty="0">
+                <a:solidFill>
+                  <a:srgbClr val="999999"/>
+                </a:solidFill>
+                <a:latin typeface="Arial" pitchFamily="34" charset="0"/>
+                <a:ea typeface="Arial" pitchFamily="34" charset="-122"/>
+                <a:cs typeface="Arial" pitchFamily="34" charset="-120"/>
+              </a:rPr>
+              <a:t>CoreWeave / 2nd-market trackers, 2026, </a:t>
+            </a:r>
+            <a:pPr indent="0" marL="0">
+              <a:buNone/>
+            </a:pPr>
+            <a:r>
+              <a:rPr lang="en-US" sz="700" b="1" dirty="0">
+                <a:solidFill>
+                  <a:srgbClr val="999999"/>
+                </a:solidFill>
+                <a:latin typeface="Arial" pitchFamily="34" charset="0"/>
+                <a:ea typeface="Arial" pitchFamily="34" charset="-122"/>
+                <a:cs typeface="Arial" pitchFamily="34" charset="-120"/>
+              </a:rPr>
+              <a:t>(7) </a:t>
+            </a:r>
+            <a:pPr indent="0" marL="0">
+              <a:buNone/>
+            </a:pPr>
+            <a:r>
+              <a:rPr lang="en-US" sz="700" dirty="0">
+                <a:solidFill>
+                  <a:srgbClr val="999999"/>
+                </a:solidFill>
+                <a:latin typeface="Arial" pitchFamily="34" charset="0"/>
+                <a:ea typeface="Arial" pitchFamily="34" charset="-122"/>
+                <a:cs typeface="Arial" pitchFamily="34" charset="-120"/>
+              </a:rPr>
+              <a:t>Public filings / press retrospectives, 2001–02, </a:t>
+            </a:r>
+            <a:pPr indent="0" marL="0">
+              <a:buNone/>
+            </a:pPr>
+            <a:r>
+              <a:rPr lang="en-US" sz="700" b="1" dirty="0">
+                <a:solidFill>
+                  <a:srgbClr val="999999"/>
+                </a:solidFill>
+                <a:latin typeface="Arial" pitchFamily="34" charset="0"/>
+                <a:ea typeface="Arial" pitchFamily="34" charset="-122"/>
+                <a:cs typeface="Arial" pitchFamily="34" charset="-120"/>
+              </a:rPr>
+              <a:t>(8) </a:t>
+            </a:r>
+            <a:pPr indent="0" marL="0">
+              <a:buNone/>
+            </a:pPr>
+            <a:r>
+              <a:rPr lang="en-US" sz="700" dirty="0">
+                <a:solidFill>
+                  <a:srgbClr val="999999"/>
+                </a:solidFill>
+                <a:latin typeface="Arial" pitchFamily="34" charset="0"/>
+                <a:ea typeface="Arial" pitchFamily="34" charset="-122"/>
+                <a:cs typeface="Arial" pitchFamily="34" charset="-120"/>
+              </a:rPr>
+              <a:t>Bloomberg, 2025 YE.</a:t>
             </a:r>
             <a:endParaRPr lang="en-US" sz="700" dirty="0"/>
           </a:p>
-          <a:p>
-            <a:pPr indent="0" marL="0">
-              <a:spcAft>
-                <a:spcPts val="100"/>
-              </a:spcAft>
-              <a:buNone/>
-            </a:pPr>
-            <a:r>
-              <a:rPr lang="en-US" sz="700" b="1" dirty="0">
-                <a:solidFill>
-                  <a:srgbClr val="999999"/>
-                </a:solidFill>
-                <a:latin typeface="Arial" pitchFamily="34" charset="0"/>
-                <a:ea typeface="Arial" pitchFamily="34" charset="-122"/>
-                <a:cs typeface="Arial" pitchFamily="34" charset="-120"/>
-              </a:rPr>
-              <a:t>2  </a:t>
-            </a:r>
-            <a:pPr indent="0" marL="0">
-              <a:spcAft>
-                <a:spcPts val="100"/>
-              </a:spcAft>
-              <a:buNone/>
-            </a:pPr>
-            <a:r>
-              <a:rPr lang="en-US" sz="700" dirty="0">
-                <a:solidFill>
-                  <a:srgbClr val="999999"/>
-                </a:solidFill>
-                <a:latin typeface="Arial" pitchFamily="34" charset="0"/>
-                <a:ea typeface="Arial" pitchFamily="34" charset="-122"/>
-                <a:cs typeface="Arial" pitchFamily="34" charset="-120"/>
-              </a:rPr>
-              <a:t>GuruFocus (Apr 17, 2026).</a:t>
-            </a:r>
-            <a:endParaRPr lang="en-US" sz="700" dirty="0"/>
-          </a:p>
-          <a:p>
-            <a:pPr indent="0" marL="0">
-              <a:spcAft>
-                <a:spcPts val="100"/>
-              </a:spcAft>
-              <a:buNone/>
-            </a:pPr>
-            <a:r>
-              <a:rPr lang="en-US" sz="700" b="1" dirty="0">
-                <a:solidFill>
-                  <a:srgbClr val="999999"/>
-                </a:solidFill>
-                <a:latin typeface="Arial" pitchFamily="34" charset="0"/>
-                <a:ea typeface="Arial" pitchFamily="34" charset="-122"/>
-                <a:cs typeface="Arial" pitchFamily="34" charset="-120"/>
-              </a:rPr>
-              <a:t>3  </a:t>
-            </a:r>
-            <a:pPr indent="0" marL="0">
-              <a:spcAft>
-                <a:spcPts val="100"/>
-              </a:spcAft>
-              <a:buNone/>
-            </a:pPr>
-            <a:r>
-              <a:rPr lang="en-US" sz="700" dirty="0">
-                <a:solidFill>
-                  <a:srgbClr val="999999"/>
-                </a:solidFill>
-                <a:latin typeface="Arial" pitchFamily="34" charset="0"/>
-                <a:ea typeface="Arial" pitchFamily="34" charset="-122"/>
-                <a:cs typeface="Arial" pitchFamily="34" charset="-120"/>
-              </a:rPr>
-              <a:t>Jay Ritter, Univ. of Florida IPO data.</a:t>
-            </a:r>
-            <a:endParaRPr lang="en-US" sz="700" dirty="0"/>
-          </a:p>
-          <a:p>
-            <a:pPr indent="0" marL="0">
-              <a:spcAft>
-                <a:spcPts val="100"/>
-              </a:spcAft>
-              <a:buNone/>
-            </a:pPr>
-            <a:r>
-              <a:rPr lang="en-US" sz="700" b="1" dirty="0">
-                <a:solidFill>
-                  <a:srgbClr val="999999"/>
-                </a:solidFill>
-                <a:latin typeface="Arial" pitchFamily="34" charset="0"/>
-                <a:ea typeface="Arial" pitchFamily="34" charset="-122"/>
-                <a:cs typeface="Arial" pitchFamily="34" charset="-120"/>
-              </a:rPr>
-              <a:t>4  </a:t>
-            </a:r>
-            <a:pPr indent="0" marL="0">
-              <a:spcAft>
-                <a:spcPts val="100"/>
-              </a:spcAft>
-              <a:buNone/>
-            </a:pPr>
-            <a:r>
-              <a:rPr lang="en-US" sz="700" dirty="0">
-                <a:solidFill>
-                  <a:srgbClr val="999999"/>
-                </a:solidFill>
-                <a:latin typeface="Arial" pitchFamily="34" charset="0"/>
-                <a:ea typeface="Arial" pitchFamily="34" charset="-122"/>
-                <a:cs typeface="Arial" pitchFamily="34" charset="-120"/>
-              </a:rPr>
-              <a:t>Bloomberg / company filings, 2025 TTM.</a:t>
-            </a:r>
-            <a:endParaRPr lang="en-US" sz="700" dirty="0"/>
-          </a:p>
-        </p:txBody>
-      </p:sp>
-      <p:sp>
-        <p:nvSpPr>
-          <p:cNvPr id="38" name="Text 36"/>
-          <p:cNvSpPr/>
-          <p:nvPr/>
-        </p:nvSpPr>
-        <p:spPr>
-          <a:xfrm>
-            <a:off x="4663440" y="5532120"/>
-            <a:ext cx="4023360" cy="731520"/>
-          </a:xfrm>
-          <a:prstGeom prst="rect">
-            <a:avLst/>
-          </a:prstGeom>
-          <a:noFill/>
-          <a:ln/>
-        </p:spPr>
-        <p:txBody>
-          <a:bodyPr wrap="square" lIns="0" tIns="0" rIns="0" bIns="0" rtlCol="0" anchor="t"/>
-          <a:lstStyle/>
-          <a:p>
-            <a:pPr indent="0" marL="0">
-              <a:spcAft>
-                <a:spcPts val="100"/>
-              </a:spcAft>
-              <a:buNone/>
-            </a:pPr>
-            <a:r>
-              <a:rPr lang="en-US" sz="700" b="1" dirty="0">
-                <a:solidFill>
-                  <a:srgbClr val="999999"/>
-                </a:solidFill>
-                <a:latin typeface="Arial" pitchFamily="34" charset="0"/>
-                <a:ea typeface="Arial" pitchFamily="34" charset="-122"/>
-                <a:cs typeface="Arial" pitchFamily="34" charset="-120"/>
-              </a:rPr>
-              <a:t>5  </a:t>
-            </a:r>
-            <a:pPr indent="0" marL="0">
-              <a:spcAft>
-                <a:spcPts val="100"/>
-              </a:spcAft>
-              <a:buNone/>
-            </a:pPr>
-            <a:r>
-              <a:rPr lang="en-US" sz="700" dirty="0">
-                <a:solidFill>
-                  <a:srgbClr val="999999"/>
-                </a:solidFill>
-                <a:latin typeface="Arial" pitchFamily="34" charset="0"/>
-                <a:ea typeface="Arial" pitchFamily="34" charset="-122"/>
-                <a:cs typeface="Arial" pitchFamily="34" charset="-120"/>
-              </a:rPr>
-              <a:t>FCC / industry retrospectives.</a:t>
-            </a:r>
-            <a:endParaRPr lang="en-US" sz="700" dirty="0"/>
-          </a:p>
-          <a:p>
-            <a:pPr indent="0" marL="0">
-              <a:spcAft>
-                <a:spcPts val="100"/>
-              </a:spcAft>
-              <a:buNone/>
-            </a:pPr>
-            <a:r>
-              <a:rPr lang="en-US" sz="700" b="1" dirty="0">
-                <a:solidFill>
-                  <a:srgbClr val="999999"/>
-                </a:solidFill>
-                <a:latin typeface="Arial" pitchFamily="34" charset="0"/>
-                <a:ea typeface="Arial" pitchFamily="34" charset="-122"/>
-                <a:cs typeface="Arial" pitchFamily="34" charset="-120"/>
-              </a:rPr>
-              <a:t>6  </a:t>
-            </a:r>
-            <a:pPr indent="0" marL="0">
-              <a:spcAft>
-                <a:spcPts val="100"/>
-              </a:spcAft>
-              <a:buNone/>
-            </a:pPr>
-            <a:r>
-              <a:rPr lang="en-US" sz="700" dirty="0">
-                <a:solidFill>
-                  <a:srgbClr val="999999"/>
-                </a:solidFill>
-                <a:latin typeface="Arial" pitchFamily="34" charset="0"/>
-                <a:ea typeface="Arial" pitchFamily="34" charset="-122"/>
-                <a:cs typeface="Arial" pitchFamily="34" charset="-120"/>
-              </a:rPr>
-              <a:t>CoreWeave / 2nd-market trackers, 2026.</a:t>
-            </a:r>
-            <a:endParaRPr lang="en-US" sz="700" dirty="0"/>
-          </a:p>
-          <a:p>
-            <a:pPr indent="0" marL="0">
-              <a:spcAft>
-                <a:spcPts val="100"/>
-              </a:spcAft>
-              <a:buNone/>
-            </a:pPr>
-            <a:r>
-              <a:rPr lang="en-US" sz="700" b="1" dirty="0">
-                <a:solidFill>
-                  <a:srgbClr val="999999"/>
-                </a:solidFill>
-                <a:latin typeface="Arial" pitchFamily="34" charset="0"/>
-                <a:ea typeface="Arial" pitchFamily="34" charset="-122"/>
-                <a:cs typeface="Arial" pitchFamily="34" charset="-120"/>
-              </a:rPr>
-              <a:t>7  </a:t>
-            </a:r>
-            <a:pPr indent="0" marL="0">
-              <a:spcAft>
-                <a:spcPts val="100"/>
-              </a:spcAft>
-              <a:buNone/>
-            </a:pPr>
-            <a:r>
-              <a:rPr lang="en-US" sz="700" dirty="0">
-                <a:solidFill>
-                  <a:srgbClr val="999999"/>
-                </a:solidFill>
-                <a:latin typeface="Arial" pitchFamily="34" charset="0"/>
-                <a:ea typeface="Arial" pitchFamily="34" charset="-122"/>
-                <a:cs typeface="Arial" pitchFamily="34" charset="-120"/>
-              </a:rPr>
-              <a:t>Public filings / press retrospectives, 2001–02.</a:t>
-            </a:r>
-            <a:endParaRPr lang="en-US" sz="700" dirty="0"/>
-          </a:p>
-          <a:p>
-            <a:pPr indent="0" marL="0">
-              <a:spcAft>
-                <a:spcPts val="100"/>
-              </a:spcAft>
-              <a:buNone/>
-            </a:pPr>
-            <a:r>
-              <a:rPr lang="en-US" sz="700" b="1" dirty="0">
-                <a:solidFill>
-                  <a:srgbClr val="999999"/>
-                </a:solidFill>
-                <a:latin typeface="Arial" pitchFamily="34" charset="0"/>
-                <a:ea typeface="Arial" pitchFamily="34" charset="-122"/>
-                <a:cs typeface="Arial" pitchFamily="34" charset="-120"/>
-              </a:rPr>
-              <a:t>8  </a:t>
-            </a:r>
-            <a:pPr indent="0" marL="0">
-              <a:spcAft>
-                <a:spcPts val="100"/>
-              </a:spcAft>
-              <a:buNone/>
-            </a:pPr>
-            <a:r>
-              <a:rPr lang="en-US" sz="700" dirty="0">
-                <a:solidFill>
-                  <a:srgbClr val="999999"/>
-                </a:solidFill>
-                <a:latin typeface="Arial" pitchFamily="34" charset="0"/>
-                <a:ea typeface="Arial" pitchFamily="34" charset="-122"/>
-                <a:cs typeface="Arial" pitchFamily="34" charset="-120"/>
-              </a:rPr>
-              <a:t>Bloomberg, 2025 YE.</a:t>
-            </a:r>
-            <a:endParaRPr lang="en-US" sz="700" dirty="0"/>
-          </a:p>
-        </p:txBody>
-      </p:sp>
-      <p:sp>
-        <p:nvSpPr>
-          <p:cNvPr id="39" name="Shape 37"/>
+        </p:txBody>
+      </p:sp>
+      <p:sp>
+        <p:nvSpPr>
+          <p:cNvPr id="38" name="Shape 36"/>
           <p:cNvSpPr/>
           <p:nvPr/>
         </p:nvSpPr>
@@ -13389,7 +13466,7 @@
       </p:sp>
       <p:sp>
         <p:nvSpPr>
-          <p:cNvPr id="40" name="Text 38"/>
+          <p:cNvPr id="39" name="Text 37"/>
           <p:cNvSpPr/>
           <p:nvPr/>
         </p:nvSpPr>
@@ -13428,7 +13505,7 @@
       </p:sp>
       <p:sp>
         <p:nvSpPr>
-          <p:cNvPr id="41" name="Text 39"/>
+          <p:cNvPr id="40" name="Text 38"/>
           <p:cNvSpPr/>
           <p:nvPr/>
         </p:nvSpPr>
@@ -13756,75 +13833,11 @@
               </a:rPr>
               <a:t>~90%</a:t>
             </a:r>
-            <a:endParaRPr lang="en-US" sz="4000" dirty="0"/>
-          </a:p>
-        </p:txBody>
-      </p:sp>
-      <p:sp>
-        <p:nvSpPr>
-          <p:cNvPr id="10" name="Text 8"/>
-          <p:cNvSpPr/>
-          <p:nvPr/>
-        </p:nvSpPr>
-        <p:spPr>
-          <a:xfrm>
-            <a:off x="3886200" y="2514600"/>
-            <a:ext cx="2377440" cy="502920"/>
-          </a:xfrm>
-          <a:prstGeom prst="rect">
-            <a:avLst/>
-          </a:prstGeom>
-          <a:noFill/>
-          <a:ln/>
-        </p:spPr>
-        <p:txBody>
-          <a:bodyPr wrap="square" lIns="0" tIns="0" rIns="0" bIns="0" rtlCol="0" anchor="t"/>
-          <a:lstStyle/>
-          <a:p>
             <a:pPr algn="ctr" indent="0" marL="0">
               <a:buNone/>
             </a:pPr>
             <a:r>
-              <a:rPr lang="en-US" sz="1100" dirty="0">
-                <a:solidFill>
-                  <a:srgbClr val="666666"/>
-                </a:solidFill>
-                <a:latin typeface="Arial" pitchFamily="34" charset="0"/>
-                <a:ea typeface="Arial" pitchFamily="34" charset="-122"/>
-                <a:cs typeface="Arial" pitchFamily="34" charset="-120"/>
-              </a:rPr>
-              <a:t>TSMC share of advanced-node chips</a:t>
-            </a:r>
-            <a:endParaRPr lang="en-US" sz="1100" dirty="0"/>
-          </a:p>
-        </p:txBody>
-      </p:sp>
-      <p:sp>
-        <p:nvSpPr>
-          <p:cNvPr id="11" name="Text 9"/>
-          <p:cNvSpPr/>
-          <p:nvPr/>
-        </p:nvSpPr>
-        <p:spPr>
-          <a:xfrm>
-            <a:off x="6446520" y="1783080"/>
-            <a:ext cx="2377440" cy="685800"/>
-          </a:xfrm>
-          <a:prstGeom prst="rect">
-            <a:avLst/>
-          </a:prstGeom>
-          <a:noFill/>
-          <a:ln/>
-        </p:spPr>
-        <p:txBody>
-          <a:bodyPr wrap="square" lIns="0" tIns="0" rIns="0" bIns="0" rtlCol="0" anchor="ctr"/>
-          <a:lstStyle/>
-          <a:p>
-            <a:pPr algn="ctr" indent="0" marL="0">
-              <a:buNone/>
-            </a:pPr>
-            <a:r>
-              <a:rPr lang="en-US" sz="4000" b="1" dirty="0">
+              <a:rPr lang="en-US" sz="1400" baseline="30000" dirty="0">
                 <a:solidFill>
                   <a:srgbClr val="CC0000"/>
                 </a:solidFill>
@@ -13832,7 +13845,99 @@
                 <a:ea typeface="Arial Black" pitchFamily="34" charset="-122"/>
                 <a:cs typeface="Arial Black" pitchFamily="34" charset="-120"/>
               </a:rPr>
+              <a:t> 1</a:t>
+            </a:r>
+            <a:endParaRPr lang="en-US" sz="4000" dirty="0"/>
+          </a:p>
+        </p:txBody>
+      </p:sp>
+      <p:sp>
+        <p:nvSpPr>
+          <p:cNvPr id="10" name="Text 8"/>
+          <p:cNvSpPr/>
+          <p:nvPr/>
+        </p:nvSpPr>
+        <p:spPr>
+          <a:xfrm>
+            <a:off x="3886200" y="2514600"/>
+            <a:ext cx="2377440" cy="502920"/>
+          </a:xfrm>
+          <a:prstGeom prst="rect">
+            <a:avLst/>
+          </a:prstGeom>
+          <a:noFill/>
+          <a:ln/>
+        </p:spPr>
+        <p:txBody>
+          <a:bodyPr wrap="square" lIns="0" tIns="0" rIns="0" bIns="0" rtlCol="0" anchor="t"/>
+          <a:lstStyle/>
+          <a:p>
+            <a:pPr algn="ctr" indent="0" marL="0">
+              <a:buNone/>
+            </a:pPr>
+            <a:r>
+              <a:rPr lang="en-US" sz="1100" dirty="0">
+                <a:solidFill>
+                  <a:srgbClr val="666666"/>
+                </a:solidFill>
+                <a:latin typeface="Arial" pitchFamily="34" charset="0"/>
+                <a:ea typeface="Arial" pitchFamily="34" charset="-122"/>
+                <a:cs typeface="Arial" pitchFamily="34" charset="-120"/>
+              </a:rPr>
+              <a:t>TSMC share of advanced-node chips</a:t>
+            </a:r>
+            <a:endParaRPr lang="en-US" sz="1100" dirty="0"/>
+          </a:p>
+        </p:txBody>
+      </p:sp>
+      <p:sp>
+        <p:nvSpPr>
+          <p:cNvPr id="11" name="Text 9"/>
+          <p:cNvSpPr/>
+          <p:nvPr/>
+        </p:nvSpPr>
+        <p:spPr>
+          <a:xfrm>
+            <a:off x="6446520" y="1783080"/>
+            <a:ext cx="2377440" cy="685800"/>
+          </a:xfrm>
+          <a:prstGeom prst="rect">
+            <a:avLst/>
+          </a:prstGeom>
+          <a:noFill/>
+          <a:ln/>
+        </p:spPr>
+        <p:txBody>
+          <a:bodyPr wrap="square" lIns="0" tIns="0" rIns="0" bIns="0" rtlCol="0" anchor="ctr"/>
+          <a:lstStyle/>
+          <a:p>
+            <a:pPr algn="ctr" indent="0" marL="0">
+              <a:buNone/>
+            </a:pPr>
+            <a:r>
+              <a:rPr lang="en-US" sz="4000" b="1" dirty="0">
+                <a:solidFill>
+                  <a:srgbClr val="CC0000"/>
+                </a:solidFill>
+                <a:latin typeface="Arial Black" pitchFamily="34" charset="0"/>
+                <a:ea typeface="Arial Black" pitchFamily="34" charset="-122"/>
+                <a:cs typeface="Arial Black" pitchFamily="34" charset="-120"/>
+              </a:rPr>
               <a:t>76%</a:t>
+            </a:r>
+            <a:pPr algn="ctr" indent="0" marL="0">
+              <a:buNone/>
+            </a:pPr>
+            <a:r>
+              <a:rPr lang="en-US" sz="1400" baseline="30000" dirty="0">
+                <a:solidFill>
+                  <a:srgbClr val="CC0000"/>
+                </a:solidFill>
+                <a:latin typeface="Arial Black" pitchFamily="34" charset="0"/>
+                <a:ea typeface="Arial Black" pitchFamily="34" charset="-122"/>
+                <a:cs typeface="Arial Black" pitchFamily="34" charset="-120"/>
+              </a:rPr>
+              <a:t> 2</a:t>
             </a:r>
             <a:endParaRPr lang="en-US" sz="4000" dirty="0"/>
           </a:p>
@@ -13910,7 +14015,63 @@
                 <a:ea typeface="Arial" pitchFamily="34" charset="-122"/>
                 <a:cs typeface="Arial" pitchFamily="34" charset="-120"/>
               </a:rPr>
-              <a:t>A single leading-edge chip crosses 70+ borders and six countries before reaching a data center. ASML builds fewer than 100 EUV machines a year.</a:t>
+              <a:t>A single leading-edge chip crosses 70+ borders and six countries</a:t>
+            </a:r>
+            <a:pPr indent="0" marL="0">
+              <a:buNone/>
+            </a:pPr>
+            <a:r>
+              <a:rPr lang="en-US" sz="800" baseline="30000" dirty="0">
+                <a:solidFill>
+                  <a:srgbClr val="333333"/>
+                </a:solidFill>
+                <a:latin typeface="Arial" pitchFamily="34" charset="0"/>
+                <a:ea typeface="Arial" pitchFamily="34" charset="-122"/>
+                <a:cs typeface="Arial" pitchFamily="34" charset="-120"/>
+              </a:rPr>
+              <a:t> 3</a:t>
+            </a:r>
+            <a:pPr indent="0" marL="0">
+              <a:buNone/>
+            </a:pPr>
+            <a:r>
+              <a:rPr lang="en-US" sz="1200" dirty="0">
+                <a:solidFill>
+                  <a:srgbClr val="333333"/>
+                </a:solidFill>
+                <a:latin typeface="Arial" pitchFamily="34" charset="0"/>
+                <a:ea typeface="Arial" pitchFamily="34" charset="-122"/>
+                <a:cs typeface="Arial" pitchFamily="34" charset="-120"/>
+              </a:rPr>
+              <a:t> before reaching a data center. ASML builds fewer than 100 EUV machines a year</a:t>
+            </a:r>
+            <a:pPr indent="0" marL="0">
+              <a:buNone/>
+            </a:pPr>
+            <a:r>
+              <a:rPr lang="en-US" sz="800" baseline="30000" dirty="0">
+                <a:solidFill>
+                  <a:srgbClr val="333333"/>
+                </a:solidFill>
+                <a:latin typeface="Arial" pitchFamily="34" charset="0"/>
+                <a:ea typeface="Arial" pitchFamily="34" charset="-122"/>
+                <a:cs typeface="Arial" pitchFamily="34" charset="-120"/>
+              </a:rPr>
+              <a:t> 4</a:t>
+            </a:r>
+            <a:pPr indent="0" marL="0">
+              <a:buNone/>
+            </a:pPr>
+            <a:r>
+              <a:rPr lang="en-US" sz="1200" dirty="0">
+                <a:solidFill>
+                  <a:srgbClr val="333333"/>
+                </a:solidFill>
+                <a:latin typeface="Arial" pitchFamily="34" charset="0"/>
+                <a:ea typeface="Arial" pitchFamily="34" charset="-122"/>
+                <a:cs typeface="Arial" pitchFamily="34" charset="-120"/>
+              </a:rPr>
+              <a:t>.</a:t>
             </a:r>
             <a:endParaRPr lang="en-US" sz="1200" dirty="0"/>
           </a:p>
@@ -14401,7 +14562,7 @@
         <p:spPr>
           <a:xfrm>
             <a:off x="457200" y="5875020"/>
-            <a:ext cx="8229600" cy="320040"/>
+            <a:ext cx="8229600" cy="457200"/>
           </a:xfrm>
           <a:prstGeom prst="rect">
             <a:avLst/>
@@ -14417,6 +14578,20 @@
               <a:buNone/>
             </a:pPr>
             <a:r>
+              <a:rPr lang="en-US" sz="700" b="1" dirty="0">
+                <a:solidFill>
+                  <a:srgbClr val="999999"/>
+                </a:solidFill>
+                <a:latin typeface="Arial" pitchFamily="34" charset="0"/>
+                <a:ea typeface="Arial" pitchFamily="34" charset="-122"/>
+                <a:cs typeface="Arial" pitchFamily="34" charset="-120"/>
+              </a:rPr>
+              <a:t>(1) </a:t>
+            </a:r>
+            <a:pPr indent="0" marL="0">
+              <a:buNone/>
+            </a:pPr>
+            <a:r>
               <a:rPr lang="en-US" sz="700" dirty="0">
                 <a:solidFill>
                   <a:srgbClr val="999999"/>
@@ -14425,7 +14600,91 @@
                 <a:ea typeface="Arial" pitchFamily="34" charset="-122"/>
                 <a:cs typeface="Arial" pitchFamily="34" charset="-120"/>
               </a:rPr>
-              <a:t>Sources: TSMC, Samsung, Micron, Intel filings; US Commerce Dept CHIPS Program Office (Nov 2025 — $36B+ committed of $52.7B); SIA.</a:t>
+              <a:t>TrendForce / Counterpoint, 2025, </a:t>
+            </a:r>
+            <a:pPr indent="0" marL="0">
+              <a:buNone/>
+            </a:pPr>
+            <a:r>
+              <a:rPr lang="en-US" sz="700" b="1" dirty="0">
+                <a:solidFill>
+                  <a:srgbClr val="999999"/>
+                </a:solidFill>
+                <a:latin typeface="Arial" pitchFamily="34" charset="0"/>
+                <a:ea typeface="Arial" pitchFamily="34" charset="-122"/>
+                <a:cs typeface="Arial" pitchFamily="34" charset="-120"/>
+              </a:rPr>
+              <a:t>(2) </a:t>
+            </a:r>
+            <a:pPr indent="0" marL="0">
+              <a:buNone/>
+            </a:pPr>
+            <a:r>
+              <a:rPr lang="en-US" sz="700" dirty="0">
+                <a:solidFill>
+                  <a:srgbClr val="999999"/>
+                </a:solidFill>
+                <a:latin typeface="Arial" pitchFamily="34" charset="0"/>
+                <a:ea typeface="Arial" pitchFamily="34" charset="-122"/>
+                <a:cs typeface="Arial" pitchFamily="34" charset="-120"/>
+              </a:rPr>
+              <a:t>TrendForce, 2025, </a:t>
+            </a:r>
+            <a:pPr indent="0" marL="0">
+              <a:buNone/>
+            </a:pPr>
+            <a:r>
+              <a:rPr lang="en-US" sz="700" b="1" dirty="0">
+                <a:solidFill>
+                  <a:srgbClr val="999999"/>
+                </a:solidFill>
+                <a:latin typeface="Arial" pitchFamily="34" charset="0"/>
+                <a:ea typeface="Arial" pitchFamily="34" charset="-122"/>
+                <a:cs typeface="Arial" pitchFamily="34" charset="-120"/>
+              </a:rPr>
+              <a:t>(3) </a:t>
+            </a:r>
+            <a:pPr indent="0" marL="0">
+              <a:buNone/>
+            </a:pPr>
+            <a:r>
+              <a:rPr lang="en-US" sz="700" dirty="0">
+                <a:solidFill>
+                  <a:srgbClr val="999999"/>
+                </a:solidFill>
+                <a:latin typeface="Arial" pitchFamily="34" charset="0"/>
+                <a:ea typeface="Arial" pitchFamily="34" charset="-122"/>
+                <a:cs typeface="Arial" pitchFamily="34" charset="-120"/>
+              </a:rPr>
+              <a:t>SIA semiconductor supply-chain report, </a:t>
+            </a:r>
+            <a:pPr indent="0" marL="0">
+              <a:buNone/>
+            </a:pPr>
+            <a:r>
+              <a:rPr lang="en-US" sz="700" b="1" dirty="0">
+                <a:solidFill>
+                  <a:srgbClr val="999999"/>
+                </a:solidFill>
+                <a:latin typeface="Arial" pitchFamily="34" charset="0"/>
+                <a:ea typeface="Arial" pitchFamily="34" charset="-122"/>
+                <a:cs typeface="Arial" pitchFamily="34" charset="-120"/>
+              </a:rPr>
+              <a:t>(4) </a:t>
+            </a:r>
+            <a:pPr indent="0" marL="0">
+              <a:buNone/>
+            </a:pPr>
+            <a:r>
+              <a:rPr lang="en-US" sz="700" dirty="0">
+                <a:solidFill>
+                  <a:srgbClr val="999999"/>
+                </a:solidFill>
+                <a:latin typeface="Arial" pitchFamily="34" charset="0"/>
+                <a:ea typeface="Arial" pitchFamily="34" charset="-122"/>
+                <a:cs typeface="Arial" pitchFamily="34" charset="-120"/>
+              </a:rPr>
+              <a:t>ASML 2025 annual report.</a:t>
             </a:r>
             <a:endParaRPr lang="en-US" sz="700" dirty="0"/>
           </a:p>
@@ -14886,7 +15145,7 @@
         <p:spPr>
           <a:xfrm>
             <a:off x="640080" y="3429000"/>
-            <a:ext cx="2240280" cy="2148840"/>
+            <a:ext cx="2240280" cy="1874520"/>
           </a:xfrm>
           <a:prstGeom prst="rect">
             <a:avLst/>
@@ -14916,6 +15175,23 @@
               </a:rPr>
               <a:t>H100 / H200 / Blackwell banned from China.</a:t>
             </a:r>
+            <a:pPr indent="0" marL="0">
+              <a:spcAft>
+                <a:spcPts val="500"/>
+              </a:spcAft>
+              <a:buNone/>
+            </a:pPr>
+            <a:r>
+              <a:rPr lang="en-US" sz="700" baseline="30000" dirty="0">
+                <a:solidFill>
+                  <a:srgbClr val="333333"/>
+                </a:solidFill>
+                <a:latin typeface="Arial" pitchFamily="34" charset="0"/>
+                <a:ea typeface="Arial" pitchFamily="34" charset="-122"/>
+                <a:cs typeface="Arial" pitchFamily="34" charset="-120"/>
+              </a:rPr>
+              <a:t> 1</a:t>
+            </a:r>
             <a:endParaRPr lang="en-US" sz="1000" dirty="0"/>
           </a:p>
           <a:p>
@@ -14937,6 +15213,23 @@
               </a:rPr>
               <a:t>H20 reinstated with a 15% Treasury fee.</a:t>
             </a:r>
+            <a:pPr indent="0" marL="0">
+              <a:spcAft>
+                <a:spcPts val="500"/>
+              </a:spcAft>
+              <a:buNone/>
+            </a:pPr>
+            <a:r>
+              <a:rPr lang="en-US" sz="700" baseline="30000" dirty="0">
+                <a:solidFill>
+                  <a:srgbClr val="333333"/>
+                </a:solidFill>
+                <a:latin typeface="Arial" pitchFamily="34" charset="0"/>
+                <a:ea typeface="Arial" pitchFamily="34" charset="-122"/>
+                <a:cs typeface="Arial" pitchFamily="34" charset="-120"/>
+              </a:rPr>
+              <a:t> 2</a:t>
+            </a:r>
             <a:endParaRPr lang="en-US" sz="1000" dirty="0"/>
           </a:p>
           <a:p>
@@ -14958,6 +15251,23 @@
               </a:rPr>
               <a:t>$5.5B NVIDIA H20 writedown.</a:t>
             </a:r>
+            <a:pPr indent="0" marL="0">
+              <a:spcAft>
+                <a:spcPts val="500"/>
+              </a:spcAft>
+              <a:buNone/>
+            </a:pPr>
+            <a:r>
+              <a:rPr lang="en-US" sz="700" baseline="30000" dirty="0">
+                <a:solidFill>
+                  <a:srgbClr val="333333"/>
+                </a:solidFill>
+                <a:latin typeface="Arial" pitchFamily="34" charset="0"/>
+                <a:ea typeface="Arial" pitchFamily="34" charset="-122"/>
+                <a:cs typeface="Arial" pitchFamily="34" charset="-120"/>
+              </a:rPr>
+              <a:t> 3</a:t>
+            </a:r>
             <a:endParaRPr lang="en-US" sz="1000" dirty="0"/>
           </a:p>
           <a:p>
@@ -14978,6 +15288,23 @@
                 <a:cs typeface="Arial" pitchFamily="34" charset="-120"/>
               </a:rPr>
               <a:t>ASML DUV banned; China ~20% of revenue.</a:t>
+            </a:r>
+            <a:pPr indent="0" marL="0">
+              <a:spcAft>
+                <a:spcPts val="500"/>
+              </a:spcAft>
+              <a:buNone/>
+            </a:pPr>
+            <a:r>
+              <a:rPr lang="en-US" sz="700" baseline="30000" dirty="0">
+                <a:solidFill>
+                  <a:srgbClr val="333333"/>
+                </a:solidFill>
+                <a:latin typeface="Arial" pitchFamily="34" charset="0"/>
+                <a:ea typeface="Arial" pitchFamily="34" charset="-122"/>
+                <a:cs typeface="Arial" pitchFamily="34" charset="-120"/>
+              </a:rPr>
+              <a:t> 4</a:t>
             </a:r>
             <a:endParaRPr lang="en-US" sz="1000" dirty="0"/>
           </a:p>
@@ -15143,7 +15470,7 @@
         <p:spPr>
           <a:xfrm>
             <a:off x="3474720" y="3429000"/>
-            <a:ext cx="2240280" cy="2148840"/>
+            <a:ext cx="2240280" cy="1874520"/>
           </a:xfrm>
           <a:prstGeom prst="rect">
             <a:avLst/>
@@ -15173,6 +15500,23 @@
               </a:rPr>
               <a:t>EU AI Act enforcement: Aug 2, 2026.</a:t>
             </a:r>
+            <a:pPr indent="0" marL="0">
+              <a:spcAft>
+                <a:spcPts val="500"/>
+              </a:spcAft>
+              <a:buNone/>
+            </a:pPr>
+            <a:r>
+              <a:rPr lang="en-US" sz="700" baseline="30000" dirty="0">
+                <a:solidFill>
+                  <a:srgbClr val="333333"/>
+                </a:solidFill>
+                <a:latin typeface="Arial" pitchFamily="34" charset="0"/>
+                <a:ea typeface="Arial" pitchFamily="34" charset="-122"/>
+                <a:cs typeface="Arial" pitchFamily="34" charset="-120"/>
+              </a:rPr>
+              <a:t> 5</a:t>
+            </a:r>
             <a:endParaRPr lang="en-US" sz="1000" dirty="0"/>
           </a:p>
           <a:p>
@@ -15194,6 +15538,23 @@
               </a:rPr>
               <a:t>Fines up to €35M or 7% of global revenue.</a:t>
             </a:r>
+            <a:pPr indent="0" marL="0">
+              <a:spcAft>
+                <a:spcPts val="500"/>
+              </a:spcAft>
+              <a:buNone/>
+            </a:pPr>
+            <a:r>
+              <a:rPr lang="en-US" sz="700" baseline="30000" dirty="0">
+                <a:solidFill>
+                  <a:srgbClr val="333333"/>
+                </a:solidFill>
+                <a:latin typeface="Arial" pitchFamily="34" charset="0"/>
+                <a:ea typeface="Arial" pitchFamily="34" charset="-122"/>
+                <a:cs typeface="Arial" pitchFamily="34" charset="-120"/>
+              </a:rPr>
+              <a:t> 6</a:t>
+            </a:r>
             <a:endParaRPr lang="en-US" sz="1000" dirty="0"/>
           </a:p>
           <a:p>
@@ -15215,6 +15576,23 @@
               </a:rPr>
               <a:t>Initial compliance: $8–15M per system.</a:t>
             </a:r>
+            <a:pPr indent="0" marL="0">
+              <a:spcAft>
+                <a:spcPts val="500"/>
+              </a:spcAft>
+              <a:buNone/>
+            </a:pPr>
+            <a:r>
+              <a:rPr lang="en-US" sz="700" baseline="30000" dirty="0">
+                <a:solidFill>
+                  <a:srgbClr val="333333"/>
+                </a:solidFill>
+                <a:latin typeface="Arial" pitchFamily="34" charset="0"/>
+                <a:ea typeface="Arial" pitchFamily="34" charset="-122"/>
+                <a:cs typeface="Arial" pitchFamily="34" charset="-120"/>
+              </a:rPr>
+              <a:t> 7</a:t>
+            </a:r>
             <a:endParaRPr lang="en-US" sz="1000" dirty="0"/>
           </a:p>
           <a:p>
@@ -15235,6 +15613,23 @@
                 <a:cs typeface="Arial" pitchFamily="34" charset="-120"/>
               </a:rPr>
               <a:t>Only 36% of enterprises feel prepared.</a:t>
+            </a:r>
+            <a:pPr indent="0" marL="0">
+              <a:spcAft>
+                <a:spcPts val="500"/>
+              </a:spcAft>
+              <a:buNone/>
+            </a:pPr>
+            <a:r>
+              <a:rPr lang="en-US" sz="700" baseline="30000" dirty="0">
+                <a:solidFill>
+                  <a:srgbClr val="333333"/>
+                </a:solidFill>
+                <a:latin typeface="Arial" pitchFamily="34" charset="0"/>
+                <a:ea typeface="Arial" pitchFamily="34" charset="-122"/>
+                <a:cs typeface="Arial" pitchFamily="34" charset="-120"/>
+              </a:rPr>
+              <a:t> 8</a:t>
             </a:r>
             <a:endParaRPr lang="en-US" sz="1000" dirty="0"/>
           </a:p>
@@ -15400,7 +15795,7 @@
         <p:spPr>
           <a:xfrm>
             <a:off x="6309360" y="3429000"/>
-            <a:ext cx="2240280" cy="2148840"/>
+            <a:ext cx="2240280" cy="1874520"/>
           </a:xfrm>
           <a:prstGeom prst="rect">
             <a:avLst/>
@@ -15430,6 +15825,23 @@
               </a:rPr>
               <a:t>CHIPS Act: ~$36B committed of $52.7B.</a:t>
             </a:r>
+            <a:pPr indent="0" marL="0">
+              <a:spcAft>
+                <a:spcPts val="500"/>
+              </a:spcAft>
+              <a:buNone/>
+            </a:pPr>
+            <a:r>
+              <a:rPr lang="en-US" sz="700" baseline="30000" dirty="0">
+                <a:solidFill>
+                  <a:srgbClr val="333333"/>
+                </a:solidFill>
+                <a:latin typeface="Arial" pitchFamily="34" charset="0"/>
+                <a:ea typeface="Arial" pitchFamily="34" charset="-122"/>
+                <a:cs typeface="Arial" pitchFamily="34" charset="-120"/>
+              </a:rPr>
+              <a:t> 9</a:t>
+            </a:r>
             <a:endParaRPr lang="en-US" sz="1000" dirty="0"/>
           </a:p>
           <a:p>
@@ -15451,6 +15863,23 @@
               </a:rPr>
               <a:t>China controls ~90% of rare-earth processing.</a:t>
             </a:r>
+            <a:pPr indent="0" marL="0">
+              <a:spcAft>
+                <a:spcPts val="500"/>
+              </a:spcAft>
+              <a:buNone/>
+            </a:pPr>
+            <a:r>
+              <a:rPr lang="en-US" sz="700" baseline="30000" dirty="0">
+                <a:solidFill>
+                  <a:srgbClr val="333333"/>
+                </a:solidFill>
+                <a:latin typeface="Arial" pitchFamily="34" charset="0"/>
+                <a:ea typeface="Arial" pitchFamily="34" charset="-122"/>
+                <a:cs typeface="Arial" pitchFamily="34" charset="-120"/>
+              </a:rPr>
+              <a:t> 10</a:t>
+            </a:r>
             <a:endParaRPr lang="en-US" sz="1000" dirty="0"/>
           </a:p>
           <a:p>
@@ -15472,6 +15901,23 @@
               </a:rPr>
               <a:t>Gallium / germanium controls since Jul 2023.</a:t>
             </a:r>
+            <a:pPr indent="0" marL="0">
+              <a:spcAft>
+                <a:spcPts val="500"/>
+              </a:spcAft>
+              <a:buNone/>
+            </a:pPr>
+            <a:r>
+              <a:rPr lang="en-US" sz="700" baseline="30000" dirty="0">
+                <a:solidFill>
+                  <a:srgbClr val="333333"/>
+                </a:solidFill>
+                <a:latin typeface="Arial" pitchFamily="34" charset="0"/>
+                <a:ea typeface="Arial" pitchFamily="34" charset="-122"/>
+                <a:cs typeface="Arial" pitchFamily="34" charset="-120"/>
+              </a:rPr>
+              <a:t> 11</a:t>
+            </a:r>
             <a:endParaRPr lang="en-US" sz="1000" dirty="0"/>
           </a:p>
           <a:p>
@@ -15493,6 +15939,23 @@
               </a:rPr>
               <a:t>SMIC 5nm yield ~20% vs &gt;70% threshold.</a:t>
             </a:r>
+            <a:pPr indent="0" marL="0">
+              <a:spcAft>
+                <a:spcPts val="500"/>
+              </a:spcAft>
+              <a:buNone/>
+            </a:pPr>
+            <a:r>
+              <a:rPr lang="en-US" sz="700" baseline="30000" dirty="0">
+                <a:solidFill>
+                  <a:srgbClr val="333333"/>
+                </a:solidFill>
+                <a:latin typeface="Arial" pitchFamily="34" charset="0"/>
+                <a:ea typeface="Arial" pitchFamily="34" charset="-122"/>
+                <a:cs typeface="Arial" pitchFamily="34" charset="-120"/>
+              </a:rPr>
+              <a:t> 12</a:t>
+            </a:r>
             <a:endParaRPr lang="en-US" sz="1000" dirty="0"/>
           </a:p>
         </p:txBody>
@@ -15506,7 +15969,7 @@
         <p:spPr>
           <a:xfrm>
             <a:off x="457200" y="5875020"/>
-            <a:ext cx="8229600" cy="320040"/>
+            <a:ext cx="8229600" cy="457200"/>
           </a:xfrm>
           <a:prstGeom prst="rect">
             <a:avLst/>
@@ -15522,6 +15985,20 @@
               <a:buNone/>
             </a:pPr>
             <a:r>
+              <a:rPr lang="en-US" sz="700" b="1" dirty="0">
+                <a:solidFill>
+                  <a:srgbClr val="999999"/>
+                </a:solidFill>
+                <a:latin typeface="Arial" pitchFamily="34" charset="0"/>
+                <a:ea typeface="Arial" pitchFamily="34" charset="-122"/>
+                <a:cs typeface="Arial" pitchFamily="34" charset="-120"/>
+              </a:rPr>
+              <a:t>(1) </a:t>
+            </a:r>
+            <a:pPr indent="0" marL="0">
+              <a:buNone/>
+            </a:pPr>
+            <a:r>
               <a:rPr lang="en-US" sz="700" dirty="0">
                 <a:solidFill>
                   <a:srgbClr val="999999"/>
@@ -15530,7 +16007,315 @@
                 <a:ea typeface="Arial" pitchFamily="34" charset="-122"/>
                 <a:cs typeface="Arial" pitchFamily="34" charset="-120"/>
               </a:rPr>
-              <a:t>Sources: NVIDIA 10-Q; ASML filings; EU AI Act Article 99 / Chapter V (Aug 2, 2026 enforcement); US Bureau of Industry and Security; Commerce Dept (Nov 2025).</a:t>
+              <a:t>US BIS export rules, 2023–25, </a:t>
+            </a:r>
+            <a:pPr indent="0" marL="0">
+              <a:buNone/>
+            </a:pPr>
+            <a:r>
+              <a:rPr lang="en-US" sz="700" b="1" dirty="0">
+                <a:solidFill>
+                  <a:srgbClr val="999999"/>
+                </a:solidFill>
+                <a:latin typeface="Arial" pitchFamily="34" charset="0"/>
+                <a:ea typeface="Arial" pitchFamily="34" charset="-122"/>
+                <a:cs typeface="Arial" pitchFamily="34" charset="-120"/>
+              </a:rPr>
+              <a:t>(2) </a:t>
+            </a:r>
+            <a:pPr indent="0" marL="0">
+              <a:buNone/>
+            </a:pPr>
+            <a:r>
+              <a:rPr lang="en-US" sz="700" dirty="0">
+                <a:solidFill>
+                  <a:srgbClr val="999999"/>
+                </a:solidFill>
+                <a:latin typeface="Arial" pitchFamily="34" charset="0"/>
+                <a:ea typeface="Arial" pitchFamily="34" charset="-122"/>
+                <a:cs typeface="Arial" pitchFamily="34" charset="-120"/>
+              </a:rPr>
+              <a:t>US Treasury / NVIDIA, Jul 2025, </a:t>
+            </a:r>
+            <a:pPr indent="0" marL="0">
+              <a:buNone/>
+            </a:pPr>
+            <a:r>
+              <a:rPr lang="en-US" sz="700" b="1" dirty="0">
+                <a:solidFill>
+                  <a:srgbClr val="999999"/>
+                </a:solidFill>
+                <a:latin typeface="Arial" pitchFamily="34" charset="0"/>
+                <a:ea typeface="Arial" pitchFamily="34" charset="-122"/>
+                <a:cs typeface="Arial" pitchFamily="34" charset="-120"/>
+              </a:rPr>
+              <a:t>(3) </a:t>
+            </a:r>
+            <a:pPr indent="0" marL="0">
+              <a:buNone/>
+            </a:pPr>
+            <a:r>
+              <a:rPr lang="en-US" sz="700" dirty="0">
+                <a:solidFill>
+                  <a:srgbClr val="999999"/>
+                </a:solidFill>
+                <a:latin typeface="Arial" pitchFamily="34" charset="0"/>
+                <a:ea typeface="Arial" pitchFamily="34" charset="-122"/>
+                <a:cs typeface="Arial" pitchFamily="34" charset="-120"/>
+              </a:rPr>
+              <a:t>NVIDIA 10-Q, FY26 Q1, </a:t>
+            </a:r>
+            <a:pPr indent="0" marL="0">
+              <a:buNone/>
+            </a:pPr>
+            <a:r>
+              <a:rPr lang="en-US" sz="700" b="1" dirty="0">
+                <a:solidFill>
+                  <a:srgbClr val="999999"/>
+                </a:solidFill>
+                <a:latin typeface="Arial" pitchFamily="34" charset="0"/>
+                <a:ea typeface="Arial" pitchFamily="34" charset="-122"/>
+                <a:cs typeface="Arial" pitchFamily="34" charset="-120"/>
+              </a:rPr>
+              <a:t>(4) </a:t>
+            </a:r>
+            <a:pPr indent="0" marL="0">
+              <a:buNone/>
+            </a:pPr>
+            <a:r>
+              <a:rPr lang="en-US" sz="700" dirty="0">
+                <a:solidFill>
+                  <a:srgbClr val="999999"/>
+                </a:solidFill>
+                <a:latin typeface="Arial" pitchFamily="34" charset="0"/>
+                <a:ea typeface="Arial" pitchFamily="34" charset="-122"/>
+                <a:cs typeface="Arial" pitchFamily="34" charset="-120"/>
+              </a:rPr>
+              <a:t>ASML 2025 annual report, </a:t>
+            </a:r>
+            <a:pPr indent="0" marL="0">
+              <a:buNone/>
+            </a:pPr>
+            <a:r>
+              <a:rPr lang="en-US" sz="700" b="1" dirty="0">
+                <a:solidFill>
+                  <a:srgbClr val="999999"/>
+                </a:solidFill>
+                <a:latin typeface="Arial" pitchFamily="34" charset="0"/>
+                <a:ea typeface="Arial" pitchFamily="34" charset="-122"/>
+                <a:cs typeface="Arial" pitchFamily="34" charset="-120"/>
+              </a:rPr>
+              <a:t>(5) </a:t>
+            </a:r>
+            <a:pPr indent="0" marL="0">
+              <a:buNone/>
+            </a:pPr>
+            <a:r>
+              <a:rPr lang="en-US" sz="700" dirty="0">
+                <a:solidFill>
+                  <a:srgbClr val="999999"/>
+                </a:solidFill>
+                <a:latin typeface="Arial" pitchFamily="34" charset="0"/>
+                <a:ea typeface="Arial" pitchFamily="34" charset="-122"/>
+                <a:cs typeface="Arial" pitchFamily="34" charset="-120"/>
+              </a:rPr>
+              <a:t>EU AI Act, Article 99, </a:t>
+            </a:r>
+            <a:pPr indent="0" marL="0">
+              <a:buNone/>
+            </a:pPr>
+            <a:r>
+              <a:rPr lang="en-US" sz="700" b="1" dirty="0">
+                <a:solidFill>
+                  <a:srgbClr val="999999"/>
+                </a:solidFill>
+                <a:latin typeface="Arial" pitchFamily="34" charset="0"/>
+                <a:ea typeface="Arial" pitchFamily="34" charset="-122"/>
+                <a:cs typeface="Arial" pitchFamily="34" charset="-120"/>
+              </a:rPr>
+              <a:t>(6) </a:t>
+            </a:r>
+            <a:pPr indent="0" marL="0">
+              <a:buNone/>
+            </a:pPr>
+            <a:r>
+              <a:rPr lang="en-US" sz="700" dirty="0">
+                <a:solidFill>
+                  <a:srgbClr val="999999"/>
+                </a:solidFill>
+                <a:latin typeface="Arial" pitchFamily="34" charset="0"/>
+                <a:ea typeface="Arial" pitchFamily="34" charset="-122"/>
+                <a:cs typeface="Arial" pitchFamily="34" charset="-120"/>
+              </a:rPr>
+              <a:t>EU AI Act, Article 99, </a:t>
+            </a:r>
+            <a:pPr indent="0" marL="0">
+              <a:buNone/>
+            </a:pPr>
+            <a:r>
+              <a:rPr lang="en-US" sz="700" b="1" dirty="0">
+                <a:solidFill>
+                  <a:srgbClr val="999999"/>
+                </a:solidFill>
+                <a:latin typeface="Arial" pitchFamily="34" charset="0"/>
+                <a:ea typeface="Arial" pitchFamily="34" charset="-122"/>
+                <a:cs typeface="Arial" pitchFamily="34" charset="-120"/>
+              </a:rPr>
+              <a:t>(7) </a:t>
+            </a:r>
+            <a:pPr indent="0" marL="0">
+              <a:buNone/>
+            </a:pPr>
+            <a:r>
+              <a:rPr lang="en-US" sz="700" dirty="0">
+                <a:solidFill>
+                  <a:srgbClr val="999999"/>
+                </a:solidFill>
+                <a:latin typeface="Arial" pitchFamily="34" charset="0"/>
+                <a:ea typeface="Arial" pitchFamily="34" charset="-122"/>
+                <a:cs typeface="Arial" pitchFamily="34" charset="-120"/>
+              </a:rPr>
+              <a:t>EU Commission / law firm analyses, 2025, </a:t>
+            </a:r>
+            <a:pPr indent="0" marL="0">
+              <a:buNone/>
+            </a:pPr>
+            <a:r>
+              <a:rPr lang="en-US" sz="700" b="1" dirty="0">
+                <a:solidFill>
+                  <a:srgbClr val="999999"/>
+                </a:solidFill>
+                <a:latin typeface="Arial" pitchFamily="34" charset="0"/>
+                <a:ea typeface="Arial" pitchFamily="34" charset="-122"/>
+                <a:cs typeface="Arial" pitchFamily="34" charset="-120"/>
+              </a:rPr>
+              <a:t>(8) </a:t>
+            </a:r>
+            <a:pPr indent="0" marL="0">
+              <a:buNone/>
+            </a:pPr>
+            <a:r>
+              <a:rPr lang="en-US" sz="700" dirty="0">
+                <a:solidFill>
+                  <a:srgbClr val="999999"/>
+                </a:solidFill>
+                <a:latin typeface="Arial" pitchFamily="34" charset="0"/>
+                <a:ea typeface="Arial" pitchFamily="34" charset="-122"/>
+                <a:cs typeface="Arial" pitchFamily="34" charset="-120"/>
+              </a:rPr>
+              <a:t>Gartner enterprise AI readiness, 2026, </a:t>
+            </a:r>
+            <a:pPr indent="0" marL="0">
+              <a:buNone/>
+            </a:pPr>
+            <a:r>
+              <a:rPr lang="en-US" sz="700" b="1" dirty="0">
+                <a:solidFill>
+                  <a:srgbClr val="999999"/>
+                </a:solidFill>
+                <a:latin typeface="Arial" pitchFamily="34" charset="0"/>
+                <a:ea typeface="Arial" pitchFamily="34" charset="-122"/>
+                <a:cs typeface="Arial" pitchFamily="34" charset="-120"/>
+              </a:rPr>
+              <a:t>(9) </a:t>
+            </a:r>
+            <a:pPr indent="0" marL="0">
+              <a:buNone/>
+            </a:pPr>
+            <a:r>
+              <a:rPr lang="en-US" sz="700" dirty="0">
+                <a:solidFill>
+                  <a:srgbClr val="999999"/>
+                </a:solidFill>
+                <a:latin typeface="Arial" pitchFamily="34" charset="0"/>
+                <a:ea typeface="Arial" pitchFamily="34" charset="-122"/>
+                <a:cs typeface="Arial" pitchFamily="34" charset="-120"/>
+              </a:rPr>
+              <a:t>US Commerce Dept CHIPS Office, Nov 2025, </a:t>
+            </a:r>
+            <a:pPr indent="0" marL="0">
+              <a:buNone/>
+            </a:pPr>
+            <a:r>
+              <a:rPr lang="en-US" sz="700" b="1" dirty="0">
+                <a:solidFill>
+                  <a:srgbClr val="999999"/>
+                </a:solidFill>
+                <a:latin typeface="Arial" pitchFamily="34" charset="0"/>
+                <a:ea typeface="Arial" pitchFamily="34" charset="-122"/>
+                <a:cs typeface="Arial" pitchFamily="34" charset="-120"/>
+              </a:rPr>
+              <a:t>(10) </a:t>
+            </a:r>
+            <a:pPr indent="0" marL="0">
+              <a:buNone/>
+            </a:pPr>
+            <a:r>
+              <a:rPr lang="en-US" sz="700" dirty="0">
+                <a:solidFill>
+                  <a:srgbClr val="999999"/>
+                </a:solidFill>
+                <a:latin typeface="Arial" pitchFamily="34" charset="0"/>
+                <a:ea typeface="Arial" pitchFamily="34" charset="-122"/>
+                <a:cs typeface="Arial" pitchFamily="34" charset="-120"/>
+              </a:rPr>
+              <a:t>IEA / USGS rare-earth reports, 2025, </a:t>
+            </a:r>
+            <a:pPr indent="0" marL="0">
+              <a:buNone/>
+            </a:pPr>
+            <a:r>
+              <a:rPr lang="en-US" sz="700" b="1" dirty="0">
+                <a:solidFill>
+                  <a:srgbClr val="999999"/>
+                </a:solidFill>
+                <a:latin typeface="Arial" pitchFamily="34" charset="0"/>
+                <a:ea typeface="Arial" pitchFamily="34" charset="-122"/>
+                <a:cs typeface="Arial" pitchFamily="34" charset="-120"/>
+              </a:rPr>
+              <a:t>(11) </a:t>
+            </a:r>
+            <a:pPr indent="0" marL="0">
+              <a:buNone/>
+            </a:pPr>
+            <a:r>
+              <a:rPr lang="en-US" sz="700" dirty="0">
+                <a:solidFill>
+                  <a:srgbClr val="999999"/>
+                </a:solidFill>
+                <a:latin typeface="Arial" pitchFamily="34" charset="0"/>
+                <a:ea typeface="Arial" pitchFamily="34" charset="-122"/>
+                <a:cs typeface="Arial" pitchFamily="34" charset="-120"/>
+              </a:rPr>
+              <a:t>China MOFCOM, Jul 2023, </a:t>
+            </a:r>
+            <a:pPr indent="0" marL="0">
+              <a:buNone/>
+            </a:pPr>
+            <a:r>
+              <a:rPr lang="en-US" sz="700" b="1" dirty="0">
+                <a:solidFill>
+                  <a:srgbClr val="999999"/>
+                </a:solidFill>
+                <a:latin typeface="Arial" pitchFamily="34" charset="0"/>
+                <a:ea typeface="Arial" pitchFamily="34" charset="-122"/>
+                <a:cs typeface="Arial" pitchFamily="34" charset="-120"/>
+              </a:rPr>
+              <a:t>(12) </a:t>
+            </a:r>
+            <a:pPr indent="0" marL="0">
+              <a:buNone/>
+            </a:pPr>
+            <a:r>
+              <a:rPr lang="en-US" sz="700" dirty="0">
+                <a:solidFill>
+                  <a:srgbClr val="999999"/>
+                </a:solidFill>
+                <a:latin typeface="Arial" pitchFamily="34" charset="0"/>
+                <a:ea typeface="Arial" pitchFamily="34" charset="-122"/>
+                <a:cs typeface="Arial" pitchFamily="34" charset="-120"/>
+              </a:rPr>
+              <a:t>TechInsights / trade press, 2025–26.</a:t>
             </a:r>
             <a:endParaRPr lang="en-US" sz="700" dirty="0"/>
           </a:p>

</xml_diff>

<commit_message>
Slides 10/17/18/19/20/21: add numbered citations and inline `(N) Source` format
- Superscript markers on each cited stat / player list, matching the
  pattern already applied to slides 13–16.
- addCitations renders each slide's source line as one wrapped 7pt gray
  paragraph with bold `(N)` markers, comma-separated.
- Slide 10: markers on each row valuation (1–4) and the funding banner (5).
- Slide 17: per-stat markers inside the three backlash cards.
- Slides 18/19/20: markers on headline stats and the PLAYERS row.
- Slide 21: markers on the three mechanism bodies and the yellow strip.

Co-Authored-By: Claude Opus 4.7 <noreply@anthropic.com>
</commit_message>
<xml_diff>
--- a/ai-markets-deck.pptx
+++ b/ai-markets-deck.pptx
@@ -5135,6 +5135,20 @@
               </a:rPr>
               <a:t>$852B</a:t>
             </a:r>
+            <a:pPr algn="ctr" indent="0" marL="0">
+              <a:buNone/>
+            </a:pPr>
+            <a:r>
+              <a:rPr lang="en-US" sz="1000" b="1" baseline="30000" dirty="0">
+                <a:solidFill>
+                  <a:srgbClr val="F6693D"/>
+                </a:solidFill>
+                <a:latin typeface="Arial Black" pitchFamily="34" charset="0"/>
+                <a:ea typeface="Arial Black" pitchFamily="34" charset="-122"/>
+                <a:cs typeface="Arial Black" pitchFamily="34" charset="-120"/>
+              </a:rPr>
+              <a:t> 1</a:t>
+            </a:r>
             <a:endParaRPr lang="en-US" sz="2000" dirty="0"/>
           </a:p>
         </p:txBody>
@@ -5339,6 +5353,20 @@
               </a:rPr>
               <a:t>$380B</a:t>
             </a:r>
+            <a:pPr algn="ctr" indent="0" marL="0">
+              <a:buNone/>
+            </a:pPr>
+            <a:r>
+              <a:rPr lang="en-US" sz="1000" b="1" baseline="30000" dirty="0">
+                <a:solidFill>
+                  <a:srgbClr val="F6693D"/>
+                </a:solidFill>
+                <a:latin typeface="Arial Black" pitchFamily="34" charset="0"/>
+                <a:ea typeface="Arial Black" pitchFamily="34" charset="-122"/>
+                <a:cs typeface="Arial Black" pitchFamily="34" charset="-120"/>
+              </a:rPr>
+              <a:t> 2</a:t>
+            </a:r>
             <a:endParaRPr lang="en-US" sz="2000" dirty="0"/>
           </a:p>
         </p:txBody>
@@ -5543,6 +5571,20 @@
               </a:rPr>
               <a:t>$2.3T</a:t>
             </a:r>
+            <a:pPr algn="ctr" indent="0" marL="0">
+              <a:buNone/>
+            </a:pPr>
+            <a:r>
+              <a:rPr lang="en-US" sz="1000" b="1" baseline="30000" dirty="0">
+                <a:solidFill>
+                  <a:srgbClr val="F6693D"/>
+                </a:solidFill>
+                <a:latin typeface="Arial Black" pitchFamily="34" charset="0"/>
+                <a:ea typeface="Arial Black" pitchFamily="34" charset="-122"/>
+                <a:cs typeface="Arial Black" pitchFamily="34" charset="-120"/>
+              </a:rPr>
+              <a:t> 3</a:t>
+            </a:r>
             <a:endParaRPr lang="en-US" sz="2000" dirty="0"/>
           </a:p>
         </p:txBody>
@@ -5747,6 +5789,20 @@
               </a:rPr>
               <a:t>$1.25T</a:t>
             </a:r>
+            <a:pPr algn="ctr" indent="0" marL="0">
+              <a:buNone/>
+            </a:pPr>
+            <a:r>
+              <a:rPr lang="en-US" sz="1000" b="1" baseline="30000" dirty="0">
+                <a:solidFill>
+                  <a:srgbClr val="F6693D"/>
+                </a:solidFill>
+                <a:latin typeface="Arial Black" pitchFamily="34" charset="0"/>
+                <a:ea typeface="Arial Black" pitchFamily="34" charset="-122"/>
+                <a:cs typeface="Arial Black" pitchFamily="34" charset="-120"/>
+              </a:rPr>
+              <a:t> 4</a:t>
+            </a:r>
             <a:endParaRPr lang="en-US" sz="2000" dirty="0"/>
           </a:p>
         </p:txBody>
@@ -5838,7 +5894,7 @@
         <p:spPr>
           <a:xfrm>
             <a:off x="457200" y="5166360"/>
-            <a:ext cx="8229600" cy="548640"/>
+            <a:ext cx="8229600" cy="502920"/>
           </a:xfrm>
           <a:prstGeom prst="rect">
             <a:avLst/>
@@ -5863,7 +5919,7 @@
         <p:spPr>
           <a:xfrm>
             <a:off x="640080" y="5166360"/>
-            <a:ext cx="7863840" cy="548640"/>
+            <a:ext cx="7863840" cy="502920"/>
           </a:xfrm>
           <a:prstGeom prst="rect">
             <a:avLst/>
@@ -5889,6 +5945,20 @@
               </a:rPr>
               <a:t>Q1 2026 funding to foundational AI startups was 2× all of 2025.</a:t>
             </a:r>
+            <a:pPr indent="0" marL="0">
+              <a:buNone/>
+            </a:pPr>
+            <a:r>
+              <a:rPr lang="en-US" sz="800" b="1" baseline="30000" dirty="0">
+                <a:solidFill>
+                  <a:srgbClr val="000000"/>
+                </a:solidFill>
+                <a:latin typeface="Arial" pitchFamily="34" charset="0"/>
+                <a:ea typeface="Arial" pitchFamily="34" charset="-122"/>
+                <a:cs typeface="Arial" pitchFamily="34" charset="-120"/>
+              </a:rPr>
+              <a:t> 5</a:t>
+            </a:r>
             <a:endParaRPr lang="en-US" sz="1400" dirty="0"/>
           </a:p>
         </p:txBody>
@@ -5902,7 +5972,7 @@
         <p:spPr>
           <a:xfrm>
             <a:off x="457200" y="5875020"/>
-            <a:ext cx="8229600" cy="320040"/>
+            <a:ext cx="8229600" cy="457200"/>
           </a:xfrm>
           <a:prstGeom prst="rect">
             <a:avLst/>
@@ -5918,6 +5988,20 @@
               <a:buNone/>
             </a:pPr>
             <a:r>
+              <a:rPr lang="en-US" sz="700" b="1" dirty="0">
+                <a:solidFill>
+                  <a:srgbClr val="999999"/>
+                </a:solidFill>
+                <a:latin typeface="Arial" pitchFamily="34" charset="0"/>
+                <a:ea typeface="Arial" pitchFamily="34" charset="-122"/>
+                <a:cs typeface="Arial" pitchFamily="34" charset="-120"/>
+              </a:rPr>
+              <a:t>(1) </a:t>
+            </a:r>
+            <a:pPr indent="0" marL="0">
+              <a:buNone/>
+            </a:pPr>
+            <a:r>
               <a:rPr lang="en-US" sz="700" dirty="0">
                 <a:solidFill>
                   <a:srgbClr val="999999"/>
@@ -5926,7 +6010,119 @@
                 <a:ea typeface="Arial" pitchFamily="34" charset="-122"/>
                 <a:cs typeface="Arial" pitchFamily="34" charset="-120"/>
               </a:rPr>
-              <a:t>Sources: TechCrunch, CNBC (Feb 2, 2026 xAI/SpaceX merger); Crunchbase Q1 2026 VC data; Sacra ARR run-rates; Bloomberg; Alphabet 10-K &amp; 2026 capex guide.</a:t>
+              <a:t>Bloomberg / CNBC — OpenAI $122B round, Apr 2026, </a:t>
+            </a:r>
+            <a:pPr indent="0" marL="0">
+              <a:buNone/>
+            </a:pPr>
+            <a:r>
+              <a:rPr lang="en-US" sz="700" b="1" dirty="0">
+                <a:solidFill>
+                  <a:srgbClr val="999999"/>
+                </a:solidFill>
+                <a:latin typeface="Arial" pitchFamily="34" charset="0"/>
+                <a:ea typeface="Arial" pitchFamily="34" charset="-122"/>
+                <a:cs typeface="Arial" pitchFamily="34" charset="-120"/>
+              </a:rPr>
+              <a:t>(2) </a:t>
+            </a:r>
+            <a:pPr indent="0" marL="0">
+              <a:buNone/>
+            </a:pPr>
+            <a:r>
+              <a:rPr lang="en-US" sz="700" dirty="0">
+                <a:solidFill>
+                  <a:srgbClr val="999999"/>
+                </a:solidFill>
+                <a:latin typeface="Arial" pitchFamily="34" charset="0"/>
+                <a:ea typeface="Arial" pitchFamily="34" charset="-122"/>
+                <a:cs typeface="Arial" pitchFamily="34" charset="-120"/>
+              </a:rPr>
+              <a:t>Sacra / Bloomberg — Anthropic Series G, Feb 2026, </a:t>
+            </a:r>
+            <a:pPr indent="0" marL="0">
+              <a:buNone/>
+            </a:pPr>
+            <a:r>
+              <a:rPr lang="en-US" sz="700" b="1" dirty="0">
+                <a:solidFill>
+                  <a:srgbClr val="999999"/>
+                </a:solidFill>
+                <a:latin typeface="Arial" pitchFamily="34" charset="0"/>
+                <a:ea typeface="Arial" pitchFamily="34" charset="-122"/>
+                <a:cs typeface="Arial" pitchFamily="34" charset="-120"/>
+              </a:rPr>
+              <a:t>(3) </a:t>
+            </a:r>
+            <a:pPr indent="0" marL="0">
+              <a:buNone/>
+            </a:pPr>
+            <a:r>
+              <a:rPr lang="en-US" sz="700" dirty="0">
+                <a:solidFill>
+                  <a:srgbClr val="999999"/>
+                </a:solidFill>
+                <a:latin typeface="Arial" pitchFamily="34" charset="0"/>
+                <a:ea typeface="Arial" pitchFamily="34" charset="-122"/>
+                <a:cs typeface="Arial" pitchFamily="34" charset="-120"/>
+              </a:rPr>
+              <a:t>Alphabet 10-K + 2026 capex guide, </a:t>
+            </a:r>
+            <a:pPr indent="0" marL="0">
+              <a:buNone/>
+            </a:pPr>
+            <a:r>
+              <a:rPr lang="en-US" sz="700" b="1" dirty="0">
+                <a:solidFill>
+                  <a:srgbClr val="999999"/>
+                </a:solidFill>
+                <a:latin typeface="Arial" pitchFamily="34" charset="0"/>
+                <a:ea typeface="Arial" pitchFamily="34" charset="-122"/>
+                <a:cs typeface="Arial" pitchFamily="34" charset="-120"/>
+              </a:rPr>
+              <a:t>(4) </a:t>
+            </a:r>
+            <a:pPr indent="0" marL="0">
+              <a:buNone/>
+            </a:pPr>
+            <a:r>
+              <a:rPr lang="en-US" sz="700" dirty="0">
+                <a:solidFill>
+                  <a:srgbClr val="999999"/>
+                </a:solidFill>
+                <a:latin typeface="Arial" pitchFamily="34" charset="0"/>
+                <a:ea typeface="Arial" pitchFamily="34" charset="-122"/>
+                <a:cs typeface="Arial" pitchFamily="34" charset="-120"/>
+              </a:rPr>
+              <a:t>TechCrunch / CNBC — xAI-SpaceX merger, Feb 2, 2026, </a:t>
+            </a:r>
+            <a:pPr indent="0" marL="0">
+              <a:buNone/>
+            </a:pPr>
+            <a:r>
+              <a:rPr lang="en-US" sz="700" b="1" dirty="0">
+                <a:solidFill>
+                  <a:srgbClr val="999999"/>
+                </a:solidFill>
+                <a:latin typeface="Arial" pitchFamily="34" charset="0"/>
+                <a:ea typeface="Arial" pitchFamily="34" charset="-122"/>
+                <a:cs typeface="Arial" pitchFamily="34" charset="-120"/>
+              </a:rPr>
+              <a:t>(5) </a:t>
+            </a:r>
+            <a:pPr indent="0" marL="0">
+              <a:buNone/>
+            </a:pPr>
+            <a:r>
+              <a:rPr lang="en-US" sz="700" dirty="0">
+                <a:solidFill>
+                  <a:srgbClr val="999999"/>
+                </a:solidFill>
+                <a:latin typeface="Arial" pitchFamily="34" charset="0"/>
+                <a:ea typeface="Arial" pitchFamily="34" charset="-122"/>
+                <a:cs typeface="Arial" pitchFamily="34" charset="-120"/>
+              </a:rPr>
+              <a:t>Crunchbase Q1 2026 VC data.</a:t>
             </a:r>
             <a:endParaRPr lang="en-US" sz="700" dirty="0"/>
           </a:p>
@@ -16843,6 +17039,20 @@
               </a:rPr>
               <a:t>$18B halted, $46B delayed. 142 activist groups across 24 states — Virginia leads with 42 chapters.</a:t>
             </a:r>
+            <a:pPr indent="0" marL="0">
+              <a:buNone/>
+            </a:pPr>
+            <a:r>
+              <a:rPr lang="en-US" sz="700" baseline="30000" dirty="0">
+                <a:solidFill>
+                  <a:srgbClr val="333333"/>
+                </a:solidFill>
+                <a:latin typeface="Arial" pitchFamily="34" charset="0"/>
+                <a:ea typeface="Arial" pitchFamily="34" charset="-122"/>
+                <a:cs typeface="Arial" pitchFamily="34" charset="-120"/>
+              </a:rPr>
+              <a:t> 1</a:t>
+            </a:r>
             <a:endParaRPr lang="en-US" sz="1050" dirty="0"/>
           </a:p>
         </p:txBody>
@@ -16969,7 +17179,63 @@
                 <a:ea typeface="Arial" pitchFamily="34" charset="-122"/>
                 <a:cs typeface="Arial" pitchFamily="34" charset="-120"/>
               </a:rPr>
-              <a:t>Only 26% of Americans view AI positively. March 2026 "Stop the AI Race" protests hit lab HQs in SF and DC.</a:t>
+              <a:t>Only 26%</a:t>
+            </a:r>
+            <a:pPr indent="0" marL="0">
+              <a:buNone/>
+            </a:pPr>
+            <a:r>
+              <a:rPr lang="en-US" sz="700" baseline="30000" dirty="0">
+                <a:solidFill>
+                  <a:srgbClr val="333333"/>
+                </a:solidFill>
+                <a:latin typeface="Arial" pitchFamily="34" charset="0"/>
+                <a:ea typeface="Arial" pitchFamily="34" charset="-122"/>
+                <a:cs typeface="Arial" pitchFamily="34" charset="-120"/>
+              </a:rPr>
+              <a:t> 2</a:t>
+            </a:r>
+            <a:pPr indent="0" marL="0">
+              <a:buNone/>
+            </a:pPr>
+            <a:r>
+              <a:rPr lang="en-US" sz="1050" dirty="0">
+                <a:solidFill>
+                  <a:srgbClr val="333333"/>
+                </a:solidFill>
+                <a:latin typeface="Arial" pitchFamily="34" charset="0"/>
+                <a:ea typeface="Arial" pitchFamily="34" charset="-122"/>
+                <a:cs typeface="Arial" pitchFamily="34" charset="-120"/>
+              </a:rPr>
+              <a:t> of Americans view AI positively. March 2026 "Stop the AI Race" protests</a:t>
+            </a:r>
+            <a:pPr indent="0" marL="0">
+              <a:buNone/>
+            </a:pPr>
+            <a:r>
+              <a:rPr lang="en-US" sz="700" baseline="30000" dirty="0">
+                <a:solidFill>
+                  <a:srgbClr val="333333"/>
+                </a:solidFill>
+                <a:latin typeface="Arial" pitchFamily="34" charset="0"/>
+                <a:ea typeface="Arial" pitchFamily="34" charset="-122"/>
+                <a:cs typeface="Arial" pitchFamily="34" charset="-120"/>
+              </a:rPr>
+              <a:t> 3</a:t>
+            </a:r>
+            <a:pPr indent="0" marL="0">
+              <a:buNone/>
+            </a:pPr>
+            <a:r>
+              <a:rPr lang="en-US" sz="1050" dirty="0">
+                <a:solidFill>
+                  <a:srgbClr val="333333"/>
+                </a:solidFill>
+                <a:latin typeface="Arial" pitchFamily="34" charset="0"/>
+                <a:ea typeface="Arial" pitchFamily="34" charset="-122"/>
+                <a:cs typeface="Arial" pitchFamily="34" charset="-120"/>
+              </a:rPr>
+              <a:t> hit lab HQs in SF and DC.</a:t>
             </a:r>
             <a:endParaRPr lang="en-US" sz="1050" dirty="0"/>
           </a:p>
@@ -17097,7 +17363,35 @@
                 <a:ea typeface="Arial" pitchFamily="34" charset="-122"/>
                 <a:cs typeface="Arial" pitchFamily="34" charset="-120"/>
               </a:rPr>
-              <a:t>A ~480K data-center workforce gap against 400+ sites under construction. Talent, not capital, is binding.</a:t>
+              <a:t>A ~480K data-center workforce gap against 400+ sites under construction.</a:t>
+            </a:r>
+            <a:pPr indent="0" marL="0">
+              <a:buNone/>
+            </a:pPr>
+            <a:r>
+              <a:rPr lang="en-US" sz="700" baseline="30000" dirty="0">
+                <a:solidFill>
+                  <a:srgbClr val="333333"/>
+                </a:solidFill>
+                <a:latin typeface="Arial" pitchFamily="34" charset="0"/>
+                <a:ea typeface="Arial" pitchFamily="34" charset="-122"/>
+                <a:cs typeface="Arial" pitchFamily="34" charset="-120"/>
+              </a:rPr>
+              <a:t> 4</a:t>
+            </a:r>
+            <a:pPr indent="0" marL="0">
+              <a:buNone/>
+            </a:pPr>
+            <a:r>
+              <a:rPr lang="en-US" sz="1050" dirty="0">
+                <a:solidFill>
+                  <a:srgbClr val="333333"/>
+                </a:solidFill>
+                <a:latin typeface="Arial" pitchFamily="34" charset="0"/>
+                <a:ea typeface="Arial" pitchFamily="34" charset="-122"/>
+                <a:cs typeface="Arial" pitchFamily="34" charset="-120"/>
+              </a:rPr>
+              <a:t> Talent, not capital, is binding.</a:t>
             </a:r>
             <a:endParaRPr lang="en-US" sz="1050" dirty="0"/>
           </a:p>
@@ -17176,7 +17470,7 @@
         <p:spPr>
           <a:xfrm>
             <a:off x="457200" y="5875020"/>
-            <a:ext cx="8229600" cy="320040"/>
+            <a:ext cx="8229600" cy="457200"/>
           </a:xfrm>
           <a:prstGeom prst="rect">
             <a:avLst/>
@@ -17192,6 +17486,20 @@
               <a:buNone/>
             </a:pPr>
             <a:r>
+              <a:rPr lang="en-US" sz="700" b="1" dirty="0">
+                <a:solidFill>
+                  <a:srgbClr val="999999"/>
+                </a:solidFill>
+                <a:latin typeface="Arial" pitchFamily="34" charset="0"/>
+                <a:ea typeface="Arial" pitchFamily="34" charset="-122"/>
+                <a:cs typeface="Arial" pitchFamily="34" charset="-120"/>
+              </a:rPr>
+              <a:t>(1) </a:t>
+            </a:r>
+            <a:pPr indent="0" marL="0">
+              <a:buNone/>
+            </a:pPr>
+            <a:r>
               <a:rPr lang="en-US" sz="700" dirty="0">
                 <a:solidFill>
                   <a:srgbClr val="999999"/>
@@ -17200,7 +17508,91 @@
                 <a:ea typeface="Arial" pitchFamily="34" charset="-122"/>
                 <a:cs typeface="Arial" pitchFamily="34" charset="-120"/>
               </a:rPr>
-              <a:t>Sources: Data Center Watch ($18B halted, $46B delayed, 142 groups); Echelon Insights; Stop the AI Race; Fortune; TIME; CNN; NBC News; Data Center Frontier.</a:t>
+              <a:t>Data Center Watch, 2026 NIMBY tracker, </a:t>
+            </a:r>
+            <a:pPr indent="0" marL="0">
+              <a:buNone/>
+            </a:pPr>
+            <a:r>
+              <a:rPr lang="en-US" sz="700" b="1" dirty="0">
+                <a:solidFill>
+                  <a:srgbClr val="999999"/>
+                </a:solidFill>
+                <a:latin typeface="Arial" pitchFamily="34" charset="0"/>
+                <a:ea typeface="Arial" pitchFamily="34" charset="-122"/>
+                <a:cs typeface="Arial" pitchFamily="34" charset="-120"/>
+              </a:rPr>
+              <a:t>(2) </a:t>
+            </a:r>
+            <a:pPr indent="0" marL="0">
+              <a:buNone/>
+            </a:pPr>
+            <a:r>
+              <a:rPr lang="en-US" sz="700" dirty="0">
+                <a:solidFill>
+                  <a:srgbClr val="999999"/>
+                </a:solidFill>
+                <a:latin typeface="Arial" pitchFamily="34" charset="0"/>
+                <a:ea typeface="Arial" pitchFamily="34" charset="-122"/>
+                <a:cs typeface="Arial" pitchFamily="34" charset="-120"/>
+              </a:rPr>
+              <a:t>Echelon Insights, Mar 2026 AI sentiment poll, </a:t>
+            </a:r>
+            <a:pPr indent="0" marL="0">
+              <a:buNone/>
+            </a:pPr>
+            <a:r>
+              <a:rPr lang="en-US" sz="700" b="1" dirty="0">
+                <a:solidFill>
+                  <a:srgbClr val="999999"/>
+                </a:solidFill>
+                <a:latin typeface="Arial" pitchFamily="34" charset="0"/>
+                <a:ea typeface="Arial" pitchFamily="34" charset="-122"/>
+                <a:cs typeface="Arial" pitchFamily="34" charset="-120"/>
+              </a:rPr>
+              <a:t>(3) </a:t>
+            </a:r>
+            <a:pPr indent="0" marL="0">
+              <a:buNone/>
+            </a:pPr>
+            <a:r>
+              <a:rPr lang="en-US" sz="700" dirty="0">
+                <a:solidFill>
+                  <a:srgbClr val="999999"/>
+                </a:solidFill>
+                <a:latin typeface="Arial" pitchFamily="34" charset="0"/>
+                <a:ea typeface="Arial" pitchFamily="34" charset="-122"/>
+                <a:cs typeface="Arial" pitchFamily="34" charset="-120"/>
+              </a:rPr>
+              <a:t>Fortune / TIME / CNN / NBC News — Stop the AI Race coverage, </a:t>
+            </a:r>
+            <a:pPr indent="0" marL="0">
+              <a:buNone/>
+            </a:pPr>
+            <a:r>
+              <a:rPr lang="en-US" sz="700" b="1" dirty="0">
+                <a:solidFill>
+                  <a:srgbClr val="999999"/>
+                </a:solidFill>
+                <a:latin typeface="Arial" pitchFamily="34" charset="0"/>
+                <a:ea typeface="Arial" pitchFamily="34" charset="-122"/>
+                <a:cs typeface="Arial" pitchFamily="34" charset="-120"/>
+              </a:rPr>
+              <a:t>(4) </a:t>
+            </a:r>
+            <a:pPr indent="0" marL="0">
+              <a:buNone/>
+            </a:pPr>
+            <a:r>
+              <a:rPr lang="en-US" sz="700" dirty="0">
+                <a:solidFill>
+                  <a:srgbClr val="999999"/>
+                </a:solidFill>
+                <a:latin typeface="Arial" pitchFamily="34" charset="0"/>
+                <a:ea typeface="Arial" pitchFamily="34" charset="-122"/>
+                <a:cs typeface="Arial" pitchFamily="34" charset="-120"/>
+              </a:rPr>
+              <a:t>Data Center Frontier — workforce gap analysis.</a:t>
             </a:r>
             <a:endParaRPr lang="en-US" sz="700" dirty="0"/>
           </a:p>
@@ -17472,7 +17864,35 @@
                 <a:ea typeface="Arial" pitchFamily="34" charset="-122"/>
                 <a:cs typeface="Arial" pitchFamily="34" charset="-120"/>
               </a:rPr>
-              <a:t>No interconnection queue. No permits. No water. 1,361 W/m² of unfiltered solar, 24/7. Orbital compute sidesteps Earth's bottlenecks.</a:t>
+              <a:t>No interconnection queue. No permits. No water. 1,361 W/m²</a:t>
+            </a:r>
+            <a:pPr indent="0" marL="0">
+              <a:buNone/>
+            </a:pPr>
+            <a:r>
+              <a:rPr lang="en-US" sz="700" baseline="30000" dirty="0">
+                <a:solidFill>
+                  <a:srgbClr val="666666"/>
+                </a:solidFill>
+                <a:latin typeface="Arial" pitchFamily="34" charset="0"/>
+                <a:ea typeface="Arial" pitchFamily="34" charset="-122"/>
+                <a:cs typeface="Arial" pitchFamily="34" charset="-120"/>
+              </a:rPr>
+              <a:t> 1</a:t>
+            </a:r>
+            <a:pPr indent="0" marL="0">
+              <a:buNone/>
+            </a:pPr>
+            <a:r>
+              <a:rPr lang="en-US" sz="1350" dirty="0">
+                <a:solidFill>
+                  <a:srgbClr val="666666"/>
+                </a:solidFill>
+                <a:latin typeface="Arial" pitchFamily="34" charset="0"/>
+                <a:ea typeface="Arial" pitchFamily="34" charset="-122"/>
+                <a:cs typeface="Arial" pitchFamily="34" charset="-120"/>
+              </a:rPr>
+              <a:t> of unfiltered solar, 24/7. Orbital compute sidesteps Earth's bottlenecks.</a:t>
             </a:r>
             <a:endParaRPr lang="en-US" sz="1350" dirty="0"/>
           </a:p>
@@ -18023,6 +18443,20 @@
               </a:rPr>
               <a:t>Starcloud · SpaceX · Google Suncatcher · Aetherflux</a:t>
             </a:r>
+            <a:pPr indent="0" marL="0">
+              <a:buNone/>
+            </a:pPr>
+            <a:r>
+              <a:rPr lang="en-US" sz="800" baseline="30000" dirty="0">
+                <a:solidFill>
+                  <a:srgbClr val="FFFFFF"/>
+                </a:solidFill>
+                <a:latin typeface="Arial" pitchFamily="34" charset="0"/>
+                <a:ea typeface="Arial" pitchFamily="34" charset="-122"/>
+                <a:cs typeface="Arial" pitchFamily="34" charset="-120"/>
+              </a:rPr>
+              <a:t> 2</a:t>
+            </a:r>
             <a:endParaRPr lang="en-US" sz="950" dirty="0"/>
           </a:p>
         </p:txBody>
@@ -18036,7 +18470,7 @@
         <p:spPr>
           <a:xfrm>
             <a:off x="457200" y="5875020"/>
-            <a:ext cx="8229600" cy="320040"/>
+            <a:ext cx="8229600" cy="457200"/>
           </a:xfrm>
           <a:prstGeom prst="rect">
             <a:avLst/>
@@ -18052,6 +18486,20 @@
               <a:buNone/>
             </a:pPr>
             <a:r>
+              <a:rPr lang="en-US" sz="700" b="1" dirty="0">
+                <a:solidFill>
+                  <a:srgbClr val="999999"/>
+                </a:solidFill>
+                <a:latin typeface="Arial" pitchFamily="34" charset="0"/>
+                <a:ea typeface="Arial" pitchFamily="34" charset="-122"/>
+                <a:cs typeface="Arial" pitchFamily="34" charset="-120"/>
+              </a:rPr>
+              <a:t>(1) </a:t>
+            </a:r>
+            <a:pPr indent="0" marL="0">
+              <a:buNone/>
+            </a:pPr>
+            <a:r>
               <a:rPr lang="en-US" sz="700" dirty="0">
                 <a:solidFill>
                   <a:srgbClr val="999999"/>
@@ -18060,7 +18508,35 @@
                 <a:ea typeface="Arial" pitchFamily="34" charset="-122"/>
                 <a:cs typeface="Arial" pitchFamily="34" charset="-120"/>
               </a:rPr>
-              <a:t>Source: FCC filings; Starcloud, Google, SpaceX announcements; CNBC.</a:t>
+              <a:t>NASA solar constant, 1,361 W/m² at 1 AU, </a:t>
+            </a:r>
+            <a:pPr indent="0" marL="0">
+              <a:buNone/>
+            </a:pPr>
+            <a:r>
+              <a:rPr lang="en-US" sz="700" b="1" dirty="0">
+                <a:solidFill>
+                  <a:srgbClr val="999999"/>
+                </a:solidFill>
+                <a:latin typeface="Arial" pitchFamily="34" charset="0"/>
+                <a:ea typeface="Arial" pitchFamily="34" charset="-122"/>
+                <a:cs typeface="Arial" pitchFamily="34" charset="-120"/>
+              </a:rPr>
+              <a:t>(2) </a:t>
+            </a:r>
+            <a:pPr indent="0" marL="0">
+              <a:buNone/>
+            </a:pPr>
+            <a:r>
+              <a:rPr lang="en-US" sz="700" dirty="0">
+                <a:solidFill>
+                  <a:srgbClr val="999999"/>
+                </a:solidFill>
+                <a:latin typeface="Arial" pitchFamily="34" charset="0"/>
+                <a:ea typeface="Arial" pitchFamily="34" charset="-122"/>
+                <a:cs typeface="Arial" pitchFamily="34" charset="-120"/>
+              </a:rPr>
+              <a:t>FCC filings; Starcloud, SpaceX, Google Suncatcher, Aetherflux announcements; CNBC.</a:t>
             </a:r>
             <a:endParaRPr lang="en-US" sz="700" dirty="0"/>
           </a:p>
@@ -18549,6 +19025,20 @@
               </a:rPr>
               <a:t>Manufacturing, logistics, warehousing, agriculture, healthcare — pilots are underway.</a:t>
             </a:r>
+            <a:pPr indent="0" marL="0">
+              <a:buNone/>
+            </a:pPr>
+            <a:r>
+              <a:rPr lang="en-US" sz="650" baseline="30000" dirty="0">
+                <a:solidFill>
+                  <a:srgbClr val="333333"/>
+                </a:solidFill>
+                <a:latin typeface="Arial" pitchFamily="34" charset="0"/>
+                <a:ea typeface="Arial" pitchFamily="34" charset="-122"/>
+                <a:cs typeface="Arial" pitchFamily="34" charset="-120"/>
+              </a:rPr>
+              <a:t> 1</a:t>
+            </a:r>
             <a:endParaRPr lang="en-US" sz="1000" dirty="0"/>
           </a:p>
         </p:txBody>
@@ -18805,6 +19295,20 @@
               </a:rPr>
               <a:t>Every robot runs foundation models in real time. At scale, rivals LLM compute.</a:t>
             </a:r>
+            <a:pPr indent="0" marL="0">
+              <a:buNone/>
+            </a:pPr>
+            <a:r>
+              <a:rPr lang="en-US" sz="650" baseline="30000" dirty="0">
+                <a:solidFill>
+                  <a:srgbClr val="333333"/>
+                </a:solidFill>
+                <a:latin typeface="Arial" pitchFamily="34" charset="0"/>
+                <a:ea typeface="Arial" pitchFamily="34" charset="-122"/>
+                <a:cs typeface="Arial" pitchFamily="34" charset="-120"/>
+              </a:rPr>
+              <a:t> 2</a:t>
+            </a:r>
             <a:endParaRPr lang="en-US" sz="1000" dirty="0"/>
           </a:p>
         </p:txBody>
@@ -18883,6 +19387,20 @@
               </a:rPr>
               <a:t>Tesla Optimus · Figure · Boston Dynamics · Unitree · Agility</a:t>
             </a:r>
+            <a:pPr indent="0" marL="0">
+              <a:buNone/>
+            </a:pPr>
+            <a:r>
+              <a:rPr lang="en-US" sz="800" baseline="30000" dirty="0">
+                <a:solidFill>
+                  <a:srgbClr val="FFFFFF"/>
+                </a:solidFill>
+                <a:latin typeface="Arial" pitchFamily="34" charset="0"/>
+                <a:ea typeface="Arial" pitchFamily="34" charset="-122"/>
+                <a:cs typeface="Arial" pitchFamily="34" charset="-120"/>
+              </a:rPr>
+              <a:t> 3</a:t>
+            </a:r>
             <a:endParaRPr lang="en-US" sz="950" dirty="0"/>
           </a:p>
         </p:txBody>
@@ -18896,7 +19414,7 @@
         <p:spPr>
           <a:xfrm>
             <a:off x="457200" y="5875020"/>
-            <a:ext cx="8229600" cy="320040"/>
+            <a:ext cx="8229600" cy="457200"/>
           </a:xfrm>
           <a:prstGeom prst="rect">
             <a:avLst/>
@@ -18912,6 +19430,20 @@
               <a:buNone/>
             </a:pPr>
             <a:r>
+              <a:rPr lang="en-US" sz="700" b="1" dirty="0">
+                <a:solidFill>
+                  <a:srgbClr val="999999"/>
+                </a:solidFill>
+                <a:latin typeface="Arial" pitchFamily="34" charset="0"/>
+                <a:ea typeface="Arial" pitchFamily="34" charset="-122"/>
+                <a:cs typeface="Arial" pitchFamily="34" charset="-120"/>
+              </a:rPr>
+              <a:t>(1) </a:t>
+            </a:r>
+            <a:pPr indent="0" marL="0">
+              <a:buNone/>
+            </a:pPr>
+            <a:r>
               <a:rPr lang="en-US" sz="700" dirty="0">
                 <a:solidFill>
                   <a:srgbClr val="999999"/>
@@ -18920,7 +19452,63 @@
                 <a:ea typeface="Arial" pitchFamily="34" charset="-122"/>
                 <a:cs typeface="Arial" pitchFamily="34" charset="-120"/>
               </a:rPr>
-              <a:t>Source: Goldman Sachs; Figure AI, Tesla, Hyundai, NVIDIA; company announcements.</a:t>
+              <a:t>Goldman Sachs — humanoid robotics market outlook, </a:t>
+            </a:r>
+            <a:pPr indent="0" marL="0">
+              <a:buNone/>
+            </a:pPr>
+            <a:r>
+              <a:rPr lang="en-US" sz="700" b="1" dirty="0">
+                <a:solidFill>
+                  <a:srgbClr val="999999"/>
+                </a:solidFill>
+                <a:latin typeface="Arial" pitchFamily="34" charset="0"/>
+                <a:ea typeface="Arial" pitchFamily="34" charset="-122"/>
+                <a:cs typeface="Arial" pitchFamily="34" charset="-120"/>
+              </a:rPr>
+              <a:t>(2) </a:t>
+            </a:r>
+            <a:pPr indent="0" marL="0">
+              <a:buNone/>
+            </a:pPr>
+            <a:r>
+              <a:rPr lang="en-US" sz="700" dirty="0">
+                <a:solidFill>
+                  <a:srgbClr val="999999"/>
+                </a:solidFill>
+                <a:latin typeface="Arial" pitchFamily="34" charset="0"/>
+                <a:ea typeface="Arial" pitchFamily="34" charset="-122"/>
+                <a:cs typeface="Arial" pitchFamily="34" charset="-120"/>
+              </a:rPr>
+              <a:t>NVIDIA FY2026 — robotics compute keynotes, </a:t>
+            </a:r>
+            <a:pPr indent="0" marL="0">
+              <a:buNone/>
+            </a:pPr>
+            <a:r>
+              <a:rPr lang="en-US" sz="700" b="1" dirty="0">
+                <a:solidFill>
+                  <a:srgbClr val="999999"/>
+                </a:solidFill>
+                <a:latin typeface="Arial" pitchFamily="34" charset="0"/>
+                <a:ea typeface="Arial" pitchFamily="34" charset="-122"/>
+                <a:cs typeface="Arial" pitchFamily="34" charset="-120"/>
+              </a:rPr>
+              <a:t>(3) </a:t>
+            </a:r>
+            <a:pPr indent="0" marL="0">
+              <a:buNone/>
+            </a:pPr>
+            <a:r>
+              <a:rPr lang="en-US" sz="700" dirty="0">
+                <a:solidFill>
+                  <a:srgbClr val="999999"/>
+                </a:solidFill>
+                <a:latin typeface="Arial" pitchFamily="34" charset="0"/>
+                <a:ea typeface="Arial" pitchFamily="34" charset="-122"/>
+                <a:cs typeface="Arial" pitchFamily="34" charset="-120"/>
+              </a:rPr>
+              <a:t>Tesla, Figure AI, Hyundai/Boston Dynamics, Unitree, Agility — company announcements.</a:t>
             </a:r>
             <a:endParaRPr lang="en-US" sz="700" dirty="0"/>
           </a:p>
@@ -20603,7 +21191,35 @@
                 <a:ea typeface="Arial" pitchFamily="34" charset="-122"/>
                 <a:cs typeface="Arial" pitchFamily="34" charset="-120"/>
               </a:rPr>
-              <a:t>Human drivers cause ~1.35M deaths a year. Autonomous systems don't tire or lose focus.</a:t>
+              <a:t>Human drivers cause ~1.35M deaths a year.</a:t>
+            </a:r>
+            <a:pPr indent="0" marL="0">
+              <a:buNone/>
+            </a:pPr>
+            <a:r>
+              <a:rPr lang="en-US" sz="700" baseline="30000" dirty="0">
+                <a:solidFill>
+                  <a:srgbClr val="333333"/>
+                </a:solidFill>
+                <a:latin typeface="Arial" pitchFamily="34" charset="0"/>
+                <a:ea typeface="Arial" pitchFamily="34" charset="-122"/>
+                <a:cs typeface="Arial" pitchFamily="34" charset="-120"/>
+              </a:rPr>
+              <a:t> 1</a:t>
+            </a:r>
+            <a:pPr indent="0" marL="0">
+              <a:buNone/>
+            </a:pPr>
+            <a:r>
+              <a:rPr lang="en-US" sz="1050" dirty="0">
+                <a:solidFill>
+                  <a:srgbClr val="333333"/>
+                </a:solidFill>
+                <a:latin typeface="Arial" pitchFamily="34" charset="0"/>
+                <a:ea typeface="Arial" pitchFamily="34" charset="-122"/>
+                <a:cs typeface="Arial" pitchFamily="34" charset="-120"/>
+              </a:rPr>
+              <a:t> Autonomous systems don't tire or lose focus.</a:t>
             </a:r>
             <a:endParaRPr lang="en-US" sz="1050" dirty="0"/>
           </a:p>
@@ -20861,6 +21477,20 @@
               </a:rPr>
               <a:t>Each AV runs thousands of AI ops / second across cameras, lidar, radar — frontier-scale compute.</a:t>
             </a:r>
+            <a:pPr indent="0" marL="0">
+              <a:buNone/>
+            </a:pPr>
+            <a:r>
+              <a:rPr lang="en-US" sz="700" baseline="30000" dirty="0">
+                <a:solidFill>
+                  <a:srgbClr val="333333"/>
+                </a:solidFill>
+                <a:latin typeface="Arial" pitchFamily="34" charset="0"/>
+                <a:ea typeface="Arial" pitchFamily="34" charset="-122"/>
+                <a:cs typeface="Arial" pitchFamily="34" charset="-120"/>
+              </a:rPr>
+              <a:t> 2</a:t>
+            </a:r>
             <a:endParaRPr lang="en-US" sz="1050" dirty="0"/>
           </a:p>
         </p:txBody>
@@ -20939,6 +21569,20 @@
               </a:rPr>
               <a:t>Waymo · Tesla FSD · Baidu Apollo · Aurora</a:t>
             </a:r>
+            <a:pPr indent="0" marL="0">
+              <a:buNone/>
+            </a:pPr>
+            <a:r>
+              <a:rPr lang="en-US" sz="800" baseline="30000" dirty="0">
+                <a:solidFill>
+                  <a:srgbClr val="FFFFFF"/>
+                </a:solidFill>
+                <a:latin typeface="Arial" pitchFamily="34" charset="0"/>
+                <a:ea typeface="Arial" pitchFamily="34" charset="-122"/>
+                <a:cs typeface="Arial" pitchFamily="34" charset="-120"/>
+              </a:rPr>
+              <a:t> 3</a:t>
+            </a:r>
             <a:endParaRPr lang="en-US" sz="950" dirty="0"/>
           </a:p>
         </p:txBody>
@@ -20952,7 +21596,7 @@
         <p:spPr>
           <a:xfrm>
             <a:off x="457200" y="5875020"/>
-            <a:ext cx="8229600" cy="320040"/>
+            <a:ext cx="8229600" cy="457200"/>
           </a:xfrm>
           <a:prstGeom prst="rect">
             <a:avLst/>
@@ -20968,6 +21612,20 @@
               <a:buNone/>
             </a:pPr>
             <a:r>
+              <a:rPr lang="en-US" sz="700" b="1" dirty="0">
+                <a:solidFill>
+                  <a:srgbClr val="999999"/>
+                </a:solidFill>
+                <a:latin typeface="Arial" pitchFamily="34" charset="0"/>
+                <a:ea typeface="Arial" pitchFamily="34" charset="-122"/>
+                <a:cs typeface="Arial" pitchFamily="34" charset="-120"/>
+              </a:rPr>
+              <a:t>(1) </a:t>
+            </a:r>
+            <a:pPr indent="0" marL="0">
+              <a:buNone/>
+            </a:pPr>
+            <a:r>
               <a:rPr lang="en-US" sz="700" dirty="0">
                 <a:solidFill>
                   <a:srgbClr val="999999"/>
@@ -20976,7 +21634,63 @@
                 <a:ea typeface="Arial" pitchFamily="34" charset="-122"/>
                 <a:cs typeface="Arial" pitchFamily="34" charset="-120"/>
               </a:rPr>
-              <a:t>Source: Waymo, Tesla, Baidu, Aurora; WHO Global Road Safety; NVIDIA FY2026.</a:t>
+              <a:t>WHO Global Road Safety report, </a:t>
+            </a:r>
+            <a:pPr indent="0" marL="0">
+              <a:buNone/>
+            </a:pPr>
+            <a:r>
+              <a:rPr lang="en-US" sz="700" b="1" dirty="0">
+                <a:solidFill>
+                  <a:srgbClr val="999999"/>
+                </a:solidFill>
+                <a:latin typeface="Arial" pitchFamily="34" charset="0"/>
+                <a:ea typeface="Arial" pitchFamily="34" charset="-122"/>
+                <a:cs typeface="Arial" pitchFamily="34" charset="-120"/>
+              </a:rPr>
+              <a:t>(2) </a:t>
+            </a:r>
+            <a:pPr indent="0" marL="0">
+              <a:buNone/>
+            </a:pPr>
+            <a:r>
+              <a:rPr lang="en-US" sz="700" dirty="0">
+                <a:solidFill>
+                  <a:srgbClr val="999999"/>
+                </a:solidFill>
+                <a:latin typeface="Arial" pitchFamily="34" charset="0"/>
+                <a:ea typeface="Arial" pitchFamily="34" charset="-122"/>
+                <a:cs typeface="Arial" pitchFamily="34" charset="-120"/>
+              </a:rPr>
+              <a:t>NVIDIA FY2026 — automotive/DRIVE platform, </a:t>
+            </a:r>
+            <a:pPr indent="0" marL="0">
+              <a:buNone/>
+            </a:pPr>
+            <a:r>
+              <a:rPr lang="en-US" sz="700" b="1" dirty="0">
+                <a:solidFill>
+                  <a:srgbClr val="999999"/>
+                </a:solidFill>
+                <a:latin typeface="Arial" pitchFamily="34" charset="0"/>
+                <a:ea typeface="Arial" pitchFamily="34" charset="-122"/>
+                <a:cs typeface="Arial" pitchFamily="34" charset="-120"/>
+              </a:rPr>
+              <a:t>(3) </a:t>
+            </a:r>
+            <a:pPr indent="0" marL="0">
+              <a:buNone/>
+            </a:pPr>
+            <a:r>
+              <a:rPr lang="en-US" sz="700" dirty="0">
+                <a:solidFill>
+                  <a:srgbClr val="999999"/>
+                </a:solidFill>
+                <a:latin typeface="Arial" pitchFamily="34" charset="0"/>
+                <a:ea typeface="Arial" pitchFamily="34" charset="-122"/>
+                <a:cs typeface="Arial" pitchFamily="34" charset="-120"/>
+              </a:rPr>
+              <a:t>Waymo, Tesla, Baidu Apollo, Aurora — company disclosures.</a:t>
             </a:r>
             <a:endParaRPr lang="en-US" sz="700" dirty="0"/>
           </a:p>
@@ -21477,7 +22191,35 @@
                 <a:ea typeface="Arial" pitchFamily="34" charset="-122"/>
                 <a:cs typeface="Arial" pitchFamily="34" charset="-120"/>
               </a:rPr>
-              <a:t>Predicting a protein's 3D shape from its amino-acid sequence was a 50-year unsolved problem. Crystallography took months per protein. Deep learning now infers structure in seconds — unlocking every drug target at once.</a:t>
+              <a:t>Predicting a protein's 3D shape from its amino-acid sequence was a 50-year unsolved problem. Crystallography took months per protein. Deep learning now infers structure in seconds</a:t>
+            </a:r>
+            <a:pPr indent="0" marL="0">
+              <a:buNone/>
+            </a:pPr>
+            <a:r>
+              <a:rPr lang="en-US" sz="650" baseline="30000" dirty="0">
+                <a:solidFill>
+                  <a:srgbClr val="333333"/>
+                </a:solidFill>
+                <a:latin typeface="Arial" pitchFamily="34" charset="0"/>
+                <a:ea typeface="Arial" pitchFamily="34" charset="-122"/>
+                <a:cs typeface="Arial" pitchFamily="34" charset="-120"/>
+              </a:rPr>
+              <a:t> 1</a:t>
+            </a:r>
+            <a:pPr indent="0" marL="0">
+              <a:buNone/>
+            </a:pPr>
+            <a:r>
+              <a:rPr lang="en-US" sz="950" dirty="0">
+                <a:solidFill>
+                  <a:srgbClr val="333333"/>
+                </a:solidFill>
+                <a:latin typeface="Arial" pitchFamily="34" charset="0"/>
+                <a:ea typeface="Arial" pitchFamily="34" charset="-122"/>
+                <a:cs typeface="Arial" pitchFamily="34" charset="-120"/>
+              </a:rPr>
+              <a:t> — unlocking every drug target at once.</a:t>
             </a:r>
             <a:endParaRPr lang="en-US" sz="950" dirty="0"/>
           </a:p>
@@ -21619,7 +22361,35 @@
                 <a:ea typeface="Arial" pitchFamily="34" charset="-122"/>
                 <a:cs typeface="Arial" pitchFamily="34" charset="-120"/>
               </a:rPr>
-              <a:t>There are ~10⁶⁰ drug-like small molecules. Wet labs can screen millions. Generative models search the rest — proposing novel binders optimized for selectivity, potency, and drug-like properties.</a:t>
+              <a:t>There are ~10⁶⁰ drug-like small molecules.</a:t>
+            </a:r>
+            <a:pPr indent="0" marL="0">
+              <a:buNone/>
+            </a:pPr>
+            <a:r>
+              <a:rPr lang="en-US" sz="650" baseline="30000" dirty="0">
+                <a:solidFill>
+                  <a:srgbClr val="333333"/>
+                </a:solidFill>
+                <a:latin typeface="Arial" pitchFamily="34" charset="0"/>
+                <a:ea typeface="Arial" pitchFamily="34" charset="-122"/>
+                <a:cs typeface="Arial" pitchFamily="34" charset="-120"/>
+              </a:rPr>
+              <a:t> 2</a:t>
+            </a:r>
+            <a:pPr indent="0" marL="0">
+              <a:buNone/>
+            </a:pPr>
+            <a:r>
+              <a:rPr lang="en-US" sz="950" dirty="0">
+                <a:solidFill>
+                  <a:srgbClr val="333333"/>
+                </a:solidFill>
+                <a:latin typeface="Arial" pitchFamily="34" charset="0"/>
+                <a:ea typeface="Arial" pitchFamily="34" charset="-122"/>
+                <a:cs typeface="Arial" pitchFamily="34" charset="-120"/>
+              </a:rPr>
+              <a:t> Wet labs can screen millions. Generative models search the rest — proposing novel binders optimized for selectivity, potency, and drug-like properties.</a:t>
             </a:r>
             <a:endParaRPr lang="en-US" sz="950" dirty="0"/>
           </a:p>
@@ -21825,7 +22595,35 @@
                 <a:ea typeface="Arial" pitchFamily="34" charset="-122"/>
                 <a:cs typeface="Arial" pitchFamily="34" charset="-120"/>
               </a:rPr>
-              <a:t>Traditional pharma: 10–15 years, ~$2.6B per approved drug, &lt;10% Phase I success. AI collapses the design stage — clinical trials are still bound by biology and the FDA.</a:t>
+              <a:t>Traditional pharma: 10–15 years, ~$2.6B per approved drug, &lt;10% Phase I success.</a:t>
+            </a:r>
+            <a:pPr indent="0" marL="0">
+              <a:buNone/>
+            </a:pPr>
+            <a:r>
+              <a:rPr lang="en-US" sz="700" b="1" baseline="30000" dirty="0">
+                <a:solidFill>
+                  <a:srgbClr val="000000"/>
+                </a:solidFill>
+                <a:latin typeface="Arial" pitchFamily="34" charset="0"/>
+                <a:ea typeface="Arial" pitchFamily="34" charset="-122"/>
+                <a:cs typeface="Arial" pitchFamily="34" charset="-120"/>
+              </a:rPr>
+              <a:t> 3</a:t>
+            </a:r>
+            <a:pPr indent="0" marL="0">
+              <a:buNone/>
+            </a:pPr>
+            <a:r>
+              <a:rPr lang="en-US" sz="1000" b="1" dirty="0">
+                <a:solidFill>
+                  <a:srgbClr val="000000"/>
+                </a:solidFill>
+                <a:latin typeface="Arial" pitchFamily="34" charset="0"/>
+                <a:ea typeface="Arial" pitchFamily="34" charset="-122"/>
+                <a:cs typeface="Arial" pitchFamily="34" charset="-120"/>
+              </a:rPr>
+              <a:t> AI collapses the design stage — clinical trials are still bound by biology and the FDA.</a:t>
             </a:r>
             <a:endParaRPr lang="en-US" sz="1000" dirty="0"/>
           </a:p>
@@ -21840,7 +22638,7 @@
         <p:spPr>
           <a:xfrm>
             <a:off x="457200" y="5875020"/>
-            <a:ext cx="8229600" cy="320040"/>
+            <a:ext cx="8229600" cy="457200"/>
           </a:xfrm>
           <a:prstGeom prst="rect">
             <a:avLst/>
@@ -21856,6 +22654,20 @@
               <a:buNone/>
             </a:pPr>
             <a:r>
+              <a:rPr lang="en-US" sz="700" b="1" dirty="0">
+                <a:solidFill>
+                  <a:srgbClr val="999999"/>
+                </a:solidFill>
+                <a:latin typeface="Arial" pitchFamily="34" charset="0"/>
+                <a:ea typeface="Arial" pitchFamily="34" charset="-122"/>
+                <a:cs typeface="Arial" pitchFamily="34" charset="-120"/>
+              </a:rPr>
+              <a:t>(1) </a:t>
+            </a:r>
+            <a:pPr indent="0" marL="0">
+              <a:buNone/>
+            </a:pPr>
+            <a:r>
               <a:rPr lang="en-US" sz="700" dirty="0">
                 <a:solidFill>
                   <a:srgbClr val="999999"/>
@@ -21864,7 +22676,63 @@
                 <a:ea typeface="Arial" pitchFamily="34" charset="-122"/>
                 <a:cs typeface="Arial" pitchFamily="34" charset="-120"/>
               </a:rPr>
-              <a:t>Sources: Jumper et al. (AlphaFold, Nature 2020); Tufts CSDD drug-development cost and timeline studies; Hughes et al., Br. J. Pharmacol. on screening scale; Strategy Research.</a:t>
+              <a:t>Jumper et al., AlphaFold, Nature 2020, </a:t>
+            </a:r>
+            <a:pPr indent="0" marL="0">
+              <a:buNone/>
+            </a:pPr>
+            <a:r>
+              <a:rPr lang="en-US" sz="700" b="1" dirty="0">
+                <a:solidFill>
+                  <a:srgbClr val="999999"/>
+                </a:solidFill>
+                <a:latin typeface="Arial" pitchFamily="34" charset="0"/>
+                <a:ea typeface="Arial" pitchFamily="34" charset="-122"/>
+                <a:cs typeface="Arial" pitchFamily="34" charset="-120"/>
+              </a:rPr>
+              <a:t>(2) </a:t>
+            </a:r>
+            <a:pPr indent="0" marL="0">
+              <a:buNone/>
+            </a:pPr>
+            <a:r>
+              <a:rPr lang="en-US" sz="700" dirty="0">
+                <a:solidFill>
+                  <a:srgbClr val="999999"/>
+                </a:solidFill>
+                <a:latin typeface="Arial" pitchFamily="34" charset="0"/>
+                <a:ea typeface="Arial" pitchFamily="34" charset="-122"/>
+                <a:cs typeface="Arial" pitchFamily="34" charset="-120"/>
+              </a:rPr>
+              <a:t>Hughes et al., Br. J. Pharmacol. — screening scale, </a:t>
+            </a:r>
+            <a:pPr indent="0" marL="0">
+              <a:buNone/>
+            </a:pPr>
+            <a:r>
+              <a:rPr lang="en-US" sz="700" b="1" dirty="0">
+                <a:solidFill>
+                  <a:srgbClr val="999999"/>
+                </a:solidFill>
+                <a:latin typeface="Arial" pitchFamily="34" charset="0"/>
+                <a:ea typeface="Arial" pitchFamily="34" charset="-122"/>
+                <a:cs typeface="Arial" pitchFamily="34" charset="-120"/>
+              </a:rPr>
+              <a:t>(3) </a:t>
+            </a:r>
+            <a:pPr indent="0" marL="0">
+              <a:buNone/>
+            </a:pPr>
+            <a:r>
+              <a:rPr lang="en-US" sz="700" dirty="0">
+                <a:solidFill>
+                  <a:srgbClr val="999999"/>
+                </a:solidFill>
+                <a:latin typeface="Arial" pitchFamily="34" charset="0"/>
+                <a:ea typeface="Arial" pitchFamily="34" charset="-122"/>
+                <a:cs typeface="Arial" pitchFamily="34" charset="-120"/>
+              </a:rPr>
+              <a:t>Tufts CSDD — drug-development cost and timeline.</a:t>
             </a:r>
             <a:endParaRPr lang="en-US" sz="700" dirty="0"/>
           </a:p>

</xml_diff>

<commit_message>
Slide 13: redesign right column as qualitative panels — drop hero stat + tile numerals, add icon-led drivers
Co-Authored-By: Claude Opus 4.7 <noreply@anthropic.com>
</commit_message>
<xml_diff>
--- a/ai-markets-deck.pptx
+++ b/ai-markets-deck.pptx
@@ -11032,163 +11032,7 @@
         <p:spPr>
           <a:xfrm>
             <a:off x="4754880" y="1783080"/>
-            <a:ext cx="3931920" cy="1280160"/>
-          </a:xfrm>
-          <a:prstGeom prst="rect">
-            <a:avLst/>
-          </a:prstGeom>
-          <a:solidFill>
-            <a:srgbClr val="F9F9F9"/>
-          </a:solidFill>
-          <a:ln w="6350">
-            <a:solidFill>
-              <a:srgbClr val="E5E5E5"/>
-            </a:solidFill>
-            <a:prstDash val="solid"/>
-          </a:ln>
-        </p:spPr>
-      </p:sp>
-      <p:sp>
-        <p:nvSpPr>
-          <p:cNvPr id="11" name="Text 8"/>
-          <p:cNvSpPr/>
-          <p:nvPr/>
-        </p:nvSpPr>
-        <p:spPr>
-          <a:xfrm>
-            <a:off x="4754880" y="1874520"/>
-            <a:ext cx="3931920" cy="228600"/>
-          </a:xfrm>
-          <a:prstGeom prst="rect">
-            <a:avLst/>
-          </a:prstGeom>
-          <a:noFill/>
-          <a:ln/>
-        </p:spPr>
-        <p:txBody>
-          <a:bodyPr wrap="square" lIns="0" tIns="0" rIns="0" bIns="0" rtlCol="0" anchor="ctr"/>
-          <a:lstStyle/>
-          <a:p>
-            <a:pPr algn="ctr" indent="0" marL="0">
-              <a:buNone/>
-            </a:pPr>
-            <a:r>
-              <a:rPr lang="en-US" sz="1000" b="1" spc="300" kern="0" dirty="0">
-                <a:solidFill>
-                  <a:srgbClr val="666666"/>
-                </a:solidFill>
-                <a:latin typeface="Arial" pitchFamily="34" charset="0"/>
-                <a:ea typeface="Arial" pitchFamily="34" charset="-122"/>
-                <a:cs typeface="Arial" pitchFamily="34" charset="-120"/>
-              </a:rPr>
-              <a:t>YTD SPREAD — SOX vs IGV</a:t>
-            </a:r>
-            <a:endParaRPr lang="en-US" sz="1000" dirty="0"/>
-          </a:p>
-        </p:txBody>
-      </p:sp>
-      <p:sp>
-        <p:nvSpPr>
-          <p:cNvPr id="12" name="Text 9"/>
-          <p:cNvSpPr/>
-          <p:nvPr/>
-        </p:nvSpPr>
-        <p:spPr>
-          <a:xfrm>
-            <a:off x="4754880" y="2103120"/>
-            <a:ext cx="3931920" cy="640080"/>
-          </a:xfrm>
-          <a:prstGeom prst="rect">
-            <a:avLst/>
-          </a:prstGeom>
-          <a:noFill/>
-          <a:ln/>
-        </p:spPr>
-        <p:txBody>
-          <a:bodyPr wrap="square" lIns="0" tIns="0" rIns="0" bIns="0" rtlCol="0" anchor="ctr"/>
-          <a:lstStyle/>
-          <a:p>
-            <a:pPr algn="ctr" indent="0" marL="0">
-              <a:buNone/>
-            </a:pPr>
-            <a:r>
-              <a:rPr lang="en-US" sz="5200" b="1" dirty="0">
-                <a:solidFill>
-                  <a:srgbClr val="F6693D"/>
-                </a:solidFill>
-                <a:latin typeface="Arial Black" pitchFamily="34" charset="0"/>
-                <a:ea typeface="Arial Black" pitchFamily="34" charset="-122"/>
-                <a:cs typeface="Arial Black" pitchFamily="34" charset="-120"/>
-              </a:rPr>
-              <a:t>+58 pts</a:t>
-            </a:r>
-            <a:pPr algn="ctr" indent="0" marL="0">
-              <a:buNone/>
-            </a:pPr>
-            <a:r>
-              <a:rPr lang="en-US" sz="1800" baseline="30000" dirty="0">
-                <a:solidFill>
-                  <a:srgbClr val="F6693D"/>
-                </a:solidFill>
-                <a:latin typeface="Arial Black" pitchFamily="34" charset="0"/>
-                <a:ea typeface="Arial Black" pitchFamily="34" charset="-122"/>
-                <a:cs typeface="Arial Black" pitchFamily="34" charset="-120"/>
-              </a:rPr>
-              <a:t> 1</a:t>
-            </a:r>
-            <a:endParaRPr lang="en-US" sz="5200" dirty="0"/>
-          </a:p>
-        </p:txBody>
-      </p:sp>
-      <p:sp>
-        <p:nvSpPr>
-          <p:cNvPr id="13" name="Text 10"/>
-          <p:cNvSpPr/>
-          <p:nvPr/>
-        </p:nvSpPr>
-        <p:spPr>
-          <a:xfrm>
-            <a:off x="4754880" y="2761488"/>
-            <a:ext cx="3931920" cy="256032"/>
-          </a:xfrm>
-          <a:prstGeom prst="rect">
-            <a:avLst/>
-          </a:prstGeom>
-          <a:noFill/>
-          <a:ln/>
-        </p:spPr>
-        <p:txBody>
-          <a:bodyPr wrap="square" lIns="0" tIns="0" rIns="0" bIns="0" rtlCol="0" anchor="t"/>
-          <a:lstStyle/>
-          <a:p>
-            <a:pPr algn="ctr" indent="0" marL="0">
-              <a:buNone/>
-            </a:pPr>
-            <a:r>
-              <a:rPr lang="en-US" sz="1050" dirty="0">
-                <a:solidFill>
-                  <a:srgbClr val="333333"/>
-                </a:solidFill>
-                <a:latin typeface="Arial" pitchFamily="34" charset="0"/>
-                <a:ea typeface="Arial" pitchFamily="34" charset="-122"/>
-                <a:cs typeface="Arial" pitchFamily="34" charset="-120"/>
-              </a:rPr>
-              <a:t>Semis +38% vs software −20%, through Apr 17, 2026</a:t>
-            </a:r>
-            <a:endParaRPr lang="en-US" sz="1050" dirty="0"/>
-          </a:p>
-        </p:txBody>
-      </p:sp>
-      <p:sp>
-        <p:nvSpPr>
-          <p:cNvPr id="14" name="Shape 11"/>
-          <p:cNvSpPr/>
-          <p:nvPr/>
-        </p:nvSpPr>
-        <p:spPr>
-          <a:xfrm>
-            <a:off x="4754880" y="3200400"/>
-            <a:ext cx="1920240" cy="2011680"/>
+            <a:ext cx="3931920" cy="1645920"/>
           </a:xfrm>
           <a:prstGeom prst="rect">
             <a:avLst/>
@@ -11206,14 +11050,14 @@
       </p:sp>
       <p:sp>
         <p:nvSpPr>
-          <p:cNvPr id="15" name="Shape 12"/>
-          <p:cNvSpPr/>
-          <p:nvPr/>
-        </p:nvSpPr>
-        <p:spPr>
-          <a:xfrm>
-            <a:off x="4754880" y="3200400"/>
-            <a:ext cx="1920240" cy="54864"/>
+          <p:cNvPr id="11" name="Shape 8"/>
+          <p:cNvSpPr/>
+          <p:nvPr/>
+        </p:nvSpPr>
+        <p:spPr>
+          <a:xfrm>
+            <a:off x="4754880" y="1783080"/>
+            <a:ext cx="3931920" cy="54864"/>
           </a:xfrm>
           <a:prstGeom prst="rect">
             <a:avLst/>
@@ -11231,14 +11075,14 @@
       </p:sp>
       <p:sp>
         <p:nvSpPr>
-          <p:cNvPr id="16" name="Text 13"/>
-          <p:cNvSpPr/>
-          <p:nvPr/>
-        </p:nvSpPr>
-        <p:spPr>
-          <a:xfrm>
-            <a:off x="4754880" y="3328416"/>
-            <a:ext cx="1920240" cy="237744"/>
+          <p:cNvPr id="12" name="Text 9"/>
+          <p:cNvSpPr/>
+          <p:nvPr/>
+        </p:nvSpPr>
+        <p:spPr>
+          <a:xfrm>
+            <a:off x="4937760" y="1874520"/>
+            <a:ext cx="3566160" cy="182880"/>
           </a:xfrm>
           <a:prstGeom prst="rect">
             <a:avLst/>
@@ -11250,142 +11094,373 @@
           <a:bodyPr wrap="square" lIns="0" tIns="0" rIns="0" bIns="0" rtlCol="0" anchor="ctr"/>
           <a:lstStyle/>
           <a:p>
+            <a:pPr algn="l" indent="0" marL="0">
+              <a:buNone/>
+            </a:pPr>
+            <a:r>
+              <a:rPr lang="en-US" sz="1000" b="1" spc="300" kern="0" dirty="0">
+                <a:solidFill>
+                  <a:srgbClr val="666666"/>
+                </a:solidFill>
+                <a:latin typeface="Arial" pitchFamily="34" charset="0"/>
+                <a:ea typeface="Arial" pitchFamily="34" charset="-122"/>
+                <a:cs typeface="Arial" pitchFamily="34" charset="-120"/>
+              </a:rPr>
+              <a:t>WHY SEMIS ARE UP</a:t>
+            </a:r>
+            <a:endParaRPr lang="en-US" sz="1000" dirty="0"/>
+          </a:p>
+        </p:txBody>
+      </p:sp>
+      <p:sp>
+        <p:nvSpPr>
+          <p:cNvPr id="13" name="Text 10"/>
+          <p:cNvSpPr/>
+          <p:nvPr/>
+        </p:nvSpPr>
+        <p:spPr>
+          <a:xfrm>
+            <a:off x="4937760" y="2057400"/>
+            <a:ext cx="3566160" cy="347472"/>
+          </a:xfrm>
+          <a:prstGeom prst="rect">
+            <a:avLst/>
+          </a:prstGeom>
+          <a:noFill/>
+          <a:ln/>
+        </p:spPr>
+        <p:txBody>
+          <a:bodyPr wrap="square" lIns="0" tIns="0" rIns="0" bIns="0" rtlCol="0" anchor="ctr"/>
+          <a:lstStyle/>
+          <a:p>
+            <a:pPr algn="l" indent="0" marL="0">
+              <a:buNone/>
+            </a:pPr>
+            <a:r>
+              <a:rPr lang="en-US" sz="1200" b="1" dirty="0">
+                <a:solidFill>
+                  <a:srgbClr val="333333"/>
+                </a:solidFill>
+                <a:latin typeface="Arial" pitchFamily="34" charset="0"/>
+                <a:ea typeface="Arial" pitchFamily="34" charset="-122"/>
+                <a:cs typeface="Arial" pitchFamily="34" charset="-120"/>
+              </a:rPr>
+              <a:t>Sold out, with demand still building.</a:t>
+            </a:r>
+            <a:endParaRPr lang="en-US" sz="1200" dirty="0"/>
+          </a:p>
+        </p:txBody>
+      </p:sp>
+      <p:sp>
+        <p:nvSpPr>
+          <p:cNvPr id="14" name="Shape 11"/>
+          <p:cNvSpPr/>
+          <p:nvPr/>
+        </p:nvSpPr>
+        <p:spPr>
+          <a:xfrm>
+            <a:off x="4937760" y="2468880"/>
+            <a:ext cx="274320" cy="274320"/>
+          </a:xfrm>
+          <a:prstGeom prst="ellipse">
+            <a:avLst/>
+          </a:prstGeom>
+          <a:solidFill>
+            <a:srgbClr val="F6693D"/>
+          </a:solidFill>
+          <a:ln w="12700">
+            <a:solidFill>
+              <a:srgbClr val="F6693D"/>
+            </a:solidFill>
+            <a:prstDash val="solid"/>
+          </a:ln>
+        </p:spPr>
+      </p:sp>
+      <p:sp>
+        <p:nvSpPr>
+          <p:cNvPr id="15" name="Text 12"/>
+          <p:cNvSpPr/>
+          <p:nvPr/>
+        </p:nvSpPr>
+        <p:spPr>
+          <a:xfrm>
+            <a:off x="4937760" y="2468880"/>
+            <a:ext cx="274320" cy="274320"/>
+          </a:xfrm>
+          <a:prstGeom prst="rect">
+            <a:avLst/>
+          </a:prstGeom>
+          <a:noFill/>
+          <a:ln/>
+        </p:spPr>
+        <p:txBody>
+          <a:bodyPr wrap="square" lIns="0" tIns="0" rIns="0" bIns="0" rtlCol="0" anchor="ctr"/>
+          <a:lstStyle/>
+          <a:p>
             <a:pPr algn="ctr" indent="0" marL="0">
               <a:buNone/>
             </a:pPr>
             <a:r>
-              <a:rPr lang="en-US" sz="850" b="1" spc="200" kern="0" dirty="0">
-                <a:solidFill>
-                  <a:srgbClr val="333333"/>
-                </a:solidFill>
-                <a:latin typeface="Arial" pitchFamily="34" charset="0"/>
-                <a:ea typeface="Arial" pitchFamily="34" charset="-122"/>
-                <a:cs typeface="Arial" pitchFamily="34" charset="-120"/>
-              </a:rPr>
-              <a:t>WHY SEMIS ARE UP</a:t>
-            </a:r>
-            <a:endParaRPr lang="en-US" sz="850" dirty="0"/>
-          </a:p>
-        </p:txBody>
-      </p:sp>
-      <p:sp>
-        <p:nvSpPr>
-          <p:cNvPr id="17" name="Text 14"/>
-          <p:cNvSpPr/>
-          <p:nvPr/>
-        </p:nvSpPr>
-        <p:spPr>
-          <a:xfrm>
-            <a:off x="4754880" y="3602736"/>
-            <a:ext cx="1920240" cy="548640"/>
-          </a:xfrm>
-          <a:prstGeom prst="rect">
-            <a:avLst/>
-          </a:prstGeom>
-          <a:noFill/>
-          <a:ln/>
-        </p:spPr>
-        <p:txBody>
-          <a:bodyPr wrap="square" lIns="0" tIns="0" rIns="0" bIns="0" rtlCol="0" anchor="ctr"/>
-          <a:lstStyle/>
-          <a:p>
-            <a:pPr algn="ctr" indent="0" marL="0">
-              <a:buNone/>
-            </a:pPr>
-            <a:r>
-              <a:rPr lang="en-US" sz="2800" b="1" dirty="0">
-                <a:solidFill>
-                  <a:srgbClr val="F6693D"/>
+              <a:rPr lang="en-US" sz="1100" b="1" dirty="0">
+                <a:solidFill>
+                  <a:srgbClr val="FFFFFF"/>
                 </a:solidFill>
                 <a:latin typeface="Arial Black" pitchFamily="34" charset="0"/>
                 <a:ea typeface="Arial Black" pitchFamily="34" charset="-122"/>
                 <a:cs typeface="Arial Black" pitchFamily="34" charset="-120"/>
               </a:rPr>
-              <a:t>+47%</a:t>
-            </a:r>
+              <a:t>⚙</a:t>
+            </a:r>
+            <a:endParaRPr lang="en-US" sz="1100" dirty="0"/>
+          </a:p>
+        </p:txBody>
+      </p:sp>
+      <p:sp>
+        <p:nvSpPr>
+          <p:cNvPr id="16" name="Text 13"/>
+          <p:cNvSpPr/>
+          <p:nvPr/>
+        </p:nvSpPr>
+        <p:spPr>
+          <a:xfrm>
+            <a:off x="5303520" y="2441448"/>
+            <a:ext cx="3200400" cy="329184"/>
+          </a:xfrm>
+          <a:prstGeom prst="rect">
+            <a:avLst/>
+          </a:prstGeom>
+          <a:noFill/>
+          <a:ln/>
+        </p:spPr>
+        <p:txBody>
+          <a:bodyPr wrap="square" lIns="0" tIns="0" rIns="0" bIns="0" rtlCol="0" anchor="ctr"/>
+          <a:lstStyle/>
+          <a:p>
+            <a:pPr algn="l" indent="0" marL="0">
+              <a:buNone/>
+            </a:pPr>
+            <a:r>
+              <a:rPr lang="en-US" sz="950" dirty="0">
+                <a:solidFill>
+                  <a:srgbClr val="333333"/>
+                </a:solidFill>
+                <a:latin typeface="Arial" pitchFamily="34" charset="0"/>
+                <a:ea typeface="Arial" pitchFamily="34" charset="-122"/>
+                <a:cs typeface="Arial" pitchFamily="34" charset="-120"/>
+              </a:rPr>
+              <a:t>HBM sold out through 2026; hyperscalers are locking in every GB of memory they can secure.</a:t>
+            </a:r>
+            <a:pPr algn="l" indent="0" marL="0">
+              <a:buNone/>
+            </a:pPr>
+            <a:r>
+              <a:rPr lang="en-US" sz="700" baseline="30000" dirty="0">
+                <a:solidFill>
+                  <a:srgbClr val="F6693D"/>
+                </a:solidFill>
+                <a:latin typeface="Arial" pitchFamily="34" charset="0"/>
+                <a:ea typeface="Arial" pitchFamily="34" charset="-122"/>
+                <a:cs typeface="Arial" pitchFamily="34" charset="-120"/>
+              </a:rPr>
+              <a:t> 1</a:t>
+            </a:r>
+            <a:endParaRPr lang="en-US" sz="950" dirty="0"/>
+          </a:p>
+        </p:txBody>
+      </p:sp>
+      <p:sp>
+        <p:nvSpPr>
+          <p:cNvPr id="17" name="Shape 14"/>
+          <p:cNvSpPr/>
+          <p:nvPr/>
+        </p:nvSpPr>
+        <p:spPr>
+          <a:xfrm>
+            <a:off x="4937760" y="2798064"/>
+            <a:ext cx="274320" cy="274320"/>
+          </a:xfrm>
+          <a:prstGeom prst="ellipse">
+            <a:avLst/>
+          </a:prstGeom>
+          <a:solidFill>
+            <a:srgbClr val="F6693D"/>
+          </a:solidFill>
+          <a:ln w="12700">
+            <a:solidFill>
+              <a:srgbClr val="F6693D"/>
+            </a:solidFill>
+            <a:prstDash val="solid"/>
+          </a:ln>
+        </p:spPr>
+      </p:sp>
+      <p:sp>
+        <p:nvSpPr>
+          <p:cNvPr id="18" name="Text 15"/>
+          <p:cNvSpPr/>
+          <p:nvPr/>
+        </p:nvSpPr>
+        <p:spPr>
+          <a:xfrm>
+            <a:off x="4937760" y="2798064"/>
+            <a:ext cx="274320" cy="274320"/>
+          </a:xfrm>
+          <a:prstGeom prst="rect">
+            <a:avLst/>
+          </a:prstGeom>
+          <a:noFill/>
+          <a:ln/>
+        </p:spPr>
+        <p:txBody>
+          <a:bodyPr wrap="square" lIns="0" tIns="0" rIns="0" bIns="0" rtlCol="0" anchor="ctr"/>
+          <a:lstStyle/>
+          <a:p>
             <a:pPr algn="ctr" indent="0" marL="0">
               <a:buNone/>
             </a:pPr>
             <a:r>
-              <a:rPr lang="en-US" sz="1000" baseline="30000" dirty="0">
-                <a:solidFill>
-                  <a:srgbClr val="F6693D"/>
+              <a:rPr lang="en-US" sz="1100" b="1" dirty="0">
+                <a:solidFill>
+                  <a:srgbClr val="FFFFFF"/>
                 </a:solidFill>
                 <a:latin typeface="Arial Black" pitchFamily="34" charset="0"/>
                 <a:ea typeface="Arial Black" pitchFamily="34" charset="-122"/>
                 <a:cs typeface="Arial Black" pitchFamily="34" charset="-120"/>
               </a:rPr>
-              <a:t> 2</a:t>
-            </a:r>
-            <a:endParaRPr lang="en-US" sz="2800" dirty="0"/>
-          </a:p>
-        </p:txBody>
-      </p:sp>
-      <p:sp>
-        <p:nvSpPr>
-          <p:cNvPr id="18" name="Text 15"/>
-          <p:cNvSpPr/>
-          <p:nvPr/>
-        </p:nvSpPr>
-        <p:spPr>
-          <a:xfrm>
-            <a:off x="4846320" y="4187952"/>
-            <a:ext cx="1737360" cy="310896"/>
-          </a:xfrm>
-          <a:prstGeom prst="rect">
-            <a:avLst/>
-          </a:prstGeom>
-          <a:noFill/>
-          <a:ln/>
-        </p:spPr>
-        <p:txBody>
-          <a:bodyPr wrap="square" lIns="0" tIns="0" rIns="0" bIns="0" rtlCol="0" anchor="t"/>
+              <a:t>⚡</a:t>
+            </a:r>
+            <a:endParaRPr lang="en-US" sz="1100" dirty="0"/>
+          </a:p>
+        </p:txBody>
+      </p:sp>
+      <p:sp>
+        <p:nvSpPr>
+          <p:cNvPr id="19" name="Text 16"/>
+          <p:cNvSpPr/>
+          <p:nvPr/>
+        </p:nvSpPr>
+        <p:spPr>
+          <a:xfrm>
+            <a:off x="5303520" y="2770632"/>
+            <a:ext cx="3200400" cy="329184"/>
+          </a:xfrm>
+          <a:prstGeom prst="rect">
+            <a:avLst/>
+          </a:prstGeom>
+          <a:noFill/>
+          <a:ln/>
+        </p:spPr>
+        <p:txBody>
+          <a:bodyPr wrap="square" lIns="0" tIns="0" rIns="0" bIns="0" rtlCol="0" anchor="ctr"/>
+          <a:lstStyle/>
+          <a:p>
+            <a:pPr algn="l" indent="0" marL="0">
+              <a:buNone/>
+            </a:pPr>
+            <a:r>
+              <a:rPr lang="en-US" sz="950" dirty="0">
+                <a:solidFill>
+                  <a:srgbClr val="333333"/>
+                </a:solidFill>
+                <a:latin typeface="Arial" pitchFamily="34" charset="0"/>
+                <a:ea typeface="Arial" pitchFamily="34" charset="-122"/>
+                <a:cs typeface="Arial" pitchFamily="34" charset="-120"/>
+              </a:rPr>
+              <a:t>Data-center power demand keeps pulling forward; each new model generation wants more silicon.</a:t>
+            </a:r>
+            <a:endParaRPr lang="en-US" sz="950" dirty="0"/>
+          </a:p>
+        </p:txBody>
+      </p:sp>
+      <p:sp>
+        <p:nvSpPr>
+          <p:cNvPr id="20" name="Shape 17"/>
+          <p:cNvSpPr/>
+          <p:nvPr/>
+        </p:nvSpPr>
+        <p:spPr>
+          <a:xfrm>
+            <a:off x="4937760" y="3127248"/>
+            <a:ext cx="274320" cy="274320"/>
+          </a:xfrm>
+          <a:prstGeom prst="ellipse">
+            <a:avLst/>
+          </a:prstGeom>
+          <a:solidFill>
+            <a:srgbClr val="F6693D"/>
+          </a:solidFill>
+          <a:ln w="12700">
+            <a:solidFill>
+              <a:srgbClr val="F6693D"/>
+            </a:solidFill>
+            <a:prstDash val="solid"/>
+          </a:ln>
+        </p:spPr>
+      </p:sp>
+      <p:sp>
+        <p:nvSpPr>
+          <p:cNvPr id="21" name="Text 18"/>
+          <p:cNvSpPr/>
+          <p:nvPr/>
+        </p:nvSpPr>
+        <p:spPr>
+          <a:xfrm>
+            <a:off x="4937760" y="3127248"/>
+            <a:ext cx="274320" cy="274320"/>
+          </a:xfrm>
+          <a:prstGeom prst="rect">
+            <a:avLst/>
+          </a:prstGeom>
+          <a:noFill/>
+          <a:ln/>
+        </p:spPr>
+        <p:txBody>
+          <a:bodyPr wrap="square" lIns="0" tIns="0" rIns="0" bIns="0" rtlCol="0" anchor="ctr"/>
           <a:lstStyle/>
           <a:p>
             <a:pPr algn="ctr" indent="0" marL="0">
               <a:buNone/>
             </a:pPr>
             <a:r>
-              <a:rPr lang="en-US" sz="850" dirty="0">
-                <a:solidFill>
-                  <a:srgbClr val="666666"/>
-                </a:solidFill>
-                <a:latin typeface="Arial" pitchFamily="34" charset="0"/>
-                <a:ea typeface="Arial" pitchFamily="34" charset="-122"/>
-                <a:cs typeface="Arial" pitchFamily="34" charset="-120"/>
-              </a:rPr>
-              <a:t>Samsung HBM capacity lift in 2026</a:t>
-            </a:r>
-            <a:endParaRPr lang="en-US" sz="850" dirty="0"/>
-          </a:p>
-        </p:txBody>
-      </p:sp>
-      <p:sp>
-        <p:nvSpPr>
-          <p:cNvPr id="19" name="Text 16"/>
-          <p:cNvSpPr/>
-          <p:nvPr/>
-        </p:nvSpPr>
-        <p:spPr>
-          <a:xfrm>
-            <a:off x="4864608" y="4517136"/>
-            <a:ext cx="1700784" cy="658368"/>
-          </a:xfrm>
-          <a:prstGeom prst="rect">
-            <a:avLst/>
-          </a:prstGeom>
-          <a:noFill/>
-          <a:ln/>
-        </p:spPr>
-        <p:txBody>
-          <a:bodyPr wrap="square" lIns="0" tIns="0" rIns="0" bIns="0" rtlCol="0" anchor="t"/>
-          <a:lstStyle/>
-          <a:p>
-            <a:pPr algn="ctr" indent="0" marL="0">
-              <a:buNone/>
-            </a:pPr>
-            <a:r>
-              <a:rPr lang="en-US" sz="900" dirty="0">
+              <a:rPr lang="en-US" sz="1100" b="1" dirty="0">
+                <a:solidFill>
+                  <a:srgbClr val="FFFFFF"/>
+                </a:solidFill>
+                <a:latin typeface="Arial Black" pitchFamily="34" charset="0"/>
+                <a:ea typeface="Arial Black" pitchFamily="34" charset="-122"/>
+                <a:cs typeface="Arial Black" pitchFamily="34" charset="-120"/>
+              </a:rPr>
+              <a:t>↑</a:t>
+            </a:r>
+            <a:endParaRPr lang="en-US" sz="1100" dirty="0"/>
+          </a:p>
+        </p:txBody>
+      </p:sp>
+      <p:sp>
+        <p:nvSpPr>
+          <p:cNvPr id="22" name="Text 19"/>
+          <p:cNvSpPr/>
+          <p:nvPr/>
+        </p:nvSpPr>
+        <p:spPr>
+          <a:xfrm>
+            <a:off x="5303520" y="3099816"/>
+            <a:ext cx="3200400" cy="329184"/>
+          </a:xfrm>
+          <a:prstGeom prst="rect">
+            <a:avLst/>
+          </a:prstGeom>
+          <a:noFill/>
+          <a:ln/>
+        </p:spPr>
+        <p:txBody>
+          <a:bodyPr wrap="square" lIns="0" tIns="0" rIns="0" bIns="0" rtlCol="0" anchor="ctr"/>
+          <a:lstStyle/>
+          <a:p>
+            <a:pPr algn="l" indent="0" marL="0">
+              <a:buNone/>
+            </a:pPr>
+            <a:r>
+              <a:rPr lang="en-US" sz="950" dirty="0">
                 <a:solidFill>
                   <a:srgbClr val="333333"/>
                 </a:solidFill>
@@ -11393,22 +11468,22 @@
                 <a:ea typeface="Arial" pitchFamily="34" charset="-122"/>
                 <a:cs typeface="Arial" pitchFamily="34" charset="-120"/>
               </a:rPr>
-              <a:t>HBM sold out through 2026 as hyperscalers lock in every GB of AI memory.</a:t>
-            </a:r>
-            <a:endParaRPr lang="en-US" sz="900" dirty="0"/>
-          </a:p>
-        </p:txBody>
-      </p:sp>
-      <p:sp>
-        <p:nvSpPr>
-          <p:cNvPr id="20" name="Shape 17"/>
-          <p:cNvSpPr/>
-          <p:nvPr/>
-        </p:nvSpPr>
-        <p:spPr>
-          <a:xfrm>
-            <a:off x="6766560" y="3200400"/>
-            <a:ext cx="1920240" cy="2011680"/>
+              <a:t>ASPs and margins are expanding across memory and advanced-node logic.</a:t>
+            </a:r>
+            <a:endParaRPr lang="en-US" sz="950" dirty="0"/>
+          </a:p>
+        </p:txBody>
+      </p:sp>
+      <p:sp>
+        <p:nvSpPr>
+          <p:cNvPr id="23" name="Shape 20"/>
+          <p:cNvSpPr/>
+          <p:nvPr/>
+        </p:nvSpPr>
+        <p:spPr>
+          <a:xfrm>
+            <a:off x="4754880" y="3520440"/>
+            <a:ext cx="3931920" cy="1645920"/>
           </a:xfrm>
           <a:prstGeom prst="rect">
             <a:avLst/>
@@ -11426,14 +11501,14 @@
       </p:sp>
       <p:sp>
         <p:nvSpPr>
-          <p:cNvPr id="21" name="Shape 18"/>
-          <p:cNvSpPr/>
-          <p:nvPr/>
-        </p:nvSpPr>
-        <p:spPr>
-          <a:xfrm>
-            <a:off x="6766560" y="3200400"/>
-            <a:ext cx="1920240" cy="54864"/>
+          <p:cNvPr id="24" name="Shape 21"/>
+          <p:cNvSpPr/>
+          <p:nvPr/>
+        </p:nvSpPr>
+        <p:spPr>
+          <a:xfrm>
+            <a:off x="4754880" y="3520440"/>
+            <a:ext cx="3931920" cy="54864"/>
           </a:xfrm>
           <a:prstGeom prst="rect">
             <a:avLst/>
@@ -11451,14 +11526,14 @@
       </p:sp>
       <p:sp>
         <p:nvSpPr>
-          <p:cNvPr id="22" name="Text 19"/>
-          <p:cNvSpPr/>
-          <p:nvPr/>
-        </p:nvSpPr>
-        <p:spPr>
-          <a:xfrm>
-            <a:off x="6766560" y="3328416"/>
-            <a:ext cx="1920240" cy="237744"/>
+          <p:cNvPr id="25" name="Text 22"/>
+          <p:cNvSpPr/>
+          <p:nvPr/>
+        </p:nvSpPr>
+        <p:spPr>
+          <a:xfrm>
+            <a:off x="4937760" y="3611880"/>
+            <a:ext cx="3566160" cy="182880"/>
           </a:xfrm>
           <a:prstGeom prst="rect">
             <a:avLst/>
@@ -11470,142 +11545,373 @@
           <a:bodyPr wrap="square" lIns="0" tIns="0" rIns="0" bIns="0" rtlCol="0" anchor="ctr"/>
           <a:lstStyle/>
           <a:p>
+            <a:pPr algn="l" indent="0" marL="0">
+              <a:buNone/>
+            </a:pPr>
+            <a:r>
+              <a:rPr lang="en-US" sz="1000" b="1" spc="300" kern="0" dirty="0">
+                <a:solidFill>
+                  <a:srgbClr val="666666"/>
+                </a:solidFill>
+                <a:latin typeface="Arial" pitchFamily="34" charset="0"/>
+                <a:ea typeface="Arial" pitchFamily="34" charset="-122"/>
+                <a:cs typeface="Arial" pitchFamily="34" charset="-120"/>
+              </a:rPr>
+              <a:t>WHY SOFTWARE IS DOWN</a:t>
+            </a:r>
+            <a:endParaRPr lang="en-US" sz="1000" dirty="0"/>
+          </a:p>
+        </p:txBody>
+      </p:sp>
+      <p:sp>
+        <p:nvSpPr>
+          <p:cNvPr id="26" name="Text 23"/>
+          <p:cNvSpPr/>
+          <p:nvPr/>
+        </p:nvSpPr>
+        <p:spPr>
+          <a:xfrm>
+            <a:off x="4937760" y="3794760"/>
+            <a:ext cx="3566160" cy="347472"/>
+          </a:xfrm>
+          <a:prstGeom prst="rect">
+            <a:avLst/>
+          </a:prstGeom>
+          <a:noFill/>
+          <a:ln/>
+        </p:spPr>
+        <p:txBody>
+          <a:bodyPr wrap="square" lIns="0" tIns="0" rIns="0" bIns="0" rtlCol="0" anchor="ctr"/>
+          <a:lstStyle/>
+          <a:p>
+            <a:pPr algn="l" indent="0" marL="0">
+              <a:buNone/>
+            </a:pPr>
+            <a:r>
+              <a:rPr lang="en-US" sz="1200" b="1" dirty="0">
+                <a:solidFill>
+                  <a:srgbClr val="333333"/>
+                </a:solidFill>
+                <a:latin typeface="Arial" pitchFamily="34" charset="0"/>
+                <a:ea typeface="Arial" pitchFamily="34" charset="-122"/>
+                <a:cs typeface="Arial" pitchFamily="34" charset="-120"/>
+              </a:rPr>
+              <a:t>Per-seat pricing is under attack.</a:t>
+            </a:r>
+            <a:endParaRPr lang="en-US" sz="1200" dirty="0"/>
+          </a:p>
+        </p:txBody>
+      </p:sp>
+      <p:sp>
+        <p:nvSpPr>
+          <p:cNvPr id="27" name="Shape 24"/>
+          <p:cNvSpPr/>
+          <p:nvPr/>
+        </p:nvSpPr>
+        <p:spPr>
+          <a:xfrm>
+            <a:off x="4937760" y="4206240"/>
+            <a:ext cx="274320" cy="274320"/>
+          </a:xfrm>
+          <a:prstGeom prst="ellipse">
+            <a:avLst/>
+          </a:prstGeom>
+          <a:solidFill>
+            <a:srgbClr val="CC0000"/>
+          </a:solidFill>
+          <a:ln w="12700">
+            <a:solidFill>
+              <a:srgbClr val="CC0000"/>
+            </a:solidFill>
+            <a:prstDash val="solid"/>
+          </a:ln>
+        </p:spPr>
+      </p:sp>
+      <p:sp>
+        <p:nvSpPr>
+          <p:cNvPr id="28" name="Text 25"/>
+          <p:cNvSpPr/>
+          <p:nvPr/>
+        </p:nvSpPr>
+        <p:spPr>
+          <a:xfrm>
+            <a:off x="4937760" y="4206240"/>
+            <a:ext cx="274320" cy="274320"/>
+          </a:xfrm>
+          <a:prstGeom prst="rect">
+            <a:avLst/>
+          </a:prstGeom>
+          <a:noFill/>
+          <a:ln/>
+        </p:spPr>
+        <p:txBody>
+          <a:bodyPr wrap="square" lIns="0" tIns="0" rIns="0" bIns="0" rtlCol="0" anchor="ctr"/>
+          <a:lstStyle/>
+          <a:p>
             <a:pPr algn="ctr" indent="0" marL="0">
               <a:buNone/>
             </a:pPr>
             <a:r>
-              <a:rPr lang="en-US" sz="850" b="1" spc="200" kern="0" dirty="0">
-                <a:solidFill>
-                  <a:srgbClr val="333333"/>
-                </a:solidFill>
-                <a:latin typeface="Arial" pitchFamily="34" charset="0"/>
-                <a:ea typeface="Arial" pitchFamily="34" charset="-122"/>
-                <a:cs typeface="Arial" pitchFamily="34" charset="-120"/>
-              </a:rPr>
-              <a:t>WHY SOFTWARE IS DOWN</a:t>
-            </a:r>
-            <a:endParaRPr lang="en-US" sz="850" dirty="0"/>
-          </a:p>
-        </p:txBody>
-      </p:sp>
-      <p:sp>
-        <p:nvSpPr>
-          <p:cNvPr id="23" name="Text 20"/>
-          <p:cNvSpPr/>
-          <p:nvPr/>
-        </p:nvSpPr>
-        <p:spPr>
-          <a:xfrm>
-            <a:off x="6766560" y="3602736"/>
-            <a:ext cx="1920240" cy="548640"/>
-          </a:xfrm>
-          <a:prstGeom prst="rect">
-            <a:avLst/>
-          </a:prstGeom>
-          <a:noFill/>
-          <a:ln/>
-        </p:spPr>
-        <p:txBody>
-          <a:bodyPr wrap="square" lIns="0" tIns="0" rIns="0" bIns="0" rtlCol="0" anchor="ctr"/>
-          <a:lstStyle/>
-          <a:p>
-            <a:pPr algn="ctr" indent="0" marL="0">
-              <a:buNone/>
-            </a:pPr>
-            <a:r>
-              <a:rPr lang="en-US" sz="2800" b="1" dirty="0">
-                <a:solidFill>
-                  <a:srgbClr val="CC0000"/>
+              <a:rPr lang="en-US" sz="1100" b="1" dirty="0">
+                <a:solidFill>
+                  <a:srgbClr val="FFFFFF"/>
                 </a:solidFill>
                 <a:latin typeface="Arial Black" pitchFamily="34" charset="0"/>
                 <a:ea typeface="Arial Black" pitchFamily="34" charset="-122"/>
                 <a:cs typeface="Arial Black" pitchFamily="34" charset="-120"/>
               </a:rPr>
-              <a:t>−21%</a:t>
-            </a:r>
+              <a:t>◉</a:t>
+            </a:r>
+            <a:endParaRPr lang="en-US" sz="1100" dirty="0"/>
+          </a:p>
+        </p:txBody>
+      </p:sp>
+      <p:sp>
+        <p:nvSpPr>
+          <p:cNvPr id="29" name="Text 26"/>
+          <p:cNvSpPr/>
+          <p:nvPr/>
+        </p:nvSpPr>
+        <p:spPr>
+          <a:xfrm>
+            <a:off x="5303520" y="4178808"/>
+            <a:ext cx="3200400" cy="329184"/>
+          </a:xfrm>
+          <a:prstGeom prst="rect">
+            <a:avLst/>
+          </a:prstGeom>
+          <a:noFill/>
+          <a:ln/>
+        </p:spPr>
+        <p:txBody>
+          <a:bodyPr wrap="square" lIns="0" tIns="0" rIns="0" bIns="0" rtlCol="0" anchor="ctr"/>
+          <a:lstStyle/>
+          <a:p>
+            <a:pPr algn="l" indent="0" marL="0">
+              <a:buNone/>
+            </a:pPr>
+            <a:r>
+              <a:rPr lang="en-US" sz="950" dirty="0">
+                <a:solidFill>
+                  <a:srgbClr val="333333"/>
+                </a:solidFill>
+                <a:latin typeface="Arial" pitchFamily="34" charset="0"/>
+                <a:ea typeface="Arial" pitchFamily="34" charset="-122"/>
+                <a:cs typeface="Arial" pitchFamily="34" charset="-120"/>
+              </a:rPr>
+              <a:t>Agentic AI threatens per-seat pricing; 2026 CIO surveys flag displacement risk on horizontal SaaS.</a:t>
+            </a:r>
+            <a:endParaRPr lang="en-US" sz="950" dirty="0"/>
+          </a:p>
+        </p:txBody>
+      </p:sp>
+      <p:sp>
+        <p:nvSpPr>
+          <p:cNvPr id="30" name="Shape 27"/>
+          <p:cNvSpPr/>
+          <p:nvPr/>
+        </p:nvSpPr>
+        <p:spPr>
+          <a:xfrm>
+            <a:off x="4937760" y="4535424"/>
+            <a:ext cx="274320" cy="274320"/>
+          </a:xfrm>
+          <a:prstGeom prst="ellipse">
+            <a:avLst/>
+          </a:prstGeom>
+          <a:solidFill>
+            <a:srgbClr val="CC0000"/>
+          </a:solidFill>
+          <a:ln w="12700">
+            <a:solidFill>
+              <a:srgbClr val="CC0000"/>
+            </a:solidFill>
+            <a:prstDash val="solid"/>
+          </a:ln>
+        </p:spPr>
+      </p:sp>
+      <p:sp>
+        <p:nvSpPr>
+          <p:cNvPr id="31" name="Text 28"/>
+          <p:cNvSpPr/>
+          <p:nvPr/>
+        </p:nvSpPr>
+        <p:spPr>
+          <a:xfrm>
+            <a:off x="4937760" y="4535424"/>
+            <a:ext cx="274320" cy="274320"/>
+          </a:xfrm>
+          <a:prstGeom prst="rect">
+            <a:avLst/>
+          </a:prstGeom>
+          <a:noFill/>
+          <a:ln/>
+        </p:spPr>
+        <p:txBody>
+          <a:bodyPr wrap="square" lIns="0" tIns="0" rIns="0" bIns="0" rtlCol="0" anchor="ctr"/>
+          <a:lstStyle/>
+          <a:p>
             <a:pPr algn="ctr" indent="0" marL="0">
               <a:buNone/>
             </a:pPr>
             <a:r>
-              <a:rPr lang="en-US" sz="1000" baseline="30000" dirty="0">
-                <a:solidFill>
-                  <a:srgbClr val="CC0000"/>
+              <a:rPr lang="en-US" sz="1100" b="1" dirty="0">
+                <a:solidFill>
+                  <a:srgbClr val="FFFFFF"/>
                 </a:solidFill>
                 <a:latin typeface="Arial Black" pitchFamily="34" charset="0"/>
                 <a:ea typeface="Arial Black" pitchFamily="34" charset="-122"/>
                 <a:cs typeface="Arial Black" pitchFamily="34" charset="-120"/>
               </a:rPr>
-              <a:t> 3</a:t>
-            </a:r>
-            <a:endParaRPr lang="en-US" sz="2800" dirty="0"/>
-          </a:p>
-        </p:txBody>
-      </p:sp>
-      <p:sp>
-        <p:nvSpPr>
-          <p:cNvPr id="24" name="Text 21"/>
-          <p:cNvSpPr/>
-          <p:nvPr/>
-        </p:nvSpPr>
-        <p:spPr>
-          <a:xfrm>
-            <a:off x="6858000" y="4187952"/>
-            <a:ext cx="1737360" cy="310896"/>
-          </a:xfrm>
-          <a:prstGeom prst="rect">
-            <a:avLst/>
-          </a:prstGeom>
-          <a:noFill/>
-          <a:ln/>
-        </p:spPr>
-        <p:txBody>
-          <a:bodyPr wrap="square" lIns="0" tIns="0" rIns="0" bIns="0" rtlCol="0" anchor="t"/>
+              <a:t>✕</a:t>
+            </a:r>
+            <a:endParaRPr lang="en-US" sz="1100" dirty="0"/>
+          </a:p>
+        </p:txBody>
+      </p:sp>
+      <p:sp>
+        <p:nvSpPr>
+          <p:cNvPr id="32" name="Text 29"/>
+          <p:cNvSpPr/>
+          <p:nvPr/>
+        </p:nvSpPr>
+        <p:spPr>
+          <a:xfrm>
+            <a:off x="5303520" y="4507992"/>
+            <a:ext cx="3200400" cy="329184"/>
+          </a:xfrm>
+          <a:prstGeom prst="rect">
+            <a:avLst/>
+          </a:prstGeom>
+          <a:noFill/>
+          <a:ln/>
+        </p:spPr>
+        <p:txBody>
+          <a:bodyPr wrap="square" lIns="0" tIns="0" rIns="0" bIns="0" rtlCol="0" anchor="ctr"/>
+          <a:lstStyle/>
+          <a:p>
+            <a:pPr algn="l" indent="0" marL="0">
+              <a:buNone/>
+            </a:pPr>
+            <a:r>
+              <a:rPr lang="en-US" sz="950" dirty="0">
+                <a:solidFill>
+                  <a:srgbClr val="333333"/>
+                </a:solidFill>
+                <a:latin typeface="Arial" pitchFamily="34" charset="0"/>
+                <a:ea typeface="Arial" pitchFamily="34" charset="-122"/>
+                <a:cs typeface="Arial" pitchFamily="34" charset="-120"/>
+              </a:rPr>
+              <a:t>Public SaaS multiples re-rated lower as buyers underwrite slower seat growth and pricing pressure.</a:t>
+            </a:r>
+            <a:pPr algn="l" indent="0" marL="0">
+              <a:buNone/>
+            </a:pPr>
+            <a:r>
+              <a:rPr lang="en-US" sz="700" baseline="30000" dirty="0">
+                <a:solidFill>
+                  <a:srgbClr val="CC0000"/>
+                </a:solidFill>
+                <a:latin typeface="Arial" pitchFamily="34" charset="0"/>
+                <a:ea typeface="Arial" pitchFamily="34" charset="-122"/>
+                <a:cs typeface="Arial" pitchFamily="34" charset="-120"/>
+              </a:rPr>
+              <a:t> 2</a:t>
+            </a:r>
+            <a:endParaRPr lang="en-US" sz="950" dirty="0"/>
+          </a:p>
+        </p:txBody>
+      </p:sp>
+      <p:sp>
+        <p:nvSpPr>
+          <p:cNvPr id="33" name="Shape 30"/>
+          <p:cNvSpPr/>
+          <p:nvPr/>
+        </p:nvSpPr>
+        <p:spPr>
+          <a:xfrm>
+            <a:off x="4937760" y="4864608"/>
+            <a:ext cx="274320" cy="274320"/>
+          </a:xfrm>
+          <a:prstGeom prst="ellipse">
+            <a:avLst/>
+          </a:prstGeom>
+          <a:solidFill>
+            <a:srgbClr val="CC0000"/>
+          </a:solidFill>
+          <a:ln w="12700">
+            <a:solidFill>
+              <a:srgbClr val="CC0000"/>
+            </a:solidFill>
+            <a:prstDash val="solid"/>
+          </a:ln>
+        </p:spPr>
+      </p:sp>
+      <p:sp>
+        <p:nvSpPr>
+          <p:cNvPr id="34" name="Text 31"/>
+          <p:cNvSpPr/>
+          <p:nvPr/>
+        </p:nvSpPr>
+        <p:spPr>
+          <a:xfrm>
+            <a:off x="4937760" y="4864608"/>
+            <a:ext cx="274320" cy="274320"/>
+          </a:xfrm>
+          <a:prstGeom prst="rect">
+            <a:avLst/>
+          </a:prstGeom>
+          <a:noFill/>
+          <a:ln/>
+        </p:spPr>
+        <p:txBody>
+          <a:bodyPr wrap="square" lIns="0" tIns="0" rIns="0" bIns="0" rtlCol="0" anchor="ctr"/>
           <a:lstStyle/>
           <a:p>
             <a:pPr algn="ctr" indent="0" marL="0">
               <a:buNone/>
             </a:pPr>
             <a:r>
-              <a:rPr lang="en-US" sz="850" dirty="0">
-                <a:solidFill>
-                  <a:srgbClr val="666666"/>
-                </a:solidFill>
-                <a:latin typeface="Arial" pitchFamily="34" charset="0"/>
-                <a:ea typeface="Arial" pitchFamily="34" charset="-122"/>
-                <a:cs typeface="Arial" pitchFamily="34" charset="-120"/>
-              </a:rPr>
-              <a:t>Public SaaS EV/Revenue, Q4'25 → Q1'26</a:t>
-            </a:r>
-            <a:endParaRPr lang="en-US" sz="850" dirty="0"/>
-          </a:p>
-        </p:txBody>
-      </p:sp>
-      <p:sp>
-        <p:nvSpPr>
-          <p:cNvPr id="25" name="Text 22"/>
-          <p:cNvSpPr/>
-          <p:nvPr/>
-        </p:nvSpPr>
-        <p:spPr>
-          <a:xfrm>
-            <a:off x="6876288" y="4517136"/>
-            <a:ext cx="1700784" cy="658368"/>
-          </a:xfrm>
-          <a:prstGeom prst="rect">
-            <a:avLst/>
-          </a:prstGeom>
-          <a:noFill/>
-          <a:ln/>
-        </p:spPr>
-        <p:txBody>
-          <a:bodyPr wrap="square" lIns="0" tIns="0" rIns="0" bIns="0" rtlCol="0" anchor="t"/>
-          <a:lstStyle/>
-          <a:p>
-            <a:pPr algn="ctr" indent="0" marL="0">
-              <a:buNone/>
-            </a:pPr>
-            <a:r>
-              <a:rPr lang="en-US" sz="900" dirty="0">
+              <a:rPr lang="en-US" sz="1100" b="1" dirty="0">
+                <a:solidFill>
+                  <a:srgbClr val="FFFFFF"/>
+                </a:solidFill>
+                <a:latin typeface="Arial Black" pitchFamily="34" charset="0"/>
+                <a:ea typeface="Arial Black" pitchFamily="34" charset="-122"/>
+                <a:cs typeface="Arial Black" pitchFamily="34" charset="-120"/>
+              </a:rPr>
+              <a:t>↓</a:t>
+            </a:r>
+            <a:endParaRPr lang="en-US" sz="1100" dirty="0"/>
+          </a:p>
+        </p:txBody>
+      </p:sp>
+      <p:sp>
+        <p:nvSpPr>
+          <p:cNvPr id="35" name="Text 32"/>
+          <p:cNvSpPr/>
+          <p:nvPr/>
+        </p:nvSpPr>
+        <p:spPr>
+          <a:xfrm>
+            <a:off x="5303520" y="4837176"/>
+            <a:ext cx="3200400" cy="329184"/>
+          </a:xfrm>
+          <a:prstGeom prst="rect">
+            <a:avLst/>
+          </a:prstGeom>
+          <a:noFill/>
+          <a:ln/>
+        </p:spPr>
+        <p:txBody>
+          <a:bodyPr wrap="square" lIns="0" tIns="0" rIns="0" bIns="0" rtlCol="0" anchor="ctr"/>
+          <a:lstStyle/>
+          <a:p>
+            <a:pPr algn="l" indent="0" marL="0">
+              <a:buNone/>
+            </a:pPr>
+            <a:r>
+              <a:rPr lang="en-US" sz="950" dirty="0">
                 <a:solidFill>
                   <a:srgbClr val="333333"/>
                 </a:solidFill>
@@ -11613,15 +11919,15 @@
                 <a:ea typeface="Arial" pitchFamily="34" charset="-122"/>
                 <a:cs typeface="Arial" pitchFamily="34" charset="-120"/>
               </a:rPr>
-              <a:t>Agentic AI threatens seat pricing; 2026 CIO surveys flag displacement risk.</a:t>
-            </a:r>
-            <a:endParaRPr lang="en-US" sz="900" dirty="0"/>
-          </a:p>
-        </p:txBody>
-      </p:sp>
-      <p:sp>
-        <p:nvSpPr>
-          <p:cNvPr id="26" name="Text 23"/>
+              <a:t>Renewals slowing and deal cycles stretching as customers wait for vendor AI roadmaps to settle.</a:t>
+            </a:r>
+            <a:endParaRPr lang="en-US" sz="950" dirty="0"/>
+          </a:p>
+        </p:txBody>
+      </p:sp>
+      <p:sp>
+        <p:nvSpPr>
+          <p:cNvPr id="36" name="Text 33"/>
           <p:cNvSpPr/>
           <p:nvPr/>
         </p:nvSpPr>
@@ -11652,7 +11958,7 @@
                 <a:ea typeface="Arial" pitchFamily="34" charset="-122"/>
                 <a:cs typeface="Arial" pitchFamily="34" charset="-120"/>
               </a:rPr>
-              <a:t>BDC credit indices down ~5%</a:t>
+              <a:t>BDC credit indices are softening</a:t>
             </a:r>
             <a:pPr algn="ctr" indent="0" marL="0">
               <a:buNone/>
@@ -11666,7 +11972,7 @@
                 <a:ea typeface="Arial" pitchFamily="34" charset="-122"/>
                 <a:cs typeface="Arial" pitchFamily="34" charset="-120"/>
               </a:rPr>
-              <a:t> 4</a:t>
+              <a:t> 3</a:t>
             </a:r>
             <a:pPr algn="ctr" indent="0" marL="0">
               <a:buNone/>
@@ -11680,7 +11986,7 @@
                 <a:ea typeface="Arial" pitchFamily="34" charset="-122"/>
                 <a:cs typeface="Arial" pitchFamily="34" charset="-120"/>
               </a:rPr>
-              <a:t> YTD — early signs the sell-off is bleeding into private credit and PE-held SaaS.</a:t>
+              <a:t> — the first sign the SaaS sell-off is bleeding into private credit and PE-held software.</a:t>
             </a:r>
             <a:endParaRPr lang="en-US" sz="950" dirty="0"/>
           </a:p>
@@ -11688,7 +11994,7 @@
       </p:sp>
       <p:sp>
         <p:nvSpPr>
-          <p:cNvPr id="27" name="Text 24"/>
+          <p:cNvPr id="37" name="Text 34"/>
           <p:cNvSpPr/>
           <p:nvPr/>
         </p:nvSpPr>
@@ -11733,7 +12039,7 @@
                 <a:ea typeface="Arial" pitchFamily="34" charset="-122"/>
                 <a:cs typeface="Arial" pitchFamily="34" charset="-120"/>
               </a:rPr>
-              <a:t>Yahoo Finance, Apr 17, 2026 (SOX, IGV), </a:t>
+              <a:t>TrendForce via Data Center Dynamics, 2026, </a:t>
             </a:r>
             <a:pPr indent="0" marL="0">
               <a:buNone/>
@@ -11761,7 +12067,7 @@
                 <a:ea typeface="Arial" pitchFamily="34" charset="-122"/>
                 <a:cs typeface="Arial" pitchFamily="34" charset="-120"/>
               </a:rPr>
-              <a:t>TrendForce via Data Center Dynamics, 2026, </a:t>
+              <a:t>multiples.vc public software multiples, Apr 2026, </a:t>
             </a:r>
             <a:pPr indent="0" marL="0">
               <a:buNone/>
@@ -11789,34 +12095,6 @@
                 <a:ea typeface="Arial" pitchFamily="34" charset="-122"/>
                 <a:cs typeface="Arial" pitchFamily="34" charset="-120"/>
               </a:rPr>
-              <a:t>multiples.vc public software multiples, Apr 2026, </a:t>
-            </a:r>
-            <a:pPr indent="0" marL="0">
-              <a:buNone/>
-            </a:pPr>
-            <a:r>
-              <a:rPr lang="en-US" sz="700" b="1" dirty="0">
-                <a:solidFill>
-                  <a:srgbClr val="999999"/>
-                </a:solidFill>
-                <a:latin typeface="Arial" pitchFamily="34" charset="0"/>
-                <a:ea typeface="Arial" pitchFamily="34" charset="-122"/>
-                <a:cs typeface="Arial" pitchFamily="34" charset="-120"/>
-              </a:rPr>
-              <a:t>(4) </a:t>
-            </a:r>
-            <a:pPr indent="0" marL="0">
-              <a:buNone/>
-            </a:pPr>
-            <a:r>
-              <a:rPr lang="en-US" sz="700" dirty="0">
-                <a:solidFill>
-                  <a:srgbClr val="999999"/>
-                </a:solidFill>
-                <a:latin typeface="Arial" pitchFamily="34" charset="0"/>
-                <a:ea typeface="Arial" pitchFamily="34" charset="-122"/>
-                <a:cs typeface="Arial" pitchFamily="34" charset="-120"/>
-              </a:rPr>
               <a:t>VanEck BIZD / Yahoo Finance.</a:t>
             </a:r>
             <a:endParaRPr lang="en-US" sz="700" dirty="0"/>
@@ -11825,7 +12103,7 @@
       </p:sp>
       <p:sp>
         <p:nvSpPr>
-          <p:cNvPr id="28" name="Shape 25"/>
+          <p:cNvPr id="38" name="Shape 35"/>
           <p:cNvSpPr/>
           <p:nvPr/>
         </p:nvSpPr>
@@ -11850,7 +12128,7 @@
       </p:sp>
       <p:sp>
         <p:nvSpPr>
-          <p:cNvPr id="29" name="Text 26"/>
+          <p:cNvPr id="39" name="Text 36"/>
           <p:cNvSpPr/>
           <p:nvPr/>
         </p:nvSpPr>
@@ -11889,7 +12167,7 @@
       </p:sp>
       <p:sp>
         <p:nvSpPr>
-          <p:cNvPr id="30" name="Text 27"/>
+          <p:cNvPr id="40" name="Text 37"/>
           <p:cNvSpPr/>
           <p:nvPr/>
         </p:nvSpPr>

</xml_diff>

<commit_message>
Slide 13: rewrite bottom strip — drop BDC mention, summarize divergence + PE/PC pressure
Co-Authored-By: Claude Opus 4.7 <noreply@anthropic.com>
</commit_message>
<xml_diff>
--- a/ai-markets-deck.pptx
+++ b/ai-markets-deck.pptx
@@ -11958,35 +11958,7 @@
                 <a:ea typeface="Arial" pitchFamily="34" charset="-122"/>
                 <a:cs typeface="Arial" pitchFamily="34" charset="-120"/>
               </a:rPr>
-              <a:t>BDC credit indices are softening</a:t>
-            </a:r>
-            <a:pPr algn="ctr" indent="0" marL="0">
-              <a:buNone/>
-            </a:pPr>
-            <a:r>
-              <a:rPr lang="en-US" sz="700" i="1" baseline="30000" dirty="0">
-                <a:solidFill>
-                  <a:srgbClr val="666666"/>
-                </a:solidFill>
-                <a:latin typeface="Arial" pitchFamily="34" charset="0"/>
-                <a:ea typeface="Arial" pitchFamily="34" charset="-122"/>
-                <a:cs typeface="Arial" pitchFamily="34" charset="-120"/>
-              </a:rPr>
-              <a:t> 3</a:t>
-            </a:r>
-            <a:pPr algn="ctr" indent="0" marL="0">
-              <a:buNone/>
-            </a:pPr>
-            <a:r>
-              <a:rPr lang="en-US" sz="950" i="1" dirty="0">
-                <a:solidFill>
-                  <a:srgbClr val="666666"/>
-                </a:solidFill>
-                <a:latin typeface="Arial" pitchFamily="34" charset="0"/>
-                <a:ea typeface="Arial" pitchFamily="34" charset="-122"/>
-                <a:cs typeface="Arial" pitchFamily="34" charset="-120"/>
-              </a:rPr>
-              <a:t> — the first sign the SaaS sell-off is bleeding into private credit and PE-held software.</a:t>
+              <a:t>One theme, two outcomes — and software's pain is now bleeding into private equity and private credit, both anchored in SaaS.</a:t>
             </a:r>
             <a:endParaRPr lang="en-US" sz="950" dirty="0"/>
           </a:p>
@@ -12067,35 +12039,7 @@
                 <a:ea typeface="Arial" pitchFamily="34" charset="-122"/>
                 <a:cs typeface="Arial" pitchFamily="34" charset="-120"/>
               </a:rPr>
-              <a:t>multiples.vc public software multiples, Apr 2026, </a:t>
-            </a:r>
-            <a:pPr indent="0" marL="0">
-              <a:buNone/>
-            </a:pPr>
-            <a:r>
-              <a:rPr lang="en-US" sz="700" b="1" dirty="0">
-                <a:solidFill>
-                  <a:srgbClr val="999999"/>
-                </a:solidFill>
-                <a:latin typeface="Arial" pitchFamily="34" charset="0"/>
-                <a:ea typeface="Arial" pitchFamily="34" charset="-122"/>
-                <a:cs typeface="Arial" pitchFamily="34" charset="-120"/>
-              </a:rPr>
-              <a:t>(3) </a:t>
-            </a:r>
-            <a:pPr indent="0" marL="0">
-              <a:buNone/>
-            </a:pPr>
-            <a:r>
-              <a:rPr lang="en-US" sz="700" dirty="0">
-                <a:solidFill>
-                  <a:srgbClr val="999999"/>
-                </a:solidFill>
-                <a:latin typeface="Arial" pitchFamily="34" charset="0"/>
-                <a:ea typeface="Arial" pitchFamily="34" charset="-122"/>
-                <a:cs typeface="Arial" pitchFamily="34" charset="-120"/>
-              </a:rPr>
-              <a:t>VanEck BIZD / Yahoo Finance.</a:t>
+              <a:t>multiples.vc public software multiples, Apr 2026.</a:t>
             </a:r>
             <a:endParaRPr lang="en-US" sz="700" dirty="0"/>
           </a:p>

</xml_diff>

<commit_message>
Slide 15: full redesign — four chokepoint cards + reshoring timeline
Drop image placeholder and hero stats (~90% TSMC, 76% DRAM). Replace with
four single-points-of-failure cards (EUV Litho / Leading Logic / HBM Memory
/ Advanced Packaging) showing country, layer, and qualitative prose.
Add horizontal reshoring timeline (2025-2030+) showing when leading-edge
US capacity actually comes online. New synthesis line replaces label-style
title with thesis: "Four single points of failure."

Co-Authored-By: Claude Opus 4.7 <noreply@anthropic.com>
</commit_message>
<xml_diff>
--- a/ai-markets-deck.pptx
+++ b/ai-markets-deck.pptx
@@ -14084,7 +14084,7 @@
                 <a:ea typeface="Arial Black" pitchFamily="34" charset="-122"/>
                 <a:cs typeface="Arial Black" pitchFamily="34" charset="-120"/>
               </a:rPr>
-              <a:t>Supply chain fragility.</a:t>
+              <a:t>Four single points of failure.</a:t>
             </a:r>
             <a:endParaRPr lang="en-US" sz="2400" dirty="0"/>
           </a:p>
@@ -14123,7 +14123,7 @@
                 <a:ea typeface="Arial" pitchFamily="34" charset="-122"/>
                 <a:cs typeface="Arial" pitchFamily="34" charset="-120"/>
               </a:rPr>
-              <a:t>Four countries control the advanced semiconductor stack. US reshoring is real but slow — most leading-edge fabs come online 2027+.</a:t>
+              <a:t>Three of the four sit in Asia, and all four are single-sourced. US reshoring is real — but most leading-edge capacity doesn't ship until 2027+.</a:t>
             </a:r>
             <a:endParaRPr lang="en-US" sz="1350" dirty="0"/>
           </a:p>
@@ -14160,361 +14160,18 @@
         </p:nvSpPr>
         <p:spPr>
           <a:xfrm>
-            <a:off x="457200" y="1691640"/>
-            <a:ext cx="3200400" cy="3017520"/>
+            <a:off x="457200" y="1783080"/>
+            <a:ext cx="1920240" cy="274320"/>
           </a:xfrm>
           <a:prstGeom prst="rect">
             <a:avLst/>
           </a:prstGeom>
           <a:solidFill>
-            <a:srgbClr val="EEEEEE"/>
-          </a:solidFill>
-          <a:ln w="9525">
-            <a:solidFill>
-              <a:srgbClr val="BBBBBB"/>
-            </a:solidFill>
-            <a:prstDash val="dash"/>
-          </a:ln>
-        </p:spPr>
-      </p:sp>
-      <p:sp>
-        <p:nvSpPr>
-          <p:cNvPr id="8" name="Text 6"/>
-          <p:cNvSpPr/>
-          <p:nvPr/>
-        </p:nvSpPr>
-        <p:spPr>
-          <a:xfrm>
-            <a:off x="548640" y="1691640"/>
-            <a:ext cx="3017520" cy="3017520"/>
-          </a:xfrm>
-          <a:prstGeom prst="rect">
-            <a:avLst/>
-          </a:prstGeom>
-          <a:noFill/>
-          <a:ln/>
-        </p:spPr>
-        <p:txBody>
-          <a:bodyPr wrap="square" lIns="0" tIns="0" rIns="0" bIns="0" rtlCol="0" anchor="ctr"/>
-          <a:lstStyle/>
-          <a:p>
-            <a:pPr algn="ctr" indent="0" marL="0">
-              <a:buNone/>
-            </a:pPr>
-            <a:r>
-              <a:rPr lang="en-US" sz="1000" i="1" dirty="0">
-                <a:solidFill>
-                  <a:srgbClr val="888888"/>
-                </a:solidFill>
-                <a:latin typeface="Arial" pitchFamily="34" charset="0"/>
-                <a:ea typeface="Arial" pitchFamily="34" charset="-122"/>
-                <a:cs typeface="Arial" pitchFamily="34" charset="-120"/>
-              </a:rPr>
-              <a:t>IMAGE: Cinematic — two bunny-suited technicians in front of an EUV lithography tool, warm amber photolith glow, shallow DOF on a gloved hand at a control, stainless-steel cleanroom, near-square</a:t>
-            </a:r>
-            <a:endParaRPr lang="en-US" sz="1000" dirty="0"/>
-          </a:p>
-        </p:txBody>
-      </p:sp>
-      <p:sp>
-        <p:nvSpPr>
-          <p:cNvPr id="9" name="Text 7"/>
-          <p:cNvSpPr/>
-          <p:nvPr/>
-        </p:nvSpPr>
-        <p:spPr>
-          <a:xfrm>
-            <a:off x="3886200" y="1783080"/>
-            <a:ext cx="2377440" cy="685800"/>
-          </a:xfrm>
-          <a:prstGeom prst="rect">
-            <a:avLst/>
-          </a:prstGeom>
-          <a:noFill/>
-          <a:ln/>
-        </p:spPr>
-        <p:txBody>
-          <a:bodyPr wrap="square" lIns="0" tIns="0" rIns="0" bIns="0" rtlCol="0" anchor="ctr"/>
-          <a:lstStyle/>
-          <a:p>
-            <a:pPr algn="ctr" indent="0" marL="0">
-              <a:buNone/>
-            </a:pPr>
-            <a:r>
-              <a:rPr lang="en-US" sz="4000" b="1" dirty="0">
-                <a:solidFill>
-                  <a:srgbClr val="CC0000"/>
-                </a:solidFill>
-                <a:latin typeface="Arial Black" pitchFamily="34" charset="0"/>
-                <a:ea typeface="Arial Black" pitchFamily="34" charset="-122"/>
-                <a:cs typeface="Arial Black" pitchFamily="34" charset="-120"/>
-              </a:rPr>
-              <a:t>~90%</a:t>
-            </a:r>
-            <a:pPr algn="ctr" indent="0" marL="0">
-              <a:buNone/>
-            </a:pPr>
-            <a:r>
-              <a:rPr lang="en-US" sz="1400" baseline="30000" dirty="0">
-                <a:solidFill>
-                  <a:srgbClr val="CC0000"/>
-                </a:solidFill>
-                <a:latin typeface="Arial Black" pitchFamily="34" charset="0"/>
-                <a:ea typeface="Arial Black" pitchFamily="34" charset="-122"/>
-                <a:cs typeface="Arial Black" pitchFamily="34" charset="-120"/>
-              </a:rPr>
-              <a:t> 1</a:t>
-            </a:r>
-            <a:endParaRPr lang="en-US" sz="4000" dirty="0"/>
-          </a:p>
-        </p:txBody>
-      </p:sp>
-      <p:sp>
-        <p:nvSpPr>
-          <p:cNvPr id="10" name="Text 8"/>
-          <p:cNvSpPr/>
-          <p:nvPr/>
-        </p:nvSpPr>
-        <p:spPr>
-          <a:xfrm>
-            <a:off x="3886200" y="2514600"/>
-            <a:ext cx="2377440" cy="502920"/>
-          </a:xfrm>
-          <a:prstGeom prst="rect">
-            <a:avLst/>
-          </a:prstGeom>
-          <a:noFill/>
-          <a:ln/>
-        </p:spPr>
-        <p:txBody>
-          <a:bodyPr wrap="square" lIns="0" tIns="0" rIns="0" bIns="0" rtlCol="0" anchor="t"/>
-          <a:lstStyle/>
-          <a:p>
-            <a:pPr algn="ctr" indent="0" marL="0">
-              <a:buNone/>
-            </a:pPr>
-            <a:r>
-              <a:rPr lang="en-US" sz="1100" dirty="0">
-                <a:solidFill>
-                  <a:srgbClr val="666666"/>
-                </a:solidFill>
-                <a:latin typeface="Arial" pitchFamily="34" charset="0"/>
-                <a:ea typeface="Arial" pitchFamily="34" charset="-122"/>
-                <a:cs typeface="Arial" pitchFamily="34" charset="-120"/>
-              </a:rPr>
-              <a:t>TSMC share of advanced-node chips</a:t>
-            </a:r>
-            <a:endParaRPr lang="en-US" sz="1100" dirty="0"/>
-          </a:p>
-        </p:txBody>
-      </p:sp>
-      <p:sp>
-        <p:nvSpPr>
-          <p:cNvPr id="11" name="Text 9"/>
-          <p:cNvSpPr/>
-          <p:nvPr/>
-        </p:nvSpPr>
-        <p:spPr>
-          <a:xfrm>
-            <a:off x="6446520" y="1783080"/>
-            <a:ext cx="2377440" cy="685800"/>
-          </a:xfrm>
-          <a:prstGeom prst="rect">
-            <a:avLst/>
-          </a:prstGeom>
-          <a:noFill/>
-          <a:ln/>
-        </p:spPr>
-        <p:txBody>
-          <a:bodyPr wrap="square" lIns="0" tIns="0" rIns="0" bIns="0" rtlCol="0" anchor="ctr"/>
-          <a:lstStyle/>
-          <a:p>
-            <a:pPr algn="ctr" indent="0" marL="0">
-              <a:buNone/>
-            </a:pPr>
-            <a:r>
-              <a:rPr lang="en-US" sz="4000" b="1" dirty="0">
-                <a:solidFill>
-                  <a:srgbClr val="CC0000"/>
-                </a:solidFill>
-                <a:latin typeface="Arial Black" pitchFamily="34" charset="0"/>
-                <a:ea typeface="Arial Black" pitchFamily="34" charset="-122"/>
-                <a:cs typeface="Arial Black" pitchFamily="34" charset="-120"/>
-              </a:rPr>
-              <a:t>76%</a:t>
-            </a:r>
-            <a:pPr algn="ctr" indent="0" marL="0">
-              <a:buNone/>
-            </a:pPr>
-            <a:r>
-              <a:rPr lang="en-US" sz="1400" baseline="30000" dirty="0">
-                <a:solidFill>
-                  <a:srgbClr val="CC0000"/>
-                </a:solidFill>
-                <a:latin typeface="Arial Black" pitchFamily="34" charset="0"/>
-                <a:ea typeface="Arial Black" pitchFamily="34" charset="-122"/>
-                <a:cs typeface="Arial Black" pitchFamily="34" charset="-120"/>
-              </a:rPr>
-              <a:t> 2</a:t>
-            </a:r>
-            <a:endParaRPr lang="en-US" sz="4000" dirty="0"/>
-          </a:p>
-        </p:txBody>
-      </p:sp>
-      <p:sp>
-        <p:nvSpPr>
-          <p:cNvPr id="12" name="Text 10"/>
-          <p:cNvSpPr/>
-          <p:nvPr/>
-        </p:nvSpPr>
-        <p:spPr>
-          <a:xfrm>
-            <a:off x="6446520" y="2514600"/>
-            <a:ext cx="2377440" cy="502920"/>
-          </a:xfrm>
-          <a:prstGeom prst="rect">
-            <a:avLst/>
-          </a:prstGeom>
-          <a:noFill/>
-          <a:ln/>
-        </p:spPr>
-        <p:txBody>
-          <a:bodyPr wrap="square" lIns="0" tIns="0" rIns="0" bIns="0" rtlCol="0" anchor="t"/>
-          <a:lstStyle/>
-          <a:p>
-            <a:pPr algn="ctr" indent="0" marL="0">
-              <a:buNone/>
-            </a:pPr>
-            <a:r>
-              <a:rPr lang="en-US" sz="1100" dirty="0">
-                <a:solidFill>
-                  <a:srgbClr val="666666"/>
-                </a:solidFill>
-                <a:latin typeface="Arial" pitchFamily="34" charset="0"/>
-                <a:ea typeface="Arial" pitchFamily="34" charset="-122"/>
-                <a:cs typeface="Arial" pitchFamily="34" charset="-120"/>
-              </a:rPr>
-              <a:t>SK Hynix + Samsung DRAM share</a:t>
-            </a:r>
-            <a:endParaRPr lang="en-US" sz="1100" dirty="0"/>
-          </a:p>
-        </p:txBody>
-      </p:sp>
-      <p:sp>
-        <p:nvSpPr>
-          <p:cNvPr id="13" name="Text 11"/>
-          <p:cNvSpPr/>
-          <p:nvPr/>
-        </p:nvSpPr>
-        <p:spPr>
-          <a:xfrm>
-            <a:off x="3886200" y="3383280"/>
-            <a:ext cx="4800600" cy="1097280"/>
-          </a:xfrm>
-          <a:prstGeom prst="rect">
-            <a:avLst/>
-          </a:prstGeom>
-          <a:noFill/>
-          <a:ln/>
-        </p:spPr>
-        <p:txBody>
-          <a:bodyPr wrap="square" lIns="0" tIns="0" rIns="0" bIns="0" rtlCol="0" anchor="t"/>
-          <a:lstStyle/>
-          <a:p>
-            <a:pPr indent="0" marL="0">
-              <a:buNone/>
-            </a:pPr>
-            <a:r>
-              <a:rPr lang="en-US" sz="1200" dirty="0">
-                <a:solidFill>
-                  <a:srgbClr val="333333"/>
-                </a:solidFill>
-                <a:latin typeface="Arial" pitchFamily="34" charset="0"/>
-                <a:ea typeface="Arial" pitchFamily="34" charset="-122"/>
-                <a:cs typeface="Arial" pitchFamily="34" charset="-120"/>
-              </a:rPr>
-              <a:t>A single leading-edge chip crosses 70+ borders and six countries</a:t>
-            </a:r>
-            <a:pPr indent="0" marL="0">
-              <a:buNone/>
-            </a:pPr>
-            <a:r>
-              <a:rPr lang="en-US" sz="800" baseline="30000" dirty="0">
-                <a:solidFill>
-                  <a:srgbClr val="333333"/>
-                </a:solidFill>
-                <a:latin typeface="Arial" pitchFamily="34" charset="0"/>
-                <a:ea typeface="Arial" pitchFamily="34" charset="-122"/>
-                <a:cs typeface="Arial" pitchFamily="34" charset="-120"/>
-              </a:rPr>
-              <a:t> 3</a:t>
-            </a:r>
-            <a:pPr indent="0" marL="0">
-              <a:buNone/>
-            </a:pPr>
-            <a:r>
-              <a:rPr lang="en-US" sz="1200" dirty="0">
-                <a:solidFill>
-                  <a:srgbClr val="333333"/>
-                </a:solidFill>
-                <a:latin typeface="Arial" pitchFamily="34" charset="0"/>
-                <a:ea typeface="Arial" pitchFamily="34" charset="-122"/>
-                <a:cs typeface="Arial" pitchFamily="34" charset="-120"/>
-              </a:rPr>
-              <a:t> before reaching a data center. ASML builds fewer than 100 EUV machines a year</a:t>
-            </a:r>
-            <a:pPr indent="0" marL="0">
-              <a:buNone/>
-            </a:pPr>
-            <a:r>
-              <a:rPr lang="en-US" sz="800" baseline="30000" dirty="0">
-                <a:solidFill>
-                  <a:srgbClr val="333333"/>
-                </a:solidFill>
-                <a:latin typeface="Arial" pitchFamily="34" charset="0"/>
-                <a:ea typeface="Arial" pitchFamily="34" charset="-122"/>
-                <a:cs typeface="Arial" pitchFamily="34" charset="-120"/>
-              </a:rPr>
-              <a:t> 4</a:t>
-            </a:r>
-            <a:pPr indent="0" marL="0">
-              <a:buNone/>
-            </a:pPr>
-            <a:r>
-              <a:rPr lang="en-US" sz="1200" dirty="0">
-                <a:solidFill>
-                  <a:srgbClr val="333333"/>
-                </a:solidFill>
-                <a:latin typeface="Arial" pitchFamily="34" charset="0"/>
-                <a:ea typeface="Arial" pitchFamily="34" charset="-122"/>
-                <a:cs typeface="Arial" pitchFamily="34" charset="-120"/>
-              </a:rPr>
-              <a:t>.</a:t>
-            </a:r>
-            <a:endParaRPr lang="en-US" sz="1200" dirty="0"/>
-          </a:p>
-        </p:txBody>
-      </p:sp>
-      <p:sp>
-        <p:nvSpPr>
-          <p:cNvPr id="14" name="Shape 12"/>
-          <p:cNvSpPr/>
-          <p:nvPr/>
-        </p:nvSpPr>
-        <p:spPr>
-          <a:xfrm>
-            <a:off x="457200" y="4800600"/>
-            <a:ext cx="8229600" cy="320040"/>
-          </a:xfrm>
-          <a:prstGeom prst="rect">
-            <a:avLst/>
-          </a:prstGeom>
-          <a:solidFill>
-            <a:srgbClr val="333333"/>
+            <a:srgbClr val="CC0000"/>
           </a:solidFill>
           <a:ln w="12700">
             <a:solidFill>
-              <a:srgbClr val="333333"/>
+              <a:srgbClr val="CC0000"/>
             </a:solidFill>
             <a:prstDash val="solid"/>
           </a:ln>
@@ -14522,14 +14179,14 @@
       </p:sp>
       <p:sp>
         <p:nvSpPr>
-          <p:cNvPr id="15" name="Text 13"/>
-          <p:cNvSpPr/>
-          <p:nvPr/>
-        </p:nvSpPr>
-        <p:spPr>
-          <a:xfrm>
-            <a:off x="457200" y="4800600"/>
-            <a:ext cx="8229600" cy="320040"/>
+          <p:cNvPr id="8" name="Text 6"/>
+          <p:cNvSpPr/>
+          <p:nvPr/>
+        </p:nvSpPr>
+        <p:spPr>
+          <a:xfrm>
+            <a:off x="457200" y="1783080"/>
+            <a:ext cx="1920240" cy="274320"/>
           </a:xfrm>
           <a:prstGeom prst="rect">
             <a:avLst/>
@@ -14547,13 +14204,13 @@
             <a:r>
               <a:rPr lang="en-US" sz="1000" b="1" spc="300" kern="0" dirty="0">
                 <a:solidFill>
-                  <a:srgbClr val="F6693D"/>
-                </a:solidFill>
-                <a:latin typeface="Arial" pitchFamily="34" charset="0"/>
-                <a:ea typeface="Arial" pitchFamily="34" charset="-122"/>
-                <a:cs typeface="Arial" pitchFamily="34" charset="-120"/>
-              </a:rPr>
-              <a:t>US RESHORING — ACTUAL STATUS</a:t>
+                  <a:srgbClr val="FFFFFF"/>
+                </a:solidFill>
+                <a:latin typeface="Arial" pitchFamily="34" charset="0"/>
+                <a:ea typeface="Arial" pitchFamily="34" charset="-122"/>
+                <a:cs typeface="Arial" pitchFamily="34" charset="-120"/>
+              </a:rPr>
+              <a:t>NETHERLANDS</a:t>
             </a:r>
             <a:endParaRPr lang="en-US" sz="1000" dirty="0"/>
           </a:p>
@@ -14561,20 +14218,20 @@
       </p:sp>
       <p:sp>
         <p:nvSpPr>
-          <p:cNvPr id="16" name="Shape 14"/>
-          <p:cNvSpPr/>
-          <p:nvPr/>
-        </p:nvSpPr>
-        <p:spPr>
-          <a:xfrm>
-            <a:off x="502920" y="5120640"/>
-            <a:ext cx="1943100" cy="685800"/>
+          <p:cNvPr id="9" name="Shape 7"/>
+          <p:cNvSpPr/>
+          <p:nvPr/>
+        </p:nvSpPr>
+        <p:spPr>
+          <a:xfrm>
+            <a:off x="457200" y="2057400"/>
+            <a:ext cx="1920240" cy="1645920"/>
           </a:xfrm>
           <a:prstGeom prst="rect">
             <a:avLst/>
           </a:prstGeom>
           <a:solidFill>
-            <a:srgbClr val="F9F9F9"/>
+            <a:srgbClr val="FFFFFF"/>
           </a:solidFill>
           <a:ln w="6350">
             <a:solidFill>
@@ -14586,14 +14243,14 @@
       </p:sp>
       <p:sp>
         <p:nvSpPr>
-          <p:cNvPr id="17" name="Text 15"/>
-          <p:cNvSpPr/>
-          <p:nvPr/>
-        </p:nvSpPr>
-        <p:spPr>
-          <a:xfrm>
-            <a:off x="548640" y="5138928"/>
-            <a:ext cx="1828800" cy="274320"/>
+          <p:cNvPr id="10" name="Text 8"/>
+          <p:cNvSpPr/>
+          <p:nvPr/>
+        </p:nvSpPr>
+        <p:spPr>
+          <a:xfrm>
+            <a:off x="457200" y="2103120"/>
+            <a:ext cx="1920240" cy="457200"/>
           </a:xfrm>
           <a:prstGeom prst="rect">
             <a:avLst/>
@@ -14605,34 +14262,34 @@
           <a:bodyPr wrap="square" lIns="0" tIns="0" rIns="0" bIns="0" rtlCol="0" anchor="ctr"/>
           <a:lstStyle/>
           <a:p>
-            <a:pPr indent="0" marL="0">
-              <a:buNone/>
-            </a:pPr>
-            <a:r>
-              <a:rPr lang="en-US" sz="1050" b="1" dirty="0">
-                <a:solidFill>
-                  <a:srgbClr val="000000"/>
-                </a:solidFill>
-                <a:latin typeface="Arial" pitchFamily="34" charset="0"/>
-                <a:ea typeface="Arial" pitchFamily="34" charset="-122"/>
-                <a:cs typeface="Arial" pitchFamily="34" charset="-120"/>
-              </a:rPr>
-              <a:t>TSMC Arizona</a:t>
-            </a:r>
-            <a:endParaRPr lang="en-US" sz="1050" dirty="0"/>
-          </a:p>
-        </p:txBody>
-      </p:sp>
-      <p:sp>
-        <p:nvSpPr>
-          <p:cNvPr id="18" name="Text 16"/>
-          <p:cNvSpPr/>
-          <p:nvPr/>
-        </p:nvSpPr>
-        <p:spPr>
-          <a:xfrm>
-            <a:off x="548640" y="5394960"/>
-            <a:ext cx="1828800" cy="411480"/>
+            <a:pPr algn="ctr" indent="0" marL="0">
+              <a:buNone/>
+            </a:pPr>
+            <a:r>
+              <a:rPr lang="en-US" sz="3600" b="1" dirty="0">
+                <a:solidFill>
+                  <a:srgbClr val="CC0000"/>
+                </a:solidFill>
+                <a:latin typeface="Arial Black" pitchFamily="34" charset="0"/>
+                <a:ea typeface="Arial Black" pitchFamily="34" charset="-122"/>
+                <a:cs typeface="Arial Black" pitchFamily="34" charset="-120"/>
+              </a:rPr>
+              <a:t>▲</a:t>
+            </a:r>
+            <a:endParaRPr lang="en-US" sz="3600" dirty="0"/>
+          </a:p>
+        </p:txBody>
+      </p:sp>
+      <p:sp>
+        <p:nvSpPr>
+          <p:cNvPr id="11" name="Text 9"/>
+          <p:cNvSpPr/>
+          <p:nvPr/>
+        </p:nvSpPr>
+        <p:spPr>
+          <a:xfrm>
+            <a:off x="457200" y="2587752"/>
+            <a:ext cx="1920240" cy="274320"/>
           </a:xfrm>
           <a:prstGeom prst="rect">
             <a:avLst/>
@@ -14644,7 +14301,69 @@
           <a:bodyPr wrap="square" lIns="0" tIns="0" rIns="0" bIns="0" rtlCol="0" anchor="ctr"/>
           <a:lstStyle/>
           <a:p>
-            <a:pPr indent="0" marL="0">
+            <a:pPr algn="ctr" indent="0" marL="0">
+              <a:buNone/>
+            </a:pPr>
+            <a:r>
+              <a:rPr lang="en-US" sz="1300" b="1" dirty="0">
+                <a:solidFill>
+                  <a:srgbClr val="333333"/>
+                </a:solidFill>
+                <a:latin typeface="Arial" pitchFamily="34" charset="0"/>
+                <a:ea typeface="Arial" pitchFamily="34" charset="-122"/>
+                <a:cs typeface="Arial" pitchFamily="34" charset="-120"/>
+              </a:rPr>
+              <a:t>EUV Litho</a:t>
+            </a:r>
+            <a:endParaRPr lang="en-US" sz="1300" dirty="0"/>
+          </a:p>
+        </p:txBody>
+      </p:sp>
+      <p:sp>
+        <p:nvSpPr>
+          <p:cNvPr id="12" name="Shape 10"/>
+          <p:cNvSpPr/>
+          <p:nvPr/>
+        </p:nvSpPr>
+        <p:spPr>
+          <a:xfrm>
+            <a:off x="960120" y="2907792"/>
+            <a:ext cx="914400" cy="0"/>
+          </a:xfrm>
+          <a:prstGeom prst="line">
+            <a:avLst/>
+          </a:prstGeom>
+          <a:noFill/>
+          <a:ln w="19050">
+            <a:solidFill>
+              <a:srgbClr val="CC0000"/>
+            </a:solidFill>
+            <a:prstDash val="solid"/>
+          </a:ln>
+        </p:spPr>
+      </p:sp>
+      <p:sp>
+        <p:nvSpPr>
+          <p:cNvPr id="13" name="Text 11"/>
+          <p:cNvSpPr/>
+          <p:nvPr/>
+        </p:nvSpPr>
+        <p:spPr>
+          <a:xfrm>
+            <a:off x="566928" y="2999232"/>
+            <a:ext cx="1700784" cy="640080"/>
+          </a:xfrm>
+          <a:prstGeom prst="rect">
+            <a:avLst/>
+          </a:prstGeom>
+          <a:noFill/>
+          <a:ln/>
+        </p:spPr>
+        <p:txBody>
+          <a:bodyPr wrap="square" lIns="0" tIns="0" rIns="0" bIns="0" rtlCol="0" anchor="t"/>
+          <a:lstStyle/>
+          <a:p>
+            <a:pPr algn="l" indent="0" marL="0">
               <a:buNone/>
             </a:pPr>
             <a:r>
@@ -14656,7 +14375,21 @@
                 <a:ea typeface="Arial" pitchFamily="34" charset="-122"/>
                 <a:cs typeface="Arial" pitchFamily="34" charset="-120"/>
               </a:rPr>
-              <a:t>Fab 1 at 4nm; Fab 2 ~2026–27</a:t>
+              <a:t>Only firm in the world building EUV scanners — new machines ship in dozens per year, not hundreds.</a:t>
+            </a:r>
+            <a:pPr algn="l" indent="0" marL="0">
+              <a:buNone/>
+            </a:pPr>
+            <a:r>
+              <a:rPr lang="en-US" sz="700" baseline="30000" dirty="0">
+                <a:solidFill>
+                  <a:srgbClr val="CC0000"/>
+                </a:solidFill>
+                <a:latin typeface="Arial" pitchFamily="34" charset="0"/>
+                <a:ea typeface="Arial" pitchFamily="34" charset="-122"/>
+                <a:cs typeface="Arial" pitchFamily="34" charset="-120"/>
+              </a:rPr>
+              <a:t> 1</a:t>
             </a:r>
             <a:endParaRPr lang="en-US" sz="900" dirty="0"/>
           </a:p>
@@ -14664,20 +14397,84 @@
       </p:sp>
       <p:sp>
         <p:nvSpPr>
-          <p:cNvPr id="19" name="Shape 17"/>
-          <p:cNvSpPr/>
-          <p:nvPr/>
-        </p:nvSpPr>
-        <p:spPr>
-          <a:xfrm>
-            <a:off x="2537460" y="5120640"/>
-            <a:ext cx="1943100" cy="685800"/>
+          <p:cNvPr id="14" name="Shape 12"/>
+          <p:cNvSpPr/>
+          <p:nvPr/>
+        </p:nvSpPr>
+        <p:spPr>
+          <a:xfrm>
+            <a:off x="2468880" y="1783080"/>
+            <a:ext cx="1920240" cy="274320"/>
           </a:xfrm>
           <a:prstGeom prst="rect">
             <a:avLst/>
           </a:prstGeom>
           <a:solidFill>
-            <a:srgbClr val="F9F9F9"/>
+            <a:srgbClr val="CC0000"/>
+          </a:solidFill>
+          <a:ln w="12700">
+            <a:solidFill>
+              <a:srgbClr val="CC0000"/>
+            </a:solidFill>
+            <a:prstDash val="solid"/>
+          </a:ln>
+        </p:spPr>
+      </p:sp>
+      <p:sp>
+        <p:nvSpPr>
+          <p:cNvPr id="15" name="Text 13"/>
+          <p:cNvSpPr/>
+          <p:nvPr/>
+        </p:nvSpPr>
+        <p:spPr>
+          <a:xfrm>
+            <a:off x="2468880" y="1783080"/>
+            <a:ext cx="1920240" cy="274320"/>
+          </a:xfrm>
+          <a:prstGeom prst="rect">
+            <a:avLst/>
+          </a:prstGeom>
+          <a:noFill/>
+          <a:ln/>
+        </p:spPr>
+        <p:txBody>
+          <a:bodyPr wrap="square" lIns="0" tIns="0" rIns="0" bIns="0" rtlCol="0" anchor="ctr"/>
+          <a:lstStyle/>
+          <a:p>
+            <a:pPr algn="ctr" indent="0" marL="0">
+              <a:buNone/>
+            </a:pPr>
+            <a:r>
+              <a:rPr lang="en-US" sz="1000" b="1" spc="300" kern="0" dirty="0">
+                <a:solidFill>
+                  <a:srgbClr val="FFFFFF"/>
+                </a:solidFill>
+                <a:latin typeface="Arial" pitchFamily="34" charset="0"/>
+                <a:ea typeface="Arial" pitchFamily="34" charset="-122"/>
+                <a:cs typeface="Arial" pitchFamily="34" charset="-120"/>
+              </a:rPr>
+              <a:t>TAIWAN</a:t>
+            </a:r>
+            <a:endParaRPr lang="en-US" sz="1000" dirty="0"/>
+          </a:p>
+        </p:txBody>
+      </p:sp>
+      <p:sp>
+        <p:nvSpPr>
+          <p:cNvPr id="16" name="Shape 14"/>
+          <p:cNvSpPr/>
+          <p:nvPr/>
+        </p:nvSpPr>
+        <p:spPr>
+          <a:xfrm>
+            <a:off x="2468880" y="2057400"/>
+            <a:ext cx="1920240" cy="1645920"/>
+          </a:xfrm>
+          <a:prstGeom prst="rect">
+            <a:avLst/>
+          </a:prstGeom>
+          <a:solidFill>
+            <a:srgbClr val="FFFFFF"/>
           </a:solidFill>
           <a:ln w="6350">
             <a:solidFill>
@@ -14689,14 +14486,193 @@
       </p:sp>
       <p:sp>
         <p:nvSpPr>
+          <p:cNvPr id="17" name="Text 15"/>
+          <p:cNvSpPr/>
+          <p:nvPr/>
+        </p:nvSpPr>
+        <p:spPr>
+          <a:xfrm>
+            <a:off x="2468880" y="2103120"/>
+            <a:ext cx="1920240" cy="457200"/>
+          </a:xfrm>
+          <a:prstGeom prst="rect">
+            <a:avLst/>
+          </a:prstGeom>
+          <a:noFill/>
+          <a:ln/>
+        </p:spPr>
+        <p:txBody>
+          <a:bodyPr wrap="square" lIns="0" tIns="0" rIns="0" bIns="0" rtlCol="0" anchor="ctr"/>
+          <a:lstStyle/>
+          <a:p>
+            <a:pPr algn="ctr" indent="0" marL="0">
+              <a:buNone/>
+            </a:pPr>
+            <a:r>
+              <a:rPr lang="en-US" sz="3600" b="1" dirty="0">
+                <a:solidFill>
+                  <a:srgbClr val="CC0000"/>
+                </a:solidFill>
+                <a:latin typeface="Arial Black" pitchFamily="34" charset="0"/>
+                <a:ea typeface="Arial Black" pitchFamily="34" charset="-122"/>
+                <a:cs typeface="Arial Black" pitchFamily="34" charset="-120"/>
+              </a:rPr>
+              <a:t>▦</a:t>
+            </a:r>
+            <a:endParaRPr lang="en-US" sz="3600" dirty="0"/>
+          </a:p>
+        </p:txBody>
+      </p:sp>
+      <p:sp>
+        <p:nvSpPr>
+          <p:cNvPr id="18" name="Text 16"/>
+          <p:cNvSpPr/>
+          <p:nvPr/>
+        </p:nvSpPr>
+        <p:spPr>
+          <a:xfrm>
+            <a:off x="2468880" y="2587752"/>
+            <a:ext cx="1920240" cy="274320"/>
+          </a:xfrm>
+          <a:prstGeom prst="rect">
+            <a:avLst/>
+          </a:prstGeom>
+          <a:noFill/>
+          <a:ln/>
+        </p:spPr>
+        <p:txBody>
+          <a:bodyPr wrap="square" lIns="0" tIns="0" rIns="0" bIns="0" rtlCol="0" anchor="ctr"/>
+          <a:lstStyle/>
+          <a:p>
+            <a:pPr algn="ctr" indent="0" marL="0">
+              <a:buNone/>
+            </a:pPr>
+            <a:r>
+              <a:rPr lang="en-US" sz="1300" b="1" dirty="0">
+                <a:solidFill>
+                  <a:srgbClr val="333333"/>
+                </a:solidFill>
+                <a:latin typeface="Arial" pitchFamily="34" charset="0"/>
+                <a:ea typeface="Arial" pitchFamily="34" charset="-122"/>
+                <a:cs typeface="Arial" pitchFamily="34" charset="-120"/>
+              </a:rPr>
+              <a:t>Leading Logic</a:t>
+            </a:r>
+            <a:endParaRPr lang="en-US" sz="1300" dirty="0"/>
+          </a:p>
+        </p:txBody>
+      </p:sp>
+      <p:sp>
+        <p:nvSpPr>
+          <p:cNvPr id="19" name="Shape 17"/>
+          <p:cNvSpPr/>
+          <p:nvPr/>
+        </p:nvSpPr>
+        <p:spPr>
+          <a:xfrm>
+            <a:off x="2971800" y="2907792"/>
+            <a:ext cx="914400" cy="0"/>
+          </a:xfrm>
+          <a:prstGeom prst="line">
+            <a:avLst/>
+          </a:prstGeom>
+          <a:noFill/>
+          <a:ln w="19050">
+            <a:solidFill>
+              <a:srgbClr val="CC0000"/>
+            </a:solidFill>
+            <a:prstDash val="solid"/>
+          </a:ln>
+        </p:spPr>
+      </p:sp>
+      <p:sp>
+        <p:nvSpPr>
           <p:cNvPr id="20" name="Text 18"/>
           <p:cNvSpPr/>
           <p:nvPr/>
         </p:nvSpPr>
         <p:spPr>
           <a:xfrm>
-            <a:off x="2583180" y="5138928"/>
-            <a:ext cx="1828800" cy="274320"/>
+            <a:off x="2578608" y="2999232"/>
+            <a:ext cx="1700784" cy="640080"/>
+          </a:xfrm>
+          <a:prstGeom prst="rect">
+            <a:avLst/>
+          </a:prstGeom>
+          <a:noFill/>
+          <a:ln/>
+        </p:spPr>
+        <p:txBody>
+          <a:bodyPr wrap="square" lIns="0" tIns="0" rIns="0" bIns="0" rtlCol="0" anchor="t"/>
+          <a:lstStyle/>
+          <a:p>
+            <a:pPr algn="l" indent="0" marL="0">
+              <a:buNone/>
+            </a:pPr>
+            <a:r>
+              <a:rPr lang="en-US" sz="900" dirty="0">
+                <a:solidFill>
+                  <a:srgbClr val="333333"/>
+                </a:solidFill>
+                <a:latin typeface="Arial" pitchFamily="34" charset="0"/>
+                <a:ea typeface="Arial" pitchFamily="34" charset="-122"/>
+                <a:cs typeface="Arial" pitchFamily="34" charset="-120"/>
+              </a:rPr>
+              <a:t>Virtually every advanced-node chip runs through TSMC fabs in Hsinchu and Tainan — no real volume alternative exists.</a:t>
+            </a:r>
+            <a:pPr algn="l" indent="0" marL="0">
+              <a:buNone/>
+            </a:pPr>
+            <a:r>
+              <a:rPr lang="en-US" sz="700" baseline="30000" dirty="0">
+                <a:solidFill>
+                  <a:srgbClr val="CC0000"/>
+                </a:solidFill>
+                <a:latin typeface="Arial" pitchFamily="34" charset="0"/>
+                <a:ea typeface="Arial" pitchFamily="34" charset="-122"/>
+                <a:cs typeface="Arial" pitchFamily="34" charset="-120"/>
+              </a:rPr>
+              <a:t> 2</a:t>
+            </a:r>
+            <a:endParaRPr lang="en-US" sz="900" dirty="0"/>
+          </a:p>
+        </p:txBody>
+      </p:sp>
+      <p:sp>
+        <p:nvSpPr>
+          <p:cNvPr id="21" name="Shape 19"/>
+          <p:cNvSpPr/>
+          <p:nvPr/>
+        </p:nvSpPr>
+        <p:spPr>
+          <a:xfrm>
+            <a:off x="4480560" y="1783080"/>
+            <a:ext cx="1920240" cy="274320"/>
+          </a:xfrm>
+          <a:prstGeom prst="rect">
+            <a:avLst/>
+          </a:prstGeom>
+          <a:solidFill>
+            <a:srgbClr val="CC0000"/>
+          </a:solidFill>
+          <a:ln w="12700">
+            <a:solidFill>
+              <a:srgbClr val="CC0000"/>
+            </a:solidFill>
+            <a:prstDash val="solid"/>
+          </a:ln>
+        </p:spPr>
+      </p:sp>
+      <p:sp>
+        <p:nvSpPr>
+          <p:cNvPr id="22" name="Text 20"/>
+          <p:cNvSpPr/>
+          <p:nvPr/>
+        </p:nvSpPr>
+        <p:spPr>
+          <a:xfrm>
+            <a:off x="4480560" y="1783080"/>
+            <a:ext cx="1920240" cy="274320"/>
           </a:xfrm>
           <a:prstGeom prst="rect">
             <a:avLst/>
@@ -14708,79 +14684,40 @@
           <a:bodyPr wrap="square" lIns="0" tIns="0" rIns="0" bIns="0" rtlCol="0" anchor="ctr"/>
           <a:lstStyle/>
           <a:p>
-            <a:pPr indent="0" marL="0">
-              <a:buNone/>
-            </a:pPr>
-            <a:r>
-              <a:rPr lang="en-US" sz="1050" b="1" dirty="0">
-                <a:solidFill>
-                  <a:srgbClr val="000000"/>
-                </a:solidFill>
-                <a:latin typeface="Arial" pitchFamily="34" charset="0"/>
-                <a:ea typeface="Arial" pitchFamily="34" charset="-122"/>
-                <a:cs typeface="Arial" pitchFamily="34" charset="-120"/>
-              </a:rPr>
-              <a:t>Samsung Taylor</a:t>
-            </a:r>
-            <a:endParaRPr lang="en-US" sz="1050" dirty="0"/>
-          </a:p>
-        </p:txBody>
-      </p:sp>
-      <p:sp>
-        <p:nvSpPr>
-          <p:cNvPr id="21" name="Text 19"/>
-          <p:cNvSpPr/>
-          <p:nvPr/>
-        </p:nvSpPr>
-        <p:spPr>
-          <a:xfrm>
-            <a:off x="2583180" y="5394960"/>
-            <a:ext cx="1828800" cy="411480"/>
-          </a:xfrm>
-          <a:prstGeom prst="rect">
-            <a:avLst/>
-          </a:prstGeom>
-          <a:noFill/>
-          <a:ln/>
-        </p:spPr>
-        <p:txBody>
-          <a:bodyPr wrap="square" lIns="0" tIns="0" rIns="0" bIns="0" rtlCol="0" anchor="ctr"/>
-          <a:lstStyle/>
-          <a:p>
-            <a:pPr indent="0" marL="0">
-              <a:buNone/>
-            </a:pPr>
-            <a:r>
-              <a:rPr lang="en-US" sz="900" dirty="0">
-                <a:solidFill>
-                  <a:srgbClr val="333333"/>
-                </a:solidFill>
-                <a:latin typeface="Arial" pitchFamily="34" charset="0"/>
-                <a:ea typeface="Arial" pitchFamily="34" charset="-122"/>
-                <a:cs typeface="Arial" pitchFamily="34" charset="-120"/>
-              </a:rPr>
-              <a:t>2nm fab, pushed to 2026</a:t>
-            </a:r>
-            <a:endParaRPr lang="en-US" sz="900" dirty="0"/>
-          </a:p>
-        </p:txBody>
-      </p:sp>
-      <p:sp>
-        <p:nvSpPr>
-          <p:cNvPr id="22" name="Shape 20"/>
-          <p:cNvSpPr/>
-          <p:nvPr/>
-        </p:nvSpPr>
-        <p:spPr>
-          <a:xfrm>
-            <a:off x="4572000" y="5120640"/>
-            <a:ext cx="1943100" cy="685800"/>
+            <a:pPr algn="ctr" indent="0" marL="0">
+              <a:buNone/>
+            </a:pPr>
+            <a:r>
+              <a:rPr lang="en-US" sz="1000" b="1" spc="300" kern="0" dirty="0">
+                <a:solidFill>
+                  <a:srgbClr val="FFFFFF"/>
+                </a:solidFill>
+                <a:latin typeface="Arial" pitchFamily="34" charset="0"/>
+                <a:ea typeface="Arial" pitchFamily="34" charset="-122"/>
+                <a:cs typeface="Arial" pitchFamily="34" charset="-120"/>
+              </a:rPr>
+              <a:t>KOREA</a:t>
+            </a:r>
+            <a:endParaRPr lang="en-US" sz="1000" dirty="0"/>
+          </a:p>
+        </p:txBody>
+      </p:sp>
+      <p:sp>
+        <p:nvSpPr>
+          <p:cNvPr id="23" name="Shape 21"/>
+          <p:cNvSpPr/>
+          <p:nvPr/>
+        </p:nvSpPr>
+        <p:spPr>
+          <a:xfrm>
+            <a:off x="4480560" y="2057400"/>
+            <a:ext cx="1920240" cy="1645920"/>
           </a:xfrm>
           <a:prstGeom prst="rect">
             <a:avLst/>
           </a:prstGeom>
           <a:solidFill>
-            <a:srgbClr val="F9F9F9"/>
+            <a:srgbClr val="FFFFFF"/>
           </a:solidFill>
           <a:ln w="6350">
             <a:solidFill>
@@ -14792,14 +14729,14 @@
       </p:sp>
       <p:sp>
         <p:nvSpPr>
-          <p:cNvPr id="23" name="Text 21"/>
-          <p:cNvSpPr/>
-          <p:nvPr/>
-        </p:nvSpPr>
-        <p:spPr>
-          <a:xfrm>
-            <a:off x="4617720" y="5138928"/>
-            <a:ext cx="1828800" cy="274320"/>
+          <p:cNvPr id="24" name="Text 22"/>
+          <p:cNvSpPr/>
+          <p:nvPr/>
+        </p:nvSpPr>
+        <p:spPr>
+          <a:xfrm>
+            <a:off x="4480560" y="2103120"/>
+            <a:ext cx="1920240" cy="457200"/>
           </a:xfrm>
           <a:prstGeom prst="rect">
             <a:avLst/>
@@ -14811,34 +14748,34 @@
           <a:bodyPr wrap="square" lIns="0" tIns="0" rIns="0" bIns="0" rtlCol="0" anchor="ctr"/>
           <a:lstStyle/>
           <a:p>
-            <a:pPr indent="0" marL="0">
-              <a:buNone/>
-            </a:pPr>
-            <a:r>
-              <a:rPr lang="en-US" sz="1050" b="1" dirty="0">
-                <a:solidFill>
-                  <a:srgbClr val="000000"/>
-                </a:solidFill>
-                <a:latin typeface="Arial" pitchFamily="34" charset="0"/>
-                <a:ea typeface="Arial" pitchFamily="34" charset="-122"/>
-                <a:cs typeface="Arial" pitchFamily="34" charset="-120"/>
-              </a:rPr>
-              <a:t>Micron Clay NY</a:t>
-            </a:r>
-            <a:endParaRPr lang="en-US" sz="1050" dirty="0"/>
-          </a:p>
-        </p:txBody>
-      </p:sp>
-      <p:sp>
-        <p:nvSpPr>
-          <p:cNvPr id="24" name="Text 22"/>
-          <p:cNvSpPr/>
-          <p:nvPr/>
-        </p:nvSpPr>
-        <p:spPr>
-          <a:xfrm>
-            <a:off x="4617720" y="5394960"/>
-            <a:ext cx="1828800" cy="411480"/>
+            <a:pPr algn="ctr" indent="0" marL="0">
+              <a:buNone/>
+            </a:pPr>
+            <a:r>
+              <a:rPr lang="en-US" sz="3600" b="1" dirty="0">
+                <a:solidFill>
+                  <a:srgbClr val="CC0000"/>
+                </a:solidFill>
+                <a:latin typeface="Arial Black" pitchFamily="34" charset="0"/>
+                <a:ea typeface="Arial Black" pitchFamily="34" charset="-122"/>
+                <a:cs typeface="Arial Black" pitchFamily="34" charset="-120"/>
+              </a:rPr>
+              <a:t>☰</a:t>
+            </a:r>
+            <a:endParaRPr lang="en-US" sz="3600" dirty="0"/>
+          </a:p>
+        </p:txBody>
+      </p:sp>
+      <p:sp>
+        <p:nvSpPr>
+          <p:cNvPr id="25" name="Text 23"/>
+          <p:cNvSpPr/>
+          <p:nvPr/>
+        </p:nvSpPr>
+        <p:spPr>
+          <a:xfrm>
+            <a:off x="4480560" y="2587752"/>
+            <a:ext cx="1920240" cy="274320"/>
           </a:xfrm>
           <a:prstGeom prst="rect">
             <a:avLst/>
@@ -14850,7 +14787,69 @@
           <a:bodyPr wrap="square" lIns="0" tIns="0" rIns="0" bIns="0" rtlCol="0" anchor="ctr"/>
           <a:lstStyle/>
           <a:p>
-            <a:pPr indent="0" marL="0">
+            <a:pPr algn="ctr" indent="0" marL="0">
+              <a:buNone/>
+            </a:pPr>
+            <a:r>
+              <a:rPr lang="en-US" sz="1300" b="1" dirty="0">
+                <a:solidFill>
+                  <a:srgbClr val="333333"/>
+                </a:solidFill>
+                <a:latin typeface="Arial" pitchFamily="34" charset="0"/>
+                <a:ea typeface="Arial" pitchFamily="34" charset="-122"/>
+                <a:cs typeface="Arial" pitchFamily="34" charset="-120"/>
+              </a:rPr>
+              <a:t>HBM Memory</a:t>
+            </a:r>
+            <a:endParaRPr lang="en-US" sz="1300" dirty="0"/>
+          </a:p>
+        </p:txBody>
+      </p:sp>
+      <p:sp>
+        <p:nvSpPr>
+          <p:cNvPr id="26" name="Shape 24"/>
+          <p:cNvSpPr/>
+          <p:nvPr/>
+        </p:nvSpPr>
+        <p:spPr>
+          <a:xfrm>
+            <a:off x="4983480" y="2907792"/>
+            <a:ext cx="914400" cy="0"/>
+          </a:xfrm>
+          <a:prstGeom prst="line">
+            <a:avLst/>
+          </a:prstGeom>
+          <a:noFill/>
+          <a:ln w="19050">
+            <a:solidFill>
+              <a:srgbClr val="CC0000"/>
+            </a:solidFill>
+            <a:prstDash val="solid"/>
+          </a:ln>
+        </p:spPr>
+      </p:sp>
+      <p:sp>
+        <p:nvSpPr>
+          <p:cNvPr id="27" name="Text 25"/>
+          <p:cNvSpPr/>
+          <p:nvPr/>
+        </p:nvSpPr>
+        <p:spPr>
+          <a:xfrm>
+            <a:off x="4590288" y="2999232"/>
+            <a:ext cx="1700784" cy="640080"/>
+          </a:xfrm>
+          <a:prstGeom prst="rect">
+            <a:avLst/>
+          </a:prstGeom>
+          <a:noFill/>
+          <a:ln/>
+        </p:spPr>
+        <p:txBody>
+          <a:bodyPr wrap="square" lIns="0" tIns="0" rIns="0" bIns="0" rtlCol="0" anchor="t"/>
+          <a:lstStyle/>
+          <a:p>
+            <a:pPr algn="l" indent="0" marL="0">
               <a:buNone/>
             </a:pPr>
             <a:r>
@@ -14862,7 +14861,21 @@
                 <a:ea typeface="Arial" pitchFamily="34" charset="-122"/>
                 <a:cs typeface="Arial" pitchFamily="34" charset="-120"/>
               </a:rPr>
-              <a:t>Ground broken; online ~2028–30</a:t>
+              <a:t>Two Korean firms supply nearly all the high-bandwidth memory AI accelerators depend on — both booked through 2026.</a:t>
+            </a:r>
+            <a:pPr algn="l" indent="0" marL="0">
+              <a:buNone/>
+            </a:pPr>
+            <a:r>
+              <a:rPr lang="en-US" sz="700" baseline="30000" dirty="0">
+                <a:solidFill>
+                  <a:srgbClr val="CC0000"/>
+                </a:solidFill>
+                <a:latin typeface="Arial" pitchFamily="34" charset="0"/>
+                <a:ea typeface="Arial" pitchFamily="34" charset="-122"/>
+                <a:cs typeface="Arial" pitchFamily="34" charset="-120"/>
+              </a:rPr>
+              <a:t> 3</a:t>
             </a:r>
             <a:endParaRPr lang="en-US" sz="900" dirty="0"/>
           </a:p>
@@ -14870,20 +14883,84 @@
       </p:sp>
       <p:sp>
         <p:nvSpPr>
-          <p:cNvPr id="25" name="Shape 23"/>
-          <p:cNvSpPr/>
-          <p:nvPr/>
-        </p:nvSpPr>
-        <p:spPr>
-          <a:xfrm>
-            <a:off x="6606540" y="5120640"/>
-            <a:ext cx="1943100" cy="685800"/>
+          <p:cNvPr id="28" name="Shape 26"/>
+          <p:cNvSpPr/>
+          <p:nvPr/>
+        </p:nvSpPr>
+        <p:spPr>
+          <a:xfrm>
+            <a:off x="6492240" y="1783080"/>
+            <a:ext cx="1920240" cy="274320"/>
           </a:xfrm>
           <a:prstGeom prst="rect">
             <a:avLst/>
           </a:prstGeom>
           <a:solidFill>
-            <a:srgbClr val="F9F9F9"/>
+            <a:srgbClr val="CC0000"/>
+          </a:solidFill>
+          <a:ln w="12700">
+            <a:solidFill>
+              <a:srgbClr val="CC0000"/>
+            </a:solidFill>
+            <a:prstDash val="solid"/>
+          </a:ln>
+        </p:spPr>
+      </p:sp>
+      <p:sp>
+        <p:nvSpPr>
+          <p:cNvPr id="29" name="Text 27"/>
+          <p:cNvSpPr/>
+          <p:nvPr/>
+        </p:nvSpPr>
+        <p:spPr>
+          <a:xfrm>
+            <a:off x="6492240" y="1783080"/>
+            <a:ext cx="1920240" cy="274320"/>
+          </a:xfrm>
+          <a:prstGeom prst="rect">
+            <a:avLst/>
+          </a:prstGeom>
+          <a:noFill/>
+          <a:ln/>
+        </p:spPr>
+        <p:txBody>
+          <a:bodyPr wrap="square" lIns="0" tIns="0" rIns="0" bIns="0" rtlCol="0" anchor="ctr"/>
+          <a:lstStyle/>
+          <a:p>
+            <a:pPr algn="ctr" indent="0" marL="0">
+              <a:buNone/>
+            </a:pPr>
+            <a:r>
+              <a:rPr lang="en-US" sz="1000" b="1" spc="300" kern="0" dirty="0">
+                <a:solidFill>
+                  <a:srgbClr val="FFFFFF"/>
+                </a:solidFill>
+                <a:latin typeface="Arial" pitchFamily="34" charset="0"/>
+                <a:ea typeface="Arial" pitchFamily="34" charset="-122"/>
+                <a:cs typeface="Arial" pitchFamily="34" charset="-120"/>
+              </a:rPr>
+              <a:t>TAIWAN</a:t>
+            </a:r>
+            <a:endParaRPr lang="en-US" sz="1000" dirty="0"/>
+          </a:p>
+        </p:txBody>
+      </p:sp>
+      <p:sp>
+        <p:nvSpPr>
+          <p:cNvPr id="30" name="Shape 28"/>
+          <p:cNvSpPr/>
+          <p:nvPr/>
+        </p:nvSpPr>
+        <p:spPr>
+          <a:xfrm>
+            <a:off x="6492240" y="2057400"/>
+            <a:ext cx="1920240" cy="1645920"/>
+          </a:xfrm>
+          <a:prstGeom prst="rect">
+            <a:avLst/>
+          </a:prstGeom>
+          <a:solidFill>
+            <a:srgbClr val="FFFFFF"/>
           </a:solidFill>
           <a:ln w="6350">
             <a:solidFill>
@@ -14895,14 +14972,14 @@
       </p:sp>
       <p:sp>
         <p:nvSpPr>
-          <p:cNvPr id="26" name="Text 24"/>
-          <p:cNvSpPr/>
-          <p:nvPr/>
-        </p:nvSpPr>
-        <p:spPr>
-          <a:xfrm>
-            <a:off x="6652260" y="5138928"/>
-            <a:ext cx="1828800" cy="274320"/>
+          <p:cNvPr id="31" name="Text 29"/>
+          <p:cNvSpPr/>
+          <p:nvPr/>
+        </p:nvSpPr>
+        <p:spPr>
+          <a:xfrm>
+            <a:off x="6492240" y="2103120"/>
+            <a:ext cx="1920240" cy="457200"/>
           </a:xfrm>
           <a:prstGeom prst="rect">
             <a:avLst/>
@@ -14914,13 +14991,563 @@
           <a:bodyPr wrap="square" lIns="0" tIns="0" rIns="0" bIns="0" rtlCol="0" anchor="ctr"/>
           <a:lstStyle/>
           <a:p>
-            <a:pPr indent="0" marL="0">
-              <a:buNone/>
-            </a:pPr>
-            <a:r>
-              <a:rPr lang="en-US" sz="1050" b="1" dirty="0">
-                <a:solidFill>
-                  <a:srgbClr val="000000"/>
+            <a:pPr algn="ctr" indent="0" marL="0">
+              <a:buNone/>
+            </a:pPr>
+            <a:r>
+              <a:rPr lang="en-US" sz="3600" b="1" dirty="0">
+                <a:solidFill>
+                  <a:srgbClr val="CC0000"/>
+                </a:solidFill>
+                <a:latin typeface="Arial Black" pitchFamily="34" charset="0"/>
+                <a:ea typeface="Arial Black" pitchFamily="34" charset="-122"/>
+                <a:cs typeface="Arial Black" pitchFamily="34" charset="-120"/>
+              </a:rPr>
+              <a:t>◫</a:t>
+            </a:r>
+            <a:endParaRPr lang="en-US" sz="3600" dirty="0"/>
+          </a:p>
+        </p:txBody>
+      </p:sp>
+      <p:sp>
+        <p:nvSpPr>
+          <p:cNvPr id="32" name="Text 30"/>
+          <p:cNvSpPr/>
+          <p:nvPr/>
+        </p:nvSpPr>
+        <p:spPr>
+          <a:xfrm>
+            <a:off x="6492240" y="2587752"/>
+            <a:ext cx="1920240" cy="274320"/>
+          </a:xfrm>
+          <a:prstGeom prst="rect">
+            <a:avLst/>
+          </a:prstGeom>
+          <a:noFill/>
+          <a:ln/>
+        </p:spPr>
+        <p:txBody>
+          <a:bodyPr wrap="square" lIns="0" tIns="0" rIns="0" bIns="0" rtlCol="0" anchor="ctr"/>
+          <a:lstStyle/>
+          <a:p>
+            <a:pPr algn="ctr" indent="0" marL="0">
+              <a:buNone/>
+            </a:pPr>
+            <a:r>
+              <a:rPr lang="en-US" sz="1300" b="1" dirty="0">
+                <a:solidFill>
+                  <a:srgbClr val="333333"/>
+                </a:solidFill>
+                <a:latin typeface="Arial" pitchFamily="34" charset="0"/>
+                <a:ea typeface="Arial" pitchFamily="34" charset="-122"/>
+                <a:cs typeface="Arial" pitchFamily="34" charset="-120"/>
+              </a:rPr>
+              <a:t>Advanced Packaging</a:t>
+            </a:r>
+            <a:endParaRPr lang="en-US" sz="1300" dirty="0"/>
+          </a:p>
+        </p:txBody>
+      </p:sp>
+      <p:sp>
+        <p:nvSpPr>
+          <p:cNvPr id="33" name="Shape 31"/>
+          <p:cNvSpPr/>
+          <p:nvPr/>
+        </p:nvSpPr>
+        <p:spPr>
+          <a:xfrm>
+            <a:off x="6995160" y="2907792"/>
+            <a:ext cx="914400" cy="0"/>
+          </a:xfrm>
+          <a:prstGeom prst="line">
+            <a:avLst/>
+          </a:prstGeom>
+          <a:noFill/>
+          <a:ln w="19050">
+            <a:solidFill>
+              <a:srgbClr val="CC0000"/>
+            </a:solidFill>
+            <a:prstDash val="solid"/>
+          </a:ln>
+        </p:spPr>
+      </p:sp>
+      <p:sp>
+        <p:nvSpPr>
+          <p:cNvPr id="34" name="Text 32"/>
+          <p:cNvSpPr/>
+          <p:nvPr/>
+        </p:nvSpPr>
+        <p:spPr>
+          <a:xfrm>
+            <a:off x="6601968" y="2999232"/>
+            <a:ext cx="1700784" cy="640080"/>
+          </a:xfrm>
+          <a:prstGeom prst="rect">
+            <a:avLst/>
+          </a:prstGeom>
+          <a:noFill/>
+          <a:ln/>
+        </p:spPr>
+        <p:txBody>
+          <a:bodyPr wrap="square" lIns="0" tIns="0" rIns="0" bIns="0" rtlCol="0" anchor="t"/>
+          <a:lstStyle/>
+          <a:p>
+            <a:pPr algn="l" indent="0" marL="0">
+              <a:buNone/>
+            </a:pPr>
+            <a:r>
+              <a:rPr lang="en-US" sz="900" dirty="0">
+                <a:solidFill>
+                  <a:srgbClr val="333333"/>
+                </a:solidFill>
+                <a:latin typeface="Arial" pitchFamily="34" charset="0"/>
+                <a:ea typeface="Arial" pitchFamily="34" charset="-122"/>
+                <a:cs typeface="Arial" pitchFamily="34" charset="-120"/>
+              </a:rPr>
+              <a:t>TSMC's CoWoS step fuses the GPU die to its HBM stack — the only volume supplier, sold out through 2026.</a:t>
+            </a:r>
+            <a:pPr algn="l" indent="0" marL="0">
+              <a:buNone/>
+            </a:pPr>
+            <a:r>
+              <a:rPr lang="en-US" sz="700" baseline="30000" dirty="0">
+                <a:solidFill>
+                  <a:srgbClr val="CC0000"/>
+                </a:solidFill>
+                <a:latin typeface="Arial" pitchFamily="34" charset="0"/>
+                <a:ea typeface="Arial" pitchFamily="34" charset="-122"/>
+                <a:cs typeface="Arial" pitchFamily="34" charset="-120"/>
+              </a:rPr>
+              <a:t> 4</a:t>
+            </a:r>
+            <a:endParaRPr lang="en-US" sz="900" dirty="0"/>
+          </a:p>
+        </p:txBody>
+      </p:sp>
+      <p:sp>
+        <p:nvSpPr>
+          <p:cNvPr id="35" name="Text 33"/>
+          <p:cNvSpPr/>
+          <p:nvPr/>
+        </p:nvSpPr>
+        <p:spPr>
+          <a:xfrm>
+            <a:off x="457200" y="3931920"/>
+            <a:ext cx="8229600" cy="228600"/>
+          </a:xfrm>
+          <a:prstGeom prst="rect">
+            <a:avLst/>
+          </a:prstGeom>
+          <a:noFill/>
+          <a:ln/>
+        </p:spPr>
+        <p:txBody>
+          <a:bodyPr wrap="square" lIns="0" tIns="0" rIns="0" bIns="0" rtlCol="0" anchor="ctr"/>
+          <a:lstStyle/>
+          <a:p>
+            <a:pPr algn="l" indent="0" marL="0">
+              <a:buNone/>
+            </a:pPr>
+            <a:r>
+              <a:rPr lang="en-US" sz="1000" b="1" spc="300" kern="0" dirty="0">
+                <a:solidFill>
+                  <a:srgbClr val="333333"/>
+                </a:solidFill>
+                <a:latin typeface="Arial" pitchFamily="34" charset="0"/>
+                <a:ea typeface="Arial" pitchFamily="34" charset="-122"/>
+                <a:cs typeface="Arial" pitchFamily="34" charset="-120"/>
+              </a:rPr>
+              <a:t>US RESHORING — WHEN LEADING-EDGE CAPACITY COMES ONLINE</a:t>
+            </a:r>
+            <a:endParaRPr lang="en-US" sz="1000" dirty="0"/>
+          </a:p>
+        </p:txBody>
+      </p:sp>
+      <p:sp>
+        <p:nvSpPr>
+          <p:cNvPr id="36" name="Shape 34"/>
+          <p:cNvSpPr/>
+          <p:nvPr/>
+        </p:nvSpPr>
+        <p:spPr>
+          <a:xfrm>
+            <a:off x="640080" y="4572000"/>
+            <a:ext cx="7863840" cy="0"/>
+          </a:xfrm>
+          <a:prstGeom prst="line">
+            <a:avLst/>
+          </a:prstGeom>
+          <a:noFill/>
+          <a:ln w="19050">
+            <a:solidFill>
+              <a:srgbClr val="333333"/>
+            </a:solidFill>
+            <a:prstDash val="solid"/>
+          </a:ln>
+        </p:spPr>
+      </p:sp>
+      <p:sp>
+        <p:nvSpPr>
+          <p:cNvPr id="37" name="Shape 35"/>
+          <p:cNvSpPr/>
+          <p:nvPr/>
+        </p:nvSpPr>
+        <p:spPr>
+          <a:xfrm>
+            <a:off x="566928" y="4498848"/>
+            <a:ext cx="146304" cy="146304"/>
+          </a:xfrm>
+          <a:prstGeom prst="ellipse">
+            <a:avLst/>
+          </a:prstGeom>
+          <a:solidFill>
+            <a:srgbClr val="CC0000"/>
+          </a:solidFill>
+          <a:ln w="12700">
+            <a:solidFill>
+              <a:srgbClr val="CC0000"/>
+            </a:solidFill>
+            <a:prstDash val="solid"/>
+          </a:ln>
+        </p:spPr>
+      </p:sp>
+      <p:sp>
+        <p:nvSpPr>
+          <p:cNvPr id="38" name="Text 36"/>
+          <p:cNvSpPr/>
+          <p:nvPr/>
+        </p:nvSpPr>
+        <p:spPr>
+          <a:xfrm>
+            <a:off x="457200" y="4206240"/>
+            <a:ext cx="1280160" cy="274320"/>
+          </a:xfrm>
+          <a:prstGeom prst="rect">
+            <a:avLst/>
+          </a:prstGeom>
+          <a:noFill/>
+          <a:ln/>
+        </p:spPr>
+        <p:txBody>
+          <a:bodyPr wrap="square" lIns="0" tIns="0" rIns="0" bIns="0" rtlCol="0" anchor="b"/>
+          <a:lstStyle/>
+          <a:p>
+            <a:pPr algn="l" indent="0" marL="0">
+              <a:buNone/>
+            </a:pPr>
+            <a:r>
+              <a:rPr lang="en-US" sz="1000" b="1" dirty="0">
+                <a:solidFill>
+                  <a:srgbClr val="333333"/>
+                </a:solidFill>
+                <a:latin typeface="Arial" pitchFamily="34" charset="0"/>
+                <a:ea typeface="Arial" pitchFamily="34" charset="-122"/>
+                <a:cs typeface="Arial" pitchFamily="34" charset="-120"/>
+              </a:rPr>
+              <a:t>TSMC AZ Fab 1</a:t>
+            </a:r>
+            <a:endParaRPr lang="en-US" sz="1000" dirty="0"/>
+          </a:p>
+        </p:txBody>
+      </p:sp>
+      <p:sp>
+        <p:nvSpPr>
+          <p:cNvPr id="39" name="Text 37"/>
+          <p:cNvSpPr/>
+          <p:nvPr/>
+        </p:nvSpPr>
+        <p:spPr>
+          <a:xfrm>
+            <a:off x="365760" y="4709160"/>
+            <a:ext cx="640080" cy="228600"/>
+          </a:xfrm>
+          <a:prstGeom prst="rect">
+            <a:avLst/>
+          </a:prstGeom>
+          <a:noFill/>
+          <a:ln/>
+        </p:spPr>
+        <p:txBody>
+          <a:bodyPr wrap="square" lIns="0" tIns="0" rIns="0" bIns="0" rtlCol="0" anchor="t"/>
+          <a:lstStyle/>
+          <a:p>
+            <a:pPr algn="l" indent="0" marL="0">
+              <a:buNone/>
+            </a:pPr>
+            <a:r>
+              <a:rPr lang="en-US" sz="1000" b="1" dirty="0">
+                <a:solidFill>
+                  <a:srgbClr val="CC0000"/>
+                </a:solidFill>
+                <a:latin typeface="Arial" pitchFamily="34" charset="0"/>
+                <a:ea typeface="Arial" pitchFamily="34" charset="-122"/>
+                <a:cs typeface="Arial" pitchFamily="34" charset="-120"/>
+              </a:rPr>
+              <a:t>2025</a:t>
+            </a:r>
+            <a:endParaRPr lang="en-US" sz="1000" dirty="0"/>
+          </a:p>
+        </p:txBody>
+      </p:sp>
+      <p:sp>
+        <p:nvSpPr>
+          <p:cNvPr id="40" name="Shape 38"/>
+          <p:cNvSpPr/>
+          <p:nvPr/>
+        </p:nvSpPr>
+        <p:spPr>
+          <a:xfrm>
+            <a:off x="2532888" y="4498848"/>
+            <a:ext cx="146304" cy="146304"/>
+          </a:xfrm>
+          <a:prstGeom prst="ellipse">
+            <a:avLst/>
+          </a:prstGeom>
+          <a:solidFill>
+            <a:srgbClr val="CC0000"/>
+          </a:solidFill>
+          <a:ln w="12700">
+            <a:solidFill>
+              <a:srgbClr val="CC0000"/>
+            </a:solidFill>
+            <a:prstDash val="solid"/>
+          </a:ln>
+        </p:spPr>
+      </p:sp>
+      <p:sp>
+        <p:nvSpPr>
+          <p:cNvPr id="41" name="Text 39"/>
+          <p:cNvSpPr/>
+          <p:nvPr/>
+        </p:nvSpPr>
+        <p:spPr>
+          <a:xfrm>
+            <a:off x="1828800" y="4206240"/>
+            <a:ext cx="1554480" cy="274320"/>
+          </a:xfrm>
+          <a:prstGeom prst="rect">
+            <a:avLst/>
+          </a:prstGeom>
+          <a:noFill/>
+          <a:ln/>
+        </p:spPr>
+        <p:txBody>
+          <a:bodyPr wrap="square" lIns="0" tIns="0" rIns="0" bIns="0" rtlCol="0" anchor="b"/>
+          <a:lstStyle/>
+          <a:p>
+            <a:pPr algn="ctr" indent="0" marL="0">
+              <a:buNone/>
+            </a:pPr>
+            <a:r>
+              <a:rPr lang="en-US" sz="1000" b="1" dirty="0">
+                <a:solidFill>
+                  <a:srgbClr val="333333"/>
+                </a:solidFill>
+                <a:latin typeface="Arial" pitchFamily="34" charset="0"/>
+                <a:ea typeface="Arial" pitchFamily="34" charset="-122"/>
+                <a:cs typeface="Arial" pitchFamily="34" charset="-120"/>
+              </a:rPr>
+              <a:t>Samsung Taylor</a:t>
+            </a:r>
+            <a:endParaRPr lang="en-US" sz="1000" dirty="0"/>
+          </a:p>
+        </p:txBody>
+      </p:sp>
+      <p:sp>
+        <p:nvSpPr>
+          <p:cNvPr id="42" name="Text 40"/>
+          <p:cNvSpPr/>
+          <p:nvPr/>
+        </p:nvSpPr>
+        <p:spPr>
+          <a:xfrm>
+            <a:off x="2240280" y="4709160"/>
+            <a:ext cx="731520" cy="228600"/>
+          </a:xfrm>
+          <a:prstGeom prst="rect">
+            <a:avLst/>
+          </a:prstGeom>
+          <a:noFill/>
+          <a:ln/>
+        </p:spPr>
+        <p:txBody>
+          <a:bodyPr wrap="square" lIns="0" tIns="0" rIns="0" bIns="0" rtlCol="0" anchor="t"/>
+          <a:lstStyle/>
+          <a:p>
+            <a:pPr algn="ctr" indent="0" marL="0">
+              <a:buNone/>
+            </a:pPr>
+            <a:r>
+              <a:rPr lang="en-US" sz="1000" b="1" dirty="0">
+                <a:solidFill>
+                  <a:srgbClr val="CC0000"/>
+                </a:solidFill>
+                <a:latin typeface="Arial" pitchFamily="34" charset="0"/>
+                <a:ea typeface="Arial" pitchFamily="34" charset="-122"/>
+                <a:cs typeface="Arial" pitchFamily="34" charset="-120"/>
+              </a:rPr>
+              <a:t>2026</a:t>
+            </a:r>
+            <a:endParaRPr lang="en-US" sz="1000" dirty="0"/>
+          </a:p>
+        </p:txBody>
+      </p:sp>
+      <p:sp>
+        <p:nvSpPr>
+          <p:cNvPr id="43" name="Shape 41"/>
+          <p:cNvSpPr/>
+          <p:nvPr/>
+        </p:nvSpPr>
+        <p:spPr>
+          <a:xfrm>
+            <a:off x="4498848" y="4498848"/>
+            <a:ext cx="146304" cy="146304"/>
+          </a:xfrm>
+          <a:prstGeom prst="ellipse">
+            <a:avLst/>
+          </a:prstGeom>
+          <a:solidFill>
+            <a:srgbClr val="CC0000"/>
+          </a:solidFill>
+          <a:ln w="12700">
+            <a:solidFill>
+              <a:srgbClr val="CC0000"/>
+            </a:solidFill>
+            <a:prstDash val="solid"/>
+          </a:ln>
+        </p:spPr>
+      </p:sp>
+      <p:sp>
+        <p:nvSpPr>
+          <p:cNvPr id="44" name="Text 42"/>
+          <p:cNvSpPr/>
+          <p:nvPr/>
+        </p:nvSpPr>
+        <p:spPr>
+          <a:xfrm>
+            <a:off x="3794760" y="4206240"/>
+            <a:ext cx="1554480" cy="274320"/>
+          </a:xfrm>
+          <a:prstGeom prst="rect">
+            <a:avLst/>
+          </a:prstGeom>
+          <a:noFill/>
+          <a:ln/>
+        </p:spPr>
+        <p:txBody>
+          <a:bodyPr wrap="square" lIns="0" tIns="0" rIns="0" bIns="0" rtlCol="0" anchor="b"/>
+          <a:lstStyle/>
+          <a:p>
+            <a:pPr algn="ctr" indent="0" marL="0">
+              <a:buNone/>
+            </a:pPr>
+            <a:r>
+              <a:rPr lang="en-US" sz="1000" b="1" dirty="0">
+                <a:solidFill>
+                  <a:srgbClr val="333333"/>
+                </a:solidFill>
+                <a:latin typeface="Arial" pitchFamily="34" charset="0"/>
+                <a:ea typeface="Arial" pitchFamily="34" charset="-122"/>
+                <a:cs typeface="Arial" pitchFamily="34" charset="-120"/>
+              </a:rPr>
+              <a:t>TSMC AZ Fab 2</a:t>
+            </a:r>
+            <a:endParaRPr lang="en-US" sz="1000" dirty="0"/>
+          </a:p>
+        </p:txBody>
+      </p:sp>
+      <p:sp>
+        <p:nvSpPr>
+          <p:cNvPr id="45" name="Text 43"/>
+          <p:cNvSpPr/>
+          <p:nvPr/>
+        </p:nvSpPr>
+        <p:spPr>
+          <a:xfrm>
+            <a:off x="4206240" y="4709160"/>
+            <a:ext cx="731520" cy="228600"/>
+          </a:xfrm>
+          <a:prstGeom prst="rect">
+            <a:avLst/>
+          </a:prstGeom>
+          <a:noFill/>
+          <a:ln/>
+        </p:spPr>
+        <p:txBody>
+          <a:bodyPr wrap="square" lIns="0" tIns="0" rIns="0" bIns="0" rtlCol="0" anchor="t"/>
+          <a:lstStyle/>
+          <a:p>
+            <a:pPr algn="ctr" indent="0" marL="0">
+              <a:buNone/>
+            </a:pPr>
+            <a:r>
+              <a:rPr lang="en-US" sz="1000" b="1" dirty="0">
+                <a:solidFill>
+                  <a:srgbClr val="CC0000"/>
+                </a:solidFill>
+                <a:latin typeface="Arial" pitchFamily="34" charset="0"/>
+                <a:ea typeface="Arial" pitchFamily="34" charset="-122"/>
+                <a:cs typeface="Arial" pitchFamily="34" charset="-120"/>
+              </a:rPr>
+              <a:t>2027</a:t>
+            </a:r>
+            <a:endParaRPr lang="en-US" sz="1000" dirty="0"/>
+          </a:p>
+        </p:txBody>
+      </p:sp>
+      <p:sp>
+        <p:nvSpPr>
+          <p:cNvPr id="46" name="Shape 44"/>
+          <p:cNvSpPr/>
+          <p:nvPr/>
+        </p:nvSpPr>
+        <p:spPr>
+          <a:xfrm>
+            <a:off x="6464808" y="4498848"/>
+            <a:ext cx="146304" cy="146304"/>
+          </a:xfrm>
+          <a:prstGeom prst="ellipse">
+            <a:avLst/>
+          </a:prstGeom>
+          <a:solidFill>
+            <a:srgbClr val="CC0000"/>
+          </a:solidFill>
+          <a:ln w="12700">
+            <a:solidFill>
+              <a:srgbClr val="CC0000"/>
+            </a:solidFill>
+            <a:prstDash val="solid"/>
+          </a:ln>
+        </p:spPr>
+      </p:sp>
+      <p:sp>
+        <p:nvSpPr>
+          <p:cNvPr id="47" name="Text 45"/>
+          <p:cNvSpPr/>
+          <p:nvPr/>
+        </p:nvSpPr>
+        <p:spPr>
+          <a:xfrm>
+            <a:off x="5760720" y="4206240"/>
+            <a:ext cx="1554480" cy="274320"/>
+          </a:xfrm>
+          <a:prstGeom prst="rect">
+            <a:avLst/>
+          </a:prstGeom>
+          <a:noFill/>
+          <a:ln/>
+        </p:spPr>
+        <p:txBody>
+          <a:bodyPr wrap="square" lIns="0" tIns="0" rIns="0" bIns="0" rtlCol="0" anchor="b"/>
+          <a:lstStyle/>
+          <a:p>
+            <a:pPr algn="ctr" indent="0" marL="0">
+              <a:buNone/>
+            </a:pPr>
+            <a:r>
+              <a:rPr lang="en-US" sz="1000" b="1" dirty="0">
+                <a:solidFill>
+                  <a:srgbClr val="333333"/>
                 </a:solidFill>
                 <a:latin typeface="Arial" pitchFamily="34" charset="0"/>
                 <a:ea typeface="Arial" pitchFamily="34" charset="-122"/>
@@ -14928,20 +15555,162 @@
               </a:rPr>
               <a:t>Intel Ohio</a:t>
             </a:r>
-            <a:endParaRPr lang="en-US" sz="1050" dirty="0"/>
-          </a:p>
-        </p:txBody>
-      </p:sp>
-      <p:sp>
-        <p:nvSpPr>
-          <p:cNvPr id="27" name="Text 25"/>
-          <p:cNvSpPr/>
-          <p:nvPr/>
-        </p:nvSpPr>
-        <p:spPr>
-          <a:xfrm>
-            <a:off x="6652260" y="5394960"/>
-            <a:ext cx="1828800" cy="411480"/>
+            <a:endParaRPr lang="en-US" sz="1000" dirty="0"/>
+          </a:p>
+        </p:txBody>
+      </p:sp>
+      <p:sp>
+        <p:nvSpPr>
+          <p:cNvPr id="48" name="Text 46"/>
+          <p:cNvSpPr/>
+          <p:nvPr/>
+        </p:nvSpPr>
+        <p:spPr>
+          <a:xfrm>
+            <a:off x="6172200" y="4709160"/>
+            <a:ext cx="731520" cy="228600"/>
+          </a:xfrm>
+          <a:prstGeom prst="rect">
+            <a:avLst/>
+          </a:prstGeom>
+          <a:noFill/>
+          <a:ln/>
+        </p:spPr>
+        <p:txBody>
+          <a:bodyPr wrap="square" lIns="0" tIns="0" rIns="0" bIns="0" rtlCol="0" anchor="t"/>
+          <a:lstStyle/>
+          <a:p>
+            <a:pPr algn="ctr" indent="0" marL="0">
+              <a:buNone/>
+            </a:pPr>
+            <a:r>
+              <a:rPr lang="en-US" sz="1000" b="1" dirty="0">
+                <a:solidFill>
+                  <a:srgbClr val="CC0000"/>
+                </a:solidFill>
+                <a:latin typeface="Arial" pitchFamily="34" charset="0"/>
+                <a:ea typeface="Arial" pitchFamily="34" charset="-122"/>
+                <a:cs typeface="Arial" pitchFamily="34" charset="-120"/>
+              </a:rPr>
+              <a:t>2028</a:t>
+            </a:r>
+            <a:endParaRPr lang="en-US" sz="1000" dirty="0"/>
+          </a:p>
+        </p:txBody>
+      </p:sp>
+      <p:sp>
+        <p:nvSpPr>
+          <p:cNvPr id="49" name="Shape 47"/>
+          <p:cNvSpPr/>
+          <p:nvPr/>
+        </p:nvSpPr>
+        <p:spPr>
+          <a:xfrm>
+            <a:off x="8430768" y="4498848"/>
+            <a:ext cx="146304" cy="146304"/>
+          </a:xfrm>
+          <a:prstGeom prst="ellipse">
+            <a:avLst/>
+          </a:prstGeom>
+          <a:solidFill>
+            <a:srgbClr val="CC0000"/>
+          </a:solidFill>
+          <a:ln w="12700">
+            <a:solidFill>
+              <a:srgbClr val="CC0000"/>
+            </a:solidFill>
+            <a:prstDash val="solid"/>
+          </a:ln>
+        </p:spPr>
+      </p:sp>
+      <p:sp>
+        <p:nvSpPr>
+          <p:cNvPr id="50" name="Text 48"/>
+          <p:cNvSpPr/>
+          <p:nvPr/>
+        </p:nvSpPr>
+        <p:spPr>
+          <a:xfrm>
+            <a:off x="7406640" y="4206240"/>
+            <a:ext cx="1280160" cy="274320"/>
+          </a:xfrm>
+          <a:prstGeom prst="rect">
+            <a:avLst/>
+          </a:prstGeom>
+          <a:noFill/>
+          <a:ln/>
+        </p:spPr>
+        <p:txBody>
+          <a:bodyPr wrap="square" lIns="0" tIns="0" rIns="0" bIns="0" rtlCol="0" anchor="b"/>
+          <a:lstStyle/>
+          <a:p>
+            <a:pPr algn="r" indent="0" marL="0">
+              <a:buNone/>
+            </a:pPr>
+            <a:r>
+              <a:rPr lang="en-US" sz="1000" b="1" dirty="0">
+                <a:solidFill>
+                  <a:srgbClr val="333333"/>
+                </a:solidFill>
+                <a:latin typeface="Arial" pitchFamily="34" charset="0"/>
+                <a:ea typeface="Arial" pitchFamily="34" charset="-122"/>
+                <a:cs typeface="Arial" pitchFamily="34" charset="-120"/>
+              </a:rPr>
+              <a:t>Micron Clay NY</a:t>
+            </a:r>
+            <a:endParaRPr lang="en-US" sz="1000" dirty="0"/>
+          </a:p>
+        </p:txBody>
+      </p:sp>
+      <p:sp>
+        <p:nvSpPr>
+          <p:cNvPr id="51" name="Text 49"/>
+          <p:cNvSpPr/>
+          <p:nvPr/>
+        </p:nvSpPr>
+        <p:spPr>
+          <a:xfrm>
+            <a:off x="7955280" y="4709160"/>
+            <a:ext cx="731520" cy="228600"/>
+          </a:xfrm>
+          <a:prstGeom prst="rect">
+            <a:avLst/>
+          </a:prstGeom>
+          <a:noFill/>
+          <a:ln/>
+        </p:spPr>
+        <p:txBody>
+          <a:bodyPr wrap="square" lIns="0" tIns="0" rIns="0" bIns="0" rtlCol="0" anchor="t"/>
+          <a:lstStyle/>
+          <a:p>
+            <a:pPr algn="r" indent="0" marL="0">
+              <a:buNone/>
+            </a:pPr>
+            <a:r>
+              <a:rPr lang="en-US" sz="1000" b="1" dirty="0">
+                <a:solidFill>
+                  <a:srgbClr val="CC0000"/>
+                </a:solidFill>
+                <a:latin typeface="Arial" pitchFamily="34" charset="0"/>
+                <a:ea typeface="Arial" pitchFamily="34" charset="-122"/>
+                <a:cs typeface="Arial" pitchFamily="34" charset="-120"/>
+              </a:rPr>
+              <a:t>2030+</a:t>
+            </a:r>
+            <a:endParaRPr lang="en-US" sz="1000" dirty="0"/>
+          </a:p>
+        </p:txBody>
+      </p:sp>
+      <p:sp>
+        <p:nvSpPr>
+          <p:cNvPr id="52" name="Text 50"/>
+          <p:cNvSpPr/>
+          <p:nvPr/>
+        </p:nvSpPr>
+        <p:spPr>
+          <a:xfrm>
+            <a:off x="457200" y="5349240"/>
+            <a:ext cx="8229600" cy="274320"/>
           </a:xfrm>
           <a:prstGeom prst="rect">
             <a:avLst/>
@@ -14953,27 +15722,27 @@
           <a:bodyPr wrap="square" lIns="0" tIns="0" rIns="0" bIns="0" rtlCol="0" anchor="ctr"/>
           <a:lstStyle/>
           <a:p>
-            <a:pPr indent="0" marL="0">
-              <a:buNone/>
-            </a:pPr>
-            <a:r>
-              <a:rPr lang="en-US" sz="900" dirty="0">
-                <a:solidFill>
-                  <a:srgbClr val="333333"/>
-                </a:solidFill>
-                <a:latin typeface="Arial" pitchFamily="34" charset="0"/>
-                <a:ea typeface="Arial" pitchFamily="34" charset="-122"/>
-                <a:cs typeface="Arial" pitchFamily="34" charset="-120"/>
-              </a:rPr>
-              <a:t>Two fabs; online ~2027–28</a:t>
-            </a:r>
-            <a:endParaRPr lang="en-US" sz="900" dirty="0"/>
-          </a:p>
-        </p:txBody>
-      </p:sp>
-      <p:sp>
-        <p:nvSpPr>
-          <p:cNvPr id="28" name="Text 26"/>
+            <a:pPr algn="ctr" indent="0" marL="0">
+              <a:buNone/>
+            </a:pPr>
+            <a:r>
+              <a:rPr lang="en-US" sz="950" i="1" dirty="0">
+                <a:solidFill>
+                  <a:srgbClr val="666666"/>
+                </a:solidFill>
+                <a:latin typeface="Arial" pitchFamily="34" charset="0"/>
+                <a:ea typeface="Arial" pitchFamily="34" charset="-122"/>
+                <a:cs typeface="Arial" pitchFamily="34" charset="-120"/>
+              </a:rPr>
+              <a:t>Each link is single-sourced — and there is no spare capacity in the chain to absorb a shock at any one of them.</a:t>
+            </a:r>
+            <a:endParaRPr lang="en-US" sz="950" dirty="0"/>
+          </a:p>
+        </p:txBody>
+      </p:sp>
+      <p:sp>
+        <p:nvSpPr>
+          <p:cNvPr id="53" name="Text 51"/>
           <p:cNvSpPr/>
           <p:nvPr/>
         </p:nvSpPr>
@@ -15018,6 +15787,34 @@
                 <a:ea typeface="Arial" pitchFamily="34" charset="-122"/>
                 <a:cs typeface="Arial" pitchFamily="34" charset="-120"/>
               </a:rPr>
+              <a:t>ASML 2025 annual report, </a:t>
+            </a:r>
+            <a:pPr indent="0" marL="0">
+              <a:buNone/>
+            </a:pPr>
+            <a:r>
+              <a:rPr lang="en-US" sz="700" b="1" dirty="0">
+                <a:solidFill>
+                  <a:srgbClr val="999999"/>
+                </a:solidFill>
+                <a:latin typeface="Arial" pitchFamily="34" charset="0"/>
+                <a:ea typeface="Arial" pitchFamily="34" charset="-122"/>
+                <a:cs typeface="Arial" pitchFamily="34" charset="-120"/>
+              </a:rPr>
+              <a:t>(2) </a:t>
+            </a:r>
+            <a:pPr indent="0" marL="0">
+              <a:buNone/>
+            </a:pPr>
+            <a:r>
+              <a:rPr lang="en-US" sz="700" dirty="0">
+                <a:solidFill>
+                  <a:srgbClr val="999999"/>
+                </a:solidFill>
+                <a:latin typeface="Arial" pitchFamily="34" charset="0"/>
+                <a:ea typeface="Arial" pitchFamily="34" charset="-122"/>
+                <a:cs typeface="Arial" pitchFamily="34" charset="-120"/>
+              </a:rPr>
               <a:t>TrendForce / Counterpoint, 2025, </a:t>
             </a:r>
             <a:pPr indent="0" marL="0">
@@ -15032,7 +15829,7 @@
                 <a:ea typeface="Arial" pitchFamily="34" charset="-122"/>
                 <a:cs typeface="Arial" pitchFamily="34" charset="-120"/>
               </a:rPr>
-              <a:t>(2) </a:t>
+              <a:t>(3) </a:t>
             </a:r>
             <a:pPr indent="0" marL="0">
               <a:buNone/>
@@ -15046,7 +15843,7 @@
                 <a:ea typeface="Arial" pitchFamily="34" charset="-122"/>
                 <a:cs typeface="Arial" pitchFamily="34" charset="-120"/>
               </a:rPr>
-              <a:t>TrendForce, 2025, </a:t>
+              <a:t>TrendForce HBM tracker; SK Hynix Q1 2026 commentary, </a:t>
             </a:r>
             <a:pPr indent="0" marL="0">
               <a:buNone/>
@@ -15060,7 +15857,7 @@
                 <a:ea typeface="Arial" pitchFamily="34" charset="-122"/>
                 <a:cs typeface="Arial" pitchFamily="34" charset="-120"/>
               </a:rPr>
-              <a:t>(3) </a:t>
+              <a:t>(4) </a:t>
             </a:r>
             <a:pPr indent="0" marL="0">
               <a:buNone/>
@@ -15074,35 +15871,7 @@
                 <a:ea typeface="Arial" pitchFamily="34" charset="-122"/>
                 <a:cs typeface="Arial" pitchFamily="34" charset="-120"/>
               </a:rPr>
-              <a:t>SIA semiconductor supply-chain report, </a:t>
-            </a:r>
-            <a:pPr indent="0" marL="0">
-              <a:buNone/>
-            </a:pPr>
-            <a:r>
-              <a:rPr lang="en-US" sz="700" b="1" dirty="0">
-                <a:solidFill>
-                  <a:srgbClr val="999999"/>
-                </a:solidFill>
-                <a:latin typeface="Arial" pitchFamily="34" charset="0"/>
-                <a:ea typeface="Arial" pitchFamily="34" charset="-122"/>
-                <a:cs typeface="Arial" pitchFamily="34" charset="-120"/>
-              </a:rPr>
-              <a:t>(4) </a:t>
-            </a:r>
-            <a:pPr indent="0" marL="0">
-              <a:buNone/>
-            </a:pPr>
-            <a:r>
-              <a:rPr lang="en-US" sz="700" dirty="0">
-                <a:solidFill>
-                  <a:srgbClr val="999999"/>
-                </a:solidFill>
-                <a:latin typeface="Arial" pitchFamily="34" charset="0"/>
-                <a:ea typeface="Arial" pitchFamily="34" charset="-122"/>
-                <a:cs typeface="Arial" pitchFamily="34" charset="-120"/>
-              </a:rPr>
-              <a:t>ASML 2025 annual report.</a:t>
+              <a:t>TSMC Q4 2025 earnings commentary.</a:t>
             </a:r>
             <a:endParaRPr lang="en-US" sz="700" dirty="0"/>
           </a:p>
@@ -15110,7 +15879,7 @@
       </p:sp>
       <p:sp>
         <p:nvSpPr>
-          <p:cNvPr id="29" name="Shape 27"/>
+          <p:cNvPr id="54" name="Shape 52"/>
           <p:cNvSpPr/>
           <p:nvPr/>
         </p:nvSpPr>
@@ -15135,7 +15904,7 @@
       </p:sp>
       <p:sp>
         <p:nvSpPr>
-          <p:cNvPr id="30" name="Text 28"/>
+          <p:cNvPr id="55" name="Text 53"/>
           <p:cNvSpPr/>
           <p:nvPr/>
         </p:nvSpPr>
@@ -15174,7 +15943,7 @@
       </p:sp>
       <p:sp>
         <p:nvSpPr>
-          <p:cNvPr id="31" name="Text 29"/>
+          <p:cNvPr id="56" name="Text 54"/>
           <p:cNvSpPr/>
           <p:nvPr/>
         </p:nvSpPr>

</xml_diff>

<commit_message>
Editorial pass: full-sentence titles, date stamps, TOC appendix row
Rewrite 14 topic-label titles as full-sentence takeaways (slides 4, 5, 7, 8,
10, 11, 12, 13, 16, 17, 18, 19, 20, 22). Date-stamp quantitative claims inline
on slides 9, 10, 11, 17, 22. Add 7th TOC row "07 APPENDIX 23 - 24" with medGray
sidebar; compress row spacing 0.72 -> 0.62; renumber appendix footers A1/A2 to
23/24. Slide 11 subhead: "lower multiple" -> "similar multiple". Slide 13
subhead rewritten to lead with the 50+ point spread and PE/PC bleed. See
PLAN3_REPORT.md.

Co-Authored-By: Claude Opus 4.7 <noreply@anthropic.com>
</commit_message>
<xml_diff>
--- a/ai-markets-deck.pptx
+++ b/ai-markets-deck.pptx
@@ -4945,7 +4945,7 @@
                 <a:ea typeface="Arial Black" pitchFamily="34" charset="-122"/>
                 <a:cs typeface="Arial Black" pitchFamily="34" charset="-120"/>
               </a:rPr>
-              <a:t>The labs.</a:t>
+              <a:t>Q1 funding doubled all of 2025 — two giants, one public, one merger</a:t>
             </a:r>
             <a:endParaRPr lang="en-US" sz="2400" dirty="0"/>
           </a:p>
@@ -5887,7 +5887,46 @@
       </p:sp>
       <p:sp>
         <p:nvSpPr>
-          <p:cNvPr id="31" name="Shape 25"/>
+          <p:cNvPr id="31" name="Text 25"/>
+          <p:cNvSpPr/>
+          <p:nvPr/>
+        </p:nvSpPr>
+        <p:spPr>
+          <a:xfrm>
+            <a:off x="457200" y="4919472"/>
+            <a:ext cx="8229600" cy="182880"/>
+          </a:xfrm>
+          <a:prstGeom prst="rect">
+            <a:avLst/>
+          </a:prstGeom>
+          <a:noFill/>
+          <a:ln/>
+        </p:spPr>
+        <p:txBody>
+          <a:bodyPr wrap="square" lIns="0" tIns="0" rIns="0" bIns="0" rtlCol="0" anchor="t"/>
+          <a:lstStyle/>
+          <a:p>
+            <a:pPr algn="r" indent="0" marL="0">
+              <a:buNone/>
+            </a:pPr>
+            <a:r>
+              <a:rPr lang="en-US" sz="800" i="1" dirty="0">
+                <a:solidFill>
+                  <a:srgbClr val="666666"/>
+                </a:solidFill>
+                <a:latin typeface="Arial" pitchFamily="34" charset="0"/>
+                <a:ea typeface="Arial" pitchFamily="34" charset="-122"/>
+                <a:cs typeface="Arial" pitchFamily="34" charset="-120"/>
+              </a:rPr>
+              <a:t>All valuations as of Apr 22, 2026.</a:t>
+            </a:r>
+            <a:endParaRPr lang="en-US" sz="800" dirty="0"/>
+          </a:p>
+        </p:txBody>
+      </p:sp>
+      <p:sp>
+        <p:nvSpPr>
+          <p:cNvPr id="32" name="Shape 26"/>
           <p:cNvSpPr/>
           <p:nvPr/>
         </p:nvSpPr>
@@ -5912,7 +5951,7 @@
       </p:sp>
       <p:sp>
         <p:nvSpPr>
-          <p:cNvPr id="32" name="Text 26"/>
+          <p:cNvPr id="33" name="Text 27"/>
           <p:cNvSpPr/>
           <p:nvPr/>
         </p:nvSpPr>
@@ -5965,7 +6004,7 @@
       </p:sp>
       <p:sp>
         <p:nvSpPr>
-          <p:cNvPr id="33" name="Text 27"/>
+          <p:cNvPr id="34" name="Text 28"/>
           <p:cNvSpPr/>
           <p:nvPr/>
         </p:nvSpPr>
@@ -6130,7 +6169,7 @@
       </p:sp>
       <p:sp>
         <p:nvSpPr>
-          <p:cNvPr id="34" name="Shape 28"/>
+          <p:cNvPr id="35" name="Shape 29"/>
           <p:cNvSpPr/>
           <p:nvPr/>
         </p:nvSpPr>
@@ -6155,7 +6194,7 @@
       </p:sp>
       <p:sp>
         <p:nvSpPr>
-          <p:cNvPr id="35" name="Text 29"/>
+          <p:cNvPr id="36" name="Text 30"/>
           <p:cNvSpPr/>
           <p:nvPr/>
         </p:nvSpPr>
@@ -6194,7 +6233,7 @@
       </p:sp>
       <p:sp>
         <p:nvSpPr>
-          <p:cNvPr id="36" name="Text 30"/>
+          <p:cNvPr id="37" name="Text 31"/>
           <p:cNvSpPr/>
           <p:nvPr/>
         </p:nvSpPr>
@@ -6355,7 +6394,7 @@
                 <a:ea typeface="Arial Black" pitchFamily="34" charset="-122"/>
                 <a:cs typeface="Arial Black" pitchFamily="34" charset="-120"/>
               </a:rPr>
-              <a:t>Earnings &amp; valuations.</a:t>
+              <a:t>Top 10 Tech grow 4× faster than Top 10 Non-Tech — at a similar multiple</a:t>
             </a:r>
             <a:endParaRPr lang="en-US" sz="2400" dirty="0"/>
           </a:p>
@@ -6394,7 +6433,7 @@
                 <a:ea typeface="Arial" pitchFamily="34" charset="-122"/>
                 <a:cs typeface="Arial" pitchFamily="34" charset="-120"/>
               </a:rPr>
-              <a:t>Top 10 Tech firms are growing 4× faster than the top 10 Non-Tech — at a lower multiple. The divergence in fundamentals has not been priced into valuations.</a:t>
+              <a:t>Top 10 Tech firms are growing 4× faster than the top 10 Non-Tech — at a similar multiple. The divergence in fundamentals has not been priced into valuations.</a:t>
             </a:r>
             <a:endParaRPr lang="en-US" sz="1350" dirty="0"/>
           </a:p>
@@ -9100,7 +9139,7 @@
                 <a:ea typeface="Arial" pitchFamily="34" charset="-122"/>
                 <a:cs typeface="Arial" pitchFamily="34" charset="-120"/>
               </a:rPr>
-              <a:t>Tech median: ~26× fwd P/E on ~17% forward revenue growth. Non-Tech: ~23× on ~5%. The divergence is in the engine, not the multiple.</a:t>
+              <a:t>Tech median: ~26× fwd P/E on ~17% forward revenue growth. Non-Tech: ~23× on ~5% (consensus, Apr 22, 2026). The divergence is in the engine, not the multiple.</a:t>
             </a:r>
             <a:endParaRPr lang="en-US" sz="1100" dirty="0"/>
           </a:p>
@@ -9372,7 +9411,7 @@
                 <a:ea typeface="Arial Black" pitchFamily="34" charset="-122"/>
                 <a:cs typeface="Arial Black" pitchFamily="34" charset="-120"/>
               </a:rPr>
-              <a:t>What is agentic AI?</a:t>
+              <a:t>Agentic AI uses 10–100× the compute per session — that's the capex thesis</a:t>
             </a:r>
             <a:endParaRPr lang="en-US" sz="2400" dirty="0"/>
           </a:p>
@@ -10877,7 +10916,7 @@
                 <a:ea typeface="Arial Black" pitchFamily="34" charset="-122"/>
                 <a:cs typeface="Arial Black" pitchFamily="34" charset="-120"/>
               </a:rPr>
-              <a:t>The divergence.</a:t>
+              <a:t>Semis up, software down — one theme, two outcomes</a:t>
             </a:r>
             <a:endParaRPr lang="en-US" sz="2400" dirty="0"/>
           </a:p>
@@ -10916,7 +10955,7 @@
                 <a:ea typeface="Arial" pitchFamily="34" charset="-122"/>
                 <a:cs typeface="Arial" pitchFamily="34" charset="-120"/>
               </a:rPr>
-              <a:t>Semis are up, software is down — a wide spread inside one theme. The sell-off is starting to bleed into private credit and PE-held SaaS.</a:t>
+              <a:t>A 50+ point spread inside a single theme — and the pain is now bleeding into private credit and PE-held SaaS.</a:t>
             </a:r>
             <a:endParaRPr lang="en-US" sz="1350" dirty="0"/>
           </a:p>
@@ -16104,7 +16143,7 @@
                 <a:ea typeface="Arial Black" pitchFamily="34" charset="-122"/>
                 <a:cs typeface="Arial Black" pitchFamily="34" charset="-120"/>
               </a:rPr>
-              <a:t>Policy &amp; regulation.</a:t>
+              <a:t>Export controls, EU rules, and rare-earths decide who sells what</a:t>
             </a:r>
             <a:endParaRPr lang="en-US" sz="2400" dirty="0"/>
           </a:p>
@@ -17735,7 +17774,7 @@
                 <a:ea typeface="Arial Black" pitchFamily="34" charset="-122"/>
                 <a:cs typeface="Arial Black" pitchFamily="34" charset="-120"/>
               </a:rPr>
-              <a:t>AI backlash.</a:t>
+              <a:t>Communities, voters, and labor are pricing the AI infrastructure bet lower</a:t>
             </a:r>
             <a:endParaRPr lang="en-US" sz="2400" dirty="0"/>
           </a:p>
@@ -18198,7 +18237,7 @@
                 <a:ea typeface="Arial" pitchFamily="34" charset="-122"/>
                 <a:cs typeface="Arial" pitchFamily="34" charset="-120"/>
               </a:rPr>
-              <a:t> of Americans view AI positively. March 2026 "Stop the AI Race" protests</a:t>
+              <a:t> (Echelon Insights, Mar 2026) of Americans view AI positively. March 2026 "Stop the AI Race" protests</a:t>
             </a:r>
             <a:pPr indent="0" marL="0">
               <a:buNone/>
@@ -18816,7 +18855,7 @@
                 <a:ea typeface="Arial Black" pitchFamily="34" charset="-122"/>
                 <a:cs typeface="Arial Black" pitchFamily="34" charset="-120"/>
               </a:rPr>
-              <a:t>Beyond the grid.</a:t>
+              <a:t>Orbital compute sidesteps Earth-bound bottlenecks — pilot stage today</a:t>
             </a:r>
             <a:endParaRPr lang="en-US" sz="2400" dirty="0"/>
           </a:p>
@@ -19760,7 +19799,7 @@
                 <a:ea typeface="Arial Black" pitchFamily="34" charset="-122"/>
                 <a:cs typeface="Arial Black" pitchFamily="34" charset="-120"/>
               </a:rPr>
-              <a:t>Physical AI.</a:t>
+              <a:t>Humanoids hit pilot scale — every robot is a walking inference endpoint</a:t>
             </a:r>
             <a:endParaRPr lang="en-US" sz="2400" dirty="0"/>
           </a:p>
@@ -20704,7 +20743,7 @@
         <p:spPr>
           <a:xfrm>
             <a:off x="457200" y="1737360"/>
-            <a:ext cx="109728" cy="585216"/>
+            <a:ext cx="109728" cy="493776"/>
           </a:xfrm>
           <a:prstGeom prst="rect">
             <a:avLst/>
@@ -20729,7 +20768,7 @@
         <p:spPr>
           <a:xfrm>
             <a:off x="731520" y="1737360"/>
-            <a:ext cx="822960" cy="585216"/>
+            <a:ext cx="822960" cy="493776"/>
           </a:xfrm>
           <a:prstGeom prst="rect">
             <a:avLst/>
@@ -20768,7 +20807,7 @@
         <p:spPr>
           <a:xfrm>
             <a:off x="1645920" y="1737360"/>
-            <a:ext cx="5943600" cy="585216"/>
+            <a:ext cx="5943600" cy="493776"/>
           </a:xfrm>
           <a:prstGeom prst="rect">
             <a:avLst/>
@@ -20807,7 +20846,7 @@
         <p:spPr>
           <a:xfrm>
             <a:off x="7315200" y="1737360"/>
-            <a:ext cx="1371600" cy="585216"/>
+            <a:ext cx="1371600" cy="493776"/>
           </a:xfrm>
           <a:prstGeom prst="rect">
             <a:avLst/>
@@ -20845,7 +20884,7 @@
         </p:nvSpPr>
         <p:spPr>
           <a:xfrm>
-            <a:off x="731520" y="2359152"/>
+            <a:off x="731520" y="2267712"/>
             <a:ext cx="7955280" cy="0"/>
           </a:xfrm>
           <a:prstGeom prst="line">
@@ -20868,8 +20907,8 @@
         </p:nvSpPr>
         <p:spPr>
           <a:xfrm>
-            <a:off x="457200" y="2395728"/>
-            <a:ext cx="109728" cy="585216"/>
+            <a:off x="457200" y="2304288"/>
+            <a:ext cx="109728" cy="493776"/>
           </a:xfrm>
           <a:prstGeom prst="rect">
             <a:avLst/>
@@ -20893,8 +20932,8 @@
         </p:nvSpPr>
         <p:spPr>
           <a:xfrm>
-            <a:off x="731520" y="2395728"/>
-            <a:ext cx="822960" cy="585216"/>
+            <a:off x="731520" y="2304288"/>
+            <a:ext cx="822960" cy="493776"/>
           </a:xfrm>
           <a:prstGeom prst="rect">
             <a:avLst/>
@@ -20932,8 +20971,8 @@
         </p:nvSpPr>
         <p:spPr>
           <a:xfrm>
-            <a:off x="1645920" y="2395728"/>
-            <a:ext cx="5943600" cy="585216"/>
+            <a:off x="1645920" y="2304288"/>
+            <a:ext cx="5943600" cy="493776"/>
           </a:xfrm>
           <a:prstGeom prst="rect">
             <a:avLst/>
@@ -20971,8 +21010,8 @@
         </p:nvSpPr>
         <p:spPr>
           <a:xfrm>
-            <a:off x="7315200" y="2395728"/>
-            <a:ext cx="1371600" cy="585216"/>
+            <a:off x="7315200" y="2304288"/>
+            <a:ext cx="1371600" cy="493776"/>
           </a:xfrm>
           <a:prstGeom prst="rect">
             <a:avLst/>
@@ -21010,7 +21049,7 @@
         </p:nvSpPr>
         <p:spPr>
           <a:xfrm>
-            <a:off x="731520" y="3017520"/>
+            <a:off x="731520" y="2834640"/>
             <a:ext cx="7955280" cy="0"/>
           </a:xfrm>
           <a:prstGeom prst="line">
@@ -21033,8 +21072,8 @@
         </p:nvSpPr>
         <p:spPr>
           <a:xfrm>
-            <a:off x="457200" y="3054096"/>
-            <a:ext cx="109728" cy="585216"/>
+            <a:off x="457200" y="2871216"/>
+            <a:ext cx="109728" cy="493776"/>
           </a:xfrm>
           <a:prstGeom prst="rect">
             <a:avLst/>
@@ -21058,8 +21097,8 @@
         </p:nvSpPr>
         <p:spPr>
           <a:xfrm>
-            <a:off x="731520" y="3054096"/>
-            <a:ext cx="822960" cy="585216"/>
+            <a:off x="731520" y="2871216"/>
+            <a:ext cx="822960" cy="493776"/>
           </a:xfrm>
           <a:prstGeom prst="rect">
             <a:avLst/>
@@ -21097,8 +21136,8 @@
         </p:nvSpPr>
         <p:spPr>
           <a:xfrm>
-            <a:off x="1645920" y="3054096"/>
-            <a:ext cx="5943600" cy="585216"/>
+            <a:off x="1645920" y="2871216"/>
+            <a:ext cx="5943600" cy="493776"/>
           </a:xfrm>
           <a:prstGeom prst="rect">
             <a:avLst/>
@@ -21136,8 +21175,8 @@
         </p:nvSpPr>
         <p:spPr>
           <a:xfrm>
-            <a:off x="7315200" y="3054096"/>
-            <a:ext cx="1371600" cy="585216"/>
+            <a:off x="7315200" y="2871216"/>
+            <a:ext cx="1371600" cy="493776"/>
           </a:xfrm>
           <a:prstGeom prst="rect">
             <a:avLst/>
@@ -21175,7 +21214,7 @@
         </p:nvSpPr>
         <p:spPr>
           <a:xfrm>
-            <a:off x="731520" y="3675888"/>
+            <a:off x="731520" y="3401568"/>
             <a:ext cx="7955280" cy="0"/>
           </a:xfrm>
           <a:prstGeom prst="line">
@@ -21198,8 +21237,8 @@
         </p:nvSpPr>
         <p:spPr>
           <a:xfrm>
-            <a:off x="457200" y="3712464"/>
-            <a:ext cx="109728" cy="585216"/>
+            <a:off x="457200" y="3438144"/>
+            <a:ext cx="109728" cy="493776"/>
           </a:xfrm>
           <a:prstGeom prst="rect">
             <a:avLst/>
@@ -21223,8 +21262,8 @@
         </p:nvSpPr>
         <p:spPr>
           <a:xfrm>
-            <a:off x="731520" y="3712464"/>
-            <a:ext cx="822960" cy="585216"/>
+            <a:off x="731520" y="3438144"/>
+            <a:ext cx="822960" cy="493776"/>
           </a:xfrm>
           <a:prstGeom prst="rect">
             <a:avLst/>
@@ -21262,8 +21301,8 @@
         </p:nvSpPr>
         <p:spPr>
           <a:xfrm>
-            <a:off x="1645920" y="3712464"/>
-            <a:ext cx="5943600" cy="585216"/>
+            <a:off x="1645920" y="3438144"/>
+            <a:ext cx="5943600" cy="493776"/>
           </a:xfrm>
           <a:prstGeom prst="rect">
             <a:avLst/>
@@ -21301,8 +21340,8 @@
         </p:nvSpPr>
         <p:spPr>
           <a:xfrm>
-            <a:off x="7315200" y="3712464"/>
-            <a:ext cx="1371600" cy="585216"/>
+            <a:off x="7315200" y="3438144"/>
+            <a:ext cx="1371600" cy="493776"/>
           </a:xfrm>
           <a:prstGeom prst="rect">
             <a:avLst/>
@@ -21340,7 +21379,7 @@
         </p:nvSpPr>
         <p:spPr>
           <a:xfrm>
-            <a:off x="731520" y="4334256"/>
+            <a:off x="731520" y="3968496"/>
             <a:ext cx="7955280" cy="0"/>
           </a:xfrm>
           <a:prstGeom prst="line">
@@ -21363,8 +21402,8 @@
         </p:nvSpPr>
         <p:spPr>
           <a:xfrm>
-            <a:off x="457200" y="4370832"/>
-            <a:ext cx="109728" cy="585216"/>
+            <a:off x="457200" y="4005072"/>
+            <a:ext cx="109728" cy="493776"/>
           </a:xfrm>
           <a:prstGeom prst="rect">
             <a:avLst/>
@@ -21388,8 +21427,8 @@
         </p:nvSpPr>
         <p:spPr>
           <a:xfrm>
-            <a:off x="731520" y="4370832"/>
-            <a:ext cx="822960" cy="585216"/>
+            <a:off x="731520" y="4005072"/>
+            <a:ext cx="822960" cy="493776"/>
           </a:xfrm>
           <a:prstGeom prst="rect">
             <a:avLst/>
@@ -21427,8 +21466,8 @@
         </p:nvSpPr>
         <p:spPr>
           <a:xfrm>
-            <a:off x="1645920" y="4370832"/>
-            <a:ext cx="5943600" cy="585216"/>
+            <a:off x="1645920" y="4005072"/>
+            <a:ext cx="5943600" cy="493776"/>
           </a:xfrm>
           <a:prstGeom prst="rect">
             <a:avLst/>
@@ -21466,8 +21505,8 @@
         </p:nvSpPr>
         <p:spPr>
           <a:xfrm>
-            <a:off x="7315200" y="4370832"/>
-            <a:ext cx="1371600" cy="585216"/>
+            <a:off x="7315200" y="4005072"/>
+            <a:ext cx="1371600" cy="493776"/>
           </a:xfrm>
           <a:prstGeom prst="rect">
             <a:avLst/>
@@ -21505,7 +21544,7 @@
         </p:nvSpPr>
         <p:spPr>
           <a:xfrm>
-            <a:off x="731520" y="4992624"/>
+            <a:off x="731520" y="4535424"/>
             <a:ext cx="7955280" cy="0"/>
           </a:xfrm>
           <a:prstGeom prst="line">
@@ -21528,8 +21567,8 @@
         </p:nvSpPr>
         <p:spPr>
           <a:xfrm>
-            <a:off x="457200" y="5029200"/>
-            <a:ext cx="109728" cy="585216"/>
+            <a:off x="457200" y="4572000"/>
+            <a:ext cx="109728" cy="493776"/>
           </a:xfrm>
           <a:prstGeom prst="rect">
             <a:avLst/>
@@ -21553,8 +21592,8 @@
         </p:nvSpPr>
         <p:spPr>
           <a:xfrm>
-            <a:off x="731520" y="5029200"/>
-            <a:ext cx="822960" cy="585216"/>
+            <a:off x="731520" y="4572000"/>
+            <a:ext cx="822960" cy="493776"/>
           </a:xfrm>
           <a:prstGeom prst="rect">
             <a:avLst/>
@@ -21592,8 +21631,8 @@
         </p:nvSpPr>
         <p:spPr>
           <a:xfrm>
-            <a:off x="1645920" y="5029200"/>
-            <a:ext cx="5943600" cy="585216"/>
+            <a:off x="1645920" y="4572000"/>
+            <a:ext cx="5943600" cy="493776"/>
           </a:xfrm>
           <a:prstGeom prst="rect">
             <a:avLst/>
@@ -21631,8 +21670,8 @@
         </p:nvSpPr>
         <p:spPr>
           <a:xfrm>
-            <a:off x="7315200" y="5029200"/>
-            <a:ext cx="1371600" cy="585216"/>
+            <a:off x="7315200" y="4572000"/>
+            <a:ext cx="1371600" cy="493776"/>
           </a:xfrm>
           <a:prstGeom prst="rect">
             <a:avLst/>
@@ -21664,7 +21703,172 @@
       </p:sp>
       <p:sp>
         <p:nvSpPr>
-          <p:cNvPr id="33" name="Text 31"/>
+          <p:cNvPr id="33" name="Shape 31"/>
+          <p:cNvSpPr/>
+          <p:nvPr/>
+        </p:nvSpPr>
+        <p:spPr>
+          <a:xfrm>
+            <a:off x="731520" y="5102352"/>
+            <a:ext cx="7955280" cy="0"/>
+          </a:xfrm>
+          <a:prstGeom prst="line">
+            <a:avLst/>
+          </a:prstGeom>
+          <a:noFill/>
+          <a:ln w="6350">
+            <a:solidFill>
+              <a:srgbClr val="E5E5E5"/>
+            </a:solidFill>
+            <a:prstDash val="solid"/>
+          </a:ln>
+        </p:spPr>
+      </p:sp>
+      <p:sp>
+        <p:nvSpPr>
+          <p:cNvPr id="34" name="Shape 32"/>
+          <p:cNvSpPr/>
+          <p:nvPr/>
+        </p:nvSpPr>
+        <p:spPr>
+          <a:xfrm>
+            <a:off x="457200" y="5138928"/>
+            <a:ext cx="109728" cy="493776"/>
+          </a:xfrm>
+          <a:prstGeom prst="rect">
+            <a:avLst/>
+          </a:prstGeom>
+          <a:solidFill>
+            <a:srgbClr val="666666"/>
+          </a:solidFill>
+          <a:ln w="12700">
+            <a:solidFill>
+              <a:srgbClr val="666666"/>
+            </a:solidFill>
+            <a:prstDash val="solid"/>
+          </a:ln>
+        </p:spPr>
+      </p:sp>
+      <p:sp>
+        <p:nvSpPr>
+          <p:cNvPr id="35" name="Text 33"/>
+          <p:cNvSpPr/>
+          <p:nvPr/>
+        </p:nvSpPr>
+        <p:spPr>
+          <a:xfrm>
+            <a:off x="731520" y="5138928"/>
+            <a:ext cx="822960" cy="493776"/>
+          </a:xfrm>
+          <a:prstGeom prst="rect">
+            <a:avLst/>
+          </a:prstGeom>
+          <a:noFill/>
+          <a:ln/>
+        </p:spPr>
+        <p:txBody>
+          <a:bodyPr wrap="square" lIns="0" tIns="0" rIns="0" bIns="0" rtlCol="0" anchor="ctr"/>
+          <a:lstStyle/>
+          <a:p>
+            <a:pPr indent="0" marL="0">
+              <a:buNone/>
+            </a:pPr>
+            <a:r>
+              <a:rPr lang="en-US" sz="2200" b="1" dirty="0">
+                <a:solidFill>
+                  <a:srgbClr val="666666"/>
+                </a:solidFill>
+                <a:latin typeface="Arial Black" pitchFamily="34" charset="0"/>
+                <a:ea typeface="Arial Black" pitchFamily="34" charset="-122"/>
+                <a:cs typeface="Arial Black" pitchFamily="34" charset="-120"/>
+              </a:rPr>
+              <a:t>07</a:t>
+            </a:r>
+            <a:endParaRPr lang="en-US" sz="2200" dirty="0"/>
+          </a:p>
+        </p:txBody>
+      </p:sp>
+      <p:sp>
+        <p:nvSpPr>
+          <p:cNvPr id="36" name="Text 34"/>
+          <p:cNvSpPr/>
+          <p:nvPr/>
+        </p:nvSpPr>
+        <p:spPr>
+          <a:xfrm>
+            <a:off x="1645920" y="5138928"/>
+            <a:ext cx="5943600" cy="493776"/>
+          </a:xfrm>
+          <a:prstGeom prst="rect">
+            <a:avLst/>
+          </a:prstGeom>
+          <a:noFill/>
+          <a:ln/>
+        </p:spPr>
+        <p:txBody>
+          <a:bodyPr wrap="square" lIns="0" tIns="0" rIns="0" bIns="0" rtlCol="0" anchor="ctr"/>
+          <a:lstStyle/>
+          <a:p>
+            <a:pPr indent="0" marL="0">
+              <a:buNone/>
+            </a:pPr>
+            <a:r>
+              <a:rPr lang="en-US" sz="2200" b="1" spc="300" kern="0" dirty="0">
+                <a:solidFill>
+                  <a:srgbClr val="000000"/>
+                </a:solidFill>
+                <a:latin typeface="Arial Black" pitchFamily="34" charset="0"/>
+                <a:ea typeface="Arial Black" pitchFamily="34" charset="-122"/>
+                <a:cs typeface="Arial Black" pitchFamily="34" charset="-120"/>
+              </a:rPr>
+              <a:t>APPENDIX</a:t>
+            </a:r>
+            <a:endParaRPr lang="en-US" sz="2200" dirty="0"/>
+          </a:p>
+        </p:txBody>
+      </p:sp>
+      <p:sp>
+        <p:nvSpPr>
+          <p:cNvPr id="37" name="Text 35"/>
+          <p:cNvSpPr/>
+          <p:nvPr/>
+        </p:nvSpPr>
+        <p:spPr>
+          <a:xfrm>
+            <a:off x="7315200" y="5138928"/>
+            <a:ext cx="1371600" cy="493776"/>
+          </a:xfrm>
+          <a:prstGeom prst="rect">
+            <a:avLst/>
+          </a:prstGeom>
+          <a:noFill/>
+          <a:ln/>
+        </p:spPr>
+        <p:txBody>
+          <a:bodyPr wrap="square" lIns="0" tIns="0" rIns="0" bIns="0" rtlCol="0" anchor="ctr"/>
+          <a:lstStyle/>
+          <a:p>
+            <a:pPr algn="r" indent="0" marL="0">
+              <a:buNone/>
+            </a:pPr>
+            <a:r>
+              <a:rPr lang="en-US" sz="1400" dirty="0">
+                <a:solidFill>
+                  <a:srgbClr val="666666"/>
+                </a:solidFill>
+                <a:latin typeface="Arial" pitchFamily="34" charset="0"/>
+                <a:ea typeface="Arial" pitchFamily="34" charset="-122"/>
+                <a:cs typeface="Arial" pitchFamily="34" charset="-120"/>
+              </a:rPr>
+              <a:t>23 – 24</a:t>
+            </a:r>
+            <a:endParaRPr lang="en-US" sz="1400" dirty="0"/>
+          </a:p>
+        </p:txBody>
+      </p:sp>
+      <p:sp>
+        <p:nvSpPr>
+          <p:cNvPr id="38" name="Text 36"/>
           <p:cNvSpPr/>
           <p:nvPr/>
         </p:nvSpPr>
@@ -21695,7 +21899,7 @@
                 <a:ea typeface="Arial" pitchFamily="34" charset="-122"/>
                 <a:cs typeface="Arial" pitchFamily="34" charset="-120"/>
               </a:rPr>
-              <a:t>Source: Strategy Research. 22 slides, read top to bottom.</a:t>
+              <a:t>Source: Strategy Research. 24 slides, read top to bottom.</a:t>
             </a:r>
             <a:endParaRPr lang="en-US" sz="700" dirty="0"/>
           </a:p>
@@ -21703,7 +21907,7 @@
       </p:sp>
       <p:sp>
         <p:nvSpPr>
-          <p:cNvPr id="34" name="Shape 32"/>
+          <p:cNvPr id="39" name="Shape 37"/>
           <p:cNvSpPr/>
           <p:nvPr/>
         </p:nvSpPr>
@@ -21728,7 +21932,7 @@
       </p:sp>
       <p:sp>
         <p:nvSpPr>
-          <p:cNvPr id="35" name="Text 33"/>
+          <p:cNvPr id="40" name="Text 38"/>
           <p:cNvSpPr/>
           <p:nvPr/>
         </p:nvSpPr>
@@ -21767,7 +21971,7 @@
       </p:sp>
       <p:sp>
         <p:nvSpPr>
-          <p:cNvPr id="36" name="Text 34"/>
+          <p:cNvPr id="41" name="Text 39"/>
           <p:cNvSpPr/>
           <p:nvPr/>
         </p:nvSpPr>
@@ -21928,7 +22132,7 @@
                 <a:ea typeface="Arial Black" pitchFamily="34" charset="-122"/>
                 <a:cs typeface="Arial Black" pitchFamily="34" charset="-120"/>
               </a:rPr>
-              <a:t>Autonomous mobility.</a:t>
+              <a:t>Every autonomous mile compounds — every AV runs frontier edge compute</a:t>
             </a:r>
             <a:endParaRPr lang="en-US" sz="2400" dirty="0"/>
           </a:p>
@@ -23890,7 +24094,7 @@
                 <a:ea typeface="Arial Black" pitchFamily="34" charset="-122"/>
                 <a:cs typeface="Arial Black" pitchFamily="34" charset="-120"/>
               </a:rPr>
-              <a:t>Key takeaways.</a:t>
+              <a:t>Capex on credit, basket over, bottleneck moves, exposure is a thesis</a:t>
             </a:r>
             <a:endParaRPr lang="en-US" sz="2400" dirty="0"/>
           </a:p>
@@ -24236,7 +24440,7 @@
                 <a:ea typeface="Arial" pitchFamily="34" charset="-122"/>
                 <a:cs typeface="Arial" pitchFamily="34" charset="-120"/>
               </a:rPr>
-              <a:t>AI stock correlation collapsed from ~80% to ~20%. Semis +38% YTD, software –20% YTD — a 58-point spread. Memory oligopolies with pricing power outperform cloud providers burning cash.</a:t>
+              <a:t>AI stock correlation collapsed from ~80% to ~20%. Semis +38% YTD, software –20% YTD — a 58-point spread (YTD through Apr 17, 2026). Memory oligopolies with pricing power outperform cloud providers burning cash.</a:t>
             </a:r>
             <a:endParaRPr lang="en-US" sz="1050" dirty="0"/>
           </a:p>
@@ -27169,7 +27373,7 @@
                 <a:ea typeface="Arial" pitchFamily="34" charset="-122"/>
                 <a:cs typeface="Arial" pitchFamily="34" charset="-120"/>
               </a:rPr>
-              <a:t>A1</a:t>
+              <a:t>23</a:t>
             </a:r>
             <a:endParaRPr lang="en-US" sz="900" dirty="0"/>
           </a:p>
@@ -30315,7 +30519,7 @@
                 <a:ea typeface="Arial" pitchFamily="34" charset="-122"/>
                 <a:cs typeface="Arial" pitchFamily="34" charset="-120"/>
               </a:rPr>
-              <a:t>A2</a:t>
+              <a:t>24</a:t>
             </a:r>
             <a:endParaRPr lang="en-US" sz="900" dirty="0"/>
           </a:p>
@@ -31166,7 +31370,7 @@
                 <a:ea typeface="Arial Black" pitchFamily="34" charset="-122"/>
                 <a:cs typeface="Arial Black" pitchFamily="34" charset="-120"/>
               </a:rPr>
-              <a:t>AI evolution from chatbots to agents.</a:t>
+              <a:t>Sixty years of AI in six steps — and we are now in step six</a:t>
             </a:r>
             <a:endParaRPr lang="en-US" sz="2400" dirty="0"/>
           </a:p>
@@ -32675,7 +32879,7 @@
                 <a:ea typeface="Arial Black" pitchFamily="34" charset="-122"/>
                 <a:cs typeface="Arial Black" pitchFamily="34" charset="-120"/>
               </a:rPr>
-              <a:t>The AI stack.</a:t>
+              <a:t>Eleven layers, four power blocs — your exposure depends on which layer you own</a:t>
             </a:r>
             <a:endParaRPr lang="en-US" sz="2400" dirty="0"/>
           </a:p>
@@ -35400,7 +35604,7 @@
                 <a:ea typeface="Arial Black" pitchFamily="34" charset="-122"/>
                 <a:cs typeface="Arial Black" pitchFamily="34" charset="-120"/>
               </a:rPr>
-              <a:t>Semiconductors, explained.</a:t>
+              <a:t>Logic and memory absorb the capex — ASML and TSMC decide who ships</a:t>
             </a:r>
             <a:endParaRPr lang="en-US" sz="2400" dirty="0"/>
           </a:p>
@@ -37974,7 +38178,7 @@
                 <a:ea typeface="Arial Black" pitchFamily="34" charset="-122"/>
                 <a:cs typeface="Arial Black" pitchFamily="34" charset="-120"/>
               </a:rPr>
-              <a:t>Who's buying the chips.</a:t>
+              <a:t>Five hyperscalers fund ~60% of AI chip demand — their capex IS the market</a:t>
             </a:r>
             <a:endParaRPr lang="en-US" sz="2400" dirty="0"/>
           </a:p>
@@ -39723,7 +39927,7 @@
                 <a:ea typeface="Arial" pitchFamily="34" charset="-122"/>
                 <a:cs typeface="Arial" pitchFamily="34" charset="-120"/>
               </a:rPr>
-              <a:t>of US electricity demand will go to data centers by 2028 — up from ~4% in 2023</a:t>
+              <a:t>of US electricity demand will go to data centers by 2028 — up from ~4% in 2023 (EPRI high case, 2024)</a:t>
             </a:r>
             <a:endParaRPr lang="en-US" sz="1100" dirty="0"/>
           </a:p>

</xml_diff>

<commit_message>
Slides 7 + 22: redesign as educational primer and big-picture closer
Slide 7: drop the logic/memory strategic claim and six-product taxonomy. Rebuild as a plain-English AI-chip primer with photo placeholder on the left and four numbered stages (DESIGN, EQUIPMENT, FABRICATION, PACKAGING) on the right. Focus on AI accelerators (HBM, CoWoS, NVIDIA/AMD/Broadcom/Google TPU), not chips in general.

Slide 22: strip proof bodies, keep only the four big-picture statements at 18pt bold. Widen headline to 9.0" so it wraps to two clean lines.

Appendix: replace slide 7 citations with the three new entries (no Strategy Research). Re-export slide 23 to match.

Co-Authored-By: Claude Opus 4.7 <noreply@anthropic.com>
</commit_message>
<xml_diff>
--- a/ai-markets-deck.pptx
+++ b/ai-markets-deck.pptx
@@ -24070,7 +24070,7 @@
         <p:spPr>
           <a:xfrm>
             <a:off x="457200" y="182880"/>
-            <a:ext cx="6583680" cy="685800"/>
+            <a:ext cx="8229600" cy="685800"/>
           </a:xfrm>
           <a:prstGeom prst="rect">
             <a:avLst/>
@@ -24094,7 +24094,7 @@
                 <a:ea typeface="Arial Black" pitchFamily="34" charset="-122"/>
                 <a:cs typeface="Arial Black" pitchFamily="34" charset="-120"/>
               </a:rPr>
-              <a:t>Capex on credit, basket over, bottleneck moves, exposure is a thesis</a:t>
+              <a:t>Capex on credit. Basket over. Bottleneck moves. Exposure is a thesis.</a:t>
             </a:r>
             <a:endParaRPr lang="en-US" sz="2400" dirty="0"/>
           </a:p>
@@ -24133,7 +24133,7 @@
                 <a:ea typeface="Arial" pitchFamily="34" charset="-122"/>
                 <a:cs typeface="Arial" pitchFamily="34" charset="-120"/>
               </a:rPr>
-              <a:t>The thesis, distilled. Each with the number that makes it investable.</a:t>
+              <a:t>Four big-picture takeaways.</a:t>
             </a:r>
             <a:endParaRPr lang="en-US" sz="1350" dirty="0"/>
           </a:p>
@@ -24170,8 +24170,8 @@
         </p:nvSpPr>
         <p:spPr>
           <a:xfrm>
-            <a:off x="457200" y="1554480"/>
-            <a:ext cx="640080" cy="850392"/>
+            <a:off x="457200" y="1691640"/>
+            <a:ext cx="868680" cy="868680"/>
           </a:xfrm>
           <a:prstGeom prst="rect">
             <a:avLst/>
@@ -24195,8 +24195,8 @@
         </p:nvSpPr>
         <p:spPr>
           <a:xfrm>
-            <a:off x="457200" y="1554480"/>
-            <a:ext cx="640080" cy="850392"/>
+            <a:off x="457200" y="1691640"/>
+            <a:ext cx="868680" cy="868680"/>
           </a:xfrm>
           <a:prstGeom prst="rect">
             <a:avLst/>
@@ -24212,7 +24212,7 @@
               <a:buNone/>
             </a:pPr>
             <a:r>
-              <a:rPr lang="en-US" sz="2000" b="1" dirty="0">
+              <a:rPr lang="en-US" sz="2600" b="1" dirty="0">
                 <a:solidFill>
                   <a:srgbClr val="FFFFFF"/>
                 </a:solidFill>
@@ -24222,7 +24222,7 @@
               </a:rPr>
               <a:t>01</a:t>
             </a:r>
-            <a:endParaRPr lang="en-US" sz="2000" dirty="0"/>
+            <a:endParaRPr lang="en-US" sz="2600" dirty="0"/>
           </a:p>
         </p:txBody>
       </p:sp>
@@ -24234,63 +24234,24 @@
         </p:nvSpPr>
         <p:spPr>
           <a:xfrm>
-            <a:off x="1188720" y="1554480"/>
-            <a:ext cx="7498080" cy="274320"/>
-          </a:xfrm>
-          <a:prstGeom prst="rect">
-            <a:avLst/>
-          </a:prstGeom>
-          <a:noFill/>
-          <a:ln/>
-        </p:spPr>
-        <p:txBody>
-          <a:bodyPr wrap="square" lIns="0" tIns="0" rIns="0" bIns="0" rtlCol="0" anchor="t"/>
-          <a:lstStyle/>
-          <a:p>
-            <a:pPr indent="0" marL="0">
-              <a:buNone/>
-            </a:pPr>
-            <a:r>
-              <a:rPr lang="en-US" sz="1300" b="1" dirty="0">
-                <a:solidFill>
-                  <a:srgbClr val="000000"/>
-                </a:solidFill>
-                <a:latin typeface="Arial" pitchFamily="34" charset="0"/>
-                <a:ea typeface="Arial" pitchFamily="34" charset="-122"/>
-                <a:cs typeface="Arial" pitchFamily="34" charset="-120"/>
-              </a:rPr>
-              <a:t>The largest capex cycle in history — and it's going on credit.</a:t>
-            </a:r>
-            <a:endParaRPr lang="en-US" sz="1300" dirty="0"/>
-          </a:p>
-        </p:txBody>
-      </p:sp>
-      <p:sp>
-        <p:nvSpPr>
-          <p:cNvPr id="8" name="Text 6"/>
-          <p:cNvSpPr/>
-          <p:nvPr/>
-        </p:nvSpPr>
-        <p:spPr>
-          <a:xfrm>
-            <a:off x="1188720" y="1828800"/>
-            <a:ext cx="7498080" cy="576072"/>
-          </a:xfrm>
-          <a:prstGeom prst="rect">
-            <a:avLst/>
-          </a:prstGeom>
-          <a:noFill/>
-          <a:ln/>
-        </p:spPr>
-        <p:txBody>
-          <a:bodyPr wrap="square" lIns="0" tIns="0" rIns="0" bIns="0" rtlCol="0" anchor="t"/>
-          <a:lstStyle/>
-          <a:p>
-            <a:pPr indent="0" marL="0">
-              <a:buNone/>
-            </a:pPr>
-            <a:r>
-              <a:rPr lang="en-US" sz="1050" dirty="0">
+            <a:off x="1508760" y="1691640"/>
+            <a:ext cx="7178040" cy="868680"/>
+          </a:xfrm>
+          <a:prstGeom prst="rect">
+            <a:avLst/>
+          </a:prstGeom>
+          <a:noFill/>
+          <a:ln/>
+        </p:spPr>
+        <p:txBody>
+          <a:bodyPr wrap="square" lIns="0" tIns="0" rIns="0" bIns="0" rtlCol="0" anchor="ctr"/>
+          <a:lstStyle/>
+          <a:p>
+            <a:pPr indent="0" marL="0">
+              <a:buNone/>
+            </a:pPr>
+            <a:r>
+              <a:rPr lang="en-US" sz="1800" b="1" dirty="0">
                 <a:solidFill>
                   <a:srgbClr val="333333"/>
                 </a:solidFill>
@@ -24298,22 +24259,22 @@
                 <a:ea typeface="Arial" pitchFamily="34" charset="-122"/>
                 <a:cs typeface="Arial" pitchFamily="34" charset="-120"/>
               </a:rPr>
-              <a:t>~$750B hyperscaler capex in 2026, up ~$300B YoY. Amazon FCF turns negative; Meta FCF down ~90%. ~75% of that capex is AI-specific. The story has shifted from cash flow to balance sheet.</a:t>
-            </a:r>
-            <a:endParaRPr lang="en-US" sz="1050" dirty="0"/>
-          </a:p>
-        </p:txBody>
-      </p:sp>
-      <p:sp>
-        <p:nvSpPr>
-          <p:cNvPr id="9" name="Shape 7"/>
-          <p:cNvSpPr/>
-          <p:nvPr/>
-        </p:nvSpPr>
-        <p:spPr>
-          <a:xfrm>
-            <a:off x="457200" y="2514600"/>
-            <a:ext cx="640080" cy="850392"/>
+              <a:t>The largest capex cycle in history is going on credit.</a:t>
+            </a:r>
+            <a:endParaRPr lang="en-US" sz="1800" dirty="0"/>
+          </a:p>
+        </p:txBody>
+      </p:sp>
+      <p:sp>
+        <p:nvSpPr>
+          <p:cNvPr id="8" name="Shape 6"/>
+          <p:cNvSpPr/>
+          <p:nvPr/>
+        </p:nvSpPr>
+        <p:spPr>
+          <a:xfrm>
+            <a:off x="457200" y="2651760"/>
+            <a:ext cx="868680" cy="868680"/>
           </a:xfrm>
           <a:prstGeom prst="rect">
             <a:avLst/>
@@ -24331,14 +24292,14 @@
       </p:sp>
       <p:sp>
         <p:nvSpPr>
-          <p:cNvPr id="10" name="Text 8"/>
-          <p:cNvSpPr/>
-          <p:nvPr/>
-        </p:nvSpPr>
-        <p:spPr>
-          <a:xfrm>
-            <a:off x="457200" y="2514600"/>
-            <a:ext cx="640080" cy="850392"/>
+          <p:cNvPr id="9" name="Text 7"/>
+          <p:cNvSpPr/>
+          <p:nvPr/>
+        </p:nvSpPr>
+        <p:spPr>
+          <a:xfrm>
+            <a:off x="457200" y="2651760"/>
+            <a:ext cx="868680" cy="868680"/>
           </a:xfrm>
           <a:prstGeom prst="rect">
             <a:avLst/>
@@ -24354,7 +24315,7 @@
               <a:buNone/>
             </a:pPr>
             <a:r>
-              <a:rPr lang="en-US" sz="2000" b="1" dirty="0">
+              <a:rPr lang="en-US" sz="2600" b="1" dirty="0">
                 <a:solidFill>
                   <a:srgbClr val="FFFFFF"/>
                 </a:solidFill>
@@ -24364,75 +24325,36 @@
               </a:rPr>
               <a:t>02</a:t>
             </a:r>
-            <a:endParaRPr lang="en-US" sz="2000" dirty="0"/>
-          </a:p>
-        </p:txBody>
-      </p:sp>
-      <p:sp>
-        <p:nvSpPr>
-          <p:cNvPr id="11" name="Text 9"/>
-          <p:cNvSpPr/>
-          <p:nvPr/>
-        </p:nvSpPr>
-        <p:spPr>
-          <a:xfrm>
-            <a:off x="1188720" y="2514600"/>
-            <a:ext cx="7498080" cy="274320"/>
-          </a:xfrm>
-          <a:prstGeom prst="rect">
-            <a:avLst/>
-          </a:prstGeom>
-          <a:noFill/>
-          <a:ln/>
-        </p:spPr>
-        <p:txBody>
-          <a:bodyPr wrap="square" lIns="0" tIns="0" rIns="0" bIns="0" rtlCol="0" anchor="t"/>
-          <a:lstStyle/>
-          <a:p>
-            <a:pPr indent="0" marL="0">
-              <a:buNone/>
-            </a:pPr>
-            <a:r>
-              <a:rPr lang="en-US" sz="1300" b="1" dirty="0">
-                <a:solidFill>
-                  <a:srgbClr val="000000"/>
-                </a:solidFill>
-                <a:latin typeface="Arial" pitchFamily="34" charset="0"/>
-                <a:ea typeface="Arial" pitchFamily="34" charset="-122"/>
-                <a:cs typeface="Arial" pitchFamily="34" charset="-120"/>
-              </a:rPr>
-              <a:t>The market is picking winners — the basket trade is over.</a:t>
-            </a:r>
-            <a:endParaRPr lang="en-US" sz="1300" dirty="0"/>
-          </a:p>
-        </p:txBody>
-      </p:sp>
-      <p:sp>
-        <p:nvSpPr>
-          <p:cNvPr id="12" name="Text 10"/>
-          <p:cNvSpPr/>
-          <p:nvPr/>
-        </p:nvSpPr>
-        <p:spPr>
-          <a:xfrm>
-            <a:off x="1188720" y="2788920"/>
-            <a:ext cx="7498080" cy="576072"/>
-          </a:xfrm>
-          <a:prstGeom prst="rect">
-            <a:avLst/>
-          </a:prstGeom>
-          <a:noFill/>
-          <a:ln/>
-        </p:spPr>
-        <p:txBody>
-          <a:bodyPr wrap="square" lIns="0" tIns="0" rIns="0" bIns="0" rtlCol="0" anchor="t"/>
-          <a:lstStyle/>
-          <a:p>
-            <a:pPr indent="0" marL="0">
-              <a:buNone/>
-            </a:pPr>
-            <a:r>
-              <a:rPr lang="en-US" sz="1050" dirty="0">
+            <a:endParaRPr lang="en-US" sz="2600" dirty="0"/>
+          </a:p>
+        </p:txBody>
+      </p:sp>
+      <p:sp>
+        <p:nvSpPr>
+          <p:cNvPr id="10" name="Text 8"/>
+          <p:cNvSpPr/>
+          <p:nvPr/>
+        </p:nvSpPr>
+        <p:spPr>
+          <a:xfrm>
+            <a:off x="1508760" y="2651760"/>
+            <a:ext cx="7178040" cy="868680"/>
+          </a:xfrm>
+          <a:prstGeom prst="rect">
+            <a:avLst/>
+          </a:prstGeom>
+          <a:noFill/>
+          <a:ln/>
+        </p:spPr>
+        <p:txBody>
+          <a:bodyPr wrap="square" lIns="0" tIns="0" rIns="0" bIns="0" rtlCol="0" anchor="ctr"/>
+          <a:lstStyle/>
+          <a:p>
+            <a:pPr indent="0" marL="0">
+              <a:buNone/>
+            </a:pPr>
+            <a:r>
+              <a:rPr lang="en-US" sz="1800" b="1" dirty="0">
                 <a:solidFill>
                   <a:srgbClr val="333333"/>
                 </a:solidFill>
@@ -24440,22 +24362,22 @@
                 <a:ea typeface="Arial" pitchFamily="34" charset="-122"/>
                 <a:cs typeface="Arial" pitchFamily="34" charset="-120"/>
               </a:rPr>
-              <a:t>AI stock correlation collapsed from ~80% to ~20%. Semis +38% YTD, software –20% YTD — a 58-point spread (YTD through Apr 17, 2026). Memory oligopolies with pricing power outperform cloud providers burning cash.</a:t>
-            </a:r>
-            <a:endParaRPr lang="en-US" sz="1050" dirty="0"/>
-          </a:p>
-        </p:txBody>
-      </p:sp>
-      <p:sp>
-        <p:nvSpPr>
-          <p:cNvPr id="13" name="Shape 11"/>
-          <p:cNvSpPr/>
-          <p:nvPr/>
-        </p:nvSpPr>
-        <p:spPr>
-          <a:xfrm>
-            <a:off x="457200" y="3474720"/>
-            <a:ext cx="640080" cy="850392"/>
+              <a:t>The basket trade is over. The market picks winners.</a:t>
+            </a:r>
+            <a:endParaRPr lang="en-US" sz="1800" dirty="0"/>
+          </a:p>
+        </p:txBody>
+      </p:sp>
+      <p:sp>
+        <p:nvSpPr>
+          <p:cNvPr id="11" name="Shape 9"/>
+          <p:cNvSpPr/>
+          <p:nvPr/>
+        </p:nvSpPr>
+        <p:spPr>
+          <a:xfrm>
+            <a:off x="457200" y="3611880"/>
+            <a:ext cx="868680" cy="868680"/>
           </a:xfrm>
           <a:prstGeom prst="rect">
             <a:avLst/>
@@ -24473,14 +24395,14 @@
       </p:sp>
       <p:sp>
         <p:nvSpPr>
-          <p:cNvPr id="14" name="Text 12"/>
-          <p:cNvSpPr/>
-          <p:nvPr/>
-        </p:nvSpPr>
-        <p:spPr>
-          <a:xfrm>
-            <a:off x="457200" y="3474720"/>
-            <a:ext cx="640080" cy="850392"/>
+          <p:cNvPr id="12" name="Text 10"/>
+          <p:cNvSpPr/>
+          <p:nvPr/>
+        </p:nvSpPr>
+        <p:spPr>
+          <a:xfrm>
+            <a:off x="457200" y="3611880"/>
+            <a:ext cx="868680" cy="868680"/>
           </a:xfrm>
           <a:prstGeom prst="rect">
             <a:avLst/>
@@ -24496,7 +24418,7 @@
               <a:buNone/>
             </a:pPr>
             <a:r>
-              <a:rPr lang="en-US" sz="2000" b="1" dirty="0">
+              <a:rPr lang="en-US" sz="2600" b="1" dirty="0">
                 <a:solidFill>
                   <a:srgbClr val="FFFFFF"/>
                 </a:solidFill>
@@ -24506,75 +24428,36 @@
               </a:rPr>
               <a:t>03</a:t>
             </a:r>
-            <a:endParaRPr lang="en-US" sz="2000" dirty="0"/>
-          </a:p>
-        </p:txBody>
-      </p:sp>
-      <p:sp>
-        <p:nvSpPr>
-          <p:cNvPr id="15" name="Text 13"/>
-          <p:cNvSpPr/>
-          <p:nvPr/>
-        </p:nvSpPr>
-        <p:spPr>
-          <a:xfrm>
-            <a:off x="1188720" y="3474720"/>
-            <a:ext cx="7498080" cy="274320"/>
-          </a:xfrm>
-          <a:prstGeom prst="rect">
-            <a:avLst/>
-          </a:prstGeom>
-          <a:noFill/>
-          <a:ln/>
-        </p:spPr>
-        <p:txBody>
-          <a:bodyPr wrap="square" lIns="0" tIns="0" rIns="0" bIns="0" rtlCol="0" anchor="t"/>
-          <a:lstStyle/>
-          <a:p>
-            <a:pPr indent="0" marL="0">
-              <a:buNone/>
-            </a:pPr>
-            <a:r>
-              <a:rPr lang="en-US" sz="1300" b="1" dirty="0">
-                <a:solidFill>
-                  <a:srgbClr val="000000"/>
-                </a:solidFill>
-                <a:latin typeface="Arial" pitchFamily="34" charset="0"/>
-                <a:ea typeface="Arial" pitchFamily="34" charset="-122"/>
-                <a:cs typeface="Arial" pitchFamily="34" charset="-120"/>
-              </a:rPr>
-              <a:t>The bottleneck keeps moving — and that is the opportunity.</a:t>
-            </a:r>
-            <a:endParaRPr lang="en-US" sz="1300" dirty="0"/>
-          </a:p>
-        </p:txBody>
-      </p:sp>
-      <p:sp>
-        <p:nvSpPr>
-          <p:cNvPr id="16" name="Text 14"/>
-          <p:cNvSpPr/>
-          <p:nvPr/>
-        </p:nvSpPr>
-        <p:spPr>
-          <a:xfrm>
-            <a:off x="1188720" y="3749040"/>
-            <a:ext cx="7498080" cy="576072"/>
-          </a:xfrm>
-          <a:prstGeom prst="rect">
-            <a:avLst/>
-          </a:prstGeom>
-          <a:noFill/>
-          <a:ln/>
-        </p:spPr>
-        <p:txBody>
-          <a:bodyPr wrap="square" lIns="0" tIns="0" rIns="0" bIns="0" rtlCol="0" anchor="t"/>
-          <a:lstStyle/>
-          <a:p>
-            <a:pPr indent="0" marL="0">
-              <a:buNone/>
-            </a:pPr>
-            <a:r>
-              <a:rPr lang="en-US" sz="1050" dirty="0">
+            <a:endParaRPr lang="en-US" sz="2600" dirty="0"/>
+          </a:p>
+        </p:txBody>
+      </p:sp>
+      <p:sp>
+        <p:nvSpPr>
+          <p:cNvPr id="13" name="Text 11"/>
+          <p:cNvSpPr/>
+          <p:nvPr/>
+        </p:nvSpPr>
+        <p:spPr>
+          <a:xfrm>
+            <a:off x="1508760" y="3611880"/>
+            <a:ext cx="7178040" cy="868680"/>
+          </a:xfrm>
+          <a:prstGeom prst="rect">
+            <a:avLst/>
+          </a:prstGeom>
+          <a:noFill/>
+          <a:ln/>
+        </p:spPr>
+        <p:txBody>
+          <a:bodyPr wrap="square" lIns="0" tIns="0" rIns="0" bIns="0" rtlCol="0" anchor="ctr"/>
+          <a:lstStyle/>
+          <a:p>
+            <a:pPr indent="0" marL="0">
+              <a:buNone/>
+            </a:pPr>
+            <a:r>
+              <a:rPr lang="en-US" sz="1800" b="1" dirty="0">
                 <a:solidFill>
                   <a:srgbClr val="333333"/>
                 </a:solidFill>
@@ -24582,22 +24465,22 @@
                 <a:ea typeface="Arial" pitchFamily="34" charset="-122"/>
                 <a:cs typeface="Arial" pitchFamily="34" charset="-120"/>
               </a:rPr>
-              <a:t>CoWoS packaging (2023–24) → HBM / silicon wafer supply (now) → EUV lithography (&lt;100 machines/yr) by 2028. Each shift reprices a different part of the stack. HBM TAM on a path from $35B (2025) to $100B (2028).</a:t>
-            </a:r>
-            <a:endParaRPr lang="en-US" sz="1050" dirty="0"/>
-          </a:p>
-        </p:txBody>
-      </p:sp>
-      <p:sp>
-        <p:nvSpPr>
-          <p:cNvPr id="17" name="Shape 15"/>
-          <p:cNvSpPr/>
-          <p:nvPr/>
-        </p:nvSpPr>
-        <p:spPr>
-          <a:xfrm>
-            <a:off x="457200" y="4434840"/>
-            <a:ext cx="640080" cy="850392"/>
+              <a:t>The bottleneck keeps moving. That is the opportunity.</a:t>
+            </a:r>
+            <a:endParaRPr lang="en-US" sz="1800" dirty="0"/>
+          </a:p>
+        </p:txBody>
+      </p:sp>
+      <p:sp>
+        <p:nvSpPr>
+          <p:cNvPr id="14" name="Shape 12"/>
+          <p:cNvSpPr/>
+          <p:nvPr/>
+        </p:nvSpPr>
+        <p:spPr>
+          <a:xfrm>
+            <a:off x="457200" y="4572000"/>
+            <a:ext cx="868680" cy="868680"/>
           </a:xfrm>
           <a:prstGeom prst="rect">
             <a:avLst/>
@@ -24615,14 +24498,14 @@
       </p:sp>
       <p:sp>
         <p:nvSpPr>
-          <p:cNvPr id="18" name="Text 16"/>
-          <p:cNvSpPr/>
-          <p:nvPr/>
-        </p:nvSpPr>
-        <p:spPr>
-          <a:xfrm>
-            <a:off x="457200" y="4434840"/>
-            <a:ext cx="640080" cy="850392"/>
+          <p:cNvPr id="15" name="Text 13"/>
+          <p:cNvSpPr/>
+          <p:nvPr/>
+        </p:nvSpPr>
+        <p:spPr>
+          <a:xfrm>
+            <a:off x="457200" y="4572000"/>
+            <a:ext cx="868680" cy="868680"/>
           </a:xfrm>
           <a:prstGeom prst="rect">
             <a:avLst/>
@@ -24638,7 +24521,7 @@
               <a:buNone/>
             </a:pPr>
             <a:r>
-              <a:rPr lang="en-US" sz="2000" b="1" dirty="0">
+              <a:rPr lang="en-US" sz="2600" b="1" dirty="0">
                 <a:solidFill>
                   <a:srgbClr val="FFFFFF"/>
                 </a:solidFill>
@@ -24648,75 +24531,36 @@
               </a:rPr>
               <a:t>04</a:t>
             </a:r>
-            <a:endParaRPr lang="en-US" sz="2000" dirty="0"/>
-          </a:p>
-        </p:txBody>
-      </p:sp>
-      <p:sp>
-        <p:nvSpPr>
-          <p:cNvPr id="19" name="Text 17"/>
-          <p:cNvSpPr/>
-          <p:nvPr/>
-        </p:nvSpPr>
-        <p:spPr>
-          <a:xfrm>
-            <a:off x="1188720" y="4434840"/>
-            <a:ext cx="7498080" cy="274320"/>
-          </a:xfrm>
-          <a:prstGeom prst="rect">
-            <a:avLst/>
-          </a:prstGeom>
-          <a:noFill/>
-          <a:ln/>
-        </p:spPr>
-        <p:txBody>
-          <a:bodyPr wrap="square" lIns="0" tIns="0" rIns="0" bIns="0" rtlCol="0" anchor="t"/>
-          <a:lstStyle/>
-          <a:p>
-            <a:pPr indent="0" marL="0">
-              <a:buNone/>
-            </a:pPr>
-            <a:r>
-              <a:rPr lang="en-US" sz="1300" b="1" dirty="0">
-                <a:solidFill>
-                  <a:srgbClr val="000000"/>
-                </a:solidFill>
-                <a:latin typeface="Arial" pitchFamily="34" charset="0"/>
-                <a:ea typeface="Arial" pitchFamily="34" charset="-122"/>
-                <a:cs typeface="Arial" pitchFamily="34" charset="-120"/>
-              </a:rPr>
-              <a:t>The question isn't whether you have AI exposure — it's whether you chose it.</a:t>
-            </a:r>
-            <a:endParaRPr lang="en-US" sz="1300" dirty="0"/>
-          </a:p>
-        </p:txBody>
-      </p:sp>
-      <p:sp>
-        <p:nvSpPr>
-          <p:cNvPr id="20" name="Text 18"/>
-          <p:cNvSpPr/>
-          <p:nvPr/>
-        </p:nvSpPr>
-        <p:spPr>
-          <a:xfrm>
-            <a:off x="1188720" y="4709160"/>
-            <a:ext cx="7498080" cy="576072"/>
-          </a:xfrm>
-          <a:prstGeom prst="rect">
-            <a:avLst/>
-          </a:prstGeom>
-          <a:noFill/>
-          <a:ln/>
-        </p:spPr>
-        <p:txBody>
-          <a:bodyPr wrap="square" lIns="0" tIns="0" rIns="0" bIns="0" rtlCol="0" anchor="t"/>
-          <a:lstStyle/>
-          <a:p>
-            <a:pPr indent="0" marL="0">
-              <a:buNone/>
-            </a:pPr>
-            <a:r>
-              <a:rPr lang="en-US" sz="1050" dirty="0">
+            <a:endParaRPr lang="en-US" sz="2600" dirty="0"/>
+          </a:p>
+        </p:txBody>
+      </p:sp>
+      <p:sp>
+        <p:nvSpPr>
+          <p:cNvPr id="16" name="Text 14"/>
+          <p:cNvSpPr/>
+          <p:nvPr/>
+        </p:nvSpPr>
+        <p:spPr>
+          <a:xfrm>
+            <a:off x="1508760" y="4572000"/>
+            <a:ext cx="7178040" cy="868680"/>
+          </a:xfrm>
+          <a:prstGeom prst="rect">
+            <a:avLst/>
+          </a:prstGeom>
+          <a:noFill/>
+          <a:ln/>
+        </p:spPr>
+        <p:txBody>
+          <a:bodyPr wrap="square" lIns="0" tIns="0" rIns="0" bIns="0" rtlCol="0" anchor="ctr"/>
+          <a:lstStyle/>
+          <a:p>
+            <a:pPr indent="0" marL="0">
+              <a:buNone/>
+            </a:pPr>
+            <a:r>
+              <a:rPr lang="en-US" sz="1800" b="1" dirty="0">
                 <a:solidFill>
                   <a:srgbClr val="333333"/>
                 </a:solidFill>
@@ -24724,15 +24568,15 @@
                 <a:ea typeface="Arial" pitchFamily="34" charset="-122"/>
                 <a:cs typeface="Arial" pitchFamily="34" charset="-120"/>
               </a:rPr>
-              <a:t>AI-linked stocks are ~30%+ of US large-cap benchmarks. Passive exposure to a ~$750B capex cycle is not neutral — it's a thesis. Own the layer with pricing power for today's bottleneck.</a:t>
-            </a:r>
-            <a:endParaRPr lang="en-US" sz="1050" dirty="0"/>
-          </a:p>
-        </p:txBody>
-      </p:sp>
-      <p:sp>
-        <p:nvSpPr>
-          <p:cNvPr id="21" name="Text 19"/>
+              <a:t>If you index, you own the thesis. Choose it deliberately.</a:t>
+            </a:r>
+            <a:endParaRPr lang="en-US" sz="1800" dirty="0"/>
+          </a:p>
+        </p:txBody>
+      </p:sp>
+      <p:sp>
+        <p:nvSpPr>
+          <p:cNvPr id="17" name="Text 15"/>
           <p:cNvSpPr/>
           <p:nvPr/>
         </p:nvSpPr>
@@ -24763,7 +24607,7 @@
                 <a:ea typeface="Arial" pitchFamily="34" charset="-122"/>
                 <a:cs typeface="Arial" pitchFamily="34" charset="-120"/>
               </a:rPr>
-              <a:t>Sources: company filings; CreditSights / MUFG hyperscaler capex 2026 (Apr 2026); Goldman Sachs correlation data; Yahoo Finance YTD (Apr 17, 2026); SemiAnalysis; BofA HBM TAM; TrendForce.</a:t>
+              <a:t>Sources: company filings; CreditSights / MUFG; Goldman Sachs; SemiAnalysis; BofA; TrendForce. See appendix for figure-by-figure citations.</a:t>
             </a:r>
             <a:endParaRPr lang="en-US" sz="700" dirty="0"/>
           </a:p>
@@ -24771,7 +24615,7 @@
       </p:sp>
       <p:sp>
         <p:nvSpPr>
-          <p:cNvPr id="22" name="Shape 20"/>
+          <p:cNvPr id="18" name="Shape 16"/>
           <p:cNvSpPr/>
           <p:nvPr/>
         </p:nvSpPr>
@@ -24796,7 +24640,7 @@
       </p:sp>
       <p:sp>
         <p:nvSpPr>
-          <p:cNvPr id="23" name="Text 21"/>
+          <p:cNvPr id="19" name="Text 17"/>
           <p:cNvSpPr/>
           <p:nvPr/>
         </p:nvSpPr>
@@ -24835,7 +24679,7 @@
       </p:sp>
       <p:sp>
         <p:nvSpPr>
-          <p:cNvPr id="24" name="Text 22"/>
+          <p:cNvPr id="20" name="Text 18"/>
           <p:cNvSpPr/>
           <p:nvPr/>
         </p:nvSpPr>
@@ -25691,7 +25535,7 @@
                 <a:ea typeface="Arial" pitchFamily="34" charset="-122"/>
                 <a:cs typeface="Arial" pitchFamily="34" charset="-120"/>
               </a:rPr>
-              <a:t>"$975B 2026E semi market"</a:t>
+              <a:t>Four-stage AI chipmaking process</a:t>
             </a:r>
             <a:pPr indent="0" marL="0">
               <a:spcAft>
@@ -25725,7 +25569,7 @@
                 <a:ea typeface="Arial" pitchFamily="34" charset="-122"/>
                 <a:cs typeface="Arial" pitchFamily="34" charset="-120"/>
               </a:rPr>
-              <a:t>WSTS Fall 2025 forecast (Nov 2025 release)</a:t>
+              <a:t>SIA / SEMI industry taxonomy</a:t>
             </a:r>
             <a:endParaRPr lang="en-US" sz="850" dirty="0"/>
           </a:p>
@@ -25762,7 +25606,7 @@
                 <a:ea typeface="Arial" pitchFamily="34" charset="-122"/>
                 <a:cs typeface="Arial" pitchFamily="34" charset="-120"/>
               </a:rPr>
-              <a:t>Six-category chip taxonomy</a:t>
+              <a:t>"$20B fab" cost benchmark</a:t>
             </a:r>
             <a:pPr indent="0" marL="0">
               <a:spcAft>
@@ -25796,7 +25640,78 @@
                 <a:ea typeface="Arial" pitchFamily="34" charset="-122"/>
                 <a:cs typeface="Arial" pitchFamily="34" charset="-120"/>
               </a:rPr>
-              <a:t>SIA market-structure breakdown</a:t>
+              <a:t>SEMI World Fab Forecast; TSMC / Samsung capex disclosures</a:t>
+            </a:r>
+            <a:endParaRPr lang="en-US" sz="850" dirty="0"/>
+          </a:p>
+          <a:p>
+            <a:pPr indent="0" marL="0">
+              <a:spcAft>
+                <a:spcPts val="200"/>
+              </a:spcAft>
+              <a:buNone/>
+            </a:pPr>
+            <a:r>
+              <a:rPr lang="en-US" sz="850" b="1" dirty="0">
+                <a:solidFill>
+                  <a:srgbClr val="000000"/>
+                </a:solidFill>
+                <a:latin typeface="Arial" pitchFamily="34" charset="0"/>
+                <a:ea typeface="Arial" pitchFamily="34" charset="-122"/>
+                <a:cs typeface="Arial" pitchFamily="34" charset="-120"/>
+              </a:rPr>
+              <a:t>Slide 7  ·  </a:t>
+            </a:r>
+            <a:pPr indent="0" marL="0">
+              <a:spcAft>
+                <a:spcPts val="200"/>
+              </a:spcAft>
+              <a:buNone/>
+            </a:pPr>
+            <a:r>
+              <a:rPr lang="en-US" sz="850" dirty="0">
+                <a:solidFill>
+                  <a:srgbClr val="000000"/>
+                </a:solidFill>
+                <a:latin typeface="Arial" pitchFamily="34" charset="0"/>
+                <a:ea typeface="Arial" pitchFamily="34" charset="-122"/>
+                <a:cs typeface="Arial" pitchFamily="34" charset="-120"/>
+              </a:rPr>
+              <a:t>HBM + CoWoS advanced packaging</a:t>
+            </a:r>
+            <a:pPr indent="0" marL="0">
+              <a:spcAft>
+                <a:spcPts val="200"/>
+              </a:spcAft>
+              <a:buNone/>
+            </a:pPr>
+            <a:r>
+              <a:rPr lang="en-US" sz="850" dirty="0">
+                <a:solidFill>
+                  <a:srgbClr val="666666"/>
+                </a:solidFill>
+                <a:latin typeface="Arial" pitchFamily="34" charset="0"/>
+                <a:ea typeface="Arial" pitchFamily="34" charset="-122"/>
+                <a:cs typeface="Arial" pitchFamily="34" charset="-120"/>
+              </a:rPr>
+              <a:t>  —  </a:t>
+            </a:r>
+            <a:pPr indent="0" marL="0">
+              <a:spcAft>
+                <a:spcPts val="200"/>
+              </a:spcAft>
+              <a:buNone/>
+            </a:pPr>
+            <a:r>
+              <a:rPr lang="en-US" sz="850" i="1" dirty="0">
+                <a:solidFill>
+                  <a:srgbClr val="666666"/>
+                </a:solidFill>
+                <a:latin typeface="Arial" pitchFamily="34" charset="0"/>
+                <a:ea typeface="Arial" pitchFamily="34" charset="-122"/>
+                <a:cs typeface="Arial" pitchFamily="34" charset="-120"/>
+              </a:rPr>
+              <a:t>TrendForce; TSMC CoWoS capacity disclosures</a:t>
             </a:r>
             <a:endParaRPr lang="en-US" sz="850" dirty="0"/>
           </a:p>
@@ -35604,7 +35519,7 @@
                 <a:ea typeface="Arial Black" pitchFamily="34" charset="-122"/>
                 <a:cs typeface="Arial Black" pitchFamily="34" charset="-120"/>
               </a:rPr>
-              <a:t>Logic and memory absorb the capex — ASML and TSMC decide who ships</a:t>
+              <a:t>How an AI chip is made</a:t>
             </a:r>
             <a:endParaRPr lang="en-US" sz="2400" dirty="0"/>
           </a:p>
@@ -35643,7 +35558,7 @@
                 <a:ea typeface="Arial" pitchFamily="34" charset="-122"/>
                 <a:cs typeface="Arial" pitchFamily="34" charset="-120"/>
               </a:rPr>
-              <a:t>Chips pass through four making stages before reaching six product markets. AI capex piles into just two categories — but flows through bottlenecks at every stage.</a:t>
+              <a:t>Every AI accelerator inside a data center, from training GPUs to custom inference silicon, passes through the same four stages.</a:t>
             </a:r>
             <a:endParaRPr lang="en-US" sz="1350" dirty="0"/>
           </a:p>
@@ -35680,15 +35595,155 @@
         </p:nvSpPr>
         <p:spPr>
           <a:xfrm>
-            <a:off x="457200" y="1691640"/>
-            <a:ext cx="8229600" cy="777240"/>
+            <a:off x="457200" y="1554480"/>
+            <a:ext cx="4023360" cy="3931920"/>
           </a:xfrm>
           <a:prstGeom prst="rect">
             <a:avLst/>
           </a:prstGeom>
           <a:solidFill>
-            <a:srgbClr val="F9F9F9"/>
+            <a:srgbClr val="EEEEEE"/>
           </a:solidFill>
+          <a:ln w="9525">
+            <a:solidFill>
+              <a:srgbClr val="BBBBBB"/>
+            </a:solidFill>
+            <a:prstDash val="dash"/>
+          </a:ln>
+        </p:spPr>
+      </p:sp>
+      <p:sp>
+        <p:nvSpPr>
+          <p:cNvPr id="8" name="Text 6"/>
+          <p:cNvSpPr/>
+          <p:nvPr/>
+        </p:nvSpPr>
+        <p:spPr>
+          <a:xfrm>
+            <a:off x="548640" y="1554480"/>
+            <a:ext cx="3840480" cy="3931920"/>
+          </a:xfrm>
+          <a:prstGeom prst="rect">
+            <a:avLst/>
+          </a:prstGeom>
+          <a:noFill/>
+          <a:ln/>
+        </p:spPr>
+        <p:txBody>
+          <a:bodyPr wrap="square" lIns="0" tIns="0" rIns="0" bIns="0" rtlCol="0" anchor="ctr"/>
+          <a:lstStyle/>
+          <a:p>
+            <a:pPr algn="ctr" indent="0" marL="0">
+              <a:buNone/>
+            </a:pPr>
+            <a:r>
+              <a:rPr lang="en-US" sz="1000" i="1" dirty="0">
+                <a:solidFill>
+                  <a:srgbClr val="888888"/>
+                </a:solidFill>
+                <a:latin typeface="Arial" pitchFamily="34" charset="0"/>
+                <a:ea typeface="Arial" pitchFamily="34" charset="-122"/>
+                <a:cs typeface="Arial" pitchFamily="34" charset="-120"/>
+              </a:rPr>
+              <a:t>IMAGE: Photo: AI accelerator package close-up, NVIDIA H100/H200 or Blackwell style. Large central logic die surrounded by HBM memory stacks on a CoWoS substrate, gold contact pads visible, dramatic studio lighting on dark backdrop, square framing.</a:t>
+            </a:r>
+            <a:endParaRPr lang="en-US" sz="1000" dirty="0"/>
+          </a:p>
+        </p:txBody>
+      </p:sp>
+      <p:sp>
+        <p:nvSpPr>
+          <p:cNvPr id="9" name="Text 7"/>
+          <p:cNvSpPr/>
+          <p:nvPr/>
+        </p:nvSpPr>
+        <p:spPr>
+          <a:xfrm>
+            <a:off x="457200" y="5559552"/>
+            <a:ext cx="4023360" cy="274320"/>
+          </a:xfrm>
+          <a:prstGeom prst="rect">
+            <a:avLst/>
+          </a:prstGeom>
+          <a:noFill/>
+          <a:ln/>
+        </p:spPr>
+        <p:txBody>
+          <a:bodyPr wrap="square" lIns="0" tIns="0" rIns="0" bIns="0" rtlCol="0" anchor="t"/>
+          <a:lstStyle/>
+          <a:p>
+            <a:pPr indent="0" marL="0">
+              <a:buNone/>
+            </a:pPr>
+            <a:r>
+              <a:rPr lang="en-US" sz="800" i="1" dirty="0">
+                <a:solidFill>
+                  <a:srgbClr val="666666"/>
+                </a:solidFill>
+                <a:latin typeface="Arial" pitchFamily="34" charset="0"/>
+                <a:ea typeface="Arial" pitchFamily="34" charset="-122"/>
+                <a:cs typeface="Arial" pitchFamily="34" charset="-120"/>
+              </a:rPr>
+              <a:t>An AI accelerator package: a large logic die surrounded by HBM memory stacks on a CoWoS substrate.</a:t>
+            </a:r>
+            <a:endParaRPr lang="en-US" sz="800" dirty="0"/>
+          </a:p>
+        </p:txBody>
+      </p:sp>
+      <p:sp>
+        <p:nvSpPr>
+          <p:cNvPr id="10" name="Text 8"/>
+          <p:cNvSpPr/>
+          <p:nvPr/>
+        </p:nvSpPr>
+        <p:spPr>
+          <a:xfrm>
+            <a:off x="4617720" y="1554480"/>
+            <a:ext cx="4069080" cy="219456"/>
+          </a:xfrm>
+          <a:prstGeom prst="rect">
+            <a:avLst/>
+          </a:prstGeom>
+          <a:noFill/>
+          <a:ln/>
+        </p:spPr>
+        <p:txBody>
+          <a:bodyPr wrap="square" lIns="0" tIns="0" rIns="0" bIns="0" rtlCol="0" anchor="ctr"/>
+          <a:lstStyle/>
+          <a:p>
+            <a:pPr indent="0" marL="0">
+              <a:buNone/>
+            </a:pPr>
+            <a:r>
+              <a:rPr lang="en-US" sz="900" b="1" spc="200" kern="0" dirty="0">
+                <a:solidFill>
+                  <a:srgbClr val="666666"/>
+                </a:solidFill>
+                <a:latin typeface="Arial" pitchFamily="34" charset="0"/>
+                <a:ea typeface="Arial" pitchFamily="34" charset="-122"/>
+                <a:cs typeface="Arial" pitchFamily="34" charset="-120"/>
+              </a:rPr>
+              <a:t>THE FOUR STAGES</a:t>
+            </a:r>
+            <a:endParaRPr lang="en-US" sz="900" dirty="0"/>
+          </a:p>
+        </p:txBody>
+      </p:sp>
+      <p:sp>
+        <p:nvSpPr>
+          <p:cNvPr id="11" name="Shape 9"/>
+          <p:cNvSpPr/>
+          <p:nvPr/>
+        </p:nvSpPr>
+        <p:spPr>
+          <a:xfrm>
+            <a:off x="4617720" y="1783080"/>
+            <a:ext cx="4069080" cy="0"/>
+          </a:xfrm>
+          <a:prstGeom prst="line">
+            <a:avLst/>
+          </a:prstGeom>
+          <a:noFill/>
           <a:ln w="6350">
             <a:solidFill>
               <a:srgbClr val="E5E5E5"/>
@@ -35699,14 +35754,14 @@
       </p:sp>
       <p:sp>
         <p:nvSpPr>
-          <p:cNvPr id="8" name="Shape 6"/>
-          <p:cNvSpPr/>
-          <p:nvPr/>
-        </p:nvSpPr>
-        <p:spPr>
-          <a:xfrm>
-            <a:off x="640080" y="1792224"/>
-            <a:ext cx="128016" cy="128016"/>
+          <p:cNvPr id="12" name="Shape 10"/>
+          <p:cNvSpPr/>
+          <p:nvPr/>
+        </p:nvSpPr>
+        <p:spPr>
+          <a:xfrm>
+            <a:off x="4617720" y="1911096"/>
+            <a:ext cx="384048" cy="384048"/>
           </a:xfrm>
           <a:prstGeom prst="ellipse">
             <a:avLst/>
@@ -35724,14 +35779,14 @@
       </p:sp>
       <p:sp>
         <p:nvSpPr>
-          <p:cNvPr id="9" name="Text 7"/>
-          <p:cNvSpPr/>
-          <p:nvPr/>
-        </p:nvSpPr>
-        <p:spPr>
-          <a:xfrm>
-            <a:off x="822960" y="1709928"/>
-            <a:ext cx="1600200" cy="237744"/>
+          <p:cNvPr id="13" name="Text 11"/>
+          <p:cNvSpPr/>
+          <p:nvPr/>
+        </p:nvSpPr>
+        <p:spPr>
+          <a:xfrm>
+            <a:off x="4617720" y="1911096"/>
+            <a:ext cx="384048" cy="384048"/>
           </a:xfrm>
           <a:prstGeom prst="rect">
             <a:avLst/>
@@ -35743,11 +35798,50 @@
           <a:bodyPr wrap="square" lIns="0" tIns="0" rIns="0" bIns="0" rtlCol="0" anchor="ctr"/>
           <a:lstStyle/>
           <a:p>
-            <a:pPr indent="0" marL="0">
-              <a:buNone/>
-            </a:pPr>
-            <a:r>
-              <a:rPr lang="en-US" sz="1100" b="1" spc="200" kern="0" dirty="0">
+            <a:pPr algn="ctr" indent="0" marL="0">
+              <a:buNone/>
+            </a:pPr>
+            <a:r>
+              <a:rPr lang="en-US" sz="1100" b="1" dirty="0">
+                <a:solidFill>
+                  <a:srgbClr val="FFFFFF"/>
+                </a:solidFill>
+                <a:latin typeface="Arial Black" pitchFamily="34" charset="0"/>
+                <a:ea typeface="Arial Black" pitchFamily="34" charset="-122"/>
+                <a:cs typeface="Arial Black" pitchFamily="34" charset="-120"/>
+              </a:rPr>
+              <a:t>01</a:t>
+            </a:r>
+            <a:endParaRPr lang="en-US" sz="1100" dirty="0"/>
+          </a:p>
+        </p:txBody>
+      </p:sp>
+      <p:sp>
+        <p:nvSpPr>
+          <p:cNvPr id="14" name="Text 12"/>
+          <p:cNvSpPr/>
+          <p:nvPr/>
+        </p:nvSpPr>
+        <p:spPr>
+          <a:xfrm>
+            <a:off x="5166360" y="1874520"/>
+            <a:ext cx="3520440" cy="274320"/>
+          </a:xfrm>
+          <a:prstGeom prst="rect">
+            <a:avLst/>
+          </a:prstGeom>
+          <a:noFill/>
+          <a:ln/>
+        </p:spPr>
+        <p:txBody>
+          <a:bodyPr wrap="square" lIns="0" tIns="0" rIns="0" bIns="0" rtlCol="0" anchor="ctr"/>
+          <a:lstStyle/>
+          <a:p>
+            <a:pPr indent="0" marL="0">
+              <a:buNone/>
+            </a:pPr>
+            <a:r>
+              <a:rPr lang="en-US" sz="1300" b="1" spc="150" kern="0" dirty="0">
                 <a:solidFill>
                   <a:srgbClr val="000000"/>
                 </a:solidFill>
@@ -35757,36 +35851,75 @@
               </a:rPr>
               <a:t>DESIGN</a:t>
             </a:r>
-            <a:endParaRPr lang="en-US" sz="1100" dirty="0"/>
-          </a:p>
-        </p:txBody>
-      </p:sp>
-      <p:sp>
-        <p:nvSpPr>
-          <p:cNvPr id="10" name="Text 8"/>
-          <p:cNvSpPr/>
-          <p:nvPr/>
-        </p:nvSpPr>
-        <p:spPr>
-          <a:xfrm>
-            <a:off x="640080" y="1947672"/>
-            <a:ext cx="1783080" cy="182880"/>
-          </a:xfrm>
-          <a:prstGeom prst="rect">
-            <a:avLst/>
-          </a:prstGeom>
-          <a:noFill/>
-          <a:ln/>
-        </p:spPr>
-        <p:txBody>
-          <a:bodyPr wrap="square" lIns="0" tIns="0" rIns="0" bIns="0" rtlCol="0" anchor="ctr"/>
-          <a:lstStyle/>
-          <a:p>
-            <a:pPr indent="0" marL="0">
-              <a:buNone/>
-            </a:pPr>
-            <a:r>
-              <a:rPr lang="en-US" sz="950" i="1" dirty="0">
+            <a:endParaRPr lang="en-US" sz="1300" dirty="0"/>
+          </a:p>
+        </p:txBody>
+      </p:sp>
+      <p:sp>
+        <p:nvSpPr>
+          <p:cNvPr id="15" name="Text 13"/>
+          <p:cNvSpPr/>
+          <p:nvPr/>
+        </p:nvSpPr>
+        <p:spPr>
+          <a:xfrm>
+            <a:off x="5166360" y="2148840"/>
+            <a:ext cx="3520440" cy="457200"/>
+          </a:xfrm>
+          <a:prstGeom prst="rect">
+            <a:avLst/>
+          </a:prstGeom>
+          <a:noFill/>
+          <a:ln/>
+        </p:spPr>
+        <p:txBody>
+          <a:bodyPr wrap="square" lIns="0" tIns="0" rIns="0" bIns="0" rtlCol="0" anchor="t"/>
+          <a:lstStyle/>
+          <a:p>
+            <a:pPr indent="0" marL="0">
+              <a:buNone/>
+            </a:pPr>
+            <a:r>
+              <a:rPr lang="en-US" sz="1050" dirty="0">
+                <a:solidFill>
+                  <a:srgbClr val="333333"/>
+                </a:solidFill>
+                <a:latin typeface="Arial" pitchFamily="34" charset="0"/>
+                <a:ea typeface="Arial" pitchFamily="34" charset="-122"/>
+                <a:cs typeface="Arial" pitchFamily="34" charset="-120"/>
+              </a:rPr>
+              <a:t>Engineers blueprint the AI chip's tens of billions of transistors in software.</a:t>
+            </a:r>
+            <a:endParaRPr lang="en-US" sz="1050" dirty="0"/>
+          </a:p>
+        </p:txBody>
+      </p:sp>
+      <p:sp>
+        <p:nvSpPr>
+          <p:cNvPr id="16" name="Text 14"/>
+          <p:cNvSpPr/>
+          <p:nvPr/>
+        </p:nvSpPr>
+        <p:spPr>
+          <a:xfrm>
+            <a:off x="5166360" y="2587752"/>
+            <a:ext cx="3520440" cy="182880"/>
+          </a:xfrm>
+          <a:prstGeom prst="rect">
+            <a:avLst/>
+          </a:prstGeom>
+          <a:noFill/>
+          <a:ln/>
+        </p:spPr>
+        <p:txBody>
+          <a:bodyPr wrap="square" lIns="0" tIns="0" rIns="0" bIns="0" rtlCol="0" anchor="t"/>
+          <a:lstStyle/>
+          <a:p>
+            <a:pPr indent="0" marL="0">
+              <a:buNone/>
+            </a:pPr>
+            <a:r>
+              <a:rPr lang="en-US" sz="900" i="1" dirty="0">
                 <a:solidFill>
                   <a:srgbClr val="666666"/>
                 </a:solidFill>
@@ -35794,22 +35927,22 @@
                 <a:ea typeface="Arial" pitchFamily="34" charset="-122"/>
                 <a:cs typeface="Arial" pitchFamily="34" charset="-120"/>
               </a:rPr>
-              <a:t>architects the chip</a:t>
-            </a:r>
-            <a:endParaRPr lang="en-US" sz="950" dirty="0"/>
-          </a:p>
-        </p:txBody>
-      </p:sp>
-      <p:sp>
-        <p:nvSpPr>
-          <p:cNvPr id="11" name="Shape 9"/>
-          <p:cNvSpPr/>
-          <p:nvPr/>
-        </p:nvSpPr>
-        <p:spPr>
-          <a:xfrm>
-            <a:off x="658368" y="2148840"/>
-            <a:ext cx="1600200" cy="0"/>
+              <a:t>NVIDIA · AMD · Broadcom · Google TPU</a:t>
+            </a:r>
+            <a:endParaRPr lang="en-US" sz="900" dirty="0"/>
+          </a:p>
+        </p:txBody>
+      </p:sp>
+      <p:sp>
+        <p:nvSpPr>
+          <p:cNvPr id="17" name="Shape 15"/>
+          <p:cNvSpPr/>
+          <p:nvPr/>
+        </p:nvSpPr>
+        <p:spPr>
+          <a:xfrm>
+            <a:off x="4617720" y="2816352"/>
+            <a:ext cx="4069080" cy="0"/>
           </a:xfrm>
           <a:prstGeom prst="line">
             <a:avLst/>
@@ -35825,92 +35958,14 @@
       </p:sp>
       <p:sp>
         <p:nvSpPr>
-          <p:cNvPr id="12" name="Text 10"/>
-          <p:cNvSpPr/>
-          <p:nvPr/>
-        </p:nvSpPr>
-        <p:spPr>
-          <a:xfrm>
-            <a:off x="640080" y="2167128"/>
-            <a:ext cx="1783080" cy="292608"/>
-          </a:xfrm>
-          <a:prstGeom prst="rect">
-            <a:avLst/>
-          </a:prstGeom>
-          <a:noFill/>
-          <a:ln/>
-        </p:spPr>
-        <p:txBody>
-          <a:bodyPr wrap="square" lIns="0" tIns="0" rIns="0" bIns="0" rtlCol="0" anchor="t"/>
-          <a:lstStyle/>
-          <a:p>
-            <a:pPr indent="0" marL="0">
-              <a:buNone/>
-            </a:pPr>
-            <a:r>
-              <a:rPr lang="en-US" sz="850" dirty="0">
-                <a:solidFill>
-                  <a:srgbClr val="333333"/>
-                </a:solidFill>
-                <a:latin typeface="Arial" pitchFamily="34" charset="0"/>
-                <a:ea typeface="Arial" pitchFamily="34" charset="-122"/>
-                <a:cs typeface="Arial" pitchFamily="34" charset="-120"/>
-              </a:rPr>
-              <a:t>NVIDIA · Apple · AMD · Broadcom</a:t>
-            </a:r>
-            <a:endParaRPr lang="en-US" sz="850" dirty="0"/>
-          </a:p>
-        </p:txBody>
-      </p:sp>
-      <p:sp>
-        <p:nvSpPr>
-          <p:cNvPr id="13" name="Text 11"/>
-          <p:cNvSpPr/>
-          <p:nvPr/>
-        </p:nvSpPr>
-        <p:spPr>
-          <a:xfrm>
-            <a:off x="2359152" y="1897380"/>
-            <a:ext cx="219456" cy="365760"/>
-          </a:xfrm>
-          <a:prstGeom prst="rect">
-            <a:avLst/>
-          </a:prstGeom>
-          <a:noFill/>
-          <a:ln/>
-        </p:spPr>
-        <p:txBody>
-          <a:bodyPr wrap="square" lIns="0" tIns="0" rIns="0" bIns="0" rtlCol="0" anchor="ctr"/>
-          <a:lstStyle/>
-          <a:p>
-            <a:pPr algn="ctr" indent="0" marL="0">
-              <a:buNone/>
-            </a:pPr>
-            <a:r>
-              <a:rPr lang="en-US" sz="2400" b="1" dirty="0">
-                <a:solidFill>
-                  <a:srgbClr val="666666"/>
-                </a:solidFill>
-                <a:latin typeface="Arial" pitchFamily="34" charset="0"/>
-                <a:ea typeface="Arial" pitchFamily="34" charset="-122"/>
-                <a:cs typeface="Arial" pitchFamily="34" charset="-120"/>
-              </a:rPr>
-              <a:t>›</a:t>
-            </a:r>
-            <a:endParaRPr lang="en-US" sz="2400" dirty="0"/>
-          </a:p>
-        </p:txBody>
-      </p:sp>
-      <p:sp>
-        <p:nvSpPr>
-          <p:cNvPr id="14" name="Shape 12"/>
-          <p:cNvSpPr/>
-          <p:nvPr/>
-        </p:nvSpPr>
-        <p:spPr>
-          <a:xfrm>
-            <a:off x="2697480" y="1792224"/>
-            <a:ext cx="128016" cy="128016"/>
+          <p:cNvPr id="18" name="Shape 16"/>
+          <p:cNvSpPr/>
+          <p:nvPr/>
+        </p:nvSpPr>
+        <p:spPr>
+          <a:xfrm>
+            <a:off x="4617720" y="2871216"/>
+            <a:ext cx="384048" cy="384048"/>
           </a:xfrm>
           <a:prstGeom prst="ellipse">
             <a:avLst/>
@@ -35928,14 +35983,14 @@
       </p:sp>
       <p:sp>
         <p:nvSpPr>
-          <p:cNvPr id="15" name="Text 13"/>
-          <p:cNvSpPr/>
-          <p:nvPr/>
-        </p:nvSpPr>
-        <p:spPr>
-          <a:xfrm>
-            <a:off x="2880360" y="1709928"/>
-            <a:ext cx="1600200" cy="237744"/>
+          <p:cNvPr id="19" name="Text 17"/>
+          <p:cNvSpPr/>
+          <p:nvPr/>
+        </p:nvSpPr>
+        <p:spPr>
+          <a:xfrm>
+            <a:off x="4617720" y="2871216"/>
+            <a:ext cx="384048" cy="384048"/>
           </a:xfrm>
           <a:prstGeom prst="rect">
             <a:avLst/>
@@ -35947,11 +36002,50 @@
           <a:bodyPr wrap="square" lIns="0" tIns="0" rIns="0" bIns="0" rtlCol="0" anchor="ctr"/>
           <a:lstStyle/>
           <a:p>
-            <a:pPr indent="0" marL="0">
-              <a:buNone/>
-            </a:pPr>
-            <a:r>
-              <a:rPr lang="en-US" sz="1100" b="1" spc="200" kern="0" dirty="0">
+            <a:pPr algn="ctr" indent="0" marL="0">
+              <a:buNone/>
+            </a:pPr>
+            <a:r>
+              <a:rPr lang="en-US" sz="1100" b="1" dirty="0">
+                <a:solidFill>
+                  <a:srgbClr val="FFFFFF"/>
+                </a:solidFill>
+                <a:latin typeface="Arial Black" pitchFamily="34" charset="0"/>
+                <a:ea typeface="Arial Black" pitchFamily="34" charset="-122"/>
+                <a:cs typeface="Arial Black" pitchFamily="34" charset="-120"/>
+              </a:rPr>
+              <a:t>02</a:t>
+            </a:r>
+            <a:endParaRPr lang="en-US" sz="1100" dirty="0"/>
+          </a:p>
+        </p:txBody>
+      </p:sp>
+      <p:sp>
+        <p:nvSpPr>
+          <p:cNvPr id="20" name="Text 18"/>
+          <p:cNvSpPr/>
+          <p:nvPr/>
+        </p:nvSpPr>
+        <p:spPr>
+          <a:xfrm>
+            <a:off x="5166360" y="2834640"/>
+            <a:ext cx="3520440" cy="274320"/>
+          </a:xfrm>
+          <a:prstGeom prst="rect">
+            <a:avLst/>
+          </a:prstGeom>
+          <a:noFill/>
+          <a:ln/>
+        </p:spPr>
+        <p:txBody>
+          <a:bodyPr wrap="square" lIns="0" tIns="0" rIns="0" bIns="0" rtlCol="0" anchor="ctr"/>
+          <a:lstStyle/>
+          <a:p>
+            <a:pPr indent="0" marL="0">
+              <a:buNone/>
+            </a:pPr>
+            <a:r>
+              <a:rPr lang="en-US" sz="1300" b="1" spc="150" kern="0" dirty="0">
                 <a:solidFill>
                   <a:srgbClr val="000000"/>
                 </a:solidFill>
@@ -35961,36 +36055,75 @@
               </a:rPr>
               <a:t>EQUIPMENT</a:t>
             </a:r>
-            <a:endParaRPr lang="en-US" sz="1100" dirty="0"/>
-          </a:p>
-        </p:txBody>
-      </p:sp>
-      <p:sp>
-        <p:nvSpPr>
-          <p:cNvPr id="16" name="Text 14"/>
-          <p:cNvSpPr/>
-          <p:nvPr/>
-        </p:nvSpPr>
-        <p:spPr>
-          <a:xfrm>
-            <a:off x="2697480" y="1947672"/>
-            <a:ext cx="1783080" cy="182880"/>
-          </a:xfrm>
-          <a:prstGeom prst="rect">
-            <a:avLst/>
-          </a:prstGeom>
-          <a:noFill/>
-          <a:ln/>
-        </p:spPr>
-        <p:txBody>
-          <a:bodyPr wrap="square" lIns="0" tIns="0" rIns="0" bIns="0" rtlCol="0" anchor="ctr"/>
-          <a:lstStyle/>
-          <a:p>
-            <a:pPr indent="0" marL="0">
-              <a:buNone/>
-            </a:pPr>
-            <a:r>
-              <a:rPr lang="en-US" sz="950" i="1" dirty="0">
+            <a:endParaRPr lang="en-US" sz="1300" dirty="0"/>
+          </a:p>
+        </p:txBody>
+      </p:sp>
+      <p:sp>
+        <p:nvSpPr>
+          <p:cNvPr id="21" name="Text 19"/>
+          <p:cNvSpPr/>
+          <p:nvPr/>
+        </p:nvSpPr>
+        <p:spPr>
+          <a:xfrm>
+            <a:off x="5166360" y="3108960"/>
+            <a:ext cx="3520440" cy="457200"/>
+          </a:xfrm>
+          <a:prstGeom prst="rect">
+            <a:avLst/>
+          </a:prstGeom>
+          <a:noFill/>
+          <a:ln/>
+        </p:spPr>
+        <p:txBody>
+          <a:bodyPr wrap="square" lIns="0" tIns="0" rIns="0" bIns="0" rtlCol="0" anchor="t"/>
+          <a:lstStyle/>
+          <a:p>
+            <a:pPr indent="0" marL="0">
+              <a:buNone/>
+            </a:pPr>
+            <a:r>
+              <a:rPr lang="en-US" sz="1050" dirty="0">
+                <a:solidFill>
+                  <a:srgbClr val="333333"/>
+                </a:solidFill>
+                <a:latin typeface="Arial" pitchFamily="34" charset="0"/>
+                <a:ea typeface="Arial" pitchFamily="34" charset="-122"/>
+                <a:cs typeface="Arial" pitchFamily="34" charset="-120"/>
+              </a:rPr>
+              <a:t>Specialized tools, especially EUV lithography, are built to print at atomic scale.</a:t>
+            </a:r>
+            <a:endParaRPr lang="en-US" sz="1050" dirty="0"/>
+          </a:p>
+        </p:txBody>
+      </p:sp>
+      <p:sp>
+        <p:nvSpPr>
+          <p:cNvPr id="22" name="Text 20"/>
+          <p:cNvSpPr/>
+          <p:nvPr/>
+        </p:nvSpPr>
+        <p:spPr>
+          <a:xfrm>
+            <a:off x="5166360" y="3547872"/>
+            <a:ext cx="3520440" cy="182880"/>
+          </a:xfrm>
+          <a:prstGeom prst="rect">
+            <a:avLst/>
+          </a:prstGeom>
+          <a:noFill/>
+          <a:ln/>
+        </p:spPr>
+        <p:txBody>
+          <a:bodyPr wrap="square" lIns="0" tIns="0" rIns="0" bIns="0" rtlCol="0" anchor="t"/>
+          <a:lstStyle/>
+          <a:p>
+            <a:pPr indent="0" marL="0">
+              <a:buNone/>
+            </a:pPr>
+            <a:r>
+              <a:rPr lang="en-US" sz="900" i="1" dirty="0">
                 <a:solidFill>
                   <a:srgbClr val="666666"/>
                 </a:solidFill>
@@ -35998,22 +36131,22 @@
                 <a:ea typeface="Arial" pitchFamily="34" charset="-122"/>
                 <a:cs typeface="Arial" pitchFamily="34" charset="-120"/>
               </a:rPr>
-              <a:t>builds the tools</a:t>
-            </a:r>
-            <a:endParaRPr lang="en-US" sz="950" dirty="0"/>
-          </a:p>
-        </p:txBody>
-      </p:sp>
-      <p:sp>
-        <p:nvSpPr>
-          <p:cNvPr id="17" name="Shape 15"/>
-          <p:cNvSpPr/>
-          <p:nvPr/>
-        </p:nvSpPr>
-        <p:spPr>
-          <a:xfrm>
-            <a:off x="2715768" y="2148840"/>
-            <a:ext cx="1600200" cy="0"/>
+              <a:t>ASML · Applied Materials · Lam · KLA</a:t>
+            </a:r>
+            <a:endParaRPr lang="en-US" sz="900" dirty="0"/>
+          </a:p>
+        </p:txBody>
+      </p:sp>
+      <p:sp>
+        <p:nvSpPr>
+          <p:cNvPr id="23" name="Shape 21"/>
+          <p:cNvSpPr/>
+          <p:nvPr/>
+        </p:nvSpPr>
+        <p:spPr>
+          <a:xfrm>
+            <a:off x="4617720" y="3776472"/>
+            <a:ext cx="4069080" cy="0"/>
           </a:xfrm>
           <a:prstGeom prst="line">
             <a:avLst/>
@@ -36029,102 +36162,24 @@
       </p:sp>
       <p:sp>
         <p:nvSpPr>
-          <p:cNvPr id="18" name="Text 16"/>
-          <p:cNvSpPr/>
-          <p:nvPr/>
-        </p:nvSpPr>
-        <p:spPr>
-          <a:xfrm>
-            <a:off x="2697480" y="2167128"/>
-            <a:ext cx="1783080" cy="292608"/>
-          </a:xfrm>
-          <a:prstGeom prst="rect">
-            <a:avLst/>
-          </a:prstGeom>
-          <a:noFill/>
-          <a:ln/>
-        </p:spPr>
-        <p:txBody>
-          <a:bodyPr wrap="square" lIns="0" tIns="0" rIns="0" bIns="0" rtlCol="0" anchor="t"/>
-          <a:lstStyle/>
-          <a:p>
-            <a:pPr indent="0" marL="0">
-              <a:buNone/>
-            </a:pPr>
-            <a:r>
-              <a:rPr lang="en-US" sz="850" dirty="0">
-                <a:solidFill>
-                  <a:srgbClr val="333333"/>
-                </a:solidFill>
-                <a:latin typeface="Arial" pitchFamily="34" charset="0"/>
-                <a:ea typeface="Arial" pitchFamily="34" charset="-122"/>
-                <a:cs typeface="Arial" pitchFamily="34" charset="-120"/>
-              </a:rPr>
-              <a:t>ASML · Applied Materials · Lam · KLA</a:t>
-            </a:r>
-            <a:endParaRPr lang="en-US" sz="850" dirty="0"/>
-          </a:p>
-        </p:txBody>
-      </p:sp>
-      <p:sp>
-        <p:nvSpPr>
-          <p:cNvPr id="19" name="Text 17"/>
-          <p:cNvSpPr/>
-          <p:nvPr/>
-        </p:nvSpPr>
-        <p:spPr>
-          <a:xfrm>
-            <a:off x="4416552" y="1897380"/>
-            <a:ext cx="219456" cy="365760"/>
-          </a:xfrm>
-          <a:prstGeom prst="rect">
-            <a:avLst/>
-          </a:prstGeom>
-          <a:noFill/>
-          <a:ln/>
-        </p:spPr>
-        <p:txBody>
-          <a:bodyPr wrap="square" lIns="0" tIns="0" rIns="0" bIns="0" rtlCol="0" anchor="ctr"/>
-          <a:lstStyle/>
-          <a:p>
-            <a:pPr algn="ctr" indent="0" marL="0">
-              <a:buNone/>
-            </a:pPr>
-            <a:r>
-              <a:rPr lang="en-US" sz="2400" b="1" dirty="0">
-                <a:solidFill>
-                  <a:srgbClr val="666666"/>
-                </a:solidFill>
-                <a:latin typeface="Arial" pitchFamily="34" charset="0"/>
-                <a:ea typeface="Arial" pitchFamily="34" charset="-122"/>
-                <a:cs typeface="Arial" pitchFamily="34" charset="-120"/>
-              </a:rPr>
-              <a:t>›</a:t>
-            </a:r>
-            <a:endParaRPr lang="en-US" sz="2400" dirty="0"/>
-          </a:p>
-        </p:txBody>
-      </p:sp>
-      <p:sp>
-        <p:nvSpPr>
-          <p:cNvPr id="20" name="Shape 18"/>
-          <p:cNvSpPr/>
-          <p:nvPr/>
-        </p:nvSpPr>
-        <p:spPr>
-          <a:xfrm>
-            <a:off x="4754880" y="1792224"/>
-            <a:ext cx="128016" cy="128016"/>
+          <p:cNvPr id="24" name="Shape 22"/>
+          <p:cNvSpPr/>
+          <p:nvPr/>
+        </p:nvSpPr>
+        <p:spPr>
+          <a:xfrm>
+            <a:off x="4617720" y="3831336"/>
+            <a:ext cx="384048" cy="384048"/>
           </a:xfrm>
           <a:prstGeom prst="ellipse">
             <a:avLst/>
           </a:prstGeom>
           <a:solidFill>
-            <a:srgbClr val="333333"/>
+            <a:srgbClr val="008B8B"/>
           </a:solidFill>
           <a:ln w="12700">
             <a:solidFill>
-              <a:srgbClr val="333333"/>
+              <a:srgbClr val="008B8B"/>
             </a:solidFill>
             <a:prstDash val="solid"/>
           </a:ln>
@@ -36132,14 +36187,14 @@
       </p:sp>
       <p:sp>
         <p:nvSpPr>
-          <p:cNvPr id="21" name="Text 19"/>
-          <p:cNvSpPr/>
-          <p:nvPr/>
-        </p:nvSpPr>
-        <p:spPr>
-          <a:xfrm>
-            <a:off x="4937760" y="1709928"/>
-            <a:ext cx="1600200" cy="237744"/>
+          <p:cNvPr id="25" name="Text 23"/>
+          <p:cNvSpPr/>
+          <p:nvPr/>
+        </p:nvSpPr>
+        <p:spPr>
+          <a:xfrm>
+            <a:off x="4617720" y="3831336"/>
+            <a:ext cx="384048" cy="384048"/>
           </a:xfrm>
           <a:prstGeom prst="rect">
             <a:avLst/>
@@ -36151,11 +36206,50 @@
           <a:bodyPr wrap="square" lIns="0" tIns="0" rIns="0" bIns="0" rtlCol="0" anchor="ctr"/>
           <a:lstStyle/>
           <a:p>
-            <a:pPr indent="0" marL="0">
-              <a:buNone/>
-            </a:pPr>
-            <a:r>
-              <a:rPr lang="en-US" sz="1100" b="1" spc="200" kern="0" dirty="0">
+            <a:pPr algn="ctr" indent="0" marL="0">
+              <a:buNone/>
+            </a:pPr>
+            <a:r>
+              <a:rPr lang="en-US" sz="1100" b="1" dirty="0">
+                <a:solidFill>
+                  <a:srgbClr val="FFFFFF"/>
+                </a:solidFill>
+                <a:latin typeface="Arial Black" pitchFamily="34" charset="0"/>
+                <a:ea typeface="Arial Black" pitchFamily="34" charset="-122"/>
+                <a:cs typeface="Arial Black" pitchFamily="34" charset="-120"/>
+              </a:rPr>
+              <a:t>03</a:t>
+            </a:r>
+            <a:endParaRPr lang="en-US" sz="1100" dirty="0"/>
+          </a:p>
+        </p:txBody>
+      </p:sp>
+      <p:sp>
+        <p:nvSpPr>
+          <p:cNvPr id="26" name="Text 24"/>
+          <p:cNvSpPr/>
+          <p:nvPr/>
+        </p:nvSpPr>
+        <p:spPr>
+          <a:xfrm>
+            <a:off x="5166360" y="3794760"/>
+            <a:ext cx="3520440" cy="274320"/>
+          </a:xfrm>
+          <a:prstGeom prst="rect">
+            <a:avLst/>
+          </a:prstGeom>
+          <a:noFill/>
+          <a:ln/>
+        </p:spPr>
+        <p:txBody>
+          <a:bodyPr wrap="square" lIns="0" tIns="0" rIns="0" bIns="0" rtlCol="0" anchor="ctr"/>
+          <a:lstStyle/>
+          <a:p>
+            <a:pPr indent="0" marL="0">
+              <a:buNone/>
+            </a:pPr>
+            <a:r>
+              <a:rPr lang="en-US" sz="1300" b="1" spc="150" kern="0" dirty="0">
                 <a:solidFill>
                   <a:srgbClr val="000000"/>
                 </a:solidFill>
@@ -36163,38 +36257,77 @@
                 <a:ea typeface="Arial" pitchFamily="34" charset="-122"/>
                 <a:cs typeface="Arial" pitchFamily="34" charset="-120"/>
               </a:rPr>
-              <a:t>FOUNDRY</a:t>
-            </a:r>
-            <a:endParaRPr lang="en-US" sz="1100" dirty="0"/>
-          </a:p>
-        </p:txBody>
-      </p:sp>
-      <p:sp>
-        <p:nvSpPr>
-          <p:cNvPr id="22" name="Text 20"/>
-          <p:cNvSpPr/>
-          <p:nvPr/>
-        </p:nvSpPr>
-        <p:spPr>
-          <a:xfrm>
-            <a:off x="4754880" y="1947672"/>
-            <a:ext cx="1783080" cy="182880"/>
-          </a:xfrm>
-          <a:prstGeom prst="rect">
-            <a:avLst/>
-          </a:prstGeom>
-          <a:noFill/>
-          <a:ln/>
-        </p:spPr>
-        <p:txBody>
-          <a:bodyPr wrap="square" lIns="0" tIns="0" rIns="0" bIns="0" rtlCol="0" anchor="ctr"/>
-          <a:lstStyle/>
-          <a:p>
-            <a:pPr indent="0" marL="0">
-              <a:buNone/>
-            </a:pPr>
-            <a:r>
-              <a:rPr lang="en-US" sz="950" i="1" dirty="0">
+              <a:t>FABRICATION</a:t>
+            </a:r>
+            <a:endParaRPr lang="en-US" sz="1300" dirty="0"/>
+          </a:p>
+        </p:txBody>
+      </p:sp>
+      <p:sp>
+        <p:nvSpPr>
+          <p:cNvPr id="27" name="Text 25"/>
+          <p:cNvSpPr/>
+          <p:nvPr/>
+        </p:nvSpPr>
+        <p:spPr>
+          <a:xfrm>
+            <a:off x="5166360" y="4069080"/>
+            <a:ext cx="3520440" cy="457200"/>
+          </a:xfrm>
+          <a:prstGeom prst="rect">
+            <a:avLst/>
+          </a:prstGeom>
+          <a:noFill/>
+          <a:ln/>
+        </p:spPr>
+        <p:txBody>
+          <a:bodyPr wrap="square" lIns="0" tIns="0" rIns="0" bIns="0" rtlCol="0" anchor="t"/>
+          <a:lstStyle/>
+          <a:p>
+            <a:pPr indent="0" marL="0">
+              <a:buNone/>
+            </a:pPr>
+            <a:r>
+              <a:rPr lang="en-US" sz="1050" dirty="0">
+                <a:solidFill>
+                  <a:srgbClr val="333333"/>
+                </a:solidFill>
+                <a:latin typeface="Arial" pitchFamily="34" charset="0"/>
+                <a:ea typeface="Arial" pitchFamily="34" charset="-122"/>
+                <a:cs typeface="Arial" pitchFamily="34" charset="-120"/>
+              </a:rPr>
+              <a:t>Inside a $20B fab, silicon wafers are processed through 1,000+ steps.</a:t>
+            </a:r>
+            <a:endParaRPr lang="en-US" sz="1050" dirty="0"/>
+          </a:p>
+        </p:txBody>
+      </p:sp>
+      <p:sp>
+        <p:nvSpPr>
+          <p:cNvPr id="28" name="Text 26"/>
+          <p:cNvSpPr/>
+          <p:nvPr/>
+        </p:nvSpPr>
+        <p:spPr>
+          <a:xfrm>
+            <a:off x="5166360" y="4507992"/>
+            <a:ext cx="3520440" cy="182880"/>
+          </a:xfrm>
+          <a:prstGeom prst="rect">
+            <a:avLst/>
+          </a:prstGeom>
+          <a:noFill/>
+          <a:ln/>
+        </p:spPr>
+        <p:txBody>
+          <a:bodyPr wrap="square" lIns="0" tIns="0" rIns="0" bIns="0" rtlCol="0" anchor="t"/>
+          <a:lstStyle/>
+          <a:p>
+            <a:pPr indent="0" marL="0">
+              <a:buNone/>
+            </a:pPr>
+            <a:r>
+              <a:rPr lang="en-US" sz="900" i="1" dirty="0">
                 <a:solidFill>
                   <a:srgbClr val="666666"/>
                 </a:solidFill>
@@ -36202,22 +36335,22 @@
                 <a:ea typeface="Arial" pitchFamily="34" charset="-122"/>
                 <a:cs typeface="Arial" pitchFamily="34" charset="-120"/>
               </a:rPr>
-              <a:t>prints the wafer</a:t>
-            </a:r>
-            <a:endParaRPr lang="en-US" sz="950" dirty="0"/>
-          </a:p>
-        </p:txBody>
-      </p:sp>
-      <p:sp>
-        <p:nvSpPr>
-          <p:cNvPr id="23" name="Shape 21"/>
-          <p:cNvSpPr/>
-          <p:nvPr/>
-        </p:nvSpPr>
-        <p:spPr>
-          <a:xfrm>
-            <a:off x="4773168" y="2148840"/>
-            <a:ext cx="1600200" cy="0"/>
+              <a:t>TSMC · Samsung · Intel</a:t>
+            </a:r>
+            <a:endParaRPr lang="en-US" sz="900" dirty="0"/>
+          </a:p>
+        </p:txBody>
+      </p:sp>
+      <p:sp>
+        <p:nvSpPr>
+          <p:cNvPr id="29" name="Shape 27"/>
+          <p:cNvSpPr/>
+          <p:nvPr/>
+        </p:nvSpPr>
+        <p:spPr>
+          <a:xfrm>
+            <a:off x="4617720" y="4736592"/>
+            <a:ext cx="4069080" cy="0"/>
           </a:xfrm>
           <a:prstGeom prst="line">
             <a:avLst/>
@@ -36233,14 +36366,117 @@
       </p:sp>
       <p:sp>
         <p:nvSpPr>
-          <p:cNvPr id="24" name="Text 22"/>
-          <p:cNvSpPr/>
-          <p:nvPr/>
-        </p:nvSpPr>
-        <p:spPr>
-          <a:xfrm>
-            <a:off x="4754880" y="2167128"/>
-            <a:ext cx="1783080" cy="292608"/>
+          <p:cNvPr id="30" name="Shape 28"/>
+          <p:cNvSpPr/>
+          <p:nvPr/>
+        </p:nvSpPr>
+        <p:spPr>
+          <a:xfrm>
+            <a:off x="4617720" y="4791456"/>
+            <a:ext cx="384048" cy="384048"/>
+          </a:xfrm>
+          <a:prstGeom prst="ellipse">
+            <a:avLst/>
+          </a:prstGeom>
+          <a:solidFill>
+            <a:srgbClr val="051A3D"/>
+          </a:solidFill>
+          <a:ln w="12700">
+            <a:solidFill>
+              <a:srgbClr val="051A3D"/>
+            </a:solidFill>
+            <a:prstDash val="solid"/>
+          </a:ln>
+        </p:spPr>
+      </p:sp>
+      <p:sp>
+        <p:nvSpPr>
+          <p:cNvPr id="31" name="Text 29"/>
+          <p:cNvSpPr/>
+          <p:nvPr/>
+        </p:nvSpPr>
+        <p:spPr>
+          <a:xfrm>
+            <a:off x="4617720" y="4791456"/>
+            <a:ext cx="384048" cy="384048"/>
+          </a:xfrm>
+          <a:prstGeom prst="rect">
+            <a:avLst/>
+          </a:prstGeom>
+          <a:noFill/>
+          <a:ln/>
+        </p:spPr>
+        <p:txBody>
+          <a:bodyPr wrap="square" lIns="0" tIns="0" rIns="0" bIns="0" rtlCol="0" anchor="ctr"/>
+          <a:lstStyle/>
+          <a:p>
+            <a:pPr algn="ctr" indent="0" marL="0">
+              <a:buNone/>
+            </a:pPr>
+            <a:r>
+              <a:rPr lang="en-US" sz="1100" b="1" dirty="0">
+                <a:solidFill>
+                  <a:srgbClr val="FFFFFF"/>
+                </a:solidFill>
+                <a:latin typeface="Arial Black" pitchFamily="34" charset="0"/>
+                <a:ea typeface="Arial Black" pitchFamily="34" charset="-122"/>
+                <a:cs typeface="Arial Black" pitchFamily="34" charset="-120"/>
+              </a:rPr>
+              <a:t>04</a:t>
+            </a:r>
+            <a:endParaRPr lang="en-US" sz="1100" dirty="0"/>
+          </a:p>
+        </p:txBody>
+      </p:sp>
+      <p:sp>
+        <p:nvSpPr>
+          <p:cNvPr id="32" name="Text 30"/>
+          <p:cNvSpPr/>
+          <p:nvPr/>
+        </p:nvSpPr>
+        <p:spPr>
+          <a:xfrm>
+            <a:off x="5166360" y="4754880"/>
+            <a:ext cx="3520440" cy="274320"/>
+          </a:xfrm>
+          <a:prstGeom prst="rect">
+            <a:avLst/>
+          </a:prstGeom>
+          <a:noFill/>
+          <a:ln/>
+        </p:spPr>
+        <p:txBody>
+          <a:bodyPr wrap="square" lIns="0" tIns="0" rIns="0" bIns="0" rtlCol="0" anchor="ctr"/>
+          <a:lstStyle/>
+          <a:p>
+            <a:pPr indent="0" marL="0">
+              <a:buNone/>
+            </a:pPr>
+            <a:r>
+              <a:rPr lang="en-US" sz="1300" b="1" spc="150" kern="0" dirty="0">
+                <a:solidFill>
+                  <a:srgbClr val="000000"/>
+                </a:solidFill>
+                <a:latin typeface="Arial" pitchFamily="34" charset="0"/>
+                <a:ea typeface="Arial" pitchFamily="34" charset="-122"/>
+                <a:cs typeface="Arial" pitchFamily="34" charset="-120"/>
+              </a:rPr>
+              <a:t>PACKAGING</a:t>
+            </a:r>
+            <a:endParaRPr lang="en-US" sz="1300" dirty="0"/>
+          </a:p>
+        </p:txBody>
+      </p:sp>
+      <p:sp>
+        <p:nvSpPr>
+          <p:cNvPr id="33" name="Text 31"/>
+          <p:cNvSpPr/>
+          <p:nvPr/>
+        </p:nvSpPr>
+        <p:spPr>
+          <a:xfrm>
+            <a:off x="5166360" y="5029200"/>
+            <a:ext cx="3520440" cy="457200"/>
           </a:xfrm>
           <a:prstGeom prst="rect">
             <a:avLst/>
@@ -36256,7 +36492,7 @@
               <a:buNone/>
             </a:pPr>
             <a:r>
-              <a:rPr lang="en-US" sz="850" dirty="0">
+              <a:rPr lang="en-US" sz="1050" dirty="0">
                 <a:solidFill>
                   <a:srgbClr val="333333"/>
                 </a:solidFill>
@@ -36264,38 +36500,38 @@
                 <a:ea typeface="Arial" pitchFamily="34" charset="-122"/>
                 <a:cs typeface="Arial" pitchFamily="34" charset="-120"/>
               </a:rPr>
-              <a:t>TSMC · Samsung · Intel Foundry</a:t>
-            </a:r>
-            <a:endParaRPr lang="en-US" sz="850" dirty="0"/>
-          </a:p>
-        </p:txBody>
-      </p:sp>
-      <p:sp>
-        <p:nvSpPr>
-          <p:cNvPr id="25" name="Text 23"/>
-          <p:cNvSpPr/>
-          <p:nvPr/>
-        </p:nvSpPr>
-        <p:spPr>
-          <a:xfrm>
-            <a:off x="6473952" y="1897380"/>
-            <a:ext cx="219456" cy="365760"/>
-          </a:xfrm>
-          <a:prstGeom prst="rect">
-            <a:avLst/>
-          </a:prstGeom>
-          <a:noFill/>
-          <a:ln/>
-        </p:spPr>
-        <p:txBody>
-          <a:bodyPr wrap="square" lIns="0" tIns="0" rIns="0" bIns="0" rtlCol="0" anchor="ctr"/>
-          <a:lstStyle/>
-          <a:p>
-            <a:pPr algn="ctr" indent="0" marL="0">
-              <a:buNone/>
-            </a:pPr>
-            <a:r>
-              <a:rPr lang="en-US" sz="2400" b="1" dirty="0">
+              <a:t>Logic dies are stacked with HBM memory using advanced packaging like CoWoS.</a:t>
+            </a:r>
+            <a:endParaRPr lang="en-US" sz="1050" dirty="0"/>
+          </a:p>
+        </p:txBody>
+      </p:sp>
+      <p:sp>
+        <p:nvSpPr>
+          <p:cNvPr id="34" name="Text 32"/>
+          <p:cNvSpPr/>
+          <p:nvPr/>
+        </p:nvSpPr>
+        <p:spPr>
+          <a:xfrm>
+            <a:off x="5166360" y="5468112"/>
+            <a:ext cx="3520440" cy="182880"/>
+          </a:xfrm>
+          <a:prstGeom prst="rect">
+            <a:avLst/>
+          </a:prstGeom>
+          <a:noFill/>
+          <a:ln/>
+        </p:spPr>
+        <p:txBody>
+          <a:bodyPr wrap="square" lIns="0" tIns="0" rIns="0" bIns="0" rtlCol="0" anchor="t"/>
+          <a:lstStyle/>
+          <a:p>
+            <a:pPr indent="0" marL="0">
+              <a:buNone/>
+            </a:pPr>
+            <a:r>
+              <a:rPr lang="en-US" sz="900" i="1" dirty="0">
                 <a:solidFill>
                   <a:srgbClr val="666666"/>
                 </a:solidFill>
@@ -36303,24 +36539,63 @@
                 <a:ea typeface="Arial" pitchFamily="34" charset="-122"/>
                 <a:cs typeface="Arial" pitchFamily="34" charset="-120"/>
               </a:rPr>
-              <a:t>›</a:t>
-            </a:r>
-            <a:endParaRPr lang="en-US" sz="2400" dirty="0"/>
-          </a:p>
-        </p:txBody>
-      </p:sp>
-      <p:sp>
-        <p:nvSpPr>
-          <p:cNvPr id="26" name="Shape 24"/>
-          <p:cNvSpPr/>
-          <p:nvPr/>
-        </p:nvSpPr>
-        <p:spPr>
-          <a:xfrm>
-            <a:off x="6812280" y="1792224"/>
-            <a:ext cx="128016" cy="128016"/>
-          </a:xfrm>
-          <a:prstGeom prst="ellipse">
+              <a:t>TSMC CoWoS · ASE · Amkor</a:t>
+            </a:r>
+            <a:endParaRPr lang="en-US" sz="900" dirty="0"/>
+          </a:p>
+        </p:txBody>
+      </p:sp>
+      <p:sp>
+        <p:nvSpPr>
+          <p:cNvPr id="35" name="Text 33"/>
+          <p:cNvSpPr/>
+          <p:nvPr/>
+        </p:nvSpPr>
+        <p:spPr>
+          <a:xfrm>
+            <a:off x="457200" y="5875020"/>
+            <a:ext cx="8229600" cy="320040"/>
+          </a:xfrm>
+          <a:prstGeom prst="rect">
+            <a:avLst/>
+          </a:prstGeom>
+          <a:noFill/>
+          <a:ln/>
+        </p:spPr>
+        <p:txBody>
+          <a:bodyPr wrap="square" lIns="0" tIns="0" rIns="0" bIns="0" rtlCol="0" anchor="t"/>
+          <a:lstStyle/>
+          <a:p>
+            <a:pPr indent="0" marL="0">
+              <a:buNone/>
+            </a:pPr>
+            <a:r>
+              <a:rPr lang="en-US" sz="700" dirty="0">
+                <a:solidFill>
+                  <a:srgbClr val="999999"/>
+                </a:solidFill>
+                <a:latin typeface="Arial" pitchFamily="34" charset="0"/>
+                <a:ea typeface="Arial" pitchFamily="34" charset="-122"/>
+                <a:cs typeface="Arial" pitchFamily="34" charset="-120"/>
+              </a:rPr>
+              <a:t>Source: SIA / SEMI industry taxonomy; SEMI World Fab Forecast; TSMC, NVIDIA, ASML disclosures. Process descriptions are plain-English simplifications.</a:t>
+            </a:r>
+            <a:endParaRPr lang="en-US" sz="700" dirty="0"/>
+          </a:p>
+        </p:txBody>
+      </p:sp>
+      <p:sp>
+        <p:nvSpPr>
+          <p:cNvPr id="36" name="Shape 34"/>
+          <p:cNvSpPr/>
+          <p:nvPr/>
+        </p:nvSpPr>
+        <p:spPr>
+          <a:xfrm>
+            <a:off x="0" y="6286500"/>
+            <a:ext cx="9144000" cy="571500"/>
+          </a:xfrm>
+          <a:prstGeom prst="rect">
             <a:avLst/>
           </a:prstGeom>
           <a:solidFill>
@@ -36336,1649 +36611,7 @@
       </p:sp>
       <p:sp>
         <p:nvSpPr>
-          <p:cNvPr id="27" name="Text 25"/>
-          <p:cNvSpPr/>
-          <p:nvPr/>
-        </p:nvSpPr>
-        <p:spPr>
-          <a:xfrm>
-            <a:off x="6995160" y="1709928"/>
-            <a:ext cx="1600200" cy="237744"/>
-          </a:xfrm>
-          <a:prstGeom prst="rect">
-            <a:avLst/>
-          </a:prstGeom>
-          <a:noFill/>
-          <a:ln/>
-        </p:spPr>
-        <p:txBody>
-          <a:bodyPr wrap="square" lIns="0" tIns="0" rIns="0" bIns="0" rtlCol="0" anchor="ctr"/>
-          <a:lstStyle/>
-          <a:p>
-            <a:pPr indent="0" marL="0">
-              <a:buNone/>
-            </a:pPr>
-            <a:r>
-              <a:rPr lang="en-US" sz="1100" b="1" spc="200" kern="0" dirty="0">
-                <a:solidFill>
-                  <a:srgbClr val="000000"/>
-                </a:solidFill>
-                <a:latin typeface="Arial" pitchFamily="34" charset="0"/>
-                <a:ea typeface="Arial" pitchFamily="34" charset="-122"/>
-                <a:cs typeface="Arial" pitchFamily="34" charset="-120"/>
-              </a:rPr>
-              <a:t>PACKAGING</a:t>
-            </a:r>
-            <a:endParaRPr lang="en-US" sz="1100" dirty="0"/>
-          </a:p>
-        </p:txBody>
-      </p:sp>
-      <p:sp>
-        <p:nvSpPr>
-          <p:cNvPr id="28" name="Text 26"/>
-          <p:cNvSpPr/>
-          <p:nvPr/>
-        </p:nvSpPr>
-        <p:spPr>
-          <a:xfrm>
-            <a:off x="6812280" y="1947672"/>
-            <a:ext cx="1783080" cy="182880"/>
-          </a:xfrm>
-          <a:prstGeom prst="rect">
-            <a:avLst/>
-          </a:prstGeom>
-          <a:noFill/>
-          <a:ln/>
-        </p:spPr>
-        <p:txBody>
-          <a:bodyPr wrap="square" lIns="0" tIns="0" rIns="0" bIns="0" rtlCol="0" anchor="ctr"/>
-          <a:lstStyle/>
-          <a:p>
-            <a:pPr indent="0" marL="0">
-              <a:buNone/>
-            </a:pPr>
-            <a:r>
-              <a:rPr lang="en-US" sz="950" i="1" dirty="0">
-                <a:solidFill>
-                  <a:srgbClr val="666666"/>
-                </a:solidFill>
-                <a:latin typeface="Arial" pitchFamily="34" charset="0"/>
-                <a:ea typeface="Arial" pitchFamily="34" charset="-122"/>
-                <a:cs typeface="Arial" pitchFamily="34" charset="-120"/>
-              </a:rPr>
-              <a:t>stacks the dies</a:t>
-            </a:r>
-            <a:endParaRPr lang="en-US" sz="950" dirty="0"/>
-          </a:p>
-        </p:txBody>
-      </p:sp>
-      <p:sp>
-        <p:nvSpPr>
-          <p:cNvPr id="29" name="Shape 27"/>
-          <p:cNvSpPr/>
-          <p:nvPr/>
-        </p:nvSpPr>
-        <p:spPr>
-          <a:xfrm>
-            <a:off x="6830568" y="2148840"/>
-            <a:ext cx="1600200" cy="0"/>
-          </a:xfrm>
-          <a:prstGeom prst="line">
-            <a:avLst/>
-          </a:prstGeom>
-          <a:noFill/>
-          <a:ln w="6350">
-            <a:solidFill>
-              <a:srgbClr val="E5E5E5"/>
-            </a:solidFill>
-            <a:prstDash val="solid"/>
-          </a:ln>
-        </p:spPr>
-      </p:sp>
-      <p:sp>
-        <p:nvSpPr>
-          <p:cNvPr id="30" name="Text 28"/>
-          <p:cNvSpPr/>
-          <p:nvPr/>
-        </p:nvSpPr>
-        <p:spPr>
-          <a:xfrm>
-            <a:off x="6812280" y="2167128"/>
-            <a:ext cx="1783080" cy="292608"/>
-          </a:xfrm>
-          <a:prstGeom prst="rect">
-            <a:avLst/>
-          </a:prstGeom>
-          <a:noFill/>
-          <a:ln/>
-        </p:spPr>
-        <p:txBody>
-          <a:bodyPr wrap="square" lIns="0" tIns="0" rIns="0" bIns="0" rtlCol="0" anchor="t"/>
-          <a:lstStyle/>
-          <a:p>
-            <a:pPr indent="0" marL="0">
-              <a:buNone/>
-            </a:pPr>
-            <a:r>
-              <a:rPr lang="en-US" sz="850" dirty="0">
-                <a:solidFill>
-                  <a:srgbClr val="333333"/>
-                </a:solidFill>
-                <a:latin typeface="Arial" pitchFamily="34" charset="0"/>
-                <a:ea typeface="Arial" pitchFamily="34" charset="-122"/>
-                <a:cs typeface="Arial" pitchFamily="34" charset="-120"/>
-              </a:rPr>
-              <a:t>TSMC CoWoS · ASE · Amkor</a:t>
-            </a:r>
-            <a:endParaRPr lang="en-US" sz="850" dirty="0"/>
-          </a:p>
-        </p:txBody>
-      </p:sp>
-      <p:sp>
-        <p:nvSpPr>
-          <p:cNvPr id="31" name="Shape 29"/>
-          <p:cNvSpPr/>
-          <p:nvPr/>
-        </p:nvSpPr>
-        <p:spPr>
-          <a:xfrm>
-            <a:off x="457200" y="2606040"/>
-            <a:ext cx="2651760" cy="1280160"/>
-          </a:xfrm>
-          <a:prstGeom prst="rect">
-            <a:avLst/>
-          </a:prstGeom>
-          <a:solidFill>
-            <a:srgbClr val="F9F9F9"/>
-          </a:solidFill>
-          <a:ln w="6350">
-            <a:solidFill>
-              <a:srgbClr val="E5E5E5"/>
-            </a:solidFill>
-            <a:prstDash val="solid"/>
-          </a:ln>
-        </p:spPr>
-      </p:sp>
-      <p:sp>
-        <p:nvSpPr>
-          <p:cNvPr id="32" name="Shape 30"/>
-          <p:cNvSpPr/>
-          <p:nvPr/>
-        </p:nvSpPr>
-        <p:spPr>
-          <a:xfrm>
-            <a:off x="457200" y="2606040"/>
-            <a:ext cx="2651760" cy="256032"/>
-          </a:xfrm>
-          <a:prstGeom prst="rect">
-            <a:avLst/>
-          </a:prstGeom>
-          <a:solidFill>
-            <a:srgbClr val="F6693D"/>
-          </a:solidFill>
-          <a:ln w="12700">
-            <a:solidFill>
-              <a:srgbClr val="F6693D"/>
-            </a:solidFill>
-            <a:prstDash val="solid"/>
-          </a:ln>
-        </p:spPr>
-      </p:sp>
-      <p:sp>
-        <p:nvSpPr>
-          <p:cNvPr id="33" name="Text 31"/>
-          <p:cNvSpPr/>
-          <p:nvPr/>
-        </p:nvSpPr>
-        <p:spPr>
-          <a:xfrm>
-            <a:off x="457200" y="2606040"/>
-            <a:ext cx="2651760" cy="256032"/>
-          </a:xfrm>
-          <a:prstGeom prst="rect">
-            <a:avLst/>
-          </a:prstGeom>
-          <a:noFill/>
-          <a:ln/>
-        </p:spPr>
-        <p:txBody>
-          <a:bodyPr wrap="square" lIns="0" tIns="0" rIns="0" bIns="0" rtlCol="0" anchor="ctr"/>
-          <a:lstStyle/>
-          <a:p>
-            <a:pPr algn="ctr" indent="0" marL="0">
-              <a:buNone/>
-            </a:pPr>
-            <a:r>
-              <a:rPr lang="en-US" sz="1000" b="1" spc="200" kern="0" dirty="0">
-                <a:solidFill>
-                  <a:srgbClr val="FFFFFF"/>
-                </a:solidFill>
-                <a:latin typeface="Arial" pitchFamily="34" charset="0"/>
-                <a:ea typeface="Arial" pitchFamily="34" charset="-122"/>
-                <a:cs typeface="Arial" pitchFamily="34" charset="-120"/>
-              </a:rPr>
-              <a:t>LOGIC</a:t>
-            </a:r>
-            <a:endParaRPr lang="en-US" sz="1000" dirty="0"/>
-          </a:p>
-        </p:txBody>
-      </p:sp>
-      <p:sp>
-        <p:nvSpPr>
-          <p:cNvPr id="34" name="Text 32"/>
-          <p:cNvSpPr/>
-          <p:nvPr/>
-        </p:nvSpPr>
-        <p:spPr>
-          <a:xfrm>
-            <a:off x="594360" y="2916936"/>
-            <a:ext cx="2377440" cy="457200"/>
-          </a:xfrm>
-          <a:prstGeom prst="rect">
-            <a:avLst/>
-          </a:prstGeom>
-          <a:noFill/>
-          <a:ln/>
-        </p:spPr>
-        <p:txBody>
-          <a:bodyPr wrap="square" lIns="0" tIns="0" rIns="0" bIns="0" rtlCol="0" anchor="t"/>
-          <a:lstStyle/>
-          <a:p>
-            <a:pPr indent="0" marL="0">
-              <a:buNone/>
-            </a:pPr>
-            <a:r>
-              <a:rPr lang="en-US" sz="950" dirty="0">
-                <a:solidFill>
-                  <a:srgbClr val="333333"/>
-                </a:solidFill>
-                <a:latin typeface="Arial" pitchFamily="34" charset="0"/>
-                <a:ea typeface="Arial" pitchFamily="34" charset="-122"/>
-                <a:cs typeface="Arial" pitchFamily="34" charset="-120"/>
-              </a:rPr>
-              <a:t>Where computation happens — the chips that run code and move data.</a:t>
-            </a:r>
-            <a:endParaRPr lang="en-US" sz="950" dirty="0"/>
-          </a:p>
-        </p:txBody>
-      </p:sp>
-      <p:sp>
-        <p:nvSpPr>
-          <p:cNvPr id="35" name="Text 33"/>
-          <p:cNvSpPr/>
-          <p:nvPr/>
-        </p:nvSpPr>
-        <p:spPr>
-          <a:xfrm>
-            <a:off x="594360" y="3392424"/>
-            <a:ext cx="2377440" cy="237744"/>
-          </a:xfrm>
-          <a:prstGeom prst="rect">
-            <a:avLst/>
-          </a:prstGeom>
-          <a:noFill/>
-          <a:ln/>
-        </p:spPr>
-        <p:txBody>
-          <a:bodyPr wrap="square" lIns="0" tIns="0" rIns="0" bIns="0" rtlCol="0" anchor="t"/>
-          <a:lstStyle/>
-          <a:p>
-            <a:pPr indent="0" marL="0">
-              <a:buNone/>
-            </a:pPr>
-            <a:r>
-              <a:rPr lang="en-US" sz="850" i="1" dirty="0">
-                <a:solidFill>
-                  <a:srgbClr val="666666"/>
-                </a:solidFill>
-                <a:latin typeface="Arial" pitchFamily="34" charset="0"/>
-                <a:ea typeface="Arial" pitchFamily="34" charset="-122"/>
-                <a:cs typeface="Arial" pitchFamily="34" charset="-120"/>
-              </a:rPr>
-              <a:t>GPUs, AI accelerators, ASICs, FPGAs</a:t>
-            </a:r>
-            <a:endParaRPr lang="en-US" sz="850" dirty="0"/>
-          </a:p>
-        </p:txBody>
-      </p:sp>
-      <p:sp>
-        <p:nvSpPr>
-          <p:cNvPr id="36" name="Shape 34"/>
-          <p:cNvSpPr/>
-          <p:nvPr/>
-        </p:nvSpPr>
-        <p:spPr>
-          <a:xfrm>
-            <a:off x="640080" y="3648456"/>
-            <a:ext cx="2286000" cy="0"/>
-          </a:xfrm>
-          <a:prstGeom prst="line">
-            <a:avLst/>
-          </a:prstGeom>
-          <a:noFill/>
-          <a:ln w="6350">
-            <a:solidFill>
-              <a:srgbClr val="E5E5E5"/>
-            </a:solidFill>
-            <a:prstDash val="solid"/>
-          </a:ln>
-        </p:spPr>
-      </p:sp>
-      <p:sp>
-        <p:nvSpPr>
           <p:cNvPr id="37" name="Text 35"/>
-          <p:cNvSpPr/>
-          <p:nvPr/>
-        </p:nvSpPr>
-        <p:spPr>
-          <a:xfrm>
-            <a:off x="457200" y="3666744"/>
-            <a:ext cx="2651760" cy="201168"/>
-          </a:xfrm>
-          <a:prstGeom prst="rect">
-            <a:avLst/>
-          </a:prstGeom>
-          <a:noFill/>
-          <a:ln/>
-        </p:spPr>
-        <p:txBody>
-          <a:bodyPr wrap="square" lIns="0" tIns="0" rIns="0" bIns="0" rtlCol="0" anchor="ctr"/>
-          <a:lstStyle/>
-          <a:p>
-            <a:pPr algn="ctr" indent="0" marL="0">
-              <a:buNone/>
-            </a:pPr>
-            <a:r>
-              <a:rPr lang="en-US" sz="750" i="1" dirty="0">
-                <a:solidFill>
-                  <a:srgbClr val="666666"/>
-                </a:solidFill>
-                <a:latin typeface="Arial" pitchFamily="34" charset="0"/>
-                <a:ea typeface="Arial" pitchFamily="34" charset="-122"/>
-                <a:cs typeface="Arial" pitchFamily="34" charset="-120"/>
-              </a:rPr>
-              <a:t>NVIDIA · AMD · Broadcom · TSMC</a:t>
-            </a:r>
-            <a:endParaRPr lang="en-US" sz="750" dirty="0"/>
-          </a:p>
-        </p:txBody>
-      </p:sp>
-      <p:sp>
-        <p:nvSpPr>
-          <p:cNvPr id="38" name="Shape 36"/>
-          <p:cNvSpPr/>
-          <p:nvPr/>
-        </p:nvSpPr>
-        <p:spPr>
-          <a:xfrm>
-            <a:off x="3246120" y="2606040"/>
-            <a:ext cx="2651760" cy="1280160"/>
-          </a:xfrm>
-          <a:prstGeom prst="rect">
-            <a:avLst/>
-          </a:prstGeom>
-          <a:solidFill>
-            <a:srgbClr val="F9F9F9"/>
-          </a:solidFill>
-          <a:ln w="6350">
-            <a:solidFill>
-              <a:srgbClr val="E5E5E5"/>
-            </a:solidFill>
-            <a:prstDash val="solid"/>
-          </a:ln>
-        </p:spPr>
-      </p:sp>
-      <p:sp>
-        <p:nvSpPr>
-          <p:cNvPr id="39" name="Shape 37"/>
-          <p:cNvSpPr/>
-          <p:nvPr/>
-        </p:nvSpPr>
-        <p:spPr>
-          <a:xfrm>
-            <a:off x="3246120" y="2606040"/>
-            <a:ext cx="2651760" cy="256032"/>
-          </a:xfrm>
-          <a:prstGeom prst="rect">
-            <a:avLst/>
-          </a:prstGeom>
-          <a:solidFill>
-            <a:srgbClr val="FFB800"/>
-          </a:solidFill>
-          <a:ln w="12700">
-            <a:solidFill>
-              <a:srgbClr val="FFB800"/>
-            </a:solidFill>
-            <a:prstDash val="solid"/>
-          </a:ln>
-        </p:spPr>
-      </p:sp>
-      <p:sp>
-        <p:nvSpPr>
-          <p:cNvPr id="40" name="Text 38"/>
-          <p:cNvSpPr/>
-          <p:nvPr/>
-        </p:nvSpPr>
-        <p:spPr>
-          <a:xfrm>
-            <a:off x="3246120" y="2606040"/>
-            <a:ext cx="2651760" cy="256032"/>
-          </a:xfrm>
-          <a:prstGeom prst="rect">
-            <a:avLst/>
-          </a:prstGeom>
-          <a:noFill/>
-          <a:ln/>
-        </p:spPr>
-        <p:txBody>
-          <a:bodyPr wrap="square" lIns="0" tIns="0" rIns="0" bIns="0" rtlCol="0" anchor="ctr"/>
-          <a:lstStyle/>
-          <a:p>
-            <a:pPr algn="ctr" indent="0" marL="0">
-              <a:buNone/>
-            </a:pPr>
-            <a:r>
-              <a:rPr lang="en-US" sz="1000" b="1" spc="200" kern="0" dirty="0">
-                <a:solidFill>
-                  <a:srgbClr val="000000"/>
-                </a:solidFill>
-                <a:latin typeface="Arial" pitchFamily="34" charset="0"/>
-                <a:ea typeface="Arial" pitchFamily="34" charset="-122"/>
-                <a:cs typeface="Arial" pitchFamily="34" charset="-120"/>
-              </a:rPr>
-              <a:t>MEMORY</a:t>
-            </a:r>
-            <a:endParaRPr lang="en-US" sz="1000" dirty="0"/>
-          </a:p>
-        </p:txBody>
-      </p:sp>
-      <p:sp>
-        <p:nvSpPr>
-          <p:cNvPr id="41" name="Text 39"/>
-          <p:cNvSpPr/>
-          <p:nvPr/>
-        </p:nvSpPr>
-        <p:spPr>
-          <a:xfrm>
-            <a:off x="3383280" y="2916936"/>
-            <a:ext cx="2377440" cy="457200"/>
-          </a:xfrm>
-          <a:prstGeom prst="rect">
-            <a:avLst/>
-          </a:prstGeom>
-          <a:noFill/>
-          <a:ln/>
-        </p:spPr>
-        <p:txBody>
-          <a:bodyPr wrap="square" lIns="0" tIns="0" rIns="0" bIns="0" rtlCol="0" anchor="t"/>
-          <a:lstStyle/>
-          <a:p>
-            <a:pPr indent="0" marL="0">
-              <a:buNone/>
-            </a:pPr>
-            <a:r>
-              <a:rPr lang="en-US" sz="950" dirty="0">
-                <a:solidFill>
-                  <a:srgbClr val="333333"/>
-                </a:solidFill>
-                <a:latin typeface="Arial" pitchFamily="34" charset="0"/>
-                <a:ea typeface="Arial" pitchFamily="34" charset="-122"/>
-                <a:cs typeface="Arial" pitchFamily="34" charset="-120"/>
-              </a:rPr>
-              <a:t>Stores data so logic can read it at terabit speeds.</a:t>
-            </a:r>
-            <a:endParaRPr lang="en-US" sz="950" dirty="0"/>
-          </a:p>
-        </p:txBody>
-      </p:sp>
-      <p:sp>
-        <p:nvSpPr>
-          <p:cNvPr id="42" name="Text 40"/>
-          <p:cNvSpPr/>
-          <p:nvPr/>
-        </p:nvSpPr>
-        <p:spPr>
-          <a:xfrm>
-            <a:off x="3383280" y="3392424"/>
-            <a:ext cx="2377440" cy="237744"/>
-          </a:xfrm>
-          <a:prstGeom prst="rect">
-            <a:avLst/>
-          </a:prstGeom>
-          <a:noFill/>
-          <a:ln/>
-        </p:spPr>
-        <p:txBody>
-          <a:bodyPr wrap="square" lIns="0" tIns="0" rIns="0" bIns="0" rtlCol="0" anchor="t"/>
-          <a:lstStyle/>
-          <a:p>
-            <a:pPr indent="0" marL="0">
-              <a:buNone/>
-            </a:pPr>
-            <a:r>
-              <a:rPr lang="en-US" sz="850" i="1" dirty="0">
-                <a:solidFill>
-                  <a:srgbClr val="666666"/>
-                </a:solidFill>
-                <a:latin typeface="Arial" pitchFamily="34" charset="0"/>
-                <a:ea typeface="Arial" pitchFamily="34" charset="-122"/>
-                <a:cs typeface="Arial" pitchFamily="34" charset="-120"/>
-              </a:rPr>
-              <a:t>DRAM, HBM, NAND — every AI server</a:t>
-            </a:r>
-            <a:endParaRPr lang="en-US" sz="850" dirty="0"/>
-          </a:p>
-        </p:txBody>
-      </p:sp>
-      <p:sp>
-        <p:nvSpPr>
-          <p:cNvPr id="43" name="Shape 41"/>
-          <p:cNvSpPr/>
-          <p:nvPr/>
-        </p:nvSpPr>
-        <p:spPr>
-          <a:xfrm>
-            <a:off x="3429000" y="3648456"/>
-            <a:ext cx="2286000" cy="0"/>
-          </a:xfrm>
-          <a:prstGeom prst="line">
-            <a:avLst/>
-          </a:prstGeom>
-          <a:noFill/>
-          <a:ln w="6350">
-            <a:solidFill>
-              <a:srgbClr val="E5E5E5"/>
-            </a:solidFill>
-            <a:prstDash val="solid"/>
-          </a:ln>
-        </p:spPr>
-      </p:sp>
-      <p:sp>
-        <p:nvSpPr>
-          <p:cNvPr id="44" name="Text 42"/>
-          <p:cNvSpPr/>
-          <p:nvPr/>
-        </p:nvSpPr>
-        <p:spPr>
-          <a:xfrm>
-            <a:off x="3246120" y="3666744"/>
-            <a:ext cx="2651760" cy="201168"/>
-          </a:xfrm>
-          <a:prstGeom prst="rect">
-            <a:avLst/>
-          </a:prstGeom>
-          <a:noFill/>
-          <a:ln/>
-        </p:spPr>
-        <p:txBody>
-          <a:bodyPr wrap="square" lIns="0" tIns="0" rIns="0" bIns="0" rtlCol="0" anchor="ctr"/>
-          <a:lstStyle/>
-          <a:p>
-            <a:pPr algn="ctr" indent="0" marL="0">
-              <a:buNone/>
-            </a:pPr>
-            <a:r>
-              <a:rPr lang="en-US" sz="750" i="1" dirty="0">
-                <a:solidFill>
-                  <a:srgbClr val="666666"/>
-                </a:solidFill>
-                <a:latin typeface="Arial" pitchFamily="34" charset="0"/>
-                <a:ea typeface="Arial" pitchFamily="34" charset="-122"/>
-                <a:cs typeface="Arial" pitchFamily="34" charset="-120"/>
-              </a:rPr>
-              <a:t>SK Hynix · Samsung · Micron</a:t>
-            </a:r>
-            <a:endParaRPr lang="en-US" sz="750" dirty="0"/>
-          </a:p>
-        </p:txBody>
-      </p:sp>
-      <p:sp>
-        <p:nvSpPr>
-          <p:cNvPr id="45" name="Shape 43"/>
-          <p:cNvSpPr/>
-          <p:nvPr/>
-        </p:nvSpPr>
-        <p:spPr>
-          <a:xfrm>
-            <a:off x="6035040" y="2606040"/>
-            <a:ext cx="2651760" cy="1280160"/>
-          </a:xfrm>
-          <a:prstGeom prst="rect">
-            <a:avLst/>
-          </a:prstGeom>
-          <a:solidFill>
-            <a:srgbClr val="F9F9F9"/>
-          </a:solidFill>
-          <a:ln w="6350">
-            <a:solidFill>
-              <a:srgbClr val="E5E5E5"/>
-            </a:solidFill>
-            <a:prstDash val="solid"/>
-          </a:ln>
-        </p:spPr>
-      </p:sp>
-      <p:sp>
-        <p:nvSpPr>
-          <p:cNvPr id="46" name="Shape 44"/>
-          <p:cNvSpPr/>
-          <p:nvPr/>
-        </p:nvSpPr>
-        <p:spPr>
-          <a:xfrm>
-            <a:off x="6035040" y="2606040"/>
-            <a:ext cx="2651760" cy="256032"/>
-          </a:xfrm>
-          <a:prstGeom prst="rect">
-            <a:avLst/>
-          </a:prstGeom>
-          <a:solidFill>
-            <a:srgbClr val="008B8B"/>
-          </a:solidFill>
-          <a:ln w="12700">
-            <a:solidFill>
-              <a:srgbClr val="008B8B"/>
-            </a:solidFill>
-            <a:prstDash val="solid"/>
-          </a:ln>
-        </p:spPr>
-      </p:sp>
-      <p:sp>
-        <p:nvSpPr>
-          <p:cNvPr id="47" name="Text 45"/>
-          <p:cNvSpPr/>
-          <p:nvPr/>
-        </p:nvSpPr>
-        <p:spPr>
-          <a:xfrm>
-            <a:off x="6035040" y="2606040"/>
-            <a:ext cx="2651760" cy="256032"/>
-          </a:xfrm>
-          <a:prstGeom prst="rect">
-            <a:avLst/>
-          </a:prstGeom>
-          <a:noFill/>
-          <a:ln/>
-        </p:spPr>
-        <p:txBody>
-          <a:bodyPr wrap="square" lIns="0" tIns="0" rIns="0" bIns="0" rtlCol="0" anchor="ctr"/>
-          <a:lstStyle/>
-          <a:p>
-            <a:pPr algn="ctr" indent="0" marL="0">
-              <a:buNone/>
-            </a:pPr>
-            <a:r>
-              <a:rPr lang="en-US" sz="1000" b="1" spc="200" kern="0" dirty="0">
-                <a:solidFill>
-                  <a:srgbClr val="FFFFFF"/>
-                </a:solidFill>
-                <a:latin typeface="Arial" pitchFamily="34" charset="0"/>
-                <a:ea typeface="Arial" pitchFamily="34" charset="-122"/>
-                <a:cs typeface="Arial" pitchFamily="34" charset="-120"/>
-              </a:rPr>
-              <a:t>PROCESSORS</a:t>
-            </a:r>
-            <a:endParaRPr lang="en-US" sz="1000" dirty="0"/>
-          </a:p>
-        </p:txBody>
-      </p:sp>
-      <p:sp>
-        <p:nvSpPr>
-          <p:cNvPr id="48" name="Text 46"/>
-          <p:cNvSpPr/>
-          <p:nvPr/>
-        </p:nvSpPr>
-        <p:spPr>
-          <a:xfrm>
-            <a:off x="6172200" y="2916936"/>
-            <a:ext cx="2377440" cy="457200"/>
-          </a:xfrm>
-          <a:prstGeom prst="rect">
-            <a:avLst/>
-          </a:prstGeom>
-          <a:noFill/>
-          <a:ln/>
-        </p:spPr>
-        <p:txBody>
-          <a:bodyPr wrap="square" lIns="0" tIns="0" rIns="0" bIns="0" rtlCol="0" anchor="t"/>
-          <a:lstStyle/>
-          <a:p>
-            <a:pPr indent="0" marL="0">
-              <a:buNone/>
-            </a:pPr>
-            <a:r>
-              <a:rPr lang="en-US" sz="950" dirty="0">
-                <a:solidFill>
-                  <a:srgbClr val="333333"/>
-                </a:solidFill>
-                <a:latin typeface="Arial" pitchFamily="34" charset="0"/>
-                <a:ea typeface="Arial" pitchFamily="34" charset="-122"/>
-                <a:cs typeface="Arial" pitchFamily="34" charset="-120"/>
-              </a:rPr>
-              <a:t>General-purpose silicon that runs your operating system.</a:t>
-            </a:r>
-            <a:endParaRPr lang="en-US" sz="950" dirty="0"/>
-          </a:p>
-        </p:txBody>
-      </p:sp>
-      <p:sp>
-        <p:nvSpPr>
-          <p:cNvPr id="49" name="Text 47"/>
-          <p:cNvSpPr/>
-          <p:nvPr/>
-        </p:nvSpPr>
-        <p:spPr>
-          <a:xfrm>
-            <a:off x="6172200" y="3392424"/>
-            <a:ext cx="2377440" cy="237744"/>
-          </a:xfrm>
-          <a:prstGeom prst="rect">
-            <a:avLst/>
-          </a:prstGeom>
-          <a:noFill/>
-          <a:ln/>
-        </p:spPr>
-        <p:txBody>
-          <a:bodyPr wrap="square" lIns="0" tIns="0" rIns="0" bIns="0" rtlCol="0" anchor="t"/>
-          <a:lstStyle/>
-          <a:p>
-            <a:pPr indent="0" marL="0">
-              <a:buNone/>
-            </a:pPr>
-            <a:r>
-              <a:rPr lang="en-US" sz="850" i="1" dirty="0">
-                <a:solidFill>
-                  <a:srgbClr val="666666"/>
-                </a:solidFill>
-                <a:latin typeface="Arial" pitchFamily="34" charset="0"/>
-                <a:ea typeface="Arial" pitchFamily="34" charset="-122"/>
-                <a:cs typeface="Arial" pitchFamily="34" charset="-120"/>
-              </a:rPr>
-              <a:t>CPUs in every phone and PC</a:t>
-            </a:r>
-            <a:endParaRPr lang="en-US" sz="850" dirty="0"/>
-          </a:p>
-        </p:txBody>
-      </p:sp>
-      <p:sp>
-        <p:nvSpPr>
-          <p:cNvPr id="50" name="Shape 48"/>
-          <p:cNvSpPr/>
-          <p:nvPr/>
-        </p:nvSpPr>
-        <p:spPr>
-          <a:xfrm>
-            <a:off x="6217920" y="3648456"/>
-            <a:ext cx="2286000" cy="0"/>
-          </a:xfrm>
-          <a:prstGeom prst="line">
-            <a:avLst/>
-          </a:prstGeom>
-          <a:noFill/>
-          <a:ln w="6350">
-            <a:solidFill>
-              <a:srgbClr val="E5E5E5"/>
-            </a:solidFill>
-            <a:prstDash val="solid"/>
-          </a:ln>
-        </p:spPr>
-      </p:sp>
-      <p:sp>
-        <p:nvSpPr>
-          <p:cNvPr id="51" name="Text 49"/>
-          <p:cNvSpPr/>
-          <p:nvPr/>
-        </p:nvSpPr>
-        <p:spPr>
-          <a:xfrm>
-            <a:off x="6035040" y="3666744"/>
-            <a:ext cx="2651760" cy="201168"/>
-          </a:xfrm>
-          <a:prstGeom prst="rect">
-            <a:avLst/>
-          </a:prstGeom>
-          <a:noFill/>
-          <a:ln/>
-        </p:spPr>
-        <p:txBody>
-          <a:bodyPr wrap="square" lIns="0" tIns="0" rIns="0" bIns="0" rtlCol="0" anchor="ctr"/>
-          <a:lstStyle/>
-          <a:p>
-            <a:pPr algn="ctr" indent="0" marL="0">
-              <a:buNone/>
-            </a:pPr>
-            <a:r>
-              <a:rPr lang="en-US" sz="750" i="1" dirty="0">
-                <a:solidFill>
-                  <a:srgbClr val="666666"/>
-                </a:solidFill>
-                <a:latin typeface="Arial" pitchFamily="34" charset="0"/>
-                <a:ea typeface="Arial" pitchFamily="34" charset="-122"/>
-                <a:cs typeface="Arial" pitchFamily="34" charset="-120"/>
-              </a:rPr>
-              <a:t>Intel · AMD · Apple · Qualcomm</a:t>
-            </a:r>
-            <a:endParaRPr lang="en-US" sz="750" dirty="0"/>
-          </a:p>
-        </p:txBody>
-      </p:sp>
-      <p:sp>
-        <p:nvSpPr>
-          <p:cNvPr id="52" name="Shape 50"/>
-          <p:cNvSpPr/>
-          <p:nvPr/>
-        </p:nvSpPr>
-        <p:spPr>
-          <a:xfrm>
-            <a:off x="457200" y="3977640"/>
-            <a:ext cx="2651760" cy="1280160"/>
-          </a:xfrm>
-          <a:prstGeom prst="rect">
-            <a:avLst/>
-          </a:prstGeom>
-          <a:solidFill>
-            <a:srgbClr val="F9F9F9"/>
-          </a:solidFill>
-          <a:ln w="6350">
-            <a:solidFill>
-              <a:srgbClr val="E5E5E5"/>
-            </a:solidFill>
-            <a:prstDash val="solid"/>
-          </a:ln>
-        </p:spPr>
-      </p:sp>
-      <p:sp>
-        <p:nvSpPr>
-          <p:cNvPr id="53" name="Shape 51"/>
-          <p:cNvSpPr/>
-          <p:nvPr/>
-        </p:nvSpPr>
-        <p:spPr>
-          <a:xfrm>
-            <a:off x="457200" y="3977640"/>
-            <a:ext cx="2651760" cy="256032"/>
-          </a:xfrm>
-          <a:prstGeom prst="rect">
-            <a:avLst/>
-          </a:prstGeom>
-          <a:solidFill>
-            <a:srgbClr val="051A3D"/>
-          </a:solidFill>
-          <a:ln w="12700">
-            <a:solidFill>
-              <a:srgbClr val="051A3D"/>
-            </a:solidFill>
-            <a:prstDash val="solid"/>
-          </a:ln>
-        </p:spPr>
-      </p:sp>
-      <p:sp>
-        <p:nvSpPr>
-          <p:cNvPr id="54" name="Text 52"/>
-          <p:cNvSpPr/>
-          <p:nvPr/>
-        </p:nvSpPr>
-        <p:spPr>
-          <a:xfrm>
-            <a:off x="457200" y="3977640"/>
-            <a:ext cx="2651760" cy="256032"/>
-          </a:xfrm>
-          <a:prstGeom prst="rect">
-            <a:avLst/>
-          </a:prstGeom>
-          <a:noFill/>
-          <a:ln/>
-        </p:spPr>
-        <p:txBody>
-          <a:bodyPr wrap="square" lIns="0" tIns="0" rIns="0" bIns="0" rtlCol="0" anchor="ctr"/>
-          <a:lstStyle/>
-          <a:p>
-            <a:pPr algn="ctr" indent="0" marL="0">
-              <a:buNone/>
-            </a:pPr>
-            <a:r>
-              <a:rPr lang="en-US" sz="1000" b="1" spc="200" kern="0" dirty="0">
-                <a:solidFill>
-                  <a:srgbClr val="FFFFFF"/>
-                </a:solidFill>
-                <a:latin typeface="Arial" pitchFamily="34" charset="0"/>
-                <a:ea typeface="Arial" pitchFamily="34" charset="-122"/>
-                <a:cs typeface="Arial" pitchFamily="34" charset="-120"/>
-              </a:rPr>
-              <a:t>ANALOG</a:t>
-            </a:r>
-            <a:endParaRPr lang="en-US" sz="1000" dirty="0"/>
-          </a:p>
-        </p:txBody>
-      </p:sp>
-      <p:sp>
-        <p:nvSpPr>
-          <p:cNvPr id="55" name="Text 53"/>
-          <p:cNvSpPr/>
-          <p:nvPr/>
-        </p:nvSpPr>
-        <p:spPr>
-          <a:xfrm>
-            <a:off x="594360" y="4288536"/>
-            <a:ext cx="2377440" cy="457200"/>
-          </a:xfrm>
-          <a:prstGeom prst="rect">
-            <a:avLst/>
-          </a:prstGeom>
-          <a:noFill/>
-          <a:ln/>
-        </p:spPr>
-        <p:txBody>
-          <a:bodyPr wrap="square" lIns="0" tIns="0" rIns="0" bIns="0" rtlCol="0" anchor="t"/>
-          <a:lstStyle/>
-          <a:p>
-            <a:pPr indent="0" marL="0">
-              <a:buNone/>
-            </a:pPr>
-            <a:r>
-              <a:rPr lang="en-US" sz="950" dirty="0">
-                <a:solidFill>
-                  <a:srgbClr val="333333"/>
-                </a:solidFill>
-                <a:latin typeface="Arial" pitchFamily="34" charset="0"/>
-                <a:ea typeface="Arial" pitchFamily="34" charset="-122"/>
-                <a:cs typeface="Arial" pitchFamily="34" charset="-120"/>
-              </a:rPr>
-              <a:t>The bridge between silicon and the real world — voltages, signals, RF.</a:t>
-            </a:r>
-            <a:endParaRPr lang="en-US" sz="950" dirty="0"/>
-          </a:p>
-        </p:txBody>
-      </p:sp>
-      <p:sp>
-        <p:nvSpPr>
-          <p:cNvPr id="56" name="Text 54"/>
-          <p:cNvSpPr/>
-          <p:nvPr/>
-        </p:nvSpPr>
-        <p:spPr>
-          <a:xfrm>
-            <a:off x="594360" y="4764024"/>
-            <a:ext cx="2377440" cy="237744"/>
-          </a:xfrm>
-          <a:prstGeom prst="rect">
-            <a:avLst/>
-          </a:prstGeom>
-          <a:noFill/>
-          <a:ln/>
-        </p:spPr>
-        <p:txBody>
-          <a:bodyPr wrap="square" lIns="0" tIns="0" rIns="0" bIns="0" rtlCol="0" anchor="t"/>
-          <a:lstStyle/>
-          <a:p>
-            <a:pPr indent="0" marL="0">
-              <a:buNone/>
-            </a:pPr>
-            <a:r>
-              <a:rPr lang="en-US" sz="850" i="1" dirty="0">
-                <a:solidFill>
-                  <a:srgbClr val="666666"/>
-                </a:solidFill>
-                <a:latin typeface="Arial" pitchFamily="34" charset="0"/>
-                <a:ea typeface="Arial" pitchFamily="34" charset="-122"/>
-                <a:cs typeface="Arial" pitchFamily="34" charset="-120"/>
-              </a:rPr>
-              <a:t>Power management, radio, audio</a:t>
-            </a:r>
-            <a:endParaRPr lang="en-US" sz="850" dirty="0"/>
-          </a:p>
-        </p:txBody>
-      </p:sp>
-      <p:sp>
-        <p:nvSpPr>
-          <p:cNvPr id="57" name="Shape 55"/>
-          <p:cNvSpPr/>
-          <p:nvPr/>
-        </p:nvSpPr>
-        <p:spPr>
-          <a:xfrm>
-            <a:off x="640080" y="5020056"/>
-            <a:ext cx="2286000" cy="0"/>
-          </a:xfrm>
-          <a:prstGeom prst="line">
-            <a:avLst/>
-          </a:prstGeom>
-          <a:noFill/>
-          <a:ln w="6350">
-            <a:solidFill>
-              <a:srgbClr val="E5E5E5"/>
-            </a:solidFill>
-            <a:prstDash val="solid"/>
-          </a:ln>
-        </p:spPr>
-      </p:sp>
-      <p:sp>
-        <p:nvSpPr>
-          <p:cNvPr id="58" name="Text 56"/>
-          <p:cNvSpPr/>
-          <p:nvPr/>
-        </p:nvSpPr>
-        <p:spPr>
-          <a:xfrm>
-            <a:off x="457200" y="5038344"/>
-            <a:ext cx="2651760" cy="201168"/>
-          </a:xfrm>
-          <a:prstGeom prst="rect">
-            <a:avLst/>
-          </a:prstGeom>
-          <a:noFill/>
-          <a:ln/>
-        </p:spPr>
-        <p:txBody>
-          <a:bodyPr wrap="square" lIns="0" tIns="0" rIns="0" bIns="0" rtlCol="0" anchor="ctr"/>
-          <a:lstStyle/>
-          <a:p>
-            <a:pPr algn="ctr" indent="0" marL="0">
-              <a:buNone/>
-            </a:pPr>
-            <a:r>
-              <a:rPr lang="en-US" sz="750" i="1" dirty="0">
-                <a:solidFill>
-                  <a:srgbClr val="666666"/>
-                </a:solidFill>
-                <a:latin typeface="Arial" pitchFamily="34" charset="0"/>
-                <a:ea typeface="Arial" pitchFamily="34" charset="-122"/>
-                <a:cs typeface="Arial" pitchFamily="34" charset="-120"/>
-              </a:rPr>
-              <a:t>TI · Analog Devices · Infineon</a:t>
-            </a:r>
-            <a:endParaRPr lang="en-US" sz="750" dirty="0"/>
-          </a:p>
-        </p:txBody>
-      </p:sp>
-      <p:sp>
-        <p:nvSpPr>
-          <p:cNvPr id="59" name="Shape 57"/>
-          <p:cNvSpPr/>
-          <p:nvPr/>
-        </p:nvSpPr>
-        <p:spPr>
-          <a:xfrm>
-            <a:off x="3246120" y="3977640"/>
-            <a:ext cx="2651760" cy="1280160"/>
-          </a:xfrm>
-          <a:prstGeom prst="rect">
-            <a:avLst/>
-          </a:prstGeom>
-          <a:solidFill>
-            <a:srgbClr val="F9F9F9"/>
-          </a:solidFill>
-          <a:ln w="6350">
-            <a:solidFill>
-              <a:srgbClr val="E5E5E5"/>
-            </a:solidFill>
-            <a:prstDash val="solid"/>
-          </a:ln>
-        </p:spPr>
-      </p:sp>
-      <p:sp>
-        <p:nvSpPr>
-          <p:cNvPr id="60" name="Shape 58"/>
-          <p:cNvSpPr/>
-          <p:nvPr/>
-        </p:nvSpPr>
-        <p:spPr>
-          <a:xfrm>
-            <a:off x="3246120" y="3977640"/>
-            <a:ext cx="2651760" cy="256032"/>
-          </a:xfrm>
-          <a:prstGeom prst="rect">
-            <a:avLst/>
-          </a:prstGeom>
-          <a:solidFill>
-            <a:srgbClr val="00A854"/>
-          </a:solidFill>
-          <a:ln w="12700">
-            <a:solidFill>
-              <a:srgbClr val="00A854"/>
-            </a:solidFill>
-            <a:prstDash val="solid"/>
-          </a:ln>
-        </p:spPr>
-      </p:sp>
-      <p:sp>
-        <p:nvSpPr>
-          <p:cNvPr id="61" name="Text 59"/>
-          <p:cNvSpPr/>
-          <p:nvPr/>
-        </p:nvSpPr>
-        <p:spPr>
-          <a:xfrm>
-            <a:off x="3246120" y="3977640"/>
-            <a:ext cx="2651760" cy="256032"/>
-          </a:xfrm>
-          <a:prstGeom prst="rect">
-            <a:avLst/>
-          </a:prstGeom>
-          <a:noFill/>
-          <a:ln/>
-        </p:spPr>
-        <p:txBody>
-          <a:bodyPr wrap="square" lIns="0" tIns="0" rIns="0" bIns="0" rtlCol="0" anchor="ctr"/>
-          <a:lstStyle/>
-          <a:p>
-            <a:pPr algn="ctr" indent="0" marL="0">
-              <a:buNone/>
-            </a:pPr>
-            <a:r>
-              <a:rPr lang="en-US" sz="1000" b="1" spc="200" kern="0" dirty="0">
-                <a:solidFill>
-                  <a:srgbClr val="FFFFFF"/>
-                </a:solidFill>
-                <a:latin typeface="Arial" pitchFamily="34" charset="0"/>
-                <a:ea typeface="Arial" pitchFamily="34" charset="-122"/>
-                <a:cs typeface="Arial" pitchFamily="34" charset="-120"/>
-              </a:rPr>
-              <a:t>SENSORS + OPTO</a:t>
-            </a:r>
-            <a:endParaRPr lang="en-US" sz="1000" dirty="0"/>
-          </a:p>
-        </p:txBody>
-      </p:sp>
-      <p:sp>
-        <p:nvSpPr>
-          <p:cNvPr id="62" name="Text 60"/>
-          <p:cNvSpPr/>
-          <p:nvPr/>
-        </p:nvSpPr>
-        <p:spPr>
-          <a:xfrm>
-            <a:off x="3383280" y="4288536"/>
-            <a:ext cx="2377440" cy="457200"/>
-          </a:xfrm>
-          <a:prstGeom prst="rect">
-            <a:avLst/>
-          </a:prstGeom>
-          <a:noFill/>
-          <a:ln/>
-        </p:spPr>
-        <p:txBody>
-          <a:bodyPr wrap="square" lIns="0" tIns="0" rIns="0" bIns="0" rtlCol="0" anchor="t"/>
-          <a:lstStyle/>
-          <a:p>
-            <a:pPr indent="0" marL="0">
-              <a:buNone/>
-            </a:pPr>
-            <a:r>
-              <a:rPr lang="en-US" sz="950" dirty="0">
-                <a:solidFill>
-                  <a:srgbClr val="333333"/>
-                </a:solidFill>
-                <a:latin typeface="Arial" pitchFamily="34" charset="0"/>
-                <a:ea typeface="Arial" pitchFamily="34" charset="-122"/>
-                <a:cs typeface="Arial" pitchFamily="34" charset="-120"/>
-              </a:rPr>
-              <a:t>How chips see, hear, and communicate with photons.</a:t>
-            </a:r>
-            <a:endParaRPr lang="en-US" sz="950" dirty="0"/>
-          </a:p>
-        </p:txBody>
-      </p:sp>
-      <p:sp>
-        <p:nvSpPr>
-          <p:cNvPr id="63" name="Text 61"/>
-          <p:cNvSpPr/>
-          <p:nvPr/>
-        </p:nvSpPr>
-        <p:spPr>
-          <a:xfrm>
-            <a:off x="3383280" y="4764024"/>
-            <a:ext cx="2377440" cy="237744"/>
-          </a:xfrm>
-          <a:prstGeom prst="rect">
-            <a:avLst/>
-          </a:prstGeom>
-          <a:noFill/>
-          <a:ln/>
-        </p:spPr>
-        <p:txBody>
-          <a:bodyPr wrap="square" lIns="0" tIns="0" rIns="0" bIns="0" rtlCol="0" anchor="t"/>
-          <a:lstStyle/>
-          <a:p>
-            <a:pPr indent="0" marL="0">
-              <a:buNone/>
-            </a:pPr>
-            <a:r>
-              <a:rPr lang="en-US" sz="850" i="1" dirty="0">
-                <a:solidFill>
-                  <a:srgbClr val="666666"/>
-                </a:solidFill>
-                <a:latin typeface="Arial" pitchFamily="34" charset="0"/>
-                <a:ea typeface="Arial" pitchFamily="34" charset="-122"/>
-                <a:cs typeface="Arial" pitchFamily="34" charset="-120"/>
-              </a:rPr>
-              <a:t>Phone cameras, lidar, fiber optics</a:t>
-            </a:r>
-            <a:endParaRPr lang="en-US" sz="850" dirty="0"/>
-          </a:p>
-        </p:txBody>
-      </p:sp>
-      <p:sp>
-        <p:nvSpPr>
-          <p:cNvPr id="64" name="Shape 62"/>
-          <p:cNvSpPr/>
-          <p:nvPr/>
-        </p:nvSpPr>
-        <p:spPr>
-          <a:xfrm>
-            <a:off x="3429000" y="5020056"/>
-            <a:ext cx="2286000" cy="0"/>
-          </a:xfrm>
-          <a:prstGeom prst="line">
-            <a:avLst/>
-          </a:prstGeom>
-          <a:noFill/>
-          <a:ln w="6350">
-            <a:solidFill>
-              <a:srgbClr val="E5E5E5"/>
-            </a:solidFill>
-            <a:prstDash val="solid"/>
-          </a:ln>
-        </p:spPr>
-      </p:sp>
-      <p:sp>
-        <p:nvSpPr>
-          <p:cNvPr id="65" name="Text 63"/>
-          <p:cNvSpPr/>
-          <p:nvPr/>
-        </p:nvSpPr>
-        <p:spPr>
-          <a:xfrm>
-            <a:off x="3246120" y="5038344"/>
-            <a:ext cx="2651760" cy="201168"/>
-          </a:xfrm>
-          <a:prstGeom prst="rect">
-            <a:avLst/>
-          </a:prstGeom>
-          <a:noFill/>
-          <a:ln/>
-        </p:spPr>
-        <p:txBody>
-          <a:bodyPr wrap="square" lIns="0" tIns="0" rIns="0" bIns="0" rtlCol="0" anchor="ctr"/>
-          <a:lstStyle/>
-          <a:p>
-            <a:pPr algn="ctr" indent="0" marL="0">
-              <a:buNone/>
-            </a:pPr>
-            <a:r>
-              <a:rPr lang="en-US" sz="750" i="1" dirty="0">
-                <a:solidFill>
-                  <a:srgbClr val="666666"/>
-                </a:solidFill>
-                <a:latin typeface="Arial" pitchFamily="34" charset="0"/>
-                <a:ea typeface="Arial" pitchFamily="34" charset="-122"/>
-                <a:cs typeface="Arial" pitchFamily="34" charset="-120"/>
-              </a:rPr>
-              <a:t>Sony · Samsung · STMicro</a:t>
-            </a:r>
-            <a:endParaRPr lang="en-US" sz="750" dirty="0"/>
-          </a:p>
-        </p:txBody>
-      </p:sp>
-      <p:sp>
-        <p:nvSpPr>
-          <p:cNvPr id="66" name="Shape 64"/>
-          <p:cNvSpPr/>
-          <p:nvPr/>
-        </p:nvSpPr>
-        <p:spPr>
-          <a:xfrm>
-            <a:off x="6035040" y="3977640"/>
-            <a:ext cx="2651760" cy="1280160"/>
-          </a:xfrm>
-          <a:prstGeom prst="rect">
-            <a:avLst/>
-          </a:prstGeom>
-          <a:solidFill>
-            <a:srgbClr val="F9F9F9"/>
-          </a:solidFill>
-          <a:ln w="6350">
-            <a:solidFill>
-              <a:srgbClr val="E5E5E5"/>
-            </a:solidFill>
-            <a:prstDash val="solid"/>
-          </a:ln>
-        </p:spPr>
-      </p:sp>
-      <p:sp>
-        <p:nvSpPr>
-          <p:cNvPr id="67" name="Shape 65"/>
-          <p:cNvSpPr/>
-          <p:nvPr/>
-        </p:nvSpPr>
-        <p:spPr>
-          <a:xfrm>
-            <a:off x="6035040" y="3977640"/>
-            <a:ext cx="2651760" cy="256032"/>
-          </a:xfrm>
-          <a:prstGeom prst="rect">
-            <a:avLst/>
-          </a:prstGeom>
-          <a:solidFill>
-            <a:srgbClr val="666666"/>
-          </a:solidFill>
-          <a:ln w="12700">
-            <a:solidFill>
-              <a:srgbClr val="666666"/>
-            </a:solidFill>
-            <a:prstDash val="solid"/>
-          </a:ln>
-        </p:spPr>
-      </p:sp>
-      <p:sp>
-        <p:nvSpPr>
-          <p:cNvPr id="68" name="Text 66"/>
-          <p:cNvSpPr/>
-          <p:nvPr/>
-        </p:nvSpPr>
-        <p:spPr>
-          <a:xfrm>
-            <a:off x="6035040" y="3977640"/>
-            <a:ext cx="2651760" cy="256032"/>
-          </a:xfrm>
-          <a:prstGeom prst="rect">
-            <a:avLst/>
-          </a:prstGeom>
-          <a:noFill/>
-          <a:ln/>
-        </p:spPr>
-        <p:txBody>
-          <a:bodyPr wrap="square" lIns="0" tIns="0" rIns="0" bIns="0" rtlCol="0" anchor="ctr"/>
-          <a:lstStyle/>
-          <a:p>
-            <a:pPr algn="ctr" indent="0" marL="0">
-              <a:buNone/>
-            </a:pPr>
-            <a:r>
-              <a:rPr lang="en-US" sz="1000" b="1" spc="200" kern="0" dirty="0">
-                <a:solidFill>
-                  <a:srgbClr val="FFFFFF"/>
-                </a:solidFill>
-                <a:latin typeface="Arial" pitchFamily="34" charset="0"/>
-                <a:ea typeface="Arial" pitchFamily="34" charset="-122"/>
-                <a:cs typeface="Arial" pitchFamily="34" charset="-120"/>
-              </a:rPr>
-              <a:t>DISCRETE + POWER</a:t>
-            </a:r>
-            <a:endParaRPr lang="en-US" sz="1000" dirty="0"/>
-          </a:p>
-        </p:txBody>
-      </p:sp>
-      <p:sp>
-        <p:nvSpPr>
-          <p:cNvPr id="69" name="Text 67"/>
-          <p:cNvSpPr/>
-          <p:nvPr/>
-        </p:nvSpPr>
-        <p:spPr>
-          <a:xfrm>
-            <a:off x="6172200" y="4288536"/>
-            <a:ext cx="2377440" cy="457200"/>
-          </a:xfrm>
-          <a:prstGeom prst="rect">
-            <a:avLst/>
-          </a:prstGeom>
-          <a:noFill/>
-          <a:ln/>
-        </p:spPr>
-        <p:txBody>
-          <a:bodyPr wrap="square" lIns="0" tIns="0" rIns="0" bIns="0" rtlCol="0" anchor="t"/>
-          <a:lstStyle/>
-          <a:p>
-            <a:pPr indent="0" marL="0">
-              <a:buNone/>
-            </a:pPr>
-            <a:r>
-              <a:rPr lang="en-US" sz="950" dirty="0">
-                <a:solidFill>
-                  <a:srgbClr val="333333"/>
-                </a:solidFill>
-                <a:latin typeface="Arial" pitchFamily="34" charset="0"/>
-                <a:ea typeface="Arial" pitchFamily="34" charset="-122"/>
-                <a:cs typeface="Arial" pitchFamily="34" charset="-120"/>
-              </a:rPr>
-              <a:t>Heavy-current switching for machines, grids, and vehicles.</a:t>
-            </a:r>
-            <a:endParaRPr lang="en-US" sz="950" dirty="0"/>
-          </a:p>
-        </p:txBody>
-      </p:sp>
-      <p:sp>
-        <p:nvSpPr>
-          <p:cNvPr id="70" name="Text 68"/>
-          <p:cNvSpPr/>
-          <p:nvPr/>
-        </p:nvSpPr>
-        <p:spPr>
-          <a:xfrm>
-            <a:off x="6172200" y="4764024"/>
-            <a:ext cx="2377440" cy="237744"/>
-          </a:xfrm>
-          <a:prstGeom prst="rect">
-            <a:avLst/>
-          </a:prstGeom>
-          <a:noFill/>
-          <a:ln/>
-        </p:spPr>
-        <p:txBody>
-          <a:bodyPr wrap="square" lIns="0" tIns="0" rIns="0" bIns="0" rtlCol="0" anchor="t"/>
-          <a:lstStyle/>
-          <a:p>
-            <a:pPr indent="0" marL="0">
-              <a:buNone/>
-            </a:pPr>
-            <a:r>
-              <a:rPr lang="en-US" sz="850" i="1" dirty="0">
-                <a:solidFill>
-                  <a:srgbClr val="666666"/>
-                </a:solidFill>
-                <a:latin typeface="Arial" pitchFamily="34" charset="0"/>
-                <a:ea typeface="Arial" pitchFamily="34" charset="-122"/>
-                <a:cs typeface="Arial" pitchFamily="34" charset="-120"/>
-              </a:rPr>
-              <a:t>EVs, industrial motors, chargers</a:t>
-            </a:r>
-            <a:endParaRPr lang="en-US" sz="850" dirty="0"/>
-          </a:p>
-        </p:txBody>
-      </p:sp>
-      <p:sp>
-        <p:nvSpPr>
-          <p:cNvPr id="71" name="Shape 69"/>
-          <p:cNvSpPr/>
-          <p:nvPr/>
-        </p:nvSpPr>
-        <p:spPr>
-          <a:xfrm>
-            <a:off x="6217920" y="5020056"/>
-            <a:ext cx="2286000" cy="0"/>
-          </a:xfrm>
-          <a:prstGeom prst="line">
-            <a:avLst/>
-          </a:prstGeom>
-          <a:noFill/>
-          <a:ln w="6350">
-            <a:solidFill>
-              <a:srgbClr val="E5E5E5"/>
-            </a:solidFill>
-            <a:prstDash val="solid"/>
-          </a:ln>
-        </p:spPr>
-      </p:sp>
-      <p:sp>
-        <p:nvSpPr>
-          <p:cNvPr id="72" name="Text 70"/>
-          <p:cNvSpPr/>
-          <p:nvPr/>
-        </p:nvSpPr>
-        <p:spPr>
-          <a:xfrm>
-            <a:off x="6035040" y="5038344"/>
-            <a:ext cx="2651760" cy="201168"/>
-          </a:xfrm>
-          <a:prstGeom prst="rect">
-            <a:avLst/>
-          </a:prstGeom>
-          <a:noFill/>
-          <a:ln/>
-        </p:spPr>
-        <p:txBody>
-          <a:bodyPr wrap="square" lIns="0" tIns="0" rIns="0" bIns="0" rtlCol="0" anchor="ctr"/>
-          <a:lstStyle/>
-          <a:p>
-            <a:pPr algn="ctr" indent="0" marL="0">
-              <a:buNone/>
-            </a:pPr>
-            <a:r>
-              <a:rPr lang="en-US" sz="750" i="1" dirty="0">
-                <a:solidFill>
-                  <a:srgbClr val="666666"/>
-                </a:solidFill>
-                <a:latin typeface="Arial" pitchFamily="34" charset="0"/>
-                <a:ea typeface="Arial" pitchFamily="34" charset="-122"/>
-                <a:cs typeface="Arial" pitchFamily="34" charset="-120"/>
-              </a:rPr>
-              <a:t>Infineon · ON Semi · Wolfspeed</a:t>
-            </a:r>
-            <a:endParaRPr lang="en-US" sz="750" dirty="0"/>
-          </a:p>
-        </p:txBody>
-      </p:sp>
-      <p:sp>
-        <p:nvSpPr>
-          <p:cNvPr id="73" name="Shape 71"/>
-          <p:cNvSpPr/>
-          <p:nvPr/>
-        </p:nvSpPr>
-        <p:spPr>
-          <a:xfrm>
-            <a:off x="457200" y="5285232"/>
-            <a:ext cx="8229600" cy="402336"/>
-          </a:xfrm>
-          <a:prstGeom prst="rect">
-            <a:avLst/>
-          </a:prstGeom>
-          <a:solidFill>
-            <a:srgbClr val="FFD100"/>
-          </a:solidFill>
-          <a:ln w="12700">
-            <a:solidFill>
-              <a:srgbClr val="FFD100"/>
-            </a:solidFill>
-            <a:prstDash val="solid"/>
-          </a:ln>
-        </p:spPr>
-      </p:sp>
-      <p:sp>
-        <p:nvSpPr>
-          <p:cNvPr id="74" name="Text 72"/>
-          <p:cNvSpPr/>
-          <p:nvPr/>
-        </p:nvSpPr>
-        <p:spPr>
-          <a:xfrm>
-            <a:off x="640080" y="5285232"/>
-            <a:ext cx="7863840" cy="402336"/>
-          </a:xfrm>
-          <a:prstGeom prst="rect">
-            <a:avLst/>
-          </a:prstGeom>
-          <a:noFill/>
-          <a:ln/>
-        </p:spPr>
-        <p:txBody>
-          <a:bodyPr wrap="square" lIns="0" tIns="0" rIns="0" bIns="0" rtlCol="0" anchor="ctr"/>
-          <a:lstStyle/>
-          <a:p>
-            <a:pPr indent="0" marL="0">
-              <a:buNone/>
-            </a:pPr>
-            <a:r>
-              <a:rPr lang="en-US" sz="1150" b="1" dirty="0">
-                <a:solidFill>
-                  <a:srgbClr val="000000"/>
-                </a:solidFill>
-                <a:latin typeface="Arial" pitchFamily="34" charset="0"/>
-                <a:ea typeface="Arial" pitchFamily="34" charset="-122"/>
-                <a:cs typeface="Arial" pitchFamily="34" charset="-120"/>
-              </a:rPr>
-              <a:t>Logic and memory absorb the AI capex — but every chip flows through ASML tools, TSMC fabs, and advanced packaging, where bottlenecks decide who ships.</a:t>
-            </a:r>
-            <a:endParaRPr lang="en-US" sz="1150" dirty="0"/>
-          </a:p>
-        </p:txBody>
-      </p:sp>
-      <p:sp>
-        <p:nvSpPr>
-          <p:cNvPr id="75" name="Text 73"/>
-          <p:cNvSpPr/>
-          <p:nvPr/>
-        </p:nvSpPr>
-        <p:spPr>
-          <a:xfrm>
-            <a:off x="457200" y="5875020"/>
-            <a:ext cx="8229600" cy="320040"/>
-          </a:xfrm>
-          <a:prstGeom prst="rect">
-            <a:avLst/>
-          </a:prstGeom>
-          <a:noFill/>
-          <a:ln/>
-        </p:spPr>
-        <p:txBody>
-          <a:bodyPr wrap="square" lIns="0" tIns="0" rIns="0" bIns="0" rtlCol="0" anchor="t"/>
-          <a:lstStyle/>
-          <a:p>
-            <a:pPr indent="0" marL="0">
-              <a:buNone/>
-            </a:pPr>
-            <a:r>
-              <a:rPr lang="en-US" sz="700" dirty="0">
-                <a:solidFill>
-                  <a:srgbClr val="999999"/>
-                </a:solidFill>
-                <a:latin typeface="Arial" pitchFamily="34" charset="0"/>
-                <a:ea typeface="Arial" pitchFamily="34" charset="-122"/>
-                <a:cs typeface="Arial" pitchFamily="34" charset="-120"/>
-              </a:rPr>
-              <a:t>Sources: SIA category taxonomy; WSTS Fall 2025; SEMI World Fab Forecast; TrendForce; company disclosures. Category descriptions are plain-English simplifications.</a:t>
-            </a:r>
-            <a:endParaRPr lang="en-US" sz="700" dirty="0"/>
-          </a:p>
-        </p:txBody>
-      </p:sp>
-      <p:sp>
-        <p:nvSpPr>
-          <p:cNvPr id="76" name="Shape 74"/>
-          <p:cNvSpPr/>
-          <p:nvPr/>
-        </p:nvSpPr>
-        <p:spPr>
-          <a:xfrm>
-            <a:off x="0" y="6286500"/>
-            <a:ext cx="9144000" cy="571500"/>
-          </a:xfrm>
-          <a:prstGeom prst="rect">
-            <a:avLst/>
-          </a:prstGeom>
-          <a:solidFill>
-            <a:srgbClr val="000000"/>
-          </a:solidFill>
-          <a:ln w="12700">
-            <a:solidFill>
-              <a:srgbClr val="000000"/>
-            </a:solidFill>
-            <a:prstDash val="solid"/>
-          </a:ln>
-        </p:spPr>
-      </p:sp>
-      <p:sp>
-        <p:nvSpPr>
-          <p:cNvPr id="77" name="Text 75"/>
           <p:cNvSpPr/>
           <p:nvPr/>
         </p:nvSpPr>
@@ -38017,7 +36650,7 @@
       </p:sp>
       <p:sp>
         <p:nvSpPr>
-          <p:cNvPr id="78" name="Text 76"/>
+          <p:cNvPr id="38" name="Text 36"/>
           <p:cNvSpPr/>
           <p:nvPr/>
         </p:nvSpPr>

</xml_diff>

<commit_message>
Slide 7: rewrite stage descriptions in plain language, drop company examples
Replace jargon ("$20B fab", "EUV lithography", "logic dies", "HBM", "CoWoS") with everyday phrasing aimed at a non-technical reader. Remove the company-name line under each stage so the slide reads as a process explainer, not a vendor map. Caption simplified the same way.

Co-Authored-By: Claude Opus 4.7 <noreply@anthropic.com>
</commit_message>
<xml_diff>
--- a/ai-markets-deck.pptx
+++ b/ai-markets-deck.pptx
@@ -35684,7 +35684,7 @@
                 <a:ea typeface="Arial" pitchFamily="34" charset="-122"/>
                 <a:cs typeface="Arial" pitchFamily="34" charset="-120"/>
               </a:rPr>
-              <a:t>An AI accelerator package: a large logic die surrounded by HBM memory stacks on a CoWoS substrate.</a:t>
+              <a:t>An AI accelerator package: a large processor chip surrounded by high-speed memory chips, all wired into one unit.</a:t>
             </a:r>
             <a:endParaRPr lang="en-US" sz="800" dirty="0"/>
           </a:p>
@@ -35864,7 +35864,7 @@
         <p:spPr>
           <a:xfrm>
             <a:off x="5166360" y="2148840"/>
-            <a:ext cx="3520440" cy="457200"/>
+            <a:ext cx="3520440" cy="594360"/>
           </a:xfrm>
           <a:prstGeom prst="rect">
             <a:avLst/>
@@ -35888,7 +35888,7 @@
                 <a:ea typeface="Arial" pitchFamily="34" charset="-122"/>
                 <a:cs typeface="Arial" pitchFamily="34" charset="-120"/>
               </a:rPr>
-              <a:t>Engineers blueprint the AI chip's tens of billions of transistors in software.</a:t>
+              <a:t>Engineers draft the chip's blueprint in software, mapping where each of tens of billions of microscopic switches will sit.</a:t>
             </a:r>
             <a:endParaRPr lang="en-US" sz="1050" dirty="0"/>
           </a:p>
@@ -35896,46 +35896,7 @@
       </p:sp>
       <p:sp>
         <p:nvSpPr>
-          <p:cNvPr id="16" name="Text 14"/>
-          <p:cNvSpPr/>
-          <p:nvPr/>
-        </p:nvSpPr>
-        <p:spPr>
-          <a:xfrm>
-            <a:off x="5166360" y="2587752"/>
-            <a:ext cx="3520440" cy="182880"/>
-          </a:xfrm>
-          <a:prstGeom prst="rect">
-            <a:avLst/>
-          </a:prstGeom>
-          <a:noFill/>
-          <a:ln/>
-        </p:spPr>
-        <p:txBody>
-          <a:bodyPr wrap="square" lIns="0" tIns="0" rIns="0" bIns="0" rtlCol="0" anchor="t"/>
-          <a:lstStyle/>
-          <a:p>
-            <a:pPr indent="0" marL="0">
-              <a:buNone/>
-            </a:pPr>
-            <a:r>
-              <a:rPr lang="en-US" sz="900" i="1" dirty="0">
-                <a:solidFill>
-                  <a:srgbClr val="666666"/>
-                </a:solidFill>
-                <a:latin typeface="Arial" pitchFamily="34" charset="0"/>
-                <a:ea typeface="Arial" pitchFamily="34" charset="-122"/>
-                <a:cs typeface="Arial" pitchFamily="34" charset="-120"/>
-              </a:rPr>
-              <a:t>NVIDIA · AMD · Broadcom · Google TPU</a:t>
-            </a:r>
-            <a:endParaRPr lang="en-US" sz="900" dirty="0"/>
-          </a:p>
-        </p:txBody>
-      </p:sp>
-      <p:sp>
-        <p:nvSpPr>
-          <p:cNvPr id="17" name="Shape 15"/>
+          <p:cNvPr id="16" name="Shape 14"/>
           <p:cNvSpPr/>
           <p:nvPr/>
         </p:nvSpPr>
@@ -35958,7 +35919,7 @@
       </p:sp>
       <p:sp>
         <p:nvSpPr>
-          <p:cNvPr id="18" name="Shape 16"/>
+          <p:cNvPr id="17" name="Shape 15"/>
           <p:cNvSpPr/>
           <p:nvPr/>
         </p:nvSpPr>
@@ -35983,7 +35944,7 @@
       </p:sp>
       <p:sp>
         <p:nvSpPr>
-          <p:cNvPr id="19" name="Text 17"/>
+          <p:cNvPr id="18" name="Text 16"/>
           <p:cNvSpPr/>
           <p:nvPr/>
         </p:nvSpPr>
@@ -36022,7 +35983,7 @@
       </p:sp>
       <p:sp>
         <p:nvSpPr>
-          <p:cNvPr id="20" name="Text 18"/>
+          <p:cNvPr id="19" name="Text 17"/>
           <p:cNvSpPr/>
           <p:nvPr/>
         </p:nvSpPr>
@@ -36061,14 +36022,14 @@
       </p:sp>
       <p:sp>
         <p:nvSpPr>
-          <p:cNvPr id="21" name="Text 19"/>
+          <p:cNvPr id="20" name="Text 18"/>
           <p:cNvSpPr/>
           <p:nvPr/>
         </p:nvSpPr>
         <p:spPr>
           <a:xfrm>
             <a:off x="5166360" y="3108960"/>
-            <a:ext cx="3520440" cy="457200"/>
+            <a:ext cx="3520440" cy="594360"/>
           </a:xfrm>
           <a:prstGeom prst="rect">
             <a:avLst/>
@@ -36092,7 +36053,7 @@
                 <a:ea typeface="Arial" pitchFamily="34" charset="-122"/>
                 <a:cs typeface="Arial" pitchFamily="34" charset="-120"/>
               </a:rPr>
-              <a:t>Specialized tools, especially EUV lithography, are built to print at atomic scale.</a:t>
+              <a:t>Highly specialized machines are built to print circuit patterns at near-atomic scale using ultraviolet light.</a:t>
             </a:r>
             <a:endParaRPr lang="en-US" sz="1050" dirty="0"/>
           </a:p>
@@ -36100,46 +36061,7 @@
       </p:sp>
       <p:sp>
         <p:nvSpPr>
-          <p:cNvPr id="22" name="Text 20"/>
-          <p:cNvSpPr/>
-          <p:nvPr/>
-        </p:nvSpPr>
-        <p:spPr>
-          <a:xfrm>
-            <a:off x="5166360" y="3547872"/>
-            <a:ext cx="3520440" cy="182880"/>
-          </a:xfrm>
-          <a:prstGeom prst="rect">
-            <a:avLst/>
-          </a:prstGeom>
-          <a:noFill/>
-          <a:ln/>
-        </p:spPr>
-        <p:txBody>
-          <a:bodyPr wrap="square" lIns="0" tIns="0" rIns="0" bIns="0" rtlCol="0" anchor="t"/>
-          <a:lstStyle/>
-          <a:p>
-            <a:pPr indent="0" marL="0">
-              <a:buNone/>
-            </a:pPr>
-            <a:r>
-              <a:rPr lang="en-US" sz="900" i="1" dirty="0">
-                <a:solidFill>
-                  <a:srgbClr val="666666"/>
-                </a:solidFill>
-                <a:latin typeface="Arial" pitchFamily="34" charset="0"/>
-                <a:ea typeface="Arial" pitchFamily="34" charset="-122"/>
-                <a:cs typeface="Arial" pitchFamily="34" charset="-120"/>
-              </a:rPr>
-              <a:t>ASML · Applied Materials · Lam · KLA</a:t>
-            </a:r>
-            <a:endParaRPr lang="en-US" sz="900" dirty="0"/>
-          </a:p>
-        </p:txBody>
-      </p:sp>
-      <p:sp>
-        <p:nvSpPr>
-          <p:cNvPr id="23" name="Shape 21"/>
+          <p:cNvPr id="21" name="Shape 19"/>
           <p:cNvSpPr/>
           <p:nvPr/>
         </p:nvSpPr>
@@ -36162,7 +36084,7 @@
       </p:sp>
       <p:sp>
         <p:nvSpPr>
-          <p:cNvPr id="24" name="Shape 22"/>
+          <p:cNvPr id="22" name="Shape 20"/>
           <p:cNvSpPr/>
           <p:nvPr/>
         </p:nvSpPr>
@@ -36187,7 +36109,7 @@
       </p:sp>
       <p:sp>
         <p:nvSpPr>
-          <p:cNvPr id="25" name="Text 23"/>
+          <p:cNvPr id="23" name="Text 21"/>
           <p:cNvSpPr/>
           <p:nvPr/>
         </p:nvSpPr>
@@ -36226,7 +36148,7 @@
       </p:sp>
       <p:sp>
         <p:nvSpPr>
-          <p:cNvPr id="26" name="Text 24"/>
+          <p:cNvPr id="24" name="Text 22"/>
           <p:cNvSpPr/>
           <p:nvPr/>
         </p:nvSpPr>
@@ -36265,14 +36187,14 @@
       </p:sp>
       <p:sp>
         <p:nvSpPr>
-          <p:cNvPr id="27" name="Text 25"/>
+          <p:cNvPr id="25" name="Text 23"/>
           <p:cNvSpPr/>
           <p:nvPr/>
         </p:nvSpPr>
         <p:spPr>
           <a:xfrm>
             <a:off x="5166360" y="4069080"/>
-            <a:ext cx="3520440" cy="457200"/>
+            <a:ext cx="3520440" cy="594360"/>
           </a:xfrm>
           <a:prstGeom prst="rect">
             <a:avLst/>
@@ -36296,7 +36218,7 @@
                 <a:ea typeface="Arial" pitchFamily="34" charset="-122"/>
                 <a:cs typeface="Arial" pitchFamily="34" charset="-120"/>
               </a:rPr>
-              <a:t>Inside a $20B fab, silicon wafers are processed through 1,000+ steps.</a:t>
+              <a:t>Silicon wafers pass through more than a thousand precise steps inside ultra-clean factories that take years to build.</a:t>
             </a:r>
             <a:endParaRPr lang="en-US" sz="1050" dirty="0"/>
           </a:p>
@@ -36304,46 +36226,7 @@
       </p:sp>
       <p:sp>
         <p:nvSpPr>
-          <p:cNvPr id="28" name="Text 26"/>
-          <p:cNvSpPr/>
-          <p:nvPr/>
-        </p:nvSpPr>
-        <p:spPr>
-          <a:xfrm>
-            <a:off x="5166360" y="4507992"/>
-            <a:ext cx="3520440" cy="182880"/>
-          </a:xfrm>
-          <a:prstGeom prst="rect">
-            <a:avLst/>
-          </a:prstGeom>
-          <a:noFill/>
-          <a:ln/>
-        </p:spPr>
-        <p:txBody>
-          <a:bodyPr wrap="square" lIns="0" tIns="0" rIns="0" bIns="0" rtlCol="0" anchor="t"/>
-          <a:lstStyle/>
-          <a:p>
-            <a:pPr indent="0" marL="0">
-              <a:buNone/>
-            </a:pPr>
-            <a:r>
-              <a:rPr lang="en-US" sz="900" i="1" dirty="0">
-                <a:solidFill>
-                  <a:srgbClr val="666666"/>
-                </a:solidFill>
-                <a:latin typeface="Arial" pitchFamily="34" charset="0"/>
-                <a:ea typeface="Arial" pitchFamily="34" charset="-122"/>
-                <a:cs typeface="Arial" pitchFamily="34" charset="-120"/>
-              </a:rPr>
-              <a:t>TSMC · Samsung · Intel</a:t>
-            </a:r>
-            <a:endParaRPr lang="en-US" sz="900" dirty="0"/>
-          </a:p>
-        </p:txBody>
-      </p:sp>
-      <p:sp>
-        <p:nvSpPr>
-          <p:cNvPr id="29" name="Shape 27"/>
+          <p:cNvPr id="26" name="Shape 24"/>
           <p:cNvSpPr/>
           <p:nvPr/>
         </p:nvSpPr>
@@ -36366,7 +36249,7 @@
       </p:sp>
       <p:sp>
         <p:nvSpPr>
-          <p:cNvPr id="30" name="Shape 28"/>
+          <p:cNvPr id="27" name="Shape 25"/>
           <p:cNvSpPr/>
           <p:nvPr/>
         </p:nvSpPr>
@@ -36391,7 +36274,7 @@
       </p:sp>
       <p:sp>
         <p:nvSpPr>
-          <p:cNvPr id="31" name="Text 29"/>
+          <p:cNvPr id="28" name="Text 26"/>
           <p:cNvSpPr/>
           <p:nvPr/>
         </p:nvSpPr>
@@ -36430,7 +36313,7 @@
       </p:sp>
       <p:sp>
         <p:nvSpPr>
-          <p:cNvPr id="32" name="Text 30"/>
+          <p:cNvPr id="29" name="Text 27"/>
           <p:cNvSpPr/>
           <p:nvPr/>
         </p:nvSpPr>
@@ -36469,14 +36352,14 @@
       </p:sp>
       <p:sp>
         <p:nvSpPr>
-          <p:cNvPr id="33" name="Text 31"/>
+          <p:cNvPr id="30" name="Text 28"/>
           <p:cNvSpPr/>
           <p:nvPr/>
         </p:nvSpPr>
         <p:spPr>
           <a:xfrm>
             <a:off x="5166360" y="5029200"/>
-            <a:ext cx="3520440" cy="457200"/>
+            <a:ext cx="3520440" cy="594360"/>
           </a:xfrm>
           <a:prstGeom prst="rect">
             <a:avLst/>
@@ -36500,7 +36383,7 @@
                 <a:ea typeface="Arial" pitchFamily="34" charset="-122"/>
                 <a:cs typeface="Arial" pitchFamily="34" charset="-120"/>
               </a:rPr>
-              <a:t>Logic dies are stacked with HBM memory using advanced packaging like CoWoS.</a:t>
+              <a:t>The finished chip is bonded with high-speed memory into a single package ready to plug into a server.</a:t>
             </a:r>
             <a:endParaRPr lang="en-US" sz="1050" dirty="0"/>
           </a:p>
@@ -36508,46 +36391,7 @@
       </p:sp>
       <p:sp>
         <p:nvSpPr>
-          <p:cNvPr id="34" name="Text 32"/>
-          <p:cNvSpPr/>
-          <p:nvPr/>
-        </p:nvSpPr>
-        <p:spPr>
-          <a:xfrm>
-            <a:off x="5166360" y="5468112"/>
-            <a:ext cx="3520440" cy="182880"/>
-          </a:xfrm>
-          <a:prstGeom prst="rect">
-            <a:avLst/>
-          </a:prstGeom>
-          <a:noFill/>
-          <a:ln/>
-        </p:spPr>
-        <p:txBody>
-          <a:bodyPr wrap="square" lIns="0" tIns="0" rIns="0" bIns="0" rtlCol="0" anchor="t"/>
-          <a:lstStyle/>
-          <a:p>
-            <a:pPr indent="0" marL="0">
-              <a:buNone/>
-            </a:pPr>
-            <a:r>
-              <a:rPr lang="en-US" sz="900" i="1" dirty="0">
-                <a:solidFill>
-                  <a:srgbClr val="666666"/>
-                </a:solidFill>
-                <a:latin typeface="Arial" pitchFamily="34" charset="0"/>
-                <a:ea typeface="Arial" pitchFamily="34" charset="-122"/>
-                <a:cs typeface="Arial" pitchFamily="34" charset="-120"/>
-              </a:rPr>
-              <a:t>TSMC CoWoS · ASE · Amkor</a:t>
-            </a:r>
-            <a:endParaRPr lang="en-US" sz="900" dirty="0"/>
-          </a:p>
-        </p:txBody>
-      </p:sp>
-      <p:sp>
-        <p:nvSpPr>
-          <p:cNvPr id="35" name="Text 33"/>
+          <p:cNvPr id="31" name="Text 29"/>
           <p:cNvSpPr/>
           <p:nvPr/>
         </p:nvSpPr>
@@ -36586,7 +36430,7 @@
       </p:sp>
       <p:sp>
         <p:nvSpPr>
-          <p:cNvPr id="36" name="Shape 34"/>
+          <p:cNvPr id="32" name="Shape 30"/>
           <p:cNvSpPr/>
           <p:nvPr/>
         </p:nvSpPr>
@@ -36611,7 +36455,7 @@
       </p:sp>
       <p:sp>
         <p:nvSpPr>
-          <p:cNvPr id="37" name="Text 35"/>
+          <p:cNvPr id="33" name="Text 31"/>
           <p:cNvSpPr/>
           <p:nvPr/>
         </p:nvSpPr>
@@ -36650,7 +36494,7 @@
       </p:sp>
       <p:sp>
         <p:nvSpPr>
-          <p:cNvPr id="38" name="Text 36"/>
+          <p:cNvPr id="34" name="Text 32"/>
           <p:cNvSpPr/>
           <p:nvPr/>
         </p:nvSpPr>

</xml_diff>

<commit_message>
Slide 22: add a supporting paragraph beneath each takeaway
The barebones single-line points read as headlines without payoff. Add a 2-3 line follow-up under each that completes the thought (capex on credit -> balance-sheet risk; basket over -> alpha sits in selection; bottleneck moves -> next constraint captures margin; index = thesis -> deliberate sizing). Statement type drops to 15pt to make room; rows widen to 1.12" so the supporting block fits without colliding with the source line.

Co-Authored-By: Claude Opus 4.7 <noreply@anthropic.com>
</commit_message>
<xml_diff>
--- a/ai-markets-deck.pptx
+++ b/ai-markets-deck.pptx
@@ -24170,7 +24170,7 @@
         </p:nvSpPr>
         <p:spPr>
           <a:xfrm>
-            <a:off x="457200" y="1691640"/>
+            <a:off x="457200" y="1463040"/>
             <a:ext cx="868680" cy="868680"/>
           </a:xfrm>
           <a:prstGeom prst="rect">
@@ -24195,7 +24195,7 @@
         </p:nvSpPr>
         <p:spPr>
           <a:xfrm>
-            <a:off x="457200" y="1691640"/>
+            <a:off x="457200" y="1463040"/>
             <a:ext cx="868680" cy="868680"/>
           </a:xfrm>
           <a:prstGeom prst="rect">
@@ -24234,24 +24234,24 @@
         </p:nvSpPr>
         <p:spPr>
           <a:xfrm>
-            <a:off x="1508760" y="1691640"/>
-            <a:ext cx="7178040" cy="868680"/>
-          </a:xfrm>
-          <a:prstGeom prst="rect">
-            <a:avLst/>
-          </a:prstGeom>
-          <a:noFill/>
-          <a:ln/>
-        </p:spPr>
-        <p:txBody>
-          <a:bodyPr wrap="square" lIns="0" tIns="0" rIns="0" bIns="0" rtlCol="0" anchor="ctr"/>
-          <a:lstStyle/>
-          <a:p>
-            <a:pPr indent="0" marL="0">
-              <a:buNone/>
-            </a:pPr>
-            <a:r>
-              <a:rPr lang="en-US" sz="1800" b="1" dirty="0">
+            <a:off x="1508760" y="1481328"/>
+            <a:ext cx="7178040" cy="329184"/>
+          </a:xfrm>
+          <a:prstGeom prst="rect">
+            <a:avLst/>
+          </a:prstGeom>
+          <a:noFill/>
+          <a:ln/>
+        </p:spPr>
+        <p:txBody>
+          <a:bodyPr wrap="square" lIns="0" tIns="0" rIns="0" bIns="0" rtlCol="0" anchor="t"/>
+          <a:lstStyle/>
+          <a:p>
+            <a:pPr indent="0" marL="0">
+              <a:buNone/>
+            </a:pPr>
+            <a:r>
+              <a:rPr lang="en-US" sz="1500" b="1" dirty="0">
                 <a:solidFill>
                   <a:srgbClr val="333333"/>
                 </a:solidFill>
@@ -24261,19 +24261,58 @@
               </a:rPr>
               <a:t>The largest capex cycle in history is going on credit.</a:t>
             </a:r>
-            <a:endParaRPr lang="en-US" sz="1800" dirty="0"/>
-          </a:p>
-        </p:txBody>
-      </p:sp>
-      <p:sp>
-        <p:nvSpPr>
-          <p:cNvPr id="8" name="Shape 6"/>
-          <p:cNvSpPr/>
-          <p:nvPr/>
-        </p:nvSpPr>
-        <p:spPr>
-          <a:xfrm>
-            <a:off x="457200" y="2651760"/>
+            <a:endParaRPr lang="en-US" sz="1500" dirty="0"/>
+          </a:p>
+        </p:txBody>
+      </p:sp>
+      <p:sp>
+        <p:nvSpPr>
+          <p:cNvPr id="8" name="Text 6"/>
+          <p:cNvSpPr/>
+          <p:nvPr/>
+        </p:nvSpPr>
+        <p:spPr>
+          <a:xfrm>
+            <a:off x="1508760" y="1828800"/>
+            <a:ext cx="7178040" cy="621792"/>
+          </a:xfrm>
+          <a:prstGeom prst="rect">
+            <a:avLst/>
+          </a:prstGeom>
+          <a:noFill/>
+          <a:ln/>
+        </p:spPr>
+        <p:txBody>
+          <a:bodyPr wrap="square" lIns="0" tIns="0" rIns="0" bIns="0" rtlCol="0" anchor="t"/>
+          <a:lstStyle/>
+          <a:p>
+            <a:pPr indent="0" marL="0">
+              <a:buNone/>
+            </a:pPr>
+            <a:r>
+              <a:rPr lang="en-US" sz="1050" dirty="0">
+                <a:solidFill>
+                  <a:srgbClr val="666666"/>
+                </a:solidFill>
+                <a:latin typeface="Arial" pitchFamily="34" charset="0"/>
+                <a:ea typeface="Arial" pitchFamily="34" charset="-122"/>
+                <a:cs typeface="Arial" pitchFamily="34" charset="-120"/>
+              </a:rPr>
+              <a:t>Hyperscalers fund a record AI buildout with rising leverage, not free cash flow. The cycle's risk shifts from operations onto balance sheets, and credit conditions now matter as much as compute demand.</a:t>
+            </a:r>
+            <a:endParaRPr lang="en-US" sz="1050" dirty="0"/>
+          </a:p>
+        </p:txBody>
+      </p:sp>
+      <p:sp>
+        <p:nvSpPr>
+          <p:cNvPr id="9" name="Shape 7"/>
+          <p:cNvSpPr/>
+          <p:nvPr/>
+        </p:nvSpPr>
+        <p:spPr>
+          <a:xfrm>
+            <a:off x="457200" y="2487168"/>
             <a:ext cx="868680" cy="868680"/>
           </a:xfrm>
           <a:prstGeom prst="rect">
@@ -24292,13 +24331,13 @@
       </p:sp>
       <p:sp>
         <p:nvSpPr>
-          <p:cNvPr id="9" name="Text 7"/>
-          <p:cNvSpPr/>
-          <p:nvPr/>
-        </p:nvSpPr>
-        <p:spPr>
-          <a:xfrm>
-            <a:off x="457200" y="2651760"/>
+          <p:cNvPr id="10" name="Text 8"/>
+          <p:cNvSpPr/>
+          <p:nvPr/>
+        </p:nvSpPr>
+        <p:spPr>
+          <a:xfrm>
+            <a:off x="457200" y="2487168"/>
             <a:ext cx="868680" cy="868680"/>
           </a:xfrm>
           <a:prstGeom prst="rect">
@@ -24331,30 +24370,30 @@
       </p:sp>
       <p:sp>
         <p:nvSpPr>
-          <p:cNvPr id="10" name="Text 8"/>
-          <p:cNvSpPr/>
-          <p:nvPr/>
-        </p:nvSpPr>
-        <p:spPr>
-          <a:xfrm>
-            <a:off x="1508760" y="2651760"/>
-            <a:ext cx="7178040" cy="868680"/>
-          </a:xfrm>
-          <a:prstGeom prst="rect">
-            <a:avLst/>
-          </a:prstGeom>
-          <a:noFill/>
-          <a:ln/>
-        </p:spPr>
-        <p:txBody>
-          <a:bodyPr wrap="square" lIns="0" tIns="0" rIns="0" bIns="0" rtlCol="0" anchor="ctr"/>
-          <a:lstStyle/>
-          <a:p>
-            <a:pPr indent="0" marL="0">
-              <a:buNone/>
-            </a:pPr>
-            <a:r>
-              <a:rPr lang="en-US" sz="1800" b="1" dirty="0">
+          <p:cNvPr id="11" name="Text 9"/>
+          <p:cNvSpPr/>
+          <p:nvPr/>
+        </p:nvSpPr>
+        <p:spPr>
+          <a:xfrm>
+            <a:off x="1508760" y="2505456"/>
+            <a:ext cx="7178040" cy="329184"/>
+          </a:xfrm>
+          <a:prstGeom prst="rect">
+            <a:avLst/>
+          </a:prstGeom>
+          <a:noFill/>
+          <a:ln/>
+        </p:spPr>
+        <p:txBody>
+          <a:bodyPr wrap="square" lIns="0" tIns="0" rIns="0" bIns="0" rtlCol="0" anchor="t"/>
+          <a:lstStyle/>
+          <a:p>
+            <a:pPr indent="0" marL="0">
+              <a:buNone/>
+            </a:pPr>
+            <a:r>
+              <a:rPr lang="en-US" sz="1500" b="1" dirty="0">
                 <a:solidFill>
                   <a:srgbClr val="333333"/>
                 </a:solidFill>
@@ -24364,19 +24403,58 @@
               </a:rPr>
               <a:t>The basket trade is over. The market picks winners.</a:t>
             </a:r>
-            <a:endParaRPr lang="en-US" sz="1800" dirty="0"/>
-          </a:p>
-        </p:txBody>
-      </p:sp>
-      <p:sp>
-        <p:nvSpPr>
-          <p:cNvPr id="11" name="Shape 9"/>
-          <p:cNvSpPr/>
-          <p:nvPr/>
-        </p:nvSpPr>
-        <p:spPr>
-          <a:xfrm>
-            <a:off x="457200" y="3611880"/>
+            <a:endParaRPr lang="en-US" sz="1500" dirty="0"/>
+          </a:p>
+        </p:txBody>
+      </p:sp>
+      <p:sp>
+        <p:nvSpPr>
+          <p:cNvPr id="12" name="Text 10"/>
+          <p:cNvSpPr/>
+          <p:nvPr/>
+        </p:nvSpPr>
+        <p:spPr>
+          <a:xfrm>
+            <a:off x="1508760" y="2852928"/>
+            <a:ext cx="7178040" cy="621792"/>
+          </a:xfrm>
+          <a:prstGeom prst="rect">
+            <a:avLst/>
+          </a:prstGeom>
+          <a:noFill/>
+          <a:ln/>
+        </p:spPr>
+        <p:txBody>
+          <a:bodyPr wrap="square" lIns="0" tIns="0" rIns="0" bIns="0" rtlCol="0" anchor="t"/>
+          <a:lstStyle/>
+          <a:p>
+            <a:pPr indent="0" marL="0">
+              <a:buNone/>
+            </a:pPr>
+            <a:r>
+              <a:rPr lang="en-US" sz="1050" dirty="0">
+                <a:solidFill>
+                  <a:srgbClr val="666666"/>
+                </a:solidFill>
+                <a:latin typeface="Arial" pitchFamily="34" charset="0"/>
+                <a:ea typeface="Arial" pitchFamily="34" charset="-122"/>
+                <a:cs typeface="Arial" pitchFamily="34" charset="-120"/>
+              </a:rPr>
+              <a:t>Returns inside the AI complex have dispersed sharply. Owning the whole space no longer works; alpha now sits in choosing which layer of the stack, and which name within it, you actually want to own.</a:t>
+            </a:r>
+            <a:endParaRPr lang="en-US" sz="1050" dirty="0"/>
+          </a:p>
+        </p:txBody>
+      </p:sp>
+      <p:sp>
+        <p:nvSpPr>
+          <p:cNvPr id="13" name="Shape 11"/>
+          <p:cNvSpPr/>
+          <p:nvPr/>
+        </p:nvSpPr>
+        <p:spPr>
+          <a:xfrm>
+            <a:off x="457200" y="3511296"/>
             <a:ext cx="868680" cy="868680"/>
           </a:xfrm>
           <a:prstGeom prst="rect">
@@ -24395,13 +24473,13 @@
       </p:sp>
       <p:sp>
         <p:nvSpPr>
-          <p:cNvPr id="12" name="Text 10"/>
-          <p:cNvSpPr/>
-          <p:nvPr/>
-        </p:nvSpPr>
-        <p:spPr>
-          <a:xfrm>
-            <a:off x="457200" y="3611880"/>
+          <p:cNvPr id="14" name="Text 12"/>
+          <p:cNvSpPr/>
+          <p:nvPr/>
+        </p:nvSpPr>
+        <p:spPr>
+          <a:xfrm>
+            <a:off x="457200" y="3511296"/>
             <a:ext cx="868680" cy="868680"/>
           </a:xfrm>
           <a:prstGeom prst="rect">
@@ -24434,30 +24512,30 @@
       </p:sp>
       <p:sp>
         <p:nvSpPr>
-          <p:cNvPr id="13" name="Text 11"/>
-          <p:cNvSpPr/>
-          <p:nvPr/>
-        </p:nvSpPr>
-        <p:spPr>
-          <a:xfrm>
-            <a:off x="1508760" y="3611880"/>
-            <a:ext cx="7178040" cy="868680"/>
-          </a:xfrm>
-          <a:prstGeom prst="rect">
-            <a:avLst/>
-          </a:prstGeom>
-          <a:noFill/>
-          <a:ln/>
-        </p:spPr>
-        <p:txBody>
-          <a:bodyPr wrap="square" lIns="0" tIns="0" rIns="0" bIns="0" rtlCol="0" anchor="ctr"/>
-          <a:lstStyle/>
-          <a:p>
-            <a:pPr indent="0" marL="0">
-              <a:buNone/>
-            </a:pPr>
-            <a:r>
-              <a:rPr lang="en-US" sz="1800" b="1" dirty="0">
+          <p:cNvPr id="15" name="Text 13"/>
+          <p:cNvSpPr/>
+          <p:nvPr/>
+        </p:nvSpPr>
+        <p:spPr>
+          <a:xfrm>
+            <a:off x="1508760" y="3529584"/>
+            <a:ext cx="7178040" cy="329184"/>
+          </a:xfrm>
+          <a:prstGeom prst="rect">
+            <a:avLst/>
+          </a:prstGeom>
+          <a:noFill/>
+          <a:ln/>
+        </p:spPr>
+        <p:txBody>
+          <a:bodyPr wrap="square" lIns="0" tIns="0" rIns="0" bIns="0" rtlCol="0" anchor="t"/>
+          <a:lstStyle/>
+          <a:p>
+            <a:pPr indent="0" marL="0">
+              <a:buNone/>
+            </a:pPr>
+            <a:r>
+              <a:rPr lang="en-US" sz="1500" b="1" dirty="0">
                 <a:solidFill>
                   <a:srgbClr val="333333"/>
                 </a:solidFill>
@@ -24467,19 +24545,58 @@
               </a:rPr>
               <a:t>The bottleneck keeps moving. That is the opportunity.</a:t>
             </a:r>
-            <a:endParaRPr lang="en-US" sz="1800" dirty="0"/>
-          </a:p>
-        </p:txBody>
-      </p:sp>
-      <p:sp>
-        <p:nvSpPr>
-          <p:cNvPr id="14" name="Shape 12"/>
-          <p:cNvSpPr/>
-          <p:nvPr/>
-        </p:nvSpPr>
-        <p:spPr>
-          <a:xfrm>
-            <a:off x="457200" y="4572000"/>
+            <a:endParaRPr lang="en-US" sz="1500" dirty="0"/>
+          </a:p>
+        </p:txBody>
+      </p:sp>
+      <p:sp>
+        <p:nvSpPr>
+          <p:cNvPr id="16" name="Text 14"/>
+          <p:cNvSpPr/>
+          <p:nvPr/>
+        </p:nvSpPr>
+        <p:spPr>
+          <a:xfrm>
+            <a:off x="1508760" y="3877056"/>
+            <a:ext cx="7178040" cy="621792"/>
+          </a:xfrm>
+          <a:prstGeom prst="rect">
+            <a:avLst/>
+          </a:prstGeom>
+          <a:noFill/>
+          <a:ln/>
+        </p:spPr>
+        <p:txBody>
+          <a:bodyPr wrap="square" lIns="0" tIns="0" rIns="0" bIns="0" rtlCol="0" anchor="t"/>
+          <a:lstStyle/>
+          <a:p>
+            <a:pPr indent="0" marL="0">
+              <a:buNone/>
+            </a:pPr>
+            <a:r>
+              <a:rPr lang="en-US" sz="1050" dirty="0">
+                <a:solidFill>
+                  <a:srgbClr val="666666"/>
+                </a:solidFill>
+                <a:latin typeface="Arial" pitchFamily="34" charset="0"/>
+                <a:ea typeface="Arial" pitchFamily="34" charset="-122"/>
+                <a:cs typeface="Arial" pitchFamily="34" charset="-120"/>
+              </a:rPr>
+              <a:t>From foundry capacity to memory to advanced packaging to power and the grid, the binding constraint keeps shifting. Whoever owns the next bottleneck captures the margin until the next one forms.</a:t>
+            </a:r>
+            <a:endParaRPr lang="en-US" sz="1050" dirty="0"/>
+          </a:p>
+        </p:txBody>
+      </p:sp>
+      <p:sp>
+        <p:nvSpPr>
+          <p:cNvPr id="17" name="Shape 15"/>
+          <p:cNvSpPr/>
+          <p:nvPr/>
+        </p:nvSpPr>
+        <p:spPr>
+          <a:xfrm>
+            <a:off x="457200" y="4535424"/>
             <a:ext cx="868680" cy="868680"/>
           </a:xfrm>
           <a:prstGeom prst="rect">
@@ -24498,13 +24615,13 @@
       </p:sp>
       <p:sp>
         <p:nvSpPr>
-          <p:cNvPr id="15" name="Text 13"/>
-          <p:cNvSpPr/>
-          <p:nvPr/>
-        </p:nvSpPr>
-        <p:spPr>
-          <a:xfrm>
-            <a:off x="457200" y="4572000"/>
+          <p:cNvPr id="18" name="Text 16"/>
+          <p:cNvSpPr/>
+          <p:nvPr/>
+        </p:nvSpPr>
+        <p:spPr>
+          <a:xfrm>
+            <a:off x="457200" y="4535424"/>
             <a:ext cx="868680" cy="868680"/>
           </a:xfrm>
           <a:prstGeom prst="rect">
@@ -24537,30 +24654,30 @@
       </p:sp>
       <p:sp>
         <p:nvSpPr>
-          <p:cNvPr id="16" name="Text 14"/>
-          <p:cNvSpPr/>
-          <p:nvPr/>
-        </p:nvSpPr>
-        <p:spPr>
-          <a:xfrm>
-            <a:off x="1508760" y="4572000"/>
-            <a:ext cx="7178040" cy="868680"/>
-          </a:xfrm>
-          <a:prstGeom prst="rect">
-            <a:avLst/>
-          </a:prstGeom>
-          <a:noFill/>
-          <a:ln/>
-        </p:spPr>
-        <p:txBody>
-          <a:bodyPr wrap="square" lIns="0" tIns="0" rIns="0" bIns="0" rtlCol="0" anchor="ctr"/>
-          <a:lstStyle/>
-          <a:p>
-            <a:pPr indent="0" marL="0">
-              <a:buNone/>
-            </a:pPr>
-            <a:r>
-              <a:rPr lang="en-US" sz="1800" b="1" dirty="0">
+          <p:cNvPr id="19" name="Text 17"/>
+          <p:cNvSpPr/>
+          <p:nvPr/>
+        </p:nvSpPr>
+        <p:spPr>
+          <a:xfrm>
+            <a:off x="1508760" y="4553712"/>
+            <a:ext cx="7178040" cy="329184"/>
+          </a:xfrm>
+          <a:prstGeom prst="rect">
+            <a:avLst/>
+          </a:prstGeom>
+          <a:noFill/>
+          <a:ln/>
+        </p:spPr>
+        <p:txBody>
+          <a:bodyPr wrap="square" lIns="0" tIns="0" rIns="0" bIns="0" rtlCol="0" anchor="t"/>
+          <a:lstStyle/>
+          <a:p>
+            <a:pPr indent="0" marL="0">
+              <a:buNone/>
+            </a:pPr>
+            <a:r>
+              <a:rPr lang="en-US" sz="1500" b="1" dirty="0">
                 <a:solidFill>
                   <a:srgbClr val="333333"/>
                 </a:solidFill>
@@ -24570,13 +24687,52 @@
               </a:rPr>
               <a:t>If you index, you own the thesis. Choose it deliberately.</a:t>
             </a:r>
-            <a:endParaRPr lang="en-US" sz="1800" dirty="0"/>
-          </a:p>
-        </p:txBody>
-      </p:sp>
-      <p:sp>
-        <p:nvSpPr>
-          <p:cNvPr id="17" name="Text 15"/>
+            <a:endParaRPr lang="en-US" sz="1500" dirty="0"/>
+          </a:p>
+        </p:txBody>
+      </p:sp>
+      <p:sp>
+        <p:nvSpPr>
+          <p:cNvPr id="20" name="Text 18"/>
+          <p:cNvSpPr/>
+          <p:nvPr/>
+        </p:nvSpPr>
+        <p:spPr>
+          <a:xfrm>
+            <a:off x="1508760" y="4901184"/>
+            <a:ext cx="7178040" cy="621792"/>
+          </a:xfrm>
+          <a:prstGeom prst="rect">
+            <a:avLst/>
+          </a:prstGeom>
+          <a:noFill/>
+          <a:ln/>
+        </p:spPr>
+        <p:txBody>
+          <a:bodyPr wrap="square" lIns="0" tIns="0" rIns="0" bIns="0" rtlCol="0" anchor="t"/>
+          <a:lstStyle/>
+          <a:p>
+            <a:pPr indent="0" marL="0">
+              <a:buNone/>
+            </a:pPr>
+            <a:r>
+              <a:rPr lang="en-US" sz="1050" dirty="0">
+                <a:solidFill>
+                  <a:srgbClr val="666666"/>
+                </a:solidFill>
+                <a:latin typeface="Arial" pitchFamily="34" charset="0"/>
+                <a:ea typeface="Arial" pitchFamily="34" charset="-122"/>
+                <a:cs typeface="Arial" pitchFamily="34" charset="-120"/>
+              </a:rPr>
+              <a:t>US large-cap indices already embed AI capex exposure at concentrated weights. Recognize that exposure, size it, or hedge it, but the position should be a deliberate choice rather than a default.</a:t>
+            </a:r>
+            <a:endParaRPr lang="en-US" sz="1050" dirty="0"/>
+          </a:p>
+        </p:txBody>
+      </p:sp>
+      <p:sp>
+        <p:nvSpPr>
+          <p:cNvPr id="21" name="Text 19"/>
           <p:cNvSpPr/>
           <p:nvPr/>
         </p:nvSpPr>
@@ -24615,7 +24771,7 @@
       </p:sp>
       <p:sp>
         <p:nvSpPr>
-          <p:cNvPr id="18" name="Shape 16"/>
+          <p:cNvPr id="22" name="Shape 20"/>
           <p:cNvSpPr/>
           <p:nvPr/>
         </p:nvSpPr>
@@ -24640,7 +24796,7 @@
       </p:sp>
       <p:sp>
         <p:nvSpPr>
-          <p:cNvPr id="19" name="Text 17"/>
+          <p:cNvPr id="23" name="Text 21"/>
           <p:cNvSpPr/>
           <p:nvPr/>
         </p:nvSpPr>
@@ -24679,7 +24835,7 @@
       </p:sp>
       <p:sp>
         <p:nvSpPr>
-          <p:cNvPr id="20" name="Text 18"/>
+          <p:cNvPr id="24" name="Text 22"/>
           <p:cNvSpPr/>
           <p:nvPr/>
         </p:nvSpPr>

</xml_diff>

<commit_message>
Slide 22: reframe takeaway #1 around historical scale, not credit
Drop the leverage/credit framing. The first point now anchors on the historic significance of the moment: hyperscaler 2026 AI capex exceeds the inflation-adjusted total cost of the entire Apollo program (Planetary Society / NASA, ~$290B in 2024 dollars) and is roughly 3x peak dot-com telecom capex (Richmond Fed, ~$215B in 2024 dollars at the 2000 peak).

Statement: "The AI buildout has no modern precedent in scale."
Headline phrase updated from "Capex on credit" to "Generational scale" to match.
Source line swaps CreditSights/MUFG for Planetary Society / NASA and Richmond Fed.

Co-Authored-By: Claude Opus 4.7 <noreply@anthropic.com>
</commit_message>
<xml_diff>
--- a/ai-markets-deck.pptx
+++ b/ai-markets-deck.pptx
@@ -24094,7 +24094,7 @@
                 <a:ea typeface="Arial Black" pitchFamily="34" charset="-122"/>
                 <a:cs typeface="Arial Black" pitchFamily="34" charset="-120"/>
               </a:rPr>
-              <a:t>Capex on credit. Basket over. Bottleneck moves. Exposure is a thesis.</a:t>
+              <a:t>Generational scale. Basket over. Bottleneck moves. Exposure is a thesis.</a:t>
             </a:r>
             <a:endParaRPr lang="en-US" sz="2400" dirty="0"/>
           </a:p>
@@ -24259,7 +24259,7 @@
                 <a:ea typeface="Arial" pitchFamily="34" charset="-122"/>
                 <a:cs typeface="Arial" pitchFamily="34" charset="-120"/>
               </a:rPr>
-              <a:t>The largest capex cycle in history is going on credit.</a:t>
+              <a:t>The AI buildout has no modern precedent in scale.</a:t>
             </a:r>
             <a:endParaRPr lang="en-US" sz="1500" dirty="0"/>
           </a:p>
@@ -24298,7 +24298,7 @@
                 <a:ea typeface="Arial" pitchFamily="34" charset="-122"/>
                 <a:cs typeface="Arial" pitchFamily="34" charset="-120"/>
               </a:rPr>
-              <a:t>Hyperscalers fund a record AI buildout with rising leverage, not free cash flow. The cycle's risk shifts from operations onto balance sheets, and credit conditions now matter as much as compute demand.</a:t>
+              <a:t>In 2026 alone, hyperscalers will spend more on AI infrastructure than the inflation-adjusted cost of the entire Apollo program, and roughly three times peak dot-com telecom capex. The scale itself is the story.</a:t>
             </a:r>
             <a:endParaRPr lang="en-US" sz="1050" dirty="0"/>
           </a:p>
@@ -24763,7 +24763,7 @@
                 <a:ea typeface="Arial" pitchFamily="34" charset="-122"/>
                 <a:cs typeface="Arial" pitchFamily="34" charset="-120"/>
               </a:rPr>
-              <a:t>Sources: company filings; CreditSights / MUFG; Goldman Sachs; SemiAnalysis; BofA; TrendForce. See appendix for figure-by-figure citations.</a:t>
+              <a:t>Sources: company filings; Planetary Society / NASA Apollo cost data; Richmond Fed dot-com telecom capex; Goldman Sachs; SemiAnalysis; BofA; TrendForce. See appendix for figure-by-figure citations.</a:t>
             </a:r>
             <a:endParaRPr lang="en-US" sz="700" dirty="0"/>
           </a:p>

</xml_diff>

<commit_message>
Slide 22: rewrite all four titles to state each point directly
Drop the punchy/cryptic phrasing in favor of declarative statements that read as the takeaway itself. Each title now stands alone as the claim; the supporting paragraph fleshes it out without restating.

01: "AI is the largest single-technology capex cycle in modern history."
02: "The basket trade is over. Stock selection now drives AI returns."
03: "The bottleneck moves through the AI stack. Own the next one."
04: "If you index, you already own the AI capex thesis."

Co-Authored-By: Claude Opus 4.7 <noreply@anthropic.com>
</commit_message>
<xml_diff>
--- a/ai-markets-deck.pptx
+++ b/ai-markets-deck.pptx
@@ -24259,7 +24259,7 @@
                 <a:ea typeface="Arial" pitchFamily="34" charset="-122"/>
                 <a:cs typeface="Arial" pitchFamily="34" charset="-120"/>
               </a:rPr>
-              <a:t>The AI buildout has no modern precedent in scale.</a:t>
+              <a:t>AI is the largest single-technology capex cycle in modern history.</a:t>
             </a:r>
             <a:endParaRPr lang="en-US" sz="1500" dirty="0"/>
           </a:p>
@@ -24401,7 +24401,7 @@
                 <a:ea typeface="Arial" pitchFamily="34" charset="-122"/>
                 <a:cs typeface="Arial" pitchFamily="34" charset="-120"/>
               </a:rPr>
-              <a:t>The basket trade is over. The market picks winners.</a:t>
+              <a:t>The basket trade is over. Stock selection now drives AI returns.</a:t>
             </a:r>
             <a:endParaRPr lang="en-US" sz="1500" dirty="0"/>
           </a:p>
@@ -24543,7 +24543,7 @@
                 <a:ea typeface="Arial" pitchFamily="34" charset="-122"/>
                 <a:cs typeface="Arial" pitchFamily="34" charset="-120"/>
               </a:rPr>
-              <a:t>The bottleneck keeps moving. That is the opportunity.</a:t>
+              <a:t>The bottleneck moves through the AI stack. Own the next one.</a:t>
             </a:r>
             <a:endParaRPr lang="en-US" sz="1500" dirty="0"/>
           </a:p>
@@ -24685,7 +24685,7 @@
                 <a:ea typeface="Arial" pitchFamily="34" charset="-122"/>
                 <a:cs typeface="Arial" pitchFamily="34" charset="-120"/>
               </a:rPr>
-              <a:t>If you index, you own the thesis. Choose it deliberately.</a:t>
+              <a:t>If you index, you already own the AI capex thesis.</a:t>
             </a:r>
             <a:endParaRPr lang="en-US" sz="1500" dirty="0"/>
           </a:p>

</xml_diff>

<commit_message>
Slide 22: soften takeaway #1, drop specific historical comparisons
Pull the Apollo program and dot-com telecom comparisons from the support text. While those numbers are sourced (Planetary Society / NASA, Richmond Fed), specific historical claims invite counter-citations and a debate the slide does not need.

New title: "AI is the defining capital-allocation event of this decade."
New support describes hyperscaler capex reshaping power grids, real estate, and supply chains, and being the dominant driver of US business investment. Compelling and directionally defensible without staking a flag on a contested number.

Source line cleaned up to drop NASA / Planetary Society / Richmond Fed references that no longer apply.

Co-Authored-By: Claude Opus 4.7 <noreply@anthropic.com>
</commit_message>
<xml_diff>
--- a/ai-markets-deck.pptx
+++ b/ai-markets-deck.pptx
@@ -24259,7 +24259,7 @@
                 <a:ea typeface="Arial" pitchFamily="34" charset="-122"/>
                 <a:cs typeface="Arial" pitchFamily="34" charset="-120"/>
               </a:rPr>
-              <a:t>AI is the largest single-technology capex cycle in modern history.</a:t>
+              <a:t>AI is the defining capital-allocation event of this decade.</a:t>
             </a:r>
             <a:endParaRPr lang="en-US" sz="1500" dirty="0"/>
           </a:p>
@@ -24298,7 +24298,7 @@
                 <a:ea typeface="Arial" pitchFamily="34" charset="-122"/>
                 <a:cs typeface="Arial" pitchFamily="34" charset="-120"/>
               </a:rPr>
-              <a:t>In 2026 alone, hyperscalers will spend more on AI infrastructure than the inflation-adjusted cost of the entire Apollo program, and roughly three times peak dot-com telecom capex. The scale itself is the story.</a:t>
+              <a:t>A handful of hyperscalers are deploying capital fast enough to reshape power grids, real estate, and global supply chains all at once. AI capex has become the dominant driver of US business investment, and the scale itself is the story.</a:t>
             </a:r>
             <a:endParaRPr lang="en-US" sz="1050" dirty="0"/>
           </a:p>
@@ -24763,7 +24763,7 @@
                 <a:ea typeface="Arial" pitchFamily="34" charset="-122"/>
                 <a:cs typeface="Arial" pitchFamily="34" charset="-120"/>
               </a:rPr>
-              <a:t>Sources: company filings; Planetary Society / NASA Apollo cost data; Richmond Fed dot-com telecom capex; Goldman Sachs; SemiAnalysis; BofA; TrendForce. See appendix for figure-by-figure citations.</a:t>
+              <a:t>Sources: company filings; Goldman Sachs; SemiAnalysis; BofA; TrendForce. See appendix for figure-by-figure citations.</a:t>
             </a:r>
             <a:endParaRPr lang="en-US" sz="700" dirty="0"/>
           </a:p>

</xml_diff>

<commit_message>
Slide 22: rewrite takeaways 2/3/4 plus headline
Replace "basket trade is over" framing in #2 with a winners-vs-losers cut: foundries, memory, and AI infrastructure surging while parts of legacy software and SaaS get cannibalized.

Replace "own the next one" framing in #3 with the evolution-of-the-trade story: yesterday foundry capacity, today memory and packaging, tomorrow power and the grid.

Restore the deployed site's #4 framing: "The question isn't whether you have AI exposure. It's whether you chose it."

Headline mirrors the new bullets: "Generational scale. Winners diverge. Trade evolves. Exposure is a thesis."

Co-Authored-By: Claude Opus 4.7 <noreply@anthropic.com>
</commit_message>
<xml_diff>
--- a/ai-markets-deck.pptx
+++ b/ai-markets-deck.pptx
@@ -24094,7 +24094,7 @@
                 <a:ea typeface="Arial Black" pitchFamily="34" charset="-122"/>
                 <a:cs typeface="Arial Black" pitchFamily="34" charset="-120"/>
               </a:rPr>
-              <a:t>Generational scale. Basket over. Bottleneck moves. Exposure is a thesis.</a:t>
+              <a:t>Generational scale. Winners diverge. Trade evolves. Exposure is a thesis.</a:t>
             </a:r>
             <a:endParaRPr lang="en-US" sz="2400" dirty="0"/>
           </a:p>
@@ -24401,7 +24401,7 @@
                 <a:ea typeface="Arial" pitchFamily="34" charset="-122"/>
                 <a:cs typeface="Arial" pitchFamily="34" charset="-120"/>
               </a:rPr>
-              <a:t>The basket trade is over. Stock selection now drives AI returns.</a:t>
+              <a:t>The AI buildout is producing sharp winners and sharp losers.</a:t>
             </a:r>
             <a:endParaRPr lang="en-US" sz="1500" dirty="0"/>
           </a:p>
@@ -24440,7 +24440,7 @@
                 <a:ea typeface="Arial" pitchFamily="34" charset="-122"/>
                 <a:cs typeface="Arial" pitchFamily="34" charset="-120"/>
               </a:rPr>
-              <a:t>Returns inside the AI complex have dispersed sharply. Owning the whole space no longer works; alpha now sits in choosing which layer of the stack, and which name within it, you actually want to own.</a:t>
+              <a:t>Foundries, memory, and the picks-and-shovels of AI infrastructure are surging, while parts of legacy software and SaaS are getting cannibalized by AI-native competitors. Returns inside the AI complex have dispersed sharply, and the spread keeps widening.</a:t>
             </a:r>
             <a:endParaRPr lang="en-US" sz="1050" dirty="0"/>
           </a:p>
@@ -24543,7 +24543,7 @@
                 <a:ea typeface="Arial" pitchFamily="34" charset="-122"/>
                 <a:cs typeface="Arial" pitchFamily="34" charset="-120"/>
               </a:rPr>
-              <a:t>The bottleneck moves through the AI stack. Own the next one.</a:t>
+              <a:t>The AI trade keeps evolving as bottlenecks shift through the stack.</a:t>
             </a:r>
             <a:endParaRPr lang="en-US" sz="1500" dirty="0"/>
           </a:p>
@@ -24582,7 +24582,7 @@
                 <a:ea typeface="Arial" pitchFamily="34" charset="-122"/>
                 <a:cs typeface="Arial" pitchFamily="34" charset="-120"/>
               </a:rPr>
-              <a:t>From foundry capacity to memory to advanced packaging to power and the grid, the binding constraint keeps shifting. Whoever owns the next bottleneck captures the margin until the next one forms.</a:t>
+              <a:t>Yesterday it was foundry capacity. Today it is memory and advanced packaging. Tomorrow it will be power and the grid. The binding constraint keeps moving, and the names that lead the trade move with it.</a:t>
             </a:r>
             <a:endParaRPr lang="en-US" sz="1050" dirty="0"/>
           </a:p>
@@ -24685,7 +24685,7 @@
                 <a:ea typeface="Arial" pitchFamily="34" charset="-122"/>
                 <a:cs typeface="Arial" pitchFamily="34" charset="-120"/>
               </a:rPr>
-              <a:t>If you index, you already own the AI capex thesis.</a:t>
+              <a:t>The question isn't whether you have AI exposure. It's whether you chose it.</a:t>
             </a:r>
             <a:endParaRPr lang="en-US" sz="1500" dirty="0"/>
           </a:p>

</xml_diff>

<commit_message>
Slide 10: add column headers and refresh stale numbers
Add LAB / VALUATION / MULTIPLE / RECENT EVENT column headers above the four-row lab table so each number is clearly labeled rather than just a stack of orange figures.

Refresh data per Apr 2026 verification:
- Google: $2.3T → $4.0T market cap, ~20× → ~31× P/E, ~$85B → ~$180B 2026 capex (companiesmarketcap, Q4 2025 Alphabet capex guide). The old numbers were materially stale.
- OpenAI: round date "Apr 2026" → "Mar 2026" (round closed Mar 31, CNBC).
- Anthropic: add Google's Apr $40B investment to the recent-event line (TechCrunch, 2026-04-24).

Appendix and citation 1 updated to match.

Co-Authored-By: Claude Opus 4.7 <noreply@anthropic.com>
</commit_message>
<xml_diff>
--- a/ai-markets-deck.pptx
+++ b/ai-markets-deck.pptx
@@ -5015,7 +5015,186 @@
       </p:sp>
       <p:sp>
         <p:nvSpPr>
-          <p:cNvPr id="7" name="Shape 5"/>
+          <p:cNvPr id="7" name="Text 5"/>
+          <p:cNvSpPr/>
+          <p:nvPr/>
+        </p:nvSpPr>
+        <p:spPr>
+          <a:xfrm>
+            <a:off x="640080" y="1417320"/>
+            <a:ext cx="2468880" cy="201168"/>
+          </a:xfrm>
+          <a:prstGeom prst="rect">
+            <a:avLst/>
+          </a:prstGeom>
+          <a:noFill/>
+          <a:ln/>
+        </p:spPr>
+        <p:txBody>
+          <a:bodyPr wrap="square" lIns="0" tIns="0" rIns="0" bIns="0" rtlCol="0" anchor="ctr"/>
+          <a:lstStyle/>
+          <a:p>
+            <a:pPr indent="0" marL="0">
+              <a:buNone/>
+            </a:pPr>
+            <a:r>
+              <a:rPr lang="en-US" sz="900" b="1" spc="200" kern="0" dirty="0">
+                <a:solidFill>
+                  <a:srgbClr val="666666"/>
+                </a:solidFill>
+                <a:latin typeface="Arial" pitchFamily="34" charset="0"/>
+                <a:ea typeface="Arial" pitchFamily="34" charset="-122"/>
+                <a:cs typeface="Arial" pitchFamily="34" charset="-120"/>
+              </a:rPr>
+              <a:t>LAB</a:t>
+            </a:r>
+            <a:endParaRPr lang="en-US" sz="900" dirty="0"/>
+          </a:p>
+        </p:txBody>
+      </p:sp>
+      <p:sp>
+        <p:nvSpPr>
+          <p:cNvPr id="8" name="Text 6"/>
+          <p:cNvSpPr/>
+          <p:nvPr/>
+        </p:nvSpPr>
+        <p:spPr>
+          <a:xfrm>
+            <a:off x="3200400" y="1417320"/>
+            <a:ext cx="1280160" cy="201168"/>
+          </a:xfrm>
+          <a:prstGeom prst="rect">
+            <a:avLst/>
+          </a:prstGeom>
+          <a:noFill/>
+          <a:ln/>
+        </p:spPr>
+        <p:txBody>
+          <a:bodyPr wrap="square" lIns="0" tIns="0" rIns="0" bIns="0" rtlCol="0" anchor="ctr"/>
+          <a:lstStyle/>
+          <a:p>
+            <a:pPr algn="ctr" indent="0" marL="0">
+              <a:buNone/>
+            </a:pPr>
+            <a:r>
+              <a:rPr lang="en-US" sz="900" b="1" spc="200" kern="0" dirty="0">
+                <a:solidFill>
+                  <a:srgbClr val="666666"/>
+                </a:solidFill>
+                <a:latin typeface="Arial" pitchFamily="34" charset="0"/>
+                <a:ea typeface="Arial" pitchFamily="34" charset="-122"/>
+                <a:cs typeface="Arial" pitchFamily="34" charset="-120"/>
+              </a:rPr>
+              <a:t>VALUATION</a:t>
+            </a:r>
+            <a:endParaRPr lang="en-US" sz="900" dirty="0"/>
+          </a:p>
+        </p:txBody>
+      </p:sp>
+      <p:sp>
+        <p:nvSpPr>
+          <p:cNvPr id="9" name="Text 7"/>
+          <p:cNvSpPr/>
+          <p:nvPr/>
+        </p:nvSpPr>
+        <p:spPr>
+          <a:xfrm>
+            <a:off x="4480560" y="1417320"/>
+            <a:ext cx="1188720" cy="201168"/>
+          </a:xfrm>
+          <a:prstGeom prst="rect">
+            <a:avLst/>
+          </a:prstGeom>
+          <a:noFill/>
+          <a:ln/>
+        </p:spPr>
+        <p:txBody>
+          <a:bodyPr wrap="square" lIns="0" tIns="0" rIns="0" bIns="0" rtlCol="0" anchor="ctr"/>
+          <a:lstStyle/>
+          <a:p>
+            <a:pPr algn="ctr" indent="0" marL="0">
+              <a:buNone/>
+            </a:pPr>
+            <a:r>
+              <a:rPr lang="en-US" sz="900" b="1" spc="200" kern="0" dirty="0">
+                <a:solidFill>
+                  <a:srgbClr val="666666"/>
+                </a:solidFill>
+                <a:latin typeface="Arial" pitchFamily="34" charset="0"/>
+                <a:ea typeface="Arial" pitchFamily="34" charset="-122"/>
+                <a:cs typeface="Arial" pitchFamily="34" charset="-120"/>
+              </a:rPr>
+              <a:t>MULTIPLE</a:t>
+            </a:r>
+            <a:endParaRPr lang="en-US" sz="900" dirty="0"/>
+          </a:p>
+        </p:txBody>
+      </p:sp>
+      <p:sp>
+        <p:nvSpPr>
+          <p:cNvPr id="10" name="Text 8"/>
+          <p:cNvSpPr/>
+          <p:nvPr/>
+        </p:nvSpPr>
+        <p:spPr>
+          <a:xfrm>
+            <a:off x="5760720" y="1417320"/>
+            <a:ext cx="2834640" cy="201168"/>
+          </a:xfrm>
+          <a:prstGeom prst="rect">
+            <a:avLst/>
+          </a:prstGeom>
+          <a:noFill/>
+          <a:ln/>
+        </p:spPr>
+        <p:txBody>
+          <a:bodyPr wrap="square" lIns="0" tIns="0" rIns="0" bIns="0" rtlCol="0" anchor="ctr"/>
+          <a:lstStyle/>
+          <a:p>
+            <a:pPr indent="0" marL="0">
+              <a:buNone/>
+            </a:pPr>
+            <a:r>
+              <a:rPr lang="en-US" sz="900" b="1" spc="200" kern="0" dirty="0">
+                <a:solidFill>
+                  <a:srgbClr val="666666"/>
+                </a:solidFill>
+                <a:latin typeface="Arial" pitchFamily="34" charset="0"/>
+                <a:ea typeface="Arial" pitchFamily="34" charset="-122"/>
+                <a:cs typeface="Arial" pitchFamily="34" charset="-120"/>
+              </a:rPr>
+              <a:t>RECENT EVENT</a:t>
+            </a:r>
+            <a:endParaRPr lang="en-US" sz="900" dirty="0"/>
+          </a:p>
+        </p:txBody>
+      </p:sp>
+      <p:sp>
+        <p:nvSpPr>
+          <p:cNvPr id="11" name="Shape 9"/>
+          <p:cNvSpPr/>
+          <p:nvPr/>
+        </p:nvSpPr>
+        <p:spPr>
+          <a:xfrm>
+            <a:off x="457200" y="1645920"/>
+            <a:ext cx="8229600" cy="0"/>
+          </a:xfrm>
+          <a:prstGeom prst="line">
+            <a:avLst/>
+          </a:prstGeom>
+          <a:noFill/>
+          <a:ln w="6350">
+            <a:solidFill>
+              <a:srgbClr val="E5E5E5"/>
+            </a:solidFill>
+            <a:prstDash val="solid"/>
+          </a:ln>
+        </p:spPr>
+      </p:sp>
+      <p:sp>
+        <p:nvSpPr>
+          <p:cNvPr id="12" name="Shape 10"/>
           <p:cNvSpPr/>
           <p:nvPr/>
         </p:nvSpPr>
@@ -5040,7 +5219,7 @@
       </p:sp>
       <p:pic>
         <p:nvPicPr>
-          <p:cNvPr id="8" name="Image 0" descr="logos/openai.png">    </p:cNvPr>
+          <p:cNvPr id="13" name="Image 0" descr="logos/openai.png">    </p:cNvPr>
           <p:cNvPicPr>
             <a:picLocks noChangeAspect="1"/>
           </p:cNvPicPr>
@@ -5063,7 +5242,7 @@
       </p:pic>
       <p:sp>
         <p:nvSpPr>
-          <p:cNvPr id="9" name="Text 6"/>
+          <p:cNvPr id="14" name="Text 11"/>
           <p:cNvSpPr/>
           <p:nvPr/>
         </p:nvSpPr>
@@ -5102,7 +5281,7 @@
       </p:sp>
       <p:sp>
         <p:nvSpPr>
-          <p:cNvPr id="10" name="Text 7"/>
+          <p:cNvPr id="15" name="Text 12"/>
           <p:cNvSpPr/>
           <p:nvPr/>
         </p:nvSpPr>
@@ -5155,7 +5334,7 @@
       </p:sp>
       <p:sp>
         <p:nvSpPr>
-          <p:cNvPr id="11" name="Text 8"/>
+          <p:cNvPr id="16" name="Text 13"/>
           <p:cNvSpPr/>
           <p:nvPr/>
         </p:nvSpPr>
@@ -5194,7 +5373,7 @@
       </p:sp>
       <p:sp>
         <p:nvSpPr>
-          <p:cNvPr id="12" name="Text 9"/>
+          <p:cNvPr id="17" name="Text 14"/>
           <p:cNvSpPr/>
           <p:nvPr/>
         </p:nvSpPr>
@@ -5225,7 +5404,7 @@
                 <a:ea typeface="Arial" pitchFamily="34" charset="-122"/>
                 <a:cs typeface="Arial" pitchFamily="34" charset="-120"/>
               </a:rPr>
-              <a:t>$122B round · AMZN / NVDA / SoftBank · Apr 2026</a:t>
+              <a:t>$122B round · AMZN / NVDA / SoftBank · Mar 2026</a:t>
             </a:r>
             <a:endParaRPr lang="en-US" sz="1100" dirty="0"/>
           </a:p>
@@ -5233,7 +5412,7 @@
       </p:sp>
       <p:sp>
         <p:nvSpPr>
-          <p:cNvPr id="13" name="Shape 10"/>
+          <p:cNvPr id="18" name="Shape 15"/>
           <p:cNvSpPr/>
           <p:nvPr/>
         </p:nvSpPr>
@@ -5258,7 +5437,7 @@
       </p:sp>
       <p:pic>
         <p:nvPicPr>
-          <p:cNvPr id="14" name="Image 1" descr="logos/anthropic.png">    </p:cNvPr>
+          <p:cNvPr id="19" name="Image 1" descr="logos/anthropic.png">    </p:cNvPr>
           <p:cNvPicPr>
             <a:picLocks noChangeAspect="1"/>
           </p:cNvPicPr>
@@ -5281,7 +5460,7 @@
       </p:pic>
       <p:sp>
         <p:nvSpPr>
-          <p:cNvPr id="15" name="Text 11"/>
+          <p:cNvPr id="20" name="Text 16"/>
           <p:cNvSpPr/>
           <p:nvPr/>
         </p:nvSpPr>
@@ -5320,7 +5499,7 @@
       </p:sp>
       <p:sp>
         <p:nvSpPr>
-          <p:cNvPr id="16" name="Text 12"/>
+          <p:cNvPr id="21" name="Text 17"/>
           <p:cNvSpPr/>
           <p:nvPr/>
         </p:nvSpPr>
@@ -5373,7 +5552,7 @@
       </p:sp>
       <p:sp>
         <p:nvSpPr>
-          <p:cNvPr id="17" name="Text 13"/>
+          <p:cNvPr id="22" name="Text 18"/>
           <p:cNvSpPr/>
           <p:nvPr/>
         </p:nvSpPr>
@@ -5412,7 +5591,7 @@
       </p:sp>
       <p:sp>
         <p:nvSpPr>
-          <p:cNvPr id="18" name="Text 14"/>
+          <p:cNvPr id="23" name="Text 19"/>
           <p:cNvSpPr/>
           <p:nvPr/>
         </p:nvSpPr>
@@ -5443,7 +5622,7 @@
                 <a:ea typeface="Arial" pitchFamily="34" charset="-122"/>
                 <a:cs typeface="Arial" pitchFamily="34" charset="-120"/>
               </a:rPr>
-              <a:t>$30B Series G (Feb); VCs now offering $800B+</a:t>
+              <a:t>$30B Series G (Feb); Google $40B (Apr); VCs offering $800B+</a:t>
             </a:r>
             <a:endParaRPr lang="en-US" sz="1100" dirty="0"/>
           </a:p>
@@ -5451,7 +5630,7 @@
       </p:sp>
       <p:sp>
         <p:nvSpPr>
-          <p:cNvPr id="19" name="Shape 15"/>
+          <p:cNvPr id="24" name="Shape 20"/>
           <p:cNvSpPr/>
           <p:nvPr/>
         </p:nvSpPr>
@@ -5476,7 +5655,7 @@
       </p:sp>
       <p:pic>
         <p:nvPicPr>
-          <p:cNvPr id="20" name="Image 2" descr="logos/google.png">    </p:cNvPr>
+          <p:cNvPr id="25" name="Image 2" descr="logos/google.png">    </p:cNvPr>
           <p:cNvPicPr>
             <a:picLocks noChangeAspect="1"/>
           </p:cNvPicPr>
@@ -5499,7 +5678,7 @@
       </p:pic>
       <p:sp>
         <p:nvSpPr>
-          <p:cNvPr id="21" name="Text 16"/>
+          <p:cNvPr id="26" name="Text 21"/>
           <p:cNvSpPr/>
           <p:nvPr/>
         </p:nvSpPr>
@@ -5538,7 +5717,7 @@
       </p:sp>
       <p:sp>
         <p:nvSpPr>
-          <p:cNvPr id="22" name="Text 17"/>
+          <p:cNvPr id="27" name="Text 22"/>
           <p:cNvSpPr/>
           <p:nvPr/>
         </p:nvSpPr>
@@ -5569,7 +5748,7 @@
                 <a:ea typeface="Arial Black" pitchFamily="34" charset="-122"/>
                 <a:cs typeface="Arial Black" pitchFamily="34" charset="-120"/>
               </a:rPr>
-              <a:t>$2.3T</a:t>
+              <a:t>$4.0T</a:t>
             </a:r>
             <a:pPr algn="ctr" indent="0" marL="0">
               <a:buNone/>
@@ -5591,7 +5770,7 @@
       </p:sp>
       <p:sp>
         <p:nvSpPr>
-          <p:cNvPr id="23" name="Text 18"/>
+          <p:cNvPr id="28" name="Text 23"/>
           <p:cNvSpPr/>
           <p:nvPr/>
         </p:nvSpPr>
@@ -5622,7 +5801,7 @@
                 <a:ea typeface="Arial" pitchFamily="34" charset="-122"/>
                 <a:cs typeface="Arial" pitchFamily="34" charset="-120"/>
               </a:rPr>
-              <a:t>~20× P/E</a:t>
+              <a:t>~31× P/E</a:t>
             </a:r>
             <a:endParaRPr lang="en-US" sz="1200" dirty="0"/>
           </a:p>
@@ -5630,7 +5809,7 @@
       </p:sp>
       <p:sp>
         <p:nvSpPr>
-          <p:cNvPr id="24" name="Text 19"/>
+          <p:cNvPr id="29" name="Text 24"/>
           <p:cNvSpPr/>
           <p:nvPr/>
         </p:nvSpPr>
@@ -5661,7 +5840,7 @@
                 <a:ea typeface="Arial" pitchFamily="34" charset="-122"/>
                 <a:cs typeface="Arial" pitchFamily="34" charset="-120"/>
               </a:rPr>
-              <a:t>Alphabet (public) · Gemini 3 / DeepMind · ~$85B 2026 capex</a:t>
+              <a:t>Alphabet (public) · Gemini 3 / DeepMind · ~$180B 2026 capex</a:t>
             </a:r>
             <a:endParaRPr lang="en-US" sz="1100" dirty="0"/>
           </a:p>
@@ -5669,7 +5848,7 @@
       </p:sp>
       <p:sp>
         <p:nvSpPr>
-          <p:cNvPr id="25" name="Shape 20"/>
+          <p:cNvPr id="30" name="Shape 25"/>
           <p:cNvSpPr/>
           <p:nvPr/>
         </p:nvSpPr>
@@ -5694,7 +5873,7 @@
       </p:sp>
       <p:pic>
         <p:nvPicPr>
-          <p:cNvPr id="26" name="Image 3" descr="logos/xai.png">    </p:cNvPr>
+          <p:cNvPr id="31" name="Image 3" descr="logos/xai.png">    </p:cNvPr>
           <p:cNvPicPr>
             <a:picLocks noChangeAspect="1"/>
           </p:cNvPicPr>
@@ -5717,7 +5896,7 @@
       </p:pic>
       <p:sp>
         <p:nvSpPr>
-          <p:cNvPr id="27" name="Text 21"/>
+          <p:cNvPr id="32" name="Text 26"/>
           <p:cNvSpPr/>
           <p:nvPr/>
         </p:nvSpPr>
@@ -5756,7 +5935,7 @@
       </p:sp>
       <p:sp>
         <p:nvSpPr>
-          <p:cNvPr id="28" name="Text 22"/>
+          <p:cNvPr id="33" name="Text 27"/>
           <p:cNvSpPr/>
           <p:nvPr/>
         </p:nvSpPr>
@@ -5809,7 +5988,7 @@
       </p:sp>
       <p:sp>
         <p:nvSpPr>
-          <p:cNvPr id="29" name="Text 23"/>
+          <p:cNvPr id="34" name="Text 28"/>
           <p:cNvSpPr/>
           <p:nvPr/>
         </p:nvSpPr>
@@ -5848,7 +6027,7 @@
       </p:sp>
       <p:sp>
         <p:nvSpPr>
-          <p:cNvPr id="30" name="Text 24"/>
+          <p:cNvPr id="35" name="Text 29"/>
           <p:cNvSpPr/>
           <p:nvPr/>
         </p:nvSpPr>
@@ -5887,7 +6066,7 @@
       </p:sp>
       <p:sp>
         <p:nvSpPr>
-          <p:cNvPr id="31" name="Text 25"/>
+          <p:cNvPr id="36" name="Text 30"/>
           <p:cNvSpPr/>
           <p:nvPr/>
         </p:nvSpPr>
@@ -5926,7 +6105,7 @@
       </p:sp>
       <p:sp>
         <p:nvSpPr>
-          <p:cNvPr id="32" name="Shape 26"/>
+          <p:cNvPr id="37" name="Shape 31"/>
           <p:cNvSpPr/>
           <p:nvPr/>
         </p:nvSpPr>
@@ -5951,7 +6130,7 @@
       </p:sp>
       <p:sp>
         <p:nvSpPr>
-          <p:cNvPr id="33" name="Text 27"/>
+          <p:cNvPr id="38" name="Text 32"/>
           <p:cNvSpPr/>
           <p:nvPr/>
         </p:nvSpPr>
@@ -6004,7 +6183,7 @@
       </p:sp>
       <p:sp>
         <p:nvSpPr>
-          <p:cNvPr id="34" name="Text 28"/>
+          <p:cNvPr id="39" name="Text 33"/>
           <p:cNvSpPr/>
           <p:nvPr/>
         </p:nvSpPr>
@@ -6049,7 +6228,7 @@
                 <a:ea typeface="Arial" pitchFamily="34" charset="-122"/>
                 <a:cs typeface="Arial" pitchFamily="34" charset="-120"/>
               </a:rPr>
-              <a:t>Bloomberg / CNBC — OpenAI $122B round, Apr 2026, </a:t>
+              <a:t>Bloomberg / CNBC — OpenAI $122B round, Mar 2026, </a:t>
             </a:r>
             <a:pPr indent="0" marL="0">
               <a:buNone/>
@@ -6169,7 +6348,7 @@
       </p:sp>
       <p:sp>
         <p:nvSpPr>
-          <p:cNvPr id="35" name="Shape 29"/>
+          <p:cNvPr id="40" name="Shape 34"/>
           <p:cNvSpPr/>
           <p:nvPr/>
         </p:nvSpPr>
@@ -6194,7 +6373,7 @@
       </p:sp>
       <p:sp>
         <p:nvSpPr>
-          <p:cNvPr id="36" name="Text 30"/>
+          <p:cNvPr id="41" name="Text 35"/>
           <p:cNvSpPr/>
           <p:nvPr/>
         </p:nvSpPr>
@@ -6233,7 +6412,7 @@
       </p:sp>
       <p:sp>
         <p:nvSpPr>
-          <p:cNvPr id="37" name="Text 31"/>
+          <p:cNvPr id="42" name="Text 36"/>
           <p:cNvSpPr/>
           <p:nvPr/>
         </p:nvSpPr>
@@ -26472,7 +26651,7 @@
                 <a:ea typeface="Arial" pitchFamily="34" charset="-122"/>
                 <a:cs typeface="Arial" pitchFamily="34" charset="-120"/>
               </a:rPr>
-              <a:t>Alphabet $2.3T / ~$85B 2026 capex</a:t>
+              <a:t>Alphabet $4.0T / ~$180B 2026 capex</a:t>
             </a:r>
             <a:pPr indent="0" marL="0">
               <a:spcAft>
@@ -26506,7 +26685,7 @@
                 <a:ea typeface="Arial" pitchFamily="34" charset="-122"/>
                 <a:cs typeface="Arial" pitchFamily="34" charset="-120"/>
               </a:rPr>
-              <a:t>Alphabet 10-K and 2026 capex guide</a:t>
+              <a:t>companiesmarketcap; Alphabet 2026 capex guide (Q4 2025 call)</a:t>
             </a:r>
             <a:endParaRPr lang="en-US" sz="850" dirty="0"/>
           </a:p>

</xml_diff>

<commit_message>
Audit pass: data/copy fixes, layout polish, viewer hardening, deploy lockdown
Data/copy: $300B reframed as full-year 2026 supply (was double-counting),
$105B+ window corrected to six months, Alphabet FCF -90% (double negative),
EO 30-day parenthetical repaired, slide 5 retitled 'Washington wants a stake',
POLICY kicker, slide 11 card order matches headline, SK Hynix note aligned,
~90-point spread, typographic apostrophes across slide copy.

Layout: slide 5 takeaway/source collision fixed (was 2px), slide 8 caption
orphan removed, right rails aligned to x6.65, slide 10 right-margin overshoot.

Build/viewer: slide-count assertion + auto cache-buster stamped into
slides-data.js; digit buffer for slides 10-12; swipe guard when grid open;
title/fallback cleanup; cache headers pinned; .vercelignore keeps internal
docs out of the deploy.

Co-Authored-By: Claude Fable 5 <noreply@anthropic.com>
</commit_message>
<xml_diff>
--- a/ai-markets-deck.pptx
+++ b/ai-markets-deck.pptx
@@ -1669,7 +1669,7 @@
           <a:p>
             <a:r>
               <a:rPr lang="en-US" dirty="0"/>
-              <a:t>The deck in one breath: part one is what's happening right now — models became loop-running agents, tokens became a rationed input, and Washington moved from regulating AI to debating who owns it. Part two is how markets reprice all of it: equities split the trade, the labor data started moving, the financing moved into the bond market, and your benchmark quietly became an AI fund. Twelve slides, two parts, one question throughout: what does this do to portfolios.</a:t>
+              <a:t>The deck in one breath: part one is what’s happening right now — models became loop-running agents, tokens became a rationed input, and Washington moved from regulating AI to debating who owns it. Part two is how markets reprice all of it: equities split the trade, the labor data started moving, the financing moved into the bond market, and your benchmark quietly became an AI fund. Twelve slides, two parts, one question throughout: what does this do to portfolios.</a:t>
             </a:r>
             <a:endParaRPr lang="en-US" dirty="0"/>
           </a:p>
@@ -1757,7 +1757,7 @@
           <a:p>
             <a:r>
               <a:rPr lang="en-US" dirty="0"/>
-              <a:t>The so-what slide. Nobody in this room would deliberately put 37% of an equity sleeve in ten correlated names sharing one earnings driver — but a benchmark allocation does precisely that ($37 of every $100). Four gauges, each paired with an action: demand (capex guidance + token budgets — the new same-store sales), financing (CDS and new-issue spreads, per slide 9), rates (long-duration cash flows + record supply), and concentration (equal-weight vs cap-weight as the orderly preview of the disorderly version). Honest caveat: equal-weight won 2026 but lost 2024–25 — the message is 'size the bet on purpose,' not 'sell megacaps.' Closing line is the deck's thesis in one sentence.</a:t>
+              <a:t>The so-what slide. Nobody in this room would deliberately put 37% of an equity sleeve in ten correlated names sharing one earnings driver — but a benchmark allocation does precisely that ($37 of every $100). Four gauges, each paired with an action: demand (capex guidance + token budgets — the new same-store sales), financing (CDS and new-issue spreads, per slide 9), rates (long-duration cash flows + record supply), and concentration (equal-weight vs cap-weight as the orderly preview of the disorderly version). Honest caveat: equal-weight won 2026 but lost 2024–25 — the message is 'size the bet on purpose,' not 'sell megacaps.' Closing line is the deck’s thesis in one sentence.</a:t>
             </a:r>
             <a:endParaRPr lang="en-US" dirty="0"/>
           </a:p>
@@ -1845,7 +1845,7 @@
           <a:p>
             <a:r>
               <a:rPr lang="en-US" dirty="0"/>
-              <a:t>The closer — the option value sitting behind the multiples, kept disciplined. Embodiment: agentic loops in a body, walking a shift. Orbit: it removes the exact power-and-cooling constraints behind token rationing (slide 4), and SpaceX is simultaneously the neocloud king and the launch monopolist — if orbital compute happens it's an extension of the most vertically integrated player in the stack. Wheels: every robotaxi mile is metered inference. Proteins: frontier models lead biology benchmarks; discovery becomes compute-bound. Every card is new compute demand — the Jevons curve extended a decade. Flagged speculative; gauges, not guidance.</a:t>
+              <a:t>The closer — the option value sitting behind the multiples, kept disciplined. Embodiment: agentic loops in a body, walking a shift. Orbit: it removes the exact power-and-cooling constraints behind token rationing (slide 4), and SpaceX is simultaneously the neocloud king and the launch monopolist — if orbital compute happens it’s an extension of the most vertically integrated player in the stack. Wheels: every robotaxi mile is metered inference. Proteins: frontier models lead biology benchmarks; discovery becomes compute-bound. Every card is new compute demand — the Jevons curve extended a decade. Flagged speculative; gauges, not guidance.</a:t>
             </a:r>
             <a:endParaRPr lang="en-US" dirty="0"/>
           </a:p>
@@ -2021,7 +2021,7 @@
           <a:p>
             <a:r>
               <a:rPr lang="en-US" dirty="0"/>
-              <a:t>The thesis slide — and why this isn't 2023's hype cycle: three independent systems shifting in the same direction at once. Capability: models became loop-running systems (slide 3). Economics: tokens went from subsidized to rationed (slide 4). Policy: when governments debate taking equity, the asset class changed category (slide 5). Each column carries one proof stat: $47B of run rate, $920M/month of rental, a 50% equity-tax proposal. The banner is the line to read aloud.</a:t>
+              <a:t>The thesis slide — and why this isn’t 2023’s hype cycle: three independent systems shifting in the same direction at once. Capability: models became loop-running systems (slide 3). Economics: tokens went from subsidized to rationed (slide 4). Policy: when governments debate taking equity, the asset class changed category (slide 5). Each column carries one proof stat: $47B of run rate, $920M/month of rental, a 50% equity-tax proposal. The banner is the line to read aloud.</a:t>
             </a:r>
             <a:endParaRPr lang="en-US" dirty="0"/>
           </a:p>
@@ -2109,7 +2109,7 @@
           <a:p>
             <a:r>
               <a:rPr lang="en-US" dirty="0"/>
-              <a:t>The core slide of part one. Left: the unit of work changed — from one-shot prompting to loops that try, fail, fix, and ship without a human in each cycle. Cherny's line is the cleanest articulation. Right: the Jevons paradox (coal, 1865) applied — as agents make software effectively free to produce, we don't write the same software cheaper, we write categorically more of it: PDF summaries become dashboards become disposable single-use apps become giant research projects. Investment translation: efficiency improvements do NOT cap compute demand — they expand it. That's the demand engine behind everything in part two.</a:t>
+              <a:t>The core slide of part one. Left: the unit of work changed — from one-shot prompting to loops that try, fail, fix, and ship without a human in each cycle. Cherny’s line is the cleanest articulation. Right: the Jevons paradox (coal, 1865) applied — as agents make software effectively free to produce, we don’t write the same software cheaper, we write categorically more of it: PDF summaries become dashboards become disposable single-use apps become giant research projects. Investment translation: efficiency improvements do NOT cap compute demand — they expand it. That’s the demand engine behind everything in part two.</a:t>
             </a:r>
             <a:endParaRPr lang="en-US" dirty="0"/>
           </a:p>
@@ -2197,7 +2197,7 @@
           <a:p>
             <a:r>
               <a:rPr lang="en-US" dirty="0"/>
-              <a:t>Three data points, one message: enterprises now treat tokens as a metered input with a budget line. Uber: $1,500/month per employee. Walmart: killed unlimited access for Code Puppy. The third card is the supply side — SK Hynix says the HBM shortage outlasts the decade even after doubling capacity, and Google's $920M/month rental is what scarcity costs when you don't own capacity. The READ box carries the investability point: token budgets are the new same-store sales.</a:t>
+              <a:t>Three data points, one message: enterprises now treat tokens as a metered input with a budget line. Uber: $1,500/month per employee. Walmart: killed unlimited access for Code Puppy. The third card is the supply side — SK Hynix sees no HBM relief before ~2030 even after doubling capacity, and Google’s $920M/month rental is what scarcity costs when you don’t own capacity. The READ box carries the investability point: token budgets are the new same-store sales.</a:t>
             </a:r>
             <a:endParaRPr lang="en-US" dirty="0"/>
           </a:p>
@@ -2373,7 +2373,7 @@
           <a:p>
             <a:r>
               <a:rPr lang="en-US" dirty="0"/>
-              <a:t>Part two opens with the equity scoreboard. SOXX +80% YTD (best run since 2000, ~$5.7T added in the April rally alone); equal-weight +14% beats cap-weight +11%; MAGS +6% lags; software −10%, priced for disruption. The market is no longer trading 'AI yes/no' — it's trading position in the chain. The right rail is the concentration story: 37% of the index in ten names (double the 25-year norm), Nvidia alone at 7%, and a forward multiple that's elevated but not extreme — provided the AI earnings stream keeps compounding.</a:t>
+              <a:t>Part two opens with the equity scoreboard. SOXX +80% YTD (best run since 2000, ~$5.7T added in the April rally alone); equal-weight +14% beats cap-weight +11%; MAGS +6% lags; software −10%, priced for disruption. The market is no longer trading 'AI yes/no' — it’s trading position in the chain. The right rail is the concentration story: 37% of the index in ten names (double the 25-year norm), Nvidia alone at 7%, and a forward multiple that’s elevated but not extreme — provided the AI earnings stream keeps compounding.</a:t>
             </a:r>
             <a:endParaRPr lang="en-US" dirty="0"/>
           </a:p>
@@ -2461,7 +2461,7 @@
           <a:p>
             <a:r>
               <a:rPr lang="en-US" dirty="0"/>
-              <a:t>The labor slide — new this version, with verified June 2026 data. Left: the structural story — a job stops being task execution and becomes orchestration of parallel agent loops; the 20–25% coordination figure is the pool agents are bought to recover. Right: the data — Challenger's May report made AI the #1 stated layoff reason for the first time (~40% of announced cuts, with the honest caveat that it's self-reported and partly scapegoating); the entry level is where it bites (grad unemployment 5.6% vs 4.2%, declining payrolls for the youngest AI-exposed cohort); and the advantage gap stratifies pay within surviving roles. Markets price labor twice: as a cost line agents deflate, and as the political trigger for slide 5's ownership debate.</a:t>
+              <a:t>The labor slide — new this version, with verified June 2026 data. Left: the structural story — a job stops being task execution and becomes orchestration of parallel agent loops; the 20–25% coordination figure is the pool agents are bought to recover. Right: the data — Challenger’s May report made AI the #1 stated layoff reason for the first time (~40% of announced cuts, with the honest caveat that it’s self-reported and partly scapegoating); the entry level is where it bites (grad unemployment 5.6% vs 4.2%, declining payrolls for the youngest AI-exposed cohort); and the advantage gap stratifies pay within surviving roles. Markets price labor twice: as a cost line agents deflate, and as the political trigger for slide 5’s ownership debate.</a:t>
             </a:r>
             <a:endParaRPr lang="en-US" dirty="0"/>
           </a:p>
@@ -2549,7 +2549,7 @@
           <a:p>
             <a:r>
               <a:rPr lang="en-US" dirty="0"/>
-              <a:t>Bonds, part one: the gap. Capex went from $410B to ~$705B guided (+72%) — and three of four raised guidance in the latest round. The cash math: ~94% of operating cash flow committed to capex, dividends, and buybacks; Big-4 FCF at a decade low; Amazon outright negative ($200B capex vs ~$140B operating cash flow); Alphabet's FCF down ~90% to ~$8B. For a decade the megacap social contract was self-funding plus buybacks. It broke in 2026 — and something had to fill the gap. Next slide.</a:t>
+              <a:t>Bonds, part one: the gap. Capex went from $410B to ~$705B guided (+72%) — and three of four raised guidance in the latest round. The cash math: ~94% of operating cash flow committed to capex, dividends, and buybacks; Big-4 FCF at a decade low; Amazon outright negative ($200B capex vs ~$140B operating cash flow); Alphabet’s FCF down ~90% to ~$8B. For a decade the megacap social contract was self-funding plus buybacks. It broke in 2026 — and something had to fill the gap. Next slide.</a:t>
             </a:r>
             <a:endParaRPr lang="en-US" dirty="0"/>
           </a:p>
@@ -2637,7 +2637,7 @@
           <a:p>
             <a:r>
               <a:rPr lang="en-US" dirty="0"/>
-              <a:t>Bonds, part two: the wave. Five mega-deals in nine months — Oracle $18B (Sep '25), Meta $30B (Oct '25, the largest non-M&amp;A IG deal on record), Alphabet $17.5B and Amazon $15B (Nov '25), Oracle again $25B across eight tranches (Feb '26). Street consensus: ~$300B of AI-linked IG supply in 2026. The signal layer: Oracle's 5-yr CDS above ~125bp despite light leverage — credit is already discriminating by funding capacity, not just rating. The READ box is the takeaway for equity holders: spreads reprice before earnings revisions. Balance sheets are still lightly levered vs IG norms — this is not 2008 telecom — but the funding model changed permanently.</a:t>
+              <a:t>Bonds, part two: the wave. Five mega-deals in six months — Oracle $18B (Sep ’25), Meta $30B (Oct ’25, the largest non-M&amp;A IG deal on record), Alphabet $17.5B and Amazon $15B (Nov ’25), Oracle again $25B across eight tranches (Feb ’26). Street consensus: ~$300B of AI-linked IG supply in 2026. The signal layer: Oracle’s 5-yr CDS above ~125bp despite light leverage — credit is already discriminating by funding capacity, not just rating. The READ box is the takeaway for equity holders: spreads reprice before earnings revisions. Balance sheets are still lightly levered vs IG norms — this is not 2008 telecom — but the funding model changed permanently.</a:t>
             </a:r>
             <a:endParaRPr lang="en-US" dirty="0"/>
           </a:p>
@@ -3141,7 +3141,7 @@
                 <a:ea typeface="Arial Black" pitchFamily="34" charset="-122"/>
                 <a:cs typeface="Arial Black" pitchFamily="34" charset="-120"/>
               </a:rPr>
-              <a:t>What's happening now — and how markets reprice.</a:t>
+              <a:t>What’s happening now — and how markets reprice.</a:t>
             </a:r>
             <a:endParaRPr lang="en-US" sz="2000" dirty="0"/>
           </a:p>
@@ -3180,7 +3180,7 @@
                 <a:ea typeface="Arial" pitchFamily="34" charset="-122"/>
                 <a:cs typeface="Arial" pitchFamily="34" charset="-120"/>
               </a:rPr>
-              <a:t>Agentic loops, token rationing, and Washington's entry — then the repricing: equities, labor, and a $300B bond wave.</a:t>
+              <a:t>Agentic loops, token rationing, and Washington’s entry — then the repricing: equities, labor, and a $300B bond wave.</a:t>
             </a:r>
             <a:endParaRPr lang="en-US" sz="1300" dirty="0"/>
           </a:p>
@@ -3868,7 +3868,7 @@
         <p:spPr>
           <a:xfrm>
             <a:off x="4297680" y="1481328"/>
-            <a:ext cx="4434840" cy="256032"/>
+            <a:ext cx="4389120" cy="256032"/>
           </a:xfrm>
           <a:prstGeom prst="rect">
             <a:avLst/>
@@ -3907,7 +3907,7 @@
         <p:spPr>
           <a:xfrm>
             <a:off x="4297680" y="1783080"/>
-            <a:ext cx="4434840" cy="0"/>
+            <a:ext cx="4389120" cy="0"/>
           </a:xfrm>
           <a:prstGeom prst="line">
             <a:avLst/>
@@ -3950,7 +3950,7 @@
         <p:spPr>
           <a:xfrm>
             <a:off x="4453128" y="1847088"/>
-            <a:ext cx="4251960" cy="548640"/>
+            <a:ext cx="4233672" cy="548640"/>
           </a:xfrm>
           <a:prstGeom prst="rect">
             <a:avLst/>
@@ -4040,7 +4040,7 @@
         <p:spPr>
           <a:xfrm>
             <a:off x="4453128" y="2414016"/>
-            <a:ext cx="4251960" cy="548640"/>
+            <a:ext cx="4233672" cy="548640"/>
           </a:xfrm>
           <a:prstGeom prst="rect">
             <a:avLst/>
@@ -4130,7 +4130,7 @@
         <p:spPr>
           <a:xfrm>
             <a:off x="4453128" y="2980944"/>
-            <a:ext cx="4251960" cy="548640"/>
+            <a:ext cx="4233672" cy="548640"/>
           </a:xfrm>
           <a:prstGeom prst="rect">
             <a:avLst/>
@@ -4220,7 +4220,7 @@
         <p:spPr>
           <a:xfrm>
             <a:off x="4453128" y="3547872"/>
-            <a:ext cx="4251960" cy="548640"/>
+            <a:ext cx="4233672" cy="548640"/>
           </a:xfrm>
           <a:prstGeom prst="rect">
             <a:avLst/>
@@ -4328,7 +4328,7 @@
                 <a:ea typeface="Arial" pitchFamily="34" charset="-122"/>
                 <a:cs typeface="Arial" pitchFamily="34" charset="-120"/>
               </a:rPr>
-              <a:t>you don't need a view on AGI — you need to know what your portfolio already believes.</a:t>
+              <a:t>you don’t need a view on AGI — you need to know what your portfolio already believes.</a:t>
             </a:r>
             <a:endParaRPr lang="en-US" sz="1050" dirty="0"/>
           </a:p>
@@ -4555,7 +4555,7 @@
         <p:spPr>
           <a:xfrm>
             <a:off x="841248" y="155448"/>
-            <a:ext cx="5943600" cy="274320"/>
+            <a:ext cx="3931920" cy="274320"/>
           </a:xfrm>
           <a:prstGeom prst="rect">
             <a:avLst/>
@@ -4820,7 +4820,7 @@
       </p:sp>
       <p:pic>
         <p:nvPicPr>
-          <p:cNvPr id="11" name="Image 1" descr="slides-images/web/orbital.jpg">    </p:cNvPr>
+          <p:cNvPr id="11" name="Image 1" descr="slides-images/web/robotaxi.jpg">    </p:cNvPr>
           <p:cNvPicPr>
             <a:picLocks noChangeAspect="1"/>
           </p:cNvPicPr>
@@ -4914,7 +4914,7 @@
                 <a:ea typeface="Arial" pitchFamily="34" charset="-122"/>
                 <a:cs typeface="Arial" pitchFamily="34" charset="-120"/>
               </a:rPr>
-              <a:t>Orbit.  </a:t>
+              <a:t>Wheels.  </a:t>
             </a:r>
             <a:pPr indent="0" marL="0">
               <a:buNone/>
@@ -4928,7 +4928,7 @@
                 <a:ea typeface="Arial" pitchFamily="34" charset="-122"/>
                 <a:cs typeface="Arial" pitchFamily="34" charset="-120"/>
               </a:rPr>
-              <a:t>24/7 solar and radiative cooling escape the grid constraint behind token rationing. SpaceX owns the rockets and 550k-GPU clusters.</a:t>
+              <a:t>Robotaxis are inference on wheels — per-mile token economics and a city-scale demand pool for compute.</a:t>
             </a:r>
             <a:endParaRPr lang="en-US" sz="950" dirty="0"/>
           </a:p>
@@ -4936,7 +4936,7 @@
       </p:sp>
       <p:pic>
         <p:nvPicPr>
-          <p:cNvPr id="15" name="Image 2" descr="slides-images/web/robotaxi.jpg">    </p:cNvPr>
+          <p:cNvPr id="15" name="Image 2" descr="slides-images/web/orbital.jpg">    </p:cNvPr>
           <p:cNvPicPr>
             <a:picLocks noChangeAspect="1"/>
           </p:cNvPicPr>
@@ -5030,7 +5030,7 @@
                 <a:ea typeface="Arial" pitchFamily="34" charset="-122"/>
                 <a:cs typeface="Arial" pitchFamily="34" charset="-120"/>
               </a:rPr>
-              <a:t>Wheels.  </a:t>
+              <a:t>Orbit.  </a:t>
             </a:r>
             <a:pPr indent="0" marL="0">
               <a:buNone/>
@@ -5044,7 +5044,7 @@
                 <a:ea typeface="Arial" pitchFamily="34" charset="-122"/>
                 <a:cs typeface="Arial" pitchFamily="34" charset="-120"/>
               </a:rPr>
-              <a:t>Robotaxis are inference on wheels — per-mile token economics and a city-scale demand pool for compute.</a:t>
+              <a:t>24/7 solar and radiative cooling escape the grid constraint behind token rationing. SpaceX owns the rockets and 550k-GPU clusters.</a:t>
             </a:r>
             <a:endParaRPr lang="en-US" sz="950" dirty="0"/>
           </a:p>
@@ -5542,7 +5542,7 @@
                 <a:ea typeface="Arial" pitchFamily="34" charset="-122"/>
                 <a:cs typeface="Arial" pitchFamily="34" charset="-120"/>
               </a:rPr>
-              <a:t>Returns are total returns YTD through the most recent available close (Jun 5–9, 2026, unless noted). Index and market-cap figures as of early June 2026.</a:t>
+              <a:t>All return figures are YTD total returns through the most recent available close (Jun 5–9, 2026, unless noted). Index and market-cap figures as of early June 2026.</a:t>
             </a:r>
             <a:endParaRPr lang="en-US" sz="850" dirty="0"/>
           </a:p>
@@ -5809,7 +5809,7 @@
                 <a:ea typeface="Arial" pitchFamily="34" charset="-122"/>
                 <a:cs typeface="Arial" pitchFamily="34" charset="-120"/>
               </a:rPr>
-              <a:t>Capex guidance: company reports via CNBC (Feb 6, 2026); Tom's Hardware; Statista (midpoints)</a:t>
+              <a:t>Capex guidance: company reports via CNBC (Feb 6, 2026); Tom’s Hardware; Statista (midpoints)</a:t>
             </a:r>
             <a:endParaRPr lang="en-US" sz="720" dirty="0"/>
           </a:p>
@@ -6181,7 +6181,7 @@
                 <a:ea typeface="Arial" pitchFamily="34" charset="-122"/>
                 <a:cs typeface="Arial" pitchFamily="34" charset="-120"/>
               </a:rPr>
-              <a:t>Compute: SK Hynix HBM outlook; SpaceX Colossus; Google GPU rental; run rates via Leona's Capital</a:t>
+              <a:t>Compute: SK Hynix HBM outlook; SpaceX Colossus; Google GPU rental; run rates via Leona’s Capital</a:t>
             </a:r>
             <a:endParaRPr lang="en-US" sz="720" dirty="0"/>
           </a:p>
@@ -6472,7 +6472,7 @@
                 <a:ea typeface="Arial" pitchFamily="34" charset="-122"/>
                 <a:cs typeface="Arial" pitchFamily="34" charset="-120"/>
               </a:rPr>
-              <a:t>Capability, economics, and policy are moving at once. First what's changing (slides 3–5) — then how markets are repricing it (slides 6–11).</a:t>
+              <a:t>Capability, economics, and policy are moving at once. First what’s changing (slides 3–5) — then how markets are repricing it (slides 6–11).</a:t>
             </a:r>
             <a:endParaRPr lang="en-US" sz="1250" dirty="0"/>
           </a:p>
@@ -7340,7 +7340,7 @@
                 <a:ea typeface="Arial" pitchFamily="34" charset="-122"/>
                 <a:cs typeface="Arial" pitchFamily="34" charset="-120"/>
               </a:rPr>
-              <a:t>The chatbot's economics are exhausted. The stack is reorganizing around token-burning agentic loops — and markets are repricing around it.</a:t>
+              <a:t>The chatbot’s economics are exhausted. The stack is reorganizing around token-burning agentic loops — and markets are repricing around it.</a:t>
             </a:r>
             <a:endParaRPr lang="en-US" sz="1100" dirty="0"/>
           </a:p>
@@ -7552,7 +7552,7 @@
                 <a:ea typeface="Arial" pitchFamily="34" charset="-122"/>
                 <a:cs typeface="Arial" pitchFamily="34" charset="-120"/>
               </a:rPr>
-              <a:t>01  ·  WHAT'S HAPPENING  —  AGENTIC LOOPS</a:t>
+              <a:t>01  ·  WHAT’S HAPPENING  —  AGENTIC LOOPS</a:t>
             </a:r>
             <a:endParaRPr lang="en-US" sz="900" dirty="0"/>
           </a:p>
@@ -9039,7 +9039,7 @@
                 <a:ea typeface="Arial" pitchFamily="34" charset="-122"/>
                 <a:cs typeface="Arial" pitchFamily="34" charset="-120"/>
               </a:rPr>
-              <a:t>01  ·  WHAT'S HAPPENING  —  TOKEN RATIONING</a:t>
+              <a:t>01  ·  WHAT’S HAPPENING  —  TOKEN RATIONING</a:t>
             </a:r>
             <a:endParaRPr lang="en-US" sz="900" dirty="0"/>
           </a:p>
@@ -9527,8 +9527,8 @@
         </p:nvSpPr>
         <p:spPr>
           <a:xfrm>
-            <a:off x="6035040" y="1517904"/>
-            <a:ext cx="2651760" cy="1280160"/>
+            <a:off x="6080760" y="1517904"/>
+            <a:ext cx="2606040" cy="1280160"/>
           </a:xfrm>
           <a:prstGeom prst="rect">
             <a:avLst/>
@@ -9552,7 +9552,7 @@
         </p:nvSpPr>
         <p:spPr>
           <a:xfrm>
-            <a:off x="6035040" y="1517904"/>
+            <a:off x="6080760" y="1517904"/>
             <a:ext cx="274320" cy="32004"/>
           </a:xfrm>
           <a:prstGeom prst="rect">
@@ -9572,7 +9572,7 @@
         </p:nvSpPr>
         <p:spPr>
           <a:xfrm>
-            <a:off x="6035040" y="1517904"/>
+            <a:off x="6080760" y="1517904"/>
             <a:ext cx="32004" cy="274320"/>
           </a:xfrm>
           <a:prstGeom prst="rect">
@@ -9632,7 +9632,7 @@
         </p:nvSpPr>
         <p:spPr>
           <a:xfrm>
-            <a:off x="7040880" y="1719072"/>
+            <a:off x="7063740" y="1719072"/>
             <a:ext cx="640080" cy="347472"/>
           </a:xfrm>
           <a:prstGeom prst="triangle">
@@ -9654,7 +9654,7 @@
         </p:nvSpPr>
         <p:spPr>
           <a:xfrm>
-            <a:off x="7488936" y="1591056"/>
+            <a:off x="7511796" y="1591056"/>
             <a:ext cx="146304" cy="146304"/>
           </a:xfrm>
           <a:prstGeom prst="ellipse">
@@ -9676,8 +9676,8 @@
         </p:nvSpPr>
         <p:spPr>
           <a:xfrm>
-            <a:off x="6126480" y="2176272"/>
-            <a:ext cx="2468880" cy="219456"/>
+            <a:off x="6172200" y="2176272"/>
+            <a:ext cx="2423160" cy="219456"/>
           </a:xfrm>
           <a:prstGeom prst="rect">
             <a:avLst/>
@@ -9715,8 +9715,8 @@
         </p:nvSpPr>
         <p:spPr>
           <a:xfrm>
-            <a:off x="6217920" y="2432304"/>
-            <a:ext cx="2286000" cy="594360"/>
+            <a:off x="6263640" y="2432304"/>
+            <a:ext cx="2240280" cy="594360"/>
           </a:xfrm>
           <a:prstGeom prst="rect">
             <a:avLst/>
@@ -9754,8 +9754,8 @@
         </p:nvSpPr>
         <p:spPr>
           <a:xfrm>
-            <a:off x="6035040" y="2889504"/>
-            <a:ext cx="2651760" cy="1243584"/>
+            <a:off x="6080760" y="2889504"/>
+            <a:ext cx="2606040" cy="1243584"/>
           </a:xfrm>
           <a:prstGeom prst="rect">
             <a:avLst/>
@@ -9779,8 +9779,8 @@
         </p:nvSpPr>
         <p:spPr>
           <a:xfrm>
-            <a:off x="6172200" y="2980944"/>
-            <a:ext cx="2377440" cy="228600"/>
+            <a:off x="6217920" y="2980944"/>
+            <a:ext cx="2331720" cy="228600"/>
           </a:xfrm>
           <a:prstGeom prst="rect">
             <a:avLst/>
@@ -9818,8 +9818,8 @@
         </p:nvSpPr>
         <p:spPr>
           <a:xfrm>
-            <a:off x="6172200" y="3255264"/>
-            <a:ext cx="2377440" cy="786384"/>
+            <a:off x="6217920" y="3255264"/>
+            <a:ext cx="2331720" cy="786384"/>
           </a:xfrm>
           <a:prstGeom prst="rect">
             <a:avLst/>
@@ -10117,7 +10117,7 @@
                 <a:ea typeface="Arial" pitchFamily="34" charset="-122"/>
                 <a:cs typeface="Arial" pitchFamily="34" charset="-120"/>
               </a:rPr>
-              <a:t>01  ·  WHAT'S HAPPENING  —  THE STATE</a:t>
+              <a:t>01  ·  WHAT’S HAPPENING  —  POLICY</a:t>
             </a:r>
             <a:endParaRPr lang="en-US" sz="900" dirty="0"/>
           </a:p>
@@ -10156,7 +10156,7 @@
                 <a:ea typeface="Arial Black" pitchFamily="34" charset="-122"/>
                 <a:cs typeface="Arial Black" pitchFamily="34" charset="-120"/>
               </a:rPr>
-              <a:t>Washington enters the trade</a:t>
+              <a:t>Washington wants a stake</a:t>
             </a:r>
             <a:endParaRPr lang="en-US" sz="2600" dirty="0"/>
           </a:p>
@@ -10327,7 +10327,7 @@
                 <a:ea typeface="Arial" pitchFamily="34" charset="-122"/>
                 <a:cs typeface="Arial" pitchFamily="34" charset="-120"/>
               </a:rPr>
-              <a:t>Voluntary but high-pressure NSA review before releasing models with a “meaningful step change” in cyber capability (down from 90 days). Mandatory licensing expressly forbidden — for now.</a:t>
+              <a:t>Voluntary but high-pressure NSA review — 30 days, down from 90 — before releasing models with a “meaningful step change” in cyber capability. Mandatory licensing expressly forbidden — for now.</a:t>
             </a:r>
             <a:endParaRPr lang="en-US" sz="1050" dirty="0"/>
           </a:p>
@@ -10459,7 +10459,7 @@
                 <a:ea typeface="Arial" pitchFamily="34" charset="-122"/>
                 <a:cs typeface="Arial" pitchFamily="34" charset="-120"/>
               </a:rPr>
-              <a:t>Sanders' proposal, echoed by Trump as “a concept of a plan”: a one-time 50% tax on AI-lab equity (not profits) seeds a public fund paying “AI Dividends” to citizens.</a:t>
+              <a:t>Sanders’ proposal, echoed by Trump as “a concept of a plan”: a one-time 50% tax on AI-lab equity (not profits) seeds a public fund paying “AI Dividends” to citizens.</a:t>
             </a:r>
             <a:endParaRPr lang="en-US" sz="1050" dirty="0"/>
           </a:p>
@@ -10605,8 +10605,8 @@
         </p:nvSpPr>
         <p:spPr>
           <a:xfrm>
-            <a:off x="6172200" y="1463040"/>
-            <a:ext cx="2514600" cy="2377440"/>
+            <a:off x="6080760" y="1463040"/>
+            <a:ext cx="2606040" cy="2377440"/>
           </a:xfrm>
           <a:prstGeom prst="rect">
             <a:avLst/>
@@ -10630,7 +10630,7 @@
         </p:nvSpPr>
         <p:spPr>
           <a:xfrm>
-            <a:off x="6172200" y="1463040"/>
+            <a:off x="6080760" y="1463040"/>
             <a:ext cx="274320" cy="32004"/>
           </a:xfrm>
           <a:prstGeom prst="rect">
@@ -10650,7 +10650,7 @@
         </p:nvSpPr>
         <p:spPr>
           <a:xfrm>
-            <a:off x="6172200" y="1463040"/>
+            <a:off x="6080760" y="1463040"/>
             <a:ext cx="32004" cy="274320"/>
           </a:xfrm>
           <a:prstGeom prst="rect">
@@ -10710,7 +10710,7 @@
         </p:nvSpPr>
         <p:spPr>
           <a:xfrm>
-            <a:off x="7109460" y="2212848"/>
+            <a:off x="7063740" y="2212848"/>
             <a:ext cx="640080" cy="347472"/>
           </a:xfrm>
           <a:prstGeom prst="triangle">
@@ -10732,7 +10732,7 @@
         </p:nvSpPr>
         <p:spPr>
           <a:xfrm>
-            <a:off x="7557516" y="2084832"/>
+            <a:off x="7511796" y="2084832"/>
             <a:ext cx="146304" cy="146304"/>
           </a:xfrm>
           <a:prstGeom prst="ellipse">
@@ -10754,8 +10754,8 @@
         </p:nvSpPr>
         <p:spPr>
           <a:xfrm>
-            <a:off x="6263640" y="2670048"/>
-            <a:ext cx="2331720" cy="219456"/>
+            <a:off x="6172200" y="2670048"/>
+            <a:ext cx="2423160" cy="219456"/>
           </a:xfrm>
           <a:prstGeom prst="rect">
             <a:avLst/>
@@ -10793,8 +10793,8 @@
         </p:nvSpPr>
         <p:spPr>
           <a:xfrm>
-            <a:off x="6355080" y="2926080"/>
-            <a:ext cx="2148840" cy="594360"/>
+            <a:off x="6263640" y="2926080"/>
+            <a:ext cx="2240280" cy="594360"/>
           </a:xfrm>
           <a:prstGeom prst="rect">
             <a:avLst/>
@@ -10832,8 +10832,8 @@
         </p:nvSpPr>
         <p:spPr>
           <a:xfrm>
-            <a:off x="457200" y="4023360"/>
-            <a:ext cx="8229600" cy="274320"/>
+            <a:off x="457200" y="3931920"/>
+            <a:ext cx="8229600" cy="347472"/>
           </a:xfrm>
           <a:prstGeom prst="rect">
             <a:avLst/>
@@ -10871,7 +10871,7 @@
                 <a:ea typeface="Arial" pitchFamily="34" charset="-122"/>
                 <a:cs typeface="Arial" pitchFamily="34" charset="-120"/>
               </a:rPr>
-              <a:t>the 2026 debate is no longer whether AI is regulated — it's whether the means of AI production are publicly owned. That's a dilution tail risk no equity model carries.</a:t>
+              <a:t>the 2026 debate is no longer whether AI is regulated — it’s whether the means of AI production are publicly owned. That’s a dilution tail risk no equity model carries.</a:t>
             </a:r>
             <a:endParaRPr lang="en-US" sz="1000" dirty="0"/>
           </a:p>
@@ -11200,7 +11200,7 @@
                 <a:ea typeface="Arial" pitchFamily="34" charset="-122"/>
                 <a:cs typeface="Arial" pitchFamily="34" charset="-120"/>
               </a:rPr>
-              <a:t>Semis +80%, software −10% — a 90-point spread inside one theme, while ten stocks hold ~37% of the index.</a:t>
+              <a:t>Semis +80%, software −10% — a ~90-point spread inside one theme, while ten stocks hold ~37% of the index.</a:t>
             </a:r>
             <a:endParaRPr lang="en-US" sz="1250" dirty="0"/>
           </a:p>
@@ -12034,7 +12034,7 @@
                 <a:ea typeface="Arial" pitchFamily="34" charset="-122"/>
                 <a:cs typeface="Arial" pitchFamily="34" charset="-120"/>
               </a:rPr>
-              <a:t>of the work week goes to coordination and retrieval (OpenAI's “strange abundance”) — the labor pool agents are bought to recover.</a:t>
+              <a:t>of the work week goes to coordination and retrieval (OpenAI’s “strange abundance”) — the labor pool agents are bought to recover.</a:t>
             </a:r>
             <a:endParaRPr lang="en-US" sz="750" dirty="0"/>
           </a:p>
@@ -12695,7 +12695,7 @@
                 <a:ea typeface="Arial" pitchFamily="34" charset="-122"/>
                 <a:cs typeface="Arial" pitchFamily="34" charset="-120"/>
               </a:rPr>
-              <a:t>Challenger: AI was cited in ~40% of May's announced US job cuts (38.6k of 97k) — the first month it beat “market conditions.” 87.7k AI-attributed cuts YTD vs 54.8k in all of 2025. (Self-reported; some firms may be scapegoating AI.)</a:t>
+              <a:t>Challenger: AI was cited in ~40% of May’s announced US job cuts (38.6k of 97k) — the first month it beat “market conditions.” 87.7k AI-attributed cuts YTD vs 54.8k in all of 2025. (Self-reported; some firms may be scapegoating AI.)</a:t>
             </a:r>
             <a:endParaRPr lang="en-US" sz="950" dirty="0"/>
           </a:p>
@@ -12841,7 +12841,7 @@
                 <a:ea typeface="Arial" pitchFamily="34" charset="-122"/>
                 <a:cs typeface="Arial" pitchFamily="34" charset="-120"/>
               </a:rPr>
-              <a:t>Power users running parallel loops compound their advantage over casual users; comp follows loop design, not task execution. And displacement fear is the political fuel behind slide 5's equity-tax debate.</a:t>
+              <a:t>Power users running parallel loops compound their advantage over casual users; comp follows loop design, not task execution. And displacement fear is the political fuel behind slide 5’s equity-tax debate.</a:t>
             </a:r>
             <a:endParaRPr lang="en-US" sz="950" dirty="0"/>
           </a:p>
@@ -12880,7 +12880,7 @@
                 <a:ea typeface="Arial" pitchFamily="34" charset="-122"/>
                 <a:cs typeface="Arial" pitchFamily="34" charset="-120"/>
               </a:rPr>
-              <a:t>Source: Challenger, Gray &amp; Christmas via CNBC (Jun 5, 2026) &amp; CBS News; NY Fed recent-grad series via CNBC; orchestration framing: Internal strategic review, “The 2026 AI Frontier” (Jun 2026).</a:t>
+              <a:t>Source: Challenger, Gray &amp; Christmas via CNBC (Jun 5, 2026) &amp; CBS News; NY Fed via CNBC; entry-level payrolls: academic working papers; framing: internal strategic review (Jun 2026).</a:t>
             </a:r>
             <a:endParaRPr lang="en-US" sz="700" dirty="0"/>
           </a:p>
@@ -13170,7 +13170,7 @@
                 <a:ea typeface="Arial" pitchFamily="34" charset="-122"/>
                 <a:cs typeface="Arial" pitchFamily="34" charset="-120"/>
               </a:rPr>
-              <a:t>The buildout was self-funded until it wasn't. ~$705B of guided 2026 capex consumes the cash machine — and opens a funding gap.</a:t>
+              <a:t>The buildout was self-funded until it wasn’t. ~$705B of guided 2026 capex consumes the cash machine — and opens a funding gap.</a:t>
             </a:r>
             <a:endParaRPr lang="en-US" sz="1250" dirty="0"/>
           </a:p>
@@ -13287,7 +13287,7 @@
                 <a:ea typeface="Arial" pitchFamily="34" charset="-122"/>
                 <a:cs typeface="Arial" pitchFamily="34" charset="-120"/>
               </a:rPr>
-              <a:t>+72% year over year — guided in public, raised into record spend</a:t>
+              <a:t>+72% YoY — raised into record spend</a:t>
             </a:r>
             <a:endParaRPr lang="en-US" sz="800" dirty="0"/>
           </a:p>
@@ -13782,7 +13782,7 @@
                 <a:ea typeface="Arial" pitchFamily="34" charset="-122"/>
                 <a:cs typeface="Arial" pitchFamily="34" charset="-120"/>
               </a:rPr>
-              <a:t>Alphabet drops −90%.</a:t>
+              <a:t>Alphabet FCF −90%.</a:t>
             </a:r>
             <a:endParaRPr lang="en-US" sz="1100" dirty="0"/>
           </a:p>
@@ -13835,8 +13835,8 @@
         </p:nvSpPr>
         <p:spPr>
           <a:xfrm>
-            <a:off x="3749040" y="4041648"/>
-            <a:ext cx="4937760" cy="237744"/>
+            <a:off x="3749040" y="3986784"/>
+            <a:ext cx="4937760" cy="292608"/>
           </a:xfrm>
           <a:prstGeom prst="rect">
             <a:avLst/>
@@ -13913,7 +13913,7 @@
                 <a:ea typeface="Arial" pitchFamily="34" charset="-122"/>
                 <a:cs typeface="Arial" pitchFamily="34" charset="-120"/>
               </a:rPr>
-              <a:t>Source: BofA via Breckinridge; CNBC (Feb 6, 2026); techtimes/beincrypto FCF estimates; capex guidance via CNBC, Tom's Hardware, Statista (midpoints).</a:t>
+              <a:t>Source: BofA via Breckinridge; CNBC (Feb 6, 2026); techtimes/beincrypto FCF estimates; capex guidance via CNBC, Tom’s Hardware, Statista (midpoints).</a:t>
             </a:r>
             <a:endParaRPr lang="en-US" sz="700" dirty="0"/>
           </a:p>
@@ -14203,7 +14203,7 @@
                 <a:ea typeface="Arial" pitchFamily="34" charset="-122"/>
                 <a:cs typeface="Arial" pitchFamily="34" charset="-120"/>
               </a:rPr>
-              <a:t>$105B+ of investment-grade mega-deals in nine months — record prints, a live CDS signal, and ~$300B more expected in 2026.</a:t>
+              <a:t>$105B+ of investment-grade mega-deals in six months — record prints, a live CDS signal, and ~$300B of supply expected for full-year 2026.</a:t>
             </a:r>
             <a:endParaRPr lang="en-US" sz="1250" dirty="0"/>
           </a:p>
@@ -14403,7 +14403,7 @@
                 <a:ea typeface="Arial" pitchFamily="34" charset="-122"/>
                 <a:cs typeface="Arial" pitchFamily="34" charset="-120"/>
               </a:rPr>
-              <a:t>Sep '25</a:t>
+              <a:t>Sep ’25</a:t>
             </a:r>
             <a:endParaRPr lang="en-US" sz="800" dirty="0"/>
           </a:p>
@@ -14535,7 +14535,7 @@
                 <a:ea typeface="Arial" pitchFamily="34" charset="-122"/>
                 <a:cs typeface="Arial" pitchFamily="34" charset="-120"/>
               </a:rPr>
-              <a:t>Oct '25</a:t>
+              <a:t>Oct ’25</a:t>
             </a:r>
             <a:endParaRPr lang="en-US" sz="800" dirty="0"/>
           </a:p>
@@ -14650,7 +14650,7 @@
                 <a:ea typeface="Arial" pitchFamily="34" charset="-122"/>
                 <a:cs typeface="Arial" pitchFamily="34" charset="-120"/>
               </a:rPr>
-              <a:t>Nov '25</a:t>
+              <a:t>Nov ’25</a:t>
             </a:r>
             <a:endParaRPr lang="en-US" sz="800" dirty="0"/>
           </a:p>
@@ -14765,7 +14765,7 @@
                 <a:ea typeface="Arial" pitchFamily="34" charset="-122"/>
                 <a:cs typeface="Arial" pitchFamily="34" charset="-120"/>
               </a:rPr>
-              <a:t>Nov '25</a:t>
+              <a:t>Nov ’25</a:t>
             </a:r>
             <a:endParaRPr lang="en-US" sz="800" dirty="0"/>
           </a:p>
@@ -14897,7 +14897,7 @@
                 <a:ea typeface="Arial" pitchFamily="34" charset="-122"/>
                 <a:cs typeface="Arial" pitchFamily="34" charset="-120"/>
               </a:rPr>
-              <a:t>Feb '26</a:t>
+              <a:t>Feb ’26</a:t>
             </a:r>
             <a:endParaRPr lang="en-US" sz="800" dirty="0"/>
           </a:p>
@@ -14976,7 +14976,7 @@
                 <a:ea typeface="Arial" pitchFamily="34" charset="-122"/>
                 <a:cs typeface="Arial" pitchFamily="34" charset="-120"/>
               </a:rPr>
-              <a:t>$105B+ in nine months. </a:t>
+              <a:t>$105B+ in six months. </a:t>
             </a:r>
             <a:pPr indent="0" marL="0">
               <a:buNone/>

</xml_diff>

<commit_message>
Complete em dash sweep (0 remaining): rebuild, re-export all 13 JPGs
- Convert remaining ~85 em dashes in build-deck.js per established convention
  (colons for separators, commas/semicolons for clauses, middots in kickers)
- Fix stale cross-reference in viewer notes (slide-5 -> slide-6 policy debate)
- Track Slide13.JPG and validate-deck.js
- Re-export slides at v=202606110521; validator passes 13/13/13

Co-Authored-By: Claude Fable 5 <noreply@anthropic.com>
</commit_message>
<xml_diff>
--- a/ai-markets-deck.pptx
+++ b/ai-markets-deck.pptx
@@ -1201,13 +1201,13 @@
               <c:strCache>
                 <c:ptCount val="3"/>
                 <c:pt idx="0">
-                  <c:v>Top 3 — $18</c:v>
+                  <c:v>Top 3: $18</c:v>
                 </c:pt>
                 <c:pt idx="1">
-                  <c:v>Rest of top 10 — $19</c:v>
+                  <c:v>Rest of top 10: $19</c:v>
                 </c:pt>
                 <c:pt idx="2">
-                  <c:v>Other 490 — $63</c:v>
+                  <c:v>Other 490: $63</c:v>
                 </c:pt>
               </c:strCache>
             </c:strRef>
@@ -1670,7 +1670,7 @@
           <a:p>
             <a:r>
               <a:rPr lang="en-US" dirty="0"/>
-              <a:t>The deck in one breath: part one is what’s happening right now — models became loop-running agents, tokens became a rationed input, and Washington moved from regulating AI to debating who owns it. Part two is how markets reprice all of it: equities split the trade, the labor data started moving, the financing moved into the bond market, and your benchmark quietly became an AI fund. Twelve slides, two parts, one question throughout: what does this do to portfolios.</a:t>
+              <a:t>The deck in one breath: part one is what’s happening right now: models became loop-running agents, tokens became a rationed input, and governments moved from regulating AI to debating who owns it. Part two is how markets reprice all of it: equities split the trade, the labor data started moving, the financing moved into the bond market, and your benchmark quietly became an AI fund. Thirteen slides, two parts, one question throughout: what does this do to portfolios.</a:t>
             </a:r>
             <a:endParaRPr lang="en-US" dirty="0"/>
           </a:p>
@@ -1758,7 +1758,7 @@
           <a:p>
             <a:r>
               <a:rPr lang="en-US" dirty="0"/>
-              <a:t>Bonds, part two: the wave. Five mega-deals in six months — Oracle $18B (Sep ’25), Meta $30B (Oct ’25, the largest non-M&amp;A IG deal on record), Alphabet $17.5B and Amazon $15B (Nov ’25), Oracle again $25B across eight tranches (Feb ’26). Street consensus: ~$300B of AI-linked IG supply in 2026. The signal layer: Oracle’s 5-yr CDS above ~125bp despite light leverage — credit is already discriminating by funding capacity, not just rating. The READ box is the takeaway for equity holders: spreads reprice before earnings revisions. Balance sheets are still lightly levered vs IG norms — this is not 2008 telecom — but the funding model changed permanently.</a:t>
+              <a:t>Bonds, part two: the wave. Five mega-deals in six months: Oracle $18B (Sep ’25), Meta $30B (Oct ’25, the largest non-M&amp;A IG deal on record), Alphabet $17.5B and Amazon $15B (Nov ’25), Oracle again $25B across eight tranches (Feb ’26). Street consensus: ~$300B of AI-linked IG supply in 2026. The signal layer: Oracle’s 5-yr CDS above ~125bp despite light leverage; credit is already discriminating by funding capacity, not just rating. The READ box is the takeaway for equity holders: spreads reprice before earnings revisions. Balance sheets are still lightly levered vs IG norms (this is not 2008 telecom), but the funding model changed permanently.</a:t>
             </a:r>
             <a:endParaRPr lang="en-US" dirty="0"/>
           </a:p>
@@ -1846,7 +1846,7 @@
           <a:p>
             <a:r>
               <a:rPr lang="en-US" dirty="0"/>
-              <a:t>The so-what slide. Nobody in this room would deliberately put 37% of an equity sleeve in ten correlated names sharing one earnings driver — but a benchmark allocation does precisely that ($37 of every $100). Four gauges, each paired with an action: demand (capex guidance + token budgets — the new same-store sales), financing (CDS and new-issue spreads, per slide 10), rates (long-duration cash flows + record supply), and concentration (equal-weight vs cap-weight as the orderly preview of the disorderly version). Honest caveat: equal-weight won 2026 but lost 2024–25 — the message is 'size the bet on purpose,' not 'sell megacaps.' Closing line is the deck’s thesis in one sentence.</a:t>
+              <a:t>The so-what slide. Nobody in this room would deliberately put 37% of an equity sleeve in ten correlated names sharing one earnings driver, but a benchmark allocation does precisely that ($37 of every $100). Four gauges, each paired with an action: demand (capex guidance + token budgets: the new same-store sales), financing (CDS and new-issue spreads, per slide 10), rates (long-duration cash flows + record supply), and concentration (equal-weight vs cap-weight as the orderly preview of the disorderly version). Honest caveat: equal-weight won 2026 but lost 2024–25; the message is 'size the bet on purpose,' not 'sell megacaps.' Closing line is the deck’s thesis in one sentence.</a:t>
             </a:r>
             <a:endParaRPr lang="en-US" dirty="0"/>
           </a:p>
@@ -1934,7 +1934,7 @@
           <a:p>
             <a:r>
               <a:rPr lang="en-US" dirty="0"/>
-              <a:t>The closer — the option value sitting behind the multiples, kept disciplined. Embodiment: agentic loops in a body, walking a shift. Orbit: it removes the exact power-and-cooling constraints behind token rationing (slide 5), and SpaceX is simultaneously the neocloud king and the launch monopolist — if orbital compute happens it’s an extension of the most vertically integrated player in the stack. Wheels: every robotaxi mile is metered inference. Proteins: frontier models lead biology benchmarks; discovery becomes compute-bound. Every card is new compute demand — the Jevons curve extended a decade. Flagged speculative; gauges, not guidance.</a:t>
+              <a:t>The closer: the option value sitting behind the multiples, kept disciplined. Embodiment: agentic loops in a body, walking a shift. Orbit: it removes the exact power-and-cooling constraints behind token rationing (slide 5), and SpaceX is simultaneously the neocloud king and the launch monopolist; if orbital compute happens it’s an extension of the most vertically integrated player in the stack. Wheels: every robotaxi mile is metered inference. Proteins: frontier models lead biology benchmarks; discovery becomes compute-bound. Every card is new compute demand: the Jevons curve extended a decade. Flagged speculative; gauges, not guidance.</a:t>
             </a:r>
             <a:endParaRPr lang="en-US" dirty="0"/>
           </a:p>
@@ -2022,7 +2022,7 @@
           <a:p>
             <a:r>
               <a:rPr lang="en-US" dirty="0"/>
-              <a:t>Back matter. Canonical stamp: data as of June 2026; returns through Jun 5–9 closes. New LABOR &amp; POLICY column covers the web-verified Challenger and NY Fed figures. Honesty notes: the Jevons curve is illustrative; AI layoff attributions are self-reported and may overstate causation; frontier items are speculative; the three image placeholders (cover, token meter, capitol) are pending final art and labeled as such on-slide.</a:t>
+              <a:t>Back matter. Canonical stamp: data as of June 2026; returns through Jun 5–9 closes. New LABOR &amp; POLICY column covers the web-verified Challenger and NY Fed figures. Honesty notes: the Jevons curve is illustrative; AI layoff attributions are self-reported and may overstate causation; frontier items are speculative.</a:t>
             </a:r>
             <a:endParaRPr lang="en-US" dirty="0"/>
           </a:p>
@@ -2110,7 +2110,7 @@
           <a:p>
             <a:r>
               <a:rPr lang="en-US" dirty="0"/>
-              <a:t>The thesis slide — and why this isn’t 2023’s hype cycle: three independent systems shifting in the same direction at once. Capability: models became loop-running systems (slide 4). Economics: tokens went from subsidized to rationed (slide 5). Policy: when governments debate taking equity, the asset class changed category (slide 6). Each column carries one proof stat: $47B of run rate, $920M/month of rental, a 50% equity-tax proposal. The banner is the line to read aloud.</a:t>
+              <a:t>The thesis slide, and why this isn’t 2023’s hype cycle: three independent systems shifting in the same direction at once. Capability: models became loop-running systems (slide 4). Economics: tokens went from subsidized to rationed (slide 5). Policy: when governments debate taking equity, the asset class changed category (slide 6). Each column carries one proof stat: $47B of run rate, $920M/month of rental, a 50% equity-tax proposal. The banner is the line to read aloud.</a:t>
             </a:r>
             <a:endParaRPr lang="en-US" dirty="0"/>
           </a:p>
@@ -2198,7 +2198,7 @@
           <a:p>
             <a:r>
               <a:rPr lang="en-US" dirty="0"/>
-              <a:t>Framework slide — four dimensions where the assisted-to-agentic transition shows up. Interface shifted from chat to background loops. Cost moved from flat seats to metered tokens. Output evolved from snippets to disposable apps. Bottleneck moved from human attention to compute allocation. Each of these shows up in the market data on the slides that follow.</a:t>
+              <a:t>Framework slide: four dimensions where the assisted-to-agentic transition shows up. Interface shifted from chat to background loops. Cost moved from flat seats to metered tokens. Output evolved from snippets to disposable apps. Bottleneck moved from human attention to compute allocation. Each of these shows up in the market data on the slides that follow.</a:t>
             </a:r>
             <a:endParaRPr lang="en-US" dirty="0"/>
           </a:p>
@@ -2286,7 +2286,7 @@
           <a:p>
             <a:r>
               <a:rPr lang="en-US" dirty="0"/>
-              <a:t>The core slide of part one. Left: the unit of work changed — from one-shot prompting to loops that try, fail, fix, and ship without a human in each cycle. Cherny’s line is the cleanest articulation. Right: the Jevons paradox (coal, 1865) applied — as agents make software effectively free to produce, we don’t write the same software cheaper, we write categorically more of it: PDF summaries become dashboards become disposable single-use apps become giant research projects. Investment translation: efficiency improvements do NOT cap compute demand — they expand it. That’s the demand engine behind everything in part two.</a:t>
+              <a:t>The core slide of part one. Left: the unit of work changed: from one-shot prompting to loops that try, fail, fix, and ship without a human in each cycle. Cherny’s line is the cleanest articulation. Right: the Jevons paradox (coal, 1865) applied: as agents make software effectively free to produce, we don’t write the same software cheaper, we write categorically more of it: PDF summaries become dashboards become disposable single-use apps become giant research projects. Investment translation: efficiency improvements do NOT cap compute demand; they expand it. That’s the demand engine behind everything in part two.</a:t>
             </a:r>
             <a:endParaRPr lang="en-US" dirty="0"/>
           </a:p>
@@ -2374,7 +2374,7 @@
           <a:p>
             <a:r>
               <a:rPr lang="en-US" dirty="0"/>
-              <a:t>Three data points, one message: enterprises now treat tokens as a metered input with a budget line. Uber: $1,500/month per employee. Walmart: killed unlimited access for Code Puppy. The third card is the supply side — SK Hynix sees no HBM relief before ~2030 even after doubling capacity, and Google’s $920M/month rental is what scarcity costs when you don’t own capacity. The READ box carries the investability point: token budgets are the new same-store sales.</a:t>
+              <a:t>Three data points, one message: enterprises now treat tokens as a metered input with a budget line. Uber: $1,500/month per employee. Walmart: killed unlimited access for Code Puppy. The third card is the supply side: SK Hynix sees no HBM relief before ~2030 even after doubling capacity, and Google’s $920M/month rental is what scarcity costs when you don’t own capacity. The READ box carries the investability point: token budgets are the new same-store sales.</a:t>
             </a:r>
             <a:endParaRPr lang="en-US" dirty="0"/>
           </a:p>
@@ -2462,7 +2462,7 @@
           <a:p>
             <a:r>
               <a:rPr lang="en-US" dirty="0"/>
-              <a:t>The policy slide stays neutral by quoting all sides. EO: voluntary 30-day NSA review, cyber-focused, no licensing — lighter than feared, but a calendar item before every frontier release. SWF: a one-time 50% equity tax to fund AI Dividends — when Sanders proposes and Trump echoes, the Overton window has genuinely moved. Sacks' critique is the third leg: nationalization as a threat to the property rights underpinning lab valuations. The investable point: public-ownership tail risk now belongs in any model of lab equity, the IPO pipeline, and the hyperscalers holding lab stakes. This slide is also the political receiving end of the labor story on slide 8.</a:t>
+              <a:t>The policy slide, now global. Left: US. EO is a voluntary 30-day NSA review, lighter than feared but a calendar item before every frontier release. The 50% equity-tax proposal seeds AI Dividends: when Sanders and Trump both float it, the Overton window moved. Sacks' critique completes the triangle. Right: South Korea. Kim Yong-beom (presidential policy chief) posted a "citizen dividend" idea on May 12; KOSPI dropped 5.1% intraday. Lee Jae-myung walked it back, but Samsung's union had already demanded 15% of chip-division profit (April). The pattern: once governments frame AI as a sovereign asset, the ownership debate follows. Investable point: public-ownership tail risk now belongs in any model of lab equity, the IPO pipeline, and the hyperscalers holding lab stakes.</a:t>
             </a:r>
             <a:endParaRPr lang="en-US" dirty="0"/>
           </a:p>
@@ -2550,7 +2550,7 @@
           <a:p>
             <a:r>
               <a:rPr lang="en-US" dirty="0"/>
-              <a:t>Part two opens with the equity scoreboard. SOXX +80% YTD (best run since 2000, ~$5.7T added in the April rally alone); equal-weight +14% beats cap-weight +11%; MAGS +6% lags; software −10%, priced for disruption. The market is no longer trading 'AI yes/no' — it’s trading position in the chain. The right rail is the concentration story: 37% of the index in ten names (double the 25-year norm), Nvidia alone at 7%, and a forward multiple that’s elevated but not extreme — provided the AI earnings stream keeps compounding.</a:t>
+              <a:t>Part two opens with the equity scoreboard. SOXX +80% YTD (best run since 2000, ~$5.7T added in the April rally alone); equal-weight +14% beats cap-weight +11%; MAGS +6% lags; software −10%, priced for disruption. The market is no longer trading 'AI yes/no'; it’s trading position in the chain. The right rail is the concentration story: 37% of the index in ten names (double the 25-year norm), Nvidia alone at 7%, and a forward multiple that’s elevated but not extreme, provided the AI earnings stream keeps compounding.</a:t>
             </a:r>
             <a:endParaRPr lang="en-US" dirty="0"/>
           </a:p>
@@ -2638,7 +2638,7 @@
           <a:p>
             <a:r>
               <a:rPr lang="en-US" dirty="0"/>
-              <a:t>The labor slide — new this version, with verified June 2026 data. Left: the structural story — a job stops being task execution and becomes orchestration of parallel agent loops; the 20–25% coordination figure is the pool agents are bought to recover. Right: the data — Challenger’s May report made AI the #1 stated layoff reason for the first time (~40% of announced cuts, with the honest caveat that it’s self-reported and partly scapegoating); the entry level is where it bites (grad unemployment 5.6% vs 4.2%, declining payrolls for the youngest AI-exposed cohort); and the advantage gap stratifies pay within surviving roles. Markets price labor twice: as a cost line agents deflate, and as the political trigger for slide 6’s ownership debate.</a:t>
+              <a:t>The labor slide, new this version, with verified June 2026 data. Left: the structural story: a job stops being task execution and becomes orchestration of parallel agent loops; the 20–25% coordination figure is the pool agents are bought to recover. Right: the data: Challenger’s May report made AI the #1 stated layoff reason for the first time (~40% of announced cuts, with the honest caveat that it’s self-reported and partly scapegoating); the entry level is where it bites (grad unemployment 5.6% vs 4.2%, declining payrolls for the youngest AI-exposed cohort); and the advantage gap stratifies pay within surviving roles. Markets price labor twice: as a cost line agents deflate, and as the political trigger for slide 6’s ownership debate.</a:t>
             </a:r>
             <a:endParaRPr lang="en-US" dirty="0"/>
           </a:p>
@@ -2726,7 +2726,7 @@
           <a:p>
             <a:r>
               <a:rPr lang="en-US" dirty="0"/>
-              <a:t>Bonds, part one: the gap. Capex went from $410B to ~$705B guided (+72%) — and three of four raised guidance in the latest round. The cash math: ~94% of operating cash flow committed to capex, dividends, and buybacks; Big-4 FCF at a decade low; Amazon outright negative ($200B capex vs ~$140B operating cash flow); Alphabet’s FCF down ~90% to ~$8B. For a decade the megacap social contract was self-funding plus buybacks. It broke in 2026 — and something had to fill the gap. Next slide.</a:t>
+              <a:t>Bonds, part one: the gap. Capex went from $410B to ~$705B guided (+72%), and three of four raised guidance in the latest round. The cash math: ~94% of operating cash flow committed to capex, dividends, and buybacks; Big-4 FCF at a decade low; Amazon outright negative ($200B capex vs ~$140B operating cash flow); Alphabet’s FCF down ~90% to ~$8B. For a decade the megacap social contract was self-funding plus buybacks. It broke in 2026, and something had to fill the gap. Next slide.</a:t>
             </a:r>
             <a:endParaRPr lang="en-US" dirty="0"/>
           </a:p>
@@ -3191,7 +3191,7 @@
                 <a:ea typeface="Arial Black" pitchFamily="34" charset="-122"/>
                 <a:cs typeface="Arial Black" pitchFamily="34" charset="-120"/>
               </a:rPr>
-              <a:t>AI in the Market.</a:t>
+              <a:t>AI in the markets.</a:t>
             </a:r>
             <a:endParaRPr lang="en-US" sz="4000" dirty="0"/>
           </a:p>
@@ -3230,7 +3230,7 @@
                 <a:ea typeface="Arial Black" pitchFamily="34" charset="-122"/>
                 <a:cs typeface="Arial Black" pitchFamily="34" charset="-120"/>
               </a:rPr>
-              <a:t>What’s happening now — and how markets reprice.</a:t>
+              <a:t>What’s happening now, and how markets reprice.</a:t>
             </a:r>
             <a:endParaRPr lang="en-US" sz="2000" dirty="0"/>
           </a:p>
@@ -3269,7 +3269,7 @@
                 <a:ea typeface="Arial" pitchFamily="34" charset="-122"/>
                 <a:cs typeface="Arial" pitchFamily="34" charset="-120"/>
               </a:rPr>
-              <a:t>Agentic loops, token rationing, and Washington’s entry — then the repricing: equities, labor, and a $300B bond wave.</a:t>
+              <a:t>Agentic loops, token rationing, and the policy shift; the repricing: equities, labor, and a $300B bond wave.</a:t>
             </a:r>
             <a:endParaRPr lang="en-US" sz="1300" dirty="0"/>
           </a:p>
@@ -3326,6 +3326,481 @@
             <a:ext cx="2377440" cy="3520440"/>
           </a:xfrm>
           <a:prstGeom prst="rect">
+            <a:avLst/>
+          </a:prstGeom>
+          <a:solidFill>
+            <a:srgbClr val="1C1C20"/>
+          </a:solidFill>
+          <a:ln w="12700">
+            <a:solidFill>
+              <a:srgbClr val="2A2A30"/>
+            </a:solidFill>
+            <a:prstDash val="solid"/>
+          </a:ln>
+        </p:spPr>
+      </p:sp>
+      <p:sp>
+        <p:nvSpPr>
+          <p:cNvPr id="9" name="Shape 7"/>
+          <p:cNvSpPr/>
+          <p:nvPr/>
+        </p:nvSpPr>
+        <p:spPr>
+          <a:xfrm>
+            <a:off x="6309360" y="777240"/>
+            <a:ext cx="73152" cy="3520440"/>
+          </a:xfrm>
+          <a:prstGeom prst="rect">
+            <a:avLst/>
+          </a:prstGeom>
+          <a:solidFill>
+            <a:srgbClr val="FFD100"/>
+          </a:solidFill>
+          <a:ln/>
+        </p:spPr>
+      </p:sp>
+      <p:sp>
+        <p:nvSpPr>
+          <p:cNvPr id="10" name="Text 8"/>
+          <p:cNvSpPr/>
+          <p:nvPr/>
+        </p:nvSpPr>
+        <p:spPr>
+          <a:xfrm>
+            <a:off x="6537960" y="1033272"/>
+            <a:ext cx="1920240" cy="219456"/>
+          </a:xfrm>
+          <a:prstGeom prst="rect">
+            <a:avLst/>
+          </a:prstGeom>
+          <a:noFill/>
+          <a:ln/>
+        </p:spPr>
+        <p:txBody>
+          <a:bodyPr wrap="square" lIns="0" tIns="0" rIns="0" bIns="0" rtlCol="0" anchor="ctr"/>
+          <a:lstStyle/>
+          <a:p>
+            <a:pPr indent="0" marL="0">
+              <a:buNone/>
+            </a:pPr>
+            <a:r>
+              <a:rPr lang="en-US" sz="800" b="1" spc="220" kern="0" dirty="0">
+                <a:solidFill>
+                  <a:srgbClr val="FFD100"/>
+                </a:solidFill>
+                <a:latin typeface="Arial" pitchFamily="34" charset="0"/>
+                <a:ea typeface="Arial" pitchFamily="34" charset="-122"/>
+                <a:cs typeface="Arial" pitchFamily="34" charset="-120"/>
+              </a:rPr>
+              <a:t>AGENTIC LOOP</a:t>
+            </a:r>
+            <a:endParaRPr lang="en-US" sz="800" dirty="0"/>
+          </a:p>
+        </p:txBody>
+      </p:sp>
+      <p:sp>
+        <p:nvSpPr>
+          <p:cNvPr id="11" name="Text 9"/>
+          <p:cNvSpPr/>
+          <p:nvPr/>
+        </p:nvSpPr>
+        <p:spPr>
+          <a:xfrm>
+            <a:off x="6537960" y="1307592"/>
+            <a:ext cx="1920240" cy="365760"/>
+          </a:xfrm>
+          <a:prstGeom prst="rect">
+            <a:avLst/>
+          </a:prstGeom>
+          <a:noFill/>
+          <a:ln/>
+        </p:spPr>
+        <p:txBody>
+          <a:bodyPr wrap="square" lIns="0" tIns="0" rIns="0" bIns="0" rtlCol="0" anchor="ctr"/>
+          <a:lstStyle/>
+          <a:p>
+            <a:pPr indent="0" marL="0">
+              <a:buNone/>
+            </a:pPr>
+            <a:r>
+              <a:rPr lang="en-US" sz="900" dirty="0">
+                <a:solidFill>
+                  <a:srgbClr val="C9C9CE"/>
+                </a:solidFill>
+                <a:latin typeface="Arial" pitchFamily="34" charset="0"/>
+                <a:ea typeface="Arial" pitchFamily="34" charset="-122"/>
+                <a:cs typeface="Arial" pitchFamily="34" charset="-120"/>
+              </a:rPr>
+              <a:t>Try, fail, fix, ship - then meter the compute.</a:t>
+            </a:r>
+            <a:endParaRPr lang="en-US" sz="900" dirty="0"/>
+          </a:p>
+        </p:txBody>
+      </p:sp>
+      <p:sp>
+        <p:nvSpPr>
+          <p:cNvPr id="12" name="Shape 10"/>
+          <p:cNvSpPr/>
+          <p:nvPr/>
+        </p:nvSpPr>
+        <p:spPr>
+          <a:xfrm>
+            <a:off x="7406640" y="2203704"/>
+            <a:ext cx="256032" cy="0"/>
+          </a:xfrm>
+          <a:prstGeom prst="line">
+            <a:avLst/>
+          </a:prstGeom>
+          <a:noFill/>
+          <a:ln w="17780">
+            <a:solidFill>
+              <a:srgbClr val="2BC4C4"/>
+            </a:solidFill>
+            <a:prstDash val="solid"/>
+            <a:tailEnd type="triangle"/>
+          </a:ln>
+        </p:spPr>
+      </p:sp>
+      <p:sp>
+        <p:nvSpPr>
+          <p:cNvPr id="13" name="Shape 11"/>
+          <p:cNvSpPr/>
+          <p:nvPr/>
+        </p:nvSpPr>
+        <p:spPr>
+          <a:xfrm>
+            <a:off x="7991856" y="2368296"/>
+            <a:ext cx="0" cy="438912"/>
+          </a:xfrm>
+          <a:prstGeom prst="line">
+            <a:avLst/>
+          </a:prstGeom>
+          <a:noFill/>
+          <a:ln w="17780">
+            <a:solidFill>
+              <a:srgbClr val="2BC4C4"/>
+            </a:solidFill>
+            <a:prstDash val="solid"/>
+            <a:tailEnd type="triangle"/>
+          </a:ln>
+        </p:spPr>
+      </p:sp>
+      <p:sp>
+        <p:nvSpPr>
+          <p:cNvPr id="14" name="Shape 12"/>
+          <p:cNvSpPr/>
+          <p:nvPr/>
+        </p:nvSpPr>
+        <p:spPr>
+          <a:xfrm flipH="1">
+            <a:off x="7406640" y="2971800"/>
+            <a:ext cx="256032" cy="0"/>
+          </a:xfrm>
+          <a:prstGeom prst="line">
+            <a:avLst/>
+          </a:prstGeom>
+          <a:noFill/>
+          <a:ln w="17780">
+            <a:solidFill>
+              <a:srgbClr val="2BC4C4"/>
+            </a:solidFill>
+            <a:prstDash val="solid"/>
+            <a:tailEnd type="triangle"/>
+          </a:ln>
+        </p:spPr>
+      </p:sp>
+      <p:sp>
+        <p:nvSpPr>
+          <p:cNvPr id="15" name="Shape 13"/>
+          <p:cNvSpPr/>
+          <p:nvPr/>
+        </p:nvSpPr>
+        <p:spPr>
+          <a:xfrm flipV="1">
+            <a:off x="7077456" y="2368296"/>
+            <a:ext cx="0" cy="438912"/>
+          </a:xfrm>
+          <a:prstGeom prst="line">
+            <a:avLst/>
+          </a:prstGeom>
+          <a:noFill/>
+          <a:ln w="17780">
+            <a:solidFill>
+              <a:srgbClr val="2BC4C4"/>
+            </a:solidFill>
+            <a:prstDash val="solid"/>
+            <a:tailEnd type="triangle"/>
+          </a:ln>
+        </p:spPr>
+      </p:sp>
+      <p:sp>
+        <p:nvSpPr>
+          <p:cNvPr id="16" name="Shape 14"/>
+          <p:cNvSpPr/>
+          <p:nvPr/>
+        </p:nvSpPr>
+        <p:spPr>
+          <a:xfrm>
+            <a:off x="6748272" y="2039112"/>
+            <a:ext cx="658368" cy="329184"/>
+          </a:xfrm>
+          <a:prstGeom prst="ellipse">
+            <a:avLst/>
+          </a:prstGeom>
+          <a:solidFill>
+            <a:srgbClr val="111114"/>
+          </a:solidFill>
+          <a:ln w="19050">
+            <a:solidFill>
+              <a:srgbClr val="2BC4C4"/>
+            </a:solidFill>
+            <a:prstDash val="solid"/>
+          </a:ln>
+        </p:spPr>
+      </p:sp>
+      <p:sp>
+        <p:nvSpPr>
+          <p:cNvPr id="17" name="Text 15"/>
+          <p:cNvSpPr/>
+          <p:nvPr/>
+        </p:nvSpPr>
+        <p:spPr>
+          <a:xfrm>
+            <a:off x="6748272" y="2112264"/>
+            <a:ext cx="658368" cy="146304"/>
+          </a:xfrm>
+          <a:prstGeom prst="rect">
+            <a:avLst/>
+          </a:prstGeom>
+          <a:noFill/>
+          <a:ln/>
+        </p:spPr>
+        <p:txBody>
+          <a:bodyPr wrap="square" lIns="0" tIns="0" rIns="0" bIns="0" rtlCol="0" anchor="ctr"/>
+          <a:lstStyle/>
+          <a:p>
+            <a:pPr algn="ctr" indent="0" marL="0">
+              <a:buNone/>
+            </a:pPr>
+            <a:r>
+              <a:rPr lang="en-US" sz="750" b="1" dirty="0">
+                <a:solidFill>
+                  <a:srgbClr val="2BC4C4"/>
+                </a:solidFill>
+                <a:latin typeface="Arial" pitchFamily="34" charset="0"/>
+                <a:ea typeface="Arial" pitchFamily="34" charset="-122"/>
+                <a:cs typeface="Arial" pitchFamily="34" charset="-120"/>
+              </a:rPr>
+              <a:t>TRY</a:t>
+            </a:r>
+            <a:endParaRPr lang="en-US" sz="750" dirty="0"/>
+          </a:p>
+        </p:txBody>
+      </p:sp>
+      <p:sp>
+        <p:nvSpPr>
+          <p:cNvPr id="18" name="Shape 16"/>
+          <p:cNvSpPr/>
+          <p:nvPr/>
+        </p:nvSpPr>
+        <p:spPr>
+          <a:xfrm>
+            <a:off x="7662672" y="2039112"/>
+            <a:ext cx="658368" cy="329184"/>
+          </a:xfrm>
+          <a:prstGeom prst="ellipse">
+            <a:avLst/>
+          </a:prstGeom>
+          <a:solidFill>
+            <a:srgbClr val="111114"/>
+          </a:solidFill>
+          <a:ln w="19050">
+            <a:solidFill>
+              <a:srgbClr val="2BC4C4"/>
+            </a:solidFill>
+            <a:prstDash val="solid"/>
+          </a:ln>
+        </p:spPr>
+      </p:sp>
+      <p:sp>
+        <p:nvSpPr>
+          <p:cNvPr id="19" name="Text 17"/>
+          <p:cNvSpPr/>
+          <p:nvPr/>
+        </p:nvSpPr>
+        <p:spPr>
+          <a:xfrm>
+            <a:off x="7662672" y="2112264"/>
+            <a:ext cx="658368" cy="146304"/>
+          </a:xfrm>
+          <a:prstGeom prst="rect">
+            <a:avLst/>
+          </a:prstGeom>
+          <a:noFill/>
+          <a:ln/>
+        </p:spPr>
+        <p:txBody>
+          <a:bodyPr wrap="square" lIns="0" tIns="0" rIns="0" bIns="0" rtlCol="0" anchor="ctr"/>
+          <a:lstStyle/>
+          <a:p>
+            <a:pPr algn="ctr" indent="0" marL="0">
+              <a:buNone/>
+            </a:pPr>
+            <a:r>
+              <a:rPr lang="en-US" sz="750" b="1" dirty="0">
+                <a:solidFill>
+                  <a:srgbClr val="2BC4C4"/>
+                </a:solidFill>
+                <a:latin typeface="Arial" pitchFamily="34" charset="0"/>
+                <a:ea typeface="Arial" pitchFamily="34" charset="-122"/>
+                <a:cs typeface="Arial" pitchFamily="34" charset="-120"/>
+              </a:rPr>
+              <a:t>FAIL</a:t>
+            </a:r>
+            <a:endParaRPr lang="en-US" sz="750" dirty="0"/>
+          </a:p>
+        </p:txBody>
+      </p:sp>
+      <p:sp>
+        <p:nvSpPr>
+          <p:cNvPr id="20" name="Shape 18"/>
+          <p:cNvSpPr/>
+          <p:nvPr/>
+        </p:nvSpPr>
+        <p:spPr>
+          <a:xfrm>
+            <a:off x="7662672" y="2807208"/>
+            <a:ext cx="658368" cy="329184"/>
+          </a:xfrm>
+          <a:prstGeom prst="ellipse">
+            <a:avLst/>
+          </a:prstGeom>
+          <a:solidFill>
+            <a:srgbClr val="111114"/>
+          </a:solidFill>
+          <a:ln w="19050">
+            <a:solidFill>
+              <a:srgbClr val="2BC4C4"/>
+            </a:solidFill>
+            <a:prstDash val="solid"/>
+          </a:ln>
+        </p:spPr>
+      </p:sp>
+      <p:sp>
+        <p:nvSpPr>
+          <p:cNvPr id="21" name="Text 19"/>
+          <p:cNvSpPr/>
+          <p:nvPr/>
+        </p:nvSpPr>
+        <p:spPr>
+          <a:xfrm>
+            <a:off x="7662672" y="2880360"/>
+            <a:ext cx="658368" cy="146304"/>
+          </a:xfrm>
+          <a:prstGeom prst="rect">
+            <a:avLst/>
+          </a:prstGeom>
+          <a:noFill/>
+          <a:ln/>
+        </p:spPr>
+        <p:txBody>
+          <a:bodyPr wrap="square" lIns="0" tIns="0" rIns="0" bIns="0" rtlCol="0" anchor="ctr"/>
+          <a:lstStyle/>
+          <a:p>
+            <a:pPr algn="ctr" indent="0" marL="0">
+              <a:buNone/>
+            </a:pPr>
+            <a:r>
+              <a:rPr lang="en-US" sz="750" b="1" dirty="0">
+                <a:solidFill>
+                  <a:srgbClr val="2BC4C4"/>
+                </a:solidFill>
+                <a:latin typeface="Arial" pitchFamily="34" charset="0"/>
+                <a:ea typeface="Arial" pitchFamily="34" charset="-122"/>
+                <a:cs typeface="Arial" pitchFamily="34" charset="-120"/>
+              </a:rPr>
+              <a:t>FIX</a:t>
+            </a:r>
+            <a:endParaRPr lang="en-US" sz="750" dirty="0"/>
+          </a:p>
+        </p:txBody>
+      </p:sp>
+      <p:sp>
+        <p:nvSpPr>
+          <p:cNvPr id="22" name="Shape 20"/>
+          <p:cNvSpPr/>
+          <p:nvPr/>
+        </p:nvSpPr>
+        <p:spPr>
+          <a:xfrm>
+            <a:off x="6748272" y="2807208"/>
+            <a:ext cx="658368" cy="329184"/>
+          </a:xfrm>
+          <a:prstGeom prst="ellipse">
+            <a:avLst/>
+          </a:prstGeom>
+          <a:solidFill>
+            <a:srgbClr val="111114"/>
+          </a:solidFill>
+          <a:ln w="19050">
+            <a:solidFill>
+              <a:srgbClr val="2BC4C4"/>
+            </a:solidFill>
+            <a:prstDash val="solid"/>
+          </a:ln>
+        </p:spPr>
+      </p:sp>
+      <p:sp>
+        <p:nvSpPr>
+          <p:cNvPr id="23" name="Text 21"/>
+          <p:cNvSpPr/>
+          <p:nvPr/>
+        </p:nvSpPr>
+        <p:spPr>
+          <a:xfrm>
+            <a:off x="6748272" y="2880360"/>
+            <a:ext cx="658368" cy="146304"/>
+          </a:xfrm>
+          <a:prstGeom prst="rect">
+            <a:avLst/>
+          </a:prstGeom>
+          <a:noFill/>
+          <a:ln/>
+        </p:spPr>
+        <p:txBody>
+          <a:bodyPr wrap="square" lIns="0" tIns="0" rIns="0" bIns="0" rtlCol="0" anchor="ctr"/>
+          <a:lstStyle/>
+          <a:p>
+            <a:pPr algn="ctr" indent="0" marL="0">
+              <a:buNone/>
+            </a:pPr>
+            <a:r>
+              <a:rPr lang="en-US" sz="750" b="1" dirty="0">
+                <a:solidFill>
+                  <a:srgbClr val="2BC4C4"/>
+                </a:solidFill>
+                <a:latin typeface="Arial" pitchFamily="34" charset="0"/>
+                <a:ea typeface="Arial" pitchFamily="34" charset="-122"/>
+                <a:cs typeface="Arial" pitchFamily="34" charset="-120"/>
+              </a:rPr>
+              <a:t>SHIP</a:t>
+            </a:r>
+            <a:endParaRPr lang="en-US" sz="750" dirty="0"/>
+          </a:p>
+        </p:txBody>
+      </p:sp>
+      <p:sp>
+        <p:nvSpPr>
+          <p:cNvPr id="24" name="Shape 22"/>
+          <p:cNvSpPr/>
+          <p:nvPr/>
+        </p:nvSpPr>
+        <p:spPr>
+          <a:xfrm>
+            <a:off x="7086600" y="2404872"/>
+            <a:ext cx="822960" cy="402336"/>
+          </a:xfrm>
+          <a:prstGeom prst="ellipse">
             <a:avLst/>
           </a:prstGeom>
           <a:solidFill>
@@ -3335,144 +3810,20 @@
             <a:solidFill>
               <a:srgbClr val="2A2A30"/>
             </a:solidFill>
-            <a:prstDash val="dash"/>
-          </a:ln>
-        </p:spPr>
-      </p:sp>
-      <p:sp>
-        <p:nvSpPr>
-          <p:cNvPr id="9" name="Shape 7"/>
-          <p:cNvSpPr/>
-          <p:nvPr/>
-        </p:nvSpPr>
-        <p:spPr>
-          <a:xfrm>
-            <a:off x="6309360" y="777240"/>
-            <a:ext cx="274320" cy="32004"/>
-          </a:xfrm>
-          <a:prstGeom prst="rect">
-            <a:avLst/>
-          </a:prstGeom>
-          <a:solidFill>
-            <a:srgbClr val="FFD100"/>
-          </a:solidFill>
-          <a:ln/>
-        </p:spPr>
-      </p:sp>
-      <p:sp>
-        <p:nvSpPr>
-          <p:cNvPr id="10" name="Shape 8"/>
-          <p:cNvSpPr/>
-          <p:nvPr/>
-        </p:nvSpPr>
-        <p:spPr>
-          <a:xfrm>
-            <a:off x="6309360" y="777240"/>
-            <a:ext cx="32004" cy="274320"/>
-          </a:xfrm>
-          <a:prstGeom prst="rect">
-            <a:avLst/>
-          </a:prstGeom>
-          <a:solidFill>
-            <a:srgbClr val="FFD100"/>
-          </a:solidFill>
-          <a:ln/>
-        </p:spPr>
-      </p:sp>
-      <p:sp>
-        <p:nvSpPr>
-          <p:cNvPr id="11" name="Shape 9"/>
-          <p:cNvSpPr/>
-          <p:nvPr/>
-        </p:nvSpPr>
-        <p:spPr>
-          <a:xfrm>
-            <a:off x="8412480" y="4265676"/>
-            <a:ext cx="274320" cy="32004"/>
-          </a:xfrm>
-          <a:prstGeom prst="rect">
-            <a:avLst/>
-          </a:prstGeom>
-          <a:solidFill>
-            <a:srgbClr val="FFD100"/>
-          </a:solidFill>
-          <a:ln/>
-        </p:spPr>
-      </p:sp>
-      <p:sp>
-        <p:nvSpPr>
-          <p:cNvPr id="12" name="Shape 10"/>
-          <p:cNvSpPr/>
-          <p:nvPr/>
-        </p:nvSpPr>
-        <p:spPr>
-          <a:xfrm>
-            <a:off x="8654796" y="4023360"/>
-            <a:ext cx="32004" cy="274320"/>
-          </a:xfrm>
-          <a:prstGeom prst="rect">
-            <a:avLst/>
-          </a:prstGeom>
-          <a:solidFill>
-            <a:srgbClr val="FFD100"/>
-          </a:solidFill>
-          <a:ln/>
-        </p:spPr>
-      </p:sp>
-      <p:sp>
-        <p:nvSpPr>
-          <p:cNvPr id="13" name="Shape 11"/>
-          <p:cNvSpPr/>
-          <p:nvPr/>
-        </p:nvSpPr>
-        <p:spPr>
-          <a:xfrm>
-            <a:off x="7178040" y="2098548"/>
-            <a:ext cx="640080" cy="347472"/>
-          </a:xfrm>
-          <a:prstGeom prst="triangle">
-            <a:avLst/>
-          </a:prstGeom>
-          <a:ln w="19050">
-            <a:solidFill>
-              <a:srgbClr val="9A9AA0"/>
-            </a:solidFill>
             <a:prstDash val="solid"/>
           </a:ln>
         </p:spPr>
       </p:sp>
       <p:sp>
         <p:nvSpPr>
-          <p:cNvPr id="14" name="Shape 12"/>
-          <p:cNvSpPr/>
-          <p:nvPr/>
-        </p:nvSpPr>
-        <p:spPr>
-          <a:xfrm>
-            <a:off x="7626096" y="1970532"/>
-            <a:ext cx="146304" cy="146304"/>
-          </a:xfrm>
-          <a:prstGeom prst="ellipse">
-            <a:avLst/>
-          </a:prstGeom>
-          <a:ln w="19050">
-            <a:solidFill>
-              <a:srgbClr val="9A9AA0"/>
-            </a:solidFill>
-            <a:prstDash val="solid"/>
-          </a:ln>
-        </p:spPr>
-      </p:sp>
-      <p:sp>
-        <p:nvSpPr>
-          <p:cNvPr id="15" name="Text 13"/>
-          <p:cNvSpPr/>
-          <p:nvPr/>
-        </p:nvSpPr>
-        <p:spPr>
-          <a:xfrm>
-            <a:off x="6400800" y="2555748"/>
-            <a:ext cx="2194560" cy="219456"/>
+          <p:cNvPr id="25" name="Text 23"/>
+          <p:cNvSpPr/>
+          <p:nvPr/>
+        </p:nvSpPr>
+        <p:spPr>
+          <a:xfrm>
+            <a:off x="7168896" y="2532888"/>
+            <a:ext cx="658368" cy="109728"/>
           </a:xfrm>
           <a:prstGeom prst="rect">
             <a:avLst/>
@@ -3488,46 +3839,125 @@
               <a:buNone/>
             </a:pPr>
             <a:r>
-              <a:rPr lang="en-US" sz="800" b="1" spc="200" kern="0" dirty="0">
-                <a:solidFill>
-                  <a:srgbClr val="FFD100"/>
-                </a:solidFill>
-                <a:latin typeface="Arial" pitchFamily="34" charset="0"/>
-                <a:ea typeface="Arial" pitchFamily="34" charset="-122"/>
-                <a:cs typeface="Arial" pitchFamily="34" charset="-120"/>
-              </a:rPr>
-              <a:t>IMAGE — AGENTIC LOOP LIGHT TRAILS</a:t>
-            </a:r>
-            <a:endParaRPr lang="en-US" sz="800" dirty="0"/>
-          </a:p>
-        </p:txBody>
-      </p:sp>
-      <p:sp>
-        <p:nvSpPr>
-          <p:cNvPr id="16" name="Text 14"/>
-          <p:cNvSpPr/>
-          <p:nvPr/>
-        </p:nvSpPr>
-        <p:spPr>
-          <a:xfrm>
-            <a:off x="6492240" y="2811780"/>
-            <a:ext cx="2011680" cy="594360"/>
-          </a:xfrm>
-          <a:prstGeom prst="rect">
-            <a:avLst/>
-          </a:prstGeom>
-          <a:noFill/>
-          <a:ln/>
-        </p:spPr>
-        <p:txBody>
-          <a:bodyPr wrap="square" lIns="0" tIns="0" rIns="0" bIns="0" rtlCol="0" anchor="t"/>
+              <a:rPr lang="en-US" sz="580" b="1" dirty="0">
+                <a:solidFill>
+                  <a:srgbClr val="FFFFFF"/>
+                </a:solidFill>
+                <a:latin typeface="Arial" pitchFamily="34" charset="0"/>
+                <a:ea typeface="Arial" pitchFamily="34" charset="-122"/>
+                <a:cs typeface="Arial" pitchFamily="34" charset="-120"/>
+              </a:rPr>
+              <a:t>RUNS UNTIL DONE</a:t>
+            </a:r>
+            <a:endParaRPr lang="en-US" sz="580" dirty="0"/>
+          </a:p>
+        </p:txBody>
+      </p:sp>
+      <p:sp>
+        <p:nvSpPr>
+          <p:cNvPr id="26" name="Text 24"/>
+          <p:cNvSpPr/>
+          <p:nvPr/>
+        </p:nvSpPr>
+        <p:spPr>
+          <a:xfrm>
+            <a:off x="6537960" y="3657600"/>
+            <a:ext cx="1005840" cy="146304"/>
+          </a:xfrm>
+          <a:prstGeom prst="rect">
+            <a:avLst/>
+          </a:prstGeom>
+          <a:noFill/>
+          <a:ln/>
+        </p:spPr>
+        <p:txBody>
+          <a:bodyPr wrap="square" lIns="0" tIns="0" rIns="0" bIns="0" rtlCol="0" anchor="ctr"/>
+          <a:lstStyle/>
+          <a:p>
+            <a:pPr indent="0" marL="0">
+              <a:buNone/>
+            </a:pPr>
+            <a:r>
+              <a:rPr lang="en-US" sz="650" b="1" spc="140" kern="0" dirty="0">
+                <a:solidFill>
+                  <a:srgbClr val="9A9AA0"/>
+                </a:solidFill>
+                <a:latin typeface="Arial" pitchFamily="34" charset="0"/>
+                <a:ea typeface="Arial" pitchFamily="34" charset="-122"/>
+                <a:cs typeface="Arial" pitchFamily="34" charset="-120"/>
+              </a:rPr>
+              <a:t>MARKET SIGNAL</a:t>
+            </a:r>
+            <a:endParaRPr lang="en-US" sz="650" dirty="0"/>
+          </a:p>
+        </p:txBody>
+      </p:sp>
+      <p:sp>
+        <p:nvSpPr>
+          <p:cNvPr id="27" name="Shape 25"/>
+          <p:cNvSpPr/>
+          <p:nvPr/>
+        </p:nvSpPr>
+        <p:spPr>
+          <a:xfrm>
+            <a:off x="6537960" y="3886200"/>
+            <a:ext cx="1920240" cy="73152"/>
+          </a:xfrm>
+          <a:prstGeom prst="rect">
+            <a:avLst/>
+          </a:prstGeom>
+          <a:solidFill>
+            <a:srgbClr val="3E3E46"/>
+          </a:solidFill>
+          <a:ln/>
+        </p:spPr>
+      </p:sp>
+      <p:sp>
+        <p:nvSpPr>
+          <p:cNvPr id="28" name="Shape 26"/>
+          <p:cNvSpPr/>
+          <p:nvPr/>
+        </p:nvSpPr>
+        <p:spPr>
+          <a:xfrm>
+            <a:off x="6537960" y="3886200"/>
+            <a:ext cx="1382573" cy="73152"/>
+          </a:xfrm>
+          <a:prstGeom prst="rect">
+            <a:avLst/>
+          </a:prstGeom>
+          <a:solidFill>
+            <a:srgbClr val="F6693D"/>
+          </a:solidFill>
+          <a:ln/>
+        </p:spPr>
+      </p:sp>
+      <p:sp>
+        <p:nvSpPr>
+          <p:cNvPr id="29" name="Text 27"/>
+          <p:cNvSpPr/>
+          <p:nvPr/>
+        </p:nvSpPr>
+        <p:spPr>
+          <a:xfrm>
+            <a:off x="6537960" y="4041648"/>
+            <a:ext cx="1920240" cy="164592"/>
+          </a:xfrm>
+          <a:prstGeom prst="rect">
+            <a:avLst/>
+          </a:prstGeom>
+          <a:noFill/>
+          <a:ln/>
+        </p:spPr>
+        <p:txBody>
+          <a:bodyPr wrap="square" lIns="0" tIns="0" rIns="0" bIns="0" rtlCol="0" anchor="ctr"/>
           <a:lstStyle/>
           <a:p>
             <a:pPr algn="ctr" indent="0" marL="0">
               <a:buNone/>
             </a:pPr>
             <a:r>
-              <a:rPr lang="en-US" sz="700" i="1" dirty="0">
+              <a:rPr lang="en-US" sz="720" dirty="0">
                 <a:solidFill>
                   <a:srgbClr val="9A9AA0"/>
                 </a:solidFill>
@@ -3535,15 +3965,15 @@
                 <a:ea typeface="Arial" pitchFamily="34" charset="-122"/>
                 <a:cs typeface="Arial" pitchFamily="34" charset="-120"/>
               </a:rPr>
-              <a:t>Glowing teal and yellow light trails forming interlocking orbits on near-black — abstract agent loops, cinematic, minimal.</a:t>
-            </a:r>
-            <a:endParaRPr lang="en-US" sz="700" dirty="0"/>
-          </a:p>
-        </p:txBody>
-      </p:sp>
-      <p:sp>
-        <p:nvSpPr>
-          <p:cNvPr id="17" name="Shape 15"/>
+              <a:t>more loops -&gt; more tokens -&gt; more capex</a:t>
+            </a:r>
+            <a:endParaRPr lang="en-US" sz="720" dirty="0"/>
+          </a:p>
+        </p:txBody>
+      </p:sp>
+      <p:sp>
+        <p:nvSpPr>
+          <p:cNvPr id="30" name="Shape 28"/>
           <p:cNvSpPr/>
           <p:nvPr/>
         </p:nvSpPr>
@@ -3563,7 +3993,7 @@
       </p:sp>
       <p:sp>
         <p:nvSpPr>
-          <p:cNvPr id="18" name="Shape 16"/>
+          <p:cNvPr id="31" name="Shape 29"/>
           <p:cNvSpPr/>
           <p:nvPr/>
         </p:nvSpPr>
@@ -3586,7 +4016,7 @@
       </p:sp>
       <p:sp>
         <p:nvSpPr>
-          <p:cNvPr id="19" name="Text 17"/>
+          <p:cNvPr id="32" name="Text 30"/>
           <p:cNvSpPr/>
           <p:nvPr/>
         </p:nvSpPr>
@@ -3708,7 +4138,7 @@
                 <a:ea typeface="Arial" pitchFamily="34" charset="-122"/>
                 <a:cs typeface="Arial" pitchFamily="34" charset="-120"/>
               </a:rPr>
-              <a:t>02  ·  MARKET IMPACT  —  FINANCING — THE BOND WAVE</a:t>
+              <a:t>02  ·  MARKET IMPACT  ·  FINANCING · THE BOND WAVE</a:t>
             </a:r>
             <a:endParaRPr lang="en-US" sz="900" dirty="0"/>
           </a:p>
@@ -3786,7 +4216,7 @@
                 <a:ea typeface="Arial" pitchFamily="34" charset="-122"/>
                 <a:cs typeface="Arial" pitchFamily="34" charset="-120"/>
               </a:rPr>
-              <a:t>$105B+ of investment-grade mega-deals in six months — record prints, a live CDS signal, and ~$300B of supply expected for full-year 2026.</a:t>
+              <a:t>$105B+ of investment-grade mega-deals in six months: record prints, a live CDS signal, and ~$300B of supply expected for full-year 2026.</a:t>
             </a:r>
             <a:endParaRPr lang="en-US" sz="1250" dirty="0"/>
           </a:p>
@@ -4729,7 +5159,7 @@
                 <a:ea typeface="Arial" pitchFamily="34" charset="-122"/>
                 <a:cs typeface="Arial" pitchFamily="34" charset="-120"/>
               </a:rPr>
-              <a:t>Oracle 5-yr CDS despite light leverage — credit already discriminates by funding capacity (MUFG).</a:t>
+              <a:t>Oracle 5-yr CDS despite light leverage; credit already discriminates by funding capacity (MUFG).</a:t>
             </a:r>
             <a:endParaRPr lang="en-US" sz="750" dirty="0"/>
           </a:p>
@@ -4855,7 +5285,7 @@
                 <a:ea typeface="Arial" pitchFamily="34" charset="-122"/>
                 <a:cs typeface="Arial" pitchFamily="34" charset="-120"/>
               </a:rPr>
-              <a:t>Spreads move before earnings revisions — the early-warning gauge for AI equities.</a:t>
+              <a:t>Spreads move before earnings revisions: the early-warning gauge for AI equities.</a:t>
             </a:r>
             <a:endParaRPr lang="en-US" sz="1000" dirty="0"/>
           </a:p>
@@ -5106,7 +5536,7 @@
                 <a:ea typeface="Arial" pitchFamily="34" charset="-122"/>
                 <a:cs typeface="Arial" pitchFamily="34" charset="-120"/>
               </a:rPr>
-              <a:t>02  ·  MARKET IMPACT  —  PORTFOLIO</a:t>
+              <a:t>02  ·  MARKET IMPACT  ·  PORTFOLIO</a:t>
             </a:r>
             <a:endParaRPr lang="en-US" sz="900" dirty="0"/>
           </a:p>
@@ -5184,7 +5614,7 @@
                 <a:ea typeface="Arial" pitchFamily="34" charset="-122"/>
                 <a:cs typeface="Arial" pitchFamily="34" charset="-120"/>
               </a:rPr>
-              <a:t>A passive S&amp;P 500 allocation embeds an undiversified AI bet no one sized deliberately — manage it with four gauges.</a:t>
+              <a:t>A passive S&amp;P 500 allocation embeds an undiversified AI bet no one sized deliberately; manage it with four gauges.</a:t>
             </a:r>
             <a:endParaRPr lang="en-US" sz="1250" dirty="0"/>
           </a:p>
@@ -5379,7 +5809,7 @@
                 <a:ea typeface="Arial" pitchFamily="34" charset="-122"/>
                 <a:cs typeface="Arial" pitchFamily="34" charset="-120"/>
               </a:rPr>
-              <a:t>Four gauges — and what to do with them</a:t>
+              <a:t>Four gauges, and what to do with them</a:t>
             </a:r>
             <a:endParaRPr lang="en-US" sz="1300" dirty="0"/>
           </a:p>
@@ -5492,7 +5922,7 @@
                 <a:ea typeface="Arial" pitchFamily="34" charset="-122"/>
                 <a:cs typeface="Arial" pitchFamily="34" charset="-120"/>
               </a:rPr>
-              <a:t>~94% of op cash flow is committed; token budgets are the new same-store sales. Know your AI beta — size the 37% deliberately.</a:t>
+              <a:t>~94% of op cash flow is committed; token budgets are the new same-store sales. Know your AI beta; size the 37% deliberately.</a:t>
             </a:r>
             <a:endParaRPr lang="en-US" sz="900" dirty="0"/>
           </a:p>
@@ -5815,7 +6245,7 @@
                 <a:ea typeface="Arial" pitchFamily="34" charset="-122"/>
                 <a:cs typeface="Arial" pitchFamily="34" charset="-120"/>
               </a:rPr>
-              <a:t>you don’t need a view on AGI — you need to know what your portfolio already believes.</a:t>
+              <a:t>you don’t need a view on AGI; you need to know what your portfolio already believes.</a:t>
             </a:r>
             <a:endParaRPr lang="en-US" sz="1050" dirty="0"/>
           </a:p>
@@ -6066,7 +6496,7 @@
                 <a:ea typeface="Arial" pitchFamily="34" charset="-122"/>
                 <a:cs typeface="Arial" pitchFamily="34" charset="-120"/>
               </a:rPr>
-              <a:t>02  ·  MARKET IMPACT  —  THE FRONTIER</a:t>
+              <a:t>02  ·  MARKET IMPACT  ·  THE FRONTIER</a:t>
             </a:r>
             <a:endParaRPr lang="en-US" sz="900" dirty="0"/>
           </a:p>
@@ -6105,7 +6535,7 @@
                 <a:ea typeface="Arial" pitchFamily="34" charset="-122"/>
                 <a:cs typeface="Arial" pitchFamily="34" charset="-120"/>
               </a:rPr>
-              <a:t>FRONTIER WATCH — SPECULATIVE</a:t>
+              <a:t>FRONTIER WATCH · SPECULATIVE</a:t>
             </a:r>
             <a:endParaRPr lang="en-US" sz="800" dirty="0"/>
           </a:p>
@@ -6144,7 +6574,7 @@
                 <a:ea typeface="Arial Black" pitchFamily="34" charset="-122"/>
                 <a:cs typeface="Arial Black" pitchFamily="34" charset="-120"/>
               </a:rPr>
-              <a:t>The loop gets hands, wheels, wings — and proteins</a:t>
+              <a:t>The loop gets hands, wheels, wings, and proteins</a:t>
             </a:r>
             <a:endParaRPr lang="en-US" sz="2300" dirty="0"/>
           </a:p>
@@ -6183,7 +6613,7 @@
                 <a:ea typeface="Arial" pitchFamily="34" charset="-122"/>
                 <a:cs typeface="Arial" pitchFamily="34" charset="-120"/>
               </a:rPr>
-              <a:t>None of this is in 2026 guidance. All of it extends the Jevons demand curve (slide 4) by another decade — the option value markets quietly pay for.</a:t>
+              <a:t>None of this is in 2026 guidance. All of it extends the Jevons demand curve (slide 4) by another decade: the option value markets quietly pay for.</a:t>
             </a:r>
             <a:endParaRPr lang="en-US" sz="1250" dirty="0"/>
           </a:p>
@@ -6299,7 +6729,7 @@
                 <a:ea typeface="Arial" pitchFamily="34" charset="-122"/>
                 <a:cs typeface="Arial" pitchFamily="34" charset="-120"/>
               </a:rPr>
-              <a:t>Agentic loops in a body — warehouse shifts, not concept art. Physical labor enters the token economy.</a:t>
+              <a:t>Agentic loops in a body: warehouse shifts, not concept art. Physical labor enters the token economy.</a:t>
             </a:r>
             <a:endParaRPr lang="en-US" sz="950" dirty="0"/>
           </a:p>
@@ -6415,7 +6845,7 @@
                 <a:ea typeface="Arial" pitchFamily="34" charset="-122"/>
                 <a:cs typeface="Arial" pitchFamily="34" charset="-120"/>
               </a:rPr>
-              <a:t>Robotaxis are inference on wheels — per-mile token economics and a city-scale demand pool for compute.</a:t>
+              <a:t>Robotaxis are inference on wheels: per-mile token economics and a city-scale demand pool for compute.</a:t>
             </a:r>
             <a:endParaRPr lang="en-US" sz="950" dirty="0"/>
           </a:p>
@@ -6700,7 +7130,7 @@
                 <a:ea typeface="Arial" pitchFamily="34" charset="-122"/>
                 <a:cs typeface="Arial" pitchFamily="34" charset="-120"/>
               </a:rPr>
-              <a:t>launch cadence, fleet miles, design wins — gauges, not guidance.</a:t>
+              <a:t>launch cadence, fleet miles, design wins: gauges, not guidance.</a:t>
             </a:r>
             <a:endParaRPr lang="en-US" sz="1000" dirty="0"/>
           </a:p>
@@ -7461,7 +7891,7 @@
                 <a:ea typeface="Arial" pitchFamily="34" charset="-122"/>
                 <a:cs typeface="Arial" pitchFamily="34" charset="-120"/>
               </a:rPr>
-              <a:t>Layoffs: Challenger, Gray &amp; Christmas via CNBC (Jun 5, 2026) &amp; CBS News — AI cited in ~40% of May cuts; 87.7k YTD</a:t>
+              <a:t>Layoffs: Challenger, Gray &amp; Christmas via CNBC (Jun 5, 2026) &amp; CBS News; AI cited in ~40% of May cuts; 87.7k YTD</a:t>
             </a:r>
             <a:endParaRPr lang="en-US" sz="720" dirty="0"/>
           </a:p>
@@ -7524,7 +7954,7 @@
                 <a:ea typeface="Arial" pitchFamily="34" charset="-122"/>
                 <a:cs typeface="Arial" pitchFamily="34" charset="-120"/>
               </a:rPr>
-              <a:t>Policy: Executive Order provisions, sovereign-wealth-fund proposals, Sacks critique — per the strategic review</a:t>
+              <a:t>Policy: Executive Order provisions, sovereign-wealth-fund proposals, Sacks critique, per the strategic review</a:t>
             </a:r>
             <a:endParaRPr lang="en-US" sz="720" dirty="0"/>
           </a:p>
@@ -7689,7 +8119,7 @@
                 <a:ea typeface="Arial" pitchFamily="34" charset="-122"/>
                 <a:cs typeface="Arial" pitchFamily="34" charset="-120"/>
               </a:rPr>
-              <a:t>Frontier watch: embodiment, orbital compute, robotaxis, AI biology — speculative</a:t>
+              <a:t>Frontier watch: embodiment, orbital compute, robotaxis, AI biology; speculative</a:t>
             </a:r>
             <a:endParaRPr lang="en-US" sz="720" dirty="0"/>
           </a:p>
@@ -7728,7 +8158,7 @@
                 <a:ea typeface="Arial" pitchFamily="34" charset="-122"/>
                 <a:cs typeface="Arial" pitchFamily="34" charset="-120"/>
               </a:rPr>
-              <a:t>Methodology: figures verified against at least one primary or institutional source; where sources disagreed, the more conservative figure was used. The Jevons chart (slide 4) is illustrative, not measured data. Layoff attributions to AI are self-reported by employers (Challenger) and may overstate causation. Frontier items (slide 12) are speculative and appear in no company guidance. Image placeholders are labeled in situ and pending final art. End of deck.</a:t>
+              <a:t>Methodology: figures verified against at least one primary or institutional source; where sources disagreed, the more conservative figure was used. The Jevons chart (slide 4) is illustrative, not measured data. Layoff attributions to AI are self-reported by employers (Challenger) and may overstate causation. Frontier items (slide 12) are speculative and appear in no company guidance. End of deck.</a:t>
             </a:r>
             <a:endParaRPr lang="en-US" sz="750" dirty="0"/>
           </a:p>
@@ -7959,7 +8389,7 @@
                 <a:ea typeface="Arial" pitchFamily="34" charset="-122"/>
                 <a:cs typeface="Arial" pitchFamily="34" charset="-120"/>
               </a:rPr>
-              <a:t>Capability, economics, and policy are moving at once. First what’s changing (slides 3–6) — then how markets are repricing it (slides 7–12).</a:t>
+              <a:t>Capability, economics, and policy are moving at once. First what’s changing (slides 3–6), then how markets are repricing it (slides 7–12).</a:t>
             </a:r>
             <a:endParaRPr lang="en-US" sz="1250" dirty="0"/>
           </a:p>
@@ -8222,7 +8652,7 @@
                 <a:ea typeface="Arial" pitchFamily="34" charset="-122"/>
                 <a:cs typeface="Arial" pitchFamily="34" charset="-120"/>
               </a:rPr>
-              <a:t>Anthropic run rate, 2026 — was $3B in 2025. Agentic capability, monetized at scale.</a:t>
+              <a:t>Anthropic run rate, 2026; was $3B in 2025. Agentic capability, monetized at scale.</a:t>
             </a:r>
             <a:endParaRPr lang="en-US" sz="750" dirty="0"/>
           </a:p>
@@ -8485,7 +8915,7 @@
                 <a:ea typeface="Arial" pitchFamily="34" charset="-122"/>
                 <a:cs typeface="Arial" pitchFamily="34" charset="-120"/>
               </a:rPr>
-              <a:t>What Google pays SpaceX to rent 110k GPUs — the market-clearing price of scarcity.</a:t>
+              <a:t>What Google pays SpaceX to rent 110k GPUs: the market-clearing price of scarcity.</a:t>
             </a:r>
             <a:endParaRPr lang="en-US" sz="750" dirty="0"/>
           </a:p>
@@ -8670,7 +9100,7 @@
                 <a:ea typeface="Arial" pitchFamily="34" charset="-122"/>
                 <a:cs typeface="Arial" pitchFamily="34" charset="-120"/>
               </a:rPr>
-              <a:t>Equity-tax proposals and pre-release reviews mean foundation models are now treated as sovereign assets — too important to leave private.</a:t>
+              <a:t>Equity-tax proposals and pre-release reviews mean foundation models are now treated as sovereign assets: too important to leave private.</a:t>
             </a:r>
             <a:endParaRPr lang="en-US" sz="900" dirty="0"/>
           </a:p>
@@ -8827,7 +9257,7 @@
                 <a:ea typeface="Arial" pitchFamily="34" charset="-122"/>
                 <a:cs typeface="Arial" pitchFamily="34" charset="-120"/>
               </a:rPr>
-              <a:t>The chatbot’s economics are exhausted. The stack is reorganizing around token-burning agentic loops — and markets are repricing around it.</a:t>
+              <a:t>The chatbot’s economics are exhausted. The stack is reorganizing around token-burning agentic loops, and markets are repricing around it.</a:t>
             </a:r>
             <a:endParaRPr lang="en-US" sz="1100" dirty="0"/>
           </a:p>
@@ -9039,7 +9469,7 @@
                 <a:ea typeface="Arial" pitchFamily="34" charset="-122"/>
                 <a:cs typeface="Arial" pitchFamily="34" charset="-120"/>
               </a:rPr>
-              <a:t>01  ·  WHAT’S HAPPENING  —  DIAGNOSTIC MATRIX</a:t>
+              <a:t>01  ·  WHAT’S HAPPENING  ·  DIAGNOSTIC MATRIX</a:t>
             </a:r>
             <a:endParaRPr lang="en-US" sz="900" dirty="0"/>
           </a:p>
@@ -9117,7 +9547,7 @@
                 <a:ea typeface="Arial" pitchFamily="34" charset="-122"/>
                 <a:cs typeface="Arial" pitchFamily="34" charset="-120"/>
               </a:rPr>
-              <a:t>Four dimensions where the shift from assisted to agentic shows up — each reprices differently.</a:t>
+              <a:t>Four dimensions where the shift from assisted to agentic shows up; each reprices differently.</a:t>
             </a:r>
             <a:endParaRPr lang="en-US" sz="1250" dirty="0"/>
           </a:p>
@@ -10315,7 +10745,7 @@
                 <a:ea typeface="Arial" pitchFamily="34" charset="-122"/>
                 <a:cs typeface="Arial" pitchFamily="34" charset="-120"/>
               </a:rPr>
-              <a:t>01  ·  WHAT’S HAPPENING  —  AGENTIC LOOPS</a:t>
+              <a:t>01  ·  WHAT’S HAPPENING  ·  AGENTIC LOOPS</a:t>
             </a:r>
             <a:endParaRPr lang="en-US" sz="900" dirty="0"/>
           </a:p>
@@ -10354,7 +10784,7 @@
                 <a:ea typeface="Arial Black" pitchFamily="34" charset="-122"/>
                 <a:cs typeface="Arial Black" pitchFamily="34" charset="-120"/>
               </a:rPr>
-              <a:t>From prompts to loops — demand has no ceiling</a:t>
+              <a:t>From prompts to loops: demand has no ceiling</a:t>
             </a:r>
             <a:endParaRPr lang="en-US" sz="2400" dirty="0"/>
           </a:p>
@@ -10393,7 +10823,7 @@
                 <a:ea typeface="Arial" pitchFamily="34" charset="-122"/>
                 <a:cs typeface="Arial" pitchFamily="34" charset="-120"/>
               </a:rPr>
-              <a:t>Agents try, fail, fix, and ship on their own. A loop burns orders of magnitude more tokens than a chat — and the Jevons curve does the rest.</a:t>
+              <a:t>Agents try, fail, fix, and ship on their own. A loop burns orders of magnitude more tokens than a chat, and the Jevons curve does the rest.</a:t>
             </a:r>
             <a:endParaRPr lang="en-US" sz="1250" dirty="0"/>
           </a:p>
@@ -11159,7 +11589,7 @@
                 <a:ea typeface="Arial" pitchFamily="34" charset="-122"/>
                 <a:cs typeface="Arial" pitchFamily="34" charset="-120"/>
               </a:rPr>
-              <a:t>Boris Cherny — the agentic workflow in one sentence</a:t>
+              <a:t>Boris Cherny, the agentic workflow in one sentence</a:t>
             </a:r>
             <a:endParaRPr lang="en-US" sz="700" dirty="0"/>
           </a:p>
@@ -11590,7 +12020,7 @@
                 <a:ea typeface="Arial" pitchFamily="34" charset="-122"/>
                 <a:cs typeface="Arial" pitchFamily="34" charset="-120"/>
               </a:rPr>
-              <a:t>Source: Internal strategic review, “The 2026 AI Frontier” (Jun 2026) — Cherny/Steinberger loops framing, Karpathy commentary, Codex “disposable software.” Jevons curve illustrative, not measured data.</a:t>
+              <a:t>Source: Internal strategic review, “The 2026 AI Frontier” (Jun 2026). Cherny/Steinberger loops framing, Karpathy commentary, Codex “disposable software.” Jevons curve illustrative, not measured data.</a:t>
             </a:r>
             <a:endParaRPr lang="en-US" sz="700" dirty="0"/>
           </a:p>
@@ -11802,7 +12232,7 @@
                 <a:ea typeface="Arial" pitchFamily="34" charset="-122"/>
                 <a:cs typeface="Arial" pitchFamily="34" charset="-120"/>
               </a:rPr>
-              <a:t>01  ·  WHAT’S HAPPENING  —  TOKEN RATIONING</a:t>
+              <a:t>01  ·  WHAT’S HAPPENING  ·  TOKEN RATIONING</a:t>
             </a:r>
             <a:endParaRPr lang="en-US" sz="900" dirty="0"/>
           </a:p>
@@ -11880,7 +12310,7 @@
                 <a:ea typeface="Arial" pitchFamily="34" charset="-122"/>
                 <a:cs typeface="Arial" pitchFamily="34" charset="-120"/>
               </a:rPr>
-              <a:t>Major firms are abandoning unlimited access and writing token budgets — rationing is what demand looks like when the input is scarce.</a:t>
+              <a:t>Major firms are abandoning unlimited access and writing token budgets; rationing is what demand looks like when the input is scarce.</a:t>
             </a:r>
             <a:endParaRPr lang="en-US" sz="1250" dirty="0"/>
           </a:p>
@@ -12012,7 +12442,7 @@
                 <a:ea typeface="Arial" pitchFamily="34" charset="-122"/>
                 <a:cs typeface="Arial" pitchFamily="34" charset="-120"/>
               </a:rPr>
-              <a:t>A hard $1,500/month token cap per employee replaced unlimited access — “eye-watering” agentic costs became a managed line item, not an experiment.</a:t>
+              <a:t>A hard $1,500/month token cap per employee replaced unlimited access; “eye-watering” agentic costs became a managed line item, not an experiment.</a:t>
             </a:r>
             <a:endParaRPr lang="en-US" sz="1050" dirty="0"/>
           </a:p>
@@ -12144,7 +12574,7 @@
                 <a:ea typeface="Arial" pitchFamily="34" charset="-122"/>
                 <a:cs typeface="Arial" pitchFamily="34" charset="-120"/>
               </a:rPr>
-              <a:t>“Code Puppy,” its agentic dev tool, moved from unlimited tokens to individual budgets plus efficiency training — absorbing the cost of the agentic shift.</a:t>
+              <a:t>“Code Puppy,” its agentic dev tool, moved from unlimited tokens to individual budgets plus efficiency training, absorbing the cost of the agentic shift.</a:t>
             </a:r>
             <a:endParaRPr lang="en-US" sz="1050" dirty="0"/>
           </a:p>
@@ -12262,7 +12692,7 @@
                 <a:ea typeface="Arial" pitchFamily="34" charset="-122"/>
                 <a:cs typeface="Arial" pitchFamily="34" charset="-120"/>
               </a:rPr>
-              <a:t>Scarcity is structural — and priced.  </a:t>
+              <a:t>Scarcity is structural, and priced.  </a:t>
             </a:r>
             <a:pPr indent="0" marL="0">
               <a:buNone/>
@@ -12297,13 +12727,13 @@
             <a:avLst/>
           </a:prstGeom>
           <a:solidFill>
-            <a:srgbClr val="1E1E24"/>
+            <a:srgbClr val="1C1C20"/>
           </a:solidFill>
           <a:ln w="12700">
             <a:solidFill>
               <a:srgbClr val="2A2A30"/>
             </a:solidFill>
-            <a:prstDash val="dash"/>
+            <a:prstDash val="solid"/>
           </a:ln>
         </p:spPr>
       </p:sp>
@@ -12316,7 +12746,7 @@
         <p:spPr>
           <a:xfrm>
             <a:off x="6080760" y="1517904"/>
-            <a:ext cx="274320" cy="32004"/>
+            <a:ext cx="2606040" cy="54864"/>
           </a:xfrm>
           <a:prstGeom prst="rect">
             <a:avLst/>
@@ -12329,14 +12759,448 @@
       </p:sp>
       <p:sp>
         <p:nvSpPr>
-          <p:cNvPr id="20" name="Shape 18"/>
-          <p:cNvSpPr/>
-          <p:nvPr/>
-        </p:nvSpPr>
-        <p:spPr>
-          <a:xfrm>
-            <a:off x="6080760" y="1517904"/>
-            <a:ext cx="32004" cy="274320"/>
+          <p:cNvPr id="20" name="Text 18"/>
+          <p:cNvSpPr/>
+          <p:nvPr/>
+        </p:nvSpPr>
+        <p:spPr>
+          <a:xfrm>
+            <a:off x="6245352" y="1664208"/>
+            <a:ext cx="2276856" cy="164592"/>
+          </a:xfrm>
+          <a:prstGeom prst="rect">
+            <a:avLst/>
+          </a:prstGeom>
+          <a:noFill/>
+          <a:ln/>
+        </p:spPr>
+        <p:txBody>
+          <a:bodyPr wrap="square" lIns="0" tIns="0" rIns="0" bIns="0" rtlCol="0" anchor="ctr"/>
+          <a:lstStyle/>
+          <a:p>
+            <a:pPr indent="0" marL="0">
+              <a:buNone/>
+            </a:pPr>
+            <a:r>
+              <a:rPr lang="en-US" sz="720" b="1" spc="200" kern="0" dirty="0">
+                <a:solidFill>
+                  <a:srgbClr val="FFB800"/>
+                </a:solidFill>
+                <a:latin typeface="Arial" pitchFamily="34" charset="0"/>
+                <a:ea typeface="Arial" pitchFamily="34" charset="-122"/>
+                <a:cs typeface="Arial" pitchFamily="34" charset="-120"/>
+              </a:rPr>
+              <a:t>TOKEN BUDGET METER</a:t>
+            </a:r>
+            <a:endParaRPr lang="en-US" sz="720" dirty="0"/>
+          </a:p>
+        </p:txBody>
+      </p:sp>
+      <p:sp>
+        <p:nvSpPr>
+          <p:cNvPr id="21" name="Shape 19"/>
+          <p:cNvSpPr/>
+          <p:nvPr/>
+        </p:nvSpPr>
+        <p:spPr>
+          <a:xfrm>
+            <a:off x="6281928" y="1975104"/>
+            <a:ext cx="256032" cy="320040"/>
+          </a:xfrm>
+          <a:prstGeom prst="rect">
+            <a:avLst/>
+          </a:prstGeom>
+          <a:solidFill>
+            <a:srgbClr val="000000"/>
+          </a:solidFill>
+          <a:ln w="9525">
+            <a:solidFill>
+              <a:srgbClr val="2A2A30"/>
+            </a:solidFill>
+            <a:prstDash val="solid"/>
+          </a:ln>
+        </p:spPr>
+      </p:sp>
+      <p:sp>
+        <p:nvSpPr>
+          <p:cNvPr id="22" name="Text 20"/>
+          <p:cNvSpPr/>
+          <p:nvPr/>
+        </p:nvSpPr>
+        <p:spPr>
+          <a:xfrm>
+            <a:off x="6281928" y="2039112"/>
+            <a:ext cx="256032" cy="146304"/>
+          </a:xfrm>
+          <a:prstGeom prst="rect">
+            <a:avLst/>
+          </a:prstGeom>
+          <a:noFill/>
+          <a:ln/>
+        </p:spPr>
+        <p:txBody>
+          <a:bodyPr wrap="square" lIns="0" tIns="0" rIns="0" bIns="0" rtlCol="0" anchor="ctr"/>
+          <a:lstStyle/>
+          <a:p>
+            <a:pPr algn="ctr" indent="0" marL="0">
+              <a:buNone/>
+            </a:pPr>
+            <a:r>
+              <a:rPr lang="en-US" sz="1000" b="1" dirty="0">
+                <a:solidFill>
+                  <a:srgbClr val="FFFFFF"/>
+                </a:solidFill>
+                <a:latin typeface="Arial Black" pitchFamily="34" charset="0"/>
+                <a:ea typeface="Arial Black" pitchFamily="34" charset="-122"/>
+                <a:cs typeface="Arial Black" pitchFamily="34" charset="-120"/>
+              </a:rPr>
+              <a:t>1</a:t>
+            </a:r>
+            <a:endParaRPr lang="en-US" sz="1000" dirty="0"/>
+          </a:p>
+        </p:txBody>
+      </p:sp>
+      <p:sp>
+        <p:nvSpPr>
+          <p:cNvPr id="23" name="Shape 21"/>
+          <p:cNvSpPr/>
+          <p:nvPr/>
+        </p:nvSpPr>
+        <p:spPr>
+          <a:xfrm>
+            <a:off x="6592824" y="1975104"/>
+            <a:ext cx="256032" cy="320040"/>
+          </a:xfrm>
+          <a:prstGeom prst="rect">
+            <a:avLst/>
+          </a:prstGeom>
+          <a:solidFill>
+            <a:srgbClr val="000000"/>
+          </a:solidFill>
+          <a:ln w="9525">
+            <a:solidFill>
+              <a:srgbClr val="2A2A30"/>
+            </a:solidFill>
+            <a:prstDash val="solid"/>
+          </a:ln>
+        </p:spPr>
+      </p:sp>
+      <p:sp>
+        <p:nvSpPr>
+          <p:cNvPr id="24" name="Text 22"/>
+          <p:cNvSpPr/>
+          <p:nvPr/>
+        </p:nvSpPr>
+        <p:spPr>
+          <a:xfrm>
+            <a:off x="6592824" y="2039112"/>
+            <a:ext cx="256032" cy="146304"/>
+          </a:xfrm>
+          <a:prstGeom prst="rect">
+            <a:avLst/>
+          </a:prstGeom>
+          <a:noFill/>
+          <a:ln/>
+        </p:spPr>
+        <p:txBody>
+          <a:bodyPr wrap="square" lIns="0" tIns="0" rIns="0" bIns="0" rtlCol="0" anchor="ctr"/>
+          <a:lstStyle/>
+          <a:p>
+            <a:pPr algn="ctr" indent="0" marL="0">
+              <a:buNone/>
+            </a:pPr>
+            <a:r>
+              <a:rPr lang="en-US" sz="1000" b="1" dirty="0">
+                <a:solidFill>
+                  <a:srgbClr val="FFFFFF"/>
+                </a:solidFill>
+                <a:latin typeface="Arial Black" pitchFamily="34" charset="0"/>
+                <a:ea typeface="Arial Black" pitchFamily="34" charset="-122"/>
+                <a:cs typeface="Arial Black" pitchFamily="34" charset="-120"/>
+              </a:rPr>
+              <a:t>5</a:t>
+            </a:r>
+            <a:endParaRPr lang="en-US" sz="1000" dirty="0"/>
+          </a:p>
+        </p:txBody>
+      </p:sp>
+      <p:sp>
+        <p:nvSpPr>
+          <p:cNvPr id="25" name="Shape 23"/>
+          <p:cNvSpPr/>
+          <p:nvPr/>
+        </p:nvSpPr>
+        <p:spPr>
+          <a:xfrm>
+            <a:off x="6903720" y="1975104"/>
+            <a:ext cx="256032" cy="320040"/>
+          </a:xfrm>
+          <a:prstGeom prst="rect">
+            <a:avLst/>
+          </a:prstGeom>
+          <a:solidFill>
+            <a:srgbClr val="000000"/>
+          </a:solidFill>
+          <a:ln w="9525">
+            <a:solidFill>
+              <a:srgbClr val="2A2A30"/>
+            </a:solidFill>
+            <a:prstDash val="solid"/>
+          </a:ln>
+        </p:spPr>
+      </p:sp>
+      <p:sp>
+        <p:nvSpPr>
+          <p:cNvPr id="26" name="Text 24"/>
+          <p:cNvSpPr/>
+          <p:nvPr/>
+        </p:nvSpPr>
+        <p:spPr>
+          <a:xfrm>
+            <a:off x="6903720" y="2039112"/>
+            <a:ext cx="256032" cy="146304"/>
+          </a:xfrm>
+          <a:prstGeom prst="rect">
+            <a:avLst/>
+          </a:prstGeom>
+          <a:noFill/>
+          <a:ln/>
+        </p:spPr>
+        <p:txBody>
+          <a:bodyPr wrap="square" lIns="0" tIns="0" rIns="0" bIns="0" rtlCol="0" anchor="ctr"/>
+          <a:lstStyle/>
+          <a:p>
+            <a:pPr algn="ctr" indent="0" marL="0">
+              <a:buNone/>
+            </a:pPr>
+            <a:r>
+              <a:rPr lang="en-US" sz="1000" b="1" dirty="0">
+                <a:solidFill>
+                  <a:srgbClr val="FFFFFF"/>
+                </a:solidFill>
+                <a:latin typeface="Arial Black" pitchFamily="34" charset="0"/>
+                <a:ea typeface="Arial Black" pitchFamily="34" charset="-122"/>
+                <a:cs typeface="Arial Black" pitchFamily="34" charset="-120"/>
+              </a:rPr>
+              <a:t>0</a:t>
+            </a:r>
+            <a:endParaRPr lang="en-US" sz="1000" dirty="0"/>
+          </a:p>
+        </p:txBody>
+      </p:sp>
+      <p:sp>
+        <p:nvSpPr>
+          <p:cNvPr id="27" name="Shape 25"/>
+          <p:cNvSpPr/>
+          <p:nvPr/>
+        </p:nvSpPr>
+        <p:spPr>
+          <a:xfrm>
+            <a:off x="7214616" y="1975104"/>
+            <a:ext cx="256032" cy="320040"/>
+          </a:xfrm>
+          <a:prstGeom prst="rect">
+            <a:avLst/>
+          </a:prstGeom>
+          <a:solidFill>
+            <a:srgbClr val="000000"/>
+          </a:solidFill>
+          <a:ln w="9525">
+            <a:solidFill>
+              <a:srgbClr val="2A2A30"/>
+            </a:solidFill>
+            <a:prstDash val="solid"/>
+          </a:ln>
+        </p:spPr>
+      </p:sp>
+      <p:sp>
+        <p:nvSpPr>
+          <p:cNvPr id="28" name="Text 26"/>
+          <p:cNvSpPr/>
+          <p:nvPr/>
+        </p:nvSpPr>
+        <p:spPr>
+          <a:xfrm>
+            <a:off x="7214616" y="2039112"/>
+            <a:ext cx="256032" cy="146304"/>
+          </a:xfrm>
+          <a:prstGeom prst="rect">
+            <a:avLst/>
+          </a:prstGeom>
+          <a:noFill/>
+          <a:ln/>
+        </p:spPr>
+        <p:txBody>
+          <a:bodyPr wrap="square" lIns="0" tIns="0" rIns="0" bIns="0" rtlCol="0" anchor="ctr"/>
+          <a:lstStyle/>
+          <a:p>
+            <a:pPr algn="ctr" indent="0" marL="0">
+              <a:buNone/>
+            </a:pPr>
+            <a:r>
+              <a:rPr lang="en-US" sz="1000" b="1" dirty="0">
+                <a:solidFill>
+                  <a:srgbClr val="FFFFFF"/>
+                </a:solidFill>
+                <a:latin typeface="Arial Black" pitchFamily="34" charset="0"/>
+                <a:ea typeface="Arial Black" pitchFamily="34" charset="-122"/>
+                <a:cs typeface="Arial Black" pitchFamily="34" charset="-120"/>
+              </a:rPr>
+              <a:t>0</a:t>
+            </a:r>
+            <a:endParaRPr lang="en-US" sz="1000" dirty="0"/>
+          </a:p>
+        </p:txBody>
+      </p:sp>
+      <p:sp>
+        <p:nvSpPr>
+          <p:cNvPr id="29" name="Text 27"/>
+          <p:cNvSpPr/>
+          <p:nvPr/>
+        </p:nvSpPr>
+        <p:spPr>
+          <a:xfrm>
+            <a:off x="7616952" y="2048256"/>
+            <a:ext cx="868680" cy="201168"/>
+          </a:xfrm>
+          <a:prstGeom prst="rect">
+            <a:avLst/>
+          </a:prstGeom>
+          <a:noFill/>
+          <a:ln/>
+        </p:spPr>
+        <p:txBody>
+          <a:bodyPr wrap="square" lIns="0" tIns="0" rIns="0" bIns="0" rtlCol="0" anchor="ctr"/>
+          <a:lstStyle/>
+          <a:p>
+            <a:pPr indent="0" marL="0">
+              <a:buNone/>
+            </a:pPr>
+            <a:r>
+              <a:rPr lang="en-US" sz="720" dirty="0">
+                <a:solidFill>
+                  <a:srgbClr val="9A9AA0"/>
+                </a:solidFill>
+                <a:latin typeface="Arial" pitchFamily="34" charset="0"/>
+                <a:ea typeface="Arial" pitchFamily="34" charset="-122"/>
+                <a:cs typeface="Arial" pitchFamily="34" charset="-120"/>
+              </a:rPr>
+              <a:t>$ / employee / month</a:t>
+            </a:r>
+            <a:endParaRPr lang="en-US" sz="720" dirty="0"/>
+          </a:p>
+        </p:txBody>
+      </p:sp>
+      <p:sp>
+        <p:nvSpPr>
+          <p:cNvPr id="30" name="Shape 28"/>
+          <p:cNvSpPr/>
+          <p:nvPr/>
+        </p:nvSpPr>
+        <p:spPr>
+          <a:xfrm>
+            <a:off x="6336792" y="2629814"/>
+            <a:ext cx="219456" cy="149962"/>
+          </a:xfrm>
+          <a:prstGeom prst="rect">
+            <a:avLst/>
+          </a:prstGeom>
+          <a:solidFill>
+            <a:srgbClr val="F6693D"/>
+          </a:solidFill>
+          <a:ln w="12700">
+            <a:solidFill>
+              <a:srgbClr val="F6693D"/>
+            </a:solidFill>
+            <a:prstDash val="solid"/>
+          </a:ln>
+        </p:spPr>
+      </p:sp>
+      <p:sp>
+        <p:nvSpPr>
+          <p:cNvPr id="31" name="Shape 29"/>
+          <p:cNvSpPr/>
+          <p:nvPr/>
+        </p:nvSpPr>
+        <p:spPr>
+          <a:xfrm>
+            <a:off x="6629400" y="2601651"/>
+            <a:ext cx="219456" cy="178125"/>
+          </a:xfrm>
+          <a:prstGeom prst="rect">
+            <a:avLst/>
+          </a:prstGeom>
+          <a:solidFill>
+            <a:srgbClr val="F6693D"/>
+          </a:solidFill>
+          <a:ln w="12700">
+            <a:solidFill>
+              <a:srgbClr val="F6693D"/>
+            </a:solidFill>
+            <a:prstDash val="solid"/>
+          </a:ln>
+        </p:spPr>
+      </p:sp>
+      <p:sp>
+        <p:nvSpPr>
+          <p:cNvPr id="32" name="Shape 30"/>
+          <p:cNvSpPr/>
+          <p:nvPr/>
+        </p:nvSpPr>
+        <p:spPr>
+          <a:xfrm>
+            <a:off x="6922008" y="2569464"/>
+            <a:ext cx="219456" cy="210312"/>
+          </a:xfrm>
+          <a:prstGeom prst="rect">
+            <a:avLst/>
+          </a:prstGeom>
+          <a:solidFill>
+            <a:srgbClr val="F6693D"/>
+          </a:solidFill>
+          <a:ln w="12700">
+            <a:solidFill>
+              <a:srgbClr val="F6693D"/>
+            </a:solidFill>
+            <a:prstDash val="solid"/>
+          </a:ln>
+        </p:spPr>
+      </p:sp>
+      <p:sp>
+        <p:nvSpPr>
+          <p:cNvPr id="33" name="Shape 31"/>
+          <p:cNvSpPr/>
+          <p:nvPr/>
+        </p:nvSpPr>
+        <p:spPr>
+          <a:xfrm>
+            <a:off x="7214616" y="2545324"/>
+            <a:ext cx="219456" cy="234452"/>
+          </a:xfrm>
+          <a:prstGeom prst="rect">
+            <a:avLst/>
+          </a:prstGeom>
+          <a:solidFill>
+            <a:srgbClr val="F6693D"/>
+          </a:solidFill>
+          <a:ln w="12700">
+            <a:solidFill>
+              <a:srgbClr val="F6693D"/>
+            </a:solidFill>
+            <a:prstDash val="solid"/>
+          </a:ln>
+        </p:spPr>
+      </p:sp>
+      <p:sp>
+        <p:nvSpPr>
+          <p:cNvPr id="34" name="Shape 32"/>
+          <p:cNvSpPr/>
+          <p:nvPr/>
+        </p:nvSpPr>
+        <p:spPr>
+          <a:xfrm>
+            <a:off x="7507224" y="2509114"/>
+            <a:ext cx="219456" cy="270662"/>
           </a:xfrm>
           <a:prstGeom prst="rect">
             <a:avLst/>
@@ -12344,19 +13208,24 @@
           <a:solidFill>
             <a:srgbClr val="FFB800"/>
           </a:solidFill>
-          <a:ln/>
-        </p:spPr>
-      </p:sp>
-      <p:sp>
-        <p:nvSpPr>
-          <p:cNvPr id="21" name="Shape 19"/>
-          <p:cNvSpPr/>
-          <p:nvPr/>
-        </p:nvSpPr>
-        <p:spPr>
-          <a:xfrm>
-            <a:off x="8412480" y="2766060"/>
-            <a:ext cx="274320" cy="32004"/>
+          <a:ln w="12700">
+            <a:solidFill>
+              <a:srgbClr val="FFB800"/>
+            </a:solidFill>
+            <a:prstDash val="solid"/>
+          </a:ln>
+        </p:spPr>
+      </p:sp>
+      <p:sp>
+        <p:nvSpPr>
+          <p:cNvPr id="35" name="Shape 33"/>
+          <p:cNvSpPr/>
+          <p:nvPr/>
+        </p:nvSpPr>
+        <p:spPr>
+          <a:xfrm>
+            <a:off x="7799832" y="2468880"/>
+            <a:ext cx="219456" cy="310896"/>
           </a:xfrm>
           <a:prstGeom prst="rect">
             <a:avLst/>
@@ -12364,46 +13233,9 @@
           <a:solidFill>
             <a:srgbClr val="FFB800"/>
           </a:solidFill>
-          <a:ln/>
-        </p:spPr>
-      </p:sp>
-      <p:sp>
-        <p:nvSpPr>
-          <p:cNvPr id="22" name="Shape 20"/>
-          <p:cNvSpPr/>
-          <p:nvPr/>
-        </p:nvSpPr>
-        <p:spPr>
-          <a:xfrm>
-            <a:off x="8654796" y="2523744"/>
-            <a:ext cx="32004" cy="274320"/>
-          </a:xfrm>
-          <a:prstGeom prst="rect">
-            <a:avLst/>
-          </a:prstGeom>
-          <a:solidFill>
-            <a:srgbClr val="FFB800"/>
-          </a:solidFill>
-          <a:ln/>
-        </p:spPr>
-      </p:sp>
-      <p:sp>
-        <p:nvSpPr>
-          <p:cNvPr id="23" name="Shape 21"/>
-          <p:cNvSpPr/>
-          <p:nvPr/>
-        </p:nvSpPr>
-        <p:spPr>
-          <a:xfrm>
-            <a:off x="7063740" y="1719072"/>
-            <a:ext cx="640080" cy="347472"/>
-          </a:xfrm>
-          <a:prstGeom prst="triangle">
-            <a:avLst/>
-          </a:prstGeom>
-          <a:ln w="19050">
+          <a:ln w="12700">
             <a:solidFill>
-              <a:srgbClr val="9A9AA0"/>
+              <a:srgbClr val="FFB800"/>
             </a:solidFill>
             <a:prstDash val="solid"/>
           </a:ln>
@@ -12411,107 +13243,7 @@
       </p:sp>
       <p:sp>
         <p:nvSpPr>
-          <p:cNvPr id="24" name="Shape 22"/>
-          <p:cNvSpPr/>
-          <p:nvPr/>
-        </p:nvSpPr>
-        <p:spPr>
-          <a:xfrm>
-            <a:off x="7511796" y="1591056"/>
-            <a:ext cx="146304" cy="146304"/>
-          </a:xfrm>
-          <a:prstGeom prst="ellipse">
-            <a:avLst/>
-          </a:prstGeom>
-          <a:ln w="19050">
-            <a:solidFill>
-              <a:srgbClr val="9A9AA0"/>
-            </a:solidFill>
-            <a:prstDash val="solid"/>
-          </a:ln>
-        </p:spPr>
-      </p:sp>
-      <p:sp>
-        <p:nvSpPr>
-          <p:cNvPr id="25" name="Text 23"/>
-          <p:cNvSpPr/>
-          <p:nvPr/>
-        </p:nvSpPr>
-        <p:spPr>
-          <a:xfrm>
-            <a:off x="6172200" y="2176272"/>
-            <a:ext cx="2423160" cy="219456"/>
-          </a:xfrm>
-          <a:prstGeom prst="rect">
-            <a:avLst/>
-          </a:prstGeom>
-          <a:noFill/>
-          <a:ln/>
-        </p:spPr>
-        <p:txBody>
-          <a:bodyPr wrap="square" lIns="0" tIns="0" rIns="0" bIns="0" rtlCol="0" anchor="ctr"/>
-          <a:lstStyle/>
-          <a:p>
-            <a:pPr algn="ctr" indent="0" marL="0">
-              <a:buNone/>
-            </a:pPr>
-            <a:r>
-              <a:rPr lang="en-US" sz="800" b="1" spc="200" kern="0" dirty="0">
-                <a:solidFill>
-                  <a:srgbClr val="FFB800"/>
-                </a:solidFill>
-                <a:latin typeface="Arial" pitchFamily="34" charset="0"/>
-                <a:ea typeface="Arial" pitchFamily="34" charset="-122"/>
-                <a:cs typeface="Arial" pitchFamily="34" charset="-120"/>
-              </a:rPr>
-              <a:t>IMAGE — TOKEN METER</a:t>
-            </a:r>
-            <a:endParaRPr lang="en-US" sz="800" dirty="0"/>
-          </a:p>
-        </p:txBody>
-      </p:sp>
-      <p:sp>
-        <p:nvSpPr>
-          <p:cNvPr id="26" name="Text 24"/>
-          <p:cNvSpPr/>
-          <p:nvPr/>
-        </p:nvSpPr>
-        <p:spPr>
-          <a:xfrm>
-            <a:off x="6263640" y="2432304"/>
-            <a:ext cx="2240280" cy="594360"/>
-          </a:xfrm>
-          <a:prstGeom prst="rect">
-            <a:avLst/>
-          </a:prstGeom>
-          <a:noFill/>
-          <a:ln/>
-        </p:spPr>
-        <p:txBody>
-          <a:bodyPr wrap="square" lIns="0" tIns="0" rIns="0" bIns="0" rtlCol="0" anchor="t"/>
-          <a:lstStyle/>
-          <a:p>
-            <a:pPr algn="ctr" indent="0" marL="0">
-              <a:buNone/>
-            </a:pPr>
-            <a:r>
-              <a:rPr lang="en-US" sz="700" i="1" dirty="0">
-                <a:solidFill>
-                  <a:srgbClr val="9A9AA0"/>
-                </a:solidFill>
-                <a:latin typeface="Arial" pitchFamily="34" charset="0"/>
-                <a:ea typeface="Arial" pitchFamily="34" charset="-122"/>
-                <a:cs typeface="Arial" pitchFamily="34" charset="-120"/>
-              </a:rPr>
-              <a:t>Industrial utility meter for the AI era — glowing gold digits, a stream of tokens flowing in, dark brushed metal.</a:t>
-            </a:r>
-            <a:endParaRPr lang="en-US" sz="700" dirty="0"/>
-          </a:p>
-        </p:txBody>
-      </p:sp>
-      <p:sp>
-        <p:nvSpPr>
-          <p:cNvPr id="27" name="Shape 25"/>
+          <p:cNvPr id="36" name="Shape 34"/>
           <p:cNvSpPr/>
           <p:nvPr/>
         </p:nvSpPr>
@@ -12536,7 +13268,7 @@
       </p:sp>
       <p:sp>
         <p:nvSpPr>
-          <p:cNvPr id="28" name="Text 26"/>
+          <p:cNvPr id="37" name="Text 35"/>
           <p:cNvSpPr/>
           <p:nvPr/>
         </p:nvSpPr>
@@ -12575,7 +13307,7 @@
       </p:sp>
       <p:sp>
         <p:nvSpPr>
-          <p:cNvPr id="29" name="Text 27"/>
+          <p:cNvPr id="38" name="Text 36"/>
           <p:cNvSpPr/>
           <p:nvPr/>
         </p:nvSpPr>
@@ -12637,7 +13369,7 @@
       </p:sp>
       <p:sp>
         <p:nvSpPr>
-          <p:cNvPr id="30" name="Text 28"/>
+          <p:cNvPr id="39" name="Text 37"/>
           <p:cNvSpPr/>
           <p:nvPr/>
         </p:nvSpPr>
@@ -12668,7 +13400,7 @@
                 <a:ea typeface="Arial" pitchFamily="34" charset="-122"/>
                 <a:cs typeface="Arial" pitchFamily="34" charset="-120"/>
               </a:rPr>
-              <a:t>Source: Internal strategic review, “The 2026 AI Frontier” (Jun 2026) — Uber and Walmart cost-management cases; SK Hynix HBM outlook; Google/SpaceX GPU rental.</a:t>
+              <a:t>Source: Internal strategic review, “The 2026 AI Frontier” (Jun 2026). Uber and Walmart cost-management cases; SK Hynix HBM outlook; Google/SpaceX GPU rental.</a:t>
             </a:r>
             <a:endParaRPr lang="en-US" sz="700" dirty="0"/>
           </a:p>
@@ -12676,7 +13408,7 @@
       </p:sp>
       <p:sp>
         <p:nvSpPr>
-          <p:cNvPr id="31" name="Shape 29"/>
+          <p:cNvPr id="40" name="Shape 38"/>
           <p:cNvSpPr/>
           <p:nvPr/>
         </p:nvSpPr>
@@ -12696,7 +13428,7 @@
       </p:sp>
       <p:sp>
         <p:nvSpPr>
-          <p:cNvPr id="32" name="Shape 30"/>
+          <p:cNvPr id="41" name="Shape 39"/>
           <p:cNvSpPr/>
           <p:nvPr/>
         </p:nvSpPr>
@@ -12719,7 +13451,7 @@
       </p:sp>
       <p:sp>
         <p:nvSpPr>
-          <p:cNvPr id="33" name="Text 31"/>
+          <p:cNvPr id="42" name="Text 40"/>
           <p:cNvSpPr/>
           <p:nvPr/>
         </p:nvSpPr>
@@ -12758,7 +13490,7 @@
       </p:sp>
       <p:sp>
         <p:nvSpPr>
-          <p:cNvPr id="34" name="Text 32"/>
+          <p:cNvPr id="43" name="Text 41"/>
           <p:cNvSpPr/>
           <p:nvPr/>
         </p:nvSpPr>
@@ -12880,7 +13612,7 @@
                 <a:ea typeface="Arial" pitchFamily="34" charset="-122"/>
                 <a:cs typeface="Arial" pitchFamily="34" charset="-120"/>
               </a:rPr>
-              <a:t>01  ·  WHAT’S HAPPENING  —  POLICY</a:t>
+              <a:t>01  ·  WHAT’S HAPPENING  ·  POLICY</a:t>
             </a:r>
             <a:endParaRPr lang="en-US" sz="900" dirty="0"/>
           </a:p>
@@ -12919,7 +13651,7 @@
                 <a:ea typeface="Arial Black" pitchFamily="34" charset="-122"/>
                 <a:cs typeface="Arial Black" pitchFamily="34" charset="-120"/>
               </a:rPr>
-              <a:t>Washington wants a stake</a:t>
+              <a:t>Governments want a stake</a:t>
             </a:r>
             <a:endParaRPr lang="en-US" sz="2600" dirty="0"/>
           </a:p>
@@ -12958,7 +13690,7 @@
                 <a:ea typeface="Arial" pitchFamily="34" charset="-122"/>
                 <a:cs typeface="Arial" pitchFamily="34" charset="-120"/>
               </a:rPr>
-              <a:t>Trump, Bannon, and Sanders converge on oversight and public participation in the AI upside — ownership, not regulation, is now the debate.</a:t>
+              <a:t>From Washington to Seoul, the debate shifted from regulating AI to owning a piece of it. Markets priced the Korea proposal in hours.</a:t>
             </a:r>
             <a:endParaRPr lang="en-US" sz="1250" dirty="0"/>
           </a:p>
@@ -12966,14 +13698,53 @@
       </p:sp>
       <p:sp>
         <p:nvSpPr>
-          <p:cNvPr id="6" name="Shape 4"/>
-          <p:cNvSpPr/>
-          <p:nvPr/>
-        </p:nvSpPr>
-        <p:spPr>
-          <a:xfrm>
-            <a:off x="457200" y="1463040"/>
-            <a:ext cx="5486400" cy="768096"/>
+          <p:cNvPr id="6" name="Text 4"/>
+          <p:cNvSpPr/>
+          <p:nvPr/>
+        </p:nvSpPr>
+        <p:spPr>
+          <a:xfrm>
+            <a:off x="457200" y="1417320"/>
+            <a:ext cx="4297680" cy="182880"/>
+          </a:xfrm>
+          <a:prstGeom prst="rect">
+            <a:avLst/>
+          </a:prstGeom>
+          <a:noFill/>
+          <a:ln/>
+        </p:spPr>
+        <p:txBody>
+          <a:bodyPr wrap="square" lIns="0" tIns="0" rIns="0" bIns="0" rtlCol="0" anchor="ctr"/>
+          <a:lstStyle/>
+          <a:p>
+            <a:pPr indent="0" marL="0">
+              <a:buNone/>
+            </a:pPr>
+            <a:r>
+              <a:rPr lang="en-US" sz="800" b="1" spc="200" kern="0" dirty="0">
+                <a:solidFill>
+                  <a:srgbClr val="9B7BE0"/>
+                </a:solidFill>
+                <a:latin typeface="Arial" pitchFamily="34" charset="0"/>
+                <a:ea typeface="Arial" pitchFamily="34" charset="-122"/>
+                <a:cs typeface="Arial" pitchFamily="34" charset="-120"/>
+              </a:rPr>
+              <a:t>UNITED STATES</a:t>
+            </a:r>
+            <a:endParaRPr lang="en-US" sz="800" dirty="0"/>
+          </a:p>
+        </p:txBody>
+      </p:sp>
+      <p:sp>
+        <p:nvSpPr>
+          <p:cNvPr id="7" name="Shape 5"/>
+          <p:cNvSpPr/>
+          <p:nvPr/>
+        </p:nvSpPr>
+        <p:spPr>
+          <a:xfrm>
+            <a:off x="457200" y="1664208"/>
+            <a:ext cx="4297680" cy="658368"/>
           </a:xfrm>
           <a:prstGeom prst="rect">
             <a:avLst/>
@@ -12986,14 +13757,14 @@
       </p:sp>
       <p:sp>
         <p:nvSpPr>
-          <p:cNvPr id="7" name="Shape 5"/>
-          <p:cNvSpPr/>
-          <p:nvPr/>
-        </p:nvSpPr>
-        <p:spPr>
-          <a:xfrm>
-            <a:off x="457200" y="1463040"/>
-            <a:ext cx="64008" cy="768096"/>
+          <p:cNvPr id="8" name="Shape 6"/>
+          <p:cNvSpPr/>
+          <p:nvPr/>
+        </p:nvSpPr>
+        <p:spPr>
+          <a:xfrm>
+            <a:off x="457200" y="1664208"/>
+            <a:ext cx="64008" cy="658368"/>
           </a:xfrm>
           <a:prstGeom prst="rect">
             <a:avLst/>
@@ -13006,14 +13777,14 @@
       </p:sp>
       <p:sp>
         <p:nvSpPr>
-          <p:cNvPr id="8" name="Text 6"/>
-          <p:cNvSpPr/>
-          <p:nvPr/>
-        </p:nvSpPr>
-        <p:spPr>
-          <a:xfrm>
-            <a:off x="621792" y="1536192"/>
-            <a:ext cx="5212080" cy="182880"/>
+          <p:cNvPr id="9" name="Text 7"/>
+          <p:cNvSpPr/>
+          <p:nvPr/>
+        </p:nvSpPr>
+        <p:spPr>
+          <a:xfrm>
+            <a:off x="621792" y="1737360"/>
+            <a:ext cx="4023360" cy="182880"/>
           </a:xfrm>
           <a:prstGeom prst="rect">
             <a:avLst/>
@@ -13037,7 +13808,7 @@
                 <a:ea typeface="Arial" pitchFamily="34" charset="-122"/>
                 <a:cs typeface="Arial" pitchFamily="34" charset="-120"/>
               </a:rPr>
-              <a:t>THE EXECUTIVE ORDER</a:t>
+              <a:t>EXECUTIVE ORDER</a:t>
             </a:r>
             <a:endParaRPr lang="en-US" sz="750" dirty="0"/>
           </a:p>
@@ -13045,14 +13816,14 @@
       </p:sp>
       <p:sp>
         <p:nvSpPr>
-          <p:cNvPr id="9" name="Text 7"/>
-          <p:cNvSpPr/>
-          <p:nvPr/>
-        </p:nvSpPr>
-        <p:spPr>
-          <a:xfrm>
-            <a:off x="621792" y="1737360"/>
-            <a:ext cx="5157216" cy="402336"/>
+          <p:cNvPr id="10" name="Text 8"/>
+          <p:cNvSpPr/>
+          <p:nvPr/>
+        </p:nvSpPr>
+        <p:spPr>
+          <a:xfrm>
+            <a:off x="621792" y="1938528"/>
+            <a:ext cx="3968496" cy="292608"/>
           </a:xfrm>
           <a:prstGeom prst="rect">
             <a:avLst/>
@@ -13076,7 +13847,7 @@
                 <a:ea typeface="Arial" pitchFamily="34" charset="-122"/>
                 <a:cs typeface="Arial" pitchFamily="34" charset="-120"/>
               </a:rPr>
-              <a:t>A 30-day federal checkpoint.  </a:t>
+              <a:t>30-day NSA checkpoint.  </a:t>
             </a:r>
             <a:pPr indent="0" marL="0">
               <a:buNone/>
@@ -13090,7 +13861,7 @@
                 <a:ea typeface="Arial" pitchFamily="34" charset="-122"/>
                 <a:cs typeface="Arial" pitchFamily="34" charset="-120"/>
               </a:rPr>
-              <a:t>Voluntary but high-pressure NSA review — 30 days, down from 90 — before releasing models with a “meaningful step change” in cyber capability. Mandatory licensing expressly forbidden — for now.</a:t>
+              <a:t>Voluntary pre-release review before deploying models with a step change in cyber capability. Mandatory licensing expressly forbidden, for now.</a:t>
             </a:r>
             <a:endParaRPr lang="en-US" sz="1050" dirty="0"/>
           </a:p>
@@ -13098,14 +13869,14 @@
       </p:sp>
       <p:sp>
         <p:nvSpPr>
-          <p:cNvPr id="10" name="Shape 8"/>
-          <p:cNvSpPr/>
-          <p:nvPr/>
-        </p:nvSpPr>
-        <p:spPr>
-          <a:xfrm>
-            <a:off x="457200" y="2304288"/>
-            <a:ext cx="5486400" cy="768096"/>
+          <p:cNvPr id="11" name="Shape 9"/>
+          <p:cNvSpPr/>
+          <p:nvPr/>
+        </p:nvSpPr>
+        <p:spPr>
+          <a:xfrm>
+            <a:off x="457200" y="2377440"/>
+            <a:ext cx="4297680" cy="658368"/>
           </a:xfrm>
           <a:prstGeom prst="rect">
             <a:avLst/>
@@ -13118,14 +13889,14 @@
       </p:sp>
       <p:sp>
         <p:nvSpPr>
-          <p:cNvPr id="11" name="Shape 9"/>
-          <p:cNvSpPr/>
-          <p:nvPr/>
-        </p:nvSpPr>
-        <p:spPr>
-          <a:xfrm>
-            <a:off x="457200" y="2304288"/>
-            <a:ext cx="64008" cy="768096"/>
+          <p:cNvPr id="12" name="Shape 10"/>
+          <p:cNvSpPr/>
+          <p:nvPr/>
+        </p:nvSpPr>
+        <p:spPr>
+          <a:xfrm>
+            <a:off x="457200" y="2377440"/>
+            <a:ext cx="64008" cy="658368"/>
           </a:xfrm>
           <a:prstGeom prst="rect">
             <a:avLst/>
@@ -13138,14 +13909,14 @@
       </p:sp>
       <p:sp>
         <p:nvSpPr>
-          <p:cNvPr id="12" name="Text 10"/>
-          <p:cNvSpPr/>
-          <p:nvPr/>
-        </p:nvSpPr>
-        <p:spPr>
-          <a:xfrm>
-            <a:off x="621792" y="2377440"/>
-            <a:ext cx="5212080" cy="182880"/>
+          <p:cNvPr id="13" name="Text 11"/>
+          <p:cNvSpPr/>
+          <p:nvPr/>
+        </p:nvSpPr>
+        <p:spPr>
+          <a:xfrm>
+            <a:off x="621792" y="2450592"/>
+            <a:ext cx="4023360" cy="182880"/>
           </a:xfrm>
           <a:prstGeom prst="rect">
             <a:avLst/>
@@ -13169,7 +13940,7 @@
                 <a:ea typeface="Arial" pitchFamily="34" charset="-122"/>
                 <a:cs typeface="Arial" pitchFamily="34" charset="-120"/>
               </a:rPr>
-              <a:t>THE SOVEREIGN WEALTH FUND</a:t>
+              <a:t>SOVEREIGN WEALTH FUND</a:t>
             </a:r>
             <a:endParaRPr lang="en-US" sz="750" dirty="0"/>
           </a:p>
@@ -13177,14 +13948,14 @@
       </p:sp>
       <p:sp>
         <p:nvSpPr>
-          <p:cNvPr id="13" name="Text 11"/>
-          <p:cNvSpPr/>
-          <p:nvPr/>
-        </p:nvSpPr>
-        <p:spPr>
-          <a:xfrm>
-            <a:off x="621792" y="2578608"/>
-            <a:ext cx="5157216" cy="402336"/>
+          <p:cNvPr id="14" name="Text 12"/>
+          <p:cNvSpPr/>
+          <p:nvPr/>
+        </p:nvSpPr>
+        <p:spPr>
+          <a:xfrm>
+            <a:off x="621792" y="2651760"/>
+            <a:ext cx="3968496" cy="292608"/>
           </a:xfrm>
           <a:prstGeom prst="rect">
             <a:avLst/>
@@ -13208,7 +13979,7 @@
                 <a:ea typeface="Arial" pitchFamily="34" charset="-122"/>
                 <a:cs typeface="Arial" pitchFamily="34" charset="-120"/>
               </a:rPr>
-              <a:t>A 50% claim on lab equity.  </a:t>
+              <a:t>50% claim on lab equity.  </a:t>
             </a:r>
             <a:pPr indent="0" marL="0">
               <a:buNone/>
@@ -13222,7 +13993,7 @@
                 <a:ea typeface="Arial" pitchFamily="34" charset="-122"/>
                 <a:cs typeface="Arial" pitchFamily="34" charset="-120"/>
               </a:rPr>
-              <a:t>Sanders’ proposal, echoed by Trump as “a concept of a plan”: a one-time 50% tax on AI-lab equity (not profits) seeds a public fund paying “AI Dividends” to citizens.</a:t>
+              <a:t>Sanders proposed, Trump echoed: a one-time 50% tax on AI-lab equity to seed a public fund paying "AI Dividends" to citizens.</a:t>
             </a:r>
             <a:endParaRPr lang="en-US" sz="1050" dirty="0"/>
           </a:p>
@@ -13230,14 +14001,14 @@
       </p:sp>
       <p:sp>
         <p:nvSpPr>
-          <p:cNvPr id="14" name="Shape 12"/>
-          <p:cNvSpPr/>
-          <p:nvPr/>
-        </p:nvSpPr>
-        <p:spPr>
-          <a:xfrm>
-            <a:off x="457200" y="3145536"/>
-            <a:ext cx="5486400" cy="768096"/>
+          <p:cNvPr id="15" name="Shape 13"/>
+          <p:cNvSpPr/>
+          <p:nvPr/>
+        </p:nvSpPr>
+        <p:spPr>
+          <a:xfrm>
+            <a:off x="457200" y="3090672"/>
+            <a:ext cx="4297680" cy="658368"/>
           </a:xfrm>
           <a:prstGeom prst="rect">
             <a:avLst/>
@@ -13250,14 +14021,14 @@
       </p:sp>
       <p:sp>
         <p:nvSpPr>
-          <p:cNvPr id="15" name="Shape 13"/>
-          <p:cNvSpPr/>
-          <p:nvPr/>
-        </p:nvSpPr>
-        <p:spPr>
-          <a:xfrm>
-            <a:off x="457200" y="3145536"/>
-            <a:ext cx="64008" cy="768096"/>
+          <p:cNvPr id="16" name="Shape 14"/>
+          <p:cNvSpPr/>
+          <p:nvPr/>
+        </p:nvSpPr>
+        <p:spPr>
+          <a:xfrm>
+            <a:off x="457200" y="3090672"/>
+            <a:ext cx="64008" cy="658368"/>
           </a:xfrm>
           <a:prstGeom prst="rect">
             <a:avLst/>
@@ -13270,14 +14041,14 @@
       </p:sp>
       <p:sp>
         <p:nvSpPr>
-          <p:cNvPr id="16" name="Text 14"/>
-          <p:cNvSpPr/>
-          <p:nvPr/>
-        </p:nvSpPr>
-        <p:spPr>
-          <a:xfrm>
-            <a:off x="621792" y="3218688"/>
-            <a:ext cx="5212080" cy="182880"/>
+          <p:cNvPr id="17" name="Text 15"/>
+          <p:cNvSpPr/>
+          <p:nvPr/>
+        </p:nvSpPr>
+        <p:spPr>
+          <a:xfrm>
+            <a:off x="621792" y="3163824"/>
+            <a:ext cx="4023360" cy="182880"/>
           </a:xfrm>
           <a:prstGeom prst="rect">
             <a:avLst/>
@@ -13309,14 +14080,14 @@
       </p:sp>
       <p:sp>
         <p:nvSpPr>
-          <p:cNvPr id="17" name="Text 15"/>
-          <p:cNvSpPr/>
-          <p:nvPr/>
-        </p:nvSpPr>
-        <p:spPr>
-          <a:xfrm>
-            <a:off x="621792" y="3419856"/>
-            <a:ext cx="5157216" cy="402336"/>
+          <p:cNvPr id="18" name="Text 16"/>
+          <p:cNvSpPr/>
+          <p:nvPr/>
+        </p:nvSpPr>
+        <p:spPr>
+          <a:xfrm>
+            <a:off x="621792" y="3364992"/>
+            <a:ext cx="3968496" cy="292608"/>
           </a:xfrm>
           <a:prstGeom prst="rect">
             <a:avLst/>
@@ -13340,7 +14111,7 @@
                 <a:ea typeface="Arial" pitchFamily="34" charset="-122"/>
                 <a:cs typeface="Arial" pitchFamily="34" charset="-120"/>
               </a:rPr>
-              <a:t>“Corporate-government fusion.”  </a:t>
+              <a:t>"Corporate-government fusion."  </a:t>
             </a:r>
             <a:pPr indent="0" marL="0">
               <a:buNone/>
@@ -13354,7 +14125,7 @@
                 <a:ea typeface="Arial" pitchFamily="34" charset="-122"/>
                 <a:cs typeface="Arial" pitchFamily="34" charset="-120"/>
               </a:rPr>
-              <a:t>Sacks: government equity risks a CCP-style social-credit state — and nationalization talk is a “stupidity tax” on the job-apocalypse narrative the labs themselves stoked.</a:t>
+              <a:t>Sacks: government equity risks a social-credit state. Nationalization talk is a "stupidity tax" on the job-apocalypse narrative.</a:t>
             </a:r>
             <a:endParaRPr lang="en-US" sz="1050" dirty="0"/>
           </a:p>
@@ -13362,163 +14133,303 @@
       </p:sp>
       <p:sp>
         <p:nvSpPr>
-          <p:cNvPr id="18" name="Shape 16"/>
-          <p:cNvSpPr/>
-          <p:nvPr/>
-        </p:nvSpPr>
-        <p:spPr>
-          <a:xfrm>
-            <a:off x="6080760" y="1463040"/>
-            <a:ext cx="2606040" cy="2377440"/>
+          <p:cNvPr id="19" name="Text 17"/>
+          <p:cNvSpPr/>
+          <p:nvPr/>
+        </p:nvSpPr>
+        <p:spPr>
+          <a:xfrm>
+            <a:off x="4892040" y="1417320"/>
+            <a:ext cx="3794760" cy="182880"/>
+          </a:xfrm>
+          <a:prstGeom prst="rect">
+            <a:avLst/>
+          </a:prstGeom>
+          <a:noFill/>
+          <a:ln/>
+        </p:spPr>
+        <p:txBody>
+          <a:bodyPr wrap="square" lIns="0" tIns="0" rIns="0" bIns="0" rtlCol="0" anchor="ctr"/>
+          <a:lstStyle/>
+          <a:p>
+            <a:pPr indent="0" marL="0">
+              <a:buNone/>
+            </a:pPr>
+            <a:r>
+              <a:rPr lang="en-US" sz="800" b="1" spc="200" kern="0" dirty="0">
+                <a:solidFill>
+                  <a:srgbClr val="2BC4C4"/>
+                </a:solidFill>
+                <a:latin typeface="Arial" pitchFamily="34" charset="0"/>
+                <a:ea typeface="Arial" pitchFamily="34" charset="-122"/>
+                <a:cs typeface="Arial" pitchFamily="34" charset="-120"/>
+              </a:rPr>
+              <a:t>SOUTH KOREA</a:t>
+            </a:r>
+            <a:endParaRPr lang="en-US" sz="800" dirty="0"/>
+          </a:p>
+        </p:txBody>
+      </p:sp>
+      <p:sp>
+        <p:nvSpPr>
+          <p:cNvPr id="20" name="Text 18"/>
+          <p:cNvSpPr/>
+          <p:nvPr/>
+        </p:nvSpPr>
+        <p:spPr>
+          <a:xfrm>
+            <a:off x="4892040" y="1664208"/>
+            <a:ext cx="3794760" cy="384048"/>
+          </a:xfrm>
+          <a:prstGeom prst="rect">
+            <a:avLst/>
+          </a:prstGeom>
+          <a:noFill/>
+          <a:ln/>
+        </p:spPr>
+        <p:txBody>
+          <a:bodyPr wrap="square" lIns="0" tIns="0" rIns="0" bIns="0" rtlCol="0" anchor="ctr"/>
+          <a:lstStyle/>
+          <a:p>
+            <a:pPr indent="0" marL="0">
+              <a:buNone/>
+            </a:pPr>
+            <a:r>
+              <a:rPr lang="en-US" sz="2000" b="1" dirty="0">
+                <a:solidFill>
+                  <a:srgbClr val="E5484D"/>
+                </a:solidFill>
+                <a:latin typeface="Arial Black" pitchFamily="34" charset="0"/>
+                <a:ea typeface="Arial Black" pitchFamily="34" charset="-122"/>
+                <a:cs typeface="Arial Black" pitchFamily="34" charset="-120"/>
+              </a:rPr>
+              <a:t>KOSPI -5.1%</a:t>
+            </a:r>
+            <a:endParaRPr lang="en-US" sz="2000" dirty="0"/>
+          </a:p>
+        </p:txBody>
+      </p:sp>
+      <p:sp>
+        <p:nvSpPr>
+          <p:cNvPr id="21" name="Text 19"/>
+          <p:cNvSpPr/>
+          <p:nvPr/>
+        </p:nvSpPr>
+        <p:spPr>
+          <a:xfrm>
+            <a:off x="4892040" y="2066544"/>
+            <a:ext cx="3794760" cy="438912"/>
+          </a:xfrm>
+          <a:prstGeom prst="rect">
+            <a:avLst/>
+          </a:prstGeom>
+          <a:noFill/>
+          <a:ln/>
+        </p:spPr>
+        <p:txBody>
+          <a:bodyPr wrap="square" lIns="0" tIns="0" rIns="0" bIns="0" rtlCol="0" anchor="t"/>
+          <a:lstStyle/>
+          <a:p>
+            <a:pPr indent="0" marL="0">
+              <a:buNone/>
+            </a:pPr>
+            <a:r>
+              <a:rPr lang="en-US" sz="750" dirty="0">
+                <a:solidFill>
+                  <a:srgbClr val="9A9AA0"/>
+                </a:solidFill>
+                <a:latin typeface="Arial" pitchFamily="34" charset="0"/>
+                <a:ea typeface="Arial" pitchFamily="34" charset="-122"/>
+                <a:cs typeface="Arial" pitchFamily="34" charset="-120"/>
+              </a:rPr>
+              <a:t>Intraday drop on May 12 after the "citizen dividend" post. The market priced the proposal in hours.</a:t>
+            </a:r>
+            <a:endParaRPr lang="en-US" sz="750" dirty="0"/>
+          </a:p>
+        </p:txBody>
+      </p:sp>
+      <p:sp>
+        <p:nvSpPr>
+          <p:cNvPr id="22" name="Shape 20"/>
+          <p:cNvSpPr/>
+          <p:nvPr/>
+        </p:nvSpPr>
+        <p:spPr>
+          <a:xfrm>
+            <a:off x="4892040" y="2514600"/>
+            <a:ext cx="3794760" cy="841248"/>
           </a:xfrm>
           <a:prstGeom prst="rect">
             <a:avLst/>
           </a:prstGeom>
           <a:solidFill>
-            <a:srgbClr val="1E1E24"/>
+            <a:srgbClr val="1C1C20"/>
           </a:solidFill>
-          <a:ln w="12700">
-            <a:solidFill>
-              <a:srgbClr val="2A2A30"/>
-            </a:solidFill>
-            <a:prstDash val="dash"/>
-          </a:ln>
-        </p:spPr>
-      </p:sp>
-      <p:sp>
-        <p:nvSpPr>
-          <p:cNvPr id="19" name="Shape 17"/>
-          <p:cNvSpPr/>
-          <p:nvPr/>
-        </p:nvSpPr>
-        <p:spPr>
-          <a:xfrm>
-            <a:off x="6080760" y="1463040"/>
-            <a:ext cx="274320" cy="32004"/>
+          <a:ln/>
+        </p:spPr>
+      </p:sp>
+      <p:sp>
+        <p:nvSpPr>
+          <p:cNvPr id="23" name="Shape 21"/>
+          <p:cNvSpPr/>
+          <p:nvPr/>
+        </p:nvSpPr>
+        <p:spPr>
+          <a:xfrm>
+            <a:off x="4892040" y="2514600"/>
+            <a:ext cx="64008" cy="841248"/>
           </a:xfrm>
           <a:prstGeom prst="rect">
             <a:avLst/>
           </a:prstGeom>
           <a:solidFill>
-            <a:srgbClr val="9B7BE0"/>
+            <a:srgbClr val="2BC4C4"/>
           </a:solidFill>
           <a:ln/>
         </p:spPr>
       </p:sp>
       <p:sp>
         <p:nvSpPr>
-          <p:cNvPr id="20" name="Shape 18"/>
-          <p:cNvSpPr/>
-          <p:nvPr/>
-        </p:nvSpPr>
-        <p:spPr>
-          <a:xfrm>
-            <a:off x="6080760" y="1463040"/>
-            <a:ext cx="32004" cy="274320"/>
+          <p:cNvPr id="24" name="Text 22"/>
+          <p:cNvSpPr/>
+          <p:nvPr/>
+        </p:nvSpPr>
+        <p:spPr>
+          <a:xfrm>
+            <a:off x="5056632" y="2587752"/>
+            <a:ext cx="3520440" cy="182880"/>
+          </a:xfrm>
+          <a:prstGeom prst="rect">
+            <a:avLst/>
+          </a:prstGeom>
+          <a:noFill/>
+          <a:ln/>
+        </p:spPr>
+        <p:txBody>
+          <a:bodyPr wrap="square" lIns="0" tIns="0" rIns="0" bIns="0" rtlCol="0" anchor="ctr"/>
+          <a:lstStyle/>
+          <a:p>
+            <a:pPr indent="0" marL="0">
+              <a:buNone/>
+            </a:pPr>
+            <a:r>
+              <a:rPr lang="en-US" sz="750" b="1" spc="200" kern="0" dirty="0">
+                <a:solidFill>
+                  <a:srgbClr val="2BC4C4"/>
+                </a:solidFill>
+                <a:latin typeface="Arial" pitchFamily="34" charset="0"/>
+                <a:ea typeface="Arial" pitchFamily="34" charset="-122"/>
+                <a:cs typeface="Arial" pitchFamily="34" charset="-120"/>
+              </a:rPr>
+              <a:t>CITIZEN DIVIDEND</a:t>
+            </a:r>
+            <a:endParaRPr lang="en-US" sz="750" dirty="0"/>
+          </a:p>
+        </p:txBody>
+      </p:sp>
+      <p:sp>
+        <p:nvSpPr>
+          <p:cNvPr id="25" name="Text 23"/>
+          <p:cNvSpPr/>
+          <p:nvPr/>
+        </p:nvSpPr>
+        <p:spPr>
+          <a:xfrm>
+            <a:off x="5056632" y="2788920"/>
+            <a:ext cx="3465576" cy="475488"/>
+          </a:xfrm>
+          <a:prstGeom prst="rect">
+            <a:avLst/>
+          </a:prstGeom>
+          <a:noFill/>
+          <a:ln/>
+        </p:spPr>
+        <p:txBody>
+          <a:bodyPr wrap="square" lIns="0" tIns="0" rIns="0" bIns="0" rtlCol="0" anchor="t"/>
+          <a:lstStyle/>
+          <a:p>
+            <a:pPr indent="0" marL="0">
+              <a:buNone/>
+            </a:pPr>
+            <a:r>
+              <a:rPr lang="en-US" sz="1050" b="1" dirty="0">
+                <a:solidFill>
+                  <a:srgbClr val="FFFFFF"/>
+                </a:solidFill>
+                <a:latin typeface="Arial" pitchFamily="34" charset="0"/>
+                <a:ea typeface="Arial" pitchFamily="34" charset="-122"/>
+                <a:cs typeface="Arial" pitchFamily="34" charset="-120"/>
+              </a:rPr>
+              <a:t>Kim Yong-beom floated an AI tax windfall.  </a:t>
+            </a:r>
+            <a:pPr indent="0" marL="0">
+              <a:buNone/>
+            </a:pPr>
+            <a:r>
+              <a:rPr lang="en-US" sz="900" dirty="0">
+                <a:solidFill>
+                  <a:srgbClr val="C9C9CE"/>
+                </a:solidFill>
+                <a:latin typeface="Arial" pitchFamily="34" charset="0"/>
+                <a:ea typeface="Arial" pitchFamily="34" charset="-122"/>
+                <a:cs typeface="Arial" pitchFamily="34" charset="-120"/>
+              </a:rPr>
+              <a:t>The presidential policy chief proposed a "citizen dividend" funded by AI and chip-sector tax revenue (May 12, Facebook post). President Lee Jae-myung clarified it was not official policy. Norway and Alaska sovereign-fund models cited.</a:t>
+            </a:r>
+            <a:endParaRPr lang="en-US" sz="1050" dirty="0"/>
+          </a:p>
+        </p:txBody>
+      </p:sp>
+      <p:sp>
+        <p:nvSpPr>
+          <p:cNvPr id="26" name="Shape 24"/>
+          <p:cNvSpPr/>
+          <p:nvPr/>
+        </p:nvSpPr>
+        <p:spPr>
+          <a:xfrm>
+            <a:off x="4892040" y="3429000"/>
+            <a:ext cx="3794760" cy="658368"/>
           </a:xfrm>
           <a:prstGeom prst="rect">
             <a:avLst/>
           </a:prstGeom>
           <a:solidFill>
-            <a:srgbClr val="9B7BE0"/>
+            <a:srgbClr val="1C1C20"/>
           </a:solidFill>
           <a:ln/>
         </p:spPr>
       </p:sp>
       <p:sp>
         <p:nvSpPr>
-          <p:cNvPr id="21" name="Shape 19"/>
-          <p:cNvSpPr/>
-          <p:nvPr/>
-        </p:nvSpPr>
-        <p:spPr>
-          <a:xfrm>
-            <a:off x="8412480" y="3808476"/>
-            <a:ext cx="274320" cy="32004"/>
+          <p:cNvPr id="27" name="Shape 25"/>
+          <p:cNvSpPr/>
+          <p:nvPr/>
+        </p:nvSpPr>
+        <p:spPr>
+          <a:xfrm>
+            <a:off x="4892040" y="3429000"/>
+            <a:ext cx="64008" cy="658368"/>
           </a:xfrm>
           <a:prstGeom prst="rect">
             <a:avLst/>
           </a:prstGeom>
           <a:solidFill>
-            <a:srgbClr val="9B7BE0"/>
+            <a:srgbClr val="FFB800"/>
           </a:solidFill>
           <a:ln/>
         </p:spPr>
       </p:sp>
       <p:sp>
         <p:nvSpPr>
-          <p:cNvPr id="22" name="Shape 20"/>
-          <p:cNvSpPr/>
-          <p:nvPr/>
-        </p:nvSpPr>
-        <p:spPr>
-          <a:xfrm>
-            <a:off x="8654796" y="3566160"/>
-            <a:ext cx="32004" cy="274320"/>
-          </a:xfrm>
-          <a:prstGeom prst="rect">
-            <a:avLst/>
-          </a:prstGeom>
-          <a:solidFill>
-            <a:srgbClr val="9B7BE0"/>
-          </a:solidFill>
-          <a:ln/>
-        </p:spPr>
-      </p:sp>
-      <p:sp>
-        <p:nvSpPr>
-          <p:cNvPr id="23" name="Shape 21"/>
-          <p:cNvSpPr/>
-          <p:nvPr/>
-        </p:nvSpPr>
-        <p:spPr>
-          <a:xfrm>
-            <a:off x="7063740" y="2212848"/>
-            <a:ext cx="640080" cy="347472"/>
-          </a:xfrm>
-          <a:prstGeom prst="triangle">
-            <a:avLst/>
-          </a:prstGeom>
-          <a:ln w="19050">
-            <a:solidFill>
-              <a:srgbClr val="9A9AA0"/>
-            </a:solidFill>
-            <a:prstDash val="solid"/>
-          </a:ln>
-        </p:spPr>
-      </p:sp>
-      <p:sp>
-        <p:nvSpPr>
-          <p:cNvPr id="24" name="Shape 22"/>
-          <p:cNvSpPr/>
-          <p:nvPr/>
-        </p:nvSpPr>
-        <p:spPr>
-          <a:xfrm>
-            <a:off x="7511796" y="2084832"/>
-            <a:ext cx="146304" cy="146304"/>
-          </a:xfrm>
-          <a:prstGeom prst="ellipse">
-            <a:avLst/>
-          </a:prstGeom>
-          <a:ln w="19050">
-            <a:solidFill>
-              <a:srgbClr val="9A9AA0"/>
-            </a:solidFill>
-            <a:prstDash val="solid"/>
-          </a:ln>
-        </p:spPr>
-      </p:sp>
-      <p:sp>
-        <p:nvSpPr>
-          <p:cNvPr id="25" name="Text 23"/>
-          <p:cNvSpPr/>
-          <p:nvPr/>
-        </p:nvSpPr>
-        <p:spPr>
-          <a:xfrm>
-            <a:off x="6172200" y="2670048"/>
-            <a:ext cx="2423160" cy="219456"/>
+          <p:cNvPr id="28" name="Text 26"/>
+          <p:cNvSpPr/>
+          <p:nvPr/>
+        </p:nvSpPr>
+        <p:spPr>
+          <a:xfrm>
+            <a:off x="5056632" y="3502152"/>
+            <a:ext cx="3520440" cy="182880"/>
           </a:xfrm>
           <a:prstGeom prst="rect">
             <a:avLst/>
@@ -13530,34 +14441,34 @@
           <a:bodyPr wrap="square" lIns="0" tIns="0" rIns="0" bIns="0" rtlCol="0" anchor="ctr"/>
           <a:lstStyle/>
           <a:p>
-            <a:pPr algn="ctr" indent="0" marL="0">
-              <a:buNone/>
-            </a:pPr>
-            <a:r>
-              <a:rPr lang="en-US" sz="800" b="1" spc="200" kern="0" dirty="0">
-                <a:solidFill>
-                  <a:srgbClr val="9B7BE0"/>
-                </a:solidFill>
-                <a:latin typeface="Arial" pitchFamily="34" charset="0"/>
-                <a:ea typeface="Arial" pitchFamily="34" charset="-122"/>
-                <a:cs typeface="Arial" pitchFamily="34" charset="-120"/>
-              </a:rPr>
-              <a:t>IMAGE — CAPITOL IN DARK GLASS</a:t>
-            </a:r>
-            <a:endParaRPr lang="en-US" sz="800" dirty="0"/>
-          </a:p>
-        </p:txBody>
-      </p:sp>
-      <p:sp>
-        <p:nvSpPr>
-          <p:cNvPr id="26" name="Text 24"/>
-          <p:cNvSpPr/>
-          <p:nvPr/>
-        </p:nvSpPr>
-        <p:spPr>
-          <a:xfrm>
-            <a:off x="6263640" y="2926080"/>
-            <a:ext cx="2240280" cy="594360"/>
+            <a:pPr indent="0" marL="0">
+              <a:buNone/>
+            </a:pPr>
+            <a:r>
+              <a:rPr lang="en-US" sz="750" b="1" spc="200" kern="0" dirty="0">
+                <a:solidFill>
+                  <a:srgbClr val="FFB800"/>
+                </a:solidFill>
+                <a:latin typeface="Arial" pitchFamily="34" charset="0"/>
+                <a:ea typeface="Arial" pitchFamily="34" charset="-122"/>
+                <a:cs typeface="Arial" pitchFamily="34" charset="-120"/>
+              </a:rPr>
+              <a:t>SAMSUNG UNION</a:t>
+            </a:r>
+            <a:endParaRPr lang="en-US" sz="750" dirty="0"/>
+          </a:p>
+        </p:txBody>
+      </p:sp>
+      <p:sp>
+        <p:nvSpPr>
+          <p:cNvPr id="29" name="Text 27"/>
+          <p:cNvSpPr/>
+          <p:nvPr/>
+        </p:nvSpPr>
+        <p:spPr>
+          <a:xfrm>
+            <a:off x="5056632" y="3703320"/>
+            <a:ext cx="3465576" cy="292608"/>
           </a:xfrm>
           <a:prstGeom prst="rect">
             <a:avLst/>
@@ -13569,19 +14480,125 @@
           <a:bodyPr wrap="square" lIns="0" tIns="0" rIns="0" bIns="0" rtlCol="0" anchor="t"/>
           <a:lstStyle/>
           <a:p>
-            <a:pPr algn="ctr" indent="0" marL="0">
-              <a:buNone/>
-            </a:pPr>
-            <a:r>
-              <a:rPr lang="en-US" sz="700" i="1" dirty="0">
-                <a:solidFill>
-                  <a:srgbClr val="9A9AA0"/>
-                </a:solidFill>
-                <a:latin typeface="Arial" pitchFamily="34" charset="0"/>
-                <a:ea typeface="Arial" pitchFamily="34" charset="-122"/>
-                <a:cs typeface="Arial" pitchFamily="34" charset="-120"/>
-              </a:rPr>
-              <a:t>Neoclassical government dome rendered in dark glass, faint purple circuit patterns glowing inside, black background, centered.</a:t>
+            <a:pPr indent="0" marL="0">
+              <a:buNone/>
+            </a:pPr>
+            <a:r>
+              <a:rPr lang="en-US" sz="1050" b="1" dirty="0">
+                <a:solidFill>
+                  <a:srgbClr val="FFFFFF"/>
+                </a:solidFill>
+                <a:latin typeface="Arial" pitchFamily="34" charset="0"/>
+                <a:ea typeface="Arial" pitchFamily="34" charset="-122"/>
+                <a:cs typeface="Arial" pitchFamily="34" charset="-120"/>
+              </a:rPr>
+              <a:t>Workers want 15% of chip profits.  </a:t>
+            </a:r>
+            <a:pPr indent="0" marL="0">
+              <a:buNone/>
+            </a:pPr>
+            <a:r>
+              <a:rPr lang="en-US" sz="900" dirty="0">
+                <a:solidFill>
+                  <a:srgbClr val="C9C9CE"/>
+                </a:solidFill>
+                <a:latin typeface="Arial" pitchFamily="34" charset="0"/>
+                <a:ea typeface="Arial" pitchFamily="34" charset="-122"/>
+                <a:cs typeface="Arial" pitchFamily="34" charset="-120"/>
+              </a:rPr>
+              <a:t>Samsung's largest union demanded 15% of semiconductor-division profit be shared with workers (Apr 2026), tying labor's AI claim directly to the supply chain.</a:t>
+            </a:r>
+            <a:endParaRPr lang="en-US" sz="1050" dirty="0"/>
+          </a:p>
+        </p:txBody>
+      </p:sp>
+      <p:sp>
+        <p:nvSpPr>
+          <p:cNvPr id="30" name="Text 28"/>
+          <p:cNvSpPr/>
+          <p:nvPr/>
+        </p:nvSpPr>
+        <p:spPr>
+          <a:xfrm>
+            <a:off x="457200" y="4133088"/>
+            <a:ext cx="8229600" cy="347472"/>
+          </a:xfrm>
+          <a:prstGeom prst="rect">
+            <a:avLst/>
+          </a:prstGeom>
+          <a:noFill/>
+          <a:ln/>
+        </p:spPr>
+        <p:txBody>
+          <a:bodyPr wrap="square" lIns="0" tIns="0" rIns="0" bIns="0" rtlCol="0" anchor="ctr"/>
+          <a:lstStyle/>
+          <a:p>
+            <a:pPr indent="0" marL="0">
+              <a:buNone/>
+            </a:pPr>
+            <a:r>
+              <a:rPr lang="en-US" sz="950" b="1" dirty="0">
+                <a:solidFill>
+                  <a:srgbClr val="FFFFFF"/>
+                </a:solidFill>
+                <a:latin typeface="Arial" pitchFamily="34" charset="0"/>
+                <a:ea typeface="Arial" pitchFamily="34" charset="-122"/>
+                <a:cs typeface="Arial" pitchFamily="34" charset="-120"/>
+              </a:rPr>
+              <a:t>Investor read: </a:t>
+            </a:r>
+            <a:pPr indent="0" marL="0">
+              <a:buNone/>
+            </a:pPr>
+            <a:r>
+              <a:rPr lang="en-US" sz="950" dirty="0">
+                <a:solidFill>
+                  <a:srgbClr val="C9C9CE"/>
+                </a:solidFill>
+                <a:latin typeface="Arial" pitchFamily="34" charset="0"/>
+                <a:ea typeface="Arial" pitchFamily="34" charset="-122"/>
+                <a:cs typeface="Arial" pitchFamily="34" charset="-120"/>
+              </a:rPr>
+              <a:t>the 2026 debate is no longer whether AI is regulated. It is whether the means of AI production are publicly owned. That is a dilution tail risk no equity model carries.</a:t>
+            </a:r>
+            <a:endParaRPr lang="en-US" sz="950" dirty="0"/>
+          </a:p>
+        </p:txBody>
+      </p:sp>
+      <p:sp>
+        <p:nvSpPr>
+          <p:cNvPr id="31" name="Text 29"/>
+          <p:cNvSpPr/>
+          <p:nvPr/>
+        </p:nvSpPr>
+        <p:spPr>
+          <a:xfrm>
+            <a:off x="457200" y="4498848"/>
+            <a:ext cx="8229600" cy="384048"/>
+          </a:xfrm>
+          <a:prstGeom prst="rect">
+            <a:avLst/>
+          </a:prstGeom>
+          <a:noFill/>
+          <a:ln/>
+        </p:spPr>
+        <p:txBody>
+          <a:bodyPr wrap="square" lIns="0" tIns="0" rIns="0" bIns="0" rtlCol="0" anchor="t"/>
+          <a:lstStyle/>
+          <a:p>
+            <a:pPr indent="0" marL="0">
+              <a:buNone/>
+            </a:pPr>
+            <a:r>
+              <a:rPr lang="en-US" sz="700" dirty="0">
+                <a:solidFill>
+                  <a:srgbClr val="8A8A90"/>
+                </a:solidFill>
+                <a:latin typeface="Arial" pitchFamily="34" charset="0"/>
+                <a:ea typeface="Arial" pitchFamily="34" charset="-122"/>
+                <a:cs typeface="Arial" pitchFamily="34" charset="-120"/>
+              </a:rPr>
+              <a:t>Source: Internal strategic review, “The 2026 AI Frontier” (Jun 2026); Korea Herald, Bloomberg, Nikkei Asia (May 2026); Executive Order provisions; sovereign wealth fund proposals; Sacks critique.</a:t>
             </a:r>
             <a:endParaRPr lang="en-US" sz="700" dirty="0"/>
           </a:p>
@@ -13589,99 +14606,7 @@
       </p:sp>
       <p:sp>
         <p:nvSpPr>
-          <p:cNvPr id="27" name="Text 25"/>
-          <p:cNvSpPr/>
-          <p:nvPr/>
-        </p:nvSpPr>
-        <p:spPr>
-          <a:xfrm>
-            <a:off x="457200" y="3931920"/>
-            <a:ext cx="8229600" cy="347472"/>
-          </a:xfrm>
-          <a:prstGeom prst="rect">
-            <a:avLst/>
-          </a:prstGeom>
-          <a:noFill/>
-          <a:ln/>
-        </p:spPr>
-        <p:txBody>
-          <a:bodyPr wrap="square" lIns="0" tIns="0" rIns="0" bIns="0" rtlCol="0" anchor="ctr"/>
-          <a:lstStyle/>
-          <a:p>
-            <a:pPr indent="0" marL="0">
-              <a:buNone/>
-            </a:pPr>
-            <a:r>
-              <a:rPr lang="en-US" sz="1000" b="1" dirty="0">
-                <a:solidFill>
-                  <a:srgbClr val="FFFFFF"/>
-                </a:solidFill>
-                <a:latin typeface="Arial" pitchFamily="34" charset="0"/>
-                <a:ea typeface="Arial" pitchFamily="34" charset="-122"/>
-                <a:cs typeface="Arial" pitchFamily="34" charset="-120"/>
-              </a:rPr>
-              <a:t>Investor read: </a:t>
-            </a:r>
-            <a:pPr indent="0" marL="0">
-              <a:buNone/>
-            </a:pPr>
-            <a:r>
-              <a:rPr lang="en-US" sz="1000" dirty="0">
-                <a:solidFill>
-                  <a:srgbClr val="C9C9CE"/>
-                </a:solidFill>
-                <a:latin typeface="Arial" pitchFamily="34" charset="0"/>
-                <a:ea typeface="Arial" pitchFamily="34" charset="-122"/>
-                <a:cs typeface="Arial" pitchFamily="34" charset="-120"/>
-              </a:rPr>
-              <a:t>the 2026 debate is no longer whether AI is regulated — it’s whether the means of AI production are publicly owned. That’s a dilution tail risk no equity model carries.</a:t>
-            </a:r>
-            <a:endParaRPr lang="en-US" sz="1000" dirty="0"/>
-          </a:p>
-        </p:txBody>
-      </p:sp>
-      <p:sp>
-        <p:nvSpPr>
-          <p:cNvPr id="28" name="Text 26"/>
-          <p:cNvSpPr/>
-          <p:nvPr/>
-        </p:nvSpPr>
-        <p:spPr>
-          <a:xfrm>
-            <a:off x="457200" y="4297680"/>
-            <a:ext cx="8229600" cy="384048"/>
-          </a:xfrm>
-          <a:prstGeom prst="rect">
-            <a:avLst/>
-          </a:prstGeom>
-          <a:noFill/>
-          <a:ln/>
-        </p:spPr>
-        <p:txBody>
-          <a:bodyPr wrap="square" lIns="0" tIns="0" rIns="0" bIns="0" rtlCol="0" anchor="t"/>
-          <a:lstStyle/>
-          <a:p>
-            <a:pPr indent="0" marL="0">
-              <a:buNone/>
-            </a:pPr>
-            <a:r>
-              <a:rPr lang="en-US" sz="700" dirty="0">
-                <a:solidFill>
-                  <a:srgbClr val="8A8A90"/>
-                </a:solidFill>
-                <a:latin typeface="Arial" pitchFamily="34" charset="0"/>
-                <a:ea typeface="Arial" pitchFamily="34" charset="-122"/>
-                <a:cs typeface="Arial" pitchFamily="34" charset="-120"/>
-              </a:rPr>
-              <a:t>Source: Internal strategic review, “The 2026 AI Frontier” (Jun 2026) — Executive Order provisions, sovereign wealth fund proposals, Sacks critique.</a:t>
-            </a:r>
-            <a:endParaRPr lang="en-US" sz="700" dirty="0"/>
-          </a:p>
-        </p:txBody>
-      </p:sp>
-      <p:sp>
-        <p:nvSpPr>
-          <p:cNvPr id="29" name="Shape 27"/>
+          <p:cNvPr id="32" name="Shape 30"/>
           <p:cNvSpPr/>
           <p:nvPr/>
         </p:nvSpPr>
@@ -13701,7 +14626,7 @@
       </p:sp>
       <p:sp>
         <p:nvSpPr>
-          <p:cNvPr id="30" name="Shape 28"/>
+          <p:cNvPr id="33" name="Shape 31"/>
           <p:cNvSpPr/>
           <p:nvPr/>
         </p:nvSpPr>
@@ -13724,7 +14649,7 @@
       </p:sp>
       <p:sp>
         <p:nvSpPr>
-          <p:cNvPr id="31" name="Text 29"/>
+          <p:cNvPr id="34" name="Text 32"/>
           <p:cNvSpPr/>
           <p:nvPr/>
         </p:nvSpPr>
@@ -13763,7 +14688,7 @@
       </p:sp>
       <p:sp>
         <p:nvSpPr>
-          <p:cNvPr id="32" name="Text 30"/>
+          <p:cNvPr id="35" name="Text 33"/>
           <p:cNvSpPr/>
           <p:nvPr/>
         </p:nvSpPr>
@@ -13885,7 +14810,7 @@
                 <a:ea typeface="Arial" pitchFamily="34" charset="-122"/>
                 <a:cs typeface="Arial" pitchFamily="34" charset="-120"/>
               </a:rPr>
-              <a:t>02  ·  MARKET IMPACT  —  EQUITIES</a:t>
+              <a:t>02  ·  MARKET IMPACT  ·  EQUITIES</a:t>
             </a:r>
             <a:endParaRPr lang="en-US" sz="900" dirty="0"/>
           </a:p>
@@ -13963,7 +14888,7 @@
                 <a:ea typeface="Arial" pitchFamily="34" charset="-122"/>
                 <a:cs typeface="Arial" pitchFamily="34" charset="-120"/>
               </a:rPr>
-              <a:t>Semis +80%, software −10% — a ~90-point spread inside one theme, while ten stocks hold ~37% of the index.</a:t>
+              <a:t>Semis +80%, software −10%: a ~90-point spread inside one theme, while ten stocks hold ~37% of the index.</a:t>
             </a:r>
             <a:endParaRPr lang="en-US" sz="1250" dirty="0"/>
           </a:p>
@@ -14119,7 +15044,7 @@
                 <a:ea typeface="Arial" pitchFamily="34" charset="-122"/>
                 <a:cs typeface="Arial" pitchFamily="34" charset="-120"/>
               </a:rPr>
-              <a:t>Top-10 share of S&amp;P 500 market cap — the 1990–2015 norm was 18–23%; the 2025 peak 40.7%.</a:t>
+              <a:t>Top-10 share of S&amp;P 500 market cap; the 1990–2015 norm was 18–23%, the 2025 peak 40.7%.</a:t>
             </a:r>
             <a:endParaRPr lang="en-US" sz="750" dirty="0"/>
           </a:p>
@@ -14197,7 +15122,7 @@
                 <a:ea typeface="Arial" pitchFamily="34" charset="-122"/>
                 <a:cs typeface="Arial" pitchFamily="34" charset="-120"/>
               </a:rPr>
-              <a:t>Nvidia market cap, 7.0% of the index — Apple $4.6T and Microsoft $3.3T behind it; three names ≈ 18%.</a:t>
+              <a:t>Nvidia market cap, 7.0% of the index; Apple $4.6T and Microsoft $3.3T behind it; three names ≈ 18%.</a:t>
             </a:r>
             <a:endParaRPr lang="en-US" sz="750" dirty="0"/>
           </a:p>
@@ -14275,7 +15200,7 @@
                 <a:ea typeface="Arial" pitchFamily="34" charset="-122"/>
                 <a:cs typeface="Arial" pitchFamily="34" charset="-120"/>
               </a:rPr>
-              <a:t>S&amp;P 500 forward P/E vs a 19.0x 10-yr average — elevated, not extreme. The spread is the signal.</a:t>
+              <a:t>S&amp;P 500 forward P/E vs a 19.0x 10-yr average: elevated, not extreme. The spread is the signal.</a:t>
             </a:r>
             <a:endParaRPr lang="en-US" sz="750" dirty="0"/>
           </a:p>
@@ -14328,7 +15253,7 @@
                 <a:ea typeface="Arial" pitchFamily="34" charset="-122"/>
                 <a:cs typeface="Arial" pitchFamily="34" charset="-120"/>
               </a:rPr>
-              <a:t>Value accrues where AI spend is revenue — and erodes where AI is the threat.</a:t>
+              <a:t>Value accrues where AI spend is revenue, and erodes where AI is the threat.</a:t>
             </a:r>
             <a:endParaRPr lang="en-US" sz="1000" dirty="0"/>
           </a:p>
@@ -14579,7 +15504,7 @@
                 <a:ea typeface="Arial" pitchFamily="34" charset="-122"/>
                 <a:cs typeface="Arial" pitchFamily="34" charset="-120"/>
               </a:rPr>
-              <a:t>02  ·  MARKET IMPACT  —  LABOR</a:t>
+              <a:t>02  ·  MARKET IMPACT  ·  LABOR</a:t>
             </a:r>
             <a:endParaRPr lang="en-US" sz="900" dirty="0"/>
           </a:p>
@@ -14657,7 +15582,7 @@
                 <a:ea typeface="Arial" pitchFamily="34" charset="-122"/>
                 <a:cs typeface="Arial" pitchFamily="34" charset="-120"/>
               </a:rPr>
-              <a:t>Agents change what a job is — and in 2026 the labor data started moving. Markets price both: deflated cost lines and the policy risk that displacement fuels.</a:t>
+              <a:t>Agents change what a job is, and in 2026 the labor data started moving. Markets price both: deflated cost lines and the policy risk that displacement fuels.</a:t>
             </a:r>
             <a:endParaRPr lang="en-US" sz="1250" dirty="0"/>
           </a:p>
@@ -14797,7 +15722,7 @@
                 <a:ea typeface="Arial" pitchFamily="34" charset="-122"/>
                 <a:cs typeface="Arial" pitchFamily="34" charset="-120"/>
               </a:rPr>
-              <a:t>of the work week goes to coordination and retrieval (OpenAI’s “strange abundance”) — the labor pool agents are bought to recover.</a:t>
+              <a:t>of the work week goes to coordination and retrieval (OpenAI’s “strange abundance”): the labor pool agents are bought to recover.</a:t>
             </a:r>
             <a:endParaRPr lang="en-US" sz="750" dirty="0"/>
           </a:p>
@@ -15458,7 +16383,7 @@
                 <a:ea typeface="Arial" pitchFamily="34" charset="-122"/>
                 <a:cs typeface="Arial" pitchFamily="34" charset="-120"/>
               </a:rPr>
-              <a:t>Challenger: AI was cited in ~40% of May’s announced US job cuts (38.6k of 97k) — the first month it beat “market conditions.” 87.7k AI-attributed cuts YTD vs 54.8k in all of 2025. (Self-reported; some firms may be scapegoating AI.)</a:t>
+              <a:t>Challenger: AI was cited in ~40% of May’s announced US job cuts (38.6k of 97k), the first month it beat “market conditions.” 87.7k AI-attributed cuts YTD vs 54.8k in all of 2025. (Self-reported; some firms may be scapegoating AI.)</a:t>
             </a:r>
             <a:endParaRPr lang="en-US" sz="950" dirty="0"/>
           </a:p>
@@ -15531,7 +16456,7 @@
                 <a:ea typeface="Arial" pitchFamily="34" charset="-122"/>
                 <a:cs typeface="Arial" pitchFamily="34" charset="-120"/>
               </a:rPr>
-              <a:t>Recent-grad unemployment 5.6% vs 4.2% overall (NY Fed, Mar 2026) — one of the worst readings in a decade outside the pandemic. Payrolls for 22–25-year-olds in AI-exposed roles are declining while senior cohorts hold.</a:t>
+              <a:t>Recent-grad unemployment 5.6% vs 4.2% overall (NY Fed, Mar 2026), one of the worst readings in a decade outside the pandemic. Payrolls for 22–25-year-olds in AI-exposed roles are declining while senior cohorts hold.</a:t>
             </a:r>
             <a:endParaRPr lang="en-US" sz="950" dirty="0"/>
           </a:p>
@@ -15855,7 +16780,7 @@
                 <a:ea typeface="Arial" pitchFamily="34" charset="-122"/>
                 <a:cs typeface="Arial" pitchFamily="34" charset="-120"/>
               </a:rPr>
-              <a:t>02  ·  MARKET IMPACT  —  FINANCING — THE GAP</a:t>
+              <a:t>02  ·  MARKET IMPACT  ·  FINANCING · THE GAP</a:t>
             </a:r>
             <a:endParaRPr lang="en-US" sz="900" dirty="0"/>
           </a:p>
@@ -15933,7 +16858,7 @@
                 <a:ea typeface="Arial" pitchFamily="34" charset="-122"/>
                 <a:cs typeface="Arial" pitchFamily="34" charset="-120"/>
               </a:rPr>
-              <a:t>The buildout was self-funded until it wasn’t. ~$705B of guided 2026 capex consumes the cash machine — and opens a funding gap.</a:t>
+              <a:t>The buildout was self-funded until it wasn’t. ~$705B of guided 2026 capex consumes the cash machine, and opens a funding gap.</a:t>
             </a:r>
             <a:endParaRPr lang="en-US" sz="1250" dirty="0"/>
           </a:p>
@@ -16050,7 +16975,7 @@
                 <a:ea typeface="Arial" pitchFamily="34" charset="-122"/>
                 <a:cs typeface="Arial" pitchFamily="34" charset="-120"/>
               </a:rPr>
-              <a:t>+72% YoY — raised into record spend</a:t>
+              <a:t>+72% YoY, raised into record spend</a:t>
             </a:r>
             <a:endParaRPr lang="en-US" sz="800" dirty="0"/>
           </a:p>
@@ -16348,7 +17273,7 @@
                 <a:ea typeface="Arial" pitchFamily="34" charset="-122"/>
                 <a:cs typeface="Arial" pitchFamily="34" charset="-120"/>
               </a:rPr>
-              <a:t>Big-4 free cash flow at a decade low — at far larger revenue (CNBC)</a:t>
+              <a:t>Big-4 free cash flow at a decade low, at far larger revenue (CNBC)</a:t>
             </a:r>
             <a:endParaRPr lang="en-US" sz="750" dirty="0"/>
           </a:p>

</xml_diff>

<commit_message>
Slides 4 & 8 to native infographics; sharpen 10 image prompts
- Slide 4: native agentic-loop cycle (TRY/FAIL/FIX/SHIP) + Jevons escalation-ladder bars. Slide 8: native orchestrator -> N-agents fan-out. Drawn in-deck so labels are accurate (text-to-image garbles labels).
- Drops the loops-jevons.png and labor-orchestrator.png image slots (12 -> 10 images).
- Sharpened the remaining prompts (cover, 3 shift icons, token, gov-stake, 4 frontier) to be specific/concrete; IMAGE_PROMPTS_V3.md updated to match.
- Rebuilt: valid 12-slide .pptx + slides-data.js.

Still WIP on this branch — re-export the JPGs before merging to main.

Co-Authored-By: Claude Opus 4.8 <noreply@anthropic.com>
</commit_message>
<xml_diff>
--- a/ai-markets-deck.pptx
+++ b/ai-markets-deck.pptx
@@ -2778,7 +2778,7 @@
                 <a:ea typeface="Arial" pitchFamily="34" charset="-122"/>
                 <a:cs typeface="Arial" pitchFamily="34" charset="-120"/>
               </a:rPr>
-              <a:t>Isometric 3D illustration, a financial district whose skyscrapers are built from stacked GPU / circuit-board blocks, glowing orange and yellow data streams flowing between the towers, near-black background, clean low-poly vector style, soft studio glow, subtle floor grid, centered, no text, no logos.</a:t>
+              <a:t>Isometric 3D illustration, a financial district at night where the skyscrapers are stacked GPU server-racks; a glowing candlestick stock-chart runs like a road along their base, and a curved arrow of capital flows from a domed bank building into the single tallest GPU tower; orange and yellow accents, near-black background, clean low-poly vector style, soft studio glow, subtle floor grid, centered, no text, no logos.</a:t>
             </a:r>
             <a:endParaRPr lang="en-US" sz="700" dirty="0"/>
           </a:p>
@@ -4160,7 +4160,7 @@
                 <a:ea typeface="Arial" pitchFamily="34" charset="-122"/>
                 <a:cs typeface="Arial" pitchFamily="34" charset="-120"/>
               </a:rPr>
-              <a:t>Isometric 3D illustration, a humanoid robot working on a warehouse floor among shelving, pink accents, near-black background, clean low-poly vector style, soft studio glow, subtle floor grid, centered, no text, no logos.</a:t>
+              <a:t>Isometric 3D illustration, a humanoid robot carrying a labeled tote down a numbered warehouse aisle lined with shelving racks, mid-stride, pink accents, near-black background, clean low-poly vector style, soft studio glow, subtle floor grid, centered, no text, no logos.</a:t>
             </a:r>
             <a:endParaRPr lang="en-US" sz="700" dirty="0"/>
           </a:p>
@@ -4456,7 +4456,7 @@
                 <a:ea typeface="Arial" pitchFamily="34" charset="-122"/>
                 <a:cs typeface="Arial" pitchFamily="34" charset="-120"/>
               </a:rPr>
-              <a:t>Isometric 3D illustration, an autonomous robotaxi with a glowing sensor halo on a small city block, pink accents, near-black background, clean low-poly vector style, soft studio glow, subtle floor grid, centered, no text, no logos.</a:t>
+              <a:t>Isometric 3D illustration, a driverless robotaxi with a spinning lidar turret and glowing sensor cones stopped at a small city intersection with a traffic light and crosswalk, pink accents, near-black background, clean low-poly vector style, soft studio glow, subtle floor grid, centered, no text, no logos.</a:t>
             </a:r>
             <a:endParaRPr lang="en-US" sz="700" dirty="0"/>
           </a:p>
@@ -4752,7 +4752,7 @@
                 <a:ea typeface="Arial" pitchFamily="34" charset="-122"/>
                 <a:cs typeface="Arial" pitchFamily="34" charset="-120"/>
               </a:rPr>
-              <a:t>Isometric 3D illustration, an orbital data-center satellite with large solar panels above the curve of Earth, pink accents, near-black background, clean low-poly vector style, soft studio glow, subtle floor grid, centered, no text, no logos.</a:t>
+              <a:t>Isometric 3D illustration, a ring-shaped orbital data-center with unfolded solar-panel wings and server modules, floating above the curved horizon of Earth with sparse stars, pink accents, near-black background, clean low-poly vector style, soft studio glow, subtle floor grid, centered, no text, no logos.</a:t>
             </a:r>
             <a:endParaRPr lang="en-US" sz="700" dirty="0"/>
           </a:p>
@@ -5048,7 +5048,7 @@
                 <a:ea typeface="Arial" pitchFamily="34" charset="-122"/>
                 <a:cs typeface="Arial" pitchFamily="34" charset="-120"/>
               </a:rPr>
-              <a:t>Isometric 3D illustration, a robotic lab arm assembling a glowing folded-protein / molecule structure, pink accents, near-black background, clean low-poly vector style, soft studio glow, subtle floor grid, centered, no text, no logos.</a:t>
+              <a:t>Isometric 3D illustration, a robotic pipette arm in a lab assembling a glowing folded-protein ribbon and double-helix on a sample platform, small vials arranged around it, pink accents, near-black background, clean low-poly vector style, soft studio glow, subtle floor grid, centered, no text, no logos.</a:t>
             </a:r>
             <a:endParaRPr lang="en-US" sz="700" dirty="0"/>
           </a:p>
@@ -6695,7 +6695,7 @@
                 <a:ea typeface="Arial" pitchFamily="34" charset="-122"/>
                 <a:cs typeface="Arial" pitchFamily="34" charset="-120"/>
               </a:rPr>
-              <a:t>Isometric 3D illustration, a small robot arm assembling a glowing cube inside an endless loop track (an autonomous work loop), teal accents, near-black background, clean low-poly vector style, soft studio glow, subtle floor grid, centered, no text, no logos.</a:t>
+              <a:t>Isometric 3D illustration, a robotic arm on a small circular conveyor picking up a glowing cube, spotting a flaw, and placing it back to retry — a literal self-correcting loop, teal accents, near-black background, clean low-poly vector style, soft studio glow, subtle floor grid, centered, no text, no logos.</a:t>
             </a:r>
             <a:endParaRPr lang="en-US" sz="700" dirty="0"/>
           </a:p>
@@ -7040,7 +7040,7 @@
                 <a:ea typeface="Arial" pitchFamily="34" charset="-122"/>
                 <a:cs typeface="Arial" pitchFamily="34" charset="-120"/>
               </a:rPr>
-              <a:t>Isometric 3D illustration, a utility meter / fuel gauge dispensing glowing token coins into a laptop, metered-compute feel, orange accents, near-black background, clean low-poly vector style, soft studio glow, subtle floor grid, centered, no text, no logos.</a:t>
+              <a:t>Isometric 3D illustration, a coin-operated electricity meter wired into a GPU, its dial pushed near a red limit line, a small rationed stack of glowing token-coins beside it, orange accents, near-black background, clean low-poly vector style, soft studio glow, subtle floor grid, centered, no text, no logos.</a:t>
             </a:r>
             <a:endParaRPr lang="en-US" sz="700" dirty="0"/>
           </a:p>
@@ -7385,7 +7385,7 @@
                 <a:ea typeface="Arial" pitchFamily="34" charset="-122"/>
                 <a:cs typeface="Arial" pitchFamily="34" charset="-120"/>
               </a:rPr>
-              <a:t>Isometric 3D illustration, a government / capitol building with a glowing microchip resting on top, a flag planted in a server rack, purple accents, near-black background, clean low-poly vector style, soft studio glow, subtle floor grid, centered, no text, no logos.</a:t>
+              <a:t>Isometric 3D illustration, a capitol dome beside a server-rack tower; a giant government hand plants a flag stamped with a percent sign on the tower while an official seal hovers over a glowing microchip, purple accents, near-black background, clean low-poly vector style, soft studio glow, subtle floor grid, centered, no text, no logos.</a:t>
             </a:r>
             <a:endParaRPr lang="en-US" sz="700" dirty="0"/>
           </a:p>
@@ -9150,8 +9150,8 @@
         </p:nvSpPr>
         <p:spPr>
           <a:xfrm>
-            <a:off x="457200" y="1691640"/>
-            <a:ext cx="4206240" cy="182880"/>
+            <a:off x="457200" y="1664208"/>
+            <a:ext cx="3931920" cy="182880"/>
           </a:xfrm>
           <a:prstGeom prst="rect">
             <a:avLst/>
@@ -9167,7 +9167,7 @@
               <a:buNone/>
             </a:pPr>
             <a:r>
-              <a:rPr lang="en-US" sz="800" b="1" spc="150" kern="0" dirty="0">
+              <a:rPr lang="en-US" sz="900" b="1" spc="200" kern="0" dirty="0">
                 <a:solidFill>
                   <a:srgbClr val="2BC4C4"/>
                 </a:solidFill>
@@ -9175,50 +9175,38 @@
                 <a:ea typeface="Arial" pitchFamily="34" charset="-122"/>
                 <a:cs typeface="Arial" pitchFamily="34" charset="-120"/>
               </a:rPr>
-              <a:t>THE UNIT OF WORK CHANGED</a:t>
-            </a:r>
-            <a:endParaRPr lang="en-US" sz="800" dirty="0"/>
-          </a:p>
-        </p:txBody>
-      </p:sp>
-      <p:sp>
-        <p:nvSpPr>
-          <p:cNvPr id="7" name="Text 5"/>
-          <p:cNvSpPr/>
-          <p:nvPr/>
-        </p:nvSpPr>
-        <p:spPr>
-          <a:xfrm>
-            <a:off x="457200" y="1938528"/>
-            <a:ext cx="4206240" cy="1097280"/>
-          </a:xfrm>
-          <a:prstGeom prst="rect">
-            <a:avLst/>
-          </a:prstGeom>
-          <a:noFill/>
-          <a:ln/>
-        </p:spPr>
-        <p:txBody>
-          <a:bodyPr wrap="square" lIns="0" tIns="0" rIns="0" bIns="0" rtlCol="0" anchor="t"/>
-          <a:lstStyle/>
-          <a:p>
-            <a:pPr indent="0" marL="0">
-              <a:buNone/>
-            </a:pPr>
-            <a:r>
-              <a:rPr lang="en-US" sz="1100" dirty="0">
-                <a:solidFill>
-                  <a:srgbClr val="C9C9CE"/>
-                </a:solidFill>
-                <a:latin typeface="Arial" pitchFamily="34" charset="0"/>
-                <a:ea typeface="Arial" pitchFamily="34" charset="-122"/>
-                <a:cs typeface="Arial" pitchFamily="34" charset="-120"/>
-              </a:rPr>
-              <a:t>One-shot prompting gave way to try → fail → fix → ship loops that run without a human in each cycle. As creation friction falls, compute demand expands geometrically (the Jevons paradox).</a:t>
-            </a:r>
-            <a:endParaRPr lang="en-US" sz="1100" dirty="0"/>
-          </a:p>
-        </p:txBody>
+              <a:t>THE AGENTIC LOOP</a:t>
+            </a:r>
+            <a:endParaRPr lang="en-US" sz="900" dirty="0"/>
+          </a:p>
+        </p:txBody>
+      </p:sp>
+      <p:sp>
+        <p:nvSpPr>
+          <p:cNvPr id="7" name="Shape 5"/>
+          <p:cNvSpPr/>
+          <p:nvPr/>
+        </p:nvSpPr>
+        <p:spPr>
+          <a:xfrm>
+            <a:off x="868680" y="2011680"/>
+            <a:ext cx="1097280" cy="457200"/>
+          </a:xfrm>
+          <a:prstGeom prst="roundRect">
+            <a:avLst>
+              <a:gd name="adj" fmla="val 12000"/>
+            </a:avLst>
+          </a:prstGeom>
+          <a:solidFill>
+            <a:srgbClr val="1C1C20"/>
+          </a:solidFill>
+          <a:ln w="19050">
+            <a:solidFill>
+              <a:srgbClr val="2BC4C4"/>
+            </a:solidFill>
+            <a:prstDash val="solid"/>
+          </a:ln>
+        </p:spPr>
       </p:sp>
       <p:sp>
         <p:nvSpPr>
@@ -9228,8 +9216,8 @@
         </p:nvSpPr>
         <p:spPr>
           <a:xfrm>
-            <a:off x="457200" y="3383280"/>
-            <a:ext cx="4206240" cy="320040"/>
+            <a:off x="868680" y="2011680"/>
+            <a:ext cx="1097280" cy="457200"/>
           </a:xfrm>
           <a:prstGeom prst="rect">
             <a:avLst/>
@@ -9241,11 +9229,400 @@
           <a:bodyPr wrap="square" lIns="0" tIns="0" rIns="0" bIns="0" rtlCol="0" anchor="ctr"/>
           <a:lstStyle/>
           <a:p>
-            <a:pPr indent="0" marL="0">
-              <a:buNone/>
-            </a:pPr>
-            <a:r>
-              <a:rPr lang="en-US" sz="1500" b="1" dirty="0">
+            <a:pPr algn="ctr" indent="0" marL="0">
+              <a:buNone/>
+            </a:pPr>
+            <a:r>
+              <a:rPr lang="en-US" sz="1000" b="1" dirty="0">
+                <a:solidFill>
+                  <a:srgbClr val="2BC4C4"/>
+                </a:solidFill>
+                <a:latin typeface="Arial" pitchFamily="34" charset="0"/>
+                <a:ea typeface="Arial" pitchFamily="34" charset="-122"/>
+                <a:cs typeface="Arial" pitchFamily="34" charset="-120"/>
+              </a:rPr>
+              <a:t>TRY</a:t>
+            </a:r>
+            <a:endParaRPr lang="en-US" sz="1000" dirty="0"/>
+          </a:p>
+        </p:txBody>
+      </p:sp>
+      <p:sp>
+        <p:nvSpPr>
+          <p:cNvPr id="9" name="Shape 7"/>
+          <p:cNvSpPr/>
+          <p:nvPr/>
+        </p:nvSpPr>
+        <p:spPr>
+          <a:xfrm>
+            <a:off x="2514600" y="2011680"/>
+            <a:ext cx="1097280" cy="457200"/>
+          </a:xfrm>
+          <a:prstGeom prst="roundRect">
+            <a:avLst>
+              <a:gd name="adj" fmla="val 12000"/>
+            </a:avLst>
+          </a:prstGeom>
+          <a:solidFill>
+            <a:srgbClr val="1C1C20"/>
+          </a:solidFill>
+          <a:ln w="19050">
+            <a:solidFill>
+              <a:srgbClr val="2BC4C4"/>
+            </a:solidFill>
+            <a:prstDash val="solid"/>
+          </a:ln>
+        </p:spPr>
+      </p:sp>
+      <p:sp>
+        <p:nvSpPr>
+          <p:cNvPr id="10" name="Text 8"/>
+          <p:cNvSpPr/>
+          <p:nvPr/>
+        </p:nvSpPr>
+        <p:spPr>
+          <a:xfrm>
+            <a:off x="2514600" y="2011680"/>
+            <a:ext cx="1097280" cy="457200"/>
+          </a:xfrm>
+          <a:prstGeom prst="rect">
+            <a:avLst/>
+          </a:prstGeom>
+          <a:noFill/>
+          <a:ln/>
+        </p:spPr>
+        <p:txBody>
+          <a:bodyPr wrap="square" lIns="0" tIns="0" rIns="0" bIns="0" rtlCol="0" anchor="ctr"/>
+          <a:lstStyle/>
+          <a:p>
+            <a:pPr algn="ctr" indent="0" marL="0">
+              <a:buNone/>
+            </a:pPr>
+            <a:r>
+              <a:rPr lang="en-US" sz="1000" b="1" dirty="0">
+                <a:solidFill>
+                  <a:srgbClr val="2BC4C4"/>
+                </a:solidFill>
+                <a:latin typeface="Arial" pitchFamily="34" charset="0"/>
+                <a:ea typeface="Arial" pitchFamily="34" charset="-122"/>
+                <a:cs typeface="Arial" pitchFamily="34" charset="-120"/>
+              </a:rPr>
+              <a:t>FAIL</a:t>
+            </a:r>
+            <a:endParaRPr lang="en-US" sz="1000" dirty="0"/>
+          </a:p>
+        </p:txBody>
+      </p:sp>
+      <p:sp>
+        <p:nvSpPr>
+          <p:cNvPr id="11" name="Shape 9"/>
+          <p:cNvSpPr/>
+          <p:nvPr/>
+        </p:nvSpPr>
+        <p:spPr>
+          <a:xfrm>
+            <a:off x="2514600" y="2880360"/>
+            <a:ext cx="1097280" cy="457200"/>
+          </a:xfrm>
+          <a:prstGeom prst="roundRect">
+            <a:avLst>
+              <a:gd name="adj" fmla="val 12000"/>
+            </a:avLst>
+          </a:prstGeom>
+          <a:solidFill>
+            <a:srgbClr val="1C1C20"/>
+          </a:solidFill>
+          <a:ln w="19050">
+            <a:solidFill>
+              <a:srgbClr val="2BC4C4"/>
+            </a:solidFill>
+            <a:prstDash val="solid"/>
+          </a:ln>
+        </p:spPr>
+      </p:sp>
+      <p:sp>
+        <p:nvSpPr>
+          <p:cNvPr id="12" name="Text 10"/>
+          <p:cNvSpPr/>
+          <p:nvPr/>
+        </p:nvSpPr>
+        <p:spPr>
+          <a:xfrm>
+            <a:off x="2514600" y="2880360"/>
+            <a:ext cx="1097280" cy="457200"/>
+          </a:xfrm>
+          <a:prstGeom prst="rect">
+            <a:avLst/>
+          </a:prstGeom>
+          <a:noFill/>
+          <a:ln/>
+        </p:spPr>
+        <p:txBody>
+          <a:bodyPr wrap="square" lIns="0" tIns="0" rIns="0" bIns="0" rtlCol="0" anchor="ctr"/>
+          <a:lstStyle/>
+          <a:p>
+            <a:pPr algn="ctr" indent="0" marL="0">
+              <a:buNone/>
+            </a:pPr>
+            <a:r>
+              <a:rPr lang="en-US" sz="1000" b="1" dirty="0">
+                <a:solidFill>
+                  <a:srgbClr val="2BC4C4"/>
+                </a:solidFill>
+                <a:latin typeface="Arial" pitchFamily="34" charset="0"/>
+                <a:ea typeface="Arial" pitchFamily="34" charset="-122"/>
+                <a:cs typeface="Arial" pitchFamily="34" charset="-120"/>
+              </a:rPr>
+              <a:t>FIX</a:t>
+            </a:r>
+            <a:endParaRPr lang="en-US" sz="1000" dirty="0"/>
+          </a:p>
+        </p:txBody>
+      </p:sp>
+      <p:sp>
+        <p:nvSpPr>
+          <p:cNvPr id="13" name="Shape 11"/>
+          <p:cNvSpPr/>
+          <p:nvPr/>
+        </p:nvSpPr>
+        <p:spPr>
+          <a:xfrm>
+            <a:off x="868680" y="2880360"/>
+            <a:ext cx="1097280" cy="457200"/>
+          </a:xfrm>
+          <a:prstGeom prst="roundRect">
+            <a:avLst>
+              <a:gd name="adj" fmla="val 12000"/>
+            </a:avLst>
+          </a:prstGeom>
+          <a:solidFill>
+            <a:srgbClr val="1C1C20"/>
+          </a:solidFill>
+          <a:ln w="19050">
+            <a:solidFill>
+              <a:srgbClr val="2BC4C4"/>
+            </a:solidFill>
+            <a:prstDash val="solid"/>
+          </a:ln>
+        </p:spPr>
+      </p:sp>
+      <p:sp>
+        <p:nvSpPr>
+          <p:cNvPr id="14" name="Text 12"/>
+          <p:cNvSpPr/>
+          <p:nvPr/>
+        </p:nvSpPr>
+        <p:spPr>
+          <a:xfrm>
+            <a:off x="868680" y="2880360"/>
+            <a:ext cx="1097280" cy="457200"/>
+          </a:xfrm>
+          <a:prstGeom prst="rect">
+            <a:avLst/>
+          </a:prstGeom>
+          <a:noFill/>
+          <a:ln/>
+        </p:spPr>
+        <p:txBody>
+          <a:bodyPr wrap="square" lIns="0" tIns="0" rIns="0" bIns="0" rtlCol="0" anchor="ctr"/>
+          <a:lstStyle/>
+          <a:p>
+            <a:pPr algn="ctr" indent="0" marL="0">
+              <a:buNone/>
+            </a:pPr>
+            <a:r>
+              <a:rPr lang="en-US" sz="1000" b="1" dirty="0">
+                <a:solidFill>
+                  <a:srgbClr val="2BC4C4"/>
+                </a:solidFill>
+                <a:latin typeface="Arial" pitchFamily="34" charset="0"/>
+                <a:ea typeface="Arial" pitchFamily="34" charset="-122"/>
+                <a:cs typeface="Arial" pitchFamily="34" charset="-120"/>
+              </a:rPr>
+              <a:t>SHIP</a:t>
+            </a:r>
+            <a:endParaRPr lang="en-US" sz="1000" dirty="0"/>
+          </a:p>
+        </p:txBody>
+      </p:sp>
+      <p:sp>
+        <p:nvSpPr>
+          <p:cNvPr id="15" name="Shape 13"/>
+          <p:cNvSpPr/>
+          <p:nvPr/>
+        </p:nvSpPr>
+        <p:spPr>
+          <a:xfrm>
+            <a:off x="1993392" y="2240280"/>
+            <a:ext cx="493776" cy="0"/>
+          </a:xfrm>
+          <a:prstGeom prst="line">
+            <a:avLst/>
+          </a:prstGeom>
+          <a:noFill/>
+          <a:ln w="22225">
+            <a:solidFill>
+              <a:srgbClr val="2BC4C4"/>
+            </a:solidFill>
+            <a:prstDash val="solid"/>
+            <a:tailEnd type="triangle"/>
+          </a:ln>
+        </p:spPr>
+      </p:sp>
+      <p:sp>
+        <p:nvSpPr>
+          <p:cNvPr id="16" name="Shape 14"/>
+          <p:cNvSpPr/>
+          <p:nvPr/>
+        </p:nvSpPr>
+        <p:spPr>
+          <a:xfrm>
+            <a:off x="3063240" y="2496312"/>
+            <a:ext cx="0" cy="365760"/>
+          </a:xfrm>
+          <a:prstGeom prst="line">
+            <a:avLst/>
+          </a:prstGeom>
+          <a:noFill/>
+          <a:ln w="22225">
+            <a:solidFill>
+              <a:srgbClr val="2BC4C4"/>
+            </a:solidFill>
+            <a:prstDash val="solid"/>
+            <a:tailEnd type="triangle"/>
+          </a:ln>
+        </p:spPr>
+      </p:sp>
+      <p:sp>
+        <p:nvSpPr>
+          <p:cNvPr id="17" name="Shape 15"/>
+          <p:cNvSpPr/>
+          <p:nvPr/>
+        </p:nvSpPr>
+        <p:spPr>
+          <a:xfrm flipH="1">
+            <a:off x="1993392" y="3108960"/>
+            <a:ext cx="493776" cy="0"/>
+          </a:xfrm>
+          <a:prstGeom prst="line">
+            <a:avLst/>
+          </a:prstGeom>
+          <a:noFill/>
+          <a:ln w="22225">
+            <a:solidFill>
+              <a:srgbClr val="2BC4C4"/>
+            </a:solidFill>
+            <a:prstDash val="solid"/>
+            <a:tailEnd type="triangle"/>
+          </a:ln>
+        </p:spPr>
+      </p:sp>
+      <p:sp>
+        <p:nvSpPr>
+          <p:cNvPr id="18" name="Shape 16"/>
+          <p:cNvSpPr/>
+          <p:nvPr/>
+        </p:nvSpPr>
+        <p:spPr>
+          <a:xfrm flipV="1">
+            <a:off x="1417320" y="2496312"/>
+            <a:ext cx="0" cy="365760"/>
+          </a:xfrm>
+          <a:prstGeom prst="line">
+            <a:avLst/>
+          </a:prstGeom>
+          <a:noFill/>
+          <a:ln w="22225">
+            <a:solidFill>
+              <a:srgbClr val="2BC4C4"/>
+            </a:solidFill>
+            <a:prstDash val="solid"/>
+            <a:tailEnd type="triangle"/>
+          </a:ln>
+        </p:spPr>
+      </p:sp>
+      <p:sp>
+        <p:nvSpPr>
+          <p:cNvPr id="19" name="Text 17"/>
+          <p:cNvSpPr/>
+          <p:nvPr/>
+        </p:nvSpPr>
+        <p:spPr>
+          <a:xfrm>
+            <a:off x="1764792" y="2542032"/>
+            <a:ext cx="813816" cy="320040"/>
+          </a:xfrm>
+          <a:prstGeom prst="rect">
+            <a:avLst/>
+          </a:prstGeom>
+          <a:noFill/>
+          <a:ln/>
+        </p:spPr>
+        <p:txBody>
+          <a:bodyPr wrap="square" lIns="0" tIns="0" rIns="0" bIns="0" rtlCol="0" anchor="ctr"/>
+          <a:lstStyle/>
+          <a:p>
+            <a:pPr algn="ctr" indent="0" marL="0">
+              <a:buNone/>
+            </a:pPr>
+            <a:r>
+              <a:rPr lang="en-US" sz="700" i="1" dirty="0">
+                <a:solidFill>
+                  <a:srgbClr val="9A9AA0"/>
+                </a:solidFill>
+                <a:latin typeface="Arial" pitchFamily="34" charset="0"/>
+                <a:ea typeface="Arial" pitchFamily="34" charset="-122"/>
+                <a:cs typeface="Arial" pitchFamily="34" charset="-120"/>
+              </a:rPr>
+              <a:t>runs until</a:t>
+            </a:r>
+            <a:endParaRPr lang="en-US" sz="700" dirty="0"/>
+          </a:p>
+          <a:p>
+            <a:pPr algn="ctr" indent="0" marL="0">
+              <a:buNone/>
+            </a:pPr>
+            <a:r>
+              <a:rPr lang="en-US" sz="700" i="1" dirty="0">
+                <a:solidFill>
+                  <a:srgbClr val="9A9AA0"/>
+                </a:solidFill>
+                <a:latin typeface="Arial" pitchFamily="34" charset="0"/>
+                <a:ea typeface="Arial" pitchFamily="34" charset="-122"/>
+                <a:cs typeface="Arial" pitchFamily="34" charset="-120"/>
+              </a:rPr>
+              <a:t>done</a:t>
+            </a:r>
+            <a:endParaRPr lang="en-US" sz="700" dirty="0"/>
+          </a:p>
+        </p:txBody>
+      </p:sp>
+      <p:sp>
+        <p:nvSpPr>
+          <p:cNvPr id="20" name="Text 18"/>
+          <p:cNvSpPr/>
+          <p:nvPr/>
+        </p:nvSpPr>
+        <p:spPr>
+          <a:xfrm>
+            <a:off x="457200" y="3584448"/>
+            <a:ext cx="3931920" cy="292608"/>
+          </a:xfrm>
+          <a:prstGeom prst="rect">
+            <a:avLst/>
+          </a:prstGeom>
+          <a:noFill/>
+          <a:ln/>
+        </p:spPr>
+        <p:txBody>
+          <a:bodyPr wrap="square" lIns="0" tIns="0" rIns="0" bIns="0" rtlCol="0" anchor="ctr"/>
+          <a:lstStyle/>
+          <a:p>
+            <a:pPr indent="0" marL="0">
+              <a:buNone/>
+            </a:pPr>
+            <a:r>
+              <a:rPr lang="en-US" sz="1400" b="1" dirty="0">
                 <a:solidFill>
                   <a:srgbClr val="FFFFFF"/>
                 </a:solidFill>
@@ -9255,20 +9632,20 @@
               </a:rPr>
               <a:t>“My job is to write loops.”</a:t>
             </a:r>
-            <a:endParaRPr lang="en-US" sz="1500" dirty="0"/>
-          </a:p>
-        </p:txBody>
-      </p:sp>
-      <p:sp>
-        <p:nvSpPr>
-          <p:cNvPr id="9" name="Text 7"/>
-          <p:cNvSpPr/>
-          <p:nvPr/>
-        </p:nvSpPr>
-        <p:spPr>
-          <a:xfrm>
-            <a:off x="457200" y="3712464"/>
-            <a:ext cx="4206240" cy="182880"/>
+            <a:endParaRPr lang="en-US" sz="1400" dirty="0"/>
+          </a:p>
+        </p:txBody>
+      </p:sp>
+      <p:sp>
+        <p:nvSpPr>
+          <p:cNvPr id="21" name="Text 19"/>
+          <p:cNvSpPr/>
+          <p:nvPr/>
+        </p:nvSpPr>
+        <p:spPr>
+          <a:xfrm>
+            <a:off x="457200" y="3886200"/>
+            <a:ext cx="3931920" cy="182880"/>
           </a:xfrm>
           <a:prstGeom prst="rect">
             <a:avLst/>
@@ -9284,7 +9661,7 @@
               <a:buNone/>
             </a:pPr>
             <a:r>
-              <a:rPr lang="en-US" sz="800" dirty="0">
+              <a:rPr lang="en-US" sz="750" dirty="0">
                 <a:solidFill>
                   <a:srgbClr val="9A9AA0"/>
                 </a:solidFill>
@@ -9294,45 +9671,250 @@
               </a:rPr>
               <a:t>Boris Cherny — the agentic workflow in one sentence</a:t>
             </a:r>
-            <a:endParaRPr lang="en-US" sz="800" dirty="0"/>
-          </a:p>
-        </p:txBody>
-      </p:sp>
-      <p:sp>
-        <p:nvSpPr>
-          <p:cNvPr id="10" name="Shape 8"/>
-          <p:cNvSpPr/>
-          <p:nvPr/>
-        </p:nvSpPr>
-        <p:spPr>
-          <a:xfrm>
-            <a:off x="4846320" y="1627632"/>
-            <a:ext cx="3840480" cy="2377440"/>
+            <a:endParaRPr lang="en-US" sz="750" dirty="0"/>
+          </a:p>
+        </p:txBody>
+      </p:sp>
+      <p:sp>
+        <p:nvSpPr>
+          <p:cNvPr id="22" name="Text 20"/>
+          <p:cNvSpPr/>
+          <p:nvPr/>
+        </p:nvSpPr>
+        <p:spPr>
+          <a:xfrm>
+            <a:off x="4663440" y="1664208"/>
+            <a:ext cx="4023360" cy="182880"/>
+          </a:xfrm>
+          <a:prstGeom prst="rect">
+            <a:avLst/>
+          </a:prstGeom>
+          <a:noFill/>
+          <a:ln/>
+        </p:spPr>
+        <p:txBody>
+          <a:bodyPr wrap="square" lIns="0" tIns="0" rIns="0" bIns="0" rtlCol="0" anchor="ctr"/>
+          <a:lstStyle/>
+          <a:p>
+            <a:pPr indent="0" marL="0">
+              <a:buNone/>
+            </a:pPr>
+            <a:r>
+              <a:rPr lang="en-US" sz="900" b="1" spc="150" kern="0" dirty="0">
+                <a:solidFill>
+                  <a:srgbClr val="2BC4C4"/>
+                </a:solidFill>
+                <a:latin typeface="Arial" pitchFamily="34" charset="0"/>
+                <a:ea typeface="Arial" pitchFamily="34" charset="-122"/>
+                <a:cs typeface="Arial" pitchFamily="34" charset="-120"/>
+              </a:rPr>
+              <a:t>AS FRICTION FALLS, MORE GETS BUILT</a:t>
+            </a:r>
+            <a:endParaRPr lang="en-US" sz="900" dirty="0"/>
+          </a:p>
+        </p:txBody>
+      </p:sp>
+      <p:sp>
+        <p:nvSpPr>
+          <p:cNvPr id="23" name="Text 21"/>
+          <p:cNvSpPr/>
+          <p:nvPr/>
+        </p:nvSpPr>
+        <p:spPr>
+          <a:xfrm>
+            <a:off x="4663440" y="1883664"/>
+            <a:ext cx="4023360" cy="164592"/>
+          </a:xfrm>
+          <a:prstGeom prst="rect">
+            <a:avLst/>
+          </a:prstGeom>
+          <a:noFill/>
+          <a:ln/>
+        </p:spPr>
+        <p:txBody>
+          <a:bodyPr wrap="square" lIns="0" tIns="0" rIns="0" bIns="0" rtlCol="0" anchor="ctr"/>
+          <a:lstStyle/>
+          <a:p>
+            <a:pPr algn="r" indent="0" marL="0">
+              <a:buNone/>
+            </a:pPr>
+            <a:r>
+              <a:rPr lang="en-US" sz="750" i="1" dirty="0">
+                <a:solidFill>
+                  <a:srgbClr val="9A9AA0"/>
+                </a:solidFill>
+                <a:latin typeface="Arial" pitchFamily="34" charset="0"/>
+                <a:ea typeface="Arial" pitchFamily="34" charset="-122"/>
+                <a:cs typeface="Arial" pitchFamily="34" charset="-120"/>
+              </a:rPr>
+              <a:t>compute demanded ↑</a:t>
+            </a:r>
+            <a:endParaRPr lang="en-US" sz="750" dirty="0"/>
+          </a:p>
+        </p:txBody>
+      </p:sp>
+      <p:sp>
+        <p:nvSpPr>
+          <p:cNvPr id="24" name="Shape 22"/>
+          <p:cNvSpPr/>
+          <p:nvPr/>
+        </p:nvSpPr>
+        <p:spPr>
+          <a:xfrm>
+            <a:off x="4892040" y="3200400"/>
+            <a:ext cx="777240" cy="411480"/>
           </a:xfrm>
           <a:prstGeom prst="rect">
             <a:avLst/>
           </a:prstGeom>
           <a:solidFill>
-            <a:srgbClr val="1E1E24"/>
+            <a:srgbClr val="3E3E46"/>
           </a:solidFill>
-          <a:ln w="12700">
-            <a:solidFill>
-              <a:srgbClr val="2A2A30"/>
-            </a:solidFill>
-            <a:prstDash val="dash"/>
-          </a:ln>
-        </p:spPr>
-      </p:sp>
-      <p:sp>
-        <p:nvSpPr>
-          <p:cNvPr id="11" name="Shape 9"/>
-          <p:cNvSpPr/>
-          <p:nvPr/>
-        </p:nvSpPr>
-        <p:spPr>
-          <a:xfrm>
-            <a:off x="4846320" y="1627632"/>
-            <a:ext cx="310896" cy="36576"/>
+          <a:ln/>
+        </p:spPr>
+      </p:sp>
+      <p:sp>
+        <p:nvSpPr>
+          <p:cNvPr id="25" name="Text 23"/>
+          <p:cNvSpPr/>
+          <p:nvPr/>
+        </p:nvSpPr>
+        <p:spPr>
+          <a:xfrm>
+            <a:off x="4782312" y="3657600"/>
+            <a:ext cx="996696" cy="384048"/>
+          </a:xfrm>
+          <a:prstGeom prst="rect">
+            <a:avLst/>
+          </a:prstGeom>
+          <a:noFill/>
+          <a:ln/>
+        </p:spPr>
+        <p:txBody>
+          <a:bodyPr wrap="square" lIns="0" tIns="0" rIns="0" bIns="0" rtlCol="0" anchor="t"/>
+          <a:lstStyle/>
+          <a:p>
+            <a:pPr algn="ctr" indent="0" marL="0">
+              <a:buNone/>
+            </a:pPr>
+            <a:r>
+              <a:rPr lang="en-US" sz="680" dirty="0">
+                <a:solidFill>
+                  <a:srgbClr val="9A9AA0"/>
+                </a:solidFill>
+                <a:latin typeface="Arial" pitchFamily="34" charset="0"/>
+                <a:ea typeface="Arial" pitchFamily="34" charset="-122"/>
+                <a:cs typeface="Arial" pitchFamily="34" charset="-120"/>
+              </a:rPr>
+              <a:t>Internal</a:t>
+            </a:r>
+            <a:endParaRPr lang="en-US" sz="680" dirty="0"/>
+          </a:p>
+          <a:p>
+            <a:pPr algn="ctr" indent="0" marL="0">
+              <a:buNone/>
+            </a:pPr>
+            <a:r>
+              <a:rPr lang="en-US" sz="680" dirty="0">
+                <a:solidFill>
+                  <a:srgbClr val="9A9AA0"/>
+                </a:solidFill>
+                <a:latin typeface="Arial" pitchFamily="34" charset="0"/>
+                <a:ea typeface="Arial" pitchFamily="34" charset="-122"/>
+                <a:cs typeface="Arial" pitchFamily="34" charset="-120"/>
+              </a:rPr>
+              <a:t>PDF summaries</a:t>
+            </a:r>
+            <a:endParaRPr lang="en-US" sz="680" dirty="0"/>
+          </a:p>
+        </p:txBody>
+      </p:sp>
+      <p:sp>
+        <p:nvSpPr>
+          <p:cNvPr id="26" name="Shape 24"/>
+          <p:cNvSpPr/>
+          <p:nvPr/>
+        </p:nvSpPr>
+        <p:spPr>
+          <a:xfrm>
+            <a:off x="5852160" y="2834640"/>
+            <a:ext cx="777240" cy="777240"/>
+          </a:xfrm>
+          <a:prstGeom prst="rect">
+            <a:avLst/>
+          </a:prstGeom>
+          <a:solidFill>
+            <a:srgbClr val="3E3E46"/>
+          </a:solidFill>
+          <a:ln/>
+        </p:spPr>
+      </p:sp>
+      <p:sp>
+        <p:nvSpPr>
+          <p:cNvPr id="27" name="Text 25"/>
+          <p:cNvSpPr/>
+          <p:nvPr/>
+        </p:nvSpPr>
+        <p:spPr>
+          <a:xfrm>
+            <a:off x="5742432" y="3657600"/>
+            <a:ext cx="996696" cy="384048"/>
+          </a:xfrm>
+          <a:prstGeom prst="rect">
+            <a:avLst/>
+          </a:prstGeom>
+          <a:noFill/>
+          <a:ln/>
+        </p:spPr>
+        <p:txBody>
+          <a:bodyPr wrap="square" lIns="0" tIns="0" rIns="0" bIns="0" rtlCol="0" anchor="t"/>
+          <a:lstStyle/>
+          <a:p>
+            <a:pPr algn="ctr" indent="0" marL="0">
+              <a:buNone/>
+            </a:pPr>
+            <a:r>
+              <a:rPr lang="en-US" sz="680" dirty="0">
+                <a:solidFill>
+                  <a:srgbClr val="9A9AA0"/>
+                </a:solidFill>
+                <a:latin typeface="Arial" pitchFamily="34" charset="0"/>
+                <a:ea typeface="Arial" pitchFamily="34" charset="-122"/>
+                <a:cs typeface="Arial" pitchFamily="34" charset="-120"/>
+              </a:rPr>
+              <a:t>Custom</a:t>
+            </a:r>
+            <a:endParaRPr lang="en-US" sz="680" dirty="0"/>
+          </a:p>
+          <a:p>
+            <a:pPr algn="ctr" indent="0" marL="0">
+              <a:buNone/>
+            </a:pPr>
+            <a:r>
+              <a:rPr lang="en-US" sz="680" dirty="0">
+                <a:solidFill>
+                  <a:srgbClr val="9A9AA0"/>
+                </a:solidFill>
+                <a:latin typeface="Arial" pitchFamily="34" charset="0"/>
+                <a:ea typeface="Arial" pitchFamily="34" charset="-122"/>
+                <a:cs typeface="Arial" pitchFamily="34" charset="-120"/>
+              </a:rPr>
+              <a:t>dashboards</a:t>
+            </a:r>
+            <a:endParaRPr lang="en-US" sz="680" dirty="0"/>
+          </a:p>
+        </p:txBody>
+      </p:sp>
+      <p:sp>
+        <p:nvSpPr>
+          <p:cNvPr id="28" name="Shape 26"/>
+          <p:cNvSpPr/>
+          <p:nvPr/>
+        </p:nvSpPr>
+        <p:spPr>
+          <a:xfrm>
+            <a:off x="6812280" y="2468880"/>
+            <a:ext cx="777240" cy="1143000"/>
           </a:xfrm>
           <a:prstGeom prst="rect">
             <a:avLst/>
@@ -9345,14 +9927,70 @@
       </p:sp>
       <p:sp>
         <p:nvSpPr>
-          <p:cNvPr id="12" name="Shape 10"/>
-          <p:cNvSpPr/>
-          <p:nvPr/>
-        </p:nvSpPr>
-        <p:spPr>
-          <a:xfrm>
-            <a:off x="4846320" y="1627632"/>
-            <a:ext cx="36576" cy="310896"/>
+          <p:cNvPr id="29" name="Text 27"/>
+          <p:cNvSpPr/>
+          <p:nvPr/>
+        </p:nvSpPr>
+        <p:spPr>
+          <a:xfrm>
+            <a:off x="6702552" y="3657600"/>
+            <a:ext cx="996696" cy="384048"/>
+          </a:xfrm>
+          <a:prstGeom prst="rect">
+            <a:avLst/>
+          </a:prstGeom>
+          <a:noFill/>
+          <a:ln/>
+        </p:spPr>
+        <p:txBody>
+          <a:bodyPr wrap="square" lIns="0" tIns="0" rIns="0" bIns="0" rtlCol="0" anchor="t"/>
+          <a:lstStyle/>
+          <a:p>
+            <a:pPr algn="ctr" indent="0" marL="0">
+              <a:buNone/>
+            </a:pPr>
+            <a:r>
+              <a:rPr lang="en-US" sz="680" b="1" dirty="0">
+                <a:solidFill>
+                  <a:srgbClr val="FFFFFF"/>
+                </a:solidFill>
+                <a:latin typeface="Arial" pitchFamily="34" charset="0"/>
+                <a:ea typeface="Arial" pitchFamily="34" charset="-122"/>
+                <a:cs typeface="Arial" pitchFamily="34" charset="-120"/>
+              </a:rPr>
+              <a:t>Disposable</a:t>
+            </a:r>
+            <a:endParaRPr lang="en-US" sz="680" dirty="0"/>
+          </a:p>
+          <a:p>
+            <a:pPr algn="ctr" indent="0" marL="0">
+              <a:buNone/>
+            </a:pPr>
+            <a:r>
+              <a:rPr lang="en-US" sz="680" b="1" dirty="0">
+                <a:solidFill>
+                  <a:srgbClr val="FFFFFF"/>
+                </a:solidFill>
+                <a:latin typeface="Arial" pitchFamily="34" charset="0"/>
+                <a:ea typeface="Arial" pitchFamily="34" charset="-122"/>
+                <a:cs typeface="Arial" pitchFamily="34" charset="-120"/>
+              </a:rPr>
+              <a:t>web apps</a:t>
+            </a:r>
+            <a:endParaRPr lang="en-US" sz="680" dirty="0"/>
+          </a:p>
+        </p:txBody>
+      </p:sp>
+      <p:sp>
+        <p:nvSpPr>
+          <p:cNvPr id="30" name="Shape 28"/>
+          <p:cNvSpPr/>
+          <p:nvPr/>
+        </p:nvSpPr>
+        <p:spPr>
+          <a:xfrm>
+            <a:off x="7772400" y="2148840"/>
+            <a:ext cx="777240" cy="1463040"/>
           </a:xfrm>
           <a:prstGeom prst="rect">
             <a:avLst/>
@@ -9365,93 +10003,14 @@
       </p:sp>
       <p:sp>
         <p:nvSpPr>
-          <p:cNvPr id="13" name="Shape 11"/>
-          <p:cNvSpPr/>
-          <p:nvPr/>
-        </p:nvSpPr>
-        <p:spPr>
-          <a:xfrm>
-            <a:off x="8375904" y="3968496"/>
-            <a:ext cx="310896" cy="36576"/>
-          </a:xfrm>
-          <a:prstGeom prst="rect">
-            <a:avLst/>
-          </a:prstGeom>
-          <a:solidFill>
-            <a:srgbClr val="2BC4C4"/>
-          </a:solidFill>
-          <a:ln/>
-        </p:spPr>
-      </p:sp>
-      <p:sp>
-        <p:nvSpPr>
-          <p:cNvPr id="14" name="Shape 12"/>
-          <p:cNvSpPr/>
-          <p:nvPr/>
-        </p:nvSpPr>
-        <p:spPr>
-          <a:xfrm>
-            <a:off x="8650224" y="3694176"/>
-            <a:ext cx="36576" cy="310896"/>
-          </a:xfrm>
-          <a:prstGeom prst="rect">
-            <a:avLst/>
-          </a:prstGeom>
-          <a:solidFill>
-            <a:srgbClr val="2BC4C4"/>
-          </a:solidFill>
-          <a:ln/>
-        </p:spPr>
-      </p:sp>
-      <p:sp>
-        <p:nvSpPr>
-          <p:cNvPr id="15" name="Text 13"/>
-          <p:cNvSpPr/>
-          <p:nvPr/>
-        </p:nvSpPr>
-        <p:spPr>
-          <a:xfrm>
-            <a:off x="5029200" y="1773936"/>
-            <a:ext cx="3474720" cy="219456"/>
-          </a:xfrm>
-          <a:prstGeom prst="rect">
-            <a:avLst/>
-          </a:prstGeom>
-          <a:noFill/>
-          <a:ln/>
-        </p:spPr>
-        <p:txBody>
-          <a:bodyPr wrap="square" lIns="0" tIns="0" rIns="0" bIns="0" rtlCol="0" anchor="ctr"/>
-          <a:lstStyle/>
-          <a:p>
-            <a:pPr indent="0" marL="0">
-              <a:buNone/>
-            </a:pPr>
-            <a:r>
-              <a:rPr lang="en-US" sz="900" b="1" spc="200" kern="0" dirty="0">
-                <a:solidFill>
-                  <a:srgbClr val="2BC4C4"/>
-                </a:solidFill>
-                <a:latin typeface="Arial" pitchFamily="34" charset="0"/>
-                <a:ea typeface="Arial" pitchFamily="34" charset="-122"/>
-                <a:cs typeface="Arial" pitchFamily="34" charset="-120"/>
-              </a:rPr>
-              <a:t>IMAGE  ·  loop + rising demand</a:t>
-            </a:r>
-            <a:endParaRPr lang="en-US" sz="900" dirty="0"/>
-          </a:p>
-        </p:txBody>
-      </p:sp>
-      <p:sp>
-        <p:nvSpPr>
-          <p:cNvPr id="16" name="Text 14"/>
-          <p:cNvSpPr/>
-          <p:nvPr/>
-        </p:nvSpPr>
-        <p:spPr>
-          <a:xfrm>
-            <a:off x="5029200" y="2048256"/>
-            <a:ext cx="3474720" cy="1773936"/>
+          <p:cNvPr id="31" name="Text 29"/>
+          <p:cNvSpPr/>
+          <p:nvPr/>
+        </p:nvSpPr>
+        <p:spPr>
+          <a:xfrm>
+            <a:off x="7662672" y="3657600"/>
+            <a:ext cx="996696" cy="384048"/>
           </a:xfrm>
           <a:prstGeom prst="rect">
             <a:avLst/>
@@ -9463,11 +10022,91 @@
           <a:bodyPr wrap="square" lIns="0" tIns="0" rIns="0" bIns="0" rtlCol="0" anchor="t"/>
           <a:lstStyle/>
           <a:p>
-            <a:pPr indent="0" marL="0">
-              <a:buNone/>
-            </a:pPr>
-            <a:r>
-              <a:rPr lang="en-US" sz="700" i="1" dirty="0">
+            <a:pPr algn="ctr" indent="0" marL="0">
+              <a:buNone/>
+            </a:pPr>
+            <a:r>
+              <a:rPr lang="en-US" sz="680" b="1" dirty="0">
+                <a:solidFill>
+                  <a:srgbClr val="FFFFFF"/>
+                </a:solidFill>
+                <a:latin typeface="Arial" pitchFamily="34" charset="0"/>
+                <a:ea typeface="Arial" pitchFamily="34" charset="-122"/>
+                <a:cs typeface="Arial" pitchFamily="34" charset="-120"/>
+              </a:rPr>
+              <a:t>Giant research</a:t>
+            </a:r>
+            <a:endParaRPr lang="en-US" sz="680" dirty="0"/>
+          </a:p>
+          <a:p>
+            <a:pPr algn="ctr" indent="0" marL="0">
+              <a:buNone/>
+            </a:pPr>
+            <a:r>
+              <a:rPr lang="en-US" sz="680" b="1" dirty="0">
+                <a:solidFill>
+                  <a:srgbClr val="FFFFFF"/>
+                </a:solidFill>
+                <a:latin typeface="Arial" pitchFamily="34" charset="0"/>
+                <a:ea typeface="Arial" pitchFamily="34" charset="-122"/>
+                <a:cs typeface="Arial" pitchFamily="34" charset="-120"/>
+              </a:rPr>
+              <a:t>projects</a:t>
+            </a:r>
+            <a:endParaRPr lang="en-US" sz="680" dirty="0"/>
+          </a:p>
+        </p:txBody>
+      </p:sp>
+      <p:sp>
+        <p:nvSpPr>
+          <p:cNvPr id="32" name="Shape 30"/>
+          <p:cNvSpPr/>
+          <p:nvPr/>
+        </p:nvSpPr>
+        <p:spPr>
+          <a:xfrm flipV="1">
+            <a:off x="5029200" y="2103120"/>
+            <a:ext cx="3200400" cy="1097280"/>
+          </a:xfrm>
+          <a:prstGeom prst="line">
+            <a:avLst/>
+          </a:prstGeom>
+          <a:noFill/>
+          <a:ln w="25400">
+            <a:solidFill>
+              <a:srgbClr val="2BC4C4"/>
+            </a:solidFill>
+            <a:prstDash val="solid"/>
+            <a:tailEnd type="triangle"/>
+          </a:ln>
+        </p:spPr>
+      </p:sp>
+      <p:sp>
+        <p:nvSpPr>
+          <p:cNvPr id="33" name="Text 31"/>
+          <p:cNvSpPr/>
+          <p:nvPr/>
+        </p:nvSpPr>
+        <p:spPr>
+          <a:xfrm>
+            <a:off x="457200" y="4160520"/>
+            <a:ext cx="8229600" cy="384048"/>
+          </a:xfrm>
+          <a:prstGeom prst="rect">
+            <a:avLst/>
+          </a:prstGeom>
+          <a:noFill/>
+          <a:ln/>
+        </p:spPr>
+        <p:txBody>
+          <a:bodyPr wrap="square" lIns="0" tIns="0" rIns="0" bIns="0" rtlCol="0" anchor="t"/>
+          <a:lstStyle/>
+          <a:p>
+            <a:pPr indent="0" marL="0">
+              <a:buNone/>
+            </a:pPr>
+            <a:r>
+              <a:rPr lang="en-US" sz="700" dirty="0">
                 <a:solidFill>
                   <a:srgbClr val="8A8A90"/>
                 </a:solidFill>
@@ -9475,71 +10114,15 @@
                 <a:ea typeface="Arial" pitchFamily="34" charset="-122"/>
                 <a:cs typeface="Arial" pitchFamily="34" charset="-120"/>
               </a:rPr>
-              <a:t>ISOMETRIC PROMPT → save as loops-jevons.png</a:t>
+              <a:t>Source: Internal strategic review, “The 2026 AI Frontier” (Jun 2026). Cherny/Steinberger loop framing; Jevons paradox illustrative, not measured data.</a:t>
             </a:r>
             <a:endParaRPr lang="en-US" sz="700" dirty="0"/>
           </a:p>
-          <a:p>
-            <a:pPr indent="0" marL="0">
-              <a:buNone/>
-            </a:pPr>
-            <a:r>
-              <a:rPr lang="en-US" sz="850" dirty="0">
-                <a:solidFill>
-                  <a:srgbClr val="C9C9CE"/>
-                </a:solidFill>
-                <a:latin typeface="Arial" pitchFamily="34" charset="0"/>
-                <a:ea typeface="Arial" pitchFamily="34" charset="-122"/>
-                <a:cs typeface="Arial" pitchFamily="34" charset="-120"/>
-              </a:rPr>
-              <a:t>Isometric 3D illustration, an infinity-shaped pipeline of four gears labelled by position (try, fail, fix, ship) feeding an ascending staircase of glowing server-rack blocks that grows taller to the right (runaway compute demand), teal accents, near-black background, clean low-poly vector style, soft studio glow, subtle floor grid, centered, no text, no logos.</a:t>
-            </a:r>
-            <a:endParaRPr lang="en-US" sz="700" dirty="0"/>
-          </a:p>
-        </p:txBody>
-      </p:sp>
-      <p:sp>
-        <p:nvSpPr>
-          <p:cNvPr id="17" name="Text 15"/>
-          <p:cNvSpPr/>
-          <p:nvPr/>
-        </p:nvSpPr>
-        <p:spPr>
-          <a:xfrm>
-            <a:off x="457200" y="4114800"/>
-            <a:ext cx="8229600" cy="384048"/>
-          </a:xfrm>
-          <a:prstGeom prst="rect">
-            <a:avLst/>
-          </a:prstGeom>
-          <a:noFill/>
-          <a:ln/>
-        </p:spPr>
-        <p:txBody>
-          <a:bodyPr wrap="square" lIns="0" tIns="0" rIns="0" bIns="0" rtlCol="0" anchor="t"/>
-          <a:lstStyle/>
-          <a:p>
-            <a:pPr indent="0" marL="0">
-              <a:buNone/>
-            </a:pPr>
-            <a:r>
-              <a:rPr lang="en-US" sz="700" dirty="0">
-                <a:solidFill>
-                  <a:srgbClr val="8A8A90"/>
-                </a:solidFill>
-                <a:latin typeface="Arial" pitchFamily="34" charset="0"/>
-                <a:ea typeface="Arial" pitchFamily="34" charset="-122"/>
-                <a:cs typeface="Arial" pitchFamily="34" charset="-120"/>
-              </a:rPr>
-              <a:t>Source: Internal strategic review, “The 2026 AI Frontier” (Jun 2026). Cherny/Steinberger loop framing; Jevons paradox illustrative, not measured data.</a:t>
-            </a:r>
-            <a:endParaRPr lang="en-US" sz="700" dirty="0"/>
-          </a:p>
-        </p:txBody>
-      </p:sp>
-      <p:sp>
-        <p:nvSpPr>
-          <p:cNvPr id="18" name="Shape 16"/>
+        </p:txBody>
+      </p:sp>
+      <p:sp>
+        <p:nvSpPr>
+          <p:cNvPr id="34" name="Shape 32"/>
           <p:cNvSpPr/>
           <p:nvPr/>
         </p:nvSpPr>
@@ -9559,7 +10142,7 @@
       </p:sp>
       <p:sp>
         <p:nvSpPr>
-          <p:cNvPr id="19" name="Shape 17"/>
+          <p:cNvPr id="35" name="Shape 33"/>
           <p:cNvSpPr/>
           <p:nvPr/>
         </p:nvSpPr>
@@ -9582,7 +10165,7 @@
       </p:sp>
       <p:sp>
         <p:nvSpPr>
-          <p:cNvPr id="20" name="Text 18"/>
+          <p:cNvPr id="36" name="Text 34"/>
           <p:cNvSpPr/>
           <p:nvPr/>
         </p:nvSpPr>
@@ -9621,7 +10204,7 @@
       </p:sp>
       <p:sp>
         <p:nvSpPr>
-          <p:cNvPr id="21" name="Text 19"/>
+          <p:cNvPr id="37" name="Text 35"/>
           <p:cNvSpPr/>
           <p:nvPr/>
         </p:nvSpPr>
@@ -10021,7 +10604,7 @@
                 <a:ea typeface="Arial" pitchFamily="34" charset="-122"/>
                 <a:cs typeface="Arial" pitchFamily="34" charset="-120"/>
               </a:rPr>
-              <a:t>Isometric 3D illustration, a fuel-pump-style 'token budget' dispenser with a glowing numeric meter, piping metered light into a laptop while a near-empty reservoir sits behind it (scarcity), orange and gold accents, near-black background, clean low-poly vector style, soft studio glow, subtle floor grid, centered, no text, no logos.</a:t>
+              <a:t>Isometric 3D illustration, a guarded vault dispensing only a small rationed handful of glowing tokens onto a conveyor that feeds a row of waiting laptops, an 'allocation' valve throttling the flow, orange and gold accents, near-black background, clean low-poly vector style, soft studio glow, subtle floor grid, centered, no text, no logos.</a:t>
             </a:r>
             <a:endParaRPr lang="en-US" sz="700" dirty="0"/>
           </a:p>
@@ -10898,7 +11481,7 @@
                 <a:ea typeface="Arial" pitchFamily="34" charset="-122"/>
                 <a:cs typeface="Arial" pitchFamily="34" charset="-120"/>
               </a:rPr>
-              <a:t>Isometric 3D illustration, a government capitol building and a corporate AI tower linked by a glowing bridge made of equity/share certificates and a handshake, a public 'dividend' coin flowing toward small houses, purple accents, near-black background, clean low-poly vector style, soft studio glow, subtle floor grid, centered, no text, no logos.</a:t>
+              <a:t>Isometric 3D illustration, a giant government hand planting a flag bearing a percentage symbol atop a glowing server-rack skyscraper, while a chute rains small dividend coins down onto a cluster of tiny suburban houses below, purple accents, near-black background, clean low-poly vector style, soft studio glow, subtle floor grid, centered, no text, no logos.</a:t>
             </a:r>
             <a:endParaRPr lang="en-US" sz="700" dirty="0"/>
           </a:p>
@@ -12132,107 +12715,170 @@
       </p:sp>
       <p:sp>
         <p:nvSpPr>
-          <p:cNvPr id="6" name="Shape 4"/>
-          <p:cNvSpPr/>
-          <p:nvPr/>
-        </p:nvSpPr>
-        <p:spPr>
-          <a:xfrm>
-            <a:off x="457200" y="1645920"/>
-            <a:ext cx="3840480" cy="2377440"/>
-          </a:xfrm>
-          <a:prstGeom prst="rect">
-            <a:avLst/>
+          <p:cNvPr id="6" name="Text 4"/>
+          <p:cNvSpPr/>
+          <p:nvPr/>
+        </p:nvSpPr>
+        <p:spPr>
+          <a:xfrm>
+            <a:off x="457200" y="1664208"/>
+            <a:ext cx="3931920" cy="182880"/>
+          </a:xfrm>
+          <a:prstGeom prst="rect">
+            <a:avLst/>
+          </a:prstGeom>
+          <a:noFill/>
+          <a:ln/>
+        </p:spPr>
+        <p:txBody>
+          <a:bodyPr wrap="square" lIns="0" tIns="0" rIns="0" bIns="0" rtlCol="0" anchor="ctr"/>
+          <a:lstStyle/>
+          <a:p>
+            <a:pPr indent="0" marL="0">
+              <a:buNone/>
+            </a:pPr>
+            <a:r>
+              <a:rPr lang="en-US" sz="900" b="1" spc="150" kern="0" dirty="0">
+                <a:solidFill>
+                  <a:srgbClr val="2BC4C4"/>
+                </a:solidFill>
+                <a:latin typeface="Arial" pitchFamily="34" charset="0"/>
+                <a:ea typeface="Arial" pitchFamily="34" charset="-122"/>
+                <a:cs typeface="Arial" pitchFamily="34" charset="-120"/>
+              </a:rPr>
+              <a:t>ONE ORCHESTRATOR  →  N AGENTS</a:t>
+            </a:r>
+            <a:endParaRPr lang="en-US" sz="900" dirty="0"/>
+          </a:p>
+        </p:txBody>
+      </p:sp>
+      <p:sp>
+        <p:nvSpPr>
+          <p:cNvPr id="7" name="Shape 5"/>
+          <p:cNvSpPr/>
+          <p:nvPr/>
+        </p:nvSpPr>
+        <p:spPr>
+          <a:xfrm>
+            <a:off x="548640" y="2606040"/>
+            <a:ext cx="1234440" cy="731520"/>
+          </a:xfrm>
+          <a:prstGeom prst="roundRect">
+            <a:avLst>
+              <a:gd name="adj" fmla="val 7500"/>
+            </a:avLst>
           </a:prstGeom>
           <a:solidFill>
-            <a:srgbClr val="1E1E24"/>
+            <a:srgbClr val="1C1C20"/>
           </a:solidFill>
+          <a:ln w="22225">
+            <a:solidFill>
+              <a:srgbClr val="2BC4C4"/>
+            </a:solidFill>
+            <a:prstDash val="solid"/>
+          </a:ln>
+        </p:spPr>
+      </p:sp>
+      <p:sp>
+        <p:nvSpPr>
+          <p:cNvPr id="8" name="Text 6"/>
+          <p:cNvSpPr/>
+          <p:nvPr/>
+        </p:nvSpPr>
+        <p:spPr>
+          <a:xfrm>
+            <a:off x="548640" y="2606040"/>
+            <a:ext cx="1234440" cy="731520"/>
+          </a:xfrm>
+          <a:prstGeom prst="rect">
+            <a:avLst/>
+          </a:prstGeom>
+          <a:noFill/>
+          <a:ln/>
+        </p:spPr>
+        <p:txBody>
+          <a:bodyPr wrap="square" lIns="0" tIns="0" rIns="0" bIns="0" rtlCol="0" anchor="ctr"/>
+          <a:lstStyle/>
+          <a:p>
+            <a:pPr algn="ctr" indent="0" marL="0">
+              <a:buNone/>
+            </a:pPr>
+            <a:r>
+              <a:rPr lang="en-US" sz="1100" b="1" dirty="0">
+                <a:solidFill>
+                  <a:srgbClr val="FFFFFF"/>
+                </a:solidFill>
+                <a:latin typeface="Arial" pitchFamily="34" charset="0"/>
+                <a:ea typeface="Arial" pitchFamily="34" charset="-122"/>
+                <a:cs typeface="Arial" pitchFamily="34" charset="-120"/>
+              </a:rPr>
+              <a:t>YOU</a:t>
+            </a:r>
+            <a:endParaRPr lang="en-US" sz="1100" dirty="0"/>
+          </a:p>
+          <a:p>
+            <a:pPr algn="ctr" indent="0" marL="0">
+              <a:buNone/>
+            </a:pPr>
+            <a:r>
+              <a:rPr lang="en-US" sz="750" dirty="0">
+                <a:solidFill>
+                  <a:srgbClr val="2BC4C4"/>
+                </a:solidFill>
+                <a:latin typeface="Arial" pitchFamily="34" charset="0"/>
+                <a:ea typeface="Arial" pitchFamily="34" charset="-122"/>
+                <a:cs typeface="Arial" pitchFamily="34" charset="-120"/>
+              </a:rPr>
+              <a:t>orchestrator</a:t>
+            </a:r>
+            <a:endParaRPr lang="en-US" sz="1100" dirty="0"/>
+          </a:p>
+        </p:txBody>
+      </p:sp>
+      <p:sp>
+        <p:nvSpPr>
+          <p:cNvPr id="9" name="Shape 7"/>
+          <p:cNvSpPr/>
+          <p:nvPr/>
+        </p:nvSpPr>
+        <p:spPr>
+          <a:xfrm flipV="1">
+            <a:off x="1783080" y="2039112"/>
+            <a:ext cx="1188720" cy="932688"/>
+          </a:xfrm>
+          <a:prstGeom prst="line">
+            <a:avLst/>
+          </a:prstGeom>
+          <a:noFill/>
           <a:ln w="12700">
             <a:solidFill>
-              <a:srgbClr val="2A2A30"/>
+              <a:srgbClr val="9A9AA0"/>
             </a:solidFill>
-            <a:prstDash val="dash"/>
+            <a:prstDash val="solid"/>
+            <a:tailEnd type="triangle"/>
           </a:ln>
         </p:spPr>
       </p:sp>
       <p:sp>
         <p:nvSpPr>
-          <p:cNvPr id="7" name="Shape 5"/>
-          <p:cNvSpPr/>
-          <p:nvPr/>
-        </p:nvSpPr>
-        <p:spPr>
-          <a:xfrm>
-            <a:off x="457200" y="1645920"/>
-            <a:ext cx="310896" cy="36576"/>
-          </a:xfrm>
-          <a:prstGeom prst="rect">
-            <a:avLst/>
-          </a:prstGeom>
-          <a:solidFill>
-            <a:srgbClr val="2BC4C4"/>
-          </a:solidFill>
-          <a:ln/>
-        </p:spPr>
-      </p:sp>
-      <p:sp>
-        <p:nvSpPr>
-          <p:cNvPr id="8" name="Shape 6"/>
-          <p:cNvSpPr/>
-          <p:nvPr/>
-        </p:nvSpPr>
-        <p:spPr>
-          <a:xfrm>
-            <a:off x="457200" y="1645920"/>
-            <a:ext cx="36576" cy="310896"/>
-          </a:xfrm>
-          <a:prstGeom prst="rect">
-            <a:avLst/>
-          </a:prstGeom>
-          <a:solidFill>
-            <a:srgbClr val="2BC4C4"/>
-          </a:solidFill>
-          <a:ln/>
-        </p:spPr>
-      </p:sp>
-      <p:sp>
-        <p:nvSpPr>
-          <p:cNvPr id="9" name="Shape 7"/>
-          <p:cNvSpPr/>
-          <p:nvPr/>
-        </p:nvSpPr>
-        <p:spPr>
-          <a:xfrm>
-            <a:off x="3986784" y="3986784"/>
-            <a:ext cx="310896" cy="36576"/>
-          </a:xfrm>
-          <a:prstGeom prst="rect">
-            <a:avLst/>
-          </a:prstGeom>
-          <a:solidFill>
-            <a:srgbClr val="2BC4C4"/>
-          </a:solidFill>
-          <a:ln/>
-        </p:spPr>
-      </p:sp>
-      <p:sp>
-        <p:nvSpPr>
           <p:cNvPr id="10" name="Shape 8"/>
           <p:cNvSpPr/>
           <p:nvPr/>
         </p:nvSpPr>
         <p:spPr>
           <a:xfrm>
-            <a:off x="4261104" y="3712464"/>
-            <a:ext cx="36576" cy="310896"/>
-          </a:xfrm>
-          <a:prstGeom prst="rect">
-            <a:avLst/>
-          </a:prstGeom>
-          <a:solidFill>
-            <a:srgbClr val="2BC4C4"/>
-          </a:solidFill>
-          <a:ln/>
+            <a:off x="2971800" y="1810512"/>
+            <a:ext cx="1280160" cy="457200"/>
+          </a:xfrm>
+          <a:prstGeom prst="rect">
+            <a:avLst/>
+          </a:prstGeom>
+          <a:ln w="15875">
+            <a:solidFill>
+              <a:srgbClr val="2BC4C4"/>
+            </a:solidFill>
+            <a:prstDash val="solid"/>
+          </a:ln>
         </p:spPr>
       </p:sp>
       <p:sp>
@@ -12243,8 +12889,8 @@
         </p:nvSpPr>
         <p:spPr>
           <a:xfrm>
-            <a:off x="640080" y="1792224"/>
-            <a:ext cx="3474720" cy="219456"/>
+            <a:off x="2971800" y="1810512"/>
+            <a:ext cx="1280160" cy="457200"/>
           </a:xfrm>
           <a:prstGeom prst="rect">
             <a:avLst/>
@@ -12256,11 +12902,11 @@
           <a:bodyPr wrap="square" lIns="0" tIns="0" rIns="0" bIns="0" rtlCol="0" anchor="ctr"/>
           <a:lstStyle/>
           <a:p>
-            <a:pPr indent="0" marL="0">
-              <a:buNone/>
-            </a:pPr>
-            <a:r>
-              <a:rPr lang="en-US" sz="900" b="1" spc="200" kern="0" dirty="0">
+            <a:pPr algn="ctr" indent="0" marL="0">
+              <a:buNone/>
+            </a:pPr>
+            <a:r>
+              <a:rPr lang="en-US" sz="850" b="1" dirty="0">
                 <a:solidFill>
                   <a:srgbClr val="2BC4C4"/>
                 </a:solidFill>
@@ -12268,22 +12914,277 @@
                 <a:ea typeface="Arial" pitchFamily="34" charset="-122"/>
                 <a:cs typeface="Arial" pitchFamily="34" charset="-120"/>
               </a:rPr>
-              <a:t>IMAGE  ·  orchestrator + N agents</a:t>
-            </a:r>
-            <a:endParaRPr lang="en-US" sz="900" dirty="0"/>
-          </a:p>
-        </p:txBody>
-      </p:sp>
-      <p:sp>
-        <p:nvSpPr>
-          <p:cNvPr id="12" name="Text 10"/>
-          <p:cNvSpPr/>
-          <p:nvPr/>
-        </p:nvSpPr>
-        <p:spPr>
-          <a:xfrm>
-            <a:off x="640080" y="2066544"/>
-            <a:ext cx="3474720" cy="1773936"/>
+              <a:t>RESEARCH</a:t>
+            </a:r>
+            <a:endParaRPr lang="en-US" sz="850" dirty="0"/>
+          </a:p>
+        </p:txBody>
+      </p:sp>
+      <p:sp>
+        <p:nvSpPr>
+          <p:cNvPr id="12" name="Shape 10"/>
+          <p:cNvSpPr/>
+          <p:nvPr/>
+        </p:nvSpPr>
+        <p:spPr>
+          <a:xfrm flipV="1">
+            <a:off x="1783080" y="2624328"/>
+            <a:ext cx="1188720" cy="347472"/>
+          </a:xfrm>
+          <a:prstGeom prst="line">
+            <a:avLst/>
+          </a:prstGeom>
+          <a:noFill/>
+          <a:ln w="12700">
+            <a:solidFill>
+              <a:srgbClr val="9A9AA0"/>
+            </a:solidFill>
+            <a:prstDash val="solid"/>
+            <a:tailEnd type="triangle"/>
+          </a:ln>
+        </p:spPr>
+      </p:sp>
+      <p:sp>
+        <p:nvSpPr>
+          <p:cNvPr id="13" name="Shape 11"/>
+          <p:cNvSpPr/>
+          <p:nvPr/>
+        </p:nvSpPr>
+        <p:spPr>
+          <a:xfrm>
+            <a:off x="2971800" y="2395728"/>
+            <a:ext cx="1280160" cy="457200"/>
+          </a:xfrm>
+          <a:prstGeom prst="rect">
+            <a:avLst/>
+          </a:prstGeom>
+          <a:ln w="15875">
+            <a:solidFill>
+              <a:srgbClr val="2BC4C4"/>
+            </a:solidFill>
+            <a:prstDash val="solid"/>
+          </a:ln>
+        </p:spPr>
+      </p:sp>
+      <p:sp>
+        <p:nvSpPr>
+          <p:cNvPr id="14" name="Text 12"/>
+          <p:cNvSpPr/>
+          <p:nvPr/>
+        </p:nvSpPr>
+        <p:spPr>
+          <a:xfrm>
+            <a:off x="2971800" y="2395728"/>
+            <a:ext cx="1280160" cy="457200"/>
+          </a:xfrm>
+          <a:prstGeom prst="rect">
+            <a:avLst/>
+          </a:prstGeom>
+          <a:noFill/>
+          <a:ln/>
+        </p:spPr>
+        <p:txBody>
+          <a:bodyPr wrap="square" lIns="0" tIns="0" rIns="0" bIns="0" rtlCol="0" anchor="ctr"/>
+          <a:lstStyle/>
+          <a:p>
+            <a:pPr algn="ctr" indent="0" marL="0">
+              <a:buNone/>
+            </a:pPr>
+            <a:r>
+              <a:rPr lang="en-US" sz="850" b="1" dirty="0">
+                <a:solidFill>
+                  <a:srgbClr val="2BC4C4"/>
+                </a:solidFill>
+                <a:latin typeface="Arial" pitchFamily="34" charset="0"/>
+                <a:ea typeface="Arial" pitchFamily="34" charset="-122"/>
+                <a:cs typeface="Arial" pitchFamily="34" charset="-120"/>
+              </a:rPr>
+              <a:t>BUILD</a:t>
+            </a:r>
+            <a:endParaRPr lang="en-US" sz="850" dirty="0"/>
+          </a:p>
+        </p:txBody>
+      </p:sp>
+      <p:sp>
+        <p:nvSpPr>
+          <p:cNvPr id="15" name="Shape 13"/>
+          <p:cNvSpPr/>
+          <p:nvPr/>
+        </p:nvSpPr>
+        <p:spPr>
+          <a:xfrm>
+            <a:off x="1783080" y="2971800"/>
+            <a:ext cx="1188720" cy="237744"/>
+          </a:xfrm>
+          <a:prstGeom prst="line">
+            <a:avLst/>
+          </a:prstGeom>
+          <a:noFill/>
+          <a:ln w="12700">
+            <a:solidFill>
+              <a:srgbClr val="9A9AA0"/>
+            </a:solidFill>
+            <a:prstDash val="solid"/>
+            <a:tailEnd type="triangle"/>
+          </a:ln>
+        </p:spPr>
+      </p:sp>
+      <p:sp>
+        <p:nvSpPr>
+          <p:cNvPr id="16" name="Shape 14"/>
+          <p:cNvSpPr/>
+          <p:nvPr/>
+        </p:nvSpPr>
+        <p:spPr>
+          <a:xfrm>
+            <a:off x="2971800" y="2980944"/>
+            <a:ext cx="1280160" cy="457200"/>
+          </a:xfrm>
+          <a:prstGeom prst="rect">
+            <a:avLst/>
+          </a:prstGeom>
+          <a:ln w="15875">
+            <a:solidFill>
+              <a:srgbClr val="2BC4C4"/>
+            </a:solidFill>
+            <a:prstDash val="solid"/>
+          </a:ln>
+        </p:spPr>
+      </p:sp>
+      <p:sp>
+        <p:nvSpPr>
+          <p:cNvPr id="17" name="Text 15"/>
+          <p:cNvSpPr/>
+          <p:nvPr/>
+        </p:nvSpPr>
+        <p:spPr>
+          <a:xfrm>
+            <a:off x="2971800" y="2980944"/>
+            <a:ext cx="1280160" cy="457200"/>
+          </a:xfrm>
+          <a:prstGeom prst="rect">
+            <a:avLst/>
+          </a:prstGeom>
+          <a:noFill/>
+          <a:ln/>
+        </p:spPr>
+        <p:txBody>
+          <a:bodyPr wrap="square" lIns="0" tIns="0" rIns="0" bIns="0" rtlCol="0" anchor="ctr"/>
+          <a:lstStyle/>
+          <a:p>
+            <a:pPr algn="ctr" indent="0" marL="0">
+              <a:buNone/>
+            </a:pPr>
+            <a:r>
+              <a:rPr lang="en-US" sz="850" b="1" dirty="0">
+                <a:solidFill>
+                  <a:srgbClr val="2BC4C4"/>
+                </a:solidFill>
+                <a:latin typeface="Arial" pitchFamily="34" charset="0"/>
+                <a:ea typeface="Arial" pitchFamily="34" charset="-122"/>
+                <a:cs typeface="Arial" pitchFamily="34" charset="-120"/>
+              </a:rPr>
+              <a:t>TEST</a:t>
+            </a:r>
+            <a:endParaRPr lang="en-US" sz="850" dirty="0"/>
+          </a:p>
+        </p:txBody>
+      </p:sp>
+      <p:sp>
+        <p:nvSpPr>
+          <p:cNvPr id="18" name="Shape 16"/>
+          <p:cNvSpPr/>
+          <p:nvPr/>
+        </p:nvSpPr>
+        <p:spPr>
+          <a:xfrm>
+            <a:off x="1783080" y="2971800"/>
+            <a:ext cx="1188720" cy="822960"/>
+          </a:xfrm>
+          <a:prstGeom prst="line">
+            <a:avLst/>
+          </a:prstGeom>
+          <a:noFill/>
+          <a:ln w="12700">
+            <a:solidFill>
+              <a:srgbClr val="9A9AA0"/>
+            </a:solidFill>
+            <a:prstDash val="solid"/>
+            <a:tailEnd type="triangle"/>
+          </a:ln>
+        </p:spPr>
+      </p:sp>
+      <p:sp>
+        <p:nvSpPr>
+          <p:cNvPr id="19" name="Shape 17"/>
+          <p:cNvSpPr/>
+          <p:nvPr/>
+        </p:nvSpPr>
+        <p:spPr>
+          <a:xfrm>
+            <a:off x="2971800" y="3566160"/>
+            <a:ext cx="1280160" cy="457200"/>
+          </a:xfrm>
+          <a:prstGeom prst="rect">
+            <a:avLst/>
+          </a:prstGeom>
+          <a:ln w="15875">
+            <a:solidFill>
+              <a:srgbClr val="2BC4C4"/>
+            </a:solidFill>
+            <a:prstDash val="solid"/>
+          </a:ln>
+        </p:spPr>
+      </p:sp>
+      <p:sp>
+        <p:nvSpPr>
+          <p:cNvPr id="20" name="Text 18"/>
+          <p:cNvSpPr/>
+          <p:nvPr/>
+        </p:nvSpPr>
+        <p:spPr>
+          <a:xfrm>
+            <a:off x="2971800" y="3566160"/>
+            <a:ext cx="1280160" cy="457200"/>
+          </a:xfrm>
+          <a:prstGeom prst="rect">
+            <a:avLst/>
+          </a:prstGeom>
+          <a:noFill/>
+          <a:ln/>
+        </p:spPr>
+        <p:txBody>
+          <a:bodyPr wrap="square" lIns="0" tIns="0" rIns="0" bIns="0" rtlCol="0" anchor="ctr"/>
+          <a:lstStyle/>
+          <a:p>
+            <a:pPr algn="ctr" indent="0" marL="0">
+              <a:buNone/>
+            </a:pPr>
+            <a:r>
+              <a:rPr lang="en-US" sz="850" b="1" dirty="0">
+                <a:solidFill>
+                  <a:srgbClr val="2BC4C4"/>
+                </a:solidFill>
+                <a:latin typeface="Arial" pitchFamily="34" charset="0"/>
+                <a:ea typeface="Arial" pitchFamily="34" charset="-122"/>
+                <a:cs typeface="Arial" pitchFamily="34" charset="-120"/>
+              </a:rPr>
+              <a:t>SHIP</a:t>
+            </a:r>
+            <a:endParaRPr lang="en-US" sz="850" dirty="0"/>
+          </a:p>
+        </p:txBody>
+      </p:sp>
+      <p:sp>
+        <p:nvSpPr>
+          <p:cNvPr id="21" name="Text 19"/>
+          <p:cNvSpPr/>
+          <p:nvPr/>
+        </p:nvSpPr>
+        <p:spPr>
+          <a:xfrm>
+            <a:off x="548640" y="3675888"/>
+            <a:ext cx="2286000" cy="457200"/>
           </a:xfrm>
           <a:prstGeom prst="rect">
             <a:avLst/>
@@ -12299,40 +13200,23 @@
               <a:buNone/>
             </a:pPr>
             <a:r>
-              <a:rPr lang="en-US" sz="700" i="1" dirty="0">
-                <a:solidFill>
-                  <a:srgbClr val="8A8A90"/>
-                </a:solidFill>
-                <a:latin typeface="Arial" pitchFamily="34" charset="0"/>
-                <a:ea typeface="Arial" pitchFamily="34" charset="-122"/>
-                <a:cs typeface="Arial" pitchFamily="34" charset="-120"/>
-              </a:rPr>
-              <a:t>ISOMETRIC PROMPT → save as labor-orchestrator.png</a:t>
-            </a:r>
-            <a:endParaRPr lang="en-US" sz="700" dirty="0"/>
-          </a:p>
-          <a:p>
-            <a:pPr indent="0" marL="0">
-              <a:buNone/>
-            </a:pPr>
-            <a:r>
-              <a:rPr lang="en-US" sz="850" dirty="0">
-                <a:solidFill>
-                  <a:srgbClr val="C9C9CE"/>
-                </a:solidFill>
-                <a:latin typeface="Arial" pitchFamily="34" charset="0"/>
-                <a:ea typeface="Arial" pitchFamily="34" charset="-122"/>
-                <a:cs typeface="Arial" pitchFamily="34" charset="-120"/>
-              </a:rPr>
-              <a:t>Isometric 3D illustration, a single human at a control console directing a fan-out of many small agent-robots working in parallel on research, build, test and ship tasks, glowing connection lines, teal accents, near-black background, clean low-poly vector style, soft studio glow, subtle floor grid, centered, no text, no logos.</a:t>
-            </a:r>
-            <a:endParaRPr lang="en-US" sz="700" dirty="0"/>
-          </a:p>
-        </p:txBody>
-      </p:sp>
-      <p:sp>
-        <p:nvSpPr>
-          <p:cNvPr id="13" name="Shape 11"/>
+              <a:rPr lang="en-US" sz="800" i="1" dirty="0">
+                <a:solidFill>
+                  <a:srgbClr val="9A9AA0"/>
+                </a:solidFill>
+                <a:latin typeface="Arial" pitchFamily="34" charset="0"/>
+                <a:ea typeface="Arial" pitchFamily="34" charset="-122"/>
+                <a:cs typeface="Arial" pitchFamily="34" charset="-120"/>
+              </a:rPr>
+              <a:t>one person now outputs like a team</a:t>
+            </a:r>
+            <a:endParaRPr lang="en-US" sz="800" dirty="0"/>
+          </a:p>
+        </p:txBody>
+      </p:sp>
+      <p:sp>
+        <p:nvSpPr>
+          <p:cNvPr id="22" name="Shape 20"/>
           <p:cNvSpPr/>
           <p:nvPr/>
         </p:nvSpPr>
@@ -12352,7 +13236,7 @@
       </p:sp>
       <p:sp>
         <p:nvSpPr>
-          <p:cNvPr id="14" name="Text 12"/>
+          <p:cNvPr id="23" name="Text 21"/>
           <p:cNvSpPr/>
           <p:nvPr/>
         </p:nvSpPr>
@@ -12408,7 +13292,7 @@
       </p:sp>
       <p:sp>
         <p:nvSpPr>
-          <p:cNvPr id="15" name="Shape 13"/>
+          <p:cNvPr id="24" name="Shape 22"/>
           <p:cNvSpPr/>
           <p:nvPr/>
         </p:nvSpPr>
@@ -12428,7 +13312,7 @@
       </p:sp>
       <p:sp>
         <p:nvSpPr>
-          <p:cNvPr id="16" name="Text 14"/>
+          <p:cNvPr id="25" name="Text 23"/>
           <p:cNvSpPr/>
           <p:nvPr/>
         </p:nvSpPr>
@@ -12484,7 +13368,7 @@
       </p:sp>
       <p:sp>
         <p:nvSpPr>
-          <p:cNvPr id="17" name="Shape 15"/>
+          <p:cNvPr id="26" name="Shape 24"/>
           <p:cNvSpPr/>
           <p:nvPr/>
         </p:nvSpPr>
@@ -12504,7 +13388,7 @@
       </p:sp>
       <p:sp>
         <p:nvSpPr>
-          <p:cNvPr id="18" name="Text 16"/>
+          <p:cNvPr id="27" name="Text 25"/>
           <p:cNvSpPr/>
           <p:nvPr/>
         </p:nvSpPr>
@@ -12560,7 +13444,7 @@
       </p:sp>
       <p:sp>
         <p:nvSpPr>
-          <p:cNvPr id="19" name="Text 17"/>
+          <p:cNvPr id="28" name="Text 26"/>
           <p:cNvSpPr/>
           <p:nvPr/>
         </p:nvSpPr>
@@ -12599,7 +13483,7 @@
       </p:sp>
       <p:sp>
         <p:nvSpPr>
-          <p:cNvPr id="20" name="Shape 18"/>
+          <p:cNvPr id="29" name="Shape 27"/>
           <p:cNvSpPr/>
           <p:nvPr/>
         </p:nvSpPr>
@@ -12619,7 +13503,7 @@
       </p:sp>
       <p:sp>
         <p:nvSpPr>
-          <p:cNvPr id="21" name="Shape 19"/>
+          <p:cNvPr id="30" name="Shape 28"/>
           <p:cNvSpPr/>
           <p:nvPr/>
         </p:nvSpPr>
@@ -12642,7 +13526,7 @@
       </p:sp>
       <p:sp>
         <p:nvSpPr>
-          <p:cNvPr id="22" name="Text 20"/>
+          <p:cNvPr id="31" name="Text 29"/>
           <p:cNvSpPr/>
           <p:nvPr/>
         </p:nvSpPr>
@@ -12681,7 +13565,7 @@
       </p:sp>
       <p:sp>
         <p:nvSpPr>
-          <p:cNvPr id="23" name="Text 21"/>
+          <p:cNvPr id="32" name="Text 30"/>
           <p:cNvSpPr/>
           <p:nvPr/>
         </p:nvSpPr>

</xml_diff>

<commit_message>
Slide 2 -> native from->to diagrams; de-isometric the image prompts
- Slide 2's three shift icons replaced with native, labeled FROM -> TO transition cards (capability/economics/policy), cohesive with the slide 4 & 8 infographics. Removes the 3 shift-*.png image slots.
- Image-prompt style changed from isometric to clean modern editorial illustration with natural perspective; STYLE/STYLE_TAIL constants + IMAGE_PROMPTS_V3.md updated.
- 7 image slots remain (cover, token, gov-stake, frontier x4), each rendering an on-slide placeholder until generated.
- Rebuilt: valid 12-slide pptx + slides-data.js.

WIP on this branch -- re-export the JPGs before merging to main.

Co-Authored-By: Claude Opus 4.8 <noreply@anthropic.com>
</commit_message>
<xml_diff>
--- a/ai-markets-deck.pptx
+++ b/ai-markets-deck.pptx
@@ -2761,7 +2761,7 @@
                 <a:ea typeface="Arial" pitchFamily="34" charset="-122"/>
                 <a:cs typeface="Arial" pitchFamily="34" charset="-120"/>
               </a:rPr>
-              <a:t>ISOMETRIC PROMPT → save as cover.png</a:t>
+              <a:t>IMAGE PROMPT → save as cover.png</a:t>
             </a:r>
             <a:endParaRPr lang="en-US" sz="700" dirty="0"/>
           </a:p>
@@ -2778,7 +2778,7 @@
                 <a:ea typeface="Arial" pitchFamily="34" charset="-122"/>
                 <a:cs typeface="Arial" pitchFamily="34" charset="-120"/>
               </a:rPr>
-              <a:t>Isometric 3D illustration, a financial district at night where the skyscrapers are stacked GPU server-racks; a glowing candlestick stock-chart runs like a road along their base, and a curved arrow of capital flows from a domed bank building into the single tallest GPU tower; orange and yellow accents, near-black background, clean low-poly vector style, soft studio glow, subtle floor grid, centered, no text, no logos.</a:t>
+              <a:t>Clean modern editorial illustration with natural perspective (not isometric), a financial district at night where the skyscrapers are stacked GPU server-racks; a glowing candlestick stock-chart runs like a road along their base, and a curved arrow of capital flows from a domed bank building into the single tallest GPU tower; orange and yellow accents, on a near-black background, soft cinematic studio lighting, minimal and polished, single centered subject, no text, no words, no logos.</a:t>
             </a:r>
             <a:endParaRPr lang="en-US" sz="700" dirty="0"/>
           </a:p>
@@ -4143,7 +4143,7 @@
                 <a:ea typeface="Arial" pitchFamily="34" charset="-122"/>
                 <a:cs typeface="Arial" pitchFamily="34" charset="-120"/>
               </a:rPr>
-              <a:t>ISOMETRIC PROMPT → save as frontier-embodiment.png</a:t>
+              <a:t>IMAGE PROMPT → save as frontier-embodiment.png</a:t>
             </a:r>
             <a:endParaRPr lang="en-US" sz="700" dirty="0"/>
           </a:p>
@@ -4160,7 +4160,7 @@
                 <a:ea typeface="Arial" pitchFamily="34" charset="-122"/>
                 <a:cs typeface="Arial" pitchFamily="34" charset="-120"/>
               </a:rPr>
-              <a:t>Isometric 3D illustration, a humanoid robot carrying a labeled tote down a numbered warehouse aisle lined with shelving racks, mid-stride, pink accents, near-black background, clean low-poly vector style, soft studio glow, subtle floor grid, centered, no text, no logos.</a:t>
+              <a:t>Clean modern editorial illustration with natural perspective (not isometric), a humanoid robot carrying a labeled tote down a numbered warehouse aisle lined with shelving racks, mid-stride, pink accents, on a near-black background, soft cinematic studio lighting, minimal and polished, single centered subject, no text, no words, no logos.</a:t>
             </a:r>
             <a:endParaRPr lang="en-US" sz="700" dirty="0"/>
           </a:p>
@@ -4439,7 +4439,7 @@
                 <a:ea typeface="Arial" pitchFamily="34" charset="-122"/>
                 <a:cs typeface="Arial" pitchFamily="34" charset="-120"/>
               </a:rPr>
-              <a:t>ISOMETRIC PROMPT → save as frontier-wheels.png</a:t>
+              <a:t>IMAGE PROMPT → save as frontier-wheels.png</a:t>
             </a:r>
             <a:endParaRPr lang="en-US" sz="700" dirty="0"/>
           </a:p>
@@ -4456,7 +4456,7 @@
                 <a:ea typeface="Arial" pitchFamily="34" charset="-122"/>
                 <a:cs typeface="Arial" pitchFamily="34" charset="-120"/>
               </a:rPr>
-              <a:t>Isometric 3D illustration, a driverless robotaxi with a spinning lidar turret and glowing sensor cones stopped at a small city intersection with a traffic light and crosswalk, pink accents, near-black background, clean low-poly vector style, soft studio glow, subtle floor grid, centered, no text, no logos.</a:t>
+              <a:t>Clean modern editorial illustration with natural perspective (not isometric), a driverless robotaxi with a spinning lidar turret and glowing sensor cones stopped at a small city intersection with a traffic light and crosswalk, pink accents, on a near-black background, soft cinematic studio lighting, minimal and polished, single centered subject, no text, no words, no logos.</a:t>
             </a:r>
             <a:endParaRPr lang="en-US" sz="700" dirty="0"/>
           </a:p>
@@ -4735,7 +4735,7 @@
                 <a:ea typeface="Arial" pitchFamily="34" charset="-122"/>
                 <a:cs typeface="Arial" pitchFamily="34" charset="-120"/>
               </a:rPr>
-              <a:t>ISOMETRIC PROMPT → save as frontier-orbit.png</a:t>
+              <a:t>IMAGE PROMPT → save as frontier-orbit.png</a:t>
             </a:r>
             <a:endParaRPr lang="en-US" sz="700" dirty="0"/>
           </a:p>
@@ -4752,7 +4752,7 @@
                 <a:ea typeface="Arial" pitchFamily="34" charset="-122"/>
                 <a:cs typeface="Arial" pitchFamily="34" charset="-120"/>
               </a:rPr>
-              <a:t>Isometric 3D illustration, a ring-shaped orbital data-center with unfolded solar-panel wings and server modules, floating above the curved horizon of Earth with sparse stars, pink accents, near-black background, clean low-poly vector style, soft studio glow, subtle floor grid, centered, no text, no logos.</a:t>
+              <a:t>Clean modern editorial illustration with natural perspective (not isometric), a ring-shaped orbital data-center with unfolded solar-panel wings and server modules, floating above the curved horizon of Earth with sparse stars, pink accents, on a near-black background, soft cinematic studio lighting, minimal and polished, single centered subject, no text, no words, no logos.</a:t>
             </a:r>
             <a:endParaRPr lang="en-US" sz="700" dirty="0"/>
           </a:p>
@@ -5031,7 +5031,7 @@
                 <a:ea typeface="Arial" pitchFamily="34" charset="-122"/>
                 <a:cs typeface="Arial" pitchFamily="34" charset="-120"/>
               </a:rPr>
-              <a:t>ISOMETRIC PROMPT → save as frontier-proteins.png</a:t>
+              <a:t>IMAGE PROMPT → save as frontier-proteins.png</a:t>
             </a:r>
             <a:endParaRPr lang="en-US" sz="700" dirty="0"/>
           </a:p>
@@ -5048,7 +5048,7 @@
                 <a:ea typeface="Arial" pitchFamily="34" charset="-122"/>
                 <a:cs typeface="Arial" pitchFamily="34" charset="-120"/>
               </a:rPr>
-              <a:t>Isometric 3D illustration, a robotic pipette arm in a lab assembling a glowing folded-protein ribbon and double-helix on a sample platform, small vials arranged around it, pink accents, near-black background, clean low-poly vector style, soft studio glow, subtle floor grid, centered, no text, no logos.</a:t>
+              <a:t>Clean modern editorial illustration with natural perspective (not isometric), a robotic pipette arm in a lab assembling a glowing folded-protein ribbon and double-helix on a sample platform, small vials arranged around it, pink accents, on a near-black background, soft cinematic studio lighting, minimal and polished, single centered subject, no text, no words, no logos.</a:t>
             </a:r>
             <a:endParaRPr lang="en-US" sz="700" dirty="0"/>
           </a:p>
@@ -6464,13 +6464,53 @@
       </p:sp>
       <p:sp>
         <p:nvSpPr>
-          <p:cNvPr id="4" name="Text 2"/>
-          <p:cNvSpPr/>
-          <p:nvPr/>
-        </p:nvSpPr>
-        <p:spPr>
-          <a:xfrm>
-            <a:off x="457200" y="1463040"/>
+          <p:cNvPr id="4" name="Shape 2"/>
+          <p:cNvSpPr/>
+          <p:nvPr/>
+        </p:nvSpPr>
+        <p:spPr>
+          <a:xfrm>
+            <a:off x="457200" y="1481328"/>
+            <a:ext cx="2697480" cy="2395728"/>
+          </a:xfrm>
+          <a:prstGeom prst="rect">
+            <a:avLst/>
+          </a:prstGeom>
+          <a:solidFill>
+            <a:srgbClr val="1C1C20"/>
+          </a:solidFill>
+          <a:ln/>
+        </p:spPr>
+      </p:sp>
+      <p:sp>
+        <p:nvSpPr>
+          <p:cNvPr id="5" name="Shape 3"/>
+          <p:cNvSpPr/>
+          <p:nvPr/>
+        </p:nvSpPr>
+        <p:spPr>
+          <a:xfrm>
+            <a:off x="457200" y="1481328"/>
+            <a:ext cx="2697480" cy="45720"/>
+          </a:xfrm>
+          <a:prstGeom prst="rect">
+            <a:avLst/>
+          </a:prstGeom>
+          <a:solidFill>
+            <a:srgbClr val="2BC4C4"/>
+          </a:solidFill>
+          <a:ln/>
+        </p:spPr>
+      </p:sp>
+      <p:sp>
+        <p:nvSpPr>
+          <p:cNvPr id="6" name="Text 4"/>
+          <p:cNvSpPr/>
+          <p:nvPr/>
+        </p:nvSpPr>
+        <p:spPr>
+          <a:xfrm>
+            <a:off x="457200" y="1627632"/>
             <a:ext cx="2697480" cy="182880"/>
           </a:xfrm>
           <a:prstGeom prst="rect">
@@ -6503,17 +6543,19 @@
       </p:sp>
       <p:sp>
         <p:nvSpPr>
-          <p:cNvPr id="5" name="Shape 3"/>
-          <p:cNvSpPr/>
-          <p:nvPr/>
-        </p:nvSpPr>
-        <p:spPr>
-          <a:xfrm>
-            <a:off x="457200" y="1700784"/>
-            <a:ext cx="2697480" cy="1417320"/>
-          </a:xfrm>
-          <a:prstGeom prst="rect">
-            <a:avLst/>
+          <p:cNvPr id="7" name="Shape 5"/>
+          <p:cNvSpPr/>
+          <p:nvPr/>
+        </p:nvSpPr>
+        <p:spPr>
+          <a:xfrm>
+            <a:off x="868680" y="1938528"/>
+            <a:ext cx="1874520" cy="384048"/>
+          </a:xfrm>
+          <a:prstGeom prst="roundRect">
+            <a:avLst>
+              <a:gd name="adj" fmla="val 11905"/>
+            </a:avLst>
           </a:prstGeom>
           <a:solidFill>
             <a:srgbClr val="1E1E24"/>
@@ -6522,100 +6564,228 @@
             <a:solidFill>
               <a:srgbClr val="2A2A30"/>
             </a:solidFill>
-            <a:prstDash val="dash"/>
+            <a:prstDash val="solid"/>
           </a:ln>
         </p:spPr>
       </p:sp>
       <p:sp>
         <p:nvSpPr>
-          <p:cNvPr id="6" name="Shape 4"/>
-          <p:cNvSpPr/>
-          <p:nvPr/>
-        </p:nvSpPr>
-        <p:spPr>
-          <a:xfrm>
-            <a:off x="457200" y="1700784"/>
-            <a:ext cx="310896" cy="36576"/>
-          </a:xfrm>
-          <a:prstGeom prst="rect">
-            <a:avLst/>
+          <p:cNvPr id="8" name="Text 6"/>
+          <p:cNvSpPr/>
+          <p:nvPr/>
+        </p:nvSpPr>
+        <p:spPr>
+          <a:xfrm>
+            <a:off x="868680" y="1938528"/>
+            <a:ext cx="1874520" cy="384048"/>
+          </a:xfrm>
+          <a:prstGeom prst="rect">
+            <a:avLst/>
+          </a:prstGeom>
+          <a:noFill/>
+          <a:ln/>
+        </p:spPr>
+        <p:txBody>
+          <a:bodyPr wrap="square" lIns="0" tIns="0" rIns="0" bIns="0" rtlCol="0" anchor="ctr"/>
+          <a:lstStyle/>
+          <a:p>
+            <a:pPr algn="ctr" indent="0" marL="0">
+              <a:buNone/>
+            </a:pPr>
+            <a:r>
+              <a:rPr lang="en-US" sz="950" dirty="0">
+                <a:solidFill>
+                  <a:srgbClr val="9A9AA0"/>
+                </a:solidFill>
+                <a:latin typeface="Arial" pitchFamily="34" charset="0"/>
+                <a:ea typeface="Arial" pitchFamily="34" charset="-122"/>
+                <a:cs typeface="Arial" pitchFamily="34" charset="-120"/>
+              </a:rPr>
+              <a:t>Linear chat</a:t>
+            </a:r>
+            <a:endParaRPr lang="en-US" sz="950" dirty="0"/>
+          </a:p>
+        </p:txBody>
+      </p:sp>
+      <p:sp>
+        <p:nvSpPr>
+          <p:cNvPr id="9" name="Shape 7"/>
+          <p:cNvSpPr/>
+          <p:nvPr/>
+        </p:nvSpPr>
+        <p:spPr>
+          <a:xfrm>
+            <a:off x="1805940" y="2359152"/>
+            <a:ext cx="0" cy="237744"/>
+          </a:xfrm>
+          <a:prstGeom prst="line">
+            <a:avLst/>
+          </a:prstGeom>
+          <a:noFill/>
+          <a:ln w="25400">
+            <a:solidFill>
+              <a:srgbClr val="2BC4C4"/>
+            </a:solidFill>
+            <a:prstDash val="solid"/>
+            <a:tailEnd type="triangle"/>
+          </a:ln>
+        </p:spPr>
+      </p:sp>
+      <p:sp>
+        <p:nvSpPr>
+          <p:cNvPr id="10" name="Shape 8"/>
+          <p:cNvSpPr/>
+          <p:nvPr/>
+        </p:nvSpPr>
+        <p:spPr>
+          <a:xfrm>
+            <a:off x="868680" y="2633472"/>
+            <a:ext cx="1874520" cy="384048"/>
+          </a:xfrm>
+          <a:prstGeom prst="roundRect">
+            <a:avLst>
+              <a:gd name="adj" fmla="val 11905"/>
+            </a:avLst>
           </a:prstGeom>
           <a:solidFill>
-            <a:srgbClr val="2BC4C4"/>
+            <a:srgbClr val="1C1C20"/>
           </a:solidFill>
-          <a:ln/>
-        </p:spPr>
-      </p:sp>
-      <p:sp>
-        <p:nvSpPr>
-          <p:cNvPr id="7" name="Shape 5"/>
-          <p:cNvSpPr/>
-          <p:nvPr/>
-        </p:nvSpPr>
-        <p:spPr>
-          <a:xfrm>
-            <a:off x="457200" y="1700784"/>
-            <a:ext cx="36576" cy="310896"/>
+          <a:ln w="19050">
+            <a:solidFill>
+              <a:srgbClr val="2BC4C4"/>
+            </a:solidFill>
+            <a:prstDash val="solid"/>
+          </a:ln>
+        </p:spPr>
+      </p:sp>
+      <p:sp>
+        <p:nvSpPr>
+          <p:cNvPr id="11" name="Text 9"/>
+          <p:cNvSpPr/>
+          <p:nvPr/>
+        </p:nvSpPr>
+        <p:spPr>
+          <a:xfrm>
+            <a:off x="868680" y="2633472"/>
+            <a:ext cx="1874520" cy="384048"/>
+          </a:xfrm>
+          <a:prstGeom prst="rect">
+            <a:avLst/>
+          </a:prstGeom>
+          <a:noFill/>
+          <a:ln/>
+        </p:spPr>
+        <p:txBody>
+          <a:bodyPr wrap="square" lIns="0" tIns="0" rIns="0" bIns="0" rtlCol="0" anchor="ctr"/>
+          <a:lstStyle/>
+          <a:p>
+            <a:pPr algn="ctr" indent="0" marL="0">
+              <a:buNone/>
+            </a:pPr>
+            <a:r>
+              <a:rPr lang="en-US" sz="950" b="1" dirty="0">
+                <a:solidFill>
+                  <a:srgbClr val="FFFFFF"/>
+                </a:solidFill>
+                <a:latin typeface="Arial" pitchFamily="34" charset="0"/>
+                <a:ea typeface="Arial" pitchFamily="34" charset="-122"/>
+                <a:cs typeface="Arial" pitchFamily="34" charset="-120"/>
+              </a:rPr>
+              <a:t>Autonomous loops</a:t>
+            </a:r>
+            <a:endParaRPr lang="en-US" sz="950" dirty="0"/>
+          </a:p>
+        </p:txBody>
+      </p:sp>
+      <p:sp>
+        <p:nvSpPr>
+          <p:cNvPr id="12" name="Text 10"/>
+          <p:cNvSpPr/>
+          <p:nvPr/>
+        </p:nvSpPr>
+        <p:spPr>
+          <a:xfrm>
+            <a:off x="621792" y="3163824"/>
+            <a:ext cx="2368296" cy="658368"/>
+          </a:xfrm>
+          <a:prstGeom prst="rect">
+            <a:avLst/>
+          </a:prstGeom>
+          <a:noFill/>
+          <a:ln/>
+        </p:spPr>
+        <p:txBody>
+          <a:bodyPr wrap="square" lIns="0" tIns="0" rIns="0" bIns="0" rtlCol="0" anchor="t"/>
+          <a:lstStyle/>
+          <a:p>
+            <a:pPr algn="ctr" indent="0" marL="0">
+              <a:buNone/>
+            </a:pPr>
+            <a:r>
+              <a:rPr lang="en-US" sz="850" dirty="0">
+                <a:solidFill>
+                  <a:srgbClr val="9A9AA0"/>
+                </a:solidFill>
+                <a:latin typeface="Arial" pitchFamily="34" charset="0"/>
+                <a:ea typeface="Arial" pitchFamily="34" charset="-122"/>
+                <a:cs typeface="Arial" pitchFamily="34" charset="-120"/>
+              </a:rPr>
+              <a:t>Models became self-correcting agents that run until the task is done.</a:t>
+            </a:r>
+            <a:endParaRPr lang="en-US" sz="850" dirty="0"/>
+          </a:p>
+        </p:txBody>
+      </p:sp>
+      <p:sp>
+        <p:nvSpPr>
+          <p:cNvPr id="13" name="Shape 11"/>
+          <p:cNvSpPr/>
+          <p:nvPr/>
+        </p:nvSpPr>
+        <p:spPr>
+          <a:xfrm>
+            <a:off x="3264408" y="1481328"/>
+            <a:ext cx="2697480" cy="2395728"/>
           </a:xfrm>
           <a:prstGeom prst="rect">
             <a:avLst/>
           </a:prstGeom>
           <a:solidFill>
-            <a:srgbClr val="2BC4C4"/>
+            <a:srgbClr val="1C1C20"/>
           </a:solidFill>
           <a:ln/>
         </p:spPr>
       </p:sp>
       <p:sp>
         <p:nvSpPr>
-          <p:cNvPr id="8" name="Shape 6"/>
-          <p:cNvSpPr/>
-          <p:nvPr/>
-        </p:nvSpPr>
-        <p:spPr>
-          <a:xfrm>
-            <a:off x="2843784" y="3081528"/>
-            <a:ext cx="310896" cy="36576"/>
+          <p:cNvPr id="14" name="Shape 12"/>
+          <p:cNvSpPr/>
+          <p:nvPr/>
+        </p:nvSpPr>
+        <p:spPr>
+          <a:xfrm>
+            <a:off x="3264408" y="1481328"/>
+            <a:ext cx="2697480" cy="45720"/>
           </a:xfrm>
           <a:prstGeom prst="rect">
             <a:avLst/>
           </a:prstGeom>
           <a:solidFill>
-            <a:srgbClr val="2BC4C4"/>
+            <a:srgbClr val="F6693D"/>
           </a:solidFill>
           <a:ln/>
         </p:spPr>
       </p:sp>
       <p:sp>
         <p:nvSpPr>
-          <p:cNvPr id="9" name="Shape 7"/>
-          <p:cNvSpPr/>
-          <p:nvPr/>
-        </p:nvSpPr>
-        <p:spPr>
-          <a:xfrm>
-            <a:off x="3118104" y="2807208"/>
-            <a:ext cx="36576" cy="310896"/>
-          </a:xfrm>
-          <a:prstGeom prst="rect">
-            <a:avLst/>
-          </a:prstGeom>
-          <a:solidFill>
-            <a:srgbClr val="2BC4C4"/>
-          </a:solidFill>
-          <a:ln/>
-        </p:spPr>
-      </p:sp>
-      <p:sp>
-        <p:nvSpPr>
-          <p:cNvPr id="10" name="Text 8"/>
-          <p:cNvSpPr/>
-          <p:nvPr/>
-        </p:nvSpPr>
-        <p:spPr>
-          <a:xfrm>
-            <a:off x="640080" y="1847088"/>
-            <a:ext cx="2331720" cy="219456"/>
+          <p:cNvPr id="15" name="Text 13"/>
+          <p:cNvSpPr/>
+          <p:nvPr/>
+        </p:nvSpPr>
+        <p:spPr>
+          <a:xfrm>
+            <a:off x="3264408" y="1627632"/>
+            <a:ext cx="2697480" cy="182880"/>
           </a:xfrm>
           <a:prstGeom prst="rect">
             <a:avLst/>
@@ -6627,211 +6797,10 @@
           <a:bodyPr wrap="square" lIns="0" tIns="0" rIns="0" bIns="0" rtlCol="0" anchor="ctr"/>
           <a:lstStyle/>
           <a:p>
-            <a:pPr indent="0" marL="0">
-              <a:buNone/>
-            </a:pPr>
-            <a:r>
-              <a:rPr lang="en-US" sz="900" b="1" spc="200" kern="0" dirty="0">
-                <a:solidFill>
-                  <a:srgbClr val="2BC4C4"/>
-                </a:solidFill>
-                <a:latin typeface="Arial" pitchFamily="34" charset="0"/>
-                <a:ea typeface="Arial" pitchFamily="34" charset="-122"/>
-                <a:cs typeface="Arial" pitchFamily="34" charset="-120"/>
-              </a:rPr>
-              <a:t>IMAGE  ·  capability</a:t>
-            </a:r>
-            <a:endParaRPr lang="en-US" sz="900" dirty="0"/>
-          </a:p>
-        </p:txBody>
-      </p:sp>
-      <p:sp>
-        <p:nvSpPr>
-          <p:cNvPr id="11" name="Text 9"/>
-          <p:cNvSpPr/>
-          <p:nvPr/>
-        </p:nvSpPr>
-        <p:spPr>
-          <a:xfrm>
-            <a:off x="640080" y="2121408"/>
-            <a:ext cx="2331720" cy="813816"/>
-          </a:xfrm>
-          <a:prstGeom prst="rect">
-            <a:avLst/>
-          </a:prstGeom>
-          <a:noFill/>
-          <a:ln/>
-        </p:spPr>
-        <p:txBody>
-          <a:bodyPr wrap="square" lIns="0" tIns="0" rIns="0" bIns="0" rtlCol="0" anchor="t"/>
-          <a:lstStyle/>
-          <a:p>
-            <a:pPr indent="0" marL="0">
-              <a:buNone/>
-            </a:pPr>
-            <a:r>
-              <a:rPr lang="en-US" sz="700" i="1" dirty="0">
-                <a:solidFill>
-                  <a:srgbClr val="8A8A90"/>
-                </a:solidFill>
-                <a:latin typeface="Arial" pitchFamily="34" charset="0"/>
-                <a:ea typeface="Arial" pitchFamily="34" charset="-122"/>
-                <a:cs typeface="Arial" pitchFamily="34" charset="-120"/>
-              </a:rPr>
-              <a:t>ISOMETRIC PROMPT → save as shift-capability.png</a:t>
-            </a:r>
-            <a:endParaRPr lang="en-US" sz="700" dirty="0"/>
-          </a:p>
-          <a:p>
-            <a:pPr indent="0" marL="0">
-              <a:buNone/>
-            </a:pPr>
-            <a:r>
-              <a:rPr lang="en-US" sz="850" dirty="0">
-                <a:solidFill>
-                  <a:srgbClr val="C9C9CE"/>
-                </a:solidFill>
-                <a:latin typeface="Arial" pitchFamily="34" charset="0"/>
-                <a:ea typeface="Arial" pitchFamily="34" charset="-122"/>
-                <a:cs typeface="Arial" pitchFamily="34" charset="-120"/>
-              </a:rPr>
-              <a:t>Isometric 3D illustration, a robotic arm on a small circular conveyor picking up a glowing cube, spotting a flaw, and placing it back to retry — a literal self-correcting loop, teal accents, near-black background, clean low-poly vector style, soft studio glow, subtle floor grid, centered, no text, no logos.</a:t>
-            </a:r>
-            <a:endParaRPr lang="en-US" sz="700" dirty="0"/>
-          </a:p>
-        </p:txBody>
-      </p:sp>
-      <p:sp>
-        <p:nvSpPr>
-          <p:cNvPr id="12" name="Text 10"/>
-          <p:cNvSpPr/>
-          <p:nvPr/>
-        </p:nvSpPr>
-        <p:spPr>
-          <a:xfrm>
-            <a:off x="457200" y="3200400"/>
-            <a:ext cx="2697480" cy="274320"/>
-          </a:xfrm>
-          <a:prstGeom prst="rect">
-            <a:avLst/>
-          </a:prstGeom>
-          <a:noFill/>
-          <a:ln/>
-        </p:spPr>
-        <p:txBody>
-          <a:bodyPr wrap="square" lIns="0" tIns="0" rIns="0" bIns="0" rtlCol="0" anchor="ctr"/>
-          <a:lstStyle/>
-          <a:p>
             <a:pPr algn="ctr" indent="0" marL="0">
               <a:buNone/>
             </a:pPr>
             <a:r>
-              <a:rPr lang="en-US" sz="1100" b="1" dirty="0">
-                <a:solidFill>
-                  <a:srgbClr val="C9C9CE"/>
-                </a:solidFill>
-                <a:latin typeface="Arial" pitchFamily="34" charset="0"/>
-                <a:ea typeface="Arial" pitchFamily="34" charset="-122"/>
-                <a:cs typeface="Arial" pitchFamily="34" charset="-120"/>
-              </a:rPr>
-              <a:t>Linear chat  </a:t>
-            </a:r>
-            <a:pPr algn="ctr" indent="0" marL="0">
-              <a:buNone/>
-            </a:pPr>
-            <a:r>
-              <a:rPr lang="en-US" sz="1200" b="1" dirty="0">
-                <a:solidFill>
-                  <a:srgbClr val="2BC4C4"/>
-                </a:solidFill>
-                <a:latin typeface="Arial" pitchFamily="34" charset="0"/>
-                <a:ea typeface="Arial" pitchFamily="34" charset="-122"/>
-                <a:cs typeface="Arial" pitchFamily="34" charset="-120"/>
-              </a:rPr>
-              <a:t>→  </a:t>
-            </a:r>
-            <a:pPr algn="ctr" indent="0" marL="0">
-              <a:buNone/>
-            </a:pPr>
-            <a:r>
-              <a:rPr lang="en-US" sz="1100" b="1" dirty="0">
-                <a:solidFill>
-                  <a:srgbClr val="FFFFFF"/>
-                </a:solidFill>
-                <a:latin typeface="Arial" pitchFamily="34" charset="0"/>
-                <a:ea typeface="Arial" pitchFamily="34" charset="-122"/>
-                <a:cs typeface="Arial" pitchFamily="34" charset="-120"/>
-              </a:rPr>
-              <a:t>Autonomous loops</a:t>
-            </a:r>
-            <a:endParaRPr lang="en-US" sz="1100" dirty="0"/>
-          </a:p>
-        </p:txBody>
-      </p:sp>
-      <p:sp>
-        <p:nvSpPr>
-          <p:cNvPr id="13" name="Text 11"/>
-          <p:cNvSpPr/>
-          <p:nvPr/>
-        </p:nvSpPr>
-        <p:spPr>
-          <a:xfrm>
-            <a:off x="566928" y="3511296"/>
-            <a:ext cx="2478024" cy="457200"/>
-          </a:xfrm>
-          <a:prstGeom prst="rect">
-            <a:avLst/>
-          </a:prstGeom>
-          <a:noFill/>
-          <a:ln/>
-        </p:spPr>
-        <p:txBody>
-          <a:bodyPr wrap="square" lIns="0" tIns="0" rIns="0" bIns="0" rtlCol="0" anchor="t"/>
-          <a:lstStyle/>
-          <a:p>
-            <a:pPr algn="ctr" indent="0" marL="0">
-              <a:buNone/>
-            </a:pPr>
-            <a:r>
-              <a:rPr lang="en-US" sz="850" dirty="0">
-                <a:solidFill>
-                  <a:srgbClr val="9A9AA0"/>
-                </a:solidFill>
-                <a:latin typeface="Arial" pitchFamily="34" charset="0"/>
-                <a:ea typeface="Arial" pitchFamily="34" charset="-122"/>
-                <a:cs typeface="Arial" pitchFamily="34" charset="-120"/>
-              </a:rPr>
-              <a:t>Models became self-correcting agents that run until the task is done.</a:t>
-            </a:r>
-            <a:endParaRPr lang="en-US" sz="850" dirty="0"/>
-          </a:p>
-        </p:txBody>
-      </p:sp>
-      <p:sp>
-        <p:nvSpPr>
-          <p:cNvPr id="14" name="Text 12"/>
-          <p:cNvSpPr/>
-          <p:nvPr/>
-        </p:nvSpPr>
-        <p:spPr>
-          <a:xfrm>
-            <a:off x="3264408" y="1463040"/>
-            <a:ext cx="2697480" cy="182880"/>
-          </a:xfrm>
-          <a:prstGeom prst="rect">
-            <a:avLst/>
-          </a:prstGeom>
-          <a:noFill/>
-          <a:ln/>
-        </p:spPr>
-        <p:txBody>
-          <a:bodyPr wrap="square" lIns="0" tIns="0" rIns="0" bIns="0" rtlCol="0" anchor="ctr"/>
-          <a:lstStyle/>
-          <a:p>
-            <a:pPr algn="ctr" indent="0" marL="0">
-              <a:buNone/>
-            </a:pPr>
-            <a:r>
               <a:rPr lang="en-US" sz="800" b="1" spc="200" kern="0" dirty="0">
                 <a:solidFill>
                   <a:srgbClr val="F6693D"/>
@@ -6848,17 +6817,19 @@
       </p:sp>
       <p:sp>
         <p:nvSpPr>
-          <p:cNvPr id="15" name="Shape 13"/>
-          <p:cNvSpPr/>
-          <p:nvPr/>
-        </p:nvSpPr>
-        <p:spPr>
-          <a:xfrm>
-            <a:off x="3264408" y="1700784"/>
-            <a:ext cx="2697480" cy="1417320"/>
-          </a:xfrm>
-          <a:prstGeom prst="rect">
-            <a:avLst/>
+          <p:cNvPr id="16" name="Shape 14"/>
+          <p:cNvSpPr/>
+          <p:nvPr/>
+        </p:nvSpPr>
+        <p:spPr>
+          <a:xfrm>
+            <a:off x="3675888" y="1938528"/>
+            <a:ext cx="1874520" cy="384048"/>
+          </a:xfrm>
+          <a:prstGeom prst="roundRect">
+            <a:avLst>
+              <a:gd name="adj" fmla="val 11905"/>
+            </a:avLst>
           </a:prstGeom>
           <a:solidFill>
             <a:srgbClr val="1E1E24"/>
@@ -6867,100 +6838,228 @@
             <a:solidFill>
               <a:srgbClr val="2A2A30"/>
             </a:solidFill>
-            <a:prstDash val="dash"/>
+            <a:prstDash val="solid"/>
           </a:ln>
         </p:spPr>
       </p:sp>
       <p:sp>
         <p:nvSpPr>
-          <p:cNvPr id="16" name="Shape 14"/>
-          <p:cNvSpPr/>
-          <p:nvPr/>
-        </p:nvSpPr>
-        <p:spPr>
-          <a:xfrm>
-            <a:off x="3264408" y="1700784"/>
-            <a:ext cx="310896" cy="36576"/>
-          </a:xfrm>
-          <a:prstGeom prst="rect">
-            <a:avLst/>
+          <p:cNvPr id="17" name="Text 15"/>
+          <p:cNvSpPr/>
+          <p:nvPr/>
+        </p:nvSpPr>
+        <p:spPr>
+          <a:xfrm>
+            <a:off x="3675888" y="1938528"/>
+            <a:ext cx="1874520" cy="384048"/>
+          </a:xfrm>
+          <a:prstGeom prst="rect">
+            <a:avLst/>
+          </a:prstGeom>
+          <a:noFill/>
+          <a:ln/>
+        </p:spPr>
+        <p:txBody>
+          <a:bodyPr wrap="square" lIns="0" tIns="0" rIns="0" bIns="0" rtlCol="0" anchor="ctr"/>
+          <a:lstStyle/>
+          <a:p>
+            <a:pPr algn="ctr" indent="0" marL="0">
+              <a:buNone/>
+            </a:pPr>
+            <a:r>
+              <a:rPr lang="en-US" sz="950" dirty="0">
+                <a:solidFill>
+                  <a:srgbClr val="9A9AA0"/>
+                </a:solidFill>
+                <a:latin typeface="Arial" pitchFamily="34" charset="0"/>
+                <a:ea typeface="Arial" pitchFamily="34" charset="-122"/>
+                <a:cs typeface="Arial" pitchFamily="34" charset="-120"/>
+              </a:rPr>
+              <a:t>Token subsidy</a:t>
+            </a:r>
+            <a:endParaRPr lang="en-US" sz="950" dirty="0"/>
+          </a:p>
+        </p:txBody>
+      </p:sp>
+      <p:sp>
+        <p:nvSpPr>
+          <p:cNvPr id="18" name="Shape 16"/>
+          <p:cNvSpPr/>
+          <p:nvPr/>
+        </p:nvSpPr>
+        <p:spPr>
+          <a:xfrm>
+            <a:off x="4613148" y="2359152"/>
+            <a:ext cx="0" cy="237744"/>
+          </a:xfrm>
+          <a:prstGeom prst="line">
+            <a:avLst/>
+          </a:prstGeom>
+          <a:noFill/>
+          <a:ln w="25400">
+            <a:solidFill>
+              <a:srgbClr val="F6693D"/>
+            </a:solidFill>
+            <a:prstDash val="solid"/>
+            <a:tailEnd type="triangle"/>
+          </a:ln>
+        </p:spPr>
+      </p:sp>
+      <p:sp>
+        <p:nvSpPr>
+          <p:cNvPr id="19" name="Shape 17"/>
+          <p:cNvSpPr/>
+          <p:nvPr/>
+        </p:nvSpPr>
+        <p:spPr>
+          <a:xfrm>
+            <a:off x="3675888" y="2633472"/>
+            <a:ext cx="1874520" cy="384048"/>
+          </a:xfrm>
+          <a:prstGeom prst="roundRect">
+            <a:avLst>
+              <a:gd name="adj" fmla="val 11905"/>
+            </a:avLst>
           </a:prstGeom>
           <a:solidFill>
-            <a:srgbClr val="F6693D"/>
+            <a:srgbClr val="1C1C20"/>
           </a:solidFill>
-          <a:ln/>
-        </p:spPr>
-      </p:sp>
-      <p:sp>
-        <p:nvSpPr>
-          <p:cNvPr id="17" name="Shape 15"/>
-          <p:cNvSpPr/>
-          <p:nvPr/>
-        </p:nvSpPr>
-        <p:spPr>
-          <a:xfrm>
-            <a:off x="3264408" y="1700784"/>
-            <a:ext cx="36576" cy="310896"/>
+          <a:ln w="19050">
+            <a:solidFill>
+              <a:srgbClr val="F6693D"/>
+            </a:solidFill>
+            <a:prstDash val="solid"/>
+          </a:ln>
+        </p:spPr>
+      </p:sp>
+      <p:sp>
+        <p:nvSpPr>
+          <p:cNvPr id="20" name="Text 18"/>
+          <p:cNvSpPr/>
+          <p:nvPr/>
+        </p:nvSpPr>
+        <p:spPr>
+          <a:xfrm>
+            <a:off x="3675888" y="2633472"/>
+            <a:ext cx="1874520" cy="384048"/>
+          </a:xfrm>
+          <a:prstGeom prst="rect">
+            <a:avLst/>
+          </a:prstGeom>
+          <a:noFill/>
+          <a:ln/>
+        </p:spPr>
+        <p:txBody>
+          <a:bodyPr wrap="square" lIns="0" tIns="0" rIns="0" bIns="0" rtlCol="0" anchor="ctr"/>
+          <a:lstStyle/>
+          <a:p>
+            <a:pPr algn="ctr" indent="0" marL="0">
+              <a:buNone/>
+            </a:pPr>
+            <a:r>
+              <a:rPr lang="en-US" sz="950" b="1" dirty="0">
+                <a:solidFill>
+                  <a:srgbClr val="FFFFFF"/>
+                </a:solidFill>
+                <a:latin typeface="Arial" pitchFamily="34" charset="0"/>
+                <a:ea typeface="Arial" pitchFamily="34" charset="-122"/>
+                <a:cs typeface="Arial" pitchFamily="34" charset="-120"/>
+              </a:rPr>
+              <a:t>Token scarcity</a:t>
+            </a:r>
+            <a:endParaRPr lang="en-US" sz="950" dirty="0"/>
+          </a:p>
+        </p:txBody>
+      </p:sp>
+      <p:sp>
+        <p:nvSpPr>
+          <p:cNvPr id="21" name="Text 19"/>
+          <p:cNvSpPr/>
+          <p:nvPr/>
+        </p:nvSpPr>
+        <p:spPr>
+          <a:xfrm>
+            <a:off x="3429000" y="3163824"/>
+            <a:ext cx="2368296" cy="658368"/>
+          </a:xfrm>
+          <a:prstGeom prst="rect">
+            <a:avLst/>
+          </a:prstGeom>
+          <a:noFill/>
+          <a:ln/>
+        </p:spPr>
+        <p:txBody>
+          <a:bodyPr wrap="square" lIns="0" tIns="0" rIns="0" bIns="0" rtlCol="0" anchor="t"/>
+          <a:lstStyle/>
+          <a:p>
+            <a:pPr algn="ctr" indent="0" marL="0">
+              <a:buNone/>
+            </a:pPr>
+            <a:r>
+              <a:rPr lang="en-US" sz="850" dirty="0">
+                <a:solidFill>
+                  <a:srgbClr val="9A9AA0"/>
+                </a:solidFill>
+                <a:latin typeface="Arial" pitchFamily="34" charset="0"/>
+                <a:ea typeface="Arial" pitchFamily="34" charset="-122"/>
+                <a:cs typeface="Arial" pitchFamily="34" charset="-120"/>
+              </a:rPr>
+              <a:t>Labs stopped subsidizing tokens; enterprises now ration them like a commodity.</a:t>
+            </a:r>
+            <a:endParaRPr lang="en-US" sz="850" dirty="0"/>
+          </a:p>
+        </p:txBody>
+      </p:sp>
+      <p:sp>
+        <p:nvSpPr>
+          <p:cNvPr id="22" name="Shape 20"/>
+          <p:cNvSpPr/>
+          <p:nvPr/>
+        </p:nvSpPr>
+        <p:spPr>
+          <a:xfrm>
+            <a:off x="6071616" y="1481328"/>
+            <a:ext cx="2697480" cy="2395728"/>
           </a:xfrm>
           <a:prstGeom prst="rect">
             <a:avLst/>
           </a:prstGeom>
           <a:solidFill>
-            <a:srgbClr val="F6693D"/>
+            <a:srgbClr val="1C1C20"/>
           </a:solidFill>
           <a:ln/>
         </p:spPr>
       </p:sp>
       <p:sp>
         <p:nvSpPr>
-          <p:cNvPr id="18" name="Shape 16"/>
-          <p:cNvSpPr/>
-          <p:nvPr/>
-        </p:nvSpPr>
-        <p:spPr>
-          <a:xfrm>
-            <a:off x="5650992" y="3081528"/>
-            <a:ext cx="310896" cy="36576"/>
+          <p:cNvPr id="23" name="Shape 21"/>
+          <p:cNvSpPr/>
+          <p:nvPr/>
+        </p:nvSpPr>
+        <p:spPr>
+          <a:xfrm>
+            <a:off x="6071616" y="1481328"/>
+            <a:ext cx="2697480" cy="45720"/>
           </a:xfrm>
           <a:prstGeom prst="rect">
             <a:avLst/>
           </a:prstGeom>
           <a:solidFill>
-            <a:srgbClr val="F6693D"/>
+            <a:srgbClr val="9B7BE0"/>
           </a:solidFill>
           <a:ln/>
         </p:spPr>
       </p:sp>
       <p:sp>
         <p:nvSpPr>
-          <p:cNvPr id="19" name="Shape 17"/>
-          <p:cNvSpPr/>
-          <p:nvPr/>
-        </p:nvSpPr>
-        <p:spPr>
-          <a:xfrm>
-            <a:off x="5925312" y="2807208"/>
-            <a:ext cx="36576" cy="310896"/>
-          </a:xfrm>
-          <a:prstGeom prst="rect">
-            <a:avLst/>
-          </a:prstGeom>
-          <a:solidFill>
-            <a:srgbClr val="F6693D"/>
-          </a:solidFill>
-          <a:ln/>
-        </p:spPr>
-      </p:sp>
-      <p:sp>
-        <p:nvSpPr>
-          <p:cNvPr id="20" name="Text 18"/>
-          <p:cNvSpPr/>
-          <p:nvPr/>
-        </p:nvSpPr>
-        <p:spPr>
-          <a:xfrm>
-            <a:off x="3447288" y="1847088"/>
-            <a:ext cx="2331720" cy="219456"/>
+          <p:cNvPr id="24" name="Text 22"/>
+          <p:cNvSpPr/>
+          <p:nvPr/>
+        </p:nvSpPr>
+        <p:spPr>
+          <a:xfrm>
+            <a:off x="6071616" y="1627632"/>
+            <a:ext cx="2697480" cy="182880"/>
           </a:xfrm>
           <a:prstGeom prst="rect">
             <a:avLst/>
@@ -6972,211 +7071,10 @@
           <a:bodyPr wrap="square" lIns="0" tIns="0" rIns="0" bIns="0" rtlCol="0" anchor="ctr"/>
           <a:lstStyle/>
           <a:p>
-            <a:pPr indent="0" marL="0">
-              <a:buNone/>
-            </a:pPr>
-            <a:r>
-              <a:rPr lang="en-US" sz="900" b="1" spc="200" kern="0" dirty="0">
-                <a:solidFill>
-                  <a:srgbClr val="F6693D"/>
-                </a:solidFill>
-                <a:latin typeface="Arial" pitchFamily="34" charset="0"/>
-                <a:ea typeface="Arial" pitchFamily="34" charset="-122"/>
-                <a:cs typeface="Arial" pitchFamily="34" charset="-120"/>
-              </a:rPr>
-              <a:t>IMAGE  ·  economics</a:t>
-            </a:r>
-            <a:endParaRPr lang="en-US" sz="900" dirty="0"/>
-          </a:p>
-        </p:txBody>
-      </p:sp>
-      <p:sp>
-        <p:nvSpPr>
-          <p:cNvPr id="21" name="Text 19"/>
-          <p:cNvSpPr/>
-          <p:nvPr/>
-        </p:nvSpPr>
-        <p:spPr>
-          <a:xfrm>
-            <a:off x="3447288" y="2121408"/>
-            <a:ext cx="2331720" cy="813816"/>
-          </a:xfrm>
-          <a:prstGeom prst="rect">
-            <a:avLst/>
-          </a:prstGeom>
-          <a:noFill/>
-          <a:ln/>
-        </p:spPr>
-        <p:txBody>
-          <a:bodyPr wrap="square" lIns="0" tIns="0" rIns="0" bIns="0" rtlCol="0" anchor="t"/>
-          <a:lstStyle/>
-          <a:p>
-            <a:pPr indent="0" marL="0">
-              <a:buNone/>
-            </a:pPr>
-            <a:r>
-              <a:rPr lang="en-US" sz="700" i="1" dirty="0">
-                <a:solidFill>
-                  <a:srgbClr val="8A8A90"/>
-                </a:solidFill>
-                <a:latin typeface="Arial" pitchFamily="34" charset="0"/>
-                <a:ea typeface="Arial" pitchFamily="34" charset="-122"/>
-                <a:cs typeface="Arial" pitchFamily="34" charset="-120"/>
-              </a:rPr>
-              <a:t>ISOMETRIC PROMPT → save as shift-economics.png</a:t>
-            </a:r>
-            <a:endParaRPr lang="en-US" sz="700" dirty="0"/>
-          </a:p>
-          <a:p>
-            <a:pPr indent="0" marL="0">
-              <a:buNone/>
-            </a:pPr>
-            <a:r>
-              <a:rPr lang="en-US" sz="850" dirty="0">
-                <a:solidFill>
-                  <a:srgbClr val="C9C9CE"/>
-                </a:solidFill>
-                <a:latin typeface="Arial" pitchFamily="34" charset="0"/>
-                <a:ea typeface="Arial" pitchFamily="34" charset="-122"/>
-                <a:cs typeface="Arial" pitchFamily="34" charset="-120"/>
-              </a:rPr>
-              <a:t>Isometric 3D illustration, a coin-operated electricity meter wired into a GPU, its dial pushed near a red limit line, a small rationed stack of glowing token-coins beside it, orange accents, near-black background, clean low-poly vector style, soft studio glow, subtle floor grid, centered, no text, no logos.</a:t>
-            </a:r>
-            <a:endParaRPr lang="en-US" sz="700" dirty="0"/>
-          </a:p>
-        </p:txBody>
-      </p:sp>
-      <p:sp>
-        <p:nvSpPr>
-          <p:cNvPr id="22" name="Text 20"/>
-          <p:cNvSpPr/>
-          <p:nvPr/>
-        </p:nvSpPr>
-        <p:spPr>
-          <a:xfrm>
-            <a:off x="3264408" y="3200400"/>
-            <a:ext cx="2697480" cy="274320"/>
-          </a:xfrm>
-          <a:prstGeom prst="rect">
-            <a:avLst/>
-          </a:prstGeom>
-          <a:noFill/>
-          <a:ln/>
-        </p:spPr>
-        <p:txBody>
-          <a:bodyPr wrap="square" lIns="0" tIns="0" rIns="0" bIns="0" rtlCol="0" anchor="ctr"/>
-          <a:lstStyle/>
-          <a:p>
             <a:pPr algn="ctr" indent="0" marL="0">
               <a:buNone/>
             </a:pPr>
             <a:r>
-              <a:rPr lang="en-US" sz="1100" b="1" dirty="0">
-                <a:solidFill>
-                  <a:srgbClr val="C9C9CE"/>
-                </a:solidFill>
-                <a:latin typeface="Arial" pitchFamily="34" charset="0"/>
-                <a:ea typeface="Arial" pitchFamily="34" charset="-122"/>
-                <a:cs typeface="Arial" pitchFamily="34" charset="-120"/>
-              </a:rPr>
-              <a:t>Token subsidy  </a:t>
-            </a:r>
-            <a:pPr algn="ctr" indent="0" marL="0">
-              <a:buNone/>
-            </a:pPr>
-            <a:r>
-              <a:rPr lang="en-US" sz="1200" b="1" dirty="0">
-                <a:solidFill>
-                  <a:srgbClr val="F6693D"/>
-                </a:solidFill>
-                <a:latin typeface="Arial" pitchFamily="34" charset="0"/>
-                <a:ea typeface="Arial" pitchFamily="34" charset="-122"/>
-                <a:cs typeface="Arial" pitchFamily="34" charset="-120"/>
-              </a:rPr>
-              <a:t>→  </a:t>
-            </a:r>
-            <a:pPr algn="ctr" indent="0" marL="0">
-              <a:buNone/>
-            </a:pPr>
-            <a:r>
-              <a:rPr lang="en-US" sz="1100" b="1" dirty="0">
-                <a:solidFill>
-                  <a:srgbClr val="FFFFFF"/>
-                </a:solidFill>
-                <a:latin typeface="Arial" pitchFamily="34" charset="0"/>
-                <a:ea typeface="Arial" pitchFamily="34" charset="-122"/>
-                <a:cs typeface="Arial" pitchFamily="34" charset="-120"/>
-              </a:rPr>
-              <a:t>Token scarcity</a:t>
-            </a:r>
-            <a:endParaRPr lang="en-US" sz="1100" dirty="0"/>
-          </a:p>
-        </p:txBody>
-      </p:sp>
-      <p:sp>
-        <p:nvSpPr>
-          <p:cNvPr id="23" name="Text 21"/>
-          <p:cNvSpPr/>
-          <p:nvPr/>
-        </p:nvSpPr>
-        <p:spPr>
-          <a:xfrm>
-            <a:off x="3374136" y="3511296"/>
-            <a:ext cx="2478024" cy="457200"/>
-          </a:xfrm>
-          <a:prstGeom prst="rect">
-            <a:avLst/>
-          </a:prstGeom>
-          <a:noFill/>
-          <a:ln/>
-        </p:spPr>
-        <p:txBody>
-          <a:bodyPr wrap="square" lIns="0" tIns="0" rIns="0" bIns="0" rtlCol="0" anchor="t"/>
-          <a:lstStyle/>
-          <a:p>
-            <a:pPr algn="ctr" indent="0" marL="0">
-              <a:buNone/>
-            </a:pPr>
-            <a:r>
-              <a:rPr lang="en-US" sz="850" dirty="0">
-                <a:solidFill>
-                  <a:srgbClr val="9A9AA0"/>
-                </a:solidFill>
-                <a:latin typeface="Arial" pitchFamily="34" charset="0"/>
-                <a:ea typeface="Arial" pitchFamily="34" charset="-122"/>
-                <a:cs typeface="Arial" pitchFamily="34" charset="-120"/>
-              </a:rPr>
-              <a:t>Labs stopped subsidizing tokens; enterprises now ration them like a commodity.</a:t>
-            </a:r>
-            <a:endParaRPr lang="en-US" sz="850" dirty="0"/>
-          </a:p>
-        </p:txBody>
-      </p:sp>
-      <p:sp>
-        <p:nvSpPr>
-          <p:cNvPr id="24" name="Text 22"/>
-          <p:cNvSpPr/>
-          <p:nvPr/>
-        </p:nvSpPr>
-        <p:spPr>
-          <a:xfrm>
-            <a:off x="6071616" y="1463040"/>
-            <a:ext cx="2697480" cy="182880"/>
-          </a:xfrm>
-          <a:prstGeom prst="rect">
-            <a:avLst/>
-          </a:prstGeom>
-          <a:noFill/>
-          <a:ln/>
-        </p:spPr>
-        <p:txBody>
-          <a:bodyPr wrap="square" lIns="0" tIns="0" rIns="0" bIns="0" rtlCol="0" anchor="ctr"/>
-          <a:lstStyle/>
-          <a:p>
-            <a:pPr algn="ctr" indent="0" marL="0">
-              <a:buNone/>
-            </a:pPr>
-            <a:r>
               <a:rPr lang="en-US" sz="800" b="1" spc="200" kern="0" dirty="0">
                 <a:solidFill>
                   <a:srgbClr val="9B7BE0"/>
@@ -7199,11 +7097,13 @@
         </p:nvSpPr>
         <p:spPr>
           <a:xfrm>
-            <a:off x="6071616" y="1700784"/>
-            <a:ext cx="2697480" cy="1417320"/>
-          </a:xfrm>
-          <a:prstGeom prst="rect">
-            <a:avLst/>
+            <a:off x="6483096" y="1938528"/>
+            <a:ext cx="1874520" cy="384048"/>
+          </a:xfrm>
+          <a:prstGeom prst="roundRect">
+            <a:avLst>
+              <a:gd name="adj" fmla="val 11905"/>
+            </a:avLst>
           </a:prstGeom>
           <a:solidFill>
             <a:srgbClr val="1E1E24"/>
@@ -7212,29 +7112,48 @@
             <a:solidFill>
               <a:srgbClr val="2A2A30"/>
             </a:solidFill>
-            <a:prstDash val="dash"/>
+            <a:prstDash val="solid"/>
           </a:ln>
         </p:spPr>
       </p:sp>
       <p:sp>
         <p:nvSpPr>
-          <p:cNvPr id="26" name="Shape 24"/>
-          <p:cNvSpPr/>
-          <p:nvPr/>
-        </p:nvSpPr>
-        <p:spPr>
-          <a:xfrm>
-            <a:off x="6071616" y="1700784"/>
-            <a:ext cx="310896" cy="36576"/>
-          </a:xfrm>
-          <a:prstGeom prst="rect">
-            <a:avLst/>
-          </a:prstGeom>
-          <a:solidFill>
-            <a:srgbClr val="9B7BE0"/>
-          </a:solidFill>
-          <a:ln/>
-        </p:spPr>
+          <p:cNvPr id="26" name="Text 24"/>
+          <p:cNvSpPr/>
+          <p:nvPr/>
+        </p:nvSpPr>
+        <p:spPr>
+          <a:xfrm>
+            <a:off x="6483096" y="1938528"/>
+            <a:ext cx="1874520" cy="384048"/>
+          </a:xfrm>
+          <a:prstGeom prst="rect">
+            <a:avLst/>
+          </a:prstGeom>
+          <a:noFill/>
+          <a:ln/>
+        </p:spPr>
+        <p:txBody>
+          <a:bodyPr wrap="square" lIns="0" tIns="0" rIns="0" bIns="0" rtlCol="0" anchor="ctr"/>
+          <a:lstStyle/>
+          <a:p>
+            <a:pPr algn="ctr" indent="0" marL="0">
+              <a:buNone/>
+            </a:pPr>
+            <a:r>
+              <a:rPr lang="en-US" sz="950" dirty="0">
+                <a:solidFill>
+                  <a:srgbClr val="9A9AA0"/>
+                </a:solidFill>
+                <a:latin typeface="Arial" pitchFamily="34" charset="0"/>
+                <a:ea typeface="Arial" pitchFamily="34" charset="-122"/>
+                <a:cs typeface="Arial" pitchFamily="34" charset="-120"/>
+              </a:rPr>
+              <a:t>Private tech</a:t>
+            </a:r>
+            <a:endParaRPr lang="en-US" sz="950" dirty="0"/>
+          </a:p>
+        </p:txBody>
       </p:sp>
       <p:sp>
         <p:nvSpPr>
@@ -7244,16 +7163,20 @@
         </p:nvSpPr>
         <p:spPr>
           <a:xfrm>
-            <a:off x="6071616" y="1700784"/>
-            <a:ext cx="36576" cy="310896"/>
-          </a:xfrm>
-          <a:prstGeom prst="rect">
-            <a:avLst/>
-          </a:prstGeom>
-          <a:solidFill>
-            <a:srgbClr val="9B7BE0"/>
-          </a:solidFill>
-          <a:ln/>
+            <a:off x="7420356" y="2359152"/>
+            <a:ext cx="0" cy="237744"/>
+          </a:xfrm>
+          <a:prstGeom prst="line">
+            <a:avLst/>
+          </a:prstGeom>
+          <a:noFill/>
+          <a:ln w="25400">
+            <a:solidFill>
+              <a:srgbClr val="9B7BE0"/>
+            </a:solidFill>
+            <a:prstDash val="solid"/>
+            <a:tailEnd type="triangle"/>
+          </a:ln>
         </p:spPr>
       </p:sp>
       <p:sp>
@@ -7264,262 +7187,126 @@
         </p:nvSpPr>
         <p:spPr>
           <a:xfrm>
-            <a:off x="8458200" y="3081528"/>
-            <a:ext cx="310896" cy="36576"/>
-          </a:xfrm>
-          <a:prstGeom prst="rect">
-            <a:avLst/>
-          </a:prstGeom>
-          <a:solidFill>
-            <a:srgbClr val="9B7BE0"/>
-          </a:solidFill>
-          <a:ln/>
-        </p:spPr>
-      </p:sp>
-      <p:sp>
-        <p:nvSpPr>
-          <p:cNvPr id="29" name="Shape 27"/>
-          <p:cNvSpPr/>
-          <p:nvPr/>
-        </p:nvSpPr>
-        <p:spPr>
-          <a:xfrm>
-            <a:off x="8732520" y="2807208"/>
-            <a:ext cx="36576" cy="310896"/>
-          </a:xfrm>
-          <a:prstGeom prst="rect">
-            <a:avLst/>
-          </a:prstGeom>
-          <a:solidFill>
-            <a:srgbClr val="9B7BE0"/>
-          </a:solidFill>
-          <a:ln/>
-        </p:spPr>
-      </p:sp>
-      <p:sp>
-        <p:nvSpPr>
-          <p:cNvPr id="30" name="Text 28"/>
-          <p:cNvSpPr/>
-          <p:nvPr/>
-        </p:nvSpPr>
-        <p:spPr>
-          <a:xfrm>
-            <a:off x="6254496" y="1847088"/>
-            <a:ext cx="2331720" cy="219456"/>
-          </a:xfrm>
-          <a:prstGeom prst="rect">
-            <a:avLst/>
-          </a:prstGeom>
-          <a:noFill/>
-          <a:ln/>
-        </p:spPr>
-        <p:txBody>
-          <a:bodyPr wrap="square" lIns="0" tIns="0" rIns="0" bIns="0" rtlCol="0" anchor="ctr"/>
-          <a:lstStyle/>
-          <a:p>
-            <a:pPr indent="0" marL="0">
-              <a:buNone/>
-            </a:pPr>
-            <a:r>
-              <a:rPr lang="en-US" sz="900" b="1" spc="200" kern="0" dirty="0">
-                <a:solidFill>
-                  <a:srgbClr val="9B7BE0"/>
-                </a:solidFill>
-                <a:latin typeface="Arial" pitchFamily="34" charset="0"/>
-                <a:ea typeface="Arial" pitchFamily="34" charset="-122"/>
-                <a:cs typeface="Arial" pitchFamily="34" charset="-120"/>
-              </a:rPr>
-              <a:t>IMAGE  ·  policy</a:t>
-            </a:r>
-            <a:endParaRPr lang="en-US" sz="900" dirty="0"/>
-          </a:p>
-        </p:txBody>
-      </p:sp>
-      <p:sp>
-        <p:nvSpPr>
-          <p:cNvPr id="31" name="Text 29"/>
-          <p:cNvSpPr/>
-          <p:nvPr/>
-        </p:nvSpPr>
-        <p:spPr>
-          <a:xfrm>
-            <a:off x="6254496" y="2121408"/>
-            <a:ext cx="2331720" cy="813816"/>
-          </a:xfrm>
-          <a:prstGeom prst="rect">
-            <a:avLst/>
-          </a:prstGeom>
-          <a:noFill/>
-          <a:ln/>
-        </p:spPr>
-        <p:txBody>
-          <a:bodyPr wrap="square" lIns="0" tIns="0" rIns="0" bIns="0" rtlCol="0" anchor="t"/>
-          <a:lstStyle/>
-          <a:p>
-            <a:pPr indent="0" marL="0">
-              <a:buNone/>
-            </a:pPr>
-            <a:r>
-              <a:rPr lang="en-US" sz="700" i="1" dirty="0">
-                <a:solidFill>
-                  <a:srgbClr val="8A8A90"/>
-                </a:solidFill>
-                <a:latin typeface="Arial" pitchFamily="34" charset="0"/>
-                <a:ea typeface="Arial" pitchFamily="34" charset="-122"/>
-                <a:cs typeface="Arial" pitchFamily="34" charset="-120"/>
-              </a:rPr>
-              <a:t>ISOMETRIC PROMPT → save as shift-policy.png</a:t>
-            </a:r>
-            <a:endParaRPr lang="en-US" sz="700" dirty="0"/>
-          </a:p>
-          <a:p>
-            <a:pPr indent="0" marL="0">
-              <a:buNone/>
-            </a:pPr>
-            <a:r>
-              <a:rPr lang="en-US" sz="850" dirty="0">
-                <a:solidFill>
-                  <a:srgbClr val="C9C9CE"/>
-                </a:solidFill>
-                <a:latin typeface="Arial" pitchFamily="34" charset="0"/>
-                <a:ea typeface="Arial" pitchFamily="34" charset="-122"/>
-                <a:cs typeface="Arial" pitchFamily="34" charset="-120"/>
-              </a:rPr>
-              <a:t>Isometric 3D illustration, a capitol dome beside a server-rack tower; a giant government hand plants a flag stamped with a percent sign on the tower while an official seal hovers over a glowing microchip, purple accents, near-black background, clean low-poly vector style, soft studio glow, subtle floor grid, centered, no text, no logos.</a:t>
-            </a:r>
-            <a:endParaRPr lang="en-US" sz="700" dirty="0"/>
-          </a:p>
-        </p:txBody>
-      </p:sp>
-      <p:sp>
-        <p:nvSpPr>
-          <p:cNvPr id="32" name="Text 30"/>
-          <p:cNvSpPr/>
-          <p:nvPr/>
-        </p:nvSpPr>
-        <p:spPr>
-          <a:xfrm>
-            <a:off x="6071616" y="3200400"/>
-            <a:ext cx="2697480" cy="274320"/>
-          </a:xfrm>
-          <a:prstGeom prst="rect">
-            <a:avLst/>
-          </a:prstGeom>
-          <a:noFill/>
-          <a:ln/>
-        </p:spPr>
-        <p:txBody>
-          <a:bodyPr wrap="square" lIns="0" tIns="0" rIns="0" bIns="0" rtlCol="0" anchor="ctr"/>
-          <a:lstStyle/>
-          <a:p>
-            <a:pPr algn="ctr" indent="0" marL="0">
-              <a:buNone/>
-            </a:pPr>
-            <a:r>
-              <a:rPr lang="en-US" sz="1100" b="1" dirty="0">
-                <a:solidFill>
-                  <a:srgbClr val="C9C9CE"/>
-                </a:solidFill>
-                <a:latin typeface="Arial" pitchFamily="34" charset="0"/>
-                <a:ea typeface="Arial" pitchFamily="34" charset="-122"/>
-                <a:cs typeface="Arial" pitchFamily="34" charset="-120"/>
-              </a:rPr>
-              <a:t>Private tech  </a:t>
-            </a:r>
-            <a:pPr algn="ctr" indent="0" marL="0">
-              <a:buNone/>
-            </a:pPr>
-            <a:r>
-              <a:rPr lang="en-US" sz="1200" b="1" dirty="0">
-                <a:solidFill>
-                  <a:srgbClr val="9B7BE0"/>
-                </a:solidFill>
-                <a:latin typeface="Arial" pitchFamily="34" charset="0"/>
-                <a:ea typeface="Arial" pitchFamily="34" charset="-122"/>
-                <a:cs typeface="Arial" pitchFamily="34" charset="-120"/>
-              </a:rPr>
-              <a:t>→  </a:t>
-            </a:r>
-            <a:pPr algn="ctr" indent="0" marL="0">
-              <a:buNone/>
-            </a:pPr>
-            <a:r>
-              <a:rPr lang="en-US" sz="1100" b="1" dirty="0">
-                <a:solidFill>
-                  <a:srgbClr val="FFFFFF"/>
-                </a:solidFill>
-                <a:latin typeface="Arial" pitchFamily="34" charset="0"/>
-                <a:ea typeface="Arial" pitchFamily="34" charset="-122"/>
-                <a:cs typeface="Arial" pitchFamily="34" charset="-120"/>
-              </a:rPr>
-              <a:t>Sovereign asset</a:t>
-            </a:r>
-            <a:endParaRPr lang="en-US" sz="1100" dirty="0"/>
-          </a:p>
-        </p:txBody>
-      </p:sp>
-      <p:sp>
-        <p:nvSpPr>
-          <p:cNvPr id="33" name="Text 31"/>
-          <p:cNvSpPr/>
-          <p:nvPr/>
-        </p:nvSpPr>
-        <p:spPr>
-          <a:xfrm>
-            <a:off x="6181344" y="3511296"/>
-            <a:ext cx="2478024" cy="457200"/>
-          </a:xfrm>
-          <a:prstGeom prst="rect">
-            <a:avLst/>
-          </a:prstGeom>
-          <a:noFill/>
-          <a:ln/>
-        </p:spPr>
-        <p:txBody>
-          <a:bodyPr wrap="square" lIns="0" tIns="0" rIns="0" bIns="0" rtlCol="0" anchor="t"/>
-          <a:lstStyle/>
-          <a:p>
-            <a:pPr algn="ctr" indent="0" marL="0">
-              <a:buNone/>
-            </a:pPr>
-            <a:r>
-              <a:rPr lang="en-US" sz="850" dirty="0">
-                <a:solidFill>
-                  <a:srgbClr val="9A9AA0"/>
-                </a:solidFill>
-                <a:latin typeface="Arial" pitchFamily="34" charset="0"/>
-                <a:ea typeface="Arial" pitchFamily="34" charset="-122"/>
-                <a:cs typeface="Arial" pitchFamily="34" charset="-120"/>
-              </a:rPr>
-              <a:t>Governments now debate owning a piece of the labs, not just regulating them.</a:t>
-            </a:r>
-            <a:endParaRPr lang="en-US" sz="850" dirty="0"/>
-          </a:p>
-        </p:txBody>
-      </p:sp>
-      <p:sp>
-        <p:nvSpPr>
-          <p:cNvPr id="34" name="Shape 32"/>
-          <p:cNvSpPr/>
-          <p:nvPr/>
-        </p:nvSpPr>
-        <p:spPr>
-          <a:xfrm>
-            <a:off x="0" y="4041648"/>
-            <a:ext cx="9144000" cy="457200"/>
-          </a:xfrm>
-          <a:prstGeom prst="rect">
-            <a:avLst/>
+            <a:off x="6483096" y="2633472"/>
+            <a:ext cx="1874520" cy="384048"/>
+          </a:xfrm>
+          <a:prstGeom prst="roundRect">
+            <a:avLst>
+              <a:gd name="adj" fmla="val 11905"/>
+            </a:avLst>
           </a:prstGeom>
           <a:solidFill>
             <a:srgbClr val="1C1C20"/>
           </a:solidFill>
-          <a:ln/>
-        </p:spPr>
-      </p:sp>
-      <p:sp>
-        <p:nvSpPr>
-          <p:cNvPr id="35" name="Shape 33"/>
+          <a:ln w="19050">
+            <a:solidFill>
+              <a:srgbClr val="9B7BE0"/>
+            </a:solidFill>
+            <a:prstDash val="solid"/>
+          </a:ln>
+        </p:spPr>
+      </p:sp>
+      <p:sp>
+        <p:nvSpPr>
+          <p:cNvPr id="29" name="Text 27"/>
+          <p:cNvSpPr/>
+          <p:nvPr/>
+        </p:nvSpPr>
+        <p:spPr>
+          <a:xfrm>
+            <a:off x="6483096" y="2633472"/>
+            <a:ext cx="1874520" cy="384048"/>
+          </a:xfrm>
+          <a:prstGeom prst="rect">
+            <a:avLst/>
+          </a:prstGeom>
+          <a:noFill/>
+          <a:ln/>
+        </p:spPr>
+        <p:txBody>
+          <a:bodyPr wrap="square" lIns="0" tIns="0" rIns="0" bIns="0" rtlCol="0" anchor="ctr"/>
+          <a:lstStyle/>
+          <a:p>
+            <a:pPr algn="ctr" indent="0" marL="0">
+              <a:buNone/>
+            </a:pPr>
+            <a:r>
+              <a:rPr lang="en-US" sz="950" b="1" dirty="0">
+                <a:solidFill>
+                  <a:srgbClr val="FFFFFF"/>
+                </a:solidFill>
+                <a:latin typeface="Arial" pitchFamily="34" charset="0"/>
+                <a:ea typeface="Arial" pitchFamily="34" charset="-122"/>
+                <a:cs typeface="Arial" pitchFamily="34" charset="-120"/>
+              </a:rPr>
+              <a:t>Sovereign asset</a:t>
+            </a:r>
+            <a:endParaRPr lang="en-US" sz="950" dirty="0"/>
+          </a:p>
+        </p:txBody>
+      </p:sp>
+      <p:sp>
+        <p:nvSpPr>
+          <p:cNvPr id="30" name="Text 28"/>
+          <p:cNvSpPr/>
+          <p:nvPr/>
+        </p:nvSpPr>
+        <p:spPr>
+          <a:xfrm>
+            <a:off x="6236208" y="3163824"/>
+            <a:ext cx="2368296" cy="658368"/>
+          </a:xfrm>
+          <a:prstGeom prst="rect">
+            <a:avLst/>
+          </a:prstGeom>
+          <a:noFill/>
+          <a:ln/>
+        </p:spPr>
+        <p:txBody>
+          <a:bodyPr wrap="square" lIns="0" tIns="0" rIns="0" bIns="0" rtlCol="0" anchor="t"/>
+          <a:lstStyle/>
+          <a:p>
+            <a:pPr algn="ctr" indent="0" marL="0">
+              <a:buNone/>
+            </a:pPr>
+            <a:r>
+              <a:rPr lang="en-US" sz="850" dirty="0">
+                <a:solidFill>
+                  <a:srgbClr val="9A9AA0"/>
+                </a:solidFill>
+                <a:latin typeface="Arial" pitchFamily="34" charset="0"/>
+                <a:ea typeface="Arial" pitchFamily="34" charset="-122"/>
+                <a:cs typeface="Arial" pitchFamily="34" charset="-120"/>
+              </a:rPr>
+              <a:t>Governments now debate owning a piece of the labs, not just regulating them.</a:t>
+            </a:r>
+            <a:endParaRPr lang="en-US" sz="850" dirty="0"/>
+          </a:p>
+        </p:txBody>
+      </p:sp>
+      <p:sp>
+        <p:nvSpPr>
+          <p:cNvPr id="31" name="Shape 29"/>
+          <p:cNvSpPr/>
+          <p:nvPr/>
+        </p:nvSpPr>
+        <p:spPr>
+          <a:xfrm>
+            <a:off x="0" y="4041648"/>
+            <a:ext cx="9144000" cy="457200"/>
+          </a:xfrm>
+          <a:prstGeom prst="rect">
+            <a:avLst/>
+          </a:prstGeom>
+          <a:solidFill>
+            <a:srgbClr val="1C1C20"/>
+          </a:solidFill>
+          <a:ln/>
+        </p:spPr>
+      </p:sp>
+      <p:sp>
+        <p:nvSpPr>
+          <p:cNvPr id="32" name="Shape 30"/>
           <p:cNvSpPr/>
           <p:nvPr/>
         </p:nvSpPr>
@@ -7539,7 +7326,7 @@
       </p:sp>
       <p:sp>
         <p:nvSpPr>
-          <p:cNvPr id="36" name="Text 34"/>
+          <p:cNvPr id="33" name="Text 31"/>
           <p:cNvSpPr/>
           <p:nvPr/>
         </p:nvSpPr>
@@ -7578,7 +7365,7 @@
       </p:sp>
       <p:sp>
         <p:nvSpPr>
-          <p:cNvPr id="37" name="Shape 35"/>
+          <p:cNvPr id="34" name="Shape 32"/>
           <p:cNvSpPr/>
           <p:nvPr/>
         </p:nvSpPr>
@@ -7598,7 +7385,7 @@
       </p:sp>
       <p:sp>
         <p:nvSpPr>
-          <p:cNvPr id="38" name="Shape 36"/>
+          <p:cNvPr id="35" name="Shape 33"/>
           <p:cNvSpPr/>
           <p:nvPr/>
         </p:nvSpPr>
@@ -7621,7 +7408,7 @@
       </p:sp>
       <p:sp>
         <p:nvSpPr>
-          <p:cNvPr id="39" name="Text 37"/>
+          <p:cNvPr id="36" name="Text 34"/>
           <p:cNvSpPr/>
           <p:nvPr/>
         </p:nvSpPr>
@@ -7660,7 +7447,7 @@
       </p:sp>
       <p:sp>
         <p:nvSpPr>
-          <p:cNvPr id="40" name="Text 38"/>
+          <p:cNvPr id="37" name="Text 35"/>
           <p:cNvSpPr/>
           <p:nvPr/>
         </p:nvSpPr>
@@ -10587,7 +10374,7 @@
                 <a:ea typeface="Arial" pitchFamily="34" charset="-122"/>
                 <a:cs typeface="Arial" pitchFamily="34" charset="-120"/>
               </a:rPr>
-              <a:t>ISOMETRIC PROMPT → save as token-budget.png</a:t>
+              <a:t>IMAGE PROMPT → save as token-budget.png</a:t>
             </a:r>
             <a:endParaRPr lang="en-US" sz="700" dirty="0"/>
           </a:p>
@@ -10604,7 +10391,7 @@
                 <a:ea typeface="Arial" pitchFamily="34" charset="-122"/>
                 <a:cs typeface="Arial" pitchFamily="34" charset="-120"/>
               </a:rPr>
-              <a:t>Isometric 3D illustration, a guarded vault dispensing only a small rationed handful of glowing tokens onto a conveyor that feeds a row of waiting laptops, an 'allocation' valve throttling the flow, orange and gold accents, near-black background, clean low-poly vector style, soft studio glow, subtle floor grid, centered, no text, no logos.</a:t>
+              <a:t>Clean modern editorial illustration with natural perspective (not isometric), a guarded vault dispensing only a small rationed handful of glowing tokens onto a conveyor that feeds a row of waiting laptops, an 'allocation' valve throttling the flow, orange and gold accents, on a near-black background, soft cinematic studio lighting, minimal and polished, single centered subject, no text, no words, no logos.</a:t>
             </a:r>
             <a:endParaRPr lang="en-US" sz="700" dirty="0"/>
           </a:p>
@@ -11464,7 +11251,7 @@
                 <a:ea typeface="Arial" pitchFamily="34" charset="-122"/>
                 <a:cs typeface="Arial" pitchFamily="34" charset="-120"/>
               </a:rPr>
-              <a:t>ISOMETRIC PROMPT → save as gov-stake.png</a:t>
+              <a:t>IMAGE PROMPT → save as gov-stake.png</a:t>
             </a:r>
             <a:endParaRPr lang="en-US" sz="700" dirty="0"/>
           </a:p>
@@ -11481,7 +11268,7 @@
                 <a:ea typeface="Arial" pitchFamily="34" charset="-122"/>
                 <a:cs typeface="Arial" pitchFamily="34" charset="-120"/>
               </a:rPr>
-              <a:t>Isometric 3D illustration, a giant government hand planting a flag bearing a percentage symbol atop a glowing server-rack skyscraper, while a chute rains small dividend coins down onto a cluster of tiny suburban houses below, purple accents, near-black background, clean low-poly vector style, soft studio glow, subtle floor grid, centered, no text, no logos.</a:t>
+              <a:t>Clean modern editorial illustration with natural perspective (not isometric), a giant government hand planting a flag bearing a percentage symbol atop a glowing server-rack skyscraper, while a chute rains small dividend coins down onto a cluster of tiny suburban houses below, purple accents, on a near-black background, soft cinematic studio lighting, minimal and polished, single centered subject, no text, no words, no logos.</a:t>
             </a:r>
             <a:endParaRPr lang="en-US" sz="700" dirty="0"/>
           </a:p>

</xml_diff>

<commit_message>
Rewrite image prompts: detailed, positive style (drop "isometric"/"not isometric")
- House style now describes the target positively and in detail (modern editorial 3D illustration, three-quarter angle, volumetric lighting, glossy materials, near-black studio) instead of saying 'not isometric', which can anchor image models on the word.
- All 7 prompts in IMAGE_PROMPTS_V3.md rewritten with concrete composition, materials, lighting and palette detail; STYLE/STYLE_TAIL constants updated for the on-slide placeholders.
- Stale 'isometric' code comments corrected (slide 2 is native diagrams, not icons).
- Rebuilt: valid 12-slide pptx + slides-data.js.

Co-Authored-By: Claude Opus 4.8 <noreply@anthropic.com>
</commit_message>
<xml_diff>
--- a/ai-markets-deck.pptx
+++ b/ai-markets-deck.pptx
@@ -2778,7 +2778,7 @@
                 <a:ea typeface="Arial" pitchFamily="34" charset="-122"/>
                 <a:cs typeface="Arial" pitchFamily="34" charset="-120"/>
               </a:rPr>
-              <a:t>Clean modern editorial illustration with natural perspective (not isometric), a financial district at night where the skyscrapers are stacked GPU server-racks; a glowing candlestick stock-chart runs like a road along their base, and a curved arrow of capital flows from a domed bank building into the single tallest GPU tower; orange and yellow accents, on a near-black background, soft cinematic studio lighting, minimal and polished, single centered subject, no text, no words, no logos.</a:t>
+              <a:t>Detailed modern editorial 3D illustration, slight three-quarter camera angle, polished semi-realistic render, cinematic: a financial district at night where the skyscrapers are stacked GPU server-racks; a glowing candlestick stock-chart runs like a road along their base, and a curved arrow of capital flows from a domed bank building into the single tallest GPU tower; orange and yellow accents. Deep near-black studio background (#111114), soft volumetric lighting with gentle rim light, glossy and matte materials, fine detail, crisp focus, premium financial-tech mood, single hero subject with generous negative space, no text, no words, no logos, no watermark.</a:t>
             </a:r>
             <a:endParaRPr lang="en-US" sz="700" dirty="0"/>
           </a:p>
@@ -4160,7 +4160,7 @@
                 <a:ea typeface="Arial" pitchFamily="34" charset="-122"/>
                 <a:cs typeface="Arial" pitchFamily="34" charset="-120"/>
               </a:rPr>
-              <a:t>Clean modern editorial illustration with natural perspective (not isometric), a humanoid robot carrying a labeled tote down a numbered warehouse aisle lined with shelving racks, mid-stride, pink accents, on a near-black background, soft cinematic studio lighting, minimal and polished, single centered subject, no text, no words, no logos.</a:t>
+              <a:t>Detailed modern editorial 3D illustration, slight three-quarter camera angle, polished semi-realistic render, cinematic: a humanoid robot carrying a labeled tote down a numbered warehouse aisle lined with shelving racks, mid-stride, pink accents. Deep near-black studio background (#111114), soft volumetric lighting with gentle rim light, glossy and matte materials, fine detail, crisp focus, premium financial-tech mood, single hero subject with generous negative space, no text, no words, no logos, no watermark.</a:t>
             </a:r>
             <a:endParaRPr lang="en-US" sz="700" dirty="0"/>
           </a:p>
@@ -4456,7 +4456,7 @@
                 <a:ea typeface="Arial" pitchFamily="34" charset="-122"/>
                 <a:cs typeface="Arial" pitchFamily="34" charset="-120"/>
               </a:rPr>
-              <a:t>Clean modern editorial illustration with natural perspective (not isometric), a driverless robotaxi with a spinning lidar turret and glowing sensor cones stopped at a small city intersection with a traffic light and crosswalk, pink accents, on a near-black background, soft cinematic studio lighting, minimal and polished, single centered subject, no text, no words, no logos.</a:t>
+              <a:t>Detailed modern editorial 3D illustration, slight three-quarter camera angle, polished semi-realistic render, cinematic: a driverless robotaxi with a spinning lidar turret and glowing sensor cones stopped at a small city intersection with a traffic light and crosswalk, pink accents. Deep near-black studio background (#111114), soft volumetric lighting with gentle rim light, glossy and matte materials, fine detail, crisp focus, premium financial-tech mood, single hero subject with generous negative space, no text, no words, no logos, no watermark.</a:t>
             </a:r>
             <a:endParaRPr lang="en-US" sz="700" dirty="0"/>
           </a:p>
@@ -4752,7 +4752,7 @@
                 <a:ea typeface="Arial" pitchFamily="34" charset="-122"/>
                 <a:cs typeface="Arial" pitchFamily="34" charset="-120"/>
               </a:rPr>
-              <a:t>Clean modern editorial illustration with natural perspective (not isometric), a ring-shaped orbital data-center with unfolded solar-panel wings and server modules, floating above the curved horizon of Earth with sparse stars, pink accents, on a near-black background, soft cinematic studio lighting, minimal and polished, single centered subject, no text, no words, no logos.</a:t>
+              <a:t>Detailed modern editorial 3D illustration, slight three-quarter camera angle, polished semi-realistic render, cinematic: a ring-shaped orbital data-center with unfolded solar-panel wings and server modules, floating above the curved horizon of Earth with sparse stars, pink accents. Deep near-black studio background (#111114), soft volumetric lighting with gentle rim light, glossy and matte materials, fine detail, crisp focus, premium financial-tech mood, single hero subject with generous negative space, no text, no words, no logos, no watermark.</a:t>
             </a:r>
             <a:endParaRPr lang="en-US" sz="700" dirty="0"/>
           </a:p>
@@ -5048,7 +5048,7 @@
                 <a:ea typeface="Arial" pitchFamily="34" charset="-122"/>
                 <a:cs typeface="Arial" pitchFamily="34" charset="-120"/>
               </a:rPr>
-              <a:t>Clean modern editorial illustration with natural perspective (not isometric), a robotic pipette arm in a lab assembling a glowing folded-protein ribbon and double-helix on a sample platform, small vials arranged around it, pink accents, on a near-black background, soft cinematic studio lighting, minimal and polished, single centered subject, no text, no words, no logos.</a:t>
+              <a:t>Detailed modern editorial 3D illustration, slight three-quarter camera angle, polished semi-realistic render, cinematic: a robotic pipette arm in a lab assembling a glowing folded-protein ribbon and double-helix on a sample platform, small vials arranged around it, pink accents. Deep near-black studio background (#111114), soft volumetric lighting with gentle rim light, glossy and matte materials, fine detail, crisp focus, premium financial-tech mood, single hero subject with generous negative space, no text, no words, no logos, no watermark.</a:t>
             </a:r>
             <a:endParaRPr lang="en-US" sz="700" dirty="0"/>
           </a:p>
@@ -10391,7 +10391,7 @@
                 <a:ea typeface="Arial" pitchFamily="34" charset="-122"/>
                 <a:cs typeface="Arial" pitchFamily="34" charset="-120"/>
               </a:rPr>
-              <a:t>Clean modern editorial illustration with natural perspective (not isometric), a guarded vault dispensing only a small rationed handful of glowing tokens onto a conveyor that feeds a row of waiting laptops, an 'allocation' valve throttling the flow, orange and gold accents, on a near-black background, soft cinematic studio lighting, minimal and polished, single centered subject, no text, no words, no logos.</a:t>
+              <a:t>Detailed modern editorial 3D illustration, slight three-quarter camera angle, polished semi-realistic render, cinematic: a guarded vault dispensing only a small rationed handful of glowing tokens onto a conveyor that feeds a row of waiting laptops, an 'allocation' valve throttling the flow, orange and gold accents. Deep near-black studio background (#111114), soft volumetric lighting with gentle rim light, glossy and matte materials, fine detail, crisp focus, premium financial-tech mood, single hero subject with generous negative space, no text, no words, no logos, no watermark.</a:t>
             </a:r>
             <a:endParaRPr lang="en-US" sz="700" dirty="0"/>
           </a:p>
@@ -11268,7 +11268,7 @@
                 <a:ea typeface="Arial" pitchFamily="34" charset="-122"/>
                 <a:cs typeface="Arial" pitchFamily="34" charset="-120"/>
               </a:rPr>
-              <a:t>Clean modern editorial illustration with natural perspective (not isometric), a giant government hand planting a flag bearing a percentage symbol atop a glowing server-rack skyscraper, while a chute rains small dividend coins down onto a cluster of tiny suburban houses below, purple accents, on a near-black background, soft cinematic studio lighting, minimal and polished, single centered subject, no text, no words, no logos.</a:t>
+              <a:t>Detailed modern editorial 3D illustration, slight three-quarter camera angle, polished semi-realistic render, cinematic: a giant government hand planting a flag bearing a percentage symbol atop a glowing server-rack skyscraper, while a chute rains small dividend coins down onto a cluster of tiny suburban houses below, purple accents. Deep near-black studio background (#111114), soft volumetric lighting with gentle rim light, glossy and matte materials, fine detail, crisp focus, premium financial-tech mood, single hero subject with generous negative space, no text, no words, no logos, no watermark.</a:t>
             </a:r>
             <a:endParaRPr lang="en-US" sz="700" dirty="0"/>
           </a:p>

</xml_diff>

<commit_message>
Image prompts: de-creep + align to BII palette
- Per-theme BII accents over a warm-orange/gold base (STYLE_TAIL made palette-neutral so prompts set their own accent): cover adds green/red candlesticks; gov-stake + token go orange/gold (drop purple); the 4 frontier cards keep magenta-pink (#E8478D, a BII tertiary) over warm orange.
- De-creeped imagery: gov-stake redesigned from a looming 'giant government hand raining coins on tiny houses' to an optimistic side-by-side government + data-center public-private partnership; token's 'guarded vault / near-empty reservoir' becomes a clean orderly allocation station; the humanoid is now explicitly friendly and approachable, bright lighting throughout.
- Deck section/kicker accents (purple/teal) intentionally left unchanged per scope.
- IMAGE_PROMPTS_V3.md rewritten to match; rebuilt valid 12-slide pptx.

Co-Authored-By: Claude Opus 4.8 <noreply@anthropic.com>
</commit_message>
<xml_diff>
--- a/ai-markets-deck.pptx
+++ b/ai-markets-deck.pptx
@@ -2778,7 +2778,7 @@
                 <a:ea typeface="Arial" pitchFamily="34" charset="-122"/>
                 <a:cs typeface="Arial" pitchFamily="34" charset="-120"/>
               </a:rPr>
-              <a:t>Detailed modern editorial 3D illustration, slight three-quarter camera angle, polished semi-realistic render, cinematic: a financial district at night where the skyscrapers are stacked GPU server-racks; a glowing candlestick stock-chart runs like a road along their base, and a curved arrow of capital flows from a domed bank building into the single tallest GPU tower; orange and yellow accents. Deep near-black studio background (#111114), soft volumetric lighting with gentle rim light, glossy and matte materials, fine detail, crisp focus, premium financial-tech mood, single hero subject with generous negative space, no text, no words, no logos, no watermark.</a:t>
+              <a:t>Detailed modern editorial 3D illustration, slight three-quarter camera angle, polished semi-realistic render, clean and bright: a bright, optimistic financial district lit against a deep near-black sky, its skyscrapers built from stacked GPU server-racks with glowing status lights; a candlestick stock-chart winds through the streets like a lit highway with green up-bars and red down-bars; a luminous ribbon-arrow of capital arcs from a domed bank building up into the single tallest tower; orange (#F6693D) and gold (#FFB800) accents with green (#00A854) and red (#CC0000) candlesticks. Deep near-black (#111114) studio background; brushed-silver and white materials; clean, bright, optimistic BlackRock-style institutional palette, never dark or ominous; soft even lighting, crisp focus, premium financial-tech mood; single hero subject with generous negative space; no text, no words, no logos, no watermark.</a:t>
             </a:r>
             <a:endParaRPr lang="en-US" sz="700" dirty="0"/>
           </a:p>
@@ -4160,7 +4160,7 @@
                 <a:ea typeface="Arial" pitchFamily="34" charset="-122"/>
                 <a:cs typeface="Arial" pitchFamily="34" charset="-120"/>
               </a:rPr>
-              <a:t>Detailed modern editorial 3D illustration, slight three-quarter camera angle, polished semi-realistic render, cinematic: a humanoid robot carrying a labeled tote down a numbered warehouse aisle lined with shelving racks, mid-stride, pink accents. Deep near-black studio background (#111114), soft volumetric lighting with gentle rim light, glossy and matte materials, fine detail, crisp focus, premium financial-tech mood, single hero subject with generous negative space, no text, no words, no logos, no watermark.</a:t>
+              <a:t>Detailed modern editorial 3D illustration, slight three-quarter camera angle, polished semi-realistic render, clean and bright: a friendly, sleek white-and-silver humanoid robot walking upright down a bright, well-lit numbered warehouse aisle, carrying a labeled tote, neat shelving on either side; magenta-pink (#E8478D) and warm orange accents. Deep near-black (#111114) studio background; brushed-silver and white materials; clean, bright, optimistic BlackRock-style institutional palette, never dark or ominous; soft even lighting, crisp focus, premium financial-tech mood; single hero subject with generous negative space; no text, no words, no logos, no watermark.</a:t>
             </a:r>
             <a:endParaRPr lang="en-US" sz="700" dirty="0"/>
           </a:p>
@@ -4456,7 +4456,7 @@
                 <a:ea typeface="Arial" pitchFamily="34" charset="-122"/>
                 <a:cs typeface="Arial" pitchFamily="34" charset="-120"/>
               </a:rPr>
-              <a:t>Detailed modern editorial 3D illustration, slight three-quarter camera angle, polished semi-realistic render, cinematic: a driverless robotaxi with a spinning lidar turret and glowing sensor cones stopped at a small city intersection with a traffic light and crosswalk, pink accents. Deep near-black studio background (#111114), soft volumetric lighting with gentle rim light, glossy and matte materials, fine detail, crisp focus, premium financial-tech mood, single hero subject with generous negative space, no text, no words, no logos, no watermark.</a:t>
+              <a:t>Detailed modern editorial 3D illustration, slight three-quarter camera angle, polished semi-realistic render, clean and bright: a sleek driverless robotaxi with a spinning lidar turret and soft glowing sensor cones, stopped at a clean, bright city intersection with a traffic light and crosswalk; magenta-pink (#E8478D) and warm orange accents. Deep near-black (#111114) studio background; brushed-silver and white materials; clean, bright, optimistic BlackRock-style institutional palette, never dark or ominous; soft even lighting, crisp focus, premium financial-tech mood; single hero subject with generous negative space; no text, no words, no logos, no watermark.</a:t>
             </a:r>
             <a:endParaRPr lang="en-US" sz="700" dirty="0"/>
           </a:p>
@@ -4752,7 +4752,7 @@
                 <a:ea typeface="Arial" pitchFamily="34" charset="-122"/>
                 <a:cs typeface="Arial" pitchFamily="34" charset="-120"/>
               </a:rPr>
-              <a:t>Detailed modern editorial 3D illustration, slight three-quarter camera angle, polished semi-realistic render, cinematic: a ring-shaped orbital data-center with unfolded solar-panel wings and server modules, floating above the curved horizon of Earth with sparse stars, pink accents. Deep near-black studio background (#111114), soft volumetric lighting with gentle rim light, glossy and matte materials, fine detail, crisp focus, premium financial-tech mood, single hero subject with generous negative space, no text, no words, no logos, no watermark.</a:t>
+              <a:t>Detailed modern editorial 3D illustration, slight three-quarter camera angle, polished semi-realistic render, clean and bright: a ring-shaped orbital data-center with unfolded solar-panel wings and server modules, sunlit above the bright curved horizon of Earth; magenta-pink (#E8478D) and warm orange accents. Deep near-black (#111114) studio background; brushed-silver and white materials; clean, bright, optimistic BlackRock-style institutional palette, never dark or ominous; soft even lighting, crisp focus, premium financial-tech mood; single hero subject with generous negative space; no text, no words, no logos, no watermark.</a:t>
             </a:r>
             <a:endParaRPr lang="en-US" sz="700" dirty="0"/>
           </a:p>
@@ -5048,7 +5048,7 @@
                 <a:ea typeface="Arial" pitchFamily="34" charset="-122"/>
                 <a:cs typeface="Arial" pitchFamily="34" charset="-120"/>
               </a:rPr>
-              <a:t>Detailed modern editorial 3D illustration, slight three-quarter camera angle, polished semi-realistic render, cinematic: a robotic pipette arm in a lab assembling a glowing folded-protein ribbon and double-helix on a sample platform, small vials arranged around it, pink accents. Deep near-black studio background (#111114), soft volumetric lighting with gentle rim light, glossy and matte materials, fine detail, crisp focus, premium financial-tech mood, single hero subject with generous negative space, no text, no words, no logos, no watermark.</a:t>
+              <a:t>Detailed modern editorial 3D illustration, slight three-quarter camera angle, polished semi-realistic render, clean and bright: a precise robotic lab arm assembling a glowing folded-protein ribbon and DNA double-helix on a bright, clean sample platform with small glass vials around it; magenta-pink (#E8478D) and warm orange accents. Deep near-black (#111114) studio background; brushed-silver and white materials; clean, bright, optimistic BlackRock-style institutional palette, never dark or ominous; soft even lighting, crisp focus, premium financial-tech mood; single hero subject with generous negative space; no text, no words, no logos, no watermark.</a:t>
             </a:r>
             <a:endParaRPr lang="en-US" sz="700" dirty="0"/>
           </a:p>
@@ -10391,7 +10391,7 @@
                 <a:ea typeface="Arial" pitchFamily="34" charset="-122"/>
                 <a:cs typeface="Arial" pitchFamily="34" charset="-120"/>
               </a:rPr>
-              <a:t>Detailed modern editorial 3D illustration, slight three-quarter camera angle, polished semi-realistic render, cinematic: a guarded vault dispensing only a small rationed handful of glowing tokens onto a conveyor that feeds a row of waiting laptops, an 'allocation' valve throttling the flow, orange and gold accents. Deep near-black studio background (#111114), soft volumetric lighting with gentle rim light, glossy and matte materials, fine detail, crisp focus, premium financial-tech mood, single hero subject with generous negative space, no text, no words, no logos, no watermark.</a:t>
+              <a:t>Detailed modern editorial 3D illustration, slight three-quarter camera angle, polished semi-realistic render, clean and bright: a clean, orderly allocation station that dispenses a measured handful of glowing tokens onto a conveyor feeding a row of laptops, a clear dial set to a budget limit, managed and modern (not grim); orange (#F6693D) and gold (#FFB800) accents. Deep near-black (#111114) studio background; brushed-silver and white materials; clean, bright, optimistic BlackRock-style institutional palette, never dark or ominous; soft even lighting, crisp focus, premium financial-tech mood; single hero subject with generous negative space; no text, no words, no logos, no watermark.</a:t>
             </a:r>
             <a:endParaRPr lang="en-US" sz="700" dirty="0"/>
           </a:p>
@@ -11268,7 +11268,7 @@
                 <a:ea typeface="Arial" pitchFamily="34" charset="-122"/>
                 <a:cs typeface="Arial" pitchFamily="34" charset="-120"/>
               </a:rPr>
-              <a:t>Detailed modern editorial 3D illustration, slight three-quarter camera angle, polished semi-realistic render, cinematic: a giant government hand planting a flag bearing a percentage symbol atop a glowing server-rack skyscraper, while a chute rains small dividend coins down onto a cluster of tiny suburban houses below, purple accents. Deep near-black studio background (#111114), soft volumetric lighting with gentle rim light, glossy and matte materials, fine detail, crisp focus, premium financial-tech mood, single hero subject with generous negative space, no text, no words, no logos, no watermark.</a:t>
+              <a:t>Detailed modern editorial 3D illustration, slight three-quarter camera angle, polished semi-realistic render, clean and bright: a classical domed government building and a modern data-center tower standing side by side on a clean plaza, linked by a bright walkway along which glowing 'dividend' coins travel toward a tidy row of friendly homes — an optimistic public-private partnership; orange (#F6693D) and gold (#FFB800) accents. Deep near-black (#111114) studio background; brushed-silver and white materials; clean, bright, optimistic BlackRock-style institutional palette, never dark or ominous; soft even lighting, crisp focus, premium financial-tech mood; single hero subject with generous negative space; no text, no words, no logos, no watermark.</a:t>
             </a:r>
             <a:endParaRPr lang="en-US" sz="700" dirty="0"/>
           </a:p>

</xml_diff>